<commit_message>
Clase 4: R2 explicado con formula, el concepto de valor p y el mapa de correlaciones
La seccion de regresion multiple suma tres piezas: la formula del R2 con
su leyenda y la lectura del 0,266; el valor p leido sobre nuestro modelo
(ambas variables significativas) con la leccion de que significativo no
es importante (la bicicleta aporta 0,003 con p de 1e-8); y el mapa de
correlaciones de las candidatas para decidir que agregar. Deck en 29
slides con las tres diapos nuevas.

Co-Authored-By: Claude Fable 5 <noreply@anthropic.com>
</commit_message>
<xml_diff>
--- a/presentaciones/clase04_regresion_multiple.pptx
+++ b/presentaciones/clase04_regresion_multiple.pptx
@@ -31,6 +31,9 @@
     <p:sldId id="279" r:id="rId30"/>
     <p:sldId id="280" r:id="rId31"/>
     <p:sldId id="281" r:id="rId32"/>
+    <p:sldId id="282" r:id="rId33"/>
+    <p:sldId id="283" r:id="rId34"/>
+    <p:sldId id="284" r:id="rId35"/>
   </p:sldIdLst>
   <p:sldSz cx="9144000" cy="5138928" type="screen4x3"/>
   <p:notesSz cx="6858000" cy="9144000"/>
@@ -5854,114 +5857,35 @@
                 </a:solidFill>
                 <a:latin typeface="Fira Sans"/>
               </a:rPr>
-              <a:t>Una categórica entra como dummies</a:t>
-            </a:r>
-          </a:p>
-        </p:txBody>
-      </p:sp>
-      <p:sp>
-        <p:nvSpPr>
-          <p:cNvPr id="4" name="Rectangle 3"/>
-          <p:cNvSpPr/>
-          <p:nvPr/>
-        </p:nvSpPr>
-        <p:spPr>
-          <a:xfrm>
-            <a:off x="704088" y="1280160"/>
-            <a:ext cx="7744968" cy="2880360"/>
-          </a:xfrm>
-          <a:prstGeom prst="rect">
-            <a:avLst/>
-          </a:prstGeom>
-          <a:solidFill>
-            <a:srgbClr val="F0F2F5"/>
-          </a:solidFill>
-          <a:ln>
-            <a:solidFill>
-              <a:srgbClr val="D8DDE3"/>
-            </a:solidFill>
-          </a:ln>
-          <a:effectLst/>
-        </p:spPr>
-        <p:style>
-          <a:lnRef idx="1">
-            <a:schemeClr val="accent1"/>
-          </a:lnRef>
-          <a:fillRef idx="3">
-            <a:schemeClr val="accent1"/>
-          </a:fillRef>
-          <a:effectRef idx="2">
-            <a:schemeClr val="accent1"/>
-          </a:effectRef>
-          <a:fontRef idx="minor">
-            <a:schemeClr val="lt1"/>
-          </a:fontRef>
-        </p:style>
-        <p:txBody>
-          <a:bodyPr rtlCol="0" anchor="ctr" wrap="square" lIns="228600" tIns="137160"/>
-          <a:lstStyle/>
-          <a:p>
-            <a:pPr/>
-            <a:r>
-              <a:rPr sz="1500" b="0">
-                <a:solidFill>
-                  <a:srgbClr val="1D3557"/>
-                </a:solidFill>
-                <a:latin typeface="Menlo"/>
-              </a:rPr>
-              <a:t># Una columna 0/1 por modo; el auto queda de referencia</a:t>
-            </a:r>
-          </a:p>
-          <a:p>
-            <a:pPr/>
-            <a:r>
-              <a:rPr sz="1500" b="0">
-                <a:solidFill>
-                  <a:srgbClr val="1D3557"/>
-                </a:solidFill>
-                <a:latin typeface="Menlo"/>
-              </a:rPr>
-              <a:t>dummies = pd.get_dummies(viajes["ModoAgrupado"])</a:t>
-            </a:r>
-          </a:p>
-          <a:p>
-            <a:pPr/>
-            <a:r>
-              <a:rPr sz="1500" b="0">
-                <a:solidFill>
-                  <a:srgbClr val="1D3557"/>
-                </a:solidFill>
-                <a:latin typeface="Menlo"/>
-              </a:rPr>
-              <a:t>dummies = dummies.drop(columns=["Auto"])</a:t>
-            </a:r>
-          </a:p>
-          <a:p>
-            <a:pPr/>
-            <a:r>
-              <a:rPr sz="1500" b="0">
-                <a:solidFill>
-                  <a:srgbClr val="1D3557"/>
-                </a:solidFill>
-                <a:latin typeface="Menlo"/>
-              </a:rPr>
-              <a:t/>
-            </a:r>
-          </a:p>
-          <a:p>
-            <a:pPr/>
-            <a:r>
-              <a:rPr sz="1500" b="0">
-                <a:solidFill>
-                  <a:srgbClr val="1D3557"/>
-                </a:solidFill>
-                <a:latin typeface="Menlo"/>
-              </a:rPr>
-              <a:t># Se agregan a la X junto al log de la distancia</a:t>
-            </a:r>
-          </a:p>
-        </p:txBody>
-      </p:sp>
+              <a:t>Leer el modelo: R²</a:t>
+            </a:r>
+          </a:p>
+        </p:txBody>
+      </p:sp>
+      <p:pic>
+        <p:nvPicPr>
+          <p:cNvPr id="4" name="Picture 3" descr="c4_04_formula_r2.png"/>
+          <p:cNvPicPr>
+            <a:picLocks noChangeAspect="1"/>
+          </p:cNvPicPr>
+          <p:nvPr/>
+        </p:nvPicPr>
+        <p:blipFill>
+          <a:blip r:embed="rId2"/>
+          <a:stretch>
+            <a:fillRect/>
+          </a:stretch>
+        </p:blipFill>
+        <p:spPr>
+          <a:xfrm>
+            <a:off x="699515" y="1297266"/>
+            <a:ext cx="7744968" cy="2846146"/>
+          </a:xfrm>
+          <a:prstGeom prst="rect">
+            <a:avLst/>
+          </a:prstGeom>
+        </p:spPr>
+      </p:pic>
       <p:sp>
         <p:nvSpPr>
           <p:cNvPr id="5" name="TextBox 4"/>
@@ -5970,8 +5894,8 @@
         </p:nvSpPr>
         <p:spPr>
           <a:xfrm>
-            <a:off x="704088" y="4389120"/>
-            <a:ext cx="7744968" cy="1097280"/>
+            <a:off x="704088" y="4434840"/>
+            <a:ext cx="7744968" cy="457200"/>
           </a:xfrm>
           <a:prstGeom prst="rect">
             <a:avLst/>
@@ -5984,31 +5908,14 @@
           </a:bodyPr>
           <a:lstStyle/>
           <a:p>
-            <a:pPr>
-              <a:lnSpc>
-                <a:spcPct val="112000"/>
-              </a:lnSpc>
-              <a:spcAft>
-                <a:spcPts val="900"/>
-              </a:spcAft>
-            </a:pPr>
-            <a:r>
-              <a:rPr sz="1600" b="1">
-                <a:solidFill>
-                  <a:srgbClr val="E0A437"/>
-                </a:solidFill>
-                <a:latin typeface="Fira Sans"/>
-              </a:rPr>
-              <a:t>▸ </a:t>
-            </a:r>
-            <a:r>
-              <a:rPr sz="1600" b="0">
-                <a:solidFill>
-                  <a:srgbClr val="000000"/>
-                </a:solidFill>
-                <a:latin typeface="Fira Sans"/>
-              </a:rPr>
-              <a:t>Cada coeficiente se lee comparado con la referencia: qué le pasa al tiempo de un viaje por ser en ese modo y no en auto, a igual distancia.</a:t>
+            <a:r>
+              <a:rPr sz="1300" b="0">
+                <a:solidFill>
+                  <a:srgbClr val="333333"/>
+                </a:solidFill>
+                <a:latin typeface="Fira Sans"/>
+              </a:rPr>
+              <a:t>Nuestro 0,266: ingreso y personas explican un cuarto de la variabilidad de los vehículos entre hogares. Agregar variables nunca baja el R²; por eso no basta con mirarlo.</a:t>
             </a:r>
           </a:p>
         </p:txBody>
@@ -6104,45 +6011,21 @@
                 </a:solidFill>
                 <a:latin typeface="Fira Sans"/>
               </a:rPr>
-              <a:t>El resultado: distancia y modo</a:t>
-            </a:r>
-          </a:p>
-        </p:txBody>
-      </p:sp>
-      <p:pic>
-        <p:nvPicPr>
-          <p:cNvPr id="4" name="Picture 3" descr="c4_03_coef_modo.png"/>
-          <p:cNvPicPr>
-            <a:picLocks noChangeAspect="1"/>
-          </p:cNvPicPr>
-          <p:nvPr/>
-        </p:nvPicPr>
-        <p:blipFill>
-          <a:blip r:embed="rId2"/>
-          <a:stretch>
-            <a:fillRect/>
-          </a:stretch>
-        </p:blipFill>
-        <p:spPr>
-          <a:xfrm>
-            <a:off x="804842" y="1143000"/>
-            <a:ext cx="7534315" cy="3154680"/>
-          </a:xfrm>
-          <a:prstGeom prst="rect">
-            <a:avLst/>
-          </a:prstGeom>
-        </p:spPr>
-      </p:pic>
-      <p:sp>
-        <p:nvSpPr>
-          <p:cNvPr id="5" name="TextBox 4"/>
+              <a:t>El valor p, por ahora</a:t>
+            </a:r>
+          </a:p>
+        </p:txBody>
+      </p:sp>
+      <p:sp>
+        <p:nvSpPr>
+          <p:cNvPr id="4" name="TextBox 3"/>
           <p:cNvSpPr txBox="1"/>
           <p:nvPr/>
         </p:nvSpPr>
         <p:spPr>
           <a:xfrm>
-            <a:off x="704088" y="4434840"/>
-            <a:ext cx="7744968" cy="457200"/>
+            <a:off x="704088" y="1353312"/>
+            <a:ext cx="7744968" cy="3300984"/>
           </a:xfrm>
           <a:prstGeom prst="rect">
             <a:avLst/>
@@ -6155,14 +6038,115 @@
           </a:bodyPr>
           <a:lstStyle/>
           <a:p>
-            <a:r>
-              <a:rPr sz="1300" b="0">
-                <a:solidFill>
-                  <a:srgbClr val="333333"/>
-                </a:solidFill>
-                <a:latin typeface="Fira Sans"/>
-              </a:rPr>
-              <a:t>A igual distancia, un viaje en Bip! tarda 1,87 veces lo que uno en auto; taxi y caminata quedan casi iguales al auto. El R² sube de 0,53 a 0,60.</a:t>
+            <a:pPr>
+              <a:lnSpc>
+                <a:spcPct val="112000"/>
+              </a:lnSpc>
+              <a:spcAft>
+                <a:spcPts val="900"/>
+              </a:spcAft>
+            </a:pPr>
+            <a:r>
+              <a:rPr sz="1800" b="1">
+                <a:solidFill>
+                  <a:srgbClr val="E0A437"/>
+                </a:solidFill>
+                <a:latin typeface="Fira Sans"/>
+              </a:rPr>
+              <a:t>▸ </a:t>
+            </a:r>
+            <a:r>
+              <a:rPr sz="1800" b="1">
+                <a:solidFill>
+                  <a:srgbClr val="1D3557"/>
+                </a:solidFill>
+                <a:latin typeface="Fira Sans"/>
+              </a:rPr>
+              <a:t>La pregunta que responde: si el efecto real fuera cero, ¿qué tan raro sería este coeficiente solo por azar?</a:t>
+            </a:r>
+          </a:p>
+          <a:p>
+            <a:pPr>
+              <a:lnSpc>
+                <a:spcPct val="112000"/>
+              </a:lnSpc>
+              <a:spcAft>
+                <a:spcPts val="900"/>
+              </a:spcAft>
+            </a:pPr>
+            <a:r>
+              <a:rPr sz="1800" b="1">
+                <a:solidFill>
+                  <a:srgbClr val="E0A437"/>
+                </a:solidFill>
+                <a:latin typeface="Fira Sans"/>
+              </a:rPr>
+              <a:t>▸ </a:t>
+            </a:r>
+            <a:r>
+              <a:rPr sz="1800" b="0">
+                <a:solidFill>
+                  <a:srgbClr val="000000"/>
+                </a:solidFill>
+                <a:latin typeface="Fira Sans"/>
+              </a:rPr>
+              <a:t>En el summary es la columna P&gt;|t|: ingreso y personas dan p prácticamente 0, ninguna parece azar.</a:t>
+            </a:r>
+          </a:p>
+          <a:p>
+            <a:pPr>
+              <a:lnSpc>
+                <a:spcPct val="112000"/>
+              </a:lnSpc>
+              <a:spcAft>
+                <a:spcPts val="900"/>
+              </a:spcAft>
+            </a:pPr>
+            <a:r>
+              <a:rPr sz="1800" b="1">
+                <a:solidFill>
+                  <a:srgbClr val="E0A437"/>
+                </a:solidFill>
+                <a:latin typeface="Fira Sans"/>
+              </a:rPr>
+              <a:t>▸ </a:t>
+            </a:r>
+            <a:r>
+              <a:rPr sz="1800" b="0">
+                <a:solidFill>
+                  <a:srgbClr val="000000"/>
+                </a:solidFill>
+                <a:latin typeface="Fira Sans"/>
+              </a:rPr>
+              <a:t>Significativo no es sinónimo de importante: con 18 mil hogares, un aporte de 0,003 vehículos por bicicleta también da p diminuto.</a:t>
+            </a:r>
+          </a:p>
+          <a:p>
+            <a:pPr>
+              <a:lnSpc>
+                <a:spcPct val="112000"/>
+              </a:lnSpc>
+              <a:spcAft>
+                <a:spcPts val="900"/>
+              </a:spcAft>
+            </a:pPr>
+            <a:r>
+              <a:rPr sz="1800" b="1">
+                <a:solidFill>
+                  <a:srgbClr val="E0A437"/>
+                </a:solidFill>
+                <a:latin typeface="Fira Sans"/>
+              </a:rPr>
+              <a:t>▸ </a:t>
+            </a:r>
+            <a:r>
+              <a:rPr sz="1800" b="0">
+                <a:solidFill>
+                  <a:srgbClr val="000000"/>
+                </a:solidFill>
+                <a:latin typeface="Fira Sans"/>
+              </a:rPr>
+              <a:t>La definición formal, con hipótesis y umbrales, es la clase 5.</a:t>
             </a:r>
           </a:p>
         </p:txBody>
@@ -6258,21 +6242,45 @@
                 </a:solidFill>
                 <a:latin typeface="Fira Sans"/>
               </a:rPr>
-              <a:t>Síntesis</a:t>
-            </a:r>
-          </a:p>
-        </p:txBody>
-      </p:sp>
-      <p:sp>
-        <p:nvSpPr>
-          <p:cNvPr id="4" name="TextBox 3"/>
+              <a:t>El mapa para elegir variables</a:t>
+            </a:r>
+          </a:p>
+        </p:txBody>
+      </p:sp>
+      <p:pic>
+        <p:nvPicPr>
+          <p:cNvPr id="4" name="Picture 3" descr="c4_05_mapa_candidatas.png"/>
+          <p:cNvPicPr>
+            <a:picLocks noChangeAspect="1"/>
+          </p:cNvPicPr>
+          <p:nvPr/>
+        </p:nvPicPr>
+        <p:blipFill>
+          <a:blip r:embed="rId2"/>
+          <a:stretch>
+            <a:fillRect/>
+          </a:stretch>
+        </p:blipFill>
+        <p:spPr>
+          <a:xfrm>
+            <a:off x="2530736" y="1143000"/>
+            <a:ext cx="4082527" cy="3154680"/>
+          </a:xfrm>
+          <a:prstGeom prst="rect">
+            <a:avLst/>
+          </a:prstGeom>
+        </p:spPr>
+      </p:pic>
+      <p:sp>
+        <p:nvSpPr>
+          <p:cNvPr id="5" name="TextBox 4"/>
           <p:cNvSpPr txBox="1"/>
           <p:nvPr/>
         </p:nvSpPr>
         <p:spPr>
           <a:xfrm>
-            <a:off x="704088" y="1353312"/>
-            <a:ext cx="7744968" cy="3300984"/>
+            <a:off x="704088" y="4434840"/>
+            <a:ext cx="7744968" cy="457200"/>
           </a:xfrm>
           <a:prstGeom prst="rect">
             <a:avLst/>
@@ -6285,143 +6293,14 @@
           </a:bodyPr>
           <a:lstStyle/>
           <a:p>
-            <a:pPr>
-              <a:lnSpc>
-                <a:spcPct val="112000"/>
-              </a:lnSpc>
-              <a:spcAft>
-                <a:spcPts val="900"/>
-              </a:spcAft>
-            </a:pPr>
-            <a:r>
-              <a:rPr sz="1800" b="1">
-                <a:solidFill>
-                  <a:srgbClr val="E0A437"/>
-                </a:solidFill>
-                <a:latin typeface="Fira Sans"/>
-              </a:rPr>
-              <a:t>▸ </a:t>
-            </a:r>
-            <a:r>
-              <a:rPr sz="1800" b="0">
-                <a:solidFill>
-                  <a:srgbClr val="000000"/>
-                </a:solidFill>
-                <a:latin typeface="Fira Sans"/>
-              </a:rPr>
-              <a:t>El impacto de filas y atípicos se mide con y sin, sobre todos los resúmenes en uso.</a:t>
-            </a:r>
-          </a:p>
-          <a:p>
-            <a:pPr>
-              <a:lnSpc>
-                <a:spcPct val="112000"/>
-              </a:lnSpc>
-              <a:spcAft>
-                <a:spcPts val="900"/>
-              </a:spcAft>
-            </a:pPr>
-            <a:r>
-              <a:rPr sz="1800" b="1">
-                <a:solidFill>
-                  <a:srgbClr val="E0A437"/>
-                </a:solidFill>
-                <a:latin typeface="Fira Sans"/>
-              </a:rPr>
-              <a:t>▸ </a:t>
-            </a:r>
-            <a:r>
-              <a:rPr sz="1800" b="0">
-                <a:solidFill>
-                  <a:srgbClr val="000000"/>
-                </a:solidFill>
-                <a:latin typeface="Fira Sans"/>
-              </a:rPr>
-              <a:t>Cuando la conclusión es sobre la ciudad, se pondera: WLS.</a:t>
-            </a:r>
-          </a:p>
-          <a:p>
-            <a:pPr>
-              <a:lnSpc>
-                <a:spcPct val="112000"/>
-              </a:lnSpc>
-              <a:spcAft>
-                <a:spcPts val="900"/>
-              </a:spcAft>
-            </a:pPr>
-            <a:r>
-              <a:rPr sz="1800" b="1">
-                <a:solidFill>
-                  <a:srgbClr val="E0A437"/>
-                </a:solidFill>
-                <a:latin typeface="Fira Sans"/>
-              </a:rPr>
-              <a:t>▸ </a:t>
-            </a:r>
-            <a:r>
-              <a:rPr sz="1800" b="0">
-                <a:solidFill>
-                  <a:srgbClr val="000000"/>
-                </a:solidFill>
-                <a:latin typeface="Fira Sans"/>
-              </a:rPr>
-              <a:t>Muchos puntos: alpha o hexbin. Colas largas: log, que además es feature engineering.</a:t>
-            </a:r>
-          </a:p>
-          <a:p>
-            <a:pPr>
-              <a:lnSpc>
-                <a:spcPct val="112000"/>
-              </a:lnSpc>
-              <a:spcAft>
-                <a:spcPts val="900"/>
-              </a:spcAft>
-            </a:pPr>
-            <a:r>
-              <a:rPr sz="1800" b="1">
-                <a:solidFill>
-                  <a:srgbClr val="E0A437"/>
-                </a:solidFill>
-                <a:latin typeface="Fira Sans"/>
-              </a:rPr>
-              <a:t>▸ </a:t>
-            </a:r>
-            <a:r>
-              <a:rPr sz="1800" b="0">
-                <a:solidFill>
-                  <a:srgbClr val="000000"/>
-                </a:solidFill>
-                <a:latin typeface="Fira Sans"/>
-              </a:rPr>
-              <a:t>La regresión múltiple aísla el efecto de cada variable con las demás constantes; las categóricas entran como dummies.</a:t>
-            </a:r>
-          </a:p>
-          <a:p>
-            <a:pPr>
-              <a:lnSpc>
-                <a:spcPct val="112000"/>
-              </a:lnSpc>
-              <a:spcAft>
-                <a:spcPts val="900"/>
-              </a:spcAft>
-            </a:pPr>
-            <a:r>
-              <a:rPr sz="1800" b="1">
-                <a:solidFill>
-                  <a:srgbClr val="E0A437"/>
-                </a:solidFill>
-                <a:latin typeface="Fira Sans"/>
-              </a:rPr>
-              <a:t>▸ </a:t>
-            </a:r>
-            <a:r>
-              <a:rPr sz="1800" b="1">
-                <a:solidFill>
-                  <a:srgbClr val="1D3557"/>
-                </a:solidFill>
-                <a:latin typeface="Fira Sans"/>
-              </a:rPr>
-              <a:t>El primer EDA del proyecto usa exactamente estas herramientas (entrega: lunes 15).</a:t>
+            <a:r>
+              <a:rPr sz="1300" b="0">
+                <a:solidFill>
+                  <a:srgbClr val="333333"/>
+                </a:solidFill>
+                <a:latin typeface="Fira Sans"/>
+              </a:rPr>
+              <a:t>La fila de NumVeh es el mapa: ingreso 0,47 es el motor; las bicicletas casi no correlacionan con los vehículos (0,06) y son redundantes entre sí (0,83). Probarlas confirma: R² 0,266 a 0,267.</a:t>
             </a:r>
           </a:p>
         </p:txBody>
@@ -6517,21 +6396,124 @@
                 </a:solidFill>
                 <a:latin typeface="Fira Sans"/>
               </a:rPr>
-              <a:t>Próxima clase</a:t>
-            </a:r>
-          </a:p>
-        </p:txBody>
-      </p:sp>
-      <p:sp>
-        <p:nvSpPr>
-          <p:cNvPr id="4" name="TextBox 3"/>
+              <a:t>Una categórica entra como dummies</a:t>
+            </a:r>
+          </a:p>
+        </p:txBody>
+      </p:sp>
+      <p:sp>
+        <p:nvSpPr>
+          <p:cNvPr id="4" name="Rectangle 3"/>
+          <p:cNvSpPr/>
+          <p:nvPr/>
+        </p:nvSpPr>
+        <p:spPr>
+          <a:xfrm>
+            <a:off x="704088" y="1280160"/>
+            <a:ext cx="7744968" cy="2880360"/>
+          </a:xfrm>
+          <a:prstGeom prst="rect">
+            <a:avLst/>
+          </a:prstGeom>
+          <a:solidFill>
+            <a:srgbClr val="F0F2F5"/>
+          </a:solidFill>
+          <a:ln>
+            <a:solidFill>
+              <a:srgbClr val="D8DDE3"/>
+            </a:solidFill>
+          </a:ln>
+          <a:effectLst/>
+        </p:spPr>
+        <p:style>
+          <a:lnRef idx="1">
+            <a:schemeClr val="accent1"/>
+          </a:lnRef>
+          <a:fillRef idx="3">
+            <a:schemeClr val="accent1"/>
+          </a:fillRef>
+          <a:effectRef idx="2">
+            <a:schemeClr val="accent1"/>
+          </a:effectRef>
+          <a:fontRef idx="minor">
+            <a:schemeClr val="lt1"/>
+          </a:fontRef>
+        </p:style>
+        <p:txBody>
+          <a:bodyPr rtlCol="0" anchor="ctr" wrap="square" lIns="228600" tIns="137160"/>
+          <a:lstStyle/>
+          <a:p>
+            <a:pPr/>
+            <a:r>
+              <a:rPr sz="1500" b="0">
+                <a:solidFill>
+                  <a:srgbClr val="1D3557"/>
+                </a:solidFill>
+                <a:latin typeface="Menlo"/>
+              </a:rPr>
+              <a:t># Una columna 0/1 por modo; el auto queda de referencia</a:t>
+            </a:r>
+          </a:p>
+          <a:p>
+            <a:pPr/>
+            <a:r>
+              <a:rPr sz="1500" b="0">
+                <a:solidFill>
+                  <a:srgbClr val="1D3557"/>
+                </a:solidFill>
+                <a:latin typeface="Menlo"/>
+              </a:rPr>
+              <a:t>dummies = pd.get_dummies(viajes["ModoAgrupado"])</a:t>
+            </a:r>
+          </a:p>
+          <a:p>
+            <a:pPr/>
+            <a:r>
+              <a:rPr sz="1500" b="0">
+                <a:solidFill>
+                  <a:srgbClr val="1D3557"/>
+                </a:solidFill>
+                <a:latin typeface="Menlo"/>
+              </a:rPr>
+              <a:t>dummies = dummies.drop(columns=["Auto"])</a:t>
+            </a:r>
+          </a:p>
+          <a:p>
+            <a:pPr/>
+            <a:r>
+              <a:rPr sz="1500" b="0">
+                <a:solidFill>
+                  <a:srgbClr val="1D3557"/>
+                </a:solidFill>
+                <a:latin typeface="Menlo"/>
+              </a:rPr>
+              <a:t/>
+            </a:r>
+          </a:p>
+          <a:p>
+            <a:pPr/>
+            <a:r>
+              <a:rPr sz="1500" b="0">
+                <a:solidFill>
+                  <a:srgbClr val="1D3557"/>
+                </a:solidFill>
+                <a:latin typeface="Menlo"/>
+              </a:rPr>
+              <a:t># Se agregan a la X junto al log de la distancia</a:t>
+            </a:r>
+          </a:p>
+        </p:txBody>
+      </p:sp>
+      <p:sp>
+        <p:nvSpPr>
+          <p:cNvPr id="5" name="TextBox 4"/>
           <p:cNvSpPr txBox="1"/>
           <p:nvPr/>
         </p:nvSpPr>
         <p:spPr>
           <a:xfrm>
-            <a:off x="704088" y="1353312"/>
-            <a:ext cx="7744968" cy="3300984"/>
+            <a:off x="704088" y="4389120"/>
+            <a:ext cx="7744968" cy="1097280"/>
           </a:xfrm>
           <a:prstGeom prst="rect">
             <a:avLst/>
@@ -6553,7 +6535,7 @@
               </a:spcAft>
             </a:pPr>
             <a:r>
-              <a:rPr sz="1800" b="1">
+              <a:rPr sz="1600" b="1">
                 <a:solidFill>
                   <a:srgbClr val="E0A437"/>
                 </a:solidFill>
@@ -6562,69 +6544,13 @@
               <a:t>▸ </a:t>
             </a:r>
             <a:r>
-              <a:rPr sz="1800" b="0">
+              <a:rPr sz="1600" b="0">
                 <a:solidFill>
                   <a:srgbClr val="000000"/>
                 </a:solidFill>
                 <a:latin typeface="Fira Sans"/>
               </a:rPr>
-              <a:t>Martes 8: fundamentos de probabilidad y nociones de inferencia estadística.</a:t>
-            </a:r>
-          </a:p>
-          <a:p>
-            <a:pPr>
-              <a:lnSpc>
-                <a:spcPct val="112000"/>
-              </a:lnSpc>
-              <a:spcAft>
-                <a:spcPts val="900"/>
-              </a:spcAft>
-            </a:pPr>
-            <a:r>
-              <a:rPr sz="1800" b="1">
-                <a:solidFill>
-                  <a:srgbClr val="E0A437"/>
-                </a:solidFill>
-                <a:latin typeface="Fira Sans"/>
-              </a:rPr>
-              <a:t>▸ </a:t>
-            </a:r>
-            <a:r>
-              <a:rPr sz="1800" b="0">
-                <a:solidFill>
-                  <a:srgbClr val="000000"/>
-                </a:solidFill>
-                <a:latin typeface="Fira Sans"/>
-              </a:rPr>
-              <a:t>La pregunta pendiente desde la clase 3: ¿qué significa el valor p que statsmodels ya nos mostró?</a:t>
-            </a:r>
-          </a:p>
-          <a:p>
-            <a:pPr>
-              <a:lnSpc>
-                <a:spcPct val="112000"/>
-              </a:lnSpc>
-              <a:spcAft>
-                <a:spcPts val="900"/>
-              </a:spcAft>
-            </a:pPr>
-            <a:r>
-              <a:rPr sz="1800" b="1">
-                <a:solidFill>
-                  <a:srgbClr val="E0A437"/>
-                </a:solidFill>
-                <a:latin typeface="Fira Sans"/>
-              </a:rPr>
-              <a:t>▸ </a:t>
-            </a:r>
-            <a:r>
-              <a:rPr sz="1800" b="1">
-                <a:solidFill>
-                  <a:srgbClr val="1D3557"/>
-                </a:solidFill>
-                <a:latin typeface="Fira Sans"/>
-              </a:rPr>
-              <a:t>La formulación se entrega el lunes 7; el primer análisis exploratorio, el lunes 15.</a:t>
+              <a:t>Cada coeficiente se lee comparado con la referencia: qué le pasa al tiempo de un viaje por ser en ese modo y no en auto, a igual distancia.</a:t>
             </a:r>
           </a:p>
         </p:txBody>
@@ -6638,6 +6564,650 @@
 </file>
 
 <file path=ppt/slides/slide26.xml><?xml version="1.0" encoding="utf-8"?>
+<p:sld xmlns:a="http://schemas.openxmlformats.org/drawingml/2006/main" xmlns:p="http://schemas.openxmlformats.org/presentationml/2006/main" xmlns:r="http://schemas.openxmlformats.org/officeDocument/2006/relationships">
+  <p:cSld>
+    <p:spTree>
+      <p:nvGrpSpPr>
+        <p:cNvPr id="1" name=""/>
+        <p:cNvGrpSpPr/>
+        <p:nvPr/>
+      </p:nvGrpSpPr>
+      <p:grpSpPr/>
+      <p:sp>
+        <p:nvSpPr>
+          <p:cNvPr id="2" name="Rectangle 1"/>
+          <p:cNvSpPr/>
+          <p:nvPr/>
+        </p:nvSpPr>
+        <p:spPr>
+          <a:xfrm>
+            <a:off x="0" y="0"/>
+            <a:ext cx="9144000" cy="5138928"/>
+          </a:xfrm>
+          <a:prstGeom prst="rect">
+            <a:avLst/>
+          </a:prstGeom>
+          <a:solidFill>
+            <a:srgbClr val="FAFBFC"/>
+          </a:solidFill>
+          <a:ln>
+            <a:noFill/>
+          </a:ln>
+          <a:effectLst/>
+        </p:spPr>
+        <p:style>
+          <a:lnRef idx="1">
+            <a:schemeClr val="accent1"/>
+          </a:lnRef>
+          <a:fillRef idx="3">
+            <a:schemeClr val="accent1"/>
+          </a:fillRef>
+          <a:effectRef idx="2">
+            <a:schemeClr val="accent1"/>
+          </a:effectRef>
+          <a:fontRef idx="minor">
+            <a:schemeClr val="lt1"/>
+          </a:fontRef>
+        </p:style>
+        <p:txBody>
+          <a:bodyPr rtlCol="0" anchor="ctr"/>
+          <a:lstStyle/>
+          <a:p>
+            <a:pPr algn="ctr"/>
+          </a:p>
+        </p:txBody>
+      </p:sp>
+      <p:sp>
+        <p:nvSpPr>
+          <p:cNvPr id="3" name="TextBox 2"/>
+          <p:cNvSpPr txBox="1"/>
+          <p:nvPr/>
+        </p:nvSpPr>
+        <p:spPr>
+          <a:xfrm>
+            <a:off x="402336" y="301752"/>
+            <a:ext cx="8348472" cy="795528"/>
+          </a:xfrm>
+          <a:prstGeom prst="rect">
+            <a:avLst/>
+          </a:prstGeom>
+          <a:noFill/>
+        </p:spPr>
+        <p:txBody>
+          <a:bodyPr wrap="square">
+            <a:spAutoFit/>
+          </a:bodyPr>
+          <a:lstStyle/>
+          <a:p>
+            <a:r>
+              <a:rPr sz="2800" b="1">
+                <a:solidFill>
+                  <a:srgbClr val="0F0F0F"/>
+                </a:solidFill>
+                <a:latin typeface="Fira Sans"/>
+              </a:rPr>
+              <a:t>El resultado: distancia y modo</a:t>
+            </a:r>
+          </a:p>
+        </p:txBody>
+      </p:sp>
+      <p:pic>
+        <p:nvPicPr>
+          <p:cNvPr id="4" name="Picture 3" descr="c4_03_coef_modo.png"/>
+          <p:cNvPicPr>
+            <a:picLocks noChangeAspect="1"/>
+          </p:cNvPicPr>
+          <p:nvPr/>
+        </p:nvPicPr>
+        <p:blipFill>
+          <a:blip r:embed="rId2"/>
+          <a:stretch>
+            <a:fillRect/>
+          </a:stretch>
+        </p:blipFill>
+        <p:spPr>
+          <a:xfrm>
+            <a:off x="804842" y="1143000"/>
+            <a:ext cx="7534315" cy="3154680"/>
+          </a:xfrm>
+          <a:prstGeom prst="rect">
+            <a:avLst/>
+          </a:prstGeom>
+        </p:spPr>
+      </p:pic>
+      <p:sp>
+        <p:nvSpPr>
+          <p:cNvPr id="5" name="TextBox 4"/>
+          <p:cNvSpPr txBox="1"/>
+          <p:nvPr/>
+        </p:nvSpPr>
+        <p:spPr>
+          <a:xfrm>
+            <a:off x="704088" y="4434840"/>
+            <a:ext cx="7744968" cy="457200"/>
+          </a:xfrm>
+          <a:prstGeom prst="rect">
+            <a:avLst/>
+          </a:prstGeom>
+          <a:noFill/>
+        </p:spPr>
+        <p:txBody>
+          <a:bodyPr wrap="square">
+            <a:spAutoFit/>
+          </a:bodyPr>
+          <a:lstStyle/>
+          <a:p>
+            <a:r>
+              <a:rPr sz="1300" b="0">
+                <a:solidFill>
+                  <a:srgbClr val="333333"/>
+                </a:solidFill>
+                <a:latin typeface="Fira Sans"/>
+              </a:rPr>
+              <a:t>A igual distancia, un viaje en Bip! tarda 1,87 veces lo que uno en auto; taxi y caminata quedan casi iguales al auto. El R² sube de 0,53 a 0,60.</a:t>
+            </a:r>
+          </a:p>
+        </p:txBody>
+      </p:sp>
+    </p:spTree>
+  </p:cSld>
+  <p:clrMapOvr>
+    <a:masterClrMapping/>
+  </p:clrMapOvr>
+</p:sld>
+</file>
+
+<file path=ppt/slides/slide27.xml><?xml version="1.0" encoding="utf-8"?>
+<p:sld xmlns:a="http://schemas.openxmlformats.org/drawingml/2006/main" xmlns:p="http://schemas.openxmlformats.org/presentationml/2006/main" xmlns:r="http://schemas.openxmlformats.org/officeDocument/2006/relationships">
+  <p:cSld>
+    <p:spTree>
+      <p:nvGrpSpPr>
+        <p:cNvPr id="1" name=""/>
+        <p:cNvGrpSpPr/>
+        <p:nvPr/>
+      </p:nvGrpSpPr>
+      <p:grpSpPr/>
+      <p:sp>
+        <p:nvSpPr>
+          <p:cNvPr id="2" name="Rectangle 1"/>
+          <p:cNvSpPr/>
+          <p:nvPr/>
+        </p:nvSpPr>
+        <p:spPr>
+          <a:xfrm>
+            <a:off x="0" y="0"/>
+            <a:ext cx="9144000" cy="5138928"/>
+          </a:xfrm>
+          <a:prstGeom prst="rect">
+            <a:avLst/>
+          </a:prstGeom>
+          <a:solidFill>
+            <a:srgbClr val="FAFBFC"/>
+          </a:solidFill>
+          <a:ln>
+            <a:noFill/>
+          </a:ln>
+          <a:effectLst/>
+        </p:spPr>
+        <p:style>
+          <a:lnRef idx="1">
+            <a:schemeClr val="accent1"/>
+          </a:lnRef>
+          <a:fillRef idx="3">
+            <a:schemeClr val="accent1"/>
+          </a:fillRef>
+          <a:effectRef idx="2">
+            <a:schemeClr val="accent1"/>
+          </a:effectRef>
+          <a:fontRef idx="minor">
+            <a:schemeClr val="lt1"/>
+          </a:fontRef>
+        </p:style>
+        <p:txBody>
+          <a:bodyPr rtlCol="0" anchor="ctr"/>
+          <a:lstStyle/>
+          <a:p>
+            <a:pPr algn="ctr"/>
+          </a:p>
+        </p:txBody>
+      </p:sp>
+      <p:sp>
+        <p:nvSpPr>
+          <p:cNvPr id="3" name="TextBox 2"/>
+          <p:cNvSpPr txBox="1"/>
+          <p:nvPr/>
+        </p:nvSpPr>
+        <p:spPr>
+          <a:xfrm>
+            <a:off x="402336" y="301752"/>
+            <a:ext cx="8348472" cy="795528"/>
+          </a:xfrm>
+          <a:prstGeom prst="rect">
+            <a:avLst/>
+          </a:prstGeom>
+          <a:noFill/>
+        </p:spPr>
+        <p:txBody>
+          <a:bodyPr wrap="square">
+            <a:spAutoFit/>
+          </a:bodyPr>
+          <a:lstStyle/>
+          <a:p>
+            <a:r>
+              <a:rPr sz="2800" b="1">
+                <a:solidFill>
+                  <a:srgbClr val="0F0F0F"/>
+                </a:solidFill>
+                <a:latin typeface="Fira Sans"/>
+              </a:rPr>
+              <a:t>Síntesis</a:t>
+            </a:r>
+          </a:p>
+        </p:txBody>
+      </p:sp>
+      <p:sp>
+        <p:nvSpPr>
+          <p:cNvPr id="4" name="TextBox 3"/>
+          <p:cNvSpPr txBox="1"/>
+          <p:nvPr/>
+        </p:nvSpPr>
+        <p:spPr>
+          <a:xfrm>
+            <a:off x="704088" y="1353312"/>
+            <a:ext cx="7744968" cy="3300984"/>
+          </a:xfrm>
+          <a:prstGeom prst="rect">
+            <a:avLst/>
+          </a:prstGeom>
+          <a:noFill/>
+        </p:spPr>
+        <p:txBody>
+          <a:bodyPr wrap="square">
+            <a:spAutoFit/>
+          </a:bodyPr>
+          <a:lstStyle/>
+          <a:p>
+            <a:pPr>
+              <a:lnSpc>
+                <a:spcPct val="112000"/>
+              </a:lnSpc>
+              <a:spcAft>
+                <a:spcPts val="900"/>
+              </a:spcAft>
+            </a:pPr>
+            <a:r>
+              <a:rPr sz="1800" b="1">
+                <a:solidFill>
+                  <a:srgbClr val="E0A437"/>
+                </a:solidFill>
+                <a:latin typeface="Fira Sans"/>
+              </a:rPr>
+              <a:t>▸ </a:t>
+            </a:r>
+            <a:r>
+              <a:rPr sz="1800" b="0">
+                <a:solidFill>
+                  <a:srgbClr val="000000"/>
+                </a:solidFill>
+                <a:latin typeface="Fira Sans"/>
+              </a:rPr>
+              <a:t>El impacto de filas y atípicos se mide con y sin, sobre todos los resúmenes en uso.</a:t>
+            </a:r>
+          </a:p>
+          <a:p>
+            <a:pPr>
+              <a:lnSpc>
+                <a:spcPct val="112000"/>
+              </a:lnSpc>
+              <a:spcAft>
+                <a:spcPts val="900"/>
+              </a:spcAft>
+            </a:pPr>
+            <a:r>
+              <a:rPr sz="1800" b="1">
+                <a:solidFill>
+                  <a:srgbClr val="E0A437"/>
+                </a:solidFill>
+                <a:latin typeface="Fira Sans"/>
+              </a:rPr>
+              <a:t>▸ </a:t>
+            </a:r>
+            <a:r>
+              <a:rPr sz="1800" b="0">
+                <a:solidFill>
+                  <a:srgbClr val="000000"/>
+                </a:solidFill>
+                <a:latin typeface="Fira Sans"/>
+              </a:rPr>
+              <a:t>Cuando la conclusión es sobre la ciudad, se pondera: WLS.</a:t>
+            </a:r>
+          </a:p>
+          <a:p>
+            <a:pPr>
+              <a:lnSpc>
+                <a:spcPct val="112000"/>
+              </a:lnSpc>
+              <a:spcAft>
+                <a:spcPts val="900"/>
+              </a:spcAft>
+            </a:pPr>
+            <a:r>
+              <a:rPr sz="1800" b="1">
+                <a:solidFill>
+                  <a:srgbClr val="E0A437"/>
+                </a:solidFill>
+                <a:latin typeface="Fira Sans"/>
+              </a:rPr>
+              <a:t>▸ </a:t>
+            </a:r>
+            <a:r>
+              <a:rPr sz="1800" b="0">
+                <a:solidFill>
+                  <a:srgbClr val="000000"/>
+                </a:solidFill>
+                <a:latin typeface="Fira Sans"/>
+              </a:rPr>
+              <a:t>Muchos puntos: alpha o hexbin. Colas largas: log, que además es feature engineering.</a:t>
+            </a:r>
+          </a:p>
+          <a:p>
+            <a:pPr>
+              <a:lnSpc>
+                <a:spcPct val="112000"/>
+              </a:lnSpc>
+              <a:spcAft>
+                <a:spcPts val="900"/>
+              </a:spcAft>
+            </a:pPr>
+            <a:r>
+              <a:rPr sz="1800" b="1">
+                <a:solidFill>
+                  <a:srgbClr val="E0A437"/>
+                </a:solidFill>
+                <a:latin typeface="Fira Sans"/>
+              </a:rPr>
+              <a:t>▸ </a:t>
+            </a:r>
+            <a:r>
+              <a:rPr sz="1800" b="0">
+                <a:solidFill>
+                  <a:srgbClr val="000000"/>
+                </a:solidFill>
+                <a:latin typeface="Fira Sans"/>
+              </a:rPr>
+              <a:t>La regresión múltiple aísla el efecto de cada variable con las demás constantes; las categóricas entran como dummies.</a:t>
+            </a:r>
+          </a:p>
+          <a:p>
+            <a:pPr>
+              <a:lnSpc>
+                <a:spcPct val="112000"/>
+              </a:lnSpc>
+              <a:spcAft>
+                <a:spcPts val="900"/>
+              </a:spcAft>
+            </a:pPr>
+            <a:r>
+              <a:rPr sz="1800" b="1">
+                <a:solidFill>
+                  <a:srgbClr val="E0A437"/>
+                </a:solidFill>
+                <a:latin typeface="Fira Sans"/>
+              </a:rPr>
+              <a:t>▸ </a:t>
+            </a:r>
+            <a:r>
+              <a:rPr sz="1800" b="0">
+                <a:solidFill>
+                  <a:srgbClr val="000000"/>
+                </a:solidFill>
+                <a:latin typeface="Fira Sans"/>
+              </a:rPr>
+              <a:t>R² dice cuánto explica el modelo; el valor p, si un coeficiente se distingue del azar. Significativo no es importante.</a:t>
+            </a:r>
+          </a:p>
+          <a:p>
+            <a:pPr>
+              <a:lnSpc>
+                <a:spcPct val="112000"/>
+              </a:lnSpc>
+              <a:spcAft>
+                <a:spcPts val="900"/>
+              </a:spcAft>
+            </a:pPr>
+            <a:r>
+              <a:rPr sz="1800" b="1">
+                <a:solidFill>
+                  <a:srgbClr val="E0A437"/>
+                </a:solidFill>
+                <a:latin typeface="Fira Sans"/>
+              </a:rPr>
+              <a:t>▸ </a:t>
+            </a:r>
+            <a:r>
+              <a:rPr sz="1800" b="1">
+                <a:solidFill>
+                  <a:srgbClr val="1D3557"/>
+                </a:solidFill>
+                <a:latin typeface="Fira Sans"/>
+              </a:rPr>
+              <a:t>El primer EDA del proyecto usa exactamente estas herramientas (entrega: lunes 15).</a:t>
+            </a:r>
+          </a:p>
+        </p:txBody>
+      </p:sp>
+    </p:spTree>
+  </p:cSld>
+  <p:clrMapOvr>
+    <a:masterClrMapping/>
+  </p:clrMapOvr>
+</p:sld>
+</file>
+
+<file path=ppt/slides/slide28.xml><?xml version="1.0" encoding="utf-8"?>
+<p:sld xmlns:a="http://schemas.openxmlformats.org/drawingml/2006/main" xmlns:p="http://schemas.openxmlformats.org/presentationml/2006/main" xmlns:r="http://schemas.openxmlformats.org/officeDocument/2006/relationships">
+  <p:cSld>
+    <p:spTree>
+      <p:nvGrpSpPr>
+        <p:cNvPr id="1" name=""/>
+        <p:cNvGrpSpPr/>
+        <p:nvPr/>
+      </p:nvGrpSpPr>
+      <p:grpSpPr/>
+      <p:sp>
+        <p:nvSpPr>
+          <p:cNvPr id="2" name="Rectangle 1"/>
+          <p:cNvSpPr/>
+          <p:nvPr/>
+        </p:nvSpPr>
+        <p:spPr>
+          <a:xfrm>
+            <a:off x="0" y="0"/>
+            <a:ext cx="9144000" cy="5138928"/>
+          </a:xfrm>
+          <a:prstGeom prst="rect">
+            <a:avLst/>
+          </a:prstGeom>
+          <a:solidFill>
+            <a:srgbClr val="FAFBFC"/>
+          </a:solidFill>
+          <a:ln>
+            <a:noFill/>
+          </a:ln>
+          <a:effectLst/>
+        </p:spPr>
+        <p:style>
+          <a:lnRef idx="1">
+            <a:schemeClr val="accent1"/>
+          </a:lnRef>
+          <a:fillRef idx="3">
+            <a:schemeClr val="accent1"/>
+          </a:fillRef>
+          <a:effectRef idx="2">
+            <a:schemeClr val="accent1"/>
+          </a:effectRef>
+          <a:fontRef idx="minor">
+            <a:schemeClr val="lt1"/>
+          </a:fontRef>
+        </p:style>
+        <p:txBody>
+          <a:bodyPr rtlCol="0" anchor="ctr"/>
+          <a:lstStyle/>
+          <a:p>
+            <a:pPr algn="ctr"/>
+          </a:p>
+        </p:txBody>
+      </p:sp>
+      <p:sp>
+        <p:nvSpPr>
+          <p:cNvPr id="3" name="TextBox 2"/>
+          <p:cNvSpPr txBox="1"/>
+          <p:nvPr/>
+        </p:nvSpPr>
+        <p:spPr>
+          <a:xfrm>
+            <a:off x="402336" y="301752"/>
+            <a:ext cx="8348472" cy="795528"/>
+          </a:xfrm>
+          <a:prstGeom prst="rect">
+            <a:avLst/>
+          </a:prstGeom>
+          <a:noFill/>
+        </p:spPr>
+        <p:txBody>
+          <a:bodyPr wrap="square">
+            <a:spAutoFit/>
+          </a:bodyPr>
+          <a:lstStyle/>
+          <a:p>
+            <a:r>
+              <a:rPr sz="2800" b="1">
+                <a:solidFill>
+                  <a:srgbClr val="0F0F0F"/>
+                </a:solidFill>
+                <a:latin typeface="Fira Sans"/>
+              </a:rPr>
+              <a:t>Próxima clase</a:t>
+            </a:r>
+          </a:p>
+        </p:txBody>
+      </p:sp>
+      <p:sp>
+        <p:nvSpPr>
+          <p:cNvPr id="4" name="TextBox 3"/>
+          <p:cNvSpPr txBox="1"/>
+          <p:nvPr/>
+        </p:nvSpPr>
+        <p:spPr>
+          <a:xfrm>
+            <a:off x="704088" y="1353312"/>
+            <a:ext cx="7744968" cy="3300984"/>
+          </a:xfrm>
+          <a:prstGeom prst="rect">
+            <a:avLst/>
+          </a:prstGeom>
+          <a:noFill/>
+        </p:spPr>
+        <p:txBody>
+          <a:bodyPr wrap="square">
+            <a:spAutoFit/>
+          </a:bodyPr>
+          <a:lstStyle/>
+          <a:p>
+            <a:pPr>
+              <a:lnSpc>
+                <a:spcPct val="112000"/>
+              </a:lnSpc>
+              <a:spcAft>
+                <a:spcPts val="900"/>
+              </a:spcAft>
+            </a:pPr>
+            <a:r>
+              <a:rPr sz="1800" b="1">
+                <a:solidFill>
+                  <a:srgbClr val="E0A437"/>
+                </a:solidFill>
+                <a:latin typeface="Fira Sans"/>
+              </a:rPr>
+              <a:t>▸ </a:t>
+            </a:r>
+            <a:r>
+              <a:rPr sz="1800" b="0">
+                <a:solidFill>
+                  <a:srgbClr val="000000"/>
+                </a:solidFill>
+                <a:latin typeface="Fira Sans"/>
+              </a:rPr>
+              <a:t>Martes 8: fundamentos de probabilidad y nociones de inferencia estadística.</a:t>
+            </a:r>
+          </a:p>
+          <a:p>
+            <a:pPr>
+              <a:lnSpc>
+                <a:spcPct val="112000"/>
+              </a:lnSpc>
+              <a:spcAft>
+                <a:spcPts val="900"/>
+              </a:spcAft>
+            </a:pPr>
+            <a:r>
+              <a:rPr sz="1800" b="1">
+                <a:solidFill>
+                  <a:srgbClr val="E0A437"/>
+                </a:solidFill>
+                <a:latin typeface="Fira Sans"/>
+              </a:rPr>
+              <a:t>▸ </a:t>
+            </a:r>
+            <a:r>
+              <a:rPr sz="1800" b="0">
+                <a:solidFill>
+                  <a:srgbClr val="000000"/>
+                </a:solidFill>
+                <a:latin typeface="Fira Sans"/>
+              </a:rPr>
+              <a:t>La pregunta pendiente desde la clase 3: ¿qué significa el valor p que statsmodels ya nos mostró?</a:t>
+            </a:r>
+          </a:p>
+          <a:p>
+            <a:pPr>
+              <a:lnSpc>
+                <a:spcPct val="112000"/>
+              </a:lnSpc>
+              <a:spcAft>
+                <a:spcPts val="900"/>
+              </a:spcAft>
+            </a:pPr>
+            <a:r>
+              <a:rPr sz="1800" b="1">
+                <a:solidFill>
+                  <a:srgbClr val="E0A437"/>
+                </a:solidFill>
+                <a:latin typeface="Fira Sans"/>
+              </a:rPr>
+              <a:t>▸ </a:t>
+            </a:r>
+            <a:r>
+              <a:rPr sz="1800" b="1">
+                <a:solidFill>
+                  <a:srgbClr val="1D3557"/>
+                </a:solidFill>
+                <a:latin typeface="Fira Sans"/>
+              </a:rPr>
+              <a:t>La formulación se entrega el lunes 7; el primer análisis exploratorio, el lunes 15.</a:t>
+            </a:r>
+          </a:p>
+        </p:txBody>
+      </p:sp>
+    </p:spTree>
+  </p:cSld>
+  <p:clrMapOvr>
+    <a:masterClrMapping/>
+  </p:clrMapOvr>
+</p:sld>
+</file>
+
+<file path=ppt/slides/slide29.xml><?xml version="1.0" encoding="utf-8"?>
 <p:sld xmlns:a="http://schemas.openxmlformats.org/drawingml/2006/main" xmlns:p="http://schemas.openxmlformats.org/presentationml/2006/main" xmlns:r="http://schemas.openxmlformats.org/officeDocument/2006/relationships">
   <p:cSld>
     <p:spTree>

</xml_diff>

<commit_message>
Deck clase 4: sintesis en cinco puntos, sin desborde
Co-Authored-By: Claude Fable 5 <noreply@anthropic.com>
</commit_message>
<xml_diff>
--- a/presentaciones/clase04_regresion_multiple.pptx
+++ b/presentaciones/clase04_regresion_multiple.pptx
@@ -6907,7 +6907,7 @@
                 </a:solidFill>
                 <a:latin typeface="Fira Sans"/>
               </a:rPr>
-              <a:t>Muchos puntos: alpha o hexbin. Colas largas: log, que además es feature engineering.</a:t>
+              <a:t>Muchos puntos: alpha o hexbin. Colas largas: log.</a:t>
             </a:r>
           </a:p>
           <a:p>
@@ -6935,35 +6935,7 @@
                 </a:solidFill>
                 <a:latin typeface="Fira Sans"/>
               </a:rPr>
-              <a:t>La regresión múltiple aísla el efecto de cada variable con las demás constantes; las categóricas entran como dummies.</a:t>
-            </a:r>
-          </a:p>
-          <a:p>
-            <a:pPr>
-              <a:lnSpc>
-                <a:spcPct val="112000"/>
-              </a:lnSpc>
-              <a:spcAft>
-                <a:spcPts val="900"/>
-              </a:spcAft>
-            </a:pPr>
-            <a:r>
-              <a:rPr sz="1800" b="1">
-                <a:solidFill>
-                  <a:srgbClr val="E0A437"/>
-                </a:solidFill>
-                <a:latin typeface="Fira Sans"/>
-              </a:rPr>
-              <a:t>▸ </a:t>
-            </a:r>
-            <a:r>
-              <a:rPr sz="1800" b="0">
-                <a:solidFill>
-                  <a:srgbClr val="000000"/>
-                </a:solidFill>
-                <a:latin typeface="Fira Sans"/>
-              </a:rPr>
-              <a:t>R² dice cuánto explica el modelo; el valor p, si un coeficiente se distingue del azar. Significativo no es importante.</a:t>
+              <a:t>La múltiple aísla el efecto de cada variable (categóricas como dummies); R² dice cuánto explica y el valor p si un coeficiente se distingue del azar.</a:t>
             </a:r>
           </a:p>
           <a:p>

</xml_diff>

<commit_message>
Deck clase 4: la diapo del formato sin el esquema (ya esta en la pauta)
Co-Authored-By: Claude Fable 5 <noreply@anthropic.com>
</commit_message>
<xml_diff>
--- a/presentaciones/clase04_regresion_multiple.pptx
+++ b/presentaciones/clase04_regresion_multiple.pptx
@@ -7846,7 +7846,7 @@
                 </a:solidFill>
                 <a:latin typeface="Fira Sans"/>
               </a:rPr>
-              <a:t>Esquema sugerido: qué motiva el problema, el problema en sí, los datos y sus fuentes, y las primeras ideas.</a:t>
+              <a:t>Después de cada equipo, preguntas y comentarios del curso.</a:t>
             </a:r>
           </a:p>
           <a:p>
@@ -7874,35 +7874,7 @@
                 </a:solidFill>
                 <a:latin typeface="Fira Sans"/>
               </a:rPr>
-              <a:t>Después de cada equipo, preguntas y comentarios del curso.</a:t>
-            </a:r>
-          </a:p>
-          <a:p>
-            <a:pPr>
-              <a:lnSpc>
-                <a:spcPct val="112000"/>
-              </a:lnSpc>
-              <a:spcAft>
-                <a:spcPts val="900"/>
-              </a:spcAft>
-            </a:pPr>
-            <a:r>
-              <a:rPr sz="1800" b="1">
-                <a:solidFill>
-                  <a:srgbClr val="E0A437"/>
-                </a:solidFill>
-                <a:latin typeface="Fira Sans"/>
-              </a:rPr>
-              <a:t>▸ </a:t>
-            </a:r>
-            <a:r>
-              <a:rPr sz="1800" b="0">
-                <a:solidFill>
-                  <a:srgbClr val="000000"/>
-                </a:solidFill>
-                <a:latin typeface="Fira Sans"/>
-              </a:rPr>
-              <a:t>La pauta completa está en el repositorio, en evaluaciones.</a:t>
+              <a:t>La formulación se entrega el lunes 7: lo que escuchen hoy es insumo directo para ese documento.</a:t>
             </a:r>
           </a:p>
         </p:txBody>

</xml_diff>

<commit_message>
Deck clase 4: contenido en el primer bloque y presentaciones en el segundo
Co-Authored-By: Claude Fable 5 <noreply@anthropic.com>
</commit_message>
<xml_diff>
--- a/presentaciones/clase04_regresion_multiple.pptx
+++ b/presentaciones/clase04_regresion_multiple.pptx
@@ -3393,7 +3393,7 @@
             <a:avLst/>
           </a:prstGeom>
           <a:solidFill>
-            <a:srgbClr val="FAFBFC"/>
+            <a:srgbClr val="1D3557"/>
           </a:solidFill>
           <a:ln>
             <a:noFill/>
@@ -3430,8 +3430,8 @@
         </p:nvSpPr>
         <p:spPr>
           <a:xfrm>
-            <a:off x="402336" y="301752"/>
-            <a:ext cx="8348472" cy="795528"/>
+            <a:off x="603504" y="1847088"/>
+            <a:ext cx="7946136" cy="1399032"/>
           </a:xfrm>
           <a:prstGeom prst="rect">
             <a:avLst/>
@@ -3445,167 +3445,24 @@
           <a:lstStyle/>
           <a:p>
             <a:r>
-              <a:rPr sz="2800" b="1">
-                <a:solidFill>
-                  <a:srgbClr val="0F0F0F"/>
-                </a:solidFill>
-                <a:latin typeface="Fira Sans"/>
-              </a:rPr>
-              <a:t>Otro modelo: la motorización del hogar</a:t>
-            </a:r>
-          </a:p>
-        </p:txBody>
-      </p:sp>
-      <p:sp>
-        <p:nvSpPr>
-          <p:cNvPr id="4" name="Rectangle 3"/>
-          <p:cNvSpPr/>
-          <p:nvPr/>
-        </p:nvSpPr>
-        <p:spPr>
-          <a:xfrm>
-            <a:off x="704088" y="1280160"/>
-            <a:ext cx="7744968" cy="2880360"/>
-          </a:xfrm>
-          <a:prstGeom prst="rect">
-            <a:avLst/>
-          </a:prstGeom>
-          <a:solidFill>
-            <a:srgbClr val="F0F2F5"/>
-          </a:solidFill>
-          <a:ln>
-            <a:solidFill>
-              <a:srgbClr val="D8DDE3"/>
-            </a:solidFill>
-          </a:ln>
-          <a:effectLst/>
-        </p:spPr>
-        <p:style>
-          <a:lnRef idx="1">
-            <a:schemeClr val="accent1"/>
-          </a:lnRef>
-          <a:fillRef idx="3">
-            <a:schemeClr val="accent1"/>
-          </a:fillRef>
-          <a:effectRef idx="2">
-            <a:schemeClr val="accent1"/>
-          </a:effectRef>
-          <a:fontRef idx="minor">
-            <a:schemeClr val="lt1"/>
-          </a:fontRef>
-        </p:style>
-        <p:txBody>
-          <a:bodyPr rtlCol="0" anchor="ctr" wrap="square" lIns="228600" tIns="137160"/>
-          <a:lstStyle/>
-          <a:p>
-            <a:pPr/>
-            <a:r>
-              <a:rPr sz="1500" b="0">
-                <a:solidFill>
-                  <a:srgbClr val="1D3557"/>
-                </a:solidFill>
-                <a:latin typeface="Menlo"/>
-              </a:rPr>
-              <a:t>x = h["IngresoHogar"] / 1e6</a:t>
-            </a:r>
-          </a:p>
-          <a:p>
-            <a:pPr/>
-            <a:r>
-              <a:rPr sz="1500" b="0">
-                <a:solidFill>
-                  <a:srgbClr val="1D3557"/>
-                </a:solidFill>
-                <a:latin typeface="Menlo"/>
-              </a:rPr>
-              <a:t>y, w = h["NumVeh"], h["Factor"]</a:t>
-            </a:r>
-          </a:p>
-          <a:p>
-            <a:pPr/>
-            <a:r>
-              <a:rPr sz="1500" b="0">
-                <a:solidFill>
-                  <a:srgbClr val="1D3557"/>
-                </a:solidFill>
-                <a:latin typeface="Menlo"/>
-              </a:rPr>
-              <a:t/>
-            </a:r>
-          </a:p>
-          <a:p>
-            <a:pPr/>
-            <a:r>
-              <a:rPr sz="1500" b="0">
-                <a:solidFill>
-                  <a:srgbClr val="1D3557"/>
-                </a:solidFill>
-                <a:latin typeface="Menlo"/>
-              </a:rPr>
-              <a:t># La fórmula de la pendiente ponderada, tal cual</a:t>
-            </a:r>
-          </a:p>
-          <a:p>
-            <a:pPr/>
-            <a:r>
-              <a:rPr sz="1500" b="0">
-                <a:solidFill>
-                  <a:srgbClr val="1D3557"/>
-                </a:solidFill>
-                <a:latin typeface="Menlo"/>
-              </a:rPr>
-              <a:t>b = (w*(x - xw)*(y - yw)).sum() / (w*(x - xw)**2).sum()</a:t>
-            </a:r>
-          </a:p>
-        </p:txBody>
-      </p:sp>
-      <p:sp>
-        <p:nvSpPr>
-          <p:cNvPr id="5" name="TextBox 4"/>
-          <p:cNvSpPr txBox="1"/>
-          <p:nvPr/>
-        </p:nvSpPr>
-        <p:spPr>
-          <a:xfrm>
-            <a:off x="704088" y="4389120"/>
-            <a:ext cx="7744968" cy="1097280"/>
-          </a:xfrm>
-          <a:prstGeom prst="rect">
-            <a:avLst/>
-          </a:prstGeom>
-          <a:noFill/>
-        </p:spPr>
-        <p:txBody>
-          <a:bodyPr wrap="square">
-            <a:spAutoFit/>
-          </a:bodyPr>
-          <a:lstStyle/>
-          <a:p>
-            <a:pPr>
-              <a:lnSpc>
-                <a:spcPct val="112000"/>
-              </a:lnSpc>
-              <a:spcAft>
-                <a:spcPts val="900"/>
-              </a:spcAft>
-            </a:pPr>
-            <a:r>
-              <a:rPr sz="1600" b="1">
+              <a:rPr sz="3400" b="1">
+                <a:solidFill>
+                  <a:srgbClr val="FFFFFF"/>
+                </a:solidFill>
+                <a:latin typeface="Fira Sans"/>
+              </a:rPr>
+              <a:t>Visualización</a:t>
+            </a:r>
+          </a:p>
+          <a:p>
+            <a:r>
+              <a:rPr sz="1800" b="0">
                 <a:solidFill>
                   <a:srgbClr val="E0A437"/>
                 </a:solidFill>
                 <a:latin typeface="Fira Sans"/>
               </a:rPr>
-              <a:t>▸ </a:t>
-            </a:r>
-            <a:r>
-              <a:rPr sz="1600" b="0">
-                <a:solidFill>
-                  <a:srgbClr val="000000"/>
-                </a:solidFill>
-                <a:latin typeface="Fira Sans"/>
-              </a:rPr>
-              <a:t>18.264 hogares reales, ponderados por su factor: vehículos = 0,20 + 0,50 · ingreso. Medio vehículo más por cada millón.</a:t>
+              <a:t>Muchos puntos y colas largas</a:t>
             </a:r>
           </a:p>
         </p:txBody>
@@ -3701,14 +3558,14 @@
                 </a:solidFill>
                 <a:latin typeface="Fira Sans"/>
               </a:rPr>
-              <a:t>Los atípicos de la variable a predecir</a:t>
+              <a:t>Graficar 90 mil puntos: overplotting</a:t>
             </a:r>
           </a:p>
         </p:txBody>
       </p:sp>
       <p:pic>
         <p:nvPicPr>
-          <p:cNvPr id="4" name="Picture 3" descr="c3_27_boxplot_numveh.png"/>
+          <p:cNvPr id="4" name="Picture 3" descr="c3_08_overplotting.png"/>
           <p:cNvPicPr>
             <a:picLocks noChangeAspect="1"/>
           </p:cNvPicPr>
@@ -3722,8 +3579,8 @@
         </p:blipFill>
         <p:spPr>
           <a:xfrm>
-            <a:off x="699515" y="1492260"/>
-            <a:ext cx="7744968" cy="2456159"/>
+            <a:off x="699515" y="1545618"/>
+            <a:ext cx="7744968" cy="2349444"/>
           </a:xfrm>
           <a:prstGeom prst="rect">
             <a:avLst/>
@@ -3759,7 +3616,7 @@
                 </a:solidFill>
                 <a:latin typeface="Fira Sans"/>
               </a:rPr>
-              <a:t>El boxplot de NumVeh (clase 2): la cerca de Tukey queda en 2,5, y los hogares de 3 autos o más son atípicos. La siguiente diapo mide qué pasa al sacarlos.</a:t>
+              <a:t>Con todos los puntos sólidos, el scatter se satura y miente. Los remedios: transparencia (alpha), muestreo, o hexbin, donde el color cuenta los viajes (la distancia viene en la tabla DistanciaViaje.csv; sus −1 son faltantes disfrazados).</a:t>
             </a:r>
           </a:p>
         </p:txBody>
@@ -3855,114 +3712,35 @@
                 </a:solidFill>
                 <a:latin typeface="Fira Sans"/>
               </a:rPr>
-              <a:t>Sacar atípicos de la variable a predecir</a:t>
-            </a:r>
-          </a:p>
-        </p:txBody>
-      </p:sp>
-      <p:sp>
-        <p:nvSpPr>
-          <p:cNvPr id="4" name="Rectangle 3"/>
-          <p:cNvSpPr/>
-          <p:nvPr/>
-        </p:nvSpPr>
-        <p:spPr>
-          <a:xfrm>
-            <a:off x="704088" y="1280160"/>
-            <a:ext cx="7744968" cy="2880360"/>
-          </a:xfrm>
-          <a:prstGeom prst="rect">
-            <a:avLst/>
-          </a:prstGeom>
-          <a:solidFill>
-            <a:srgbClr val="F0F2F5"/>
-          </a:solidFill>
-          <a:ln>
-            <a:solidFill>
-              <a:srgbClr val="D8DDE3"/>
-            </a:solidFill>
-          </a:ln>
-          <a:effectLst/>
-        </p:spPr>
-        <p:style>
-          <a:lnRef idx="1">
-            <a:schemeClr val="accent1"/>
-          </a:lnRef>
-          <a:fillRef idx="3">
-            <a:schemeClr val="accent1"/>
-          </a:fillRef>
-          <a:effectRef idx="2">
-            <a:schemeClr val="accent1"/>
-          </a:effectRef>
-          <a:fontRef idx="minor">
-            <a:schemeClr val="lt1"/>
-          </a:fontRef>
-        </p:style>
-        <p:txBody>
-          <a:bodyPr rtlCol="0" anchor="ctr" wrap="square" lIns="228600" tIns="137160"/>
-          <a:lstStyle/>
-          <a:p>
-            <a:pPr/>
-            <a:r>
-              <a:rPr sz="1500" b="0">
-                <a:solidFill>
-                  <a:srgbClr val="1D3557"/>
-                </a:solidFill>
-                <a:latin typeface="Menlo"/>
-              </a:rPr>
-              <a:t>q1, q3 = h["NumVeh"].quantile([0.25, 0.75])</a:t>
-            </a:r>
-          </a:p>
-          <a:p>
-            <a:pPr/>
-            <a:r>
-              <a:rPr sz="1500" b="0">
-                <a:solidFill>
-                  <a:srgbClr val="1D3557"/>
-                </a:solidFill>
-                <a:latin typeface="Menlo"/>
-              </a:rPr>
-              <a:t>sin_atipicos = h[h["NumVeh"] &lt;= q3 + 1.5 * (q3 - q1)]</a:t>
-            </a:r>
-          </a:p>
-          <a:p>
-            <a:pPr/>
-            <a:r>
-              <a:rPr sz="1500" b="0">
-                <a:solidFill>
-                  <a:srgbClr val="1D3557"/>
-                </a:solidFill>
-                <a:latin typeface="Menlo"/>
-              </a:rPr>
-              <a:t/>
-            </a:r>
-          </a:p>
-          <a:p>
-            <a:pPr/>
-            <a:r>
-              <a:rPr sz="1500" b="0">
-                <a:solidFill>
-                  <a:srgbClr val="1D3557"/>
-                </a:solidFill>
-                <a:latin typeface="Menlo"/>
-              </a:rPr>
-              <a:t># El mismo modelo, sin los hogares de 3 autos o más</a:t>
-            </a:r>
-          </a:p>
-          <a:p>
-            <a:pPr/>
-            <a:r>
-              <a:rPr sz="1500" b="0">
-                <a:solidFill>
-                  <a:srgbClr val="1D3557"/>
-                </a:solidFill>
-                <a:latin typeface="Menlo"/>
-              </a:rPr>
-              <a:t>np.polyfit(sin_atipicos["IngresoHogar"] / 1e6, sin_atipicos["NumVeh"], 1)</a:t>
-            </a:r>
-          </a:p>
-        </p:txBody>
-      </p:sp>
+              <a:t>Cuándo usar escala logarítmica</a:t>
+            </a:r>
+          </a:p>
+        </p:txBody>
+      </p:sp>
+      <p:pic>
+        <p:nvPicPr>
+          <p:cNvPr id="4" name="Picture 3" descr="c3_10_escala_log.png"/>
+          <p:cNvPicPr>
+            <a:picLocks noChangeAspect="1"/>
+          </p:cNvPicPr>
+          <p:nvPr/>
+        </p:nvPicPr>
+        <p:blipFill>
+          <a:blip r:embed="rId2"/>
+          <a:stretch>
+            <a:fillRect/>
+          </a:stretch>
+        </p:blipFill>
+        <p:spPr>
+          <a:xfrm>
+            <a:off x="699515" y="1227136"/>
+            <a:ext cx="7744968" cy="2986407"/>
+          </a:xfrm>
+          <a:prstGeom prst="rect">
+            <a:avLst/>
+          </a:prstGeom>
+        </p:spPr>
+      </p:pic>
       <p:sp>
         <p:nvSpPr>
           <p:cNvPr id="5" name="TextBox 4"/>
@@ -3971,8 +3749,8 @@
         </p:nvSpPr>
         <p:spPr>
           <a:xfrm>
-            <a:off x="704088" y="4389120"/>
-            <a:ext cx="7744968" cy="1097280"/>
+            <a:off x="704088" y="4434840"/>
+            <a:ext cx="7744968" cy="457200"/>
           </a:xfrm>
           <a:prstGeom prst="rect">
             <a:avLst/>
@@ -3985,31 +3763,14 @@
           </a:bodyPr>
           <a:lstStyle/>
           <a:p>
-            <a:pPr>
-              <a:lnSpc>
-                <a:spcPct val="112000"/>
-              </a:lnSpc>
-              <a:spcAft>
-                <a:spcPts val="900"/>
-              </a:spcAft>
-            </a:pPr>
-            <a:r>
-              <a:rPr sz="1600" b="1">
-                <a:solidFill>
-                  <a:srgbClr val="E0A437"/>
-                </a:solidFill>
-                <a:latin typeface="Fira Sans"/>
-              </a:rPr>
-              <a:t>▸ </a:t>
-            </a:r>
-            <a:r>
-              <a:rPr sz="1600" b="0">
-                <a:solidFill>
-                  <a:srgbClr val="000000"/>
-                </a:solidFill>
-                <a:latin typeface="Fira Sans"/>
-              </a:rPr>
-              <a:t>Sacar 236 hogares aplana la pendiente ponderada (0,50 a 0,44): no eran errores, eran la señal. Los atípicos de y se investigan; se eliminan solo por dominio.</a:t>
+            <a:r>
+              <a:rPr sz="1300" b="0">
+                <a:solidFill>
+                  <a:srgbClr val="333333"/>
+                </a:solidFill>
+                <a:latin typeface="Fira Sans"/>
+              </a:rPr>
+              <a:t>La misma distancia tiene cola larga: en lineal se aplasta; en log, la forma aparece. Y transformar con log es feature engineering clásico: vuelve lineales las relaciones multiplicativas.</a:t>
             </a:r>
           </a:p>
         </p:txBody>
@@ -4047,7 +3808,7 @@
             <a:avLst/>
           </a:prstGeom>
           <a:solidFill>
-            <a:srgbClr val="1D3557"/>
+            <a:srgbClr val="FAFBFC"/>
           </a:solidFill>
           <a:ln>
             <a:noFill/>
@@ -4084,8 +3845,8 @@
         </p:nvSpPr>
         <p:spPr>
           <a:xfrm>
-            <a:off x="603504" y="1847088"/>
-            <a:ext cx="7946136" cy="1399032"/>
+            <a:off x="402336" y="301752"/>
+            <a:ext cx="8348472" cy="795528"/>
           </a:xfrm>
           <a:prstGeom prst="rect">
             <a:avLst/>
@@ -4099,24 +3860,71 @@
           <a:lstStyle/>
           <a:p>
             <a:r>
-              <a:rPr sz="3400" b="1">
-                <a:solidFill>
-                  <a:srgbClr val="FFFFFF"/>
-                </a:solidFill>
-                <a:latin typeface="Fira Sans"/>
-              </a:rPr>
-              <a:t>Visualización</a:t>
-            </a:r>
-          </a:p>
-          <a:p>
-            <a:r>
-              <a:rPr sz="1800" b="0">
-                <a:solidFill>
-                  <a:srgbClr val="E0A437"/>
-                </a:solidFill>
-                <a:latin typeface="Fira Sans"/>
-              </a:rPr>
-              <a:t>Muchos puntos y colas largas</a:t>
+              <a:rPr sz="2800" b="1">
+                <a:solidFill>
+                  <a:srgbClr val="0F0F0F"/>
+                </a:solidFill>
+                <a:latin typeface="Fira Sans"/>
+              </a:rPr>
+              <a:t>La misma regresión, tres veces</a:t>
+            </a:r>
+          </a:p>
+        </p:txBody>
+      </p:sp>
+      <p:pic>
+        <p:nvPicPr>
+          <p:cNvPr id="4" name="Picture 3" descr="c4_02_tres_modelos.png"/>
+          <p:cNvPicPr>
+            <a:picLocks noChangeAspect="1"/>
+          </p:cNvPicPr>
+          <p:nvPr/>
+        </p:nvPicPr>
+        <p:blipFill>
+          <a:blip r:embed="rId2"/>
+          <a:stretch>
+            <a:fillRect/>
+          </a:stretch>
+        </p:blipFill>
+        <p:spPr>
+          <a:xfrm>
+            <a:off x="699515" y="1660639"/>
+            <a:ext cx="7744968" cy="2119400"/>
+          </a:xfrm>
+          <a:prstGeom prst="rect">
+            <a:avLst/>
+          </a:prstGeom>
+        </p:spPr>
+      </p:pic>
+      <p:sp>
+        <p:nvSpPr>
+          <p:cNvPr id="5" name="TextBox 4"/>
+          <p:cNvSpPr txBox="1"/>
+          <p:nvPr/>
+        </p:nvSpPr>
+        <p:spPr>
+          <a:xfrm>
+            <a:off x="704088" y="4434840"/>
+            <a:ext cx="7744968" cy="457200"/>
+          </a:xfrm>
+          <a:prstGeom prst="rect">
+            <a:avLst/>
+          </a:prstGeom>
+          <a:noFill/>
+        </p:spPr>
+        <p:txBody>
+          <a:bodyPr wrap="square">
+            <a:spAutoFit/>
+          </a:bodyPr>
+          <a:lstStyle/>
+          <a:p>
+            <a:r>
+              <a:rPr sz="1300" b="0">
+                <a:solidFill>
+                  <a:srgbClr val="333333"/>
+                </a:solidFill>
+                <a:latin typeface="Fira Sans"/>
+              </a:rPr>
+              <a:t>La transformación aplicada a duración ~ distancia: el log en ambos lados endereza la nube y el R² sube de 0,32 a 0,53. Y el modelo todavía pide más variables.</a:t>
             </a:r>
           </a:p>
         </p:txBody>
@@ -4212,14 +4020,14 @@
                 </a:solidFill>
                 <a:latin typeface="Fira Sans"/>
               </a:rPr>
-              <a:t>Graficar 90 mil puntos: overplotting</a:t>
+              <a:t>El mismo gráfico, dos veces</a:t>
             </a:r>
           </a:p>
         </p:txBody>
       </p:sp>
       <p:pic>
         <p:nvPicPr>
-          <p:cNvPr id="4" name="Picture 3" descr="c3_08_overplotting.png"/>
+          <p:cNvPr id="4" name="Picture 3" descr="c3_16_mal_buen_grafico.png"/>
           <p:cNvPicPr>
             <a:picLocks noChangeAspect="1"/>
           </p:cNvPicPr>
@@ -4233,8 +4041,8 @@
         </p:blipFill>
         <p:spPr>
           <a:xfrm>
-            <a:off x="699515" y="1545618"/>
-            <a:ext cx="7744968" cy="2349444"/>
+            <a:off x="699515" y="1217944"/>
+            <a:ext cx="7744968" cy="3004790"/>
           </a:xfrm>
           <a:prstGeom prst="rect">
             <a:avLst/>
@@ -4270,7 +4078,7 @@
                 </a:solidFill>
                 <a:latin typeface="Fira Sans"/>
               </a:rPr>
-              <a:t>Con todos los puntos sólidos, el scatter se satura y miente. Los remedios: transparencia (alpha), muestreo, o hexbin, donde el color cuenta los viajes (la distancia viene en la tabla DistanciaViaje.csv; sus −1 son faltantes disfrazados).</a:t>
+              <a:t>Los mismos 30 mil viajes: sin rotular y saturado, contra rotulado, con transparencia y con el hallazgo en el título.</a:t>
             </a:r>
           </a:p>
         </p:txBody>
@@ -4366,45 +4174,21 @@
                 </a:solidFill>
                 <a:latin typeface="Fira Sans"/>
               </a:rPr>
-              <a:t>Cuándo usar escala logarítmica</a:t>
-            </a:r>
-          </a:p>
-        </p:txBody>
-      </p:sp>
-      <p:pic>
-        <p:nvPicPr>
-          <p:cNvPr id="4" name="Picture 3" descr="c3_10_escala_log.png"/>
-          <p:cNvPicPr>
-            <a:picLocks noChangeAspect="1"/>
-          </p:cNvPicPr>
-          <p:nvPr/>
-        </p:nvPicPr>
-        <p:blipFill>
-          <a:blip r:embed="rId2"/>
-          <a:stretch>
-            <a:fillRect/>
-          </a:stretch>
-        </p:blipFill>
-        <p:spPr>
-          <a:xfrm>
-            <a:off x="699515" y="1227136"/>
-            <a:ext cx="7744968" cy="2986407"/>
-          </a:xfrm>
-          <a:prstGeom prst="rect">
-            <a:avLst/>
-          </a:prstGeom>
-        </p:spPr>
-      </p:pic>
-      <p:sp>
-        <p:nvSpPr>
-          <p:cNvPr id="5" name="TextBox 4"/>
+              <a:t>Checklist del buen gráfico</a:t>
+            </a:r>
+          </a:p>
+        </p:txBody>
+      </p:sp>
+      <p:sp>
+        <p:nvSpPr>
+          <p:cNvPr id="4" name="TextBox 3"/>
           <p:cNvSpPr txBox="1"/>
           <p:nvPr/>
         </p:nvSpPr>
         <p:spPr>
           <a:xfrm>
-            <a:off x="704088" y="4434840"/>
-            <a:ext cx="7744968" cy="457200"/>
+            <a:off x="704088" y="1353312"/>
+            <a:ext cx="7744968" cy="3300984"/>
           </a:xfrm>
           <a:prstGeom prst="rect">
             <a:avLst/>
@@ -4417,14 +4201,143 @@
           </a:bodyPr>
           <a:lstStyle/>
           <a:p>
-            <a:r>
-              <a:rPr sz="1300" b="0">
-                <a:solidFill>
-                  <a:srgbClr val="333333"/>
-                </a:solidFill>
-                <a:latin typeface="Fira Sans"/>
-              </a:rPr>
-              <a:t>La misma distancia tiene cola larga: en lineal se aplasta; en log, la forma aparece. Y transformar con log es feature engineering clásico: vuelve lineales las relaciones multiplicativas.</a:t>
+            <a:pPr>
+              <a:lnSpc>
+                <a:spcPct val="112000"/>
+              </a:lnSpc>
+              <a:spcAft>
+                <a:spcPts val="900"/>
+              </a:spcAft>
+            </a:pPr>
+            <a:r>
+              <a:rPr sz="1800" b="1">
+                <a:solidFill>
+                  <a:srgbClr val="E0A437"/>
+                </a:solidFill>
+                <a:latin typeface="Fira Sans"/>
+              </a:rPr>
+              <a:t>▸ </a:t>
+            </a:r>
+            <a:r>
+              <a:rPr sz="1800" b="0">
+                <a:solidFill>
+                  <a:srgbClr val="000000"/>
+                </a:solidFill>
+                <a:latin typeface="Fira Sans"/>
+              </a:rPr>
+              <a:t>Título que diga el hallazgo, no solo las variables.</a:t>
+            </a:r>
+          </a:p>
+          <a:p>
+            <a:pPr>
+              <a:lnSpc>
+                <a:spcPct val="112000"/>
+              </a:lnSpc>
+              <a:spcAft>
+                <a:spcPts val="900"/>
+              </a:spcAft>
+            </a:pPr>
+            <a:r>
+              <a:rPr sz="1800" b="1">
+                <a:solidFill>
+                  <a:srgbClr val="E0A437"/>
+                </a:solidFill>
+                <a:latin typeface="Fira Sans"/>
+              </a:rPr>
+              <a:t>▸ </a:t>
+            </a:r>
+            <a:r>
+              <a:rPr sz="1800" b="0">
+                <a:solidFill>
+                  <a:srgbClr val="000000"/>
+                </a:solidFill>
+                <a:latin typeface="Fira Sans"/>
+              </a:rPr>
+              <a:t>Ejes con nombre y unidad; ejes que parten de cero en gráficos de barras.</a:t>
+            </a:r>
+          </a:p>
+          <a:p>
+            <a:pPr>
+              <a:lnSpc>
+                <a:spcPct val="112000"/>
+              </a:lnSpc>
+              <a:spcAft>
+                <a:spcPts val="900"/>
+              </a:spcAft>
+            </a:pPr>
+            <a:r>
+              <a:rPr sz="1800" b="1">
+                <a:solidFill>
+                  <a:srgbClr val="E0A437"/>
+                </a:solidFill>
+                <a:latin typeface="Fira Sans"/>
+              </a:rPr>
+              <a:t>▸ </a:t>
+            </a:r>
+            <a:r>
+              <a:rPr sz="1800" b="0">
+                <a:solidFill>
+                  <a:srgbClr val="000000"/>
+                </a:solidFill>
+                <a:latin typeface="Fira Sans"/>
+              </a:rPr>
+              <a:t>Muchos puntos: alpha, muestreo o hexbin.</a:t>
+            </a:r>
+          </a:p>
+          <a:p>
+            <a:pPr>
+              <a:lnSpc>
+                <a:spcPct val="112000"/>
+              </a:lnSpc>
+              <a:spcAft>
+                <a:spcPts val="900"/>
+              </a:spcAft>
+            </a:pPr>
+            <a:r>
+              <a:rPr sz="1800" b="1">
+                <a:solidFill>
+                  <a:srgbClr val="E0A437"/>
+                </a:solidFill>
+                <a:latin typeface="Fira Sans"/>
+              </a:rPr>
+              <a:t>▸ </a:t>
+            </a:r>
+            <a:r>
+              <a:rPr sz="1800" b="0">
+                <a:solidFill>
+                  <a:srgbClr val="000000"/>
+                </a:solidFill>
+                <a:latin typeface="Fira Sans"/>
+              </a:rPr>
+              <a:t>Colas largas: escala logarítmica o eje recortado, declarándolo.</a:t>
+            </a:r>
+          </a:p>
+          <a:p>
+            <a:pPr>
+              <a:lnSpc>
+                <a:spcPct val="112000"/>
+              </a:lnSpc>
+              <a:spcAft>
+                <a:spcPts val="900"/>
+              </a:spcAft>
+            </a:pPr>
+            <a:r>
+              <a:rPr sz="1800" b="1">
+                <a:solidFill>
+                  <a:srgbClr val="E0A437"/>
+                </a:solidFill>
+                <a:latin typeface="Fira Sans"/>
+              </a:rPr>
+              <a:t>▸ </a:t>
+            </a:r>
+            <a:r>
+              <a:rPr sz="1800" b="1">
+                <a:solidFill>
+                  <a:srgbClr val="1D3557"/>
+                </a:solidFill>
+                <a:latin typeface="Fira Sans"/>
+              </a:rPr>
+              <a:t>El gráfico se corrige igual que el código: se itera hasta que un tercero lo entienda sin explicación oral.</a:t>
             </a:r>
           </a:p>
         </p:txBody>
@@ -4462,7 +4375,7 @@
             <a:avLst/>
           </a:prstGeom>
           <a:solidFill>
-            <a:srgbClr val="FAFBFC"/>
+            <a:srgbClr val="1D3557"/>
           </a:solidFill>
           <a:ln>
             <a:noFill/>
@@ -4499,8 +4412,8 @@
         </p:nvSpPr>
         <p:spPr>
           <a:xfrm>
-            <a:off x="402336" y="301752"/>
-            <a:ext cx="8348472" cy="795528"/>
+            <a:off x="603504" y="1847088"/>
+            <a:ext cx="7946136" cy="1399032"/>
           </a:xfrm>
           <a:prstGeom prst="rect">
             <a:avLst/>
@@ -4514,71 +4427,24 @@
           <a:lstStyle/>
           <a:p>
             <a:r>
-              <a:rPr sz="2800" b="1">
-                <a:solidFill>
-                  <a:srgbClr val="0F0F0F"/>
-                </a:solidFill>
-                <a:latin typeface="Fira Sans"/>
-              </a:rPr>
-              <a:t>La misma regresión, tres veces</a:t>
-            </a:r>
-          </a:p>
-        </p:txBody>
-      </p:sp>
-      <p:pic>
-        <p:nvPicPr>
-          <p:cNvPr id="4" name="Picture 3" descr="c4_02_tres_modelos.png"/>
-          <p:cNvPicPr>
-            <a:picLocks noChangeAspect="1"/>
-          </p:cNvPicPr>
-          <p:nvPr/>
-        </p:nvPicPr>
-        <p:blipFill>
-          <a:blip r:embed="rId2"/>
-          <a:stretch>
-            <a:fillRect/>
-          </a:stretch>
-        </p:blipFill>
-        <p:spPr>
-          <a:xfrm>
-            <a:off x="699515" y="1660639"/>
-            <a:ext cx="7744968" cy="2119400"/>
-          </a:xfrm>
-          <a:prstGeom prst="rect">
-            <a:avLst/>
-          </a:prstGeom>
-        </p:spPr>
-      </p:pic>
-      <p:sp>
-        <p:nvSpPr>
-          <p:cNvPr id="5" name="TextBox 4"/>
-          <p:cNvSpPr txBox="1"/>
-          <p:nvPr/>
-        </p:nvSpPr>
-        <p:spPr>
-          <a:xfrm>
-            <a:off x="704088" y="4434840"/>
-            <a:ext cx="7744968" cy="457200"/>
-          </a:xfrm>
-          <a:prstGeom prst="rect">
-            <a:avLst/>
-          </a:prstGeom>
-          <a:noFill/>
-        </p:spPr>
-        <p:txBody>
-          <a:bodyPr wrap="square">
-            <a:spAutoFit/>
-          </a:bodyPr>
-          <a:lstStyle/>
-          <a:p>
-            <a:r>
-              <a:rPr sz="1300" b="0">
-                <a:solidFill>
-                  <a:srgbClr val="333333"/>
-                </a:solidFill>
-                <a:latin typeface="Fira Sans"/>
-              </a:rPr>
-              <a:t>La transformación aplicada a duración ~ distancia: el log en ambos lados endereza la nube y el R² sube de 0,32 a 0,53. Y el modelo todavía pide más variables.</a:t>
+              <a:rPr sz="3400" b="1">
+                <a:solidFill>
+                  <a:srgbClr val="FFFFFF"/>
+                </a:solidFill>
+                <a:latin typeface="Fira Sans"/>
+              </a:rPr>
+              <a:t>Regresión múltiple</a:t>
+            </a:r>
+          </a:p>
+          <a:p>
+            <a:r>
+              <a:rPr sz="1800" b="0">
+                <a:solidFill>
+                  <a:srgbClr val="E0A437"/>
+                </a:solidFill>
+                <a:latin typeface="Fira Sans"/>
+              </a:rPr>
+              <a:t>El primer modelo con varias variables</a:t>
             </a:r>
           </a:p>
         </p:txBody>
@@ -4674,14 +4540,14 @@
                 </a:solidFill>
                 <a:latin typeface="Fira Sans"/>
               </a:rPr>
-              <a:t>El mismo gráfico, dos veces</a:t>
+              <a:t>La fórmula de la regresión múltiple</a:t>
             </a:r>
           </a:p>
         </p:txBody>
       </p:sp>
       <p:pic>
         <p:nvPicPr>
-          <p:cNvPr id="4" name="Picture 3" descr="c3_16_mal_buen_grafico.png"/>
+          <p:cNvPr id="4" name="Picture 3" descr="c4_01_formula_multiple.png"/>
           <p:cNvPicPr>
             <a:picLocks noChangeAspect="1"/>
           </p:cNvPicPr>
@@ -4695,8 +4561,8 @@
         </p:blipFill>
         <p:spPr>
           <a:xfrm>
-            <a:off x="699515" y="1217944"/>
-            <a:ext cx="7744968" cy="3004790"/>
+            <a:off x="699515" y="1500263"/>
+            <a:ext cx="7744968" cy="2440154"/>
           </a:xfrm>
           <a:prstGeom prst="rect">
             <a:avLst/>
@@ -4732,7 +4598,7 @@
                 </a:solidFill>
                 <a:latin typeface="Fira Sans"/>
               </a:rPr>
-              <a:t>Los mismos 30 mil viajes: sin rotular y saturado, contra rotulado, con transparencia y con el hallazgo en el título.</a:t>
+              <a:t>Cada coeficiente aísla el efecto de su variable: cuánto cambia la predicción por una unidad de esa x, manteniendo las demás constantes.</a:t>
             </a:r>
           </a:p>
         </p:txBody>
@@ -4828,21 +4694,124 @@
                 </a:solidFill>
                 <a:latin typeface="Fira Sans"/>
               </a:rPr>
-              <a:t>Checklist del buen gráfico</a:t>
-            </a:r>
-          </a:p>
-        </p:txBody>
-      </p:sp>
-      <p:sp>
-        <p:nvSpPr>
-          <p:cNvPr id="4" name="TextBox 3"/>
+              <a:t>La motorización, con dos variables</a:t>
+            </a:r>
+          </a:p>
+        </p:txBody>
+      </p:sp>
+      <p:sp>
+        <p:nvSpPr>
+          <p:cNvPr id="4" name="Rectangle 3"/>
+          <p:cNvSpPr/>
+          <p:nvPr/>
+        </p:nvSpPr>
+        <p:spPr>
+          <a:xfrm>
+            <a:off x="704088" y="1280160"/>
+            <a:ext cx="7744968" cy="2880360"/>
+          </a:xfrm>
+          <a:prstGeom prst="rect">
+            <a:avLst/>
+          </a:prstGeom>
+          <a:solidFill>
+            <a:srgbClr val="F0F2F5"/>
+          </a:solidFill>
+          <a:ln>
+            <a:solidFill>
+              <a:srgbClr val="D8DDE3"/>
+            </a:solidFill>
+          </a:ln>
+          <a:effectLst/>
+        </p:spPr>
+        <p:style>
+          <a:lnRef idx="1">
+            <a:schemeClr val="accent1"/>
+          </a:lnRef>
+          <a:fillRef idx="3">
+            <a:schemeClr val="accent1"/>
+          </a:fillRef>
+          <a:effectRef idx="2">
+            <a:schemeClr val="accent1"/>
+          </a:effectRef>
+          <a:fontRef idx="minor">
+            <a:schemeClr val="lt1"/>
+          </a:fontRef>
+        </p:style>
+        <p:txBody>
+          <a:bodyPr rtlCol="0" anchor="ctr" wrap="square" lIns="228600" tIns="137160"/>
+          <a:lstStyle/>
+          <a:p>
+            <a:pPr/>
+            <a:r>
+              <a:rPr sz="1500" b="0">
+                <a:solidFill>
+                  <a:srgbClr val="1D3557"/>
+                </a:solidFill>
+                <a:latin typeface="Menlo"/>
+              </a:rPr>
+              <a:t>X = sm.add_constant(pd.DataFrame({</a:t>
+            </a:r>
+          </a:p>
+          <a:p>
+            <a:pPr/>
+            <a:r>
+              <a:rPr sz="1500" b="0">
+                <a:solidFill>
+                  <a:srgbClr val="1D3557"/>
+                </a:solidFill>
+                <a:latin typeface="Menlo"/>
+              </a:rPr>
+              <a:t>    "ingreso": h["IngresoHogar"] / 1e6,</a:t>
+            </a:r>
+          </a:p>
+          <a:p>
+            <a:pPr/>
+            <a:r>
+              <a:rPr sz="1500" b="0">
+                <a:solidFill>
+                  <a:srgbClr val="1D3557"/>
+                </a:solidFill>
+                <a:latin typeface="Menlo"/>
+              </a:rPr>
+              <a:t>    "personas": h["NumPer"]}))</a:t>
+            </a:r>
+          </a:p>
+          <a:p>
+            <a:pPr/>
+            <a:r>
+              <a:rPr sz="1500" b="0">
+                <a:solidFill>
+                  <a:srgbClr val="1D3557"/>
+                </a:solidFill>
+                <a:latin typeface="Menlo"/>
+              </a:rPr>
+              <a:t/>
+            </a:r>
+          </a:p>
+          <a:p>
+            <a:pPr/>
+            <a:r>
+              <a:rPr sz="1500" b="0">
+                <a:solidFill>
+                  <a:srgbClr val="1D3557"/>
+                </a:solidFill>
+                <a:latin typeface="Menlo"/>
+              </a:rPr>
+              <a:t>modelo = sm.WLS(h["NumVeh"], X, weights=h["Factor"]).fit()</a:t>
+            </a:r>
+          </a:p>
+        </p:txBody>
+      </p:sp>
+      <p:sp>
+        <p:nvSpPr>
+          <p:cNvPr id="5" name="TextBox 4"/>
           <p:cNvSpPr txBox="1"/>
           <p:nvPr/>
         </p:nvSpPr>
         <p:spPr>
           <a:xfrm>
-            <a:off x="704088" y="1353312"/>
-            <a:ext cx="7744968" cy="3300984"/>
+            <a:off x="704088" y="4389120"/>
+            <a:ext cx="7744968" cy="1097280"/>
           </a:xfrm>
           <a:prstGeom prst="rect">
             <a:avLst/>
@@ -4864,7 +4833,7 @@
               </a:spcAft>
             </a:pPr>
             <a:r>
-              <a:rPr sz="1800" b="1">
+              <a:rPr sz="1600" b="1">
                 <a:solidFill>
                   <a:srgbClr val="E0A437"/>
                 </a:solidFill>
@@ -4873,125 +4842,13 @@
               <a:t>▸ </a:t>
             </a:r>
             <a:r>
-              <a:rPr sz="1800" b="0">
+              <a:rPr sz="1600" b="0">
                 <a:solidFill>
                   <a:srgbClr val="000000"/>
                 </a:solidFill>
                 <a:latin typeface="Fira Sans"/>
               </a:rPr>
-              <a:t>Título que diga el hallazgo, no solo las variables.</a:t>
-            </a:r>
-          </a:p>
-          <a:p>
-            <a:pPr>
-              <a:lnSpc>
-                <a:spcPct val="112000"/>
-              </a:lnSpc>
-              <a:spcAft>
-                <a:spcPts val="900"/>
-              </a:spcAft>
-            </a:pPr>
-            <a:r>
-              <a:rPr sz="1800" b="1">
-                <a:solidFill>
-                  <a:srgbClr val="E0A437"/>
-                </a:solidFill>
-                <a:latin typeface="Fira Sans"/>
-              </a:rPr>
-              <a:t>▸ </a:t>
-            </a:r>
-            <a:r>
-              <a:rPr sz="1800" b="0">
-                <a:solidFill>
-                  <a:srgbClr val="000000"/>
-                </a:solidFill>
-                <a:latin typeface="Fira Sans"/>
-              </a:rPr>
-              <a:t>Ejes con nombre y unidad; ejes que parten de cero en gráficos de barras.</a:t>
-            </a:r>
-          </a:p>
-          <a:p>
-            <a:pPr>
-              <a:lnSpc>
-                <a:spcPct val="112000"/>
-              </a:lnSpc>
-              <a:spcAft>
-                <a:spcPts val="900"/>
-              </a:spcAft>
-            </a:pPr>
-            <a:r>
-              <a:rPr sz="1800" b="1">
-                <a:solidFill>
-                  <a:srgbClr val="E0A437"/>
-                </a:solidFill>
-                <a:latin typeface="Fira Sans"/>
-              </a:rPr>
-              <a:t>▸ </a:t>
-            </a:r>
-            <a:r>
-              <a:rPr sz="1800" b="0">
-                <a:solidFill>
-                  <a:srgbClr val="000000"/>
-                </a:solidFill>
-                <a:latin typeface="Fira Sans"/>
-              </a:rPr>
-              <a:t>Muchos puntos: alpha, muestreo o hexbin.</a:t>
-            </a:r>
-          </a:p>
-          <a:p>
-            <a:pPr>
-              <a:lnSpc>
-                <a:spcPct val="112000"/>
-              </a:lnSpc>
-              <a:spcAft>
-                <a:spcPts val="900"/>
-              </a:spcAft>
-            </a:pPr>
-            <a:r>
-              <a:rPr sz="1800" b="1">
-                <a:solidFill>
-                  <a:srgbClr val="E0A437"/>
-                </a:solidFill>
-                <a:latin typeface="Fira Sans"/>
-              </a:rPr>
-              <a:t>▸ </a:t>
-            </a:r>
-            <a:r>
-              <a:rPr sz="1800" b="0">
-                <a:solidFill>
-                  <a:srgbClr val="000000"/>
-                </a:solidFill>
-                <a:latin typeface="Fira Sans"/>
-              </a:rPr>
-              <a:t>Colas largas: escala logarítmica o eje recortado, declarándolo.</a:t>
-            </a:r>
-          </a:p>
-          <a:p>
-            <a:pPr>
-              <a:lnSpc>
-                <a:spcPct val="112000"/>
-              </a:lnSpc>
-              <a:spcAft>
-                <a:spcPts val="900"/>
-              </a:spcAft>
-            </a:pPr>
-            <a:r>
-              <a:rPr sz="1800" b="1">
-                <a:solidFill>
-                  <a:srgbClr val="E0A437"/>
-                </a:solidFill>
-                <a:latin typeface="Fira Sans"/>
-              </a:rPr>
-              <a:t>▸ </a:t>
-            </a:r>
-            <a:r>
-              <a:rPr sz="1800" b="1">
-                <a:solidFill>
-                  <a:srgbClr val="1D3557"/>
-                </a:solidFill>
-                <a:latin typeface="Fira Sans"/>
-              </a:rPr>
-              <a:t>El gráfico se corrige igual que el código: se itera hasta que un tercero lo entienda sin explicación oral.</a:t>
+              <a:t>Ponderado: 0,48 vehículos por millón (era 0,50 a solas) y 0,03 por persona extra. El R² sube apenas, de 0,261 a 0,266: agregar variables no siempre aporta.</a:t>
             </a:r>
           </a:p>
         </p:txBody>
@@ -5029,7 +4886,7 @@
             <a:avLst/>
           </a:prstGeom>
           <a:solidFill>
-            <a:srgbClr val="1D3557"/>
+            <a:srgbClr val="FAFBFC"/>
           </a:solidFill>
           <a:ln>
             <a:noFill/>
@@ -5066,8 +4923,8 @@
         </p:nvSpPr>
         <p:spPr>
           <a:xfrm>
-            <a:off x="603504" y="1847088"/>
-            <a:ext cx="7946136" cy="1399032"/>
+            <a:off x="402336" y="301752"/>
+            <a:ext cx="8348472" cy="795528"/>
           </a:xfrm>
           <a:prstGeom prst="rect">
             <a:avLst/>
@@ -5081,24 +4938,71 @@
           <a:lstStyle/>
           <a:p>
             <a:r>
-              <a:rPr sz="3400" b="1">
-                <a:solidFill>
-                  <a:srgbClr val="FFFFFF"/>
-                </a:solidFill>
-                <a:latin typeface="Fira Sans"/>
-              </a:rPr>
-              <a:t>Regresión múltiple</a:t>
-            </a:r>
-          </a:p>
-          <a:p>
-            <a:r>
-              <a:rPr sz="1800" b="0">
-                <a:solidFill>
-                  <a:srgbClr val="E0A437"/>
-                </a:solidFill>
-                <a:latin typeface="Fira Sans"/>
-              </a:rPr>
-              <a:t>El primer modelo con varias variables</a:t>
+              <a:rPr sz="2800" b="1">
+                <a:solidFill>
+                  <a:srgbClr val="0F0F0F"/>
+                </a:solidFill>
+                <a:latin typeface="Fira Sans"/>
+              </a:rPr>
+              <a:t>Leer el modelo: R²</a:t>
+            </a:r>
+          </a:p>
+        </p:txBody>
+      </p:sp>
+      <p:pic>
+        <p:nvPicPr>
+          <p:cNvPr id="4" name="Picture 3" descr="c4_04_formula_r2.png"/>
+          <p:cNvPicPr>
+            <a:picLocks noChangeAspect="1"/>
+          </p:cNvPicPr>
+          <p:nvPr/>
+        </p:nvPicPr>
+        <p:blipFill>
+          <a:blip r:embed="rId2"/>
+          <a:stretch>
+            <a:fillRect/>
+          </a:stretch>
+        </p:blipFill>
+        <p:spPr>
+          <a:xfrm>
+            <a:off x="699515" y="1297266"/>
+            <a:ext cx="7744968" cy="2846146"/>
+          </a:xfrm>
+          <a:prstGeom prst="rect">
+            <a:avLst/>
+          </a:prstGeom>
+        </p:spPr>
+      </p:pic>
+      <p:sp>
+        <p:nvSpPr>
+          <p:cNvPr id="5" name="TextBox 4"/>
+          <p:cNvSpPr txBox="1"/>
+          <p:nvPr/>
+        </p:nvSpPr>
+        <p:spPr>
+          <a:xfrm>
+            <a:off x="704088" y="4434840"/>
+            <a:ext cx="7744968" cy="457200"/>
+          </a:xfrm>
+          <a:prstGeom prst="rect">
+            <a:avLst/>
+          </a:prstGeom>
+          <a:noFill/>
+        </p:spPr>
+        <p:txBody>
+          <a:bodyPr wrap="square">
+            <a:spAutoFit/>
+          </a:bodyPr>
+          <a:lstStyle/>
+          <a:p>
+            <a:r>
+              <a:rPr sz="1300" b="0">
+                <a:solidFill>
+                  <a:srgbClr val="333333"/>
+                </a:solidFill>
+                <a:latin typeface="Fira Sans"/>
+              </a:rPr>
+              <a:t>Nuestro 0,266: ingreso y personas explican un cuarto de la variabilidad de los vehículos entre hogares. Agregar variables nunca baja el R²; por eso no basta con mirarlo.</a:t>
             </a:r>
           </a:p>
         </p:txBody>
@@ -5245,7 +5149,7 @@
                 </a:solidFill>
                 <a:latin typeface="Fira Sans"/>
               </a:rPr>
-              <a:t>1. Presentaciones de las ideas de proyecto Capstone.</a:t>
+              <a:t>1. El impacto de sacar filas y atípicos.</a:t>
             </a:r>
           </a:p>
           <a:p>
@@ -5273,7 +5177,7 @@
                 </a:solidFill>
                 <a:latin typeface="Fira Sans"/>
               </a:rPr>
-              <a:t>2. El impacto de sacar filas y atípicos.</a:t>
+              <a:t>2. La regresión ponderada (WLS).</a:t>
             </a:r>
           </a:p>
           <a:p>
@@ -5301,7 +5205,7 @@
                 </a:solidFill>
                 <a:latin typeface="Fira Sans"/>
               </a:rPr>
-              <a:t>3. La regresión ponderada (WLS).</a:t>
+              <a:t>3. Visualización: muchos puntos y colas largas.</a:t>
             </a:r>
           </a:p>
           <a:p>
@@ -5329,7 +5233,7 @@
                 </a:solidFill>
                 <a:latin typeface="Fira Sans"/>
               </a:rPr>
-              <a:t>4. Visualización: muchos puntos y colas largas.</a:t>
+              <a:t>4. Regresión múltiple: varias variables a la vez.</a:t>
             </a:r>
           </a:p>
           <a:p>
@@ -5357,7 +5261,7 @@
                 </a:solidFill>
                 <a:latin typeface="Fira Sans"/>
               </a:rPr>
-              <a:t>5. Regresión múltiple: varias variables a la vez.</a:t>
+              <a:t>5. Presentaciones de las ideas de proyecto Capstone (segundo bloque).</a:t>
             </a:r>
           </a:p>
         </p:txBody>
@@ -5453,45 +5357,21 @@
                 </a:solidFill>
                 <a:latin typeface="Fira Sans"/>
               </a:rPr>
-              <a:t>La fórmula de la regresión múltiple</a:t>
-            </a:r>
-          </a:p>
-        </p:txBody>
-      </p:sp>
-      <p:pic>
-        <p:nvPicPr>
-          <p:cNvPr id="4" name="Picture 3" descr="c4_01_formula_multiple.png"/>
-          <p:cNvPicPr>
-            <a:picLocks noChangeAspect="1"/>
-          </p:cNvPicPr>
-          <p:nvPr/>
-        </p:nvPicPr>
-        <p:blipFill>
-          <a:blip r:embed="rId2"/>
-          <a:stretch>
-            <a:fillRect/>
-          </a:stretch>
-        </p:blipFill>
-        <p:spPr>
-          <a:xfrm>
-            <a:off x="699515" y="1500263"/>
-            <a:ext cx="7744968" cy="2440154"/>
-          </a:xfrm>
-          <a:prstGeom prst="rect">
-            <a:avLst/>
-          </a:prstGeom>
-        </p:spPr>
-      </p:pic>
-      <p:sp>
-        <p:nvSpPr>
-          <p:cNvPr id="5" name="TextBox 4"/>
+              <a:t>El valor p, por ahora</a:t>
+            </a:r>
+          </a:p>
+        </p:txBody>
+      </p:sp>
+      <p:sp>
+        <p:nvSpPr>
+          <p:cNvPr id="4" name="TextBox 3"/>
           <p:cNvSpPr txBox="1"/>
           <p:nvPr/>
         </p:nvSpPr>
         <p:spPr>
           <a:xfrm>
-            <a:off x="704088" y="4434840"/>
-            <a:ext cx="7744968" cy="457200"/>
+            <a:off x="704088" y="1353312"/>
+            <a:ext cx="7744968" cy="3300984"/>
           </a:xfrm>
           <a:prstGeom prst="rect">
             <a:avLst/>
@@ -5504,14 +5384,115 @@
           </a:bodyPr>
           <a:lstStyle/>
           <a:p>
-            <a:r>
-              <a:rPr sz="1300" b="0">
-                <a:solidFill>
-                  <a:srgbClr val="333333"/>
-                </a:solidFill>
-                <a:latin typeface="Fira Sans"/>
-              </a:rPr>
-              <a:t>Cada coeficiente aísla el efecto de su variable: cuánto cambia la predicción por una unidad de esa x, manteniendo las demás constantes.</a:t>
+            <a:pPr>
+              <a:lnSpc>
+                <a:spcPct val="112000"/>
+              </a:lnSpc>
+              <a:spcAft>
+                <a:spcPts val="900"/>
+              </a:spcAft>
+            </a:pPr>
+            <a:r>
+              <a:rPr sz="1800" b="1">
+                <a:solidFill>
+                  <a:srgbClr val="E0A437"/>
+                </a:solidFill>
+                <a:latin typeface="Fira Sans"/>
+              </a:rPr>
+              <a:t>▸ </a:t>
+            </a:r>
+            <a:r>
+              <a:rPr sz="1800" b="1">
+                <a:solidFill>
+                  <a:srgbClr val="1D3557"/>
+                </a:solidFill>
+                <a:latin typeface="Fira Sans"/>
+              </a:rPr>
+              <a:t>La pregunta que responde: si el efecto real fuera cero, ¿qué tan raro sería este coeficiente solo por azar?</a:t>
+            </a:r>
+          </a:p>
+          <a:p>
+            <a:pPr>
+              <a:lnSpc>
+                <a:spcPct val="112000"/>
+              </a:lnSpc>
+              <a:spcAft>
+                <a:spcPts val="900"/>
+              </a:spcAft>
+            </a:pPr>
+            <a:r>
+              <a:rPr sz="1800" b="1">
+                <a:solidFill>
+                  <a:srgbClr val="E0A437"/>
+                </a:solidFill>
+                <a:latin typeface="Fira Sans"/>
+              </a:rPr>
+              <a:t>▸ </a:t>
+            </a:r>
+            <a:r>
+              <a:rPr sz="1800" b="0">
+                <a:solidFill>
+                  <a:srgbClr val="000000"/>
+                </a:solidFill>
+                <a:latin typeface="Fira Sans"/>
+              </a:rPr>
+              <a:t>En el summary es la columna P&gt;|t|: ingreso y personas dan p prácticamente 0, ninguna parece azar.</a:t>
+            </a:r>
+          </a:p>
+          <a:p>
+            <a:pPr>
+              <a:lnSpc>
+                <a:spcPct val="112000"/>
+              </a:lnSpc>
+              <a:spcAft>
+                <a:spcPts val="900"/>
+              </a:spcAft>
+            </a:pPr>
+            <a:r>
+              <a:rPr sz="1800" b="1">
+                <a:solidFill>
+                  <a:srgbClr val="E0A437"/>
+                </a:solidFill>
+                <a:latin typeface="Fira Sans"/>
+              </a:rPr>
+              <a:t>▸ </a:t>
+            </a:r>
+            <a:r>
+              <a:rPr sz="1800" b="0">
+                <a:solidFill>
+                  <a:srgbClr val="000000"/>
+                </a:solidFill>
+                <a:latin typeface="Fira Sans"/>
+              </a:rPr>
+              <a:t>Significativo no es sinónimo de importante: con 18 mil hogares, un aporte de 0,003 vehículos por bicicleta también da p diminuto.</a:t>
+            </a:r>
+          </a:p>
+          <a:p>
+            <a:pPr>
+              <a:lnSpc>
+                <a:spcPct val="112000"/>
+              </a:lnSpc>
+              <a:spcAft>
+                <a:spcPts val="900"/>
+              </a:spcAft>
+            </a:pPr>
+            <a:r>
+              <a:rPr sz="1800" b="1">
+                <a:solidFill>
+                  <a:srgbClr val="E0A437"/>
+                </a:solidFill>
+                <a:latin typeface="Fira Sans"/>
+              </a:rPr>
+              <a:t>▸ </a:t>
+            </a:r>
+            <a:r>
+              <a:rPr sz="1800" b="0">
+                <a:solidFill>
+                  <a:srgbClr val="000000"/>
+                </a:solidFill>
+                <a:latin typeface="Fira Sans"/>
+              </a:rPr>
+              <a:t>La definición formal, con hipótesis y umbrales, es la clase 5.</a:t>
             </a:r>
           </a:p>
         </p:txBody>
@@ -5607,114 +5588,35 @@
                 </a:solidFill>
                 <a:latin typeface="Fira Sans"/>
               </a:rPr>
-              <a:t>La motorización, con dos variables</a:t>
-            </a:r>
-          </a:p>
-        </p:txBody>
-      </p:sp>
-      <p:sp>
-        <p:nvSpPr>
-          <p:cNvPr id="4" name="Rectangle 3"/>
-          <p:cNvSpPr/>
-          <p:nvPr/>
-        </p:nvSpPr>
-        <p:spPr>
-          <a:xfrm>
-            <a:off x="704088" y="1280160"/>
-            <a:ext cx="7744968" cy="2880360"/>
-          </a:xfrm>
-          <a:prstGeom prst="rect">
-            <a:avLst/>
-          </a:prstGeom>
-          <a:solidFill>
-            <a:srgbClr val="F0F2F5"/>
-          </a:solidFill>
-          <a:ln>
-            <a:solidFill>
-              <a:srgbClr val="D8DDE3"/>
-            </a:solidFill>
-          </a:ln>
-          <a:effectLst/>
-        </p:spPr>
-        <p:style>
-          <a:lnRef idx="1">
-            <a:schemeClr val="accent1"/>
-          </a:lnRef>
-          <a:fillRef idx="3">
-            <a:schemeClr val="accent1"/>
-          </a:fillRef>
-          <a:effectRef idx="2">
-            <a:schemeClr val="accent1"/>
-          </a:effectRef>
-          <a:fontRef idx="minor">
-            <a:schemeClr val="lt1"/>
-          </a:fontRef>
-        </p:style>
-        <p:txBody>
-          <a:bodyPr rtlCol="0" anchor="ctr" wrap="square" lIns="228600" tIns="137160"/>
-          <a:lstStyle/>
-          <a:p>
-            <a:pPr/>
-            <a:r>
-              <a:rPr sz="1500" b="0">
-                <a:solidFill>
-                  <a:srgbClr val="1D3557"/>
-                </a:solidFill>
-                <a:latin typeface="Menlo"/>
-              </a:rPr>
-              <a:t>X = sm.add_constant(pd.DataFrame({</a:t>
-            </a:r>
-          </a:p>
-          <a:p>
-            <a:pPr/>
-            <a:r>
-              <a:rPr sz="1500" b="0">
-                <a:solidFill>
-                  <a:srgbClr val="1D3557"/>
-                </a:solidFill>
-                <a:latin typeface="Menlo"/>
-              </a:rPr>
-              <a:t>    "ingreso": h["IngresoHogar"] / 1e6,</a:t>
-            </a:r>
-          </a:p>
-          <a:p>
-            <a:pPr/>
-            <a:r>
-              <a:rPr sz="1500" b="0">
-                <a:solidFill>
-                  <a:srgbClr val="1D3557"/>
-                </a:solidFill>
-                <a:latin typeface="Menlo"/>
-              </a:rPr>
-              <a:t>    "personas": h["NumPer"]}))</a:t>
-            </a:r>
-          </a:p>
-          <a:p>
-            <a:pPr/>
-            <a:r>
-              <a:rPr sz="1500" b="0">
-                <a:solidFill>
-                  <a:srgbClr val="1D3557"/>
-                </a:solidFill>
-                <a:latin typeface="Menlo"/>
-              </a:rPr>
-              <a:t/>
-            </a:r>
-          </a:p>
-          <a:p>
-            <a:pPr/>
-            <a:r>
-              <a:rPr sz="1500" b="0">
-                <a:solidFill>
-                  <a:srgbClr val="1D3557"/>
-                </a:solidFill>
-                <a:latin typeface="Menlo"/>
-              </a:rPr>
-              <a:t>modelo = sm.WLS(h["NumVeh"], X, weights=h["Factor"]).fit()</a:t>
-            </a:r>
-          </a:p>
-        </p:txBody>
-      </p:sp>
+              <a:t>El mapa para elegir variables</a:t>
+            </a:r>
+          </a:p>
+        </p:txBody>
+      </p:sp>
+      <p:pic>
+        <p:nvPicPr>
+          <p:cNvPr id="4" name="Picture 3" descr="c4_05_mapa_candidatas.png"/>
+          <p:cNvPicPr>
+            <a:picLocks noChangeAspect="1"/>
+          </p:cNvPicPr>
+          <p:nvPr/>
+        </p:nvPicPr>
+        <p:blipFill>
+          <a:blip r:embed="rId2"/>
+          <a:stretch>
+            <a:fillRect/>
+          </a:stretch>
+        </p:blipFill>
+        <p:spPr>
+          <a:xfrm>
+            <a:off x="2530736" y="1143000"/>
+            <a:ext cx="4082527" cy="3154680"/>
+          </a:xfrm>
+          <a:prstGeom prst="rect">
+            <a:avLst/>
+          </a:prstGeom>
+        </p:spPr>
+      </p:pic>
       <p:sp>
         <p:nvSpPr>
           <p:cNvPr id="5" name="TextBox 4"/>
@@ -5723,8 +5625,8 @@
         </p:nvSpPr>
         <p:spPr>
           <a:xfrm>
-            <a:off x="704088" y="4389120"/>
-            <a:ext cx="7744968" cy="1097280"/>
+            <a:off x="704088" y="4434840"/>
+            <a:ext cx="7744968" cy="457200"/>
           </a:xfrm>
           <a:prstGeom prst="rect">
             <a:avLst/>
@@ -5737,31 +5639,14 @@
           </a:bodyPr>
           <a:lstStyle/>
           <a:p>
-            <a:pPr>
-              <a:lnSpc>
-                <a:spcPct val="112000"/>
-              </a:lnSpc>
-              <a:spcAft>
-                <a:spcPts val="900"/>
-              </a:spcAft>
-            </a:pPr>
-            <a:r>
-              <a:rPr sz="1600" b="1">
-                <a:solidFill>
-                  <a:srgbClr val="E0A437"/>
-                </a:solidFill>
-                <a:latin typeface="Fira Sans"/>
-              </a:rPr>
-              <a:t>▸ </a:t>
-            </a:r>
-            <a:r>
-              <a:rPr sz="1600" b="0">
-                <a:solidFill>
-                  <a:srgbClr val="000000"/>
-                </a:solidFill>
-                <a:latin typeface="Fira Sans"/>
-              </a:rPr>
-              <a:t>Ponderado: 0,48 vehículos por millón (era 0,50 a solas) y 0,03 por persona extra. El R² sube apenas, de 0,261 a 0,266: agregar variables no siempre aporta.</a:t>
+            <a:r>
+              <a:rPr sz="1300" b="0">
+                <a:solidFill>
+                  <a:srgbClr val="333333"/>
+                </a:solidFill>
+                <a:latin typeface="Fira Sans"/>
+              </a:rPr>
+              <a:t>La fila de NumVeh es el mapa: ingreso 0,47 es el motor; las bicicletas casi no correlacionan con los vehículos (0,06) y son redundantes entre sí (0,83). Probarlas confirma: R² 0,266 a 0,267.</a:t>
             </a:r>
           </a:p>
         </p:txBody>
@@ -5857,35 +5742,114 @@
                 </a:solidFill>
                 <a:latin typeface="Fira Sans"/>
               </a:rPr>
-              <a:t>Leer el modelo: R²</a:t>
-            </a:r>
-          </a:p>
-        </p:txBody>
-      </p:sp>
-      <p:pic>
-        <p:nvPicPr>
-          <p:cNvPr id="4" name="Picture 3" descr="c4_04_formula_r2.png"/>
-          <p:cNvPicPr>
-            <a:picLocks noChangeAspect="1"/>
-          </p:cNvPicPr>
-          <p:nvPr/>
-        </p:nvPicPr>
-        <p:blipFill>
-          <a:blip r:embed="rId2"/>
-          <a:stretch>
-            <a:fillRect/>
-          </a:stretch>
-        </p:blipFill>
-        <p:spPr>
-          <a:xfrm>
-            <a:off x="699515" y="1297266"/>
-            <a:ext cx="7744968" cy="2846146"/>
-          </a:xfrm>
-          <a:prstGeom prst="rect">
-            <a:avLst/>
-          </a:prstGeom>
-        </p:spPr>
-      </p:pic>
+              <a:t>Una categórica entra como dummies</a:t>
+            </a:r>
+          </a:p>
+        </p:txBody>
+      </p:sp>
+      <p:sp>
+        <p:nvSpPr>
+          <p:cNvPr id="4" name="Rectangle 3"/>
+          <p:cNvSpPr/>
+          <p:nvPr/>
+        </p:nvSpPr>
+        <p:spPr>
+          <a:xfrm>
+            <a:off x="704088" y="1280160"/>
+            <a:ext cx="7744968" cy="2880360"/>
+          </a:xfrm>
+          <a:prstGeom prst="rect">
+            <a:avLst/>
+          </a:prstGeom>
+          <a:solidFill>
+            <a:srgbClr val="F0F2F5"/>
+          </a:solidFill>
+          <a:ln>
+            <a:solidFill>
+              <a:srgbClr val="D8DDE3"/>
+            </a:solidFill>
+          </a:ln>
+          <a:effectLst/>
+        </p:spPr>
+        <p:style>
+          <a:lnRef idx="1">
+            <a:schemeClr val="accent1"/>
+          </a:lnRef>
+          <a:fillRef idx="3">
+            <a:schemeClr val="accent1"/>
+          </a:fillRef>
+          <a:effectRef idx="2">
+            <a:schemeClr val="accent1"/>
+          </a:effectRef>
+          <a:fontRef idx="minor">
+            <a:schemeClr val="lt1"/>
+          </a:fontRef>
+        </p:style>
+        <p:txBody>
+          <a:bodyPr rtlCol="0" anchor="ctr" wrap="square" lIns="228600" tIns="137160"/>
+          <a:lstStyle/>
+          <a:p>
+            <a:pPr/>
+            <a:r>
+              <a:rPr sz="1500" b="0">
+                <a:solidFill>
+                  <a:srgbClr val="1D3557"/>
+                </a:solidFill>
+                <a:latin typeface="Menlo"/>
+              </a:rPr>
+              <a:t># Una columna 0/1 por modo; el auto queda de referencia</a:t>
+            </a:r>
+          </a:p>
+          <a:p>
+            <a:pPr/>
+            <a:r>
+              <a:rPr sz="1500" b="0">
+                <a:solidFill>
+                  <a:srgbClr val="1D3557"/>
+                </a:solidFill>
+                <a:latin typeface="Menlo"/>
+              </a:rPr>
+              <a:t>dummies = pd.get_dummies(viajes["ModoAgrupado"])</a:t>
+            </a:r>
+          </a:p>
+          <a:p>
+            <a:pPr/>
+            <a:r>
+              <a:rPr sz="1500" b="0">
+                <a:solidFill>
+                  <a:srgbClr val="1D3557"/>
+                </a:solidFill>
+                <a:latin typeface="Menlo"/>
+              </a:rPr>
+              <a:t>dummies = dummies.drop(columns=["Auto"])</a:t>
+            </a:r>
+          </a:p>
+          <a:p>
+            <a:pPr/>
+            <a:r>
+              <a:rPr sz="1500" b="0">
+                <a:solidFill>
+                  <a:srgbClr val="1D3557"/>
+                </a:solidFill>
+                <a:latin typeface="Menlo"/>
+              </a:rPr>
+              <a:t/>
+            </a:r>
+          </a:p>
+          <a:p>
+            <a:pPr/>
+            <a:r>
+              <a:rPr sz="1500" b="0">
+                <a:solidFill>
+                  <a:srgbClr val="1D3557"/>
+                </a:solidFill>
+                <a:latin typeface="Menlo"/>
+              </a:rPr>
+              <a:t># Se agregan a la X junto al log de la distancia</a:t>
+            </a:r>
+          </a:p>
+        </p:txBody>
+      </p:sp>
       <p:sp>
         <p:nvSpPr>
           <p:cNvPr id="5" name="TextBox 4"/>
@@ -5894,8 +5858,8 @@
         </p:nvSpPr>
         <p:spPr>
           <a:xfrm>
-            <a:off x="704088" y="4434840"/>
-            <a:ext cx="7744968" cy="457200"/>
+            <a:off x="704088" y="4389120"/>
+            <a:ext cx="7744968" cy="1097280"/>
           </a:xfrm>
           <a:prstGeom prst="rect">
             <a:avLst/>
@@ -5908,14 +5872,31 @@
           </a:bodyPr>
           <a:lstStyle/>
           <a:p>
-            <a:r>
-              <a:rPr sz="1300" b="0">
-                <a:solidFill>
-                  <a:srgbClr val="333333"/>
-                </a:solidFill>
-                <a:latin typeface="Fira Sans"/>
-              </a:rPr>
-              <a:t>Nuestro 0,266: ingreso y personas explican un cuarto de la variabilidad de los vehículos entre hogares. Agregar variables nunca baja el R²; por eso no basta con mirarlo.</a:t>
+            <a:pPr>
+              <a:lnSpc>
+                <a:spcPct val="112000"/>
+              </a:lnSpc>
+              <a:spcAft>
+                <a:spcPts val="900"/>
+              </a:spcAft>
+            </a:pPr>
+            <a:r>
+              <a:rPr sz="1600" b="1">
+                <a:solidFill>
+                  <a:srgbClr val="E0A437"/>
+                </a:solidFill>
+                <a:latin typeface="Fira Sans"/>
+              </a:rPr>
+              <a:t>▸ </a:t>
+            </a:r>
+            <a:r>
+              <a:rPr sz="1600" b="0">
+                <a:solidFill>
+                  <a:srgbClr val="000000"/>
+                </a:solidFill>
+                <a:latin typeface="Fira Sans"/>
+              </a:rPr>
+              <a:t>Cada coeficiente se lee comparado con la referencia: qué le pasa al tiempo de un viaje por ser en ese modo y no en auto, a igual distancia.</a:t>
             </a:r>
           </a:p>
         </p:txBody>
@@ -6011,21 +5992,45 @@
                 </a:solidFill>
                 <a:latin typeface="Fira Sans"/>
               </a:rPr>
-              <a:t>El valor p, por ahora</a:t>
-            </a:r>
-          </a:p>
-        </p:txBody>
-      </p:sp>
-      <p:sp>
-        <p:nvSpPr>
-          <p:cNvPr id="4" name="TextBox 3"/>
+              <a:t>El resultado: distancia y modo</a:t>
+            </a:r>
+          </a:p>
+        </p:txBody>
+      </p:sp>
+      <p:pic>
+        <p:nvPicPr>
+          <p:cNvPr id="4" name="Picture 3" descr="c4_03_coef_modo.png"/>
+          <p:cNvPicPr>
+            <a:picLocks noChangeAspect="1"/>
+          </p:cNvPicPr>
+          <p:nvPr/>
+        </p:nvPicPr>
+        <p:blipFill>
+          <a:blip r:embed="rId2"/>
+          <a:stretch>
+            <a:fillRect/>
+          </a:stretch>
+        </p:blipFill>
+        <p:spPr>
+          <a:xfrm>
+            <a:off x="804842" y="1143000"/>
+            <a:ext cx="7534315" cy="3154680"/>
+          </a:xfrm>
+          <a:prstGeom prst="rect">
+            <a:avLst/>
+          </a:prstGeom>
+        </p:spPr>
+      </p:pic>
+      <p:sp>
+        <p:nvSpPr>
+          <p:cNvPr id="5" name="TextBox 4"/>
           <p:cNvSpPr txBox="1"/>
           <p:nvPr/>
         </p:nvSpPr>
         <p:spPr>
           <a:xfrm>
-            <a:off x="704088" y="1353312"/>
-            <a:ext cx="7744968" cy="3300984"/>
+            <a:off x="704088" y="4434840"/>
+            <a:ext cx="7744968" cy="457200"/>
           </a:xfrm>
           <a:prstGeom prst="rect">
             <a:avLst/>
@@ -6038,115 +6043,14 @@
           </a:bodyPr>
           <a:lstStyle/>
           <a:p>
-            <a:pPr>
-              <a:lnSpc>
-                <a:spcPct val="112000"/>
-              </a:lnSpc>
-              <a:spcAft>
-                <a:spcPts val="900"/>
-              </a:spcAft>
-            </a:pPr>
-            <a:r>
-              <a:rPr sz="1800" b="1">
-                <a:solidFill>
-                  <a:srgbClr val="E0A437"/>
-                </a:solidFill>
-                <a:latin typeface="Fira Sans"/>
-              </a:rPr>
-              <a:t>▸ </a:t>
-            </a:r>
-            <a:r>
-              <a:rPr sz="1800" b="1">
-                <a:solidFill>
-                  <a:srgbClr val="1D3557"/>
-                </a:solidFill>
-                <a:latin typeface="Fira Sans"/>
-              </a:rPr>
-              <a:t>La pregunta que responde: si el efecto real fuera cero, ¿qué tan raro sería este coeficiente solo por azar?</a:t>
-            </a:r>
-          </a:p>
-          <a:p>
-            <a:pPr>
-              <a:lnSpc>
-                <a:spcPct val="112000"/>
-              </a:lnSpc>
-              <a:spcAft>
-                <a:spcPts val="900"/>
-              </a:spcAft>
-            </a:pPr>
-            <a:r>
-              <a:rPr sz="1800" b="1">
-                <a:solidFill>
-                  <a:srgbClr val="E0A437"/>
-                </a:solidFill>
-                <a:latin typeface="Fira Sans"/>
-              </a:rPr>
-              <a:t>▸ </a:t>
-            </a:r>
-            <a:r>
-              <a:rPr sz="1800" b="0">
-                <a:solidFill>
-                  <a:srgbClr val="000000"/>
-                </a:solidFill>
-                <a:latin typeface="Fira Sans"/>
-              </a:rPr>
-              <a:t>En el summary es la columna P&gt;|t|: ingreso y personas dan p prácticamente 0, ninguna parece azar.</a:t>
-            </a:r>
-          </a:p>
-          <a:p>
-            <a:pPr>
-              <a:lnSpc>
-                <a:spcPct val="112000"/>
-              </a:lnSpc>
-              <a:spcAft>
-                <a:spcPts val="900"/>
-              </a:spcAft>
-            </a:pPr>
-            <a:r>
-              <a:rPr sz="1800" b="1">
-                <a:solidFill>
-                  <a:srgbClr val="E0A437"/>
-                </a:solidFill>
-                <a:latin typeface="Fira Sans"/>
-              </a:rPr>
-              <a:t>▸ </a:t>
-            </a:r>
-            <a:r>
-              <a:rPr sz="1800" b="0">
-                <a:solidFill>
-                  <a:srgbClr val="000000"/>
-                </a:solidFill>
-                <a:latin typeface="Fira Sans"/>
-              </a:rPr>
-              <a:t>Significativo no es sinónimo de importante: con 18 mil hogares, un aporte de 0,003 vehículos por bicicleta también da p diminuto.</a:t>
-            </a:r>
-          </a:p>
-          <a:p>
-            <a:pPr>
-              <a:lnSpc>
-                <a:spcPct val="112000"/>
-              </a:lnSpc>
-              <a:spcAft>
-                <a:spcPts val="900"/>
-              </a:spcAft>
-            </a:pPr>
-            <a:r>
-              <a:rPr sz="1800" b="1">
-                <a:solidFill>
-                  <a:srgbClr val="E0A437"/>
-                </a:solidFill>
-                <a:latin typeface="Fira Sans"/>
-              </a:rPr>
-              <a:t>▸ </a:t>
-            </a:r>
-            <a:r>
-              <a:rPr sz="1800" b="0">
-                <a:solidFill>
-                  <a:srgbClr val="000000"/>
-                </a:solidFill>
-                <a:latin typeface="Fira Sans"/>
-              </a:rPr>
-              <a:t>La definición formal, con hipótesis y umbrales, es la clase 5.</a:t>
+            <a:r>
+              <a:rPr sz="1300" b="0">
+                <a:solidFill>
+                  <a:srgbClr val="333333"/>
+                </a:solidFill>
+                <a:latin typeface="Fira Sans"/>
+              </a:rPr>
+              <a:t>A igual distancia, un viaje en Bip! tarda 1,87 veces lo que uno en auto; taxi y caminata quedan casi iguales al auto. El R² sube de 0,53 a 0,60.</a:t>
             </a:r>
           </a:p>
         </p:txBody>
@@ -6242,45 +6146,21 @@
                 </a:solidFill>
                 <a:latin typeface="Fira Sans"/>
               </a:rPr>
-              <a:t>El mapa para elegir variables</a:t>
-            </a:r>
-          </a:p>
-        </p:txBody>
-      </p:sp>
-      <p:pic>
-        <p:nvPicPr>
-          <p:cNvPr id="4" name="Picture 3" descr="c4_05_mapa_candidatas.png"/>
-          <p:cNvPicPr>
-            <a:picLocks noChangeAspect="1"/>
-          </p:cNvPicPr>
-          <p:nvPr/>
-        </p:nvPicPr>
-        <p:blipFill>
-          <a:blip r:embed="rId2"/>
-          <a:stretch>
-            <a:fillRect/>
-          </a:stretch>
-        </p:blipFill>
-        <p:spPr>
-          <a:xfrm>
-            <a:off x="2530736" y="1143000"/>
-            <a:ext cx="4082527" cy="3154680"/>
-          </a:xfrm>
-          <a:prstGeom prst="rect">
-            <a:avLst/>
-          </a:prstGeom>
-        </p:spPr>
-      </p:pic>
-      <p:sp>
-        <p:nvSpPr>
-          <p:cNvPr id="5" name="TextBox 4"/>
+              <a:t>Síntesis</a:t>
+            </a:r>
+          </a:p>
+        </p:txBody>
+      </p:sp>
+      <p:sp>
+        <p:nvSpPr>
+          <p:cNvPr id="4" name="TextBox 3"/>
           <p:cNvSpPr txBox="1"/>
           <p:nvPr/>
         </p:nvSpPr>
         <p:spPr>
           <a:xfrm>
-            <a:off x="704088" y="4434840"/>
-            <a:ext cx="7744968" cy="457200"/>
+            <a:off x="704088" y="1353312"/>
+            <a:ext cx="7744968" cy="3300984"/>
           </a:xfrm>
           <a:prstGeom prst="rect">
             <a:avLst/>
@@ -6293,14 +6173,143 @@
           </a:bodyPr>
           <a:lstStyle/>
           <a:p>
-            <a:r>
-              <a:rPr sz="1300" b="0">
-                <a:solidFill>
-                  <a:srgbClr val="333333"/>
-                </a:solidFill>
-                <a:latin typeface="Fira Sans"/>
-              </a:rPr>
-              <a:t>La fila de NumVeh es el mapa: ingreso 0,47 es el motor; las bicicletas casi no correlacionan con los vehículos (0,06) y son redundantes entre sí (0,83). Probarlas confirma: R² 0,266 a 0,267.</a:t>
+            <a:pPr>
+              <a:lnSpc>
+                <a:spcPct val="112000"/>
+              </a:lnSpc>
+              <a:spcAft>
+                <a:spcPts val="900"/>
+              </a:spcAft>
+            </a:pPr>
+            <a:r>
+              <a:rPr sz="1800" b="1">
+                <a:solidFill>
+                  <a:srgbClr val="E0A437"/>
+                </a:solidFill>
+                <a:latin typeface="Fira Sans"/>
+              </a:rPr>
+              <a:t>▸ </a:t>
+            </a:r>
+            <a:r>
+              <a:rPr sz="1800" b="0">
+                <a:solidFill>
+                  <a:srgbClr val="000000"/>
+                </a:solidFill>
+                <a:latin typeface="Fira Sans"/>
+              </a:rPr>
+              <a:t>El impacto de filas y atípicos se mide con y sin, sobre todos los resúmenes en uso.</a:t>
+            </a:r>
+          </a:p>
+          <a:p>
+            <a:pPr>
+              <a:lnSpc>
+                <a:spcPct val="112000"/>
+              </a:lnSpc>
+              <a:spcAft>
+                <a:spcPts val="900"/>
+              </a:spcAft>
+            </a:pPr>
+            <a:r>
+              <a:rPr sz="1800" b="1">
+                <a:solidFill>
+                  <a:srgbClr val="E0A437"/>
+                </a:solidFill>
+                <a:latin typeface="Fira Sans"/>
+              </a:rPr>
+              <a:t>▸ </a:t>
+            </a:r>
+            <a:r>
+              <a:rPr sz="1800" b="0">
+                <a:solidFill>
+                  <a:srgbClr val="000000"/>
+                </a:solidFill>
+                <a:latin typeface="Fira Sans"/>
+              </a:rPr>
+              <a:t>Cuando la conclusión es sobre la ciudad, se pondera: WLS.</a:t>
+            </a:r>
+          </a:p>
+          <a:p>
+            <a:pPr>
+              <a:lnSpc>
+                <a:spcPct val="112000"/>
+              </a:lnSpc>
+              <a:spcAft>
+                <a:spcPts val="900"/>
+              </a:spcAft>
+            </a:pPr>
+            <a:r>
+              <a:rPr sz="1800" b="1">
+                <a:solidFill>
+                  <a:srgbClr val="E0A437"/>
+                </a:solidFill>
+                <a:latin typeface="Fira Sans"/>
+              </a:rPr>
+              <a:t>▸ </a:t>
+            </a:r>
+            <a:r>
+              <a:rPr sz="1800" b="0">
+                <a:solidFill>
+                  <a:srgbClr val="000000"/>
+                </a:solidFill>
+                <a:latin typeface="Fira Sans"/>
+              </a:rPr>
+              <a:t>Muchos puntos: alpha o hexbin. Colas largas: log.</a:t>
+            </a:r>
+          </a:p>
+          <a:p>
+            <a:pPr>
+              <a:lnSpc>
+                <a:spcPct val="112000"/>
+              </a:lnSpc>
+              <a:spcAft>
+                <a:spcPts val="900"/>
+              </a:spcAft>
+            </a:pPr>
+            <a:r>
+              <a:rPr sz="1800" b="1">
+                <a:solidFill>
+                  <a:srgbClr val="E0A437"/>
+                </a:solidFill>
+                <a:latin typeface="Fira Sans"/>
+              </a:rPr>
+              <a:t>▸ </a:t>
+            </a:r>
+            <a:r>
+              <a:rPr sz="1800" b="0">
+                <a:solidFill>
+                  <a:srgbClr val="000000"/>
+                </a:solidFill>
+                <a:latin typeface="Fira Sans"/>
+              </a:rPr>
+              <a:t>La múltiple aísla el efecto de cada variable (categóricas como dummies); R² dice cuánto explica y el valor p si un coeficiente se distingue del azar.</a:t>
+            </a:r>
+          </a:p>
+          <a:p>
+            <a:pPr>
+              <a:lnSpc>
+                <a:spcPct val="112000"/>
+              </a:lnSpc>
+              <a:spcAft>
+                <a:spcPts val="900"/>
+              </a:spcAft>
+            </a:pPr>
+            <a:r>
+              <a:rPr sz="1800" b="1">
+                <a:solidFill>
+                  <a:srgbClr val="E0A437"/>
+                </a:solidFill>
+                <a:latin typeface="Fira Sans"/>
+              </a:rPr>
+              <a:t>▸ </a:t>
+            </a:r>
+            <a:r>
+              <a:rPr sz="1800" b="1">
+                <a:solidFill>
+                  <a:srgbClr val="1D3557"/>
+                </a:solidFill>
+                <a:latin typeface="Fira Sans"/>
+              </a:rPr>
+              <a:t>El primer EDA del proyecto usa exactamente estas herramientas (entrega: lunes 15).</a:t>
             </a:r>
           </a:p>
         </p:txBody>
@@ -6338,7 +6347,7 @@
             <a:avLst/>
           </a:prstGeom>
           <a:solidFill>
-            <a:srgbClr val="FAFBFC"/>
+            <a:srgbClr val="1D3557"/>
           </a:solidFill>
           <a:ln>
             <a:noFill/>
@@ -6375,8 +6384,8 @@
         </p:nvSpPr>
         <p:spPr>
           <a:xfrm>
-            <a:off x="402336" y="301752"/>
-            <a:ext cx="8348472" cy="795528"/>
+            <a:off x="603504" y="1847088"/>
+            <a:ext cx="7946136" cy="1399032"/>
           </a:xfrm>
           <a:prstGeom prst="rect">
             <a:avLst/>
@@ -6390,167 +6399,24 @@
           <a:lstStyle/>
           <a:p>
             <a:r>
-              <a:rPr sz="2800" b="1">
-                <a:solidFill>
-                  <a:srgbClr val="0F0F0F"/>
-                </a:solidFill>
-                <a:latin typeface="Fira Sans"/>
-              </a:rPr>
-              <a:t>Una categórica entra como dummies</a:t>
-            </a:r>
-          </a:p>
-        </p:txBody>
-      </p:sp>
-      <p:sp>
-        <p:nvSpPr>
-          <p:cNvPr id="4" name="Rectangle 3"/>
-          <p:cNvSpPr/>
-          <p:nvPr/>
-        </p:nvSpPr>
-        <p:spPr>
-          <a:xfrm>
-            <a:off x="704088" y="1280160"/>
-            <a:ext cx="7744968" cy="2880360"/>
-          </a:xfrm>
-          <a:prstGeom prst="rect">
-            <a:avLst/>
-          </a:prstGeom>
-          <a:solidFill>
-            <a:srgbClr val="F0F2F5"/>
-          </a:solidFill>
-          <a:ln>
-            <a:solidFill>
-              <a:srgbClr val="D8DDE3"/>
-            </a:solidFill>
-          </a:ln>
-          <a:effectLst/>
-        </p:spPr>
-        <p:style>
-          <a:lnRef idx="1">
-            <a:schemeClr val="accent1"/>
-          </a:lnRef>
-          <a:fillRef idx="3">
-            <a:schemeClr val="accent1"/>
-          </a:fillRef>
-          <a:effectRef idx="2">
-            <a:schemeClr val="accent1"/>
-          </a:effectRef>
-          <a:fontRef idx="minor">
-            <a:schemeClr val="lt1"/>
-          </a:fontRef>
-        </p:style>
-        <p:txBody>
-          <a:bodyPr rtlCol="0" anchor="ctr" wrap="square" lIns="228600" tIns="137160"/>
-          <a:lstStyle/>
-          <a:p>
-            <a:pPr/>
-            <a:r>
-              <a:rPr sz="1500" b="0">
-                <a:solidFill>
-                  <a:srgbClr val="1D3557"/>
-                </a:solidFill>
-                <a:latin typeface="Menlo"/>
-              </a:rPr>
-              <a:t># Una columna 0/1 por modo; el auto queda de referencia</a:t>
-            </a:r>
-          </a:p>
-          <a:p>
-            <a:pPr/>
-            <a:r>
-              <a:rPr sz="1500" b="0">
-                <a:solidFill>
-                  <a:srgbClr val="1D3557"/>
-                </a:solidFill>
-                <a:latin typeface="Menlo"/>
-              </a:rPr>
-              <a:t>dummies = pd.get_dummies(viajes["ModoAgrupado"])</a:t>
-            </a:r>
-          </a:p>
-          <a:p>
-            <a:pPr/>
-            <a:r>
-              <a:rPr sz="1500" b="0">
-                <a:solidFill>
-                  <a:srgbClr val="1D3557"/>
-                </a:solidFill>
-                <a:latin typeface="Menlo"/>
-              </a:rPr>
-              <a:t>dummies = dummies.drop(columns=["Auto"])</a:t>
-            </a:r>
-          </a:p>
-          <a:p>
-            <a:pPr/>
-            <a:r>
-              <a:rPr sz="1500" b="0">
-                <a:solidFill>
-                  <a:srgbClr val="1D3557"/>
-                </a:solidFill>
-                <a:latin typeface="Menlo"/>
-              </a:rPr>
-              <a:t/>
-            </a:r>
-          </a:p>
-          <a:p>
-            <a:pPr/>
-            <a:r>
-              <a:rPr sz="1500" b="0">
-                <a:solidFill>
-                  <a:srgbClr val="1D3557"/>
-                </a:solidFill>
-                <a:latin typeface="Menlo"/>
-              </a:rPr>
-              <a:t># Se agregan a la X junto al log de la distancia</a:t>
-            </a:r>
-          </a:p>
-        </p:txBody>
-      </p:sp>
-      <p:sp>
-        <p:nvSpPr>
-          <p:cNvPr id="5" name="TextBox 4"/>
-          <p:cNvSpPr txBox="1"/>
-          <p:nvPr/>
-        </p:nvSpPr>
-        <p:spPr>
-          <a:xfrm>
-            <a:off x="704088" y="4389120"/>
-            <a:ext cx="7744968" cy="1097280"/>
-          </a:xfrm>
-          <a:prstGeom prst="rect">
-            <a:avLst/>
-          </a:prstGeom>
-          <a:noFill/>
-        </p:spPr>
-        <p:txBody>
-          <a:bodyPr wrap="square">
-            <a:spAutoFit/>
-          </a:bodyPr>
-          <a:lstStyle/>
-          <a:p>
-            <a:pPr>
-              <a:lnSpc>
-                <a:spcPct val="112000"/>
-              </a:lnSpc>
-              <a:spcAft>
-                <a:spcPts val="900"/>
-              </a:spcAft>
-            </a:pPr>
-            <a:r>
-              <a:rPr sz="1600" b="1">
+              <a:rPr sz="3400" b="1">
+                <a:solidFill>
+                  <a:srgbClr val="FFFFFF"/>
+                </a:solidFill>
+                <a:latin typeface="Fira Sans"/>
+              </a:rPr>
+              <a:t>Recreo</a:t>
+            </a:r>
+          </a:p>
+          <a:p>
+            <a:r>
+              <a:rPr sz="1800" b="0">
                 <a:solidFill>
                   <a:srgbClr val="E0A437"/>
                 </a:solidFill>
                 <a:latin typeface="Fira Sans"/>
               </a:rPr>
-              <a:t>▸ </a:t>
-            </a:r>
-            <a:r>
-              <a:rPr sz="1600" b="0">
-                <a:solidFill>
-                  <a:srgbClr val="000000"/>
-                </a:solidFill>
-                <a:latin typeface="Fira Sans"/>
-              </a:rPr>
-              <a:t>Cada coeficiente se lee comparado con la referencia: qué le pasa al tiempo de un viaje por ser en ese modo y no en auto, a igual distancia.</a:t>
+              <a:t>10 minutos · al volver: las presentaciones de ideas</a:t>
             </a:r>
           </a:p>
         </p:txBody>
@@ -6588,7 +6454,7 @@
             <a:avLst/>
           </a:prstGeom>
           <a:solidFill>
-            <a:srgbClr val="FAFBFC"/>
+            <a:srgbClr val="1D3557"/>
           </a:solidFill>
           <a:ln>
             <a:noFill/>
@@ -6625,8 +6491,8 @@
         </p:nvSpPr>
         <p:spPr>
           <a:xfrm>
-            <a:off x="402336" y="301752"/>
-            <a:ext cx="8348472" cy="795528"/>
+            <a:off x="603504" y="1847088"/>
+            <a:ext cx="7946136" cy="1399032"/>
           </a:xfrm>
           <a:prstGeom prst="rect">
             <a:avLst/>
@@ -6640,71 +6506,24 @@
           <a:lstStyle/>
           <a:p>
             <a:r>
-              <a:rPr sz="2800" b="1">
-                <a:solidFill>
-                  <a:srgbClr val="0F0F0F"/>
-                </a:solidFill>
-                <a:latin typeface="Fira Sans"/>
-              </a:rPr>
-              <a:t>El resultado: distancia y modo</a:t>
-            </a:r>
-          </a:p>
-        </p:txBody>
-      </p:sp>
-      <p:pic>
-        <p:nvPicPr>
-          <p:cNvPr id="4" name="Picture 3" descr="c4_03_coef_modo.png"/>
-          <p:cNvPicPr>
-            <a:picLocks noChangeAspect="1"/>
-          </p:cNvPicPr>
-          <p:nvPr/>
-        </p:nvPicPr>
-        <p:blipFill>
-          <a:blip r:embed="rId2"/>
-          <a:stretch>
-            <a:fillRect/>
-          </a:stretch>
-        </p:blipFill>
-        <p:spPr>
-          <a:xfrm>
-            <a:off x="804842" y="1143000"/>
-            <a:ext cx="7534315" cy="3154680"/>
-          </a:xfrm>
-          <a:prstGeom prst="rect">
-            <a:avLst/>
-          </a:prstGeom>
-        </p:spPr>
-      </p:pic>
-      <p:sp>
-        <p:nvSpPr>
-          <p:cNvPr id="5" name="TextBox 4"/>
-          <p:cNvSpPr txBox="1"/>
-          <p:nvPr/>
-        </p:nvSpPr>
-        <p:spPr>
-          <a:xfrm>
-            <a:off x="704088" y="4434840"/>
-            <a:ext cx="7744968" cy="457200"/>
-          </a:xfrm>
-          <a:prstGeom prst="rect">
-            <a:avLst/>
-          </a:prstGeom>
-          <a:noFill/>
-        </p:spPr>
-        <p:txBody>
-          <a:bodyPr wrap="square">
-            <a:spAutoFit/>
-          </a:bodyPr>
-          <a:lstStyle/>
-          <a:p>
-            <a:r>
-              <a:rPr sz="1300" b="0">
-                <a:solidFill>
-                  <a:srgbClr val="333333"/>
-                </a:solidFill>
-                <a:latin typeface="Fira Sans"/>
-              </a:rPr>
-              <a:t>A igual distancia, un viaje en Bip! tarda 1,87 veces lo que uno en auto; taxi y caminata quedan casi iguales al auto. El R² sube de 0,53 a 0,60.</a:t>
+              <a:rPr sz="3400" b="1">
+                <a:solidFill>
+                  <a:srgbClr val="FFFFFF"/>
+                </a:solidFill>
+                <a:latin typeface="Fira Sans"/>
+              </a:rPr>
+              <a:t>Presentaciones de ideas</a:t>
+            </a:r>
+          </a:p>
+          <a:p>
+            <a:r>
+              <a:rPr sz="1800" b="0">
+                <a:solidFill>
+                  <a:srgbClr val="E0A437"/>
+                </a:solidFill>
+                <a:latin typeface="Fira Sans"/>
+              </a:rPr>
+              <a:t>De 5 a 7 minutos por equipo, y preguntas de todos</a:t>
             </a:r>
           </a:p>
         </p:txBody>
@@ -6800,7 +6619,7 @@
                 </a:solidFill>
                 <a:latin typeface="Fira Sans"/>
               </a:rPr>
-              <a:t>Síntesis</a:t>
+              <a:t>El formato</a:t>
             </a:r>
           </a:p>
         </p:txBody>
@@ -6845,13 +6664,13 @@
               <a:t>▸ </a:t>
             </a:r>
             <a:r>
-              <a:rPr sz="1800" b="0">
-                <a:solidFill>
-                  <a:srgbClr val="000000"/>
-                </a:solidFill>
-                <a:latin typeface="Fira Sans"/>
-              </a:rPr>
-              <a:t>El impacto de filas y atípicos se mide con y sin, sobre todos los resúmenes en uso.</a:t>
+              <a:rPr sz="1800" b="1">
+                <a:solidFill>
+                  <a:srgbClr val="1D3557"/>
+                </a:solidFill>
+                <a:latin typeface="Fira Sans"/>
+              </a:rPr>
+              <a:t>Esta instancia no lleva nota: es para recibir retroalimentación temprano, cuando corregir cuesta poco.</a:t>
             </a:r>
           </a:p>
           <a:p>
@@ -6879,7 +6698,7 @@
                 </a:solidFill>
                 <a:latin typeface="Fira Sans"/>
               </a:rPr>
-              <a:t>Cuando la conclusión es sobre la ciudad, se pondera: WLS.</a:t>
+              <a:t>Después de cada equipo, preguntas y comentarios del curso.</a:t>
             </a:r>
           </a:p>
           <a:p>
@@ -6907,63 +6726,7 @@
                 </a:solidFill>
                 <a:latin typeface="Fira Sans"/>
               </a:rPr>
-              <a:t>Muchos puntos: alpha o hexbin. Colas largas: log.</a:t>
-            </a:r>
-          </a:p>
-          <a:p>
-            <a:pPr>
-              <a:lnSpc>
-                <a:spcPct val="112000"/>
-              </a:lnSpc>
-              <a:spcAft>
-                <a:spcPts val="900"/>
-              </a:spcAft>
-            </a:pPr>
-            <a:r>
-              <a:rPr sz="1800" b="1">
-                <a:solidFill>
-                  <a:srgbClr val="E0A437"/>
-                </a:solidFill>
-                <a:latin typeface="Fira Sans"/>
-              </a:rPr>
-              <a:t>▸ </a:t>
-            </a:r>
-            <a:r>
-              <a:rPr sz="1800" b="0">
-                <a:solidFill>
-                  <a:srgbClr val="000000"/>
-                </a:solidFill>
-                <a:latin typeface="Fira Sans"/>
-              </a:rPr>
-              <a:t>La múltiple aísla el efecto de cada variable (categóricas como dummies); R² dice cuánto explica y el valor p si un coeficiente se distingue del azar.</a:t>
-            </a:r>
-          </a:p>
-          <a:p>
-            <a:pPr>
-              <a:lnSpc>
-                <a:spcPct val="112000"/>
-              </a:lnSpc>
-              <a:spcAft>
-                <a:spcPts val="900"/>
-              </a:spcAft>
-            </a:pPr>
-            <a:r>
-              <a:rPr sz="1800" b="1">
-                <a:solidFill>
-                  <a:srgbClr val="E0A437"/>
-                </a:solidFill>
-                <a:latin typeface="Fira Sans"/>
-              </a:rPr>
-              <a:t>▸ </a:t>
-            </a:r>
-            <a:r>
-              <a:rPr sz="1800" b="1">
-                <a:solidFill>
-                  <a:srgbClr val="1D3557"/>
-                </a:solidFill>
-                <a:latin typeface="Fira Sans"/>
-              </a:rPr>
-              <a:t>El primer EDA del proyecto usa exactamente estas herramientas (entrega: lunes 15).</a:t>
+              <a:t>La formulación se entrega el lunes 7: lo que escuchen hoy es insumo directo para ese documento.</a:t>
             </a:r>
           </a:p>
         </p:txBody>
@@ -7508,7 +7271,7 @@
                 </a:solidFill>
                 <a:latin typeface="Fira Sans"/>
               </a:rPr>
-              <a:t>Hoy: presentación de la idea de cada equipo, de 5 a 7 minutos, sin nota.</a:t>
+              <a:t>Hoy, en el segundo bloque: presentación de la idea de cada equipo, de 5 a 7 minutos, sin nota.</a:t>
             </a:r>
           </a:p>
           <a:p>
@@ -7660,7 +7423,7 @@
                 </a:solidFill>
                 <a:latin typeface="Fira Sans"/>
               </a:rPr>
-              <a:t>Presentaciones de ideas</a:t>
+              <a:t>Lo pendiente de la clase 3</a:t>
             </a:r>
           </a:p>
           <a:p>
@@ -7671,7 +7434,7 @@
                 </a:solidFill>
                 <a:latin typeface="Fira Sans"/>
               </a:rPr>
-              <a:t>De 5 a 7 minutos por equipo, y preguntas de todos</a:t>
+              <a:t>Del impacto de una fila a la regresión ponderada</a:t>
             </a:r>
           </a:p>
         </p:txBody>
@@ -7767,7 +7530,7 @@
                 </a:solidFill>
                 <a:latin typeface="Fira Sans"/>
               </a:rPr>
-              <a:t>El formato de hoy</a:t>
+              <a:t>El impacto de sacar una fila</a:t>
             </a:r>
           </a:p>
         </p:txBody>
@@ -7818,7 +7581,7 @@
                 </a:solidFill>
                 <a:latin typeface="Fira Sans"/>
               </a:rPr>
-              <a:t>Esta instancia no lleva nota: es para recibir retroalimentación temprano, cuando corregir cuesta poco.</a:t>
+              <a:t>Medirlo: recalcular cada resumen sin la fila, y comparar.</a:t>
             </a:r>
           </a:p>
           <a:p>
@@ -7846,7 +7609,7 @@
                 </a:solidFill>
                 <a:latin typeface="Fira Sans"/>
               </a:rPr>
-              <a:t>Después de cada equipo, preguntas y comentarios del curso.</a:t>
+              <a:t>Sin Lo Barnechea, r casi no se mueve (sigue en −0,34), pero la pendiente cambia en un quinto: de −4,8 a −5,8 minutos por millón.</a:t>
             </a:r>
           </a:p>
           <a:p>
@@ -7874,7 +7637,7 @@
                 </a:solidFill>
                 <a:latin typeface="Fira Sans"/>
               </a:rPr>
-              <a:t>La formulación se entrega el lunes 7: lo que escuchen hoy es insumo directo para ese documento.</a:t>
+              <a:t>Un mismo punto puede pesar poco en un resumen y mucho en otro. El código está en el notebook.</a:t>
             </a:r>
           </a:p>
         </p:txBody>
@@ -7912,7 +7675,7 @@
             <a:avLst/>
           </a:prstGeom>
           <a:solidFill>
-            <a:srgbClr val="1D3557"/>
+            <a:srgbClr val="FAFBFC"/>
           </a:solidFill>
           <a:ln>
             <a:noFill/>
@@ -7949,8 +7712,8 @@
         </p:nvSpPr>
         <p:spPr>
           <a:xfrm>
-            <a:off x="603504" y="1847088"/>
-            <a:ext cx="7946136" cy="1399032"/>
+            <a:off x="402336" y="301752"/>
+            <a:ext cx="8348472" cy="795528"/>
           </a:xfrm>
           <a:prstGeom prst="rect">
             <a:avLst/>
@@ -7964,24 +7727,71 @@
           <a:lstStyle/>
           <a:p>
             <a:r>
-              <a:rPr sz="3400" b="1">
-                <a:solidFill>
-                  <a:srgbClr val="FFFFFF"/>
-                </a:solidFill>
-                <a:latin typeface="Fira Sans"/>
-              </a:rPr>
-              <a:t>Recreo</a:t>
-            </a:r>
-          </a:p>
-          <a:p>
-            <a:r>
-              <a:rPr sz="1800" b="0">
-                <a:solidFill>
-                  <a:srgbClr val="E0A437"/>
-                </a:solidFill>
-                <a:latin typeface="Fira Sans"/>
-              </a:rPr>
-              <a:t>10 minutos · al volver: el cierre del EDA y la regresión múltiple</a:t>
+              <a:rPr sz="2800" b="1">
+                <a:solidFill>
+                  <a:srgbClr val="0F0F0F"/>
+                </a:solidFill>
+                <a:latin typeface="Fira Sans"/>
+              </a:rPr>
+              <a:t>Las fórmulas, con factor de expansión</a:t>
+            </a:r>
+          </a:p>
+        </p:txBody>
+      </p:sp>
+      <p:pic>
+        <p:nvPicPr>
+          <p:cNvPr id="4" name="Picture 3" descr="c3_22_formulas_ponderada.png"/>
+          <p:cNvPicPr>
+            <a:picLocks noChangeAspect="1"/>
+          </p:cNvPicPr>
+          <p:nvPr/>
+        </p:nvPicPr>
+        <p:blipFill>
+          <a:blip r:embed="rId2"/>
+          <a:stretch>
+            <a:fillRect/>
+          </a:stretch>
+        </p:blipFill>
+        <p:spPr>
+          <a:xfrm>
+            <a:off x="699515" y="1342115"/>
+            <a:ext cx="7744968" cy="2756450"/>
+          </a:xfrm>
+          <a:prstGeom prst="rect">
+            <a:avLst/>
+          </a:prstGeom>
+        </p:spPr>
+      </p:pic>
+      <p:sp>
+        <p:nvSpPr>
+          <p:cNvPr id="5" name="TextBox 4"/>
+          <p:cNvSpPr txBox="1"/>
+          <p:nvPr/>
+        </p:nvSpPr>
+        <p:spPr>
+          <a:xfrm>
+            <a:off x="704088" y="4434840"/>
+            <a:ext cx="7744968" cy="457200"/>
+          </a:xfrm>
+          <a:prstGeom prst="rect">
+            <a:avLst/>
+          </a:prstGeom>
+          <a:noFill/>
+        </p:spPr>
+        <p:txBody>
+          <a:bodyPr wrap="square">
+            <a:spAutoFit/>
+          </a:bodyPr>
+          <a:lstStyle/>
+          <a:p>
+            <a:r>
+              <a:rPr sz="1300" b="0">
+                <a:solidFill>
+                  <a:srgbClr val="333333"/>
+                </a:solidFill>
+                <a:latin typeface="Fira Sans"/>
+              </a:rPr>
+              <a:t>La misma recta de mínimos cuadrados, con cada término pesado por su factor: es la que usa el modelo que sigue, y en statsmodels se llama WLS (weighted least squares).</a:t>
             </a:r>
           </a:p>
         </p:txBody>
@@ -8019,7 +7829,7 @@
             <a:avLst/>
           </a:prstGeom>
           <a:solidFill>
-            <a:srgbClr val="1D3557"/>
+            <a:srgbClr val="FAFBFC"/>
           </a:solidFill>
           <a:ln>
             <a:noFill/>
@@ -8056,8 +7866,8 @@
         </p:nvSpPr>
         <p:spPr>
           <a:xfrm>
-            <a:off x="603504" y="1847088"/>
-            <a:ext cx="7946136" cy="1399032"/>
+            <a:off x="402336" y="301752"/>
+            <a:ext cx="8348472" cy="795528"/>
           </a:xfrm>
           <a:prstGeom prst="rect">
             <a:avLst/>
@@ -8071,24 +7881,167 @@
           <a:lstStyle/>
           <a:p>
             <a:r>
-              <a:rPr sz="3400" b="1">
-                <a:solidFill>
-                  <a:srgbClr val="FFFFFF"/>
-                </a:solidFill>
-                <a:latin typeface="Fira Sans"/>
-              </a:rPr>
-              <a:t>Lo pendiente de la clase 3</a:t>
-            </a:r>
-          </a:p>
-          <a:p>
-            <a:r>
-              <a:rPr sz="1800" b="0">
+              <a:rPr sz="2800" b="1">
+                <a:solidFill>
+                  <a:srgbClr val="0F0F0F"/>
+                </a:solidFill>
+                <a:latin typeface="Fira Sans"/>
+              </a:rPr>
+              <a:t>Otro modelo: la motorización del hogar</a:t>
+            </a:r>
+          </a:p>
+        </p:txBody>
+      </p:sp>
+      <p:sp>
+        <p:nvSpPr>
+          <p:cNvPr id="4" name="Rectangle 3"/>
+          <p:cNvSpPr/>
+          <p:nvPr/>
+        </p:nvSpPr>
+        <p:spPr>
+          <a:xfrm>
+            <a:off x="704088" y="1280160"/>
+            <a:ext cx="7744968" cy="2880360"/>
+          </a:xfrm>
+          <a:prstGeom prst="rect">
+            <a:avLst/>
+          </a:prstGeom>
+          <a:solidFill>
+            <a:srgbClr val="F0F2F5"/>
+          </a:solidFill>
+          <a:ln>
+            <a:solidFill>
+              <a:srgbClr val="D8DDE3"/>
+            </a:solidFill>
+          </a:ln>
+          <a:effectLst/>
+        </p:spPr>
+        <p:style>
+          <a:lnRef idx="1">
+            <a:schemeClr val="accent1"/>
+          </a:lnRef>
+          <a:fillRef idx="3">
+            <a:schemeClr val="accent1"/>
+          </a:fillRef>
+          <a:effectRef idx="2">
+            <a:schemeClr val="accent1"/>
+          </a:effectRef>
+          <a:fontRef idx="minor">
+            <a:schemeClr val="lt1"/>
+          </a:fontRef>
+        </p:style>
+        <p:txBody>
+          <a:bodyPr rtlCol="0" anchor="ctr" wrap="square" lIns="228600" tIns="137160"/>
+          <a:lstStyle/>
+          <a:p>
+            <a:pPr/>
+            <a:r>
+              <a:rPr sz="1500" b="0">
+                <a:solidFill>
+                  <a:srgbClr val="1D3557"/>
+                </a:solidFill>
+                <a:latin typeface="Menlo"/>
+              </a:rPr>
+              <a:t>x = h["IngresoHogar"] / 1e6</a:t>
+            </a:r>
+          </a:p>
+          <a:p>
+            <a:pPr/>
+            <a:r>
+              <a:rPr sz="1500" b="0">
+                <a:solidFill>
+                  <a:srgbClr val="1D3557"/>
+                </a:solidFill>
+                <a:latin typeface="Menlo"/>
+              </a:rPr>
+              <a:t>y, w = h["NumVeh"], h["Factor"]</a:t>
+            </a:r>
+          </a:p>
+          <a:p>
+            <a:pPr/>
+            <a:r>
+              <a:rPr sz="1500" b="0">
+                <a:solidFill>
+                  <a:srgbClr val="1D3557"/>
+                </a:solidFill>
+                <a:latin typeface="Menlo"/>
+              </a:rPr>
+              <a:t/>
+            </a:r>
+          </a:p>
+          <a:p>
+            <a:pPr/>
+            <a:r>
+              <a:rPr sz="1500" b="0">
+                <a:solidFill>
+                  <a:srgbClr val="1D3557"/>
+                </a:solidFill>
+                <a:latin typeface="Menlo"/>
+              </a:rPr>
+              <a:t># La fórmula de la pendiente ponderada, tal cual</a:t>
+            </a:r>
+          </a:p>
+          <a:p>
+            <a:pPr/>
+            <a:r>
+              <a:rPr sz="1500" b="0">
+                <a:solidFill>
+                  <a:srgbClr val="1D3557"/>
+                </a:solidFill>
+                <a:latin typeface="Menlo"/>
+              </a:rPr>
+              <a:t>b = (w*(x - xw)*(y - yw)).sum() / (w*(x - xw)**2).sum()</a:t>
+            </a:r>
+          </a:p>
+        </p:txBody>
+      </p:sp>
+      <p:sp>
+        <p:nvSpPr>
+          <p:cNvPr id="5" name="TextBox 4"/>
+          <p:cNvSpPr txBox="1"/>
+          <p:nvPr/>
+        </p:nvSpPr>
+        <p:spPr>
+          <a:xfrm>
+            <a:off x="704088" y="4389120"/>
+            <a:ext cx="7744968" cy="1097280"/>
+          </a:xfrm>
+          <a:prstGeom prst="rect">
+            <a:avLst/>
+          </a:prstGeom>
+          <a:noFill/>
+        </p:spPr>
+        <p:txBody>
+          <a:bodyPr wrap="square">
+            <a:spAutoFit/>
+          </a:bodyPr>
+          <a:lstStyle/>
+          <a:p>
+            <a:pPr>
+              <a:lnSpc>
+                <a:spcPct val="112000"/>
+              </a:lnSpc>
+              <a:spcAft>
+                <a:spcPts val="900"/>
+              </a:spcAft>
+            </a:pPr>
+            <a:r>
+              <a:rPr sz="1600" b="1">
                 <a:solidFill>
                   <a:srgbClr val="E0A437"/>
                 </a:solidFill>
                 <a:latin typeface="Fira Sans"/>
               </a:rPr>
-              <a:t>Del impacto de una fila a la regresión ponderada</a:t>
+              <a:t>▸ </a:t>
+            </a:r>
+            <a:r>
+              <a:rPr sz="1600" b="0">
+                <a:solidFill>
+                  <a:srgbClr val="000000"/>
+                </a:solidFill>
+                <a:latin typeface="Fira Sans"/>
+              </a:rPr>
+              <a:t>18.264 hogares reales, ponderados por su factor: vehículos = 0,20 + 0,50 · ingreso. Medio vehículo más por cada millón.</a:t>
             </a:r>
           </a:p>
         </p:txBody>
@@ -8184,21 +8137,45 @@
                 </a:solidFill>
                 <a:latin typeface="Fira Sans"/>
               </a:rPr>
-              <a:t>El impacto de sacar una fila</a:t>
-            </a:r>
-          </a:p>
-        </p:txBody>
-      </p:sp>
-      <p:sp>
-        <p:nvSpPr>
-          <p:cNvPr id="4" name="TextBox 3"/>
+              <a:t>Los atípicos de la variable a predecir</a:t>
+            </a:r>
+          </a:p>
+        </p:txBody>
+      </p:sp>
+      <p:pic>
+        <p:nvPicPr>
+          <p:cNvPr id="4" name="Picture 3" descr="c3_27_boxplot_numveh.png"/>
+          <p:cNvPicPr>
+            <a:picLocks noChangeAspect="1"/>
+          </p:cNvPicPr>
+          <p:nvPr/>
+        </p:nvPicPr>
+        <p:blipFill>
+          <a:blip r:embed="rId2"/>
+          <a:stretch>
+            <a:fillRect/>
+          </a:stretch>
+        </p:blipFill>
+        <p:spPr>
+          <a:xfrm>
+            <a:off x="699515" y="1492260"/>
+            <a:ext cx="7744968" cy="2456159"/>
+          </a:xfrm>
+          <a:prstGeom prst="rect">
+            <a:avLst/>
+          </a:prstGeom>
+        </p:spPr>
+      </p:pic>
+      <p:sp>
+        <p:nvSpPr>
+          <p:cNvPr id="5" name="TextBox 4"/>
           <p:cNvSpPr txBox="1"/>
           <p:nvPr/>
         </p:nvSpPr>
         <p:spPr>
           <a:xfrm>
-            <a:off x="704088" y="1353312"/>
-            <a:ext cx="7744968" cy="3300984"/>
+            <a:off x="704088" y="4434840"/>
+            <a:ext cx="7744968" cy="457200"/>
           </a:xfrm>
           <a:prstGeom prst="rect">
             <a:avLst/>
@@ -8211,87 +8188,14 @@
           </a:bodyPr>
           <a:lstStyle/>
           <a:p>
-            <a:pPr>
-              <a:lnSpc>
-                <a:spcPct val="112000"/>
-              </a:lnSpc>
-              <a:spcAft>
-                <a:spcPts val="900"/>
-              </a:spcAft>
-            </a:pPr>
-            <a:r>
-              <a:rPr sz="1800" b="1">
-                <a:solidFill>
-                  <a:srgbClr val="E0A437"/>
-                </a:solidFill>
-                <a:latin typeface="Fira Sans"/>
-              </a:rPr>
-              <a:t>▸ </a:t>
-            </a:r>
-            <a:r>
-              <a:rPr sz="1800" b="1">
-                <a:solidFill>
-                  <a:srgbClr val="1D3557"/>
-                </a:solidFill>
-                <a:latin typeface="Fira Sans"/>
-              </a:rPr>
-              <a:t>Medirlo: recalcular cada resumen sin la fila, y comparar.</a:t>
-            </a:r>
-          </a:p>
-          <a:p>
-            <a:pPr>
-              <a:lnSpc>
-                <a:spcPct val="112000"/>
-              </a:lnSpc>
-              <a:spcAft>
-                <a:spcPts val="900"/>
-              </a:spcAft>
-            </a:pPr>
-            <a:r>
-              <a:rPr sz="1800" b="1">
-                <a:solidFill>
-                  <a:srgbClr val="E0A437"/>
-                </a:solidFill>
-                <a:latin typeface="Fira Sans"/>
-              </a:rPr>
-              <a:t>▸ </a:t>
-            </a:r>
-            <a:r>
-              <a:rPr sz="1800" b="0">
-                <a:solidFill>
-                  <a:srgbClr val="000000"/>
-                </a:solidFill>
-                <a:latin typeface="Fira Sans"/>
-              </a:rPr>
-              <a:t>Sin Lo Barnechea, r casi no se mueve (sigue en −0,34), pero la pendiente cambia en un quinto: de −4,8 a −5,8 minutos por millón.</a:t>
-            </a:r>
-          </a:p>
-          <a:p>
-            <a:pPr>
-              <a:lnSpc>
-                <a:spcPct val="112000"/>
-              </a:lnSpc>
-              <a:spcAft>
-                <a:spcPts val="900"/>
-              </a:spcAft>
-            </a:pPr>
-            <a:r>
-              <a:rPr sz="1800" b="1">
-                <a:solidFill>
-                  <a:srgbClr val="E0A437"/>
-                </a:solidFill>
-                <a:latin typeface="Fira Sans"/>
-              </a:rPr>
-              <a:t>▸ </a:t>
-            </a:r>
-            <a:r>
-              <a:rPr sz="1800" b="0">
-                <a:solidFill>
-                  <a:srgbClr val="000000"/>
-                </a:solidFill>
-                <a:latin typeface="Fira Sans"/>
-              </a:rPr>
-              <a:t>Un mismo punto puede pesar poco en un resumen y mucho en otro. El código está en el notebook.</a:t>
+            <a:r>
+              <a:rPr sz="1300" b="0">
+                <a:solidFill>
+                  <a:srgbClr val="333333"/>
+                </a:solidFill>
+                <a:latin typeface="Fira Sans"/>
+              </a:rPr>
+              <a:t>El boxplot de NumVeh (clase 2): la cerca de Tukey queda en 2,5, y los hogares de 3 autos o más son atípicos. La siguiente diapo mide qué pasa al sacarlos.</a:t>
             </a:r>
           </a:p>
         </p:txBody>
@@ -8387,35 +8291,114 @@
                 </a:solidFill>
                 <a:latin typeface="Fira Sans"/>
               </a:rPr>
-              <a:t>Las fórmulas, con factor de expansión</a:t>
-            </a:r>
-          </a:p>
-        </p:txBody>
-      </p:sp>
-      <p:pic>
-        <p:nvPicPr>
-          <p:cNvPr id="4" name="Picture 3" descr="c3_22_formulas_ponderada.png"/>
-          <p:cNvPicPr>
-            <a:picLocks noChangeAspect="1"/>
-          </p:cNvPicPr>
-          <p:nvPr/>
-        </p:nvPicPr>
-        <p:blipFill>
-          <a:blip r:embed="rId2"/>
-          <a:stretch>
-            <a:fillRect/>
-          </a:stretch>
-        </p:blipFill>
-        <p:spPr>
-          <a:xfrm>
-            <a:off x="699515" y="1342115"/>
-            <a:ext cx="7744968" cy="2756450"/>
-          </a:xfrm>
-          <a:prstGeom prst="rect">
-            <a:avLst/>
-          </a:prstGeom>
-        </p:spPr>
-      </p:pic>
+              <a:t>Sacar atípicos de la variable a predecir</a:t>
+            </a:r>
+          </a:p>
+        </p:txBody>
+      </p:sp>
+      <p:sp>
+        <p:nvSpPr>
+          <p:cNvPr id="4" name="Rectangle 3"/>
+          <p:cNvSpPr/>
+          <p:nvPr/>
+        </p:nvSpPr>
+        <p:spPr>
+          <a:xfrm>
+            <a:off x="704088" y="1280160"/>
+            <a:ext cx="7744968" cy="2880360"/>
+          </a:xfrm>
+          <a:prstGeom prst="rect">
+            <a:avLst/>
+          </a:prstGeom>
+          <a:solidFill>
+            <a:srgbClr val="F0F2F5"/>
+          </a:solidFill>
+          <a:ln>
+            <a:solidFill>
+              <a:srgbClr val="D8DDE3"/>
+            </a:solidFill>
+          </a:ln>
+          <a:effectLst/>
+        </p:spPr>
+        <p:style>
+          <a:lnRef idx="1">
+            <a:schemeClr val="accent1"/>
+          </a:lnRef>
+          <a:fillRef idx="3">
+            <a:schemeClr val="accent1"/>
+          </a:fillRef>
+          <a:effectRef idx="2">
+            <a:schemeClr val="accent1"/>
+          </a:effectRef>
+          <a:fontRef idx="minor">
+            <a:schemeClr val="lt1"/>
+          </a:fontRef>
+        </p:style>
+        <p:txBody>
+          <a:bodyPr rtlCol="0" anchor="ctr" wrap="square" lIns="228600" tIns="137160"/>
+          <a:lstStyle/>
+          <a:p>
+            <a:pPr/>
+            <a:r>
+              <a:rPr sz="1500" b="0">
+                <a:solidFill>
+                  <a:srgbClr val="1D3557"/>
+                </a:solidFill>
+                <a:latin typeface="Menlo"/>
+              </a:rPr>
+              <a:t>q1, q3 = h["NumVeh"].quantile([0.25, 0.75])</a:t>
+            </a:r>
+          </a:p>
+          <a:p>
+            <a:pPr/>
+            <a:r>
+              <a:rPr sz="1500" b="0">
+                <a:solidFill>
+                  <a:srgbClr val="1D3557"/>
+                </a:solidFill>
+                <a:latin typeface="Menlo"/>
+              </a:rPr>
+              <a:t>sin_atipicos = h[h["NumVeh"] &lt;= q3 + 1.5 * (q3 - q1)]</a:t>
+            </a:r>
+          </a:p>
+          <a:p>
+            <a:pPr/>
+            <a:r>
+              <a:rPr sz="1500" b="0">
+                <a:solidFill>
+                  <a:srgbClr val="1D3557"/>
+                </a:solidFill>
+                <a:latin typeface="Menlo"/>
+              </a:rPr>
+              <a:t/>
+            </a:r>
+          </a:p>
+          <a:p>
+            <a:pPr/>
+            <a:r>
+              <a:rPr sz="1500" b="0">
+                <a:solidFill>
+                  <a:srgbClr val="1D3557"/>
+                </a:solidFill>
+                <a:latin typeface="Menlo"/>
+              </a:rPr>
+              <a:t># El mismo modelo, sin los hogares de 3 autos o más</a:t>
+            </a:r>
+          </a:p>
+          <a:p>
+            <a:pPr/>
+            <a:r>
+              <a:rPr sz="1500" b="0">
+                <a:solidFill>
+                  <a:srgbClr val="1D3557"/>
+                </a:solidFill>
+                <a:latin typeface="Menlo"/>
+              </a:rPr>
+              <a:t>np.polyfit(sin_atipicos["IngresoHogar"] / 1e6, sin_atipicos["NumVeh"], 1)</a:t>
+            </a:r>
+          </a:p>
+        </p:txBody>
+      </p:sp>
       <p:sp>
         <p:nvSpPr>
           <p:cNvPr id="5" name="TextBox 4"/>
@@ -8424,8 +8407,8 @@
         </p:nvSpPr>
         <p:spPr>
           <a:xfrm>
-            <a:off x="704088" y="4434840"/>
-            <a:ext cx="7744968" cy="457200"/>
+            <a:off x="704088" y="4389120"/>
+            <a:ext cx="7744968" cy="1097280"/>
           </a:xfrm>
           <a:prstGeom prst="rect">
             <a:avLst/>
@@ -8438,14 +8421,31 @@
           </a:bodyPr>
           <a:lstStyle/>
           <a:p>
-            <a:r>
-              <a:rPr sz="1300" b="0">
-                <a:solidFill>
-                  <a:srgbClr val="333333"/>
-                </a:solidFill>
-                <a:latin typeface="Fira Sans"/>
-              </a:rPr>
-              <a:t>La misma recta de mínimos cuadrados, con cada término pesado por su factor: es la que usa el modelo que sigue, y en statsmodels se llama WLS (weighted least squares).</a:t>
+            <a:pPr>
+              <a:lnSpc>
+                <a:spcPct val="112000"/>
+              </a:lnSpc>
+              <a:spcAft>
+                <a:spcPts val="900"/>
+              </a:spcAft>
+            </a:pPr>
+            <a:r>
+              <a:rPr sz="1600" b="1">
+                <a:solidFill>
+                  <a:srgbClr val="E0A437"/>
+                </a:solidFill>
+                <a:latin typeface="Fira Sans"/>
+              </a:rPr>
+              <a:t>▸ </a:t>
+            </a:r>
+            <a:r>
+              <a:rPr sz="1600" b="0">
+                <a:solidFill>
+                  <a:srgbClr val="000000"/>
+                </a:solidFill>
+                <a:latin typeface="Fira Sans"/>
+              </a:rPr>
+              <a:t>Sacar 236 hogares aplana la pendiente ponderada (0,50 a 0,44): no eran errores, eran la señal. Los atípicos de y se investigan; se eliminan solo por dominio.</a:t>
             </a:r>
           </a:p>
         </p:txBody>

</xml_diff>

<commit_message>
Deck clase 4: grafico del impacto de Lo Barnechea y el valor de la cerca (2,5) en el codigo
Co-Authored-By: Claude Fable 5 <noreply@anthropic.com>
</commit_message>
<xml_diff>
--- a/presentaciones/clase04_regresion_multiple.pptx
+++ b/presentaciones/clase04_regresion_multiple.pptx
@@ -7535,16 +7535,40 @@
           </a:p>
         </p:txBody>
       </p:sp>
-      <p:sp>
-        <p:nvSpPr>
-          <p:cNvPr id="4" name="TextBox 3"/>
+      <p:pic>
+        <p:nvPicPr>
+          <p:cNvPr id="4" name="Picture 3" descr="c4_06_impacto_fila.png"/>
+          <p:cNvPicPr>
+            <a:picLocks noChangeAspect="1"/>
+          </p:cNvPicPr>
+          <p:nvPr/>
+        </p:nvPicPr>
+        <p:blipFill>
+          <a:blip r:embed="rId2"/>
+          <a:stretch>
+            <a:fillRect/>
+          </a:stretch>
+        </p:blipFill>
+        <p:spPr>
+          <a:xfrm>
+            <a:off x="1353768" y="1143000"/>
+            <a:ext cx="6436462" cy="3154680"/>
+          </a:xfrm>
+          <a:prstGeom prst="rect">
+            <a:avLst/>
+          </a:prstGeom>
+        </p:spPr>
+      </p:pic>
+      <p:sp>
+        <p:nvSpPr>
+          <p:cNvPr id="5" name="TextBox 4"/>
           <p:cNvSpPr txBox="1"/>
           <p:nvPr/>
         </p:nvSpPr>
         <p:spPr>
           <a:xfrm>
-            <a:off x="704088" y="1353312"/>
-            <a:ext cx="7744968" cy="3300984"/>
+            <a:off x="704088" y="4434840"/>
+            <a:ext cx="7744968" cy="457200"/>
           </a:xfrm>
           <a:prstGeom prst="rect">
             <a:avLst/>
@@ -7557,87 +7581,14 @@
           </a:bodyPr>
           <a:lstStyle/>
           <a:p>
-            <a:pPr>
-              <a:lnSpc>
-                <a:spcPct val="112000"/>
-              </a:lnSpc>
-              <a:spcAft>
-                <a:spcPts val="900"/>
-              </a:spcAft>
-            </a:pPr>
-            <a:r>
-              <a:rPr sz="1800" b="1">
-                <a:solidFill>
-                  <a:srgbClr val="E0A437"/>
-                </a:solidFill>
-                <a:latin typeface="Fira Sans"/>
-              </a:rPr>
-              <a:t>▸ </a:t>
-            </a:r>
-            <a:r>
-              <a:rPr sz="1800" b="1">
-                <a:solidFill>
-                  <a:srgbClr val="1D3557"/>
-                </a:solidFill>
-                <a:latin typeface="Fira Sans"/>
-              </a:rPr>
-              <a:t>Medirlo: recalcular cada resumen sin la fila, y comparar.</a:t>
-            </a:r>
-          </a:p>
-          <a:p>
-            <a:pPr>
-              <a:lnSpc>
-                <a:spcPct val="112000"/>
-              </a:lnSpc>
-              <a:spcAft>
-                <a:spcPts val="900"/>
-              </a:spcAft>
-            </a:pPr>
-            <a:r>
-              <a:rPr sz="1800" b="1">
-                <a:solidFill>
-                  <a:srgbClr val="E0A437"/>
-                </a:solidFill>
-                <a:latin typeface="Fira Sans"/>
-              </a:rPr>
-              <a:t>▸ </a:t>
-            </a:r>
-            <a:r>
-              <a:rPr sz="1800" b="0">
-                <a:solidFill>
-                  <a:srgbClr val="000000"/>
-                </a:solidFill>
-                <a:latin typeface="Fira Sans"/>
-              </a:rPr>
-              <a:t>Sin Lo Barnechea, r casi no se mueve (sigue en −0,34), pero la pendiente cambia en un quinto: de −4,8 a −5,8 minutos por millón.</a:t>
-            </a:r>
-          </a:p>
-          <a:p>
-            <a:pPr>
-              <a:lnSpc>
-                <a:spcPct val="112000"/>
-              </a:lnSpc>
-              <a:spcAft>
-                <a:spcPts val="900"/>
-              </a:spcAft>
-            </a:pPr>
-            <a:r>
-              <a:rPr sz="1800" b="1">
-                <a:solidFill>
-                  <a:srgbClr val="E0A437"/>
-                </a:solidFill>
-                <a:latin typeface="Fira Sans"/>
-              </a:rPr>
-              <a:t>▸ </a:t>
-            </a:r>
-            <a:r>
-              <a:rPr sz="1800" b="0">
-                <a:solidFill>
-                  <a:srgbClr val="000000"/>
-                </a:solidFill>
-                <a:latin typeface="Fira Sans"/>
-              </a:rPr>
-              <a:t>Un mismo punto puede pesar poco en un resumen y mucho en otro. El código está en el notebook.</a:t>
+            <a:r>
+              <a:rPr sz="1300" b="0">
+                <a:solidFill>
+                  <a:srgbClr val="333333"/>
+                </a:solidFill>
+                <a:latin typeface="Fira Sans"/>
+              </a:rPr>
+              <a:t>Medirlo es recalcular con y sin: r casi no se mueve (−0,34), pero la pendiente cambia en un quinto, de −4,8 a −5,8 minutos por millón. Cada resumen tiene su propia sensibilidad.</a:t>
             </a:r>
           </a:p>
         </p:txBody>
@@ -8358,7 +8309,7 @@
                 </a:solidFill>
                 <a:latin typeface="Menlo"/>
               </a:rPr>
-              <a:t>sin_atipicos = h[h["NumVeh"] &lt;= q3 + 1.5 * (q3 - q1)]</a:t>
+              <a:t>sin_atipicos = h[h["NumVeh"] &lt;= q3 + 1.5 * (q3 - q1)]  # = 2.5</a:t>
             </a:r>
           </a:p>
           <a:p>

</xml_diff>

<commit_message>
Clase 4: ecuaciones ajustadas con su lectura, el valor p sobre el summary real y que explica cada modelo
Cada modelo declara que quiere explicar y con que variables (notebook y
codigo de las slides). Se agregan las ecuaciones ajustadas con numeros
reales y su lectura termino a termino (motorizacion y duracion), y la
diapo del valor p muestra la tabla de coeficientes del summary de
statsmodels con la columna P>|t| destacada. La diapo del formato queda
sin el punto redundante. Deck en 31 slides.

Co-Authored-By: Claude Fable 5 <noreply@anthropic.com>
</commit_message>
<xml_diff>
--- a/presentaciones/clase04_regresion_multiple.pptx
+++ b/presentaciones/clase04_regresion_multiple.pptx
@@ -34,6 +34,8 @@
     <p:sldId id="282" r:id="rId33"/>
     <p:sldId id="283" r:id="rId34"/>
     <p:sldId id="284" r:id="rId35"/>
+    <p:sldId id="285" r:id="rId36"/>
+    <p:sldId id="286" r:id="rId37"/>
   </p:sldIdLst>
   <p:sldSz cx="9144000" cy="5138928" type="screen4x3"/>
   <p:notesSz cx="6858000" cy="9144000"/>
@@ -4749,6 +4751,18 @@
                 </a:solidFill>
                 <a:latin typeface="Menlo"/>
               </a:rPr>
+              <a:t># Explicar los vehículos del hogar con el ingreso y las personas</a:t>
+            </a:r>
+          </a:p>
+          <a:p>
+            <a:pPr/>
+            <a:r>
+              <a:rPr sz="1500" b="0">
+                <a:solidFill>
+                  <a:srgbClr val="1D3557"/>
+                </a:solidFill>
+                <a:latin typeface="Menlo"/>
+              </a:rPr>
               <a:t>X = sm.add_constant(pd.DataFrame({</a:t>
             </a:r>
           </a:p>
@@ -4774,18 +4788,6 @@
                 <a:latin typeface="Menlo"/>
               </a:rPr>
               <a:t>    "personas": h["NumPer"]}))</a:t>
-            </a:r>
-          </a:p>
-          <a:p>
-            <a:pPr/>
-            <a:r>
-              <a:rPr sz="1500" b="0">
-                <a:solidFill>
-                  <a:srgbClr val="1D3557"/>
-                </a:solidFill>
-                <a:latin typeface="Menlo"/>
-              </a:rPr>
-              <a:t/>
             </a:r>
           </a:p>
           <a:p>
@@ -4944,14 +4946,14 @@
                 </a:solidFill>
                 <a:latin typeface="Fira Sans"/>
               </a:rPr>
-              <a:t>Leer el modelo: R²</a:t>
+              <a:t>La ecuación ajustada y su lectura</a:t>
             </a:r>
           </a:p>
         </p:txBody>
       </p:sp>
       <p:pic>
         <p:nvPicPr>
-          <p:cNvPr id="4" name="Picture 3" descr="c4_04_formula_r2.png"/>
+          <p:cNvPr id="4" name="Picture 3" descr="c4_08_ecuacion_motorizacion.png"/>
           <p:cNvPicPr>
             <a:picLocks noChangeAspect="1"/>
           </p:cNvPicPr>
@@ -4965,8 +4967,8 @@
         </p:blipFill>
         <p:spPr>
           <a:xfrm>
-            <a:off x="699515" y="1297266"/>
-            <a:ext cx="7744968" cy="2846146"/>
+            <a:off x="699515" y="1292657"/>
+            <a:ext cx="7744968" cy="2855366"/>
           </a:xfrm>
           <a:prstGeom prst="rect">
             <a:avLst/>
@@ -5002,7 +5004,7 @@
                 </a:solidFill>
                 <a:latin typeface="Fira Sans"/>
               </a:rPr>
-              <a:t>Nuestro 0,266: ingreso y personas explican un cuarto de la variabilidad de los vehículos entre hogares. Agregar variables nunca baja el R²; por eso no basta con mirarlo.</a:t>
+              <a:t>La fórmula de la múltiple con nuestros números: cada coeficiente se lee con las demás variables fijas.</a:t>
             </a:r>
           </a:p>
         </p:txBody>
@@ -5357,21 +5359,45 @@
                 </a:solidFill>
                 <a:latin typeface="Fira Sans"/>
               </a:rPr>
-              <a:t>El valor p, por ahora</a:t>
-            </a:r>
-          </a:p>
-        </p:txBody>
-      </p:sp>
-      <p:sp>
-        <p:nvSpPr>
-          <p:cNvPr id="4" name="TextBox 3"/>
+              <a:t>Leer el modelo: R²</a:t>
+            </a:r>
+          </a:p>
+        </p:txBody>
+      </p:sp>
+      <p:pic>
+        <p:nvPicPr>
+          <p:cNvPr id="4" name="Picture 3" descr="c4_04_formula_r2.png"/>
+          <p:cNvPicPr>
+            <a:picLocks noChangeAspect="1"/>
+          </p:cNvPicPr>
+          <p:nvPr/>
+        </p:nvPicPr>
+        <p:blipFill>
+          <a:blip r:embed="rId2"/>
+          <a:stretch>
+            <a:fillRect/>
+          </a:stretch>
+        </p:blipFill>
+        <p:spPr>
+          <a:xfrm>
+            <a:off x="699515" y="1297266"/>
+            <a:ext cx="7744968" cy="2846146"/>
+          </a:xfrm>
+          <a:prstGeom prst="rect">
+            <a:avLst/>
+          </a:prstGeom>
+        </p:spPr>
+      </p:pic>
+      <p:sp>
+        <p:nvSpPr>
+          <p:cNvPr id="5" name="TextBox 4"/>
           <p:cNvSpPr txBox="1"/>
           <p:nvPr/>
         </p:nvSpPr>
         <p:spPr>
           <a:xfrm>
-            <a:off x="704088" y="1353312"/>
-            <a:ext cx="7744968" cy="3300984"/>
+            <a:off x="704088" y="4434840"/>
+            <a:ext cx="7744968" cy="457200"/>
           </a:xfrm>
           <a:prstGeom prst="rect">
             <a:avLst/>
@@ -5384,115 +5410,14 @@
           </a:bodyPr>
           <a:lstStyle/>
           <a:p>
-            <a:pPr>
-              <a:lnSpc>
-                <a:spcPct val="112000"/>
-              </a:lnSpc>
-              <a:spcAft>
-                <a:spcPts val="900"/>
-              </a:spcAft>
-            </a:pPr>
-            <a:r>
-              <a:rPr sz="1800" b="1">
-                <a:solidFill>
-                  <a:srgbClr val="E0A437"/>
-                </a:solidFill>
-                <a:latin typeface="Fira Sans"/>
-              </a:rPr>
-              <a:t>▸ </a:t>
-            </a:r>
-            <a:r>
-              <a:rPr sz="1800" b="1">
-                <a:solidFill>
-                  <a:srgbClr val="1D3557"/>
-                </a:solidFill>
-                <a:latin typeface="Fira Sans"/>
-              </a:rPr>
-              <a:t>La pregunta que responde: si el efecto real fuera cero, ¿qué tan raro sería este coeficiente solo por azar?</a:t>
-            </a:r>
-          </a:p>
-          <a:p>
-            <a:pPr>
-              <a:lnSpc>
-                <a:spcPct val="112000"/>
-              </a:lnSpc>
-              <a:spcAft>
-                <a:spcPts val="900"/>
-              </a:spcAft>
-            </a:pPr>
-            <a:r>
-              <a:rPr sz="1800" b="1">
-                <a:solidFill>
-                  <a:srgbClr val="E0A437"/>
-                </a:solidFill>
-                <a:latin typeface="Fira Sans"/>
-              </a:rPr>
-              <a:t>▸ </a:t>
-            </a:r>
-            <a:r>
-              <a:rPr sz="1800" b="0">
-                <a:solidFill>
-                  <a:srgbClr val="000000"/>
-                </a:solidFill>
-                <a:latin typeface="Fira Sans"/>
-              </a:rPr>
-              <a:t>En el summary es la columna P&gt;|t|: ingreso y personas dan p prácticamente 0, ninguna parece azar.</a:t>
-            </a:r>
-          </a:p>
-          <a:p>
-            <a:pPr>
-              <a:lnSpc>
-                <a:spcPct val="112000"/>
-              </a:lnSpc>
-              <a:spcAft>
-                <a:spcPts val="900"/>
-              </a:spcAft>
-            </a:pPr>
-            <a:r>
-              <a:rPr sz="1800" b="1">
-                <a:solidFill>
-                  <a:srgbClr val="E0A437"/>
-                </a:solidFill>
-                <a:latin typeface="Fira Sans"/>
-              </a:rPr>
-              <a:t>▸ </a:t>
-            </a:r>
-            <a:r>
-              <a:rPr sz="1800" b="0">
-                <a:solidFill>
-                  <a:srgbClr val="000000"/>
-                </a:solidFill>
-                <a:latin typeface="Fira Sans"/>
-              </a:rPr>
-              <a:t>Significativo no es sinónimo de importante: con 18 mil hogares, un aporte de 0,003 vehículos por bicicleta también da p diminuto.</a:t>
-            </a:r>
-          </a:p>
-          <a:p>
-            <a:pPr>
-              <a:lnSpc>
-                <a:spcPct val="112000"/>
-              </a:lnSpc>
-              <a:spcAft>
-                <a:spcPts val="900"/>
-              </a:spcAft>
-            </a:pPr>
-            <a:r>
-              <a:rPr sz="1800" b="1">
-                <a:solidFill>
-                  <a:srgbClr val="E0A437"/>
-                </a:solidFill>
-                <a:latin typeface="Fira Sans"/>
-              </a:rPr>
-              <a:t>▸ </a:t>
-            </a:r>
-            <a:r>
-              <a:rPr sz="1800" b="0">
-                <a:solidFill>
-                  <a:srgbClr val="000000"/>
-                </a:solidFill>
-                <a:latin typeface="Fira Sans"/>
-              </a:rPr>
-              <a:t>La definición formal, con hipótesis y umbrales, es la clase 5.</a:t>
+            <a:r>
+              <a:rPr sz="1300" b="0">
+                <a:solidFill>
+                  <a:srgbClr val="333333"/>
+                </a:solidFill>
+                <a:latin typeface="Fira Sans"/>
+              </a:rPr>
+              <a:t>Nuestro 0,266: ingreso y personas explican un cuarto de la variabilidad de los vehículos entre hogares. Agregar variables nunca baja el R²; por eso no basta con mirarlo.</a:t>
             </a:r>
           </a:p>
         </p:txBody>
@@ -5588,14 +5513,14 @@
                 </a:solidFill>
                 <a:latin typeface="Fira Sans"/>
               </a:rPr>
-              <a:t>El mapa para elegir variables</a:t>
+              <a:t>El valor p: dónde vive</a:t>
             </a:r>
           </a:p>
         </p:txBody>
       </p:sp>
       <p:pic>
         <p:nvPicPr>
-          <p:cNvPr id="4" name="Picture 3" descr="c4_05_mapa_candidatas.png"/>
+          <p:cNvPr id="4" name="Picture 3" descr="c4_07_pvalue_summary.png"/>
           <p:cNvPicPr>
             <a:picLocks noChangeAspect="1"/>
           </p:cNvPicPr>
@@ -5609,8 +5534,8 @@
         </p:blipFill>
         <p:spPr>
           <a:xfrm>
-            <a:off x="2530736" y="1143000"/>
-            <a:ext cx="4082527" cy="3154680"/>
+            <a:off x="699515" y="1504912"/>
+            <a:ext cx="7744968" cy="2430856"/>
           </a:xfrm>
           <a:prstGeom prst="rect">
             <a:avLst/>
@@ -5646,7 +5571,7 @@
                 </a:solidFill>
                 <a:latin typeface="Fira Sans"/>
               </a:rPr>
-              <a:t>La fila de NumVeh es el mapa: ingreso 0,47 es el motor; las bicicletas casi no correlacionan con los vehículos (0,06) y son redundantes entre sí (0,83). Probarlas confirma: R² 0,266 a 0,267.</a:t>
+              <a:t>La pregunta que responde P&gt;|t|: si el efecto real fuera cero, ¿qué tan raro sería este coeficiente por azar? Aquí ambos dan 0,000. Ojo: con n grande hasta lo minúsculo es significativo; la clase 5 lo formaliza.</a:t>
             </a:r>
           </a:p>
         </p:txBody>
@@ -5742,114 +5667,35 @@
                 </a:solidFill>
                 <a:latin typeface="Fira Sans"/>
               </a:rPr>
-              <a:t>Una categórica entra como dummies</a:t>
-            </a:r>
-          </a:p>
-        </p:txBody>
-      </p:sp>
-      <p:sp>
-        <p:nvSpPr>
-          <p:cNvPr id="4" name="Rectangle 3"/>
-          <p:cNvSpPr/>
-          <p:nvPr/>
-        </p:nvSpPr>
-        <p:spPr>
-          <a:xfrm>
-            <a:off x="704088" y="1280160"/>
-            <a:ext cx="7744968" cy="2880360"/>
-          </a:xfrm>
-          <a:prstGeom prst="rect">
-            <a:avLst/>
-          </a:prstGeom>
-          <a:solidFill>
-            <a:srgbClr val="F0F2F5"/>
-          </a:solidFill>
-          <a:ln>
-            <a:solidFill>
-              <a:srgbClr val="D8DDE3"/>
-            </a:solidFill>
-          </a:ln>
-          <a:effectLst/>
-        </p:spPr>
-        <p:style>
-          <a:lnRef idx="1">
-            <a:schemeClr val="accent1"/>
-          </a:lnRef>
-          <a:fillRef idx="3">
-            <a:schemeClr val="accent1"/>
-          </a:fillRef>
-          <a:effectRef idx="2">
-            <a:schemeClr val="accent1"/>
-          </a:effectRef>
-          <a:fontRef idx="minor">
-            <a:schemeClr val="lt1"/>
-          </a:fontRef>
-        </p:style>
-        <p:txBody>
-          <a:bodyPr rtlCol="0" anchor="ctr" wrap="square" lIns="228600" tIns="137160"/>
-          <a:lstStyle/>
-          <a:p>
-            <a:pPr/>
-            <a:r>
-              <a:rPr sz="1500" b="0">
-                <a:solidFill>
-                  <a:srgbClr val="1D3557"/>
-                </a:solidFill>
-                <a:latin typeface="Menlo"/>
-              </a:rPr>
-              <a:t># Una columna 0/1 por modo; el auto queda de referencia</a:t>
-            </a:r>
-          </a:p>
-          <a:p>
-            <a:pPr/>
-            <a:r>
-              <a:rPr sz="1500" b="0">
-                <a:solidFill>
-                  <a:srgbClr val="1D3557"/>
-                </a:solidFill>
-                <a:latin typeface="Menlo"/>
-              </a:rPr>
-              <a:t>dummies = pd.get_dummies(viajes["ModoAgrupado"])</a:t>
-            </a:r>
-          </a:p>
-          <a:p>
-            <a:pPr/>
-            <a:r>
-              <a:rPr sz="1500" b="0">
-                <a:solidFill>
-                  <a:srgbClr val="1D3557"/>
-                </a:solidFill>
-                <a:latin typeface="Menlo"/>
-              </a:rPr>
-              <a:t>dummies = dummies.drop(columns=["Auto"])</a:t>
-            </a:r>
-          </a:p>
-          <a:p>
-            <a:pPr/>
-            <a:r>
-              <a:rPr sz="1500" b="0">
-                <a:solidFill>
-                  <a:srgbClr val="1D3557"/>
-                </a:solidFill>
-                <a:latin typeface="Menlo"/>
-              </a:rPr>
-              <a:t/>
-            </a:r>
-          </a:p>
-          <a:p>
-            <a:pPr/>
-            <a:r>
-              <a:rPr sz="1500" b="0">
-                <a:solidFill>
-                  <a:srgbClr val="1D3557"/>
-                </a:solidFill>
-                <a:latin typeface="Menlo"/>
-              </a:rPr>
-              <a:t># Se agregan a la X junto al log de la distancia</a:t>
-            </a:r>
-          </a:p>
-        </p:txBody>
-      </p:sp>
+              <a:t>El mapa para elegir variables</a:t>
+            </a:r>
+          </a:p>
+        </p:txBody>
+      </p:sp>
+      <p:pic>
+        <p:nvPicPr>
+          <p:cNvPr id="4" name="Picture 3" descr="c4_05_mapa_candidatas.png"/>
+          <p:cNvPicPr>
+            <a:picLocks noChangeAspect="1"/>
+          </p:cNvPicPr>
+          <p:nvPr/>
+        </p:nvPicPr>
+        <p:blipFill>
+          <a:blip r:embed="rId2"/>
+          <a:stretch>
+            <a:fillRect/>
+          </a:stretch>
+        </p:blipFill>
+        <p:spPr>
+          <a:xfrm>
+            <a:off x="2530736" y="1143000"/>
+            <a:ext cx="4082527" cy="3154680"/>
+          </a:xfrm>
+          <a:prstGeom prst="rect">
+            <a:avLst/>
+          </a:prstGeom>
+        </p:spPr>
+      </p:pic>
       <p:sp>
         <p:nvSpPr>
           <p:cNvPr id="5" name="TextBox 4"/>
@@ -5858,8 +5704,8 @@
         </p:nvSpPr>
         <p:spPr>
           <a:xfrm>
-            <a:off x="704088" y="4389120"/>
-            <a:ext cx="7744968" cy="1097280"/>
+            <a:off x="704088" y="4434840"/>
+            <a:ext cx="7744968" cy="457200"/>
           </a:xfrm>
           <a:prstGeom prst="rect">
             <a:avLst/>
@@ -5872,31 +5718,14 @@
           </a:bodyPr>
           <a:lstStyle/>
           <a:p>
-            <a:pPr>
-              <a:lnSpc>
-                <a:spcPct val="112000"/>
-              </a:lnSpc>
-              <a:spcAft>
-                <a:spcPts val="900"/>
-              </a:spcAft>
-            </a:pPr>
-            <a:r>
-              <a:rPr sz="1600" b="1">
-                <a:solidFill>
-                  <a:srgbClr val="E0A437"/>
-                </a:solidFill>
-                <a:latin typeface="Fira Sans"/>
-              </a:rPr>
-              <a:t>▸ </a:t>
-            </a:r>
-            <a:r>
-              <a:rPr sz="1600" b="0">
-                <a:solidFill>
-                  <a:srgbClr val="000000"/>
-                </a:solidFill>
-                <a:latin typeface="Fira Sans"/>
-              </a:rPr>
-              <a:t>Cada coeficiente se lee comparado con la referencia: qué le pasa al tiempo de un viaje por ser en ese modo y no en auto, a igual distancia.</a:t>
+            <a:r>
+              <a:rPr sz="1300" b="0">
+                <a:solidFill>
+                  <a:srgbClr val="333333"/>
+                </a:solidFill>
+                <a:latin typeface="Fira Sans"/>
+              </a:rPr>
+              <a:t>La fila de NumVeh es el mapa: ingreso 0,47 es el motor; las bicicletas casi no correlacionan con los vehículos (0,06) y son redundantes entre sí (0,83). Probarlas confirma: R² 0,266 a 0,267.</a:t>
             </a:r>
           </a:p>
         </p:txBody>
@@ -5992,35 +5821,114 @@
                 </a:solidFill>
                 <a:latin typeface="Fira Sans"/>
               </a:rPr>
-              <a:t>El resultado: distancia y modo</a:t>
-            </a:r>
-          </a:p>
-        </p:txBody>
-      </p:sp>
-      <p:pic>
-        <p:nvPicPr>
-          <p:cNvPr id="4" name="Picture 3" descr="c4_03_coef_modo.png"/>
-          <p:cNvPicPr>
-            <a:picLocks noChangeAspect="1"/>
-          </p:cNvPicPr>
-          <p:nvPr/>
-        </p:nvPicPr>
-        <p:blipFill>
-          <a:blip r:embed="rId2"/>
-          <a:stretch>
-            <a:fillRect/>
-          </a:stretch>
-        </p:blipFill>
-        <p:spPr>
-          <a:xfrm>
-            <a:off x="804842" y="1143000"/>
-            <a:ext cx="7534315" cy="3154680"/>
-          </a:xfrm>
-          <a:prstGeom prst="rect">
-            <a:avLst/>
-          </a:prstGeom>
-        </p:spPr>
-      </p:pic>
+              <a:t>Una categórica entra como dummies</a:t>
+            </a:r>
+          </a:p>
+        </p:txBody>
+      </p:sp>
+      <p:sp>
+        <p:nvSpPr>
+          <p:cNvPr id="4" name="Rectangle 3"/>
+          <p:cNvSpPr/>
+          <p:nvPr/>
+        </p:nvSpPr>
+        <p:spPr>
+          <a:xfrm>
+            <a:off x="704088" y="1280160"/>
+            <a:ext cx="7744968" cy="2880360"/>
+          </a:xfrm>
+          <a:prstGeom prst="rect">
+            <a:avLst/>
+          </a:prstGeom>
+          <a:solidFill>
+            <a:srgbClr val="F0F2F5"/>
+          </a:solidFill>
+          <a:ln>
+            <a:solidFill>
+              <a:srgbClr val="D8DDE3"/>
+            </a:solidFill>
+          </a:ln>
+          <a:effectLst/>
+        </p:spPr>
+        <p:style>
+          <a:lnRef idx="1">
+            <a:schemeClr val="accent1"/>
+          </a:lnRef>
+          <a:fillRef idx="3">
+            <a:schemeClr val="accent1"/>
+          </a:fillRef>
+          <a:effectRef idx="2">
+            <a:schemeClr val="accent1"/>
+          </a:effectRef>
+          <a:fontRef idx="minor">
+            <a:schemeClr val="lt1"/>
+          </a:fontRef>
+        </p:style>
+        <p:txBody>
+          <a:bodyPr rtlCol="0" anchor="ctr" wrap="square" lIns="228600" tIns="137160"/>
+          <a:lstStyle/>
+          <a:p>
+            <a:pPr/>
+            <a:r>
+              <a:rPr sz="1500" b="0">
+                <a:solidFill>
+                  <a:srgbClr val="1D3557"/>
+                </a:solidFill>
+                <a:latin typeface="Menlo"/>
+              </a:rPr>
+              <a:t># Una columna 0/1 por modo; el auto queda de referencia</a:t>
+            </a:r>
+          </a:p>
+          <a:p>
+            <a:pPr/>
+            <a:r>
+              <a:rPr sz="1500" b="0">
+                <a:solidFill>
+                  <a:srgbClr val="1D3557"/>
+                </a:solidFill>
+                <a:latin typeface="Menlo"/>
+              </a:rPr>
+              <a:t>dummies = pd.get_dummies(viajes["ModoAgrupado"])</a:t>
+            </a:r>
+          </a:p>
+          <a:p>
+            <a:pPr/>
+            <a:r>
+              <a:rPr sz="1500" b="0">
+                <a:solidFill>
+                  <a:srgbClr val="1D3557"/>
+                </a:solidFill>
+                <a:latin typeface="Menlo"/>
+              </a:rPr>
+              <a:t>dummies = dummies.drop(columns=["Auto"])</a:t>
+            </a:r>
+          </a:p>
+          <a:p>
+            <a:pPr/>
+            <a:r>
+              <a:rPr sz="1500" b="0">
+                <a:solidFill>
+                  <a:srgbClr val="1D3557"/>
+                </a:solidFill>
+                <a:latin typeface="Menlo"/>
+              </a:rPr>
+              <a:t/>
+            </a:r>
+          </a:p>
+          <a:p>
+            <a:pPr/>
+            <a:r>
+              <a:rPr sz="1500" b="0">
+                <a:solidFill>
+                  <a:srgbClr val="1D3557"/>
+                </a:solidFill>
+                <a:latin typeface="Menlo"/>
+              </a:rPr>
+              <a:t># Explicar la duración (log) con la distancia (log) y el modo</a:t>
+            </a:r>
+          </a:p>
+        </p:txBody>
+      </p:sp>
       <p:sp>
         <p:nvSpPr>
           <p:cNvPr id="5" name="TextBox 4"/>
@@ -6029,8 +5937,8 @@
         </p:nvSpPr>
         <p:spPr>
           <a:xfrm>
-            <a:off x="704088" y="4434840"/>
-            <a:ext cx="7744968" cy="457200"/>
+            <a:off x="704088" y="4389120"/>
+            <a:ext cx="7744968" cy="1097280"/>
           </a:xfrm>
           <a:prstGeom prst="rect">
             <a:avLst/>
@@ -6043,14 +5951,31 @@
           </a:bodyPr>
           <a:lstStyle/>
           <a:p>
-            <a:r>
-              <a:rPr sz="1300" b="0">
-                <a:solidFill>
-                  <a:srgbClr val="333333"/>
-                </a:solidFill>
-                <a:latin typeface="Fira Sans"/>
-              </a:rPr>
-              <a:t>A igual distancia, un viaje en Bip! tarda 1,87 veces lo que uno en auto; taxi y caminata quedan casi iguales al auto. El R² sube de 0,53 a 0,60.</a:t>
+            <a:pPr>
+              <a:lnSpc>
+                <a:spcPct val="112000"/>
+              </a:lnSpc>
+              <a:spcAft>
+                <a:spcPts val="900"/>
+              </a:spcAft>
+            </a:pPr>
+            <a:r>
+              <a:rPr sz="1600" b="1">
+                <a:solidFill>
+                  <a:srgbClr val="E0A437"/>
+                </a:solidFill>
+                <a:latin typeface="Fira Sans"/>
+              </a:rPr>
+              <a:t>▸ </a:t>
+            </a:r>
+            <a:r>
+              <a:rPr sz="1600" b="0">
+                <a:solidFill>
+                  <a:srgbClr val="000000"/>
+                </a:solidFill>
+                <a:latin typeface="Fira Sans"/>
+              </a:rPr>
+              <a:t>Cada coeficiente se lee comparado con la referencia: qué le pasa al tiempo de un viaje por ser en ese modo y no en auto, a igual distancia.</a:t>
             </a:r>
           </a:p>
         </p:txBody>
@@ -6146,21 +6071,45 @@
                 </a:solidFill>
                 <a:latin typeface="Fira Sans"/>
               </a:rPr>
-              <a:t>Síntesis</a:t>
-            </a:r>
-          </a:p>
-        </p:txBody>
-      </p:sp>
-      <p:sp>
-        <p:nvSpPr>
-          <p:cNvPr id="4" name="TextBox 3"/>
+              <a:t>El resultado: distancia y modo</a:t>
+            </a:r>
+          </a:p>
+        </p:txBody>
+      </p:sp>
+      <p:pic>
+        <p:nvPicPr>
+          <p:cNvPr id="4" name="Picture 3" descr="c4_03_coef_modo.png"/>
+          <p:cNvPicPr>
+            <a:picLocks noChangeAspect="1"/>
+          </p:cNvPicPr>
+          <p:nvPr/>
+        </p:nvPicPr>
+        <p:blipFill>
+          <a:blip r:embed="rId2"/>
+          <a:stretch>
+            <a:fillRect/>
+          </a:stretch>
+        </p:blipFill>
+        <p:spPr>
+          <a:xfrm>
+            <a:off x="804842" y="1143000"/>
+            <a:ext cx="7534315" cy="3154680"/>
+          </a:xfrm>
+          <a:prstGeom prst="rect">
+            <a:avLst/>
+          </a:prstGeom>
+        </p:spPr>
+      </p:pic>
+      <p:sp>
+        <p:nvSpPr>
+          <p:cNvPr id="5" name="TextBox 4"/>
           <p:cNvSpPr txBox="1"/>
           <p:nvPr/>
         </p:nvSpPr>
         <p:spPr>
           <a:xfrm>
-            <a:off x="704088" y="1353312"/>
-            <a:ext cx="7744968" cy="3300984"/>
+            <a:off x="704088" y="4434840"/>
+            <a:ext cx="7744968" cy="457200"/>
           </a:xfrm>
           <a:prstGeom prst="rect">
             <a:avLst/>
@@ -6173,143 +6122,14 @@
           </a:bodyPr>
           <a:lstStyle/>
           <a:p>
-            <a:pPr>
-              <a:lnSpc>
-                <a:spcPct val="112000"/>
-              </a:lnSpc>
-              <a:spcAft>
-                <a:spcPts val="900"/>
-              </a:spcAft>
-            </a:pPr>
-            <a:r>
-              <a:rPr sz="1800" b="1">
-                <a:solidFill>
-                  <a:srgbClr val="E0A437"/>
-                </a:solidFill>
-                <a:latin typeface="Fira Sans"/>
-              </a:rPr>
-              <a:t>▸ </a:t>
-            </a:r>
-            <a:r>
-              <a:rPr sz="1800" b="0">
-                <a:solidFill>
-                  <a:srgbClr val="000000"/>
-                </a:solidFill>
-                <a:latin typeface="Fira Sans"/>
-              </a:rPr>
-              <a:t>El impacto de filas y atípicos se mide con y sin, sobre todos los resúmenes en uso.</a:t>
-            </a:r>
-          </a:p>
-          <a:p>
-            <a:pPr>
-              <a:lnSpc>
-                <a:spcPct val="112000"/>
-              </a:lnSpc>
-              <a:spcAft>
-                <a:spcPts val="900"/>
-              </a:spcAft>
-            </a:pPr>
-            <a:r>
-              <a:rPr sz="1800" b="1">
-                <a:solidFill>
-                  <a:srgbClr val="E0A437"/>
-                </a:solidFill>
-                <a:latin typeface="Fira Sans"/>
-              </a:rPr>
-              <a:t>▸ </a:t>
-            </a:r>
-            <a:r>
-              <a:rPr sz="1800" b="0">
-                <a:solidFill>
-                  <a:srgbClr val="000000"/>
-                </a:solidFill>
-                <a:latin typeface="Fira Sans"/>
-              </a:rPr>
-              <a:t>Cuando la conclusión es sobre la ciudad, se pondera: WLS.</a:t>
-            </a:r>
-          </a:p>
-          <a:p>
-            <a:pPr>
-              <a:lnSpc>
-                <a:spcPct val="112000"/>
-              </a:lnSpc>
-              <a:spcAft>
-                <a:spcPts val="900"/>
-              </a:spcAft>
-            </a:pPr>
-            <a:r>
-              <a:rPr sz="1800" b="1">
-                <a:solidFill>
-                  <a:srgbClr val="E0A437"/>
-                </a:solidFill>
-                <a:latin typeface="Fira Sans"/>
-              </a:rPr>
-              <a:t>▸ </a:t>
-            </a:r>
-            <a:r>
-              <a:rPr sz="1800" b="0">
-                <a:solidFill>
-                  <a:srgbClr val="000000"/>
-                </a:solidFill>
-                <a:latin typeface="Fira Sans"/>
-              </a:rPr>
-              <a:t>Muchos puntos: alpha o hexbin. Colas largas: log.</a:t>
-            </a:r>
-          </a:p>
-          <a:p>
-            <a:pPr>
-              <a:lnSpc>
-                <a:spcPct val="112000"/>
-              </a:lnSpc>
-              <a:spcAft>
-                <a:spcPts val="900"/>
-              </a:spcAft>
-            </a:pPr>
-            <a:r>
-              <a:rPr sz="1800" b="1">
-                <a:solidFill>
-                  <a:srgbClr val="E0A437"/>
-                </a:solidFill>
-                <a:latin typeface="Fira Sans"/>
-              </a:rPr>
-              <a:t>▸ </a:t>
-            </a:r>
-            <a:r>
-              <a:rPr sz="1800" b="0">
-                <a:solidFill>
-                  <a:srgbClr val="000000"/>
-                </a:solidFill>
-                <a:latin typeface="Fira Sans"/>
-              </a:rPr>
-              <a:t>La múltiple aísla el efecto de cada variable (categóricas como dummies); R² dice cuánto explica y el valor p si un coeficiente se distingue del azar.</a:t>
-            </a:r>
-          </a:p>
-          <a:p>
-            <a:pPr>
-              <a:lnSpc>
-                <a:spcPct val="112000"/>
-              </a:lnSpc>
-              <a:spcAft>
-                <a:spcPts val="900"/>
-              </a:spcAft>
-            </a:pPr>
-            <a:r>
-              <a:rPr sz="1800" b="1">
-                <a:solidFill>
-                  <a:srgbClr val="E0A437"/>
-                </a:solidFill>
-                <a:latin typeface="Fira Sans"/>
-              </a:rPr>
-              <a:t>▸ </a:t>
-            </a:r>
-            <a:r>
-              <a:rPr sz="1800" b="1">
-                <a:solidFill>
-                  <a:srgbClr val="1D3557"/>
-                </a:solidFill>
-                <a:latin typeface="Fira Sans"/>
-              </a:rPr>
-              <a:t>El primer EDA del proyecto usa exactamente estas herramientas (entrega: lunes 15).</a:t>
+            <a:r>
+              <a:rPr sz="1300" b="0">
+                <a:solidFill>
+                  <a:srgbClr val="333333"/>
+                </a:solidFill>
+                <a:latin typeface="Fira Sans"/>
+              </a:rPr>
+              <a:t>A igual distancia, un viaje en Bip! tarda 1,87 veces lo que uno en auto; taxi y caminata quedan casi iguales al auto. El R² sube de 0,53 a 0,60.</a:t>
             </a:r>
           </a:p>
         </p:txBody>
@@ -6347,7 +6167,7 @@
             <a:avLst/>
           </a:prstGeom>
           <a:solidFill>
-            <a:srgbClr val="1D3557"/>
+            <a:srgbClr val="FAFBFC"/>
           </a:solidFill>
           <a:ln>
             <a:noFill/>
@@ -6384,8 +6204,8 @@
         </p:nvSpPr>
         <p:spPr>
           <a:xfrm>
-            <a:off x="603504" y="1847088"/>
-            <a:ext cx="7946136" cy="1399032"/>
+            <a:off x="402336" y="301752"/>
+            <a:ext cx="8348472" cy="795528"/>
           </a:xfrm>
           <a:prstGeom prst="rect">
             <a:avLst/>
@@ -6399,24 +6219,71 @@
           <a:lstStyle/>
           <a:p>
             <a:r>
-              <a:rPr sz="3400" b="1">
-                <a:solidFill>
-                  <a:srgbClr val="FFFFFF"/>
-                </a:solidFill>
-                <a:latin typeface="Fira Sans"/>
-              </a:rPr>
-              <a:t>Recreo</a:t>
-            </a:r>
-          </a:p>
-          <a:p>
-            <a:r>
-              <a:rPr sz="1800" b="0">
-                <a:solidFill>
-                  <a:srgbClr val="E0A437"/>
-                </a:solidFill>
-                <a:latin typeface="Fira Sans"/>
-              </a:rPr>
-              <a:t>10 minutos · al volver: las presentaciones de ideas</a:t>
+              <a:rPr sz="2800" b="1">
+                <a:solidFill>
+                  <a:srgbClr val="0F0F0F"/>
+                </a:solidFill>
+                <a:latin typeface="Fira Sans"/>
+              </a:rPr>
+              <a:t>La ecuación de la duración, leída</a:t>
+            </a:r>
+          </a:p>
+        </p:txBody>
+      </p:sp>
+      <p:pic>
+        <p:nvPicPr>
+          <p:cNvPr id="4" name="Picture 3" descr="c4_09_ecuacion_duracion.png"/>
+          <p:cNvPicPr>
+            <a:picLocks noChangeAspect="1"/>
+          </p:cNvPicPr>
+          <p:nvPr/>
+        </p:nvPicPr>
+        <p:blipFill>
+          <a:blip r:embed="rId2"/>
+          <a:stretch>
+            <a:fillRect/>
+          </a:stretch>
+        </p:blipFill>
+        <p:spPr>
+          <a:xfrm>
+            <a:off x="699515" y="1320746"/>
+            <a:ext cx="7744968" cy="2799186"/>
+          </a:xfrm>
+          <a:prstGeom prst="rect">
+            <a:avLst/>
+          </a:prstGeom>
+        </p:spPr>
+      </p:pic>
+      <p:sp>
+        <p:nvSpPr>
+          <p:cNvPr id="5" name="TextBox 4"/>
+          <p:cNvSpPr txBox="1"/>
+          <p:nvPr/>
+        </p:nvSpPr>
+        <p:spPr>
+          <a:xfrm>
+            <a:off x="704088" y="4434840"/>
+            <a:ext cx="7744968" cy="457200"/>
+          </a:xfrm>
+          <a:prstGeom prst="rect">
+            <a:avLst/>
+          </a:prstGeom>
+          <a:noFill/>
+        </p:spPr>
+        <p:txBody>
+          <a:bodyPr wrap="square">
+            <a:spAutoFit/>
+          </a:bodyPr>
+          <a:lstStyle/>
+          <a:p>
+            <a:r>
+              <a:rPr sz="1300" b="0">
+                <a:solidFill>
+                  <a:srgbClr val="333333"/>
+                </a:solidFill>
+                <a:latin typeface="Fira Sans"/>
+              </a:rPr>
+              <a:t>La misma tabla de coeficientes, escrita como ecuación: en escala log los efectos multiplican en vez de sumar.</a:t>
             </a:r>
           </a:p>
         </p:txBody>
@@ -6454,7 +6321,7 @@
             <a:avLst/>
           </a:prstGeom>
           <a:solidFill>
-            <a:srgbClr val="1D3557"/>
+            <a:srgbClr val="FAFBFC"/>
           </a:solidFill>
           <a:ln>
             <a:noFill/>
@@ -6491,8 +6358,8 @@
         </p:nvSpPr>
         <p:spPr>
           <a:xfrm>
-            <a:off x="603504" y="1847088"/>
-            <a:ext cx="7946136" cy="1399032"/>
+            <a:off x="402336" y="301752"/>
+            <a:ext cx="8348472" cy="795528"/>
           </a:xfrm>
           <a:prstGeom prst="rect">
             <a:avLst/>
@@ -6506,24 +6373,176 @@
           <a:lstStyle/>
           <a:p>
             <a:r>
-              <a:rPr sz="3400" b="1">
-                <a:solidFill>
-                  <a:srgbClr val="FFFFFF"/>
-                </a:solidFill>
-                <a:latin typeface="Fira Sans"/>
-              </a:rPr>
-              <a:t>Presentaciones de ideas</a:t>
-            </a:r>
-          </a:p>
-          <a:p>
+              <a:rPr sz="2800" b="1">
+                <a:solidFill>
+                  <a:srgbClr val="0F0F0F"/>
+                </a:solidFill>
+                <a:latin typeface="Fira Sans"/>
+              </a:rPr>
+              <a:t>Síntesis</a:t>
+            </a:r>
+          </a:p>
+        </p:txBody>
+      </p:sp>
+      <p:sp>
+        <p:nvSpPr>
+          <p:cNvPr id="4" name="TextBox 3"/>
+          <p:cNvSpPr txBox="1"/>
+          <p:nvPr/>
+        </p:nvSpPr>
+        <p:spPr>
+          <a:xfrm>
+            <a:off x="704088" y="1353312"/>
+            <a:ext cx="7744968" cy="3300984"/>
+          </a:xfrm>
+          <a:prstGeom prst="rect">
+            <a:avLst/>
+          </a:prstGeom>
+          <a:noFill/>
+        </p:spPr>
+        <p:txBody>
+          <a:bodyPr wrap="square">
+            <a:spAutoFit/>
+          </a:bodyPr>
+          <a:lstStyle/>
+          <a:p>
+            <a:pPr>
+              <a:lnSpc>
+                <a:spcPct val="112000"/>
+              </a:lnSpc>
+              <a:spcAft>
+                <a:spcPts val="900"/>
+              </a:spcAft>
+            </a:pPr>
+            <a:r>
+              <a:rPr sz="1800" b="1">
+                <a:solidFill>
+                  <a:srgbClr val="E0A437"/>
+                </a:solidFill>
+                <a:latin typeface="Fira Sans"/>
+              </a:rPr>
+              <a:t>▸ </a:t>
+            </a:r>
             <a:r>
               <a:rPr sz="1800" b="0">
                 <a:solidFill>
+                  <a:srgbClr val="000000"/>
+                </a:solidFill>
+                <a:latin typeface="Fira Sans"/>
+              </a:rPr>
+              <a:t>El impacto de filas y atípicos se mide con y sin, sobre todos los resúmenes en uso.</a:t>
+            </a:r>
+          </a:p>
+          <a:p>
+            <a:pPr>
+              <a:lnSpc>
+                <a:spcPct val="112000"/>
+              </a:lnSpc>
+              <a:spcAft>
+                <a:spcPts val="900"/>
+              </a:spcAft>
+            </a:pPr>
+            <a:r>
+              <a:rPr sz="1800" b="1">
+                <a:solidFill>
                   <a:srgbClr val="E0A437"/>
                 </a:solidFill>
                 <a:latin typeface="Fira Sans"/>
               </a:rPr>
-              <a:t>De 5 a 7 minutos por equipo, y preguntas de todos</a:t>
+              <a:t>▸ </a:t>
+            </a:r>
+            <a:r>
+              <a:rPr sz="1800" b="0">
+                <a:solidFill>
+                  <a:srgbClr val="000000"/>
+                </a:solidFill>
+                <a:latin typeface="Fira Sans"/>
+              </a:rPr>
+              <a:t>Cuando la conclusión es sobre la ciudad, se pondera: WLS.</a:t>
+            </a:r>
+          </a:p>
+          <a:p>
+            <a:pPr>
+              <a:lnSpc>
+                <a:spcPct val="112000"/>
+              </a:lnSpc>
+              <a:spcAft>
+                <a:spcPts val="900"/>
+              </a:spcAft>
+            </a:pPr>
+            <a:r>
+              <a:rPr sz="1800" b="1">
+                <a:solidFill>
+                  <a:srgbClr val="E0A437"/>
+                </a:solidFill>
+                <a:latin typeface="Fira Sans"/>
+              </a:rPr>
+              <a:t>▸ </a:t>
+            </a:r>
+            <a:r>
+              <a:rPr sz="1800" b="0">
+                <a:solidFill>
+                  <a:srgbClr val="000000"/>
+                </a:solidFill>
+                <a:latin typeface="Fira Sans"/>
+              </a:rPr>
+              <a:t>Muchos puntos: alpha o hexbin. Colas largas: log.</a:t>
+            </a:r>
+          </a:p>
+          <a:p>
+            <a:pPr>
+              <a:lnSpc>
+                <a:spcPct val="112000"/>
+              </a:lnSpc>
+              <a:spcAft>
+                <a:spcPts val="900"/>
+              </a:spcAft>
+            </a:pPr>
+            <a:r>
+              <a:rPr sz="1800" b="1">
+                <a:solidFill>
+                  <a:srgbClr val="E0A437"/>
+                </a:solidFill>
+                <a:latin typeface="Fira Sans"/>
+              </a:rPr>
+              <a:t>▸ </a:t>
+            </a:r>
+            <a:r>
+              <a:rPr sz="1800" b="0">
+                <a:solidFill>
+                  <a:srgbClr val="000000"/>
+                </a:solidFill>
+                <a:latin typeface="Fira Sans"/>
+              </a:rPr>
+              <a:t>La múltiple aísla el efecto de cada variable (categóricas como dummies); R² dice cuánto explica y el valor p si un coeficiente se distingue del azar.</a:t>
+            </a:r>
+          </a:p>
+          <a:p>
+            <a:pPr>
+              <a:lnSpc>
+                <a:spcPct val="112000"/>
+              </a:lnSpc>
+              <a:spcAft>
+                <a:spcPts val="900"/>
+              </a:spcAft>
+            </a:pPr>
+            <a:r>
+              <a:rPr sz="1800" b="1">
+                <a:solidFill>
+                  <a:srgbClr val="E0A437"/>
+                </a:solidFill>
+                <a:latin typeface="Fira Sans"/>
+              </a:rPr>
+              <a:t>▸ </a:t>
+            </a:r>
+            <a:r>
+              <a:rPr sz="1800" b="1">
+                <a:solidFill>
+                  <a:srgbClr val="1D3557"/>
+                </a:solidFill>
+                <a:latin typeface="Fira Sans"/>
+              </a:rPr>
+              <a:t>El primer EDA del proyecto usa exactamente estas herramientas (entrega: lunes 15).</a:t>
             </a:r>
           </a:p>
         </p:txBody>
@@ -6561,7 +6580,7 @@
             <a:avLst/>
           </a:prstGeom>
           <a:solidFill>
-            <a:srgbClr val="FAFBFC"/>
+            <a:srgbClr val="1D3557"/>
           </a:solidFill>
           <a:ln>
             <a:noFill/>
@@ -6598,8 +6617,8 @@
         </p:nvSpPr>
         <p:spPr>
           <a:xfrm>
-            <a:off x="402336" y="301752"/>
-            <a:ext cx="8348472" cy="795528"/>
+            <a:off x="603504" y="1847088"/>
+            <a:ext cx="7946136" cy="1399032"/>
           </a:xfrm>
           <a:prstGeom prst="rect">
             <a:avLst/>
@@ -6613,120 +6632,24 @@
           <a:lstStyle/>
           <a:p>
             <a:r>
-              <a:rPr sz="2800" b="1">
-                <a:solidFill>
-                  <a:srgbClr val="0F0F0F"/>
-                </a:solidFill>
-                <a:latin typeface="Fira Sans"/>
-              </a:rPr>
-              <a:t>El formato</a:t>
-            </a:r>
-          </a:p>
-        </p:txBody>
-      </p:sp>
-      <p:sp>
-        <p:nvSpPr>
-          <p:cNvPr id="4" name="TextBox 3"/>
-          <p:cNvSpPr txBox="1"/>
-          <p:nvPr/>
-        </p:nvSpPr>
-        <p:spPr>
-          <a:xfrm>
-            <a:off x="704088" y="1353312"/>
-            <a:ext cx="7744968" cy="3300984"/>
-          </a:xfrm>
-          <a:prstGeom prst="rect">
-            <a:avLst/>
-          </a:prstGeom>
-          <a:noFill/>
-        </p:spPr>
-        <p:txBody>
-          <a:bodyPr wrap="square">
-            <a:spAutoFit/>
-          </a:bodyPr>
-          <a:lstStyle/>
-          <a:p>
-            <a:pPr>
-              <a:lnSpc>
-                <a:spcPct val="112000"/>
-              </a:lnSpc>
-              <a:spcAft>
-                <a:spcPts val="900"/>
-              </a:spcAft>
-            </a:pPr>
-            <a:r>
-              <a:rPr sz="1800" b="1">
+              <a:rPr sz="3400" b="1">
+                <a:solidFill>
+                  <a:srgbClr val="FFFFFF"/>
+                </a:solidFill>
+                <a:latin typeface="Fira Sans"/>
+              </a:rPr>
+              <a:t>Recreo</a:t>
+            </a:r>
+          </a:p>
+          <a:p>
+            <a:r>
+              <a:rPr sz="1800" b="0">
                 <a:solidFill>
                   <a:srgbClr val="E0A437"/>
                 </a:solidFill>
                 <a:latin typeface="Fira Sans"/>
               </a:rPr>
-              <a:t>▸ </a:t>
-            </a:r>
-            <a:r>
-              <a:rPr sz="1800" b="1">
-                <a:solidFill>
-                  <a:srgbClr val="1D3557"/>
-                </a:solidFill>
-                <a:latin typeface="Fira Sans"/>
-              </a:rPr>
-              <a:t>Esta instancia no lleva nota: es para recibir retroalimentación temprano, cuando corregir cuesta poco.</a:t>
-            </a:r>
-          </a:p>
-          <a:p>
-            <a:pPr>
-              <a:lnSpc>
-                <a:spcPct val="112000"/>
-              </a:lnSpc>
-              <a:spcAft>
-                <a:spcPts val="900"/>
-              </a:spcAft>
-            </a:pPr>
-            <a:r>
-              <a:rPr sz="1800" b="1">
-                <a:solidFill>
-                  <a:srgbClr val="E0A437"/>
-                </a:solidFill>
-                <a:latin typeface="Fira Sans"/>
-              </a:rPr>
-              <a:t>▸ </a:t>
-            </a:r>
-            <a:r>
-              <a:rPr sz="1800" b="0">
-                <a:solidFill>
-                  <a:srgbClr val="000000"/>
-                </a:solidFill>
-                <a:latin typeface="Fira Sans"/>
-              </a:rPr>
-              <a:t>Después de cada equipo, preguntas y comentarios del curso.</a:t>
-            </a:r>
-          </a:p>
-          <a:p>
-            <a:pPr>
-              <a:lnSpc>
-                <a:spcPct val="112000"/>
-              </a:lnSpc>
-              <a:spcAft>
-                <a:spcPts val="900"/>
-              </a:spcAft>
-            </a:pPr>
-            <a:r>
-              <a:rPr sz="1800" b="1">
-                <a:solidFill>
-                  <a:srgbClr val="E0A437"/>
-                </a:solidFill>
-                <a:latin typeface="Fira Sans"/>
-              </a:rPr>
-              <a:t>▸ </a:t>
-            </a:r>
-            <a:r>
-              <a:rPr sz="1800" b="0">
-                <a:solidFill>
-                  <a:srgbClr val="000000"/>
-                </a:solidFill>
-                <a:latin typeface="Fira Sans"/>
-              </a:rPr>
-              <a:t>La formulación se entrega el lunes 7: lo que escuchen hoy es insumo directo para ese documento.</a:t>
+              <a:t>10 minutos · al volver: las presentaciones de ideas</a:t>
             </a:r>
           </a:p>
         </p:txBody>
@@ -6764,7 +6687,7 @@
             <a:avLst/>
           </a:prstGeom>
           <a:solidFill>
-            <a:srgbClr val="FAFBFC"/>
+            <a:srgbClr val="1D3557"/>
           </a:solidFill>
           <a:ln>
             <a:noFill/>
@@ -6801,8 +6724,8 @@
         </p:nvSpPr>
         <p:spPr>
           <a:xfrm>
-            <a:off x="402336" y="301752"/>
-            <a:ext cx="8348472" cy="795528"/>
+            <a:off x="603504" y="1847088"/>
+            <a:ext cx="7946136" cy="1399032"/>
           </a:xfrm>
           <a:prstGeom prst="rect">
             <a:avLst/>
@@ -6816,120 +6739,24 @@
           <a:lstStyle/>
           <a:p>
             <a:r>
-              <a:rPr sz="2800" b="1">
-                <a:solidFill>
-                  <a:srgbClr val="0F0F0F"/>
-                </a:solidFill>
-                <a:latin typeface="Fira Sans"/>
-              </a:rPr>
-              <a:t>Próxima clase</a:t>
-            </a:r>
-          </a:p>
-        </p:txBody>
-      </p:sp>
-      <p:sp>
-        <p:nvSpPr>
-          <p:cNvPr id="4" name="TextBox 3"/>
-          <p:cNvSpPr txBox="1"/>
-          <p:nvPr/>
-        </p:nvSpPr>
-        <p:spPr>
-          <a:xfrm>
-            <a:off x="704088" y="1353312"/>
-            <a:ext cx="7744968" cy="3300984"/>
-          </a:xfrm>
-          <a:prstGeom prst="rect">
-            <a:avLst/>
-          </a:prstGeom>
-          <a:noFill/>
-        </p:spPr>
-        <p:txBody>
-          <a:bodyPr wrap="square">
-            <a:spAutoFit/>
-          </a:bodyPr>
-          <a:lstStyle/>
-          <a:p>
-            <a:pPr>
-              <a:lnSpc>
-                <a:spcPct val="112000"/>
-              </a:lnSpc>
-              <a:spcAft>
-                <a:spcPts val="900"/>
-              </a:spcAft>
-            </a:pPr>
-            <a:r>
-              <a:rPr sz="1800" b="1">
+              <a:rPr sz="3400" b="1">
+                <a:solidFill>
+                  <a:srgbClr val="FFFFFF"/>
+                </a:solidFill>
+                <a:latin typeface="Fira Sans"/>
+              </a:rPr>
+              <a:t>Presentaciones de ideas</a:t>
+            </a:r>
+          </a:p>
+          <a:p>
+            <a:r>
+              <a:rPr sz="1800" b="0">
                 <a:solidFill>
                   <a:srgbClr val="E0A437"/>
                 </a:solidFill>
                 <a:latin typeface="Fira Sans"/>
               </a:rPr>
-              <a:t>▸ </a:t>
-            </a:r>
-            <a:r>
-              <a:rPr sz="1800" b="0">
-                <a:solidFill>
-                  <a:srgbClr val="000000"/>
-                </a:solidFill>
-                <a:latin typeface="Fira Sans"/>
-              </a:rPr>
-              <a:t>Martes 8: fundamentos de probabilidad y nociones de inferencia estadística.</a:t>
-            </a:r>
-          </a:p>
-          <a:p>
-            <a:pPr>
-              <a:lnSpc>
-                <a:spcPct val="112000"/>
-              </a:lnSpc>
-              <a:spcAft>
-                <a:spcPts val="900"/>
-              </a:spcAft>
-            </a:pPr>
-            <a:r>
-              <a:rPr sz="1800" b="1">
-                <a:solidFill>
-                  <a:srgbClr val="E0A437"/>
-                </a:solidFill>
-                <a:latin typeface="Fira Sans"/>
-              </a:rPr>
-              <a:t>▸ </a:t>
-            </a:r>
-            <a:r>
-              <a:rPr sz="1800" b="0">
-                <a:solidFill>
-                  <a:srgbClr val="000000"/>
-                </a:solidFill>
-                <a:latin typeface="Fira Sans"/>
-              </a:rPr>
-              <a:t>La pregunta pendiente desde la clase 3: ¿qué significa el valor p que statsmodels ya nos mostró?</a:t>
-            </a:r>
-          </a:p>
-          <a:p>
-            <a:pPr>
-              <a:lnSpc>
-                <a:spcPct val="112000"/>
-              </a:lnSpc>
-              <a:spcAft>
-                <a:spcPts val="900"/>
-              </a:spcAft>
-            </a:pPr>
-            <a:r>
-              <a:rPr sz="1800" b="1">
-                <a:solidFill>
-                  <a:srgbClr val="E0A437"/>
-                </a:solidFill>
-                <a:latin typeface="Fira Sans"/>
-              </a:rPr>
-              <a:t>▸ </a:t>
-            </a:r>
-            <a:r>
-              <a:rPr sz="1800" b="1">
-                <a:solidFill>
-                  <a:srgbClr val="1D3557"/>
-                </a:solidFill>
-                <a:latin typeface="Fira Sans"/>
-              </a:rPr>
-              <a:t>La formulación se entrega el lunes 7; el primer análisis exploratorio, el lunes 15.</a:t>
+              <a:t>De 5 a 7 minutos por equipo, y preguntas de todos</a:t>
             </a:r>
           </a:p>
         </p:txBody>
@@ -7025,7 +6852,7 @@
                 </a:solidFill>
                 <a:latin typeface="Fira Sans"/>
               </a:rPr>
-              <a:t>Referencias</a:t>
+              <a:t>El formato</a:t>
             </a:r>
           </a:p>
         </p:txBody>
@@ -7038,8 +6865,8 @@
         </p:nvSpPr>
         <p:spPr>
           <a:xfrm>
-            <a:off x="704088" y="1234440"/>
-            <a:ext cx="7744968" cy="3566160"/>
+            <a:off x="704088" y="1353312"/>
+            <a:ext cx="7744968" cy="3300984"/>
           </a:xfrm>
           <a:prstGeom prst="rect">
             <a:avLst/>
@@ -7054,77 +6881,57 @@
           <a:p>
             <a:pPr>
               <a:lnSpc>
-                <a:spcPct val="115000"/>
+                <a:spcPct val="112000"/>
               </a:lnSpc>
               <a:spcAft>
-                <a:spcPts val="700"/>
+                <a:spcPts val="900"/>
               </a:spcAft>
             </a:pPr>
             <a:r>
-              <a:rPr sz="1300" b="0">
-                <a:solidFill>
-                  <a:srgbClr val="333333"/>
-                </a:solidFill>
-                <a:latin typeface="Fira Sans"/>
-              </a:rPr>
-              <a:t>Tukey, J. W. (1977). Exploratory Data Analysis. Addison-Wesley.</a:t>
+              <a:rPr sz="1800" b="1">
+                <a:solidFill>
+                  <a:srgbClr val="E0A437"/>
+                </a:solidFill>
+                <a:latin typeface="Fira Sans"/>
+              </a:rPr>
+              <a:t>▸ </a:t>
+            </a:r>
+            <a:r>
+              <a:rPr sz="1800" b="1">
+                <a:solidFill>
+                  <a:srgbClr val="1D3557"/>
+                </a:solidFill>
+                <a:latin typeface="Fira Sans"/>
+              </a:rPr>
+              <a:t>Esta instancia no lleva nota: es para recibir retroalimentación temprano, cuando corregir cuesta poco.</a:t>
             </a:r>
           </a:p>
           <a:p>
             <a:pPr>
               <a:lnSpc>
-                <a:spcPct val="115000"/>
+                <a:spcPct val="112000"/>
               </a:lnSpc>
               <a:spcAft>
-                <a:spcPts val="700"/>
+                <a:spcPts val="900"/>
               </a:spcAft>
             </a:pPr>
             <a:r>
-              <a:rPr sz="1300" b="0">
-                <a:solidFill>
-                  <a:srgbClr val="333333"/>
-                </a:solidFill>
-                <a:latin typeface="Fira Sans"/>
-              </a:rPr>
-              <a:t>Seabold, S. y Perktold, J. (2010). statsmodels: Econometric and statistical modeling with Python. Proceedings of the 9th Python in Science Conference.</a:t>
-            </a:r>
-          </a:p>
-          <a:p>
-            <a:pPr>
-              <a:lnSpc>
-                <a:spcPct val="115000"/>
-              </a:lnSpc>
-              <a:spcAft>
-                <a:spcPts val="700"/>
-              </a:spcAft>
-            </a:pPr>
-            <a:r>
-              <a:rPr sz="1300" b="0">
-                <a:solidFill>
-                  <a:srgbClr val="333333"/>
-                </a:solidFill>
-                <a:latin typeface="Fira Sans"/>
-              </a:rPr>
-              <a:t>VanderPlas, J. (2016). Python Data Science Handbook. O'Reilly. Capítulo 5 (regresión lineal).</a:t>
-            </a:r>
-          </a:p>
-          <a:p>
-            <a:pPr>
-              <a:lnSpc>
-                <a:spcPct val="115000"/>
-              </a:lnSpc>
-              <a:spcAft>
-                <a:spcPts val="700"/>
-              </a:spcAft>
-            </a:pPr>
-            <a:r>
-              <a:rPr sz="1300" b="0">
-                <a:solidFill>
-                  <a:srgbClr val="333333"/>
-                </a:solidFill>
-                <a:latin typeface="Fira Sans"/>
-              </a:rPr>
-              <a:t>Datos: Encuesta Origen Destino Santiago 2012 (Sectra).</a:t>
+              <a:rPr sz="1800" b="1">
+                <a:solidFill>
+                  <a:srgbClr val="E0A437"/>
+                </a:solidFill>
+                <a:latin typeface="Fira Sans"/>
+              </a:rPr>
+              <a:t>▸ </a:t>
+            </a:r>
+            <a:r>
+              <a:rPr sz="1800" b="0">
+                <a:solidFill>
+                  <a:srgbClr val="000000"/>
+                </a:solidFill>
+                <a:latin typeface="Fira Sans"/>
+              </a:rPr>
+              <a:t>Después de cada equipo, preguntas y comentarios del curso.</a:t>
             </a:r>
           </a:p>
         </p:txBody>
@@ -7328,6 +7135,404 @@
                 <a:latin typeface="Fira Sans"/>
               </a:rPr>
               <a:t>El enunciado y la rúbrica del primer análisis exploratorio ya están publicados en el repositorio.</a:t>
+            </a:r>
+          </a:p>
+        </p:txBody>
+      </p:sp>
+    </p:spTree>
+  </p:cSld>
+  <p:clrMapOvr>
+    <a:masterClrMapping/>
+  </p:clrMapOvr>
+</p:sld>
+</file>
+
+<file path=ppt/slides/slide30.xml><?xml version="1.0" encoding="utf-8"?>
+<p:sld xmlns:a="http://schemas.openxmlformats.org/drawingml/2006/main" xmlns:p="http://schemas.openxmlformats.org/presentationml/2006/main" xmlns:r="http://schemas.openxmlformats.org/officeDocument/2006/relationships">
+  <p:cSld>
+    <p:spTree>
+      <p:nvGrpSpPr>
+        <p:cNvPr id="1" name=""/>
+        <p:cNvGrpSpPr/>
+        <p:nvPr/>
+      </p:nvGrpSpPr>
+      <p:grpSpPr/>
+      <p:sp>
+        <p:nvSpPr>
+          <p:cNvPr id="2" name="Rectangle 1"/>
+          <p:cNvSpPr/>
+          <p:nvPr/>
+        </p:nvSpPr>
+        <p:spPr>
+          <a:xfrm>
+            <a:off x="0" y="0"/>
+            <a:ext cx="9144000" cy="5138928"/>
+          </a:xfrm>
+          <a:prstGeom prst="rect">
+            <a:avLst/>
+          </a:prstGeom>
+          <a:solidFill>
+            <a:srgbClr val="FAFBFC"/>
+          </a:solidFill>
+          <a:ln>
+            <a:noFill/>
+          </a:ln>
+          <a:effectLst/>
+        </p:spPr>
+        <p:style>
+          <a:lnRef idx="1">
+            <a:schemeClr val="accent1"/>
+          </a:lnRef>
+          <a:fillRef idx="3">
+            <a:schemeClr val="accent1"/>
+          </a:fillRef>
+          <a:effectRef idx="2">
+            <a:schemeClr val="accent1"/>
+          </a:effectRef>
+          <a:fontRef idx="minor">
+            <a:schemeClr val="lt1"/>
+          </a:fontRef>
+        </p:style>
+        <p:txBody>
+          <a:bodyPr rtlCol="0" anchor="ctr"/>
+          <a:lstStyle/>
+          <a:p>
+            <a:pPr algn="ctr"/>
+          </a:p>
+        </p:txBody>
+      </p:sp>
+      <p:sp>
+        <p:nvSpPr>
+          <p:cNvPr id="3" name="TextBox 2"/>
+          <p:cNvSpPr txBox="1"/>
+          <p:nvPr/>
+        </p:nvSpPr>
+        <p:spPr>
+          <a:xfrm>
+            <a:off x="402336" y="301752"/>
+            <a:ext cx="8348472" cy="795528"/>
+          </a:xfrm>
+          <a:prstGeom prst="rect">
+            <a:avLst/>
+          </a:prstGeom>
+          <a:noFill/>
+        </p:spPr>
+        <p:txBody>
+          <a:bodyPr wrap="square">
+            <a:spAutoFit/>
+          </a:bodyPr>
+          <a:lstStyle/>
+          <a:p>
+            <a:r>
+              <a:rPr sz="2800" b="1">
+                <a:solidFill>
+                  <a:srgbClr val="0F0F0F"/>
+                </a:solidFill>
+                <a:latin typeface="Fira Sans"/>
+              </a:rPr>
+              <a:t>Próxima clase</a:t>
+            </a:r>
+          </a:p>
+        </p:txBody>
+      </p:sp>
+      <p:sp>
+        <p:nvSpPr>
+          <p:cNvPr id="4" name="TextBox 3"/>
+          <p:cNvSpPr txBox="1"/>
+          <p:nvPr/>
+        </p:nvSpPr>
+        <p:spPr>
+          <a:xfrm>
+            <a:off x="704088" y="1353312"/>
+            <a:ext cx="7744968" cy="3300984"/>
+          </a:xfrm>
+          <a:prstGeom prst="rect">
+            <a:avLst/>
+          </a:prstGeom>
+          <a:noFill/>
+        </p:spPr>
+        <p:txBody>
+          <a:bodyPr wrap="square">
+            <a:spAutoFit/>
+          </a:bodyPr>
+          <a:lstStyle/>
+          <a:p>
+            <a:pPr>
+              <a:lnSpc>
+                <a:spcPct val="112000"/>
+              </a:lnSpc>
+              <a:spcAft>
+                <a:spcPts val="900"/>
+              </a:spcAft>
+            </a:pPr>
+            <a:r>
+              <a:rPr sz="1800" b="1">
+                <a:solidFill>
+                  <a:srgbClr val="E0A437"/>
+                </a:solidFill>
+                <a:latin typeface="Fira Sans"/>
+              </a:rPr>
+              <a:t>▸ </a:t>
+            </a:r>
+            <a:r>
+              <a:rPr sz="1800" b="0">
+                <a:solidFill>
+                  <a:srgbClr val="000000"/>
+                </a:solidFill>
+                <a:latin typeface="Fira Sans"/>
+              </a:rPr>
+              <a:t>Martes 8: fundamentos de probabilidad y nociones de inferencia estadística.</a:t>
+            </a:r>
+          </a:p>
+          <a:p>
+            <a:pPr>
+              <a:lnSpc>
+                <a:spcPct val="112000"/>
+              </a:lnSpc>
+              <a:spcAft>
+                <a:spcPts val="900"/>
+              </a:spcAft>
+            </a:pPr>
+            <a:r>
+              <a:rPr sz="1800" b="1">
+                <a:solidFill>
+                  <a:srgbClr val="E0A437"/>
+                </a:solidFill>
+                <a:latin typeface="Fira Sans"/>
+              </a:rPr>
+              <a:t>▸ </a:t>
+            </a:r>
+            <a:r>
+              <a:rPr sz="1800" b="0">
+                <a:solidFill>
+                  <a:srgbClr val="000000"/>
+                </a:solidFill>
+                <a:latin typeface="Fira Sans"/>
+              </a:rPr>
+              <a:t>La pregunta pendiente desde la clase 3: ¿qué significa el valor p que statsmodels ya nos mostró?</a:t>
+            </a:r>
+          </a:p>
+          <a:p>
+            <a:pPr>
+              <a:lnSpc>
+                <a:spcPct val="112000"/>
+              </a:lnSpc>
+              <a:spcAft>
+                <a:spcPts val="900"/>
+              </a:spcAft>
+            </a:pPr>
+            <a:r>
+              <a:rPr sz="1800" b="1">
+                <a:solidFill>
+                  <a:srgbClr val="E0A437"/>
+                </a:solidFill>
+                <a:latin typeface="Fira Sans"/>
+              </a:rPr>
+              <a:t>▸ </a:t>
+            </a:r>
+            <a:r>
+              <a:rPr sz="1800" b="1">
+                <a:solidFill>
+                  <a:srgbClr val="1D3557"/>
+                </a:solidFill>
+                <a:latin typeface="Fira Sans"/>
+              </a:rPr>
+              <a:t>La formulación se entrega el lunes 7; el primer análisis exploratorio, el lunes 15.</a:t>
+            </a:r>
+          </a:p>
+        </p:txBody>
+      </p:sp>
+    </p:spTree>
+  </p:cSld>
+  <p:clrMapOvr>
+    <a:masterClrMapping/>
+  </p:clrMapOvr>
+</p:sld>
+</file>
+
+<file path=ppt/slides/slide31.xml><?xml version="1.0" encoding="utf-8"?>
+<p:sld xmlns:a="http://schemas.openxmlformats.org/drawingml/2006/main" xmlns:p="http://schemas.openxmlformats.org/presentationml/2006/main" xmlns:r="http://schemas.openxmlformats.org/officeDocument/2006/relationships">
+  <p:cSld>
+    <p:spTree>
+      <p:nvGrpSpPr>
+        <p:cNvPr id="1" name=""/>
+        <p:cNvGrpSpPr/>
+        <p:nvPr/>
+      </p:nvGrpSpPr>
+      <p:grpSpPr/>
+      <p:sp>
+        <p:nvSpPr>
+          <p:cNvPr id="2" name="Rectangle 1"/>
+          <p:cNvSpPr/>
+          <p:nvPr/>
+        </p:nvSpPr>
+        <p:spPr>
+          <a:xfrm>
+            <a:off x="0" y="0"/>
+            <a:ext cx="9144000" cy="5138928"/>
+          </a:xfrm>
+          <a:prstGeom prst="rect">
+            <a:avLst/>
+          </a:prstGeom>
+          <a:solidFill>
+            <a:srgbClr val="FAFBFC"/>
+          </a:solidFill>
+          <a:ln>
+            <a:noFill/>
+          </a:ln>
+          <a:effectLst/>
+        </p:spPr>
+        <p:style>
+          <a:lnRef idx="1">
+            <a:schemeClr val="accent1"/>
+          </a:lnRef>
+          <a:fillRef idx="3">
+            <a:schemeClr val="accent1"/>
+          </a:fillRef>
+          <a:effectRef idx="2">
+            <a:schemeClr val="accent1"/>
+          </a:effectRef>
+          <a:fontRef idx="minor">
+            <a:schemeClr val="lt1"/>
+          </a:fontRef>
+        </p:style>
+        <p:txBody>
+          <a:bodyPr rtlCol="0" anchor="ctr"/>
+          <a:lstStyle/>
+          <a:p>
+            <a:pPr algn="ctr"/>
+          </a:p>
+        </p:txBody>
+      </p:sp>
+      <p:sp>
+        <p:nvSpPr>
+          <p:cNvPr id="3" name="TextBox 2"/>
+          <p:cNvSpPr txBox="1"/>
+          <p:nvPr/>
+        </p:nvSpPr>
+        <p:spPr>
+          <a:xfrm>
+            <a:off x="402336" y="301752"/>
+            <a:ext cx="8348472" cy="795528"/>
+          </a:xfrm>
+          <a:prstGeom prst="rect">
+            <a:avLst/>
+          </a:prstGeom>
+          <a:noFill/>
+        </p:spPr>
+        <p:txBody>
+          <a:bodyPr wrap="square">
+            <a:spAutoFit/>
+          </a:bodyPr>
+          <a:lstStyle/>
+          <a:p>
+            <a:r>
+              <a:rPr sz="2800" b="1">
+                <a:solidFill>
+                  <a:srgbClr val="0F0F0F"/>
+                </a:solidFill>
+                <a:latin typeface="Fira Sans"/>
+              </a:rPr>
+              <a:t>Referencias</a:t>
+            </a:r>
+          </a:p>
+        </p:txBody>
+      </p:sp>
+      <p:sp>
+        <p:nvSpPr>
+          <p:cNvPr id="4" name="TextBox 3"/>
+          <p:cNvSpPr txBox="1"/>
+          <p:nvPr/>
+        </p:nvSpPr>
+        <p:spPr>
+          <a:xfrm>
+            <a:off x="704088" y="1234440"/>
+            <a:ext cx="7744968" cy="3566160"/>
+          </a:xfrm>
+          <a:prstGeom prst="rect">
+            <a:avLst/>
+          </a:prstGeom>
+          <a:noFill/>
+        </p:spPr>
+        <p:txBody>
+          <a:bodyPr wrap="square">
+            <a:spAutoFit/>
+          </a:bodyPr>
+          <a:lstStyle/>
+          <a:p>
+            <a:pPr>
+              <a:lnSpc>
+                <a:spcPct val="115000"/>
+              </a:lnSpc>
+              <a:spcAft>
+                <a:spcPts val="700"/>
+              </a:spcAft>
+            </a:pPr>
+            <a:r>
+              <a:rPr sz="1300" b="0">
+                <a:solidFill>
+                  <a:srgbClr val="333333"/>
+                </a:solidFill>
+                <a:latin typeface="Fira Sans"/>
+              </a:rPr>
+              <a:t>Tukey, J. W. (1977). Exploratory Data Analysis. Addison-Wesley.</a:t>
+            </a:r>
+          </a:p>
+          <a:p>
+            <a:pPr>
+              <a:lnSpc>
+                <a:spcPct val="115000"/>
+              </a:lnSpc>
+              <a:spcAft>
+                <a:spcPts val="700"/>
+              </a:spcAft>
+            </a:pPr>
+            <a:r>
+              <a:rPr sz="1300" b="0">
+                <a:solidFill>
+                  <a:srgbClr val="333333"/>
+                </a:solidFill>
+                <a:latin typeface="Fira Sans"/>
+              </a:rPr>
+              <a:t>Seabold, S. y Perktold, J. (2010). statsmodels: Econometric and statistical modeling with Python. Proceedings of the 9th Python in Science Conference.</a:t>
+            </a:r>
+          </a:p>
+          <a:p>
+            <a:pPr>
+              <a:lnSpc>
+                <a:spcPct val="115000"/>
+              </a:lnSpc>
+              <a:spcAft>
+                <a:spcPts val="700"/>
+              </a:spcAft>
+            </a:pPr>
+            <a:r>
+              <a:rPr sz="1300" b="0">
+                <a:solidFill>
+                  <a:srgbClr val="333333"/>
+                </a:solidFill>
+                <a:latin typeface="Fira Sans"/>
+              </a:rPr>
+              <a:t>VanderPlas, J. (2016). Python Data Science Handbook. O'Reilly. Capítulo 5 (regresión lineal).</a:t>
+            </a:r>
+          </a:p>
+          <a:p>
+            <a:pPr>
+              <a:lnSpc>
+                <a:spcPct val="115000"/>
+              </a:lnSpc>
+              <a:spcAft>
+                <a:spcPts val="700"/>
+              </a:spcAft>
+            </a:pPr>
+            <a:r>
+              <a:rPr sz="1300" b="0">
+                <a:solidFill>
+                  <a:srgbClr val="333333"/>
+                </a:solidFill>
+                <a:latin typeface="Fira Sans"/>
+              </a:rPr>
+              <a:t>Datos: Encuesta Origen Destino Santiago 2012 (Sectra).</a:t>
             </a:r>
           </a:p>
         </p:txBody>

</xml_diff>

<commit_message>
Clase 4: grafico del cambio de coeficientes, preguntas que marcan cada modelo de motorizacion y valor p con sujeto
El modelo de vehiculos suma la tabla y el grafico de barras con los
coeficientes de los tres modelos (solo ingreso, + personas, +
bicicletas): el ingreso apenas se mueve de 0,50 a 0,48. Cada modelo de
motorizacion abre con una slide de seccion que plantea la pregunta y
declara que explica y con que. El valor p se enuncia con sujeto: si en
la ciudad el ingreso no tuviera efecto sobre los vehiculos. Deck en 34
slides.

Co-Authored-By: Claude Fable 5 <noreply@anthropic.com>
</commit_message>
<xml_diff>
--- a/presentaciones/clase04_regresion_multiple.pptx
+++ b/presentaciones/clase04_regresion_multiple.pptx
@@ -36,6 +36,9 @@
     <p:sldId id="284" r:id="rId35"/>
     <p:sldId id="285" r:id="rId36"/>
     <p:sldId id="286" r:id="rId37"/>
+    <p:sldId id="287" r:id="rId38"/>
+    <p:sldId id="288" r:id="rId39"/>
+    <p:sldId id="289" r:id="rId40"/>
   </p:sldIdLst>
   <p:sldSz cx="9144000" cy="5138928" type="screen4x3"/>
   <p:notesSz cx="6858000" cy="9144000"/>
@@ -3395,7 +3398,7 @@
             <a:avLst/>
           </a:prstGeom>
           <a:solidFill>
-            <a:srgbClr val="1D3557"/>
+            <a:srgbClr val="FAFBFC"/>
           </a:solidFill>
           <a:ln>
             <a:noFill/>
@@ -3432,8 +3435,8 @@
         </p:nvSpPr>
         <p:spPr>
           <a:xfrm>
-            <a:off x="603504" y="1847088"/>
-            <a:ext cx="7946136" cy="1399032"/>
+            <a:off x="402336" y="301752"/>
+            <a:ext cx="8348472" cy="795528"/>
           </a:xfrm>
           <a:prstGeom prst="rect">
             <a:avLst/>
@@ -3447,24 +3450,167 @@
           <a:lstStyle/>
           <a:p>
             <a:r>
-              <a:rPr sz="3400" b="1">
-                <a:solidFill>
-                  <a:srgbClr val="FFFFFF"/>
-                </a:solidFill>
-                <a:latin typeface="Fira Sans"/>
-              </a:rPr>
-              <a:t>Visualización</a:t>
-            </a:r>
-          </a:p>
-          <a:p>
-            <a:r>
-              <a:rPr sz="1800" b="0">
+              <a:rPr sz="2800" b="1">
+                <a:solidFill>
+                  <a:srgbClr val="0F0F0F"/>
+                </a:solidFill>
+                <a:latin typeface="Fira Sans"/>
+              </a:rPr>
+              <a:t>Sacar atípicos de la variable a predecir</a:t>
+            </a:r>
+          </a:p>
+        </p:txBody>
+      </p:sp>
+      <p:sp>
+        <p:nvSpPr>
+          <p:cNvPr id="4" name="Rectangle 3"/>
+          <p:cNvSpPr/>
+          <p:nvPr/>
+        </p:nvSpPr>
+        <p:spPr>
+          <a:xfrm>
+            <a:off x="704088" y="1280160"/>
+            <a:ext cx="7744968" cy="2880360"/>
+          </a:xfrm>
+          <a:prstGeom prst="rect">
+            <a:avLst/>
+          </a:prstGeom>
+          <a:solidFill>
+            <a:srgbClr val="F0F2F5"/>
+          </a:solidFill>
+          <a:ln>
+            <a:solidFill>
+              <a:srgbClr val="D8DDE3"/>
+            </a:solidFill>
+          </a:ln>
+          <a:effectLst/>
+        </p:spPr>
+        <p:style>
+          <a:lnRef idx="1">
+            <a:schemeClr val="accent1"/>
+          </a:lnRef>
+          <a:fillRef idx="3">
+            <a:schemeClr val="accent1"/>
+          </a:fillRef>
+          <a:effectRef idx="2">
+            <a:schemeClr val="accent1"/>
+          </a:effectRef>
+          <a:fontRef idx="minor">
+            <a:schemeClr val="lt1"/>
+          </a:fontRef>
+        </p:style>
+        <p:txBody>
+          <a:bodyPr rtlCol="0" anchor="ctr" wrap="square" lIns="228600" tIns="137160"/>
+          <a:lstStyle/>
+          <a:p>
+            <a:pPr/>
+            <a:r>
+              <a:rPr sz="1500" b="0">
+                <a:solidFill>
+                  <a:srgbClr val="1D3557"/>
+                </a:solidFill>
+                <a:latin typeface="Menlo"/>
+              </a:rPr>
+              <a:t>q1, q3 = h["NumVeh"].quantile([0.25, 0.75])</a:t>
+            </a:r>
+          </a:p>
+          <a:p>
+            <a:pPr/>
+            <a:r>
+              <a:rPr sz="1500" b="0">
+                <a:solidFill>
+                  <a:srgbClr val="1D3557"/>
+                </a:solidFill>
+                <a:latin typeface="Menlo"/>
+              </a:rPr>
+              <a:t>sin_atipicos = h[h["NumVeh"] &lt;= q3 + 1.5 * (q3 - q1)]  # = 2.5</a:t>
+            </a:r>
+          </a:p>
+          <a:p>
+            <a:pPr/>
+            <a:r>
+              <a:rPr sz="1500" b="0">
+                <a:solidFill>
+                  <a:srgbClr val="1D3557"/>
+                </a:solidFill>
+                <a:latin typeface="Menlo"/>
+              </a:rPr>
+              <a:t/>
+            </a:r>
+          </a:p>
+          <a:p>
+            <a:pPr/>
+            <a:r>
+              <a:rPr sz="1500" b="0">
+                <a:solidFill>
+                  <a:srgbClr val="1D3557"/>
+                </a:solidFill>
+                <a:latin typeface="Menlo"/>
+              </a:rPr>
+              <a:t># El mismo modelo, sin los hogares de 3 autos o más</a:t>
+            </a:r>
+          </a:p>
+          <a:p>
+            <a:pPr/>
+            <a:r>
+              <a:rPr sz="1500" b="0">
+                <a:solidFill>
+                  <a:srgbClr val="1D3557"/>
+                </a:solidFill>
+                <a:latin typeface="Menlo"/>
+              </a:rPr>
+              <a:t>np.polyfit(sin_atipicos["IngresoHogar"] / 1e6, sin_atipicos["NumVeh"], 1)</a:t>
+            </a:r>
+          </a:p>
+        </p:txBody>
+      </p:sp>
+      <p:sp>
+        <p:nvSpPr>
+          <p:cNvPr id="5" name="TextBox 4"/>
+          <p:cNvSpPr txBox="1"/>
+          <p:nvPr/>
+        </p:nvSpPr>
+        <p:spPr>
+          <a:xfrm>
+            <a:off x="704088" y="4389120"/>
+            <a:ext cx="7744968" cy="1097280"/>
+          </a:xfrm>
+          <a:prstGeom prst="rect">
+            <a:avLst/>
+          </a:prstGeom>
+          <a:noFill/>
+        </p:spPr>
+        <p:txBody>
+          <a:bodyPr wrap="square">
+            <a:spAutoFit/>
+          </a:bodyPr>
+          <a:lstStyle/>
+          <a:p>
+            <a:pPr>
+              <a:lnSpc>
+                <a:spcPct val="112000"/>
+              </a:lnSpc>
+              <a:spcAft>
+                <a:spcPts val="900"/>
+              </a:spcAft>
+            </a:pPr>
+            <a:r>
+              <a:rPr sz="1600" b="1">
                 <a:solidFill>
                   <a:srgbClr val="E0A437"/>
                 </a:solidFill>
                 <a:latin typeface="Fira Sans"/>
               </a:rPr>
-              <a:t>Muchos puntos y colas largas</a:t>
+              <a:t>▸ </a:t>
+            </a:r>
+            <a:r>
+              <a:rPr sz="1600" b="0">
+                <a:solidFill>
+                  <a:srgbClr val="000000"/>
+                </a:solidFill>
+                <a:latin typeface="Fira Sans"/>
+              </a:rPr>
+              <a:t>Sacar 236 hogares aplana la pendiente ponderada (0,50 a 0,44): no eran errores, eran la señal. Los atípicos de y se investigan; se eliminan solo por dominio.</a:t>
             </a:r>
           </a:p>
         </p:txBody>
@@ -3502,7 +3648,7 @@
             <a:avLst/>
           </a:prstGeom>
           <a:solidFill>
-            <a:srgbClr val="FAFBFC"/>
+            <a:srgbClr val="1D3557"/>
           </a:solidFill>
           <a:ln>
             <a:noFill/>
@@ -3539,8 +3685,8 @@
         </p:nvSpPr>
         <p:spPr>
           <a:xfrm>
-            <a:off x="402336" y="301752"/>
-            <a:ext cx="8348472" cy="795528"/>
+            <a:off x="603504" y="1847088"/>
+            <a:ext cx="7946136" cy="1399032"/>
           </a:xfrm>
           <a:prstGeom prst="rect">
             <a:avLst/>
@@ -3554,71 +3700,24 @@
           <a:lstStyle/>
           <a:p>
             <a:r>
-              <a:rPr sz="2800" b="1">
-                <a:solidFill>
-                  <a:srgbClr val="0F0F0F"/>
-                </a:solidFill>
-                <a:latin typeface="Fira Sans"/>
-              </a:rPr>
-              <a:t>Graficar 90 mil puntos: overplotting</a:t>
-            </a:r>
-          </a:p>
-        </p:txBody>
-      </p:sp>
-      <p:pic>
-        <p:nvPicPr>
-          <p:cNvPr id="4" name="Picture 3" descr="c3_08_overplotting.png"/>
-          <p:cNvPicPr>
-            <a:picLocks noChangeAspect="1"/>
-          </p:cNvPicPr>
-          <p:nvPr/>
-        </p:nvPicPr>
-        <p:blipFill>
-          <a:blip r:embed="rId2"/>
-          <a:stretch>
-            <a:fillRect/>
-          </a:stretch>
-        </p:blipFill>
-        <p:spPr>
-          <a:xfrm>
-            <a:off x="699515" y="1545618"/>
-            <a:ext cx="7744968" cy="2349444"/>
-          </a:xfrm>
-          <a:prstGeom prst="rect">
-            <a:avLst/>
-          </a:prstGeom>
-        </p:spPr>
-      </p:pic>
-      <p:sp>
-        <p:nvSpPr>
-          <p:cNvPr id="5" name="TextBox 4"/>
-          <p:cNvSpPr txBox="1"/>
-          <p:nvPr/>
-        </p:nvSpPr>
-        <p:spPr>
-          <a:xfrm>
-            <a:off x="704088" y="4434840"/>
-            <a:ext cx="7744968" cy="457200"/>
-          </a:xfrm>
-          <a:prstGeom prst="rect">
-            <a:avLst/>
-          </a:prstGeom>
-          <a:noFill/>
-        </p:spPr>
-        <p:txBody>
-          <a:bodyPr wrap="square">
-            <a:spAutoFit/>
-          </a:bodyPr>
-          <a:lstStyle/>
-          <a:p>
-            <a:r>
-              <a:rPr sz="1300" b="0">
-                <a:solidFill>
-                  <a:srgbClr val="333333"/>
-                </a:solidFill>
-                <a:latin typeface="Fira Sans"/>
-              </a:rPr>
-              <a:t>Con todos los puntos sólidos, el scatter se satura y miente. Los remedios: transparencia (alpha), muestreo, o hexbin, donde el color cuenta los viajes (la distancia viene en la tabla DistanciaViaje.csv; sus −1 son faltantes disfrazados).</a:t>
+              <a:rPr sz="3400" b="1">
+                <a:solidFill>
+                  <a:srgbClr val="FFFFFF"/>
+                </a:solidFill>
+                <a:latin typeface="Fira Sans"/>
+              </a:rPr>
+              <a:t>Visualización</a:t>
+            </a:r>
+          </a:p>
+          <a:p>
+            <a:r>
+              <a:rPr sz="1800" b="0">
+                <a:solidFill>
+                  <a:srgbClr val="E0A437"/>
+                </a:solidFill>
+                <a:latin typeface="Fira Sans"/>
+              </a:rPr>
+              <a:t>Muchos puntos y colas largas</a:t>
             </a:r>
           </a:p>
         </p:txBody>
@@ -3714,14 +3813,14 @@
                 </a:solidFill>
                 <a:latin typeface="Fira Sans"/>
               </a:rPr>
-              <a:t>Cuándo usar escala logarítmica</a:t>
+              <a:t>Graficar 90 mil puntos: overplotting</a:t>
             </a:r>
           </a:p>
         </p:txBody>
       </p:sp>
       <p:pic>
         <p:nvPicPr>
-          <p:cNvPr id="4" name="Picture 3" descr="c3_10_escala_log.png"/>
+          <p:cNvPr id="4" name="Picture 3" descr="c3_08_overplotting.png"/>
           <p:cNvPicPr>
             <a:picLocks noChangeAspect="1"/>
           </p:cNvPicPr>
@@ -3735,8 +3834,8 @@
         </p:blipFill>
         <p:spPr>
           <a:xfrm>
-            <a:off x="699515" y="1227136"/>
-            <a:ext cx="7744968" cy="2986407"/>
+            <a:off x="699515" y="1545618"/>
+            <a:ext cx="7744968" cy="2349444"/>
           </a:xfrm>
           <a:prstGeom prst="rect">
             <a:avLst/>
@@ -3772,7 +3871,7 @@
                 </a:solidFill>
                 <a:latin typeface="Fira Sans"/>
               </a:rPr>
-              <a:t>La misma distancia tiene cola larga: en lineal se aplasta; en log, la forma aparece. Y transformar con log es feature engineering clásico: vuelve lineales las relaciones multiplicativas.</a:t>
+              <a:t>Con todos los puntos sólidos, el scatter se satura y miente. Los remedios: transparencia (alpha), muestreo, o hexbin, donde el color cuenta los viajes (la distancia viene en la tabla DistanciaViaje.csv; sus −1 son faltantes disfrazados).</a:t>
             </a:r>
           </a:p>
         </p:txBody>
@@ -3868,14 +3967,14 @@
                 </a:solidFill>
                 <a:latin typeface="Fira Sans"/>
               </a:rPr>
-              <a:t>La misma regresión, tres veces</a:t>
+              <a:t>Cuándo usar escala logarítmica</a:t>
             </a:r>
           </a:p>
         </p:txBody>
       </p:sp>
       <p:pic>
         <p:nvPicPr>
-          <p:cNvPr id="4" name="Picture 3" descr="c4_02_tres_modelos.png"/>
+          <p:cNvPr id="4" name="Picture 3" descr="c3_10_escala_log.png"/>
           <p:cNvPicPr>
             <a:picLocks noChangeAspect="1"/>
           </p:cNvPicPr>
@@ -3889,8 +3988,8 @@
         </p:blipFill>
         <p:spPr>
           <a:xfrm>
-            <a:off x="699515" y="1660639"/>
-            <a:ext cx="7744968" cy="2119400"/>
+            <a:off x="699515" y="1227136"/>
+            <a:ext cx="7744968" cy="2986407"/>
           </a:xfrm>
           <a:prstGeom prst="rect">
             <a:avLst/>
@@ -3926,7 +4025,7 @@
                 </a:solidFill>
                 <a:latin typeface="Fira Sans"/>
               </a:rPr>
-              <a:t>La transformación aplicada a duración ~ distancia: el log en ambos lados endereza la nube y el R² sube de 0,32 a 0,53. Y el modelo todavía pide más variables.</a:t>
+              <a:t>La misma distancia tiene cola larga: en lineal se aplasta; en log, la forma aparece. Y transformar con log es feature engineering clásico: vuelve lineales las relaciones multiplicativas.</a:t>
             </a:r>
           </a:p>
         </p:txBody>
@@ -4022,14 +4121,14 @@
                 </a:solidFill>
                 <a:latin typeface="Fira Sans"/>
               </a:rPr>
-              <a:t>El mismo gráfico, dos veces</a:t>
+              <a:t>La misma regresión, tres veces</a:t>
             </a:r>
           </a:p>
         </p:txBody>
       </p:sp>
       <p:pic>
         <p:nvPicPr>
-          <p:cNvPr id="4" name="Picture 3" descr="c3_16_mal_buen_grafico.png"/>
+          <p:cNvPr id="4" name="Picture 3" descr="c4_02_tres_modelos.png"/>
           <p:cNvPicPr>
             <a:picLocks noChangeAspect="1"/>
           </p:cNvPicPr>
@@ -4043,8 +4142,8 @@
         </p:blipFill>
         <p:spPr>
           <a:xfrm>
-            <a:off x="699515" y="1217944"/>
-            <a:ext cx="7744968" cy="3004790"/>
+            <a:off x="699515" y="1660639"/>
+            <a:ext cx="7744968" cy="2119400"/>
           </a:xfrm>
           <a:prstGeom prst="rect">
             <a:avLst/>
@@ -4080,7 +4179,7 @@
                 </a:solidFill>
                 <a:latin typeface="Fira Sans"/>
               </a:rPr>
-              <a:t>Los mismos 30 mil viajes: sin rotular y saturado, contra rotulado, con transparencia y con el hallazgo en el título.</a:t>
+              <a:t>La transformación aplicada a duración ~ distancia: el log en ambos lados endereza la nube y el R² sube de 0,32 a 0,53. Y el modelo todavía pide más variables.</a:t>
             </a:r>
           </a:p>
         </p:txBody>
@@ -4176,21 +4275,45 @@
                 </a:solidFill>
                 <a:latin typeface="Fira Sans"/>
               </a:rPr>
-              <a:t>Checklist del buen gráfico</a:t>
-            </a:r>
-          </a:p>
-        </p:txBody>
-      </p:sp>
-      <p:sp>
-        <p:nvSpPr>
-          <p:cNvPr id="4" name="TextBox 3"/>
+              <a:t>El mismo gráfico, dos veces</a:t>
+            </a:r>
+          </a:p>
+        </p:txBody>
+      </p:sp>
+      <p:pic>
+        <p:nvPicPr>
+          <p:cNvPr id="4" name="Picture 3" descr="c3_16_mal_buen_grafico.png"/>
+          <p:cNvPicPr>
+            <a:picLocks noChangeAspect="1"/>
+          </p:cNvPicPr>
+          <p:nvPr/>
+        </p:nvPicPr>
+        <p:blipFill>
+          <a:blip r:embed="rId2"/>
+          <a:stretch>
+            <a:fillRect/>
+          </a:stretch>
+        </p:blipFill>
+        <p:spPr>
+          <a:xfrm>
+            <a:off x="699515" y="1217944"/>
+            <a:ext cx="7744968" cy="3004790"/>
+          </a:xfrm>
+          <a:prstGeom prst="rect">
+            <a:avLst/>
+          </a:prstGeom>
+        </p:spPr>
+      </p:pic>
+      <p:sp>
+        <p:nvSpPr>
+          <p:cNvPr id="5" name="TextBox 4"/>
           <p:cNvSpPr txBox="1"/>
           <p:nvPr/>
         </p:nvSpPr>
         <p:spPr>
           <a:xfrm>
-            <a:off x="704088" y="1353312"/>
-            <a:ext cx="7744968" cy="3300984"/>
+            <a:off x="704088" y="4434840"/>
+            <a:ext cx="7744968" cy="457200"/>
           </a:xfrm>
           <a:prstGeom prst="rect">
             <a:avLst/>
@@ -4203,143 +4326,14 @@
           </a:bodyPr>
           <a:lstStyle/>
           <a:p>
-            <a:pPr>
-              <a:lnSpc>
-                <a:spcPct val="112000"/>
-              </a:lnSpc>
-              <a:spcAft>
-                <a:spcPts val="900"/>
-              </a:spcAft>
-            </a:pPr>
-            <a:r>
-              <a:rPr sz="1800" b="1">
-                <a:solidFill>
-                  <a:srgbClr val="E0A437"/>
-                </a:solidFill>
-                <a:latin typeface="Fira Sans"/>
-              </a:rPr>
-              <a:t>▸ </a:t>
-            </a:r>
-            <a:r>
-              <a:rPr sz="1800" b="0">
-                <a:solidFill>
-                  <a:srgbClr val="000000"/>
-                </a:solidFill>
-                <a:latin typeface="Fira Sans"/>
-              </a:rPr>
-              <a:t>Título que diga el hallazgo, no solo las variables.</a:t>
-            </a:r>
-          </a:p>
-          <a:p>
-            <a:pPr>
-              <a:lnSpc>
-                <a:spcPct val="112000"/>
-              </a:lnSpc>
-              <a:spcAft>
-                <a:spcPts val="900"/>
-              </a:spcAft>
-            </a:pPr>
-            <a:r>
-              <a:rPr sz="1800" b="1">
-                <a:solidFill>
-                  <a:srgbClr val="E0A437"/>
-                </a:solidFill>
-                <a:latin typeface="Fira Sans"/>
-              </a:rPr>
-              <a:t>▸ </a:t>
-            </a:r>
-            <a:r>
-              <a:rPr sz="1800" b="0">
-                <a:solidFill>
-                  <a:srgbClr val="000000"/>
-                </a:solidFill>
-                <a:latin typeface="Fira Sans"/>
-              </a:rPr>
-              <a:t>Ejes con nombre y unidad; ejes que parten de cero en gráficos de barras.</a:t>
-            </a:r>
-          </a:p>
-          <a:p>
-            <a:pPr>
-              <a:lnSpc>
-                <a:spcPct val="112000"/>
-              </a:lnSpc>
-              <a:spcAft>
-                <a:spcPts val="900"/>
-              </a:spcAft>
-            </a:pPr>
-            <a:r>
-              <a:rPr sz="1800" b="1">
-                <a:solidFill>
-                  <a:srgbClr val="E0A437"/>
-                </a:solidFill>
-                <a:latin typeface="Fira Sans"/>
-              </a:rPr>
-              <a:t>▸ </a:t>
-            </a:r>
-            <a:r>
-              <a:rPr sz="1800" b="0">
-                <a:solidFill>
-                  <a:srgbClr val="000000"/>
-                </a:solidFill>
-                <a:latin typeface="Fira Sans"/>
-              </a:rPr>
-              <a:t>Muchos puntos: alpha, muestreo o hexbin.</a:t>
-            </a:r>
-          </a:p>
-          <a:p>
-            <a:pPr>
-              <a:lnSpc>
-                <a:spcPct val="112000"/>
-              </a:lnSpc>
-              <a:spcAft>
-                <a:spcPts val="900"/>
-              </a:spcAft>
-            </a:pPr>
-            <a:r>
-              <a:rPr sz="1800" b="1">
-                <a:solidFill>
-                  <a:srgbClr val="E0A437"/>
-                </a:solidFill>
-                <a:latin typeface="Fira Sans"/>
-              </a:rPr>
-              <a:t>▸ </a:t>
-            </a:r>
-            <a:r>
-              <a:rPr sz="1800" b="0">
-                <a:solidFill>
-                  <a:srgbClr val="000000"/>
-                </a:solidFill>
-                <a:latin typeface="Fira Sans"/>
-              </a:rPr>
-              <a:t>Colas largas: escala logarítmica o eje recortado, declarándolo.</a:t>
-            </a:r>
-          </a:p>
-          <a:p>
-            <a:pPr>
-              <a:lnSpc>
-                <a:spcPct val="112000"/>
-              </a:lnSpc>
-              <a:spcAft>
-                <a:spcPts val="900"/>
-              </a:spcAft>
-            </a:pPr>
-            <a:r>
-              <a:rPr sz="1800" b="1">
-                <a:solidFill>
-                  <a:srgbClr val="E0A437"/>
-                </a:solidFill>
-                <a:latin typeface="Fira Sans"/>
-              </a:rPr>
-              <a:t>▸ </a:t>
-            </a:r>
-            <a:r>
-              <a:rPr sz="1800" b="1">
-                <a:solidFill>
-                  <a:srgbClr val="1D3557"/>
-                </a:solidFill>
-                <a:latin typeface="Fira Sans"/>
-              </a:rPr>
-              <a:t>El gráfico se corrige igual que el código: se itera hasta que un tercero lo entienda sin explicación oral.</a:t>
+            <a:r>
+              <a:rPr sz="1300" b="0">
+                <a:solidFill>
+                  <a:srgbClr val="333333"/>
+                </a:solidFill>
+                <a:latin typeface="Fira Sans"/>
+              </a:rPr>
+              <a:t>Los mismos 30 mil viajes: sin rotular y saturado, contra rotulado, con transparencia y con el hallazgo en el título.</a:t>
             </a:r>
           </a:p>
         </p:txBody>
@@ -4377,7 +4371,7 @@
             <a:avLst/>
           </a:prstGeom>
           <a:solidFill>
-            <a:srgbClr val="1D3557"/>
+            <a:srgbClr val="FAFBFC"/>
           </a:solidFill>
           <a:ln>
             <a:noFill/>
@@ -4414,8 +4408,8 @@
         </p:nvSpPr>
         <p:spPr>
           <a:xfrm>
-            <a:off x="603504" y="1847088"/>
-            <a:ext cx="7946136" cy="1399032"/>
+            <a:off x="402336" y="301752"/>
+            <a:ext cx="8348472" cy="795528"/>
           </a:xfrm>
           <a:prstGeom prst="rect">
             <a:avLst/>
@@ -4429,24 +4423,176 @@
           <a:lstStyle/>
           <a:p>
             <a:r>
-              <a:rPr sz="3400" b="1">
-                <a:solidFill>
-                  <a:srgbClr val="FFFFFF"/>
-                </a:solidFill>
-                <a:latin typeface="Fira Sans"/>
-              </a:rPr>
-              <a:t>Regresión múltiple</a:t>
-            </a:r>
-          </a:p>
-          <a:p>
+              <a:rPr sz="2800" b="1">
+                <a:solidFill>
+                  <a:srgbClr val="0F0F0F"/>
+                </a:solidFill>
+                <a:latin typeface="Fira Sans"/>
+              </a:rPr>
+              <a:t>Checklist del buen gráfico</a:t>
+            </a:r>
+          </a:p>
+        </p:txBody>
+      </p:sp>
+      <p:sp>
+        <p:nvSpPr>
+          <p:cNvPr id="4" name="TextBox 3"/>
+          <p:cNvSpPr txBox="1"/>
+          <p:nvPr/>
+        </p:nvSpPr>
+        <p:spPr>
+          <a:xfrm>
+            <a:off x="704088" y="1353312"/>
+            <a:ext cx="7744968" cy="3300984"/>
+          </a:xfrm>
+          <a:prstGeom prst="rect">
+            <a:avLst/>
+          </a:prstGeom>
+          <a:noFill/>
+        </p:spPr>
+        <p:txBody>
+          <a:bodyPr wrap="square">
+            <a:spAutoFit/>
+          </a:bodyPr>
+          <a:lstStyle/>
+          <a:p>
+            <a:pPr>
+              <a:lnSpc>
+                <a:spcPct val="112000"/>
+              </a:lnSpc>
+              <a:spcAft>
+                <a:spcPts val="900"/>
+              </a:spcAft>
+            </a:pPr>
+            <a:r>
+              <a:rPr sz="1800" b="1">
+                <a:solidFill>
+                  <a:srgbClr val="E0A437"/>
+                </a:solidFill>
+                <a:latin typeface="Fira Sans"/>
+              </a:rPr>
+              <a:t>▸ </a:t>
+            </a:r>
             <a:r>
               <a:rPr sz="1800" b="0">
                 <a:solidFill>
+                  <a:srgbClr val="000000"/>
+                </a:solidFill>
+                <a:latin typeface="Fira Sans"/>
+              </a:rPr>
+              <a:t>Título que diga el hallazgo, no solo las variables.</a:t>
+            </a:r>
+          </a:p>
+          <a:p>
+            <a:pPr>
+              <a:lnSpc>
+                <a:spcPct val="112000"/>
+              </a:lnSpc>
+              <a:spcAft>
+                <a:spcPts val="900"/>
+              </a:spcAft>
+            </a:pPr>
+            <a:r>
+              <a:rPr sz="1800" b="1">
+                <a:solidFill>
                   <a:srgbClr val="E0A437"/>
                 </a:solidFill>
                 <a:latin typeface="Fira Sans"/>
               </a:rPr>
-              <a:t>El primer modelo con varias variables</a:t>
+              <a:t>▸ </a:t>
+            </a:r>
+            <a:r>
+              <a:rPr sz="1800" b="0">
+                <a:solidFill>
+                  <a:srgbClr val="000000"/>
+                </a:solidFill>
+                <a:latin typeface="Fira Sans"/>
+              </a:rPr>
+              <a:t>Ejes con nombre y unidad; ejes que parten de cero en gráficos de barras.</a:t>
+            </a:r>
+          </a:p>
+          <a:p>
+            <a:pPr>
+              <a:lnSpc>
+                <a:spcPct val="112000"/>
+              </a:lnSpc>
+              <a:spcAft>
+                <a:spcPts val="900"/>
+              </a:spcAft>
+            </a:pPr>
+            <a:r>
+              <a:rPr sz="1800" b="1">
+                <a:solidFill>
+                  <a:srgbClr val="E0A437"/>
+                </a:solidFill>
+                <a:latin typeface="Fira Sans"/>
+              </a:rPr>
+              <a:t>▸ </a:t>
+            </a:r>
+            <a:r>
+              <a:rPr sz="1800" b="0">
+                <a:solidFill>
+                  <a:srgbClr val="000000"/>
+                </a:solidFill>
+                <a:latin typeface="Fira Sans"/>
+              </a:rPr>
+              <a:t>Muchos puntos: alpha, muestreo o hexbin.</a:t>
+            </a:r>
+          </a:p>
+          <a:p>
+            <a:pPr>
+              <a:lnSpc>
+                <a:spcPct val="112000"/>
+              </a:lnSpc>
+              <a:spcAft>
+                <a:spcPts val="900"/>
+              </a:spcAft>
+            </a:pPr>
+            <a:r>
+              <a:rPr sz="1800" b="1">
+                <a:solidFill>
+                  <a:srgbClr val="E0A437"/>
+                </a:solidFill>
+                <a:latin typeface="Fira Sans"/>
+              </a:rPr>
+              <a:t>▸ </a:t>
+            </a:r>
+            <a:r>
+              <a:rPr sz="1800" b="0">
+                <a:solidFill>
+                  <a:srgbClr val="000000"/>
+                </a:solidFill>
+                <a:latin typeface="Fira Sans"/>
+              </a:rPr>
+              <a:t>Colas largas: escala logarítmica o eje recortado, declarándolo.</a:t>
+            </a:r>
+          </a:p>
+          <a:p>
+            <a:pPr>
+              <a:lnSpc>
+                <a:spcPct val="112000"/>
+              </a:lnSpc>
+              <a:spcAft>
+                <a:spcPts val="900"/>
+              </a:spcAft>
+            </a:pPr>
+            <a:r>
+              <a:rPr sz="1800" b="1">
+                <a:solidFill>
+                  <a:srgbClr val="E0A437"/>
+                </a:solidFill>
+                <a:latin typeface="Fira Sans"/>
+              </a:rPr>
+              <a:t>▸ </a:t>
+            </a:r>
+            <a:r>
+              <a:rPr sz="1800" b="1">
+                <a:solidFill>
+                  <a:srgbClr val="1D3557"/>
+                </a:solidFill>
+                <a:latin typeface="Fira Sans"/>
+              </a:rPr>
+              <a:t>El gráfico se corrige igual que el código: se itera hasta que un tercero lo entienda sin explicación oral.</a:t>
             </a:r>
           </a:p>
         </p:txBody>
@@ -4484,7 +4630,7 @@
             <a:avLst/>
           </a:prstGeom>
           <a:solidFill>
-            <a:srgbClr val="FAFBFC"/>
+            <a:srgbClr val="1D3557"/>
           </a:solidFill>
           <a:ln>
             <a:noFill/>
@@ -4521,8 +4667,8 @@
         </p:nvSpPr>
         <p:spPr>
           <a:xfrm>
-            <a:off x="402336" y="301752"/>
-            <a:ext cx="8348472" cy="795528"/>
+            <a:off x="603504" y="1847088"/>
+            <a:ext cx="7946136" cy="1399032"/>
           </a:xfrm>
           <a:prstGeom prst="rect">
             <a:avLst/>
@@ -4536,71 +4682,24 @@
           <a:lstStyle/>
           <a:p>
             <a:r>
-              <a:rPr sz="2800" b="1">
-                <a:solidFill>
-                  <a:srgbClr val="0F0F0F"/>
-                </a:solidFill>
-                <a:latin typeface="Fira Sans"/>
-              </a:rPr>
-              <a:t>La fórmula de la regresión múltiple</a:t>
-            </a:r>
-          </a:p>
-        </p:txBody>
-      </p:sp>
-      <p:pic>
-        <p:nvPicPr>
-          <p:cNvPr id="4" name="Picture 3" descr="c4_01_formula_multiple.png"/>
-          <p:cNvPicPr>
-            <a:picLocks noChangeAspect="1"/>
-          </p:cNvPicPr>
-          <p:nvPr/>
-        </p:nvPicPr>
-        <p:blipFill>
-          <a:blip r:embed="rId2"/>
-          <a:stretch>
-            <a:fillRect/>
-          </a:stretch>
-        </p:blipFill>
-        <p:spPr>
-          <a:xfrm>
-            <a:off x="699515" y="1500263"/>
-            <a:ext cx="7744968" cy="2440154"/>
-          </a:xfrm>
-          <a:prstGeom prst="rect">
-            <a:avLst/>
-          </a:prstGeom>
-        </p:spPr>
-      </p:pic>
-      <p:sp>
-        <p:nvSpPr>
-          <p:cNvPr id="5" name="TextBox 4"/>
-          <p:cNvSpPr txBox="1"/>
-          <p:nvPr/>
-        </p:nvSpPr>
-        <p:spPr>
-          <a:xfrm>
-            <a:off x="704088" y="4434840"/>
-            <a:ext cx="7744968" cy="457200"/>
-          </a:xfrm>
-          <a:prstGeom prst="rect">
-            <a:avLst/>
-          </a:prstGeom>
-          <a:noFill/>
-        </p:spPr>
-        <p:txBody>
-          <a:bodyPr wrap="square">
-            <a:spAutoFit/>
-          </a:bodyPr>
-          <a:lstStyle/>
-          <a:p>
-            <a:r>
-              <a:rPr sz="1300" b="0">
-                <a:solidFill>
-                  <a:srgbClr val="333333"/>
-                </a:solidFill>
-                <a:latin typeface="Fira Sans"/>
-              </a:rPr>
-              <a:t>Cada coeficiente aísla el efecto de su variable: cuánto cambia la predicción por una unidad de esa x, manteniendo las demás constantes.</a:t>
+              <a:rPr sz="3400" b="1">
+                <a:solidFill>
+                  <a:srgbClr val="FFFFFF"/>
+                </a:solidFill>
+                <a:latin typeface="Fira Sans"/>
+              </a:rPr>
+              <a:t>Regresión múltiple</a:t>
+            </a:r>
+          </a:p>
+          <a:p>
+            <a:r>
+              <a:rPr sz="1800" b="0">
+                <a:solidFill>
+                  <a:srgbClr val="E0A437"/>
+                </a:solidFill>
+                <a:latin typeface="Fira Sans"/>
+              </a:rPr>
+              <a:t>El primer modelo con varias variables</a:t>
             </a:r>
           </a:p>
         </p:txBody>
@@ -4696,114 +4795,35 @@
                 </a:solidFill>
                 <a:latin typeface="Fira Sans"/>
               </a:rPr>
-              <a:t>La motorización, con dos variables</a:t>
-            </a:r>
-          </a:p>
-        </p:txBody>
-      </p:sp>
-      <p:sp>
-        <p:nvSpPr>
-          <p:cNvPr id="4" name="Rectangle 3"/>
-          <p:cNvSpPr/>
-          <p:nvPr/>
-        </p:nvSpPr>
-        <p:spPr>
-          <a:xfrm>
-            <a:off x="704088" y="1280160"/>
-            <a:ext cx="7744968" cy="2880360"/>
-          </a:xfrm>
-          <a:prstGeom prst="rect">
-            <a:avLst/>
-          </a:prstGeom>
-          <a:solidFill>
-            <a:srgbClr val="F0F2F5"/>
-          </a:solidFill>
-          <a:ln>
-            <a:solidFill>
-              <a:srgbClr val="D8DDE3"/>
-            </a:solidFill>
-          </a:ln>
-          <a:effectLst/>
-        </p:spPr>
-        <p:style>
-          <a:lnRef idx="1">
-            <a:schemeClr val="accent1"/>
-          </a:lnRef>
-          <a:fillRef idx="3">
-            <a:schemeClr val="accent1"/>
-          </a:fillRef>
-          <a:effectRef idx="2">
-            <a:schemeClr val="accent1"/>
-          </a:effectRef>
-          <a:fontRef idx="minor">
-            <a:schemeClr val="lt1"/>
-          </a:fontRef>
-        </p:style>
-        <p:txBody>
-          <a:bodyPr rtlCol="0" anchor="ctr" wrap="square" lIns="228600" tIns="137160"/>
-          <a:lstStyle/>
-          <a:p>
-            <a:pPr/>
-            <a:r>
-              <a:rPr sz="1500" b="0">
-                <a:solidFill>
-                  <a:srgbClr val="1D3557"/>
-                </a:solidFill>
-                <a:latin typeface="Menlo"/>
-              </a:rPr>
-              <a:t># Explicar los vehículos del hogar con el ingreso y las personas</a:t>
-            </a:r>
-          </a:p>
-          <a:p>
-            <a:pPr/>
-            <a:r>
-              <a:rPr sz="1500" b="0">
-                <a:solidFill>
-                  <a:srgbClr val="1D3557"/>
-                </a:solidFill>
-                <a:latin typeface="Menlo"/>
-              </a:rPr>
-              <a:t>X = sm.add_constant(pd.DataFrame({</a:t>
-            </a:r>
-          </a:p>
-          <a:p>
-            <a:pPr/>
-            <a:r>
-              <a:rPr sz="1500" b="0">
-                <a:solidFill>
-                  <a:srgbClr val="1D3557"/>
-                </a:solidFill>
-                <a:latin typeface="Menlo"/>
-              </a:rPr>
-              <a:t>    "ingreso": h["IngresoHogar"] / 1e6,</a:t>
-            </a:r>
-          </a:p>
-          <a:p>
-            <a:pPr/>
-            <a:r>
-              <a:rPr sz="1500" b="0">
-                <a:solidFill>
-                  <a:srgbClr val="1D3557"/>
-                </a:solidFill>
-                <a:latin typeface="Menlo"/>
-              </a:rPr>
-              <a:t>    "personas": h["NumPer"]}))</a:t>
-            </a:r>
-          </a:p>
-          <a:p>
-            <a:pPr/>
-            <a:r>
-              <a:rPr sz="1500" b="0">
-                <a:solidFill>
-                  <a:srgbClr val="1D3557"/>
-                </a:solidFill>
-                <a:latin typeface="Menlo"/>
-              </a:rPr>
-              <a:t>modelo = sm.WLS(h["NumVeh"], X, weights=h["Factor"]).fit()</a:t>
-            </a:r>
-          </a:p>
-        </p:txBody>
-      </p:sp>
+              <a:t>La fórmula de la regresión múltiple</a:t>
+            </a:r>
+          </a:p>
+        </p:txBody>
+      </p:sp>
+      <p:pic>
+        <p:nvPicPr>
+          <p:cNvPr id="4" name="Picture 3" descr="c4_01_formula_multiple.png"/>
+          <p:cNvPicPr>
+            <a:picLocks noChangeAspect="1"/>
+          </p:cNvPicPr>
+          <p:nvPr/>
+        </p:nvPicPr>
+        <p:blipFill>
+          <a:blip r:embed="rId2"/>
+          <a:stretch>
+            <a:fillRect/>
+          </a:stretch>
+        </p:blipFill>
+        <p:spPr>
+          <a:xfrm>
+            <a:off x="699515" y="1500263"/>
+            <a:ext cx="7744968" cy="2440154"/>
+          </a:xfrm>
+          <a:prstGeom prst="rect">
+            <a:avLst/>
+          </a:prstGeom>
+        </p:spPr>
+      </p:pic>
       <p:sp>
         <p:nvSpPr>
           <p:cNvPr id="5" name="TextBox 4"/>
@@ -4812,8 +4832,8 @@
         </p:nvSpPr>
         <p:spPr>
           <a:xfrm>
-            <a:off x="704088" y="4389120"/>
-            <a:ext cx="7744968" cy="1097280"/>
+            <a:off x="704088" y="4434840"/>
+            <a:ext cx="7744968" cy="457200"/>
           </a:xfrm>
           <a:prstGeom prst="rect">
             <a:avLst/>
@@ -4826,31 +4846,14 @@
           </a:bodyPr>
           <a:lstStyle/>
           <a:p>
-            <a:pPr>
-              <a:lnSpc>
-                <a:spcPct val="112000"/>
-              </a:lnSpc>
-              <a:spcAft>
-                <a:spcPts val="900"/>
-              </a:spcAft>
-            </a:pPr>
-            <a:r>
-              <a:rPr sz="1600" b="1">
-                <a:solidFill>
-                  <a:srgbClr val="E0A437"/>
-                </a:solidFill>
-                <a:latin typeface="Fira Sans"/>
-              </a:rPr>
-              <a:t>▸ </a:t>
-            </a:r>
-            <a:r>
-              <a:rPr sz="1600" b="0">
-                <a:solidFill>
-                  <a:srgbClr val="000000"/>
-                </a:solidFill>
-                <a:latin typeface="Fira Sans"/>
-              </a:rPr>
-              <a:t>Ponderado: 0,48 vehículos por millón (era 0,50 a solas) y 0,03 por persona extra. El R² sube apenas, de 0,261 a 0,266: agregar variables no siempre aporta.</a:t>
+            <a:r>
+              <a:rPr sz="1300" b="0">
+                <a:solidFill>
+                  <a:srgbClr val="333333"/>
+                </a:solidFill>
+                <a:latin typeface="Fira Sans"/>
+              </a:rPr>
+              <a:t>Cada coeficiente aísla el efecto de su variable: cuánto cambia la predicción por una unidad de esa x, manteniendo las demás constantes.</a:t>
             </a:r>
           </a:p>
         </p:txBody>
@@ -4888,7 +4891,7 @@
             <a:avLst/>
           </a:prstGeom>
           <a:solidFill>
-            <a:srgbClr val="FAFBFC"/>
+            <a:srgbClr val="1D3557"/>
           </a:solidFill>
           <a:ln>
             <a:noFill/>
@@ -4925,8 +4928,8 @@
         </p:nvSpPr>
         <p:spPr>
           <a:xfrm>
-            <a:off x="402336" y="301752"/>
-            <a:ext cx="8348472" cy="795528"/>
+            <a:off x="603504" y="1847088"/>
+            <a:ext cx="7946136" cy="1399032"/>
           </a:xfrm>
           <a:prstGeom prst="rect">
             <a:avLst/>
@@ -4940,71 +4943,24 @@
           <a:lstStyle/>
           <a:p>
             <a:r>
-              <a:rPr sz="2800" b="1">
-                <a:solidFill>
-                  <a:srgbClr val="0F0F0F"/>
-                </a:solidFill>
-                <a:latin typeface="Fira Sans"/>
-              </a:rPr>
-              <a:t>La ecuación ajustada y su lectura</a:t>
-            </a:r>
-          </a:p>
-        </p:txBody>
-      </p:sp>
-      <p:pic>
-        <p:nvPicPr>
-          <p:cNvPr id="4" name="Picture 3" descr="c4_08_ecuacion_motorizacion.png"/>
-          <p:cNvPicPr>
-            <a:picLocks noChangeAspect="1"/>
-          </p:cNvPicPr>
-          <p:nvPr/>
-        </p:nvPicPr>
-        <p:blipFill>
-          <a:blip r:embed="rId2"/>
-          <a:stretch>
-            <a:fillRect/>
-          </a:stretch>
-        </p:blipFill>
-        <p:spPr>
-          <a:xfrm>
-            <a:off x="699515" y="1292657"/>
-            <a:ext cx="7744968" cy="2855366"/>
-          </a:xfrm>
-          <a:prstGeom prst="rect">
-            <a:avLst/>
-          </a:prstGeom>
-        </p:spPr>
-      </p:pic>
-      <p:sp>
-        <p:nvSpPr>
-          <p:cNvPr id="5" name="TextBox 4"/>
-          <p:cNvSpPr txBox="1"/>
-          <p:nvPr/>
-        </p:nvSpPr>
-        <p:spPr>
-          <a:xfrm>
-            <a:off x="704088" y="4434840"/>
-            <a:ext cx="7744968" cy="457200"/>
-          </a:xfrm>
-          <a:prstGeom prst="rect">
-            <a:avLst/>
-          </a:prstGeom>
-          <a:noFill/>
-        </p:spPr>
-        <p:txBody>
-          <a:bodyPr wrap="square">
-            <a:spAutoFit/>
-          </a:bodyPr>
-          <a:lstStyle/>
-          <a:p>
-            <a:r>
-              <a:rPr sz="1300" b="0">
-                <a:solidFill>
-                  <a:srgbClr val="333333"/>
-                </a:solidFill>
-                <a:latin typeface="Fira Sans"/>
-              </a:rPr>
-              <a:t>La fórmula de la múltiple con nuestros números: cada coeficiente se lee con las demás variables fijas.</a:t>
+              <a:rPr sz="3400" b="1">
+                <a:solidFill>
+                  <a:srgbClr val="FFFFFF"/>
+                </a:solidFill>
+                <a:latin typeface="Fira Sans"/>
+              </a:rPr>
+              <a:t>¿Mejora el modelo si agregamos el tamaño del hogar?</a:t>
+            </a:r>
+          </a:p>
+          <a:p>
+            <a:r>
+              <a:rPr sz="1800" b="0">
+                <a:solidFill>
+                  <a:srgbClr val="E0A437"/>
+                </a:solidFill>
+                <a:latin typeface="Fira Sans"/>
+              </a:rPr>
+              <a:t>Explicar los vehículos con el ingreso y las personas: la primera regresión múltiple</a:t>
             </a:r>
           </a:p>
         </p:txBody>
@@ -5359,35 +5315,114 @@
                 </a:solidFill>
                 <a:latin typeface="Fira Sans"/>
               </a:rPr>
-              <a:t>Leer el modelo: R²</a:t>
-            </a:r>
-          </a:p>
-        </p:txBody>
-      </p:sp>
-      <p:pic>
-        <p:nvPicPr>
-          <p:cNvPr id="4" name="Picture 3" descr="c4_04_formula_r2.png"/>
-          <p:cNvPicPr>
-            <a:picLocks noChangeAspect="1"/>
-          </p:cNvPicPr>
-          <p:nvPr/>
-        </p:nvPicPr>
-        <p:blipFill>
-          <a:blip r:embed="rId2"/>
-          <a:stretch>
-            <a:fillRect/>
-          </a:stretch>
-        </p:blipFill>
-        <p:spPr>
-          <a:xfrm>
-            <a:off x="699515" y="1297266"/>
-            <a:ext cx="7744968" cy="2846146"/>
-          </a:xfrm>
-          <a:prstGeom prst="rect">
-            <a:avLst/>
-          </a:prstGeom>
-        </p:spPr>
-      </p:pic>
+              <a:t>La motorización, con dos variables</a:t>
+            </a:r>
+          </a:p>
+        </p:txBody>
+      </p:sp>
+      <p:sp>
+        <p:nvSpPr>
+          <p:cNvPr id="4" name="Rectangle 3"/>
+          <p:cNvSpPr/>
+          <p:nvPr/>
+        </p:nvSpPr>
+        <p:spPr>
+          <a:xfrm>
+            <a:off x="704088" y="1280160"/>
+            <a:ext cx="7744968" cy="2880360"/>
+          </a:xfrm>
+          <a:prstGeom prst="rect">
+            <a:avLst/>
+          </a:prstGeom>
+          <a:solidFill>
+            <a:srgbClr val="F0F2F5"/>
+          </a:solidFill>
+          <a:ln>
+            <a:solidFill>
+              <a:srgbClr val="D8DDE3"/>
+            </a:solidFill>
+          </a:ln>
+          <a:effectLst/>
+        </p:spPr>
+        <p:style>
+          <a:lnRef idx="1">
+            <a:schemeClr val="accent1"/>
+          </a:lnRef>
+          <a:fillRef idx="3">
+            <a:schemeClr val="accent1"/>
+          </a:fillRef>
+          <a:effectRef idx="2">
+            <a:schemeClr val="accent1"/>
+          </a:effectRef>
+          <a:fontRef idx="minor">
+            <a:schemeClr val="lt1"/>
+          </a:fontRef>
+        </p:style>
+        <p:txBody>
+          <a:bodyPr rtlCol="0" anchor="ctr" wrap="square" lIns="228600" tIns="137160"/>
+          <a:lstStyle/>
+          <a:p>
+            <a:pPr/>
+            <a:r>
+              <a:rPr sz="1500" b="0">
+                <a:solidFill>
+                  <a:srgbClr val="1D3557"/>
+                </a:solidFill>
+                <a:latin typeface="Menlo"/>
+              </a:rPr>
+              <a:t># Explicar los vehículos del hogar con el ingreso y las personas</a:t>
+            </a:r>
+          </a:p>
+          <a:p>
+            <a:pPr/>
+            <a:r>
+              <a:rPr sz="1500" b="0">
+                <a:solidFill>
+                  <a:srgbClr val="1D3557"/>
+                </a:solidFill>
+                <a:latin typeface="Menlo"/>
+              </a:rPr>
+              <a:t>X = sm.add_constant(pd.DataFrame({</a:t>
+            </a:r>
+          </a:p>
+          <a:p>
+            <a:pPr/>
+            <a:r>
+              <a:rPr sz="1500" b="0">
+                <a:solidFill>
+                  <a:srgbClr val="1D3557"/>
+                </a:solidFill>
+                <a:latin typeface="Menlo"/>
+              </a:rPr>
+              <a:t>    "ingreso": h["IngresoHogar"] / 1e6,</a:t>
+            </a:r>
+          </a:p>
+          <a:p>
+            <a:pPr/>
+            <a:r>
+              <a:rPr sz="1500" b="0">
+                <a:solidFill>
+                  <a:srgbClr val="1D3557"/>
+                </a:solidFill>
+                <a:latin typeface="Menlo"/>
+              </a:rPr>
+              <a:t>    "personas": h["NumPer"]}))</a:t>
+            </a:r>
+          </a:p>
+          <a:p>
+            <a:pPr/>
+            <a:r>
+              <a:rPr sz="1500" b="0">
+                <a:solidFill>
+                  <a:srgbClr val="1D3557"/>
+                </a:solidFill>
+                <a:latin typeface="Menlo"/>
+              </a:rPr>
+              <a:t>modelo = sm.WLS(h["NumVeh"], X, weights=h["Factor"]).fit()</a:t>
+            </a:r>
+          </a:p>
+        </p:txBody>
+      </p:sp>
       <p:sp>
         <p:nvSpPr>
           <p:cNvPr id="5" name="TextBox 4"/>
@@ -5396,8 +5431,8 @@
         </p:nvSpPr>
         <p:spPr>
           <a:xfrm>
-            <a:off x="704088" y="4434840"/>
-            <a:ext cx="7744968" cy="457200"/>
+            <a:off x="704088" y="4389120"/>
+            <a:ext cx="7744968" cy="1097280"/>
           </a:xfrm>
           <a:prstGeom prst="rect">
             <a:avLst/>
@@ -5410,14 +5445,31 @@
           </a:bodyPr>
           <a:lstStyle/>
           <a:p>
-            <a:r>
-              <a:rPr sz="1300" b="0">
-                <a:solidFill>
-                  <a:srgbClr val="333333"/>
-                </a:solidFill>
-                <a:latin typeface="Fira Sans"/>
-              </a:rPr>
-              <a:t>Nuestro 0,266: ingreso y personas explican un cuarto de la variabilidad de los vehículos entre hogares. Agregar variables nunca baja el R²; por eso no basta con mirarlo.</a:t>
+            <a:pPr>
+              <a:lnSpc>
+                <a:spcPct val="112000"/>
+              </a:lnSpc>
+              <a:spcAft>
+                <a:spcPts val="900"/>
+              </a:spcAft>
+            </a:pPr>
+            <a:r>
+              <a:rPr sz="1600" b="1">
+                <a:solidFill>
+                  <a:srgbClr val="E0A437"/>
+                </a:solidFill>
+                <a:latin typeface="Fira Sans"/>
+              </a:rPr>
+              <a:t>▸ </a:t>
+            </a:r>
+            <a:r>
+              <a:rPr sz="1600" b="0">
+                <a:solidFill>
+                  <a:srgbClr val="000000"/>
+                </a:solidFill>
+                <a:latin typeface="Fira Sans"/>
+              </a:rPr>
+              <a:t>Ponderado: 0,48 vehículos por millón (era 0,50 a solas) y 0,03 por persona extra. El R² sube apenas, de 0,261 a 0,266: agregar variables no siempre aporta.</a:t>
             </a:r>
           </a:p>
         </p:txBody>
@@ -5513,14 +5565,14 @@
                 </a:solidFill>
                 <a:latin typeface="Fira Sans"/>
               </a:rPr>
-              <a:t>El valor p: dónde vive</a:t>
+              <a:t>La ecuación ajustada y su lectura</a:t>
             </a:r>
           </a:p>
         </p:txBody>
       </p:sp>
       <p:pic>
         <p:nvPicPr>
-          <p:cNvPr id="4" name="Picture 3" descr="c4_07_pvalue_summary.png"/>
+          <p:cNvPr id="4" name="Picture 3" descr="c4_08_ecuacion_motorizacion.png"/>
           <p:cNvPicPr>
             <a:picLocks noChangeAspect="1"/>
           </p:cNvPicPr>
@@ -5534,8 +5586,8 @@
         </p:blipFill>
         <p:spPr>
           <a:xfrm>
-            <a:off x="699515" y="1504912"/>
-            <a:ext cx="7744968" cy="2430856"/>
+            <a:off x="699515" y="1292657"/>
+            <a:ext cx="7744968" cy="2855366"/>
           </a:xfrm>
           <a:prstGeom prst="rect">
             <a:avLst/>
@@ -5571,7 +5623,7 @@
                 </a:solidFill>
                 <a:latin typeface="Fira Sans"/>
               </a:rPr>
-              <a:t>La pregunta que responde P&gt;|t|: si el efecto real fuera cero, ¿qué tan raro sería este coeficiente por azar? Aquí ambos dan 0,000. Ojo: con n grande hasta lo minúsculo es significativo; la clase 5 lo formaliza.</a:t>
+              <a:t>La fórmula de la múltiple con nuestros números: cada coeficiente se lee con las demás variables fijas.</a:t>
             </a:r>
           </a:p>
         </p:txBody>
@@ -5667,14 +5719,14 @@
                 </a:solidFill>
                 <a:latin typeface="Fira Sans"/>
               </a:rPr>
-              <a:t>El mapa para elegir variables</a:t>
+              <a:t>Leer el modelo: R²</a:t>
             </a:r>
           </a:p>
         </p:txBody>
       </p:sp>
       <p:pic>
         <p:nvPicPr>
-          <p:cNvPr id="4" name="Picture 3" descr="c4_05_mapa_candidatas.png"/>
+          <p:cNvPr id="4" name="Picture 3" descr="c4_04_formula_r2.png"/>
           <p:cNvPicPr>
             <a:picLocks noChangeAspect="1"/>
           </p:cNvPicPr>
@@ -5688,8 +5740,8 @@
         </p:blipFill>
         <p:spPr>
           <a:xfrm>
-            <a:off x="2530736" y="1143000"/>
-            <a:ext cx="4082527" cy="3154680"/>
+            <a:off x="699515" y="1297266"/>
+            <a:ext cx="7744968" cy="2846146"/>
           </a:xfrm>
           <a:prstGeom prst="rect">
             <a:avLst/>
@@ -5725,7 +5777,7 @@
                 </a:solidFill>
                 <a:latin typeface="Fira Sans"/>
               </a:rPr>
-              <a:t>La fila de NumVeh es el mapa: ingreso 0,47 es el motor; las bicicletas casi no correlacionan con los vehículos (0,06) y son redundantes entre sí (0,83). Probarlas confirma: R² 0,266 a 0,267.</a:t>
+              <a:t>Nuestro 0,266: ingreso y personas explican un cuarto de la variabilidad de los vehículos entre hogares. Agregar variables nunca baja el R²; por eso no basta con mirarlo.</a:t>
             </a:r>
           </a:p>
         </p:txBody>
@@ -5821,114 +5873,35 @@
                 </a:solidFill>
                 <a:latin typeface="Fira Sans"/>
               </a:rPr>
-              <a:t>Una categórica entra como dummies</a:t>
-            </a:r>
-          </a:p>
-        </p:txBody>
-      </p:sp>
-      <p:sp>
-        <p:nvSpPr>
-          <p:cNvPr id="4" name="Rectangle 3"/>
-          <p:cNvSpPr/>
-          <p:nvPr/>
-        </p:nvSpPr>
-        <p:spPr>
-          <a:xfrm>
-            <a:off x="704088" y="1280160"/>
-            <a:ext cx="7744968" cy="2880360"/>
-          </a:xfrm>
-          <a:prstGeom prst="rect">
-            <a:avLst/>
-          </a:prstGeom>
-          <a:solidFill>
-            <a:srgbClr val="F0F2F5"/>
-          </a:solidFill>
-          <a:ln>
-            <a:solidFill>
-              <a:srgbClr val="D8DDE3"/>
-            </a:solidFill>
-          </a:ln>
-          <a:effectLst/>
-        </p:spPr>
-        <p:style>
-          <a:lnRef idx="1">
-            <a:schemeClr val="accent1"/>
-          </a:lnRef>
-          <a:fillRef idx="3">
-            <a:schemeClr val="accent1"/>
-          </a:fillRef>
-          <a:effectRef idx="2">
-            <a:schemeClr val="accent1"/>
-          </a:effectRef>
-          <a:fontRef idx="minor">
-            <a:schemeClr val="lt1"/>
-          </a:fontRef>
-        </p:style>
-        <p:txBody>
-          <a:bodyPr rtlCol="0" anchor="ctr" wrap="square" lIns="228600" tIns="137160"/>
-          <a:lstStyle/>
-          <a:p>
-            <a:pPr/>
-            <a:r>
-              <a:rPr sz="1500" b="0">
-                <a:solidFill>
-                  <a:srgbClr val="1D3557"/>
-                </a:solidFill>
-                <a:latin typeface="Menlo"/>
-              </a:rPr>
-              <a:t># Una columna 0/1 por modo; el auto queda de referencia</a:t>
-            </a:r>
-          </a:p>
-          <a:p>
-            <a:pPr/>
-            <a:r>
-              <a:rPr sz="1500" b="0">
-                <a:solidFill>
-                  <a:srgbClr val="1D3557"/>
-                </a:solidFill>
-                <a:latin typeface="Menlo"/>
-              </a:rPr>
-              <a:t>dummies = pd.get_dummies(viajes["ModoAgrupado"])</a:t>
-            </a:r>
-          </a:p>
-          <a:p>
-            <a:pPr/>
-            <a:r>
-              <a:rPr sz="1500" b="0">
-                <a:solidFill>
-                  <a:srgbClr val="1D3557"/>
-                </a:solidFill>
-                <a:latin typeface="Menlo"/>
-              </a:rPr>
-              <a:t>dummies = dummies.drop(columns=["Auto"])</a:t>
-            </a:r>
-          </a:p>
-          <a:p>
-            <a:pPr/>
-            <a:r>
-              <a:rPr sz="1500" b="0">
-                <a:solidFill>
-                  <a:srgbClr val="1D3557"/>
-                </a:solidFill>
-                <a:latin typeface="Menlo"/>
-              </a:rPr>
-              <a:t/>
-            </a:r>
-          </a:p>
-          <a:p>
-            <a:pPr/>
-            <a:r>
-              <a:rPr sz="1500" b="0">
-                <a:solidFill>
-                  <a:srgbClr val="1D3557"/>
-                </a:solidFill>
-                <a:latin typeface="Menlo"/>
-              </a:rPr>
-              <a:t># Explicar la duración (log) con la distancia (log) y el modo</a:t>
-            </a:r>
-          </a:p>
-        </p:txBody>
-      </p:sp>
+              <a:t>El valor p: dónde vive</a:t>
+            </a:r>
+          </a:p>
+        </p:txBody>
+      </p:sp>
+      <p:pic>
+        <p:nvPicPr>
+          <p:cNvPr id="4" name="Picture 3" descr="c4_07_pvalue_summary.png"/>
+          <p:cNvPicPr>
+            <a:picLocks noChangeAspect="1"/>
+          </p:cNvPicPr>
+          <p:nvPr/>
+        </p:nvPicPr>
+        <p:blipFill>
+          <a:blip r:embed="rId2"/>
+          <a:stretch>
+            <a:fillRect/>
+          </a:stretch>
+        </p:blipFill>
+        <p:spPr>
+          <a:xfrm>
+            <a:off x="699515" y="1504912"/>
+            <a:ext cx="7744968" cy="2430856"/>
+          </a:xfrm>
+          <a:prstGeom prst="rect">
+            <a:avLst/>
+          </a:prstGeom>
+        </p:spPr>
+      </p:pic>
       <p:sp>
         <p:nvSpPr>
           <p:cNvPr id="5" name="TextBox 4"/>
@@ -5937,8 +5910,8 @@
         </p:nvSpPr>
         <p:spPr>
           <a:xfrm>
-            <a:off x="704088" y="4389120"/>
-            <a:ext cx="7744968" cy="1097280"/>
+            <a:off x="704088" y="4434840"/>
+            <a:ext cx="7744968" cy="457200"/>
           </a:xfrm>
           <a:prstGeom prst="rect">
             <a:avLst/>
@@ -5951,31 +5924,14 @@
           </a:bodyPr>
           <a:lstStyle/>
           <a:p>
-            <a:pPr>
-              <a:lnSpc>
-                <a:spcPct val="112000"/>
-              </a:lnSpc>
-              <a:spcAft>
-                <a:spcPts val="900"/>
-              </a:spcAft>
-            </a:pPr>
-            <a:r>
-              <a:rPr sz="1600" b="1">
-                <a:solidFill>
-                  <a:srgbClr val="E0A437"/>
-                </a:solidFill>
-                <a:latin typeface="Fira Sans"/>
-              </a:rPr>
-              <a:t>▸ </a:t>
-            </a:r>
-            <a:r>
-              <a:rPr sz="1600" b="0">
-                <a:solidFill>
-                  <a:srgbClr val="000000"/>
-                </a:solidFill>
-                <a:latin typeface="Fira Sans"/>
-              </a:rPr>
-              <a:t>Cada coeficiente se lee comparado con la referencia: qué le pasa al tiempo de un viaje por ser en ese modo y no en auto, a igual distancia.</a:t>
+            <a:r>
+              <a:rPr sz="1300" b="0">
+                <a:solidFill>
+                  <a:srgbClr val="333333"/>
+                </a:solidFill>
+                <a:latin typeface="Fira Sans"/>
+              </a:rPr>
+              <a:t>Para cada variable, P&gt;|t| responde: si en la ciudad el ingreso (o las personas) no tuviera efecto alguno sobre los vehículos, ¿qué tan raro sería este coeficiente solo por azar de la muestra? Ambos dan 0,000; la clase 5 lo formaliza.</a:t>
             </a:r>
           </a:p>
         </p:txBody>
@@ -6071,14 +6027,14 @@
                 </a:solidFill>
                 <a:latin typeface="Fira Sans"/>
               </a:rPr>
-              <a:t>El resultado: distancia y modo</a:t>
+              <a:t>El mapa para elegir variables</a:t>
             </a:r>
           </a:p>
         </p:txBody>
       </p:sp>
       <p:pic>
         <p:nvPicPr>
-          <p:cNvPr id="4" name="Picture 3" descr="c4_03_coef_modo.png"/>
+          <p:cNvPr id="4" name="Picture 3" descr="c4_05_mapa_candidatas.png"/>
           <p:cNvPicPr>
             <a:picLocks noChangeAspect="1"/>
           </p:cNvPicPr>
@@ -6092,8 +6048,8 @@
         </p:blipFill>
         <p:spPr>
           <a:xfrm>
-            <a:off x="804842" y="1143000"/>
-            <a:ext cx="7534315" cy="3154680"/>
+            <a:off x="2530736" y="1143000"/>
+            <a:ext cx="4082527" cy="3154680"/>
           </a:xfrm>
           <a:prstGeom prst="rect">
             <a:avLst/>
@@ -6129,7 +6085,7 @@
                 </a:solidFill>
                 <a:latin typeface="Fira Sans"/>
               </a:rPr>
-              <a:t>A igual distancia, un viaje en Bip! tarda 1,87 veces lo que uno en auto; taxi y caminata quedan casi iguales al auto. El R² sube de 0,53 a 0,60.</a:t>
+              <a:t>La fila de NumVeh es el mapa: ingreso 0,47 es el motor; las bicicletas casi no correlacionan con los vehículos (0,06) y son redundantes entre sí (0,83). Probarlas confirma: R² 0,266 a 0,267.</a:t>
             </a:r>
           </a:p>
         </p:txBody>
@@ -6225,14 +6181,14 @@
                 </a:solidFill>
                 <a:latin typeface="Fira Sans"/>
               </a:rPr>
-              <a:t>La ecuación de la duración, leída</a:t>
+              <a:t>Los coeficientes al agregar variables</a:t>
             </a:r>
           </a:p>
         </p:txBody>
       </p:sp>
       <p:pic>
         <p:nvPicPr>
-          <p:cNvPr id="4" name="Picture 3" descr="c4_09_ecuacion_duracion.png"/>
+          <p:cNvPr id="4" name="Picture 3" descr="c4_10_cambio_coeficientes.png"/>
           <p:cNvPicPr>
             <a:picLocks noChangeAspect="1"/>
           </p:cNvPicPr>
@@ -6246,8 +6202,8 @@
         </p:blipFill>
         <p:spPr>
           <a:xfrm>
-            <a:off x="699515" y="1320746"/>
-            <a:ext cx="7744968" cy="2799186"/>
+            <a:off x="1051559" y="1143000"/>
+            <a:ext cx="7040880" cy="3154680"/>
           </a:xfrm>
           <a:prstGeom prst="rect">
             <a:avLst/>
@@ -6283,7 +6239,7 @@
                 </a:solidFill>
                 <a:latin typeface="Fira Sans"/>
               </a:rPr>
-              <a:t>La misma tabla de coeficientes, escrita como ecuación: en escala log los efectos multiplican en vez de sumar.</a:t>
+              <a:t>El ingreso apenas se mueve (0,50 a 0,48) al agregar personas y bicicletas: es un efecto robusto. Las variables nuevas entran con coeficientes minúsculos y el R² casi no cambia.</a:t>
             </a:r>
           </a:p>
         </p:txBody>
@@ -6379,21 +6335,124 @@
                 </a:solidFill>
                 <a:latin typeface="Fira Sans"/>
               </a:rPr>
-              <a:t>Síntesis</a:t>
-            </a:r>
-          </a:p>
-        </p:txBody>
-      </p:sp>
-      <p:sp>
-        <p:nvSpPr>
-          <p:cNvPr id="4" name="TextBox 3"/>
+              <a:t>Una categórica entra como dummies</a:t>
+            </a:r>
+          </a:p>
+        </p:txBody>
+      </p:sp>
+      <p:sp>
+        <p:nvSpPr>
+          <p:cNvPr id="4" name="Rectangle 3"/>
+          <p:cNvSpPr/>
+          <p:nvPr/>
+        </p:nvSpPr>
+        <p:spPr>
+          <a:xfrm>
+            <a:off x="704088" y="1280160"/>
+            <a:ext cx="7744968" cy="2880360"/>
+          </a:xfrm>
+          <a:prstGeom prst="rect">
+            <a:avLst/>
+          </a:prstGeom>
+          <a:solidFill>
+            <a:srgbClr val="F0F2F5"/>
+          </a:solidFill>
+          <a:ln>
+            <a:solidFill>
+              <a:srgbClr val="D8DDE3"/>
+            </a:solidFill>
+          </a:ln>
+          <a:effectLst/>
+        </p:spPr>
+        <p:style>
+          <a:lnRef idx="1">
+            <a:schemeClr val="accent1"/>
+          </a:lnRef>
+          <a:fillRef idx="3">
+            <a:schemeClr val="accent1"/>
+          </a:fillRef>
+          <a:effectRef idx="2">
+            <a:schemeClr val="accent1"/>
+          </a:effectRef>
+          <a:fontRef idx="minor">
+            <a:schemeClr val="lt1"/>
+          </a:fontRef>
+        </p:style>
+        <p:txBody>
+          <a:bodyPr rtlCol="0" anchor="ctr" wrap="square" lIns="228600" tIns="137160"/>
+          <a:lstStyle/>
+          <a:p>
+            <a:pPr/>
+            <a:r>
+              <a:rPr sz="1500" b="0">
+                <a:solidFill>
+                  <a:srgbClr val="1D3557"/>
+                </a:solidFill>
+                <a:latin typeface="Menlo"/>
+              </a:rPr>
+              <a:t># Una columna 0/1 por modo; el auto queda de referencia</a:t>
+            </a:r>
+          </a:p>
+          <a:p>
+            <a:pPr/>
+            <a:r>
+              <a:rPr sz="1500" b="0">
+                <a:solidFill>
+                  <a:srgbClr val="1D3557"/>
+                </a:solidFill>
+                <a:latin typeface="Menlo"/>
+              </a:rPr>
+              <a:t>dummies = pd.get_dummies(viajes["ModoAgrupado"])</a:t>
+            </a:r>
+          </a:p>
+          <a:p>
+            <a:pPr/>
+            <a:r>
+              <a:rPr sz="1500" b="0">
+                <a:solidFill>
+                  <a:srgbClr val="1D3557"/>
+                </a:solidFill>
+                <a:latin typeface="Menlo"/>
+              </a:rPr>
+              <a:t>dummies = dummies.drop(columns=["Auto"])</a:t>
+            </a:r>
+          </a:p>
+          <a:p>
+            <a:pPr/>
+            <a:r>
+              <a:rPr sz="1500" b="0">
+                <a:solidFill>
+                  <a:srgbClr val="1D3557"/>
+                </a:solidFill>
+                <a:latin typeface="Menlo"/>
+              </a:rPr>
+              <a:t/>
+            </a:r>
+          </a:p>
+          <a:p>
+            <a:pPr/>
+            <a:r>
+              <a:rPr sz="1500" b="0">
+                <a:solidFill>
+                  <a:srgbClr val="1D3557"/>
+                </a:solidFill>
+                <a:latin typeface="Menlo"/>
+              </a:rPr>
+              <a:t># Explicar la duración (log) con la distancia (log) y el modo</a:t>
+            </a:r>
+          </a:p>
+        </p:txBody>
+      </p:sp>
+      <p:sp>
+        <p:nvSpPr>
+          <p:cNvPr id="5" name="TextBox 4"/>
           <p:cNvSpPr txBox="1"/>
           <p:nvPr/>
         </p:nvSpPr>
         <p:spPr>
           <a:xfrm>
-            <a:off x="704088" y="1353312"/>
-            <a:ext cx="7744968" cy="3300984"/>
+            <a:off x="704088" y="4389120"/>
+            <a:ext cx="7744968" cy="1097280"/>
           </a:xfrm>
           <a:prstGeom prst="rect">
             <a:avLst/>
@@ -6415,7 +6474,7 @@
               </a:spcAft>
             </a:pPr>
             <a:r>
-              <a:rPr sz="1800" b="1">
+              <a:rPr sz="1600" b="1">
                 <a:solidFill>
                   <a:srgbClr val="E0A437"/>
                 </a:solidFill>
@@ -6424,125 +6483,13 @@
               <a:t>▸ </a:t>
             </a:r>
             <a:r>
-              <a:rPr sz="1800" b="0">
+              <a:rPr sz="1600" b="0">
                 <a:solidFill>
                   <a:srgbClr val="000000"/>
                 </a:solidFill>
                 <a:latin typeface="Fira Sans"/>
               </a:rPr>
-              <a:t>El impacto de filas y atípicos se mide con y sin, sobre todos los resúmenes en uso.</a:t>
-            </a:r>
-          </a:p>
-          <a:p>
-            <a:pPr>
-              <a:lnSpc>
-                <a:spcPct val="112000"/>
-              </a:lnSpc>
-              <a:spcAft>
-                <a:spcPts val="900"/>
-              </a:spcAft>
-            </a:pPr>
-            <a:r>
-              <a:rPr sz="1800" b="1">
-                <a:solidFill>
-                  <a:srgbClr val="E0A437"/>
-                </a:solidFill>
-                <a:latin typeface="Fira Sans"/>
-              </a:rPr>
-              <a:t>▸ </a:t>
-            </a:r>
-            <a:r>
-              <a:rPr sz="1800" b="0">
-                <a:solidFill>
-                  <a:srgbClr val="000000"/>
-                </a:solidFill>
-                <a:latin typeface="Fira Sans"/>
-              </a:rPr>
-              <a:t>Cuando la conclusión es sobre la ciudad, se pondera: WLS.</a:t>
-            </a:r>
-          </a:p>
-          <a:p>
-            <a:pPr>
-              <a:lnSpc>
-                <a:spcPct val="112000"/>
-              </a:lnSpc>
-              <a:spcAft>
-                <a:spcPts val="900"/>
-              </a:spcAft>
-            </a:pPr>
-            <a:r>
-              <a:rPr sz="1800" b="1">
-                <a:solidFill>
-                  <a:srgbClr val="E0A437"/>
-                </a:solidFill>
-                <a:latin typeface="Fira Sans"/>
-              </a:rPr>
-              <a:t>▸ </a:t>
-            </a:r>
-            <a:r>
-              <a:rPr sz="1800" b="0">
-                <a:solidFill>
-                  <a:srgbClr val="000000"/>
-                </a:solidFill>
-                <a:latin typeface="Fira Sans"/>
-              </a:rPr>
-              <a:t>Muchos puntos: alpha o hexbin. Colas largas: log.</a:t>
-            </a:r>
-          </a:p>
-          <a:p>
-            <a:pPr>
-              <a:lnSpc>
-                <a:spcPct val="112000"/>
-              </a:lnSpc>
-              <a:spcAft>
-                <a:spcPts val="900"/>
-              </a:spcAft>
-            </a:pPr>
-            <a:r>
-              <a:rPr sz="1800" b="1">
-                <a:solidFill>
-                  <a:srgbClr val="E0A437"/>
-                </a:solidFill>
-                <a:latin typeface="Fira Sans"/>
-              </a:rPr>
-              <a:t>▸ </a:t>
-            </a:r>
-            <a:r>
-              <a:rPr sz="1800" b="0">
-                <a:solidFill>
-                  <a:srgbClr val="000000"/>
-                </a:solidFill>
-                <a:latin typeface="Fira Sans"/>
-              </a:rPr>
-              <a:t>La múltiple aísla el efecto de cada variable (categóricas como dummies); R² dice cuánto explica y el valor p si un coeficiente se distingue del azar.</a:t>
-            </a:r>
-          </a:p>
-          <a:p>
-            <a:pPr>
-              <a:lnSpc>
-                <a:spcPct val="112000"/>
-              </a:lnSpc>
-              <a:spcAft>
-                <a:spcPts val="900"/>
-              </a:spcAft>
-            </a:pPr>
-            <a:r>
-              <a:rPr sz="1800" b="1">
-                <a:solidFill>
-                  <a:srgbClr val="E0A437"/>
-                </a:solidFill>
-                <a:latin typeface="Fira Sans"/>
-              </a:rPr>
-              <a:t>▸ </a:t>
-            </a:r>
-            <a:r>
-              <a:rPr sz="1800" b="1">
-                <a:solidFill>
-                  <a:srgbClr val="1D3557"/>
-                </a:solidFill>
-                <a:latin typeface="Fira Sans"/>
-              </a:rPr>
-              <a:t>El primer EDA del proyecto usa exactamente estas herramientas (entrega: lunes 15).</a:t>
+              <a:t>Cada coeficiente se lee comparado con la referencia: qué le pasa al tiempo de un viaje por ser en ese modo y no en auto, a igual distancia.</a:t>
             </a:r>
           </a:p>
         </p:txBody>
@@ -6580,7 +6527,7 @@
             <a:avLst/>
           </a:prstGeom>
           <a:solidFill>
-            <a:srgbClr val="1D3557"/>
+            <a:srgbClr val="FAFBFC"/>
           </a:solidFill>
           <a:ln>
             <a:noFill/>
@@ -6617,8 +6564,8 @@
         </p:nvSpPr>
         <p:spPr>
           <a:xfrm>
-            <a:off x="603504" y="1847088"/>
-            <a:ext cx="7946136" cy="1399032"/>
+            <a:off x="402336" y="301752"/>
+            <a:ext cx="8348472" cy="795528"/>
           </a:xfrm>
           <a:prstGeom prst="rect">
             <a:avLst/>
@@ -6632,24 +6579,71 @@
           <a:lstStyle/>
           <a:p>
             <a:r>
-              <a:rPr sz="3400" b="1">
-                <a:solidFill>
-                  <a:srgbClr val="FFFFFF"/>
-                </a:solidFill>
-                <a:latin typeface="Fira Sans"/>
-              </a:rPr>
-              <a:t>Recreo</a:t>
-            </a:r>
-          </a:p>
-          <a:p>
-            <a:r>
-              <a:rPr sz="1800" b="0">
-                <a:solidFill>
-                  <a:srgbClr val="E0A437"/>
-                </a:solidFill>
-                <a:latin typeface="Fira Sans"/>
-              </a:rPr>
-              <a:t>10 minutos · al volver: las presentaciones de ideas</a:t>
+              <a:rPr sz="2800" b="1">
+                <a:solidFill>
+                  <a:srgbClr val="0F0F0F"/>
+                </a:solidFill>
+                <a:latin typeface="Fira Sans"/>
+              </a:rPr>
+              <a:t>El resultado: distancia y modo</a:t>
+            </a:r>
+          </a:p>
+        </p:txBody>
+      </p:sp>
+      <p:pic>
+        <p:nvPicPr>
+          <p:cNvPr id="4" name="Picture 3" descr="c4_03_coef_modo.png"/>
+          <p:cNvPicPr>
+            <a:picLocks noChangeAspect="1"/>
+          </p:cNvPicPr>
+          <p:nvPr/>
+        </p:nvPicPr>
+        <p:blipFill>
+          <a:blip r:embed="rId2"/>
+          <a:stretch>
+            <a:fillRect/>
+          </a:stretch>
+        </p:blipFill>
+        <p:spPr>
+          <a:xfrm>
+            <a:off x="804842" y="1143000"/>
+            <a:ext cx="7534315" cy="3154680"/>
+          </a:xfrm>
+          <a:prstGeom prst="rect">
+            <a:avLst/>
+          </a:prstGeom>
+        </p:spPr>
+      </p:pic>
+      <p:sp>
+        <p:nvSpPr>
+          <p:cNvPr id="5" name="TextBox 4"/>
+          <p:cNvSpPr txBox="1"/>
+          <p:nvPr/>
+        </p:nvSpPr>
+        <p:spPr>
+          <a:xfrm>
+            <a:off x="704088" y="4434840"/>
+            <a:ext cx="7744968" cy="457200"/>
+          </a:xfrm>
+          <a:prstGeom prst="rect">
+            <a:avLst/>
+          </a:prstGeom>
+          <a:noFill/>
+        </p:spPr>
+        <p:txBody>
+          <a:bodyPr wrap="square">
+            <a:spAutoFit/>
+          </a:bodyPr>
+          <a:lstStyle/>
+          <a:p>
+            <a:r>
+              <a:rPr sz="1300" b="0">
+                <a:solidFill>
+                  <a:srgbClr val="333333"/>
+                </a:solidFill>
+                <a:latin typeface="Fira Sans"/>
+              </a:rPr>
+              <a:t>A igual distancia, un viaje en Bip! tarda 1,87 veces lo que uno en auto; taxi y caminata quedan casi iguales al auto. El R² sube de 0,53 a 0,60.</a:t>
             </a:r>
           </a:p>
         </p:txBody>
@@ -6687,7 +6681,7 @@
             <a:avLst/>
           </a:prstGeom>
           <a:solidFill>
-            <a:srgbClr val="1D3557"/>
+            <a:srgbClr val="FAFBFC"/>
           </a:solidFill>
           <a:ln>
             <a:noFill/>
@@ -6724,8 +6718,8 @@
         </p:nvSpPr>
         <p:spPr>
           <a:xfrm>
-            <a:off x="603504" y="1847088"/>
-            <a:ext cx="7946136" cy="1399032"/>
+            <a:off x="402336" y="301752"/>
+            <a:ext cx="8348472" cy="795528"/>
           </a:xfrm>
           <a:prstGeom prst="rect">
             <a:avLst/>
@@ -6739,24 +6733,71 @@
           <a:lstStyle/>
           <a:p>
             <a:r>
-              <a:rPr sz="3400" b="1">
-                <a:solidFill>
-                  <a:srgbClr val="FFFFFF"/>
-                </a:solidFill>
-                <a:latin typeface="Fira Sans"/>
-              </a:rPr>
-              <a:t>Presentaciones de ideas</a:t>
-            </a:r>
-          </a:p>
-          <a:p>
-            <a:r>
-              <a:rPr sz="1800" b="0">
-                <a:solidFill>
-                  <a:srgbClr val="E0A437"/>
-                </a:solidFill>
-                <a:latin typeface="Fira Sans"/>
-              </a:rPr>
-              <a:t>De 5 a 7 minutos por equipo, y preguntas de todos</a:t>
+              <a:rPr sz="2800" b="1">
+                <a:solidFill>
+                  <a:srgbClr val="0F0F0F"/>
+                </a:solidFill>
+                <a:latin typeface="Fira Sans"/>
+              </a:rPr>
+              <a:t>La ecuación de la duración, leída</a:t>
+            </a:r>
+          </a:p>
+        </p:txBody>
+      </p:sp>
+      <p:pic>
+        <p:nvPicPr>
+          <p:cNvPr id="4" name="Picture 3" descr="c4_09_ecuacion_duracion.png"/>
+          <p:cNvPicPr>
+            <a:picLocks noChangeAspect="1"/>
+          </p:cNvPicPr>
+          <p:nvPr/>
+        </p:nvPicPr>
+        <p:blipFill>
+          <a:blip r:embed="rId2"/>
+          <a:stretch>
+            <a:fillRect/>
+          </a:stretch>
+        </p:blipFill>
+        <p:spPr>
+          <a:xfrm>
+            <a:off x="699515" y="1320746"/>
+            <a:ext cx="7744968" cy="2799186"/>
+          </a:xfrm>
+          <a:prstGeom prst="rect">
+            <a:avLst/>
+          </a:prstGeom>
+        </p:spPr>
+      </p:pic>
+      <p:sp>
+        <p:nvSpPr>
+          <p:cNvPr id="5" name="TextBox 4"/>
+          <p:cNvSpPr txBox="1"/>
+          <p:nvPr/>
+        </p:nvSpPr>
+        <p:spPr>
+          <a:xfrm>
+            <a:off x="704088" y="4434840"/>
+            <a:ext cx="7744968" cy="457200"/>
+          </a:xfrm>
+          <a:prstGeom prst="rect">
+            <a:avLst/>
+          </a:prstGeom>
+          <a:noFill/>
+        </p:spPr>
+        <p:txBody>
+          <a:bodyPr wrap="square">
+            <a:spAutoFit/>
+          </a:bodyPr>
+          <a:lstStyle/>
+          <a:p>
+            <a:r>
+              <a:rPr sz="1300" b="0">
+                <a:solidFill>
+                  <a:srgbClr val="333333"/>
+                </a:solidFill>
+                <a:latin typeface="Fira Sans"/>
+              </a:rPr>
+              <a:t>La misma tabla de coeficientes, escrita como ecuación: en escala log los efectos multiplican en vez de sumar.</a:t>
             </a:r>
           </a:p>
         </p:txBody>
@@ -6852,7 +6893,7 @@
                 </a:solidFill>
                 <a:latin typeface="Fira Sans"/>
               </a:rPr>
-              <a:t>El formato</a:t>
+              <a:t>Síntesis</a:t>
             </a:r>
           </a:p>
         </p:txBody>
@@ -6897,13 +6938,13 @@
               <a:t>▸ </a:t>
             </a:r>
             <a:r>
-              <a:rPr sz="1800" b="1">
-                <a:solidFill>
-                  <a:srgbClr val="1D3557"/>
-                </a:solidFill>
-                <a:latin typeface="Fira Sans"/>
-              </a:rPr>
-              <a:t>Esta instancia no lleva nota: es para recibir retroalimentación temprano, cuando corregir cuesta poco.</a:t>
+              <a:rPr sz="1800" b="0">
+                <a:solidFill>
+                  <a:srgbClr val="000000"/>
+                </a:solidFill>
+                <a:latin typeface="Fira Sans"/>
+              </a:rPr>
+              <a:t>El impacto de filas y atípicos se mide con y sin, sobre todos los resúmenes en uso.</a:t>
             </a:r>
           </a:p>
           <a:p>
@@ -6931,7 +6972,91 @@
                 </a:solidFill>
                 <a:latin typeface="Fira Sans"/>
               </a:rPr>
-              <a:t>Después de cada equipo, preguntas y comentarios del curso.</a:t>
+              <a:t>Cuando la conclusión es sobre la ciudad, se pondera: WLS.</a:t>
+            </a:r>
+          </a:p>
+          <a:p>
+            <a:pPr>
+              <a:lnSpc>
+                <a:spcPct val="112000"/>
+              </a:lnSpc>
+              <a:spcAft>
+                <a:spcPts val="900"/>
+              </a:spcAft>
+            </a:pPr>
+            <a:r>
+              <a:rPr sz="1800" b="1">
+                <a:solidFill>
+                  <a:srgbClr val="E0A437"/>
+                </a:solidFill>
+                <a:latin typeface="Fira Sans"/>
+              </a:rPr>
+              <a:t>▸ </a:t>
+            </a:r>
+            <a:r>
+              <a:rPr sz="1800" b="0">
+                <a:solidFill>
+                  <a:srgbClr val="000000"/>
+                </a:solidFill>
+                <a:latin typeface="Fira Sans"/>
+              </a:rPr>
+              <a:t>Muchos puntos: alpha o hexbin. Colas largas: log.</a:t>
+            </a:r>
+          </a:p>
+          <a:p>
+            <a:pPr>
+              <a:lnSpc>
+                <a:spcPct val="112000"/>
+              </a:lnSpc>
+              <a:spcAft>
+                <a:spcPts val="900"/>
+              </a:spcAft>
+            </a:pPr>
+            <a:r>
+              <a:rPr sz="1800" b="1">
+                <a:solidFill>
+                  <a:srgbClr val="E0A437"/>
+                </a:solidFill>
+                <a:latin typeface="Fira Sans"/>
+              </a:rPr>
+              <a:t>▸ </a:t>
+            </a:r>
+            <a:r>
+              <a:rPr sz="1800" b="0">
+                <a:solidFill>
+                  <a:srgbClr val="000000"/>
+                </a:solidFill>
+                <a:latin typeface="Fira Sans"/>
+              </a:rPr>
+              <a:t>La múltiple aísla el efecto de cada variable (categóricas como dummies); R² dice cuánto explica y el valor p si un coeficiente se distingue del azar.</a:t>
+            </a:r>
+          </a:p>
+          <a:p>
+            <a:pPr>
+              <a:lnSpc>
+                <a:spcPct val="112000"/>
+              </a:lnSpc>
+              <a:spcAft>
+                <a:spcPts val="900"/>
+              </a:spcAft>
+            </a:pPr>
+            <a:r>
+              <a:rPr sz="1800" b="1">
+                <a:solidFill>
+                  <a:srgbClr val="E0A437"/>
+                </a:solidFill>
+                <a:latin typeface="Fira Sans"/>
+              </a:rPr>
+              <a:t>▸ </a:t>
+            </a:r>
+            <a:r>
+              <a:rPr sz="1800" b="1">
+                <a:solidFill>
+                  <a:srgbClr val="1D3557"/>
+                </a:solidFill>
+                <a:latin typeface="Fira Sans"/>
+              </a:rPr>
+              <a:t>El primer EDA del proyecto usa exactamente estas herramientas (entrega: lunes 15).</a:t>
             </a:r>
           </a:p>
         </p:txBody>
@@ -7172,7 +7297,7 @@
             <a:avLst/>
           </a:prstGeom>
           <a:solidFill>
-            <a:srgbClr val="FAFBFC"/>
+            <a:srgbClr val="1D3557"/>
           </a:solidFill>
           <a:ln>
             <a:noFill/>
@@ -7209,8 +7334,8 @@
         </p:nvSpPr>
         <p:spPr>
           <a:xfrm>
-            <a:off x="402336" y="301752"/>
-            <a:ext cx="8348472" cy="795528"/>
+            <a:off x="603504" y="1847088"/>
+            <a:ext cx="7946136" cy="1399032"/>
           </a:xfrm>
           <a:prstGeom prst="rect">
             <a:avLst/>
@@ -7224,120 +7349,24 @@
           <a:lstStyle/>
           <a:p>
             <a:r>
-              <a:rPr sz="2800" b="1">
-                <a:solidFill>
-                  <a:srgbClr val="0F0F0F"/>
-                </a:solidFill>
-                <a:latin typeface="Fira Sans"/>
-              </a:rPr>
-              <a:t>Próxima clase</a:t>
-            </a:r>
-          </a:p>
-        </p:txBody>
-      </p:sp>
-      <p:sp>
-        <p:nvSpPr>
-          <p:cNvPr id="4" name="TextBox 3"/>
-          <p:cNvSpPr txBox="1"/>
-          <p:nvPr/>
-        </p:nvSpPr>
-        <p:spPr>
-          <a:xfrm>
-            <a:off x="704088" y="1353312"/>
-            <a:ext cx="7744968" cy="3300984"/>
-          </a:xfrm>
-          <a:prstGeom prst="rect">
-            <a:avLst/>
-          </a:prstGeom>
-          <a:noFill/>
-        </p:spPr>
-        <p:txBody>
-          <a:bodyPr wrap="square">
-            <a:spAutoFit/>
-          </a:bodyPr>
-          <a:lstStyle/>
-          <a:p>
-            <a:pPr>
-              <a:lnSpc>
-                <a:spcPct val="112000"/>
-              </a:lnSpc>
-              <a:spcAft>
-                <a:spcPts val="900"/>
-              </a:spcAft>
-            </a:pPr>
-            <a:r>
-              <a:rPr sz="1800" b="1">
+              <a:rPr sz="3400" b="1">
+                <a:solidFill>
+                  <a:srgbClr val="FFFFFF"/>
+                </a:solidFill>
+                <a:latin typeface="Fira Sans"/>
+              </a:rPr>
+              <a:t>Recreo</a:t>
+            </a:r>
+          </a:p>
+          <a:p>
+            <a:r>
+              <a:rPr sz="1800" b="0">
                 <a:solidFill>
                   <a:srgbClr val="E0A437"/>
                 </a:solidFill>
                 <a:latin typeface="Fira Sans"/>
               </a:rPr>
-              <a:t>▸ </a:t>
-            </a:r>
-            <a:r>
-              <a:rPr sz="1800" b="0">
-                <a:solidFill>
-                  <a:srgbClr val="000000"/>
-                </a:solidFill>
-                <a:latin typeface="Fira Sans"/>
-              </a:rPr>
-              <a:t>Martes 8: fundamentos de probabilidad y nociones de inferencia estadística.</a:t>
-            </a:r>
-          </a:p>
-          <a:p>
-            <a:pPr>
-              <a:lnSpc>
-                <a:spcPct val="112000"/>
-              </a:lnSpc>
-              <a:spcAft>
-                <a:spcPts val="900"/>
-              </a:spcAft>
-            </a:pPr>
-            <a:r>
-              <a:rPr sz="1800" b="1">
-                <a:solidFill>
-                  <a:srgbClr val="E0A437"/>
-                </a:solidFill>
-                <a:latin typeface="Fira Sans"/>
-              </a:rPr>
-              <a:t>▸ </a:t>
-            </a:r>
-            <a:r>
-              <a:rPr sz="1800" b="0">
-                <a:solidFill>
-                  <a:srgbClr val="000000"/>
-                </a:solidFill>
-                <a:latin typeface="Fira Sans"/>
-              </a:rPr>
-              <a:t>La pregunta pendiente desde la clase 3: ¿qué significa el valor p que statsmodels ya nos mostró?</a:t>
-            </a:r>
-          </a:p>
-          <a:p>
-            <a:pPr>
-              <a:lnSpc>
-                <a:spcPct val="112000"/>
-              </a:lnSpc>
-              <a:spcAft>
-                <a:spcPts val="900"/>
-              </a:spcAft>
-            </a:pPr>
-            <a:r>
-              <a:rPr sz="1800" b="1">
-                <a:solidFill>
-                  <a:srgbClr val="E0A437"/>
-                </a:solidFill>
-                <a:latin typeface="Fira Sans"/>
-              </a:rPr>
-              <a:t>▸ </a:t>
-            </a:r>
-            <a:r>
-              <a:rPr sz="1800" b="1">
-                <a:solidFill>
-                  <a:srgbClr val="1D3557"/>
-                </a:solidFill>
-                <a:latin typeface="Fira Sans"/>
-              </a:rPr>
-              <a:t>La formulación se entrega el lunes 7; el primer análisis exploratorio, el lunes 15.</a:t>
+              <a:t>10 minutos · al volver: las presentaciones de ideas</a:t>
             </a:r>
           </a:p>
         </p:txBody>
@@ -7375,6 +7404,491 @@
             <a:avLst/>
           </a:prstGeom>
           <a:solidFill>
+            <a:srgbClr val="1D3557"/>
+          </a:solidFill>
+          <a:ln>
+            <a:noFill/>
+          </a:ln>
+          <a:effectLst/>
+        </p:spPr>
+        <p:style>
+          <a:lnRef idx="1">
+            <a:schemeClr val="accent1"/>
+          </a:lnRef>
+          <a:fillRef idx="3">
+            <a:schemeClr val="accent1"/>
+          </a:fillRef>
+          <a:effectRef idx="2">
+            <a:schemeClr val="accent1"/>
+          </a:effectRef>
+          <a:fontRef idx="minor">
+            <a:schemeClr val="lt1"/>
+          </a:fontRef>
+        </p:style>
+        <p:txBody>
+          <a:bodyPr rtlCol="0" anchor="ctr"/>
+          <a:lstStyle/>
+          <a:p>
+            <a:pPr algn="ctr"/>
+          </a:p>
+        </p:txBody>
+      </p:sp>
+      <p:sp>
+        <p:nvSpPr>
+          <p:cNvPr id="3" name="TextBox 2"/>
+          <p:cNvSpPr txBox="1"/>
+          <p:nvPr/>
+        </p:nvSpPr>
+        <p:spPr>
+          <a:xfrm>
+            <a:off x="603504" y="1847088"/>
+            <a:ext cx="7946136" cy="1399032"/>
+          </a:xfrm>
+          <a:prstGeom prst="rect">
+            <a:avLst/>
+          </a:prstGeom>
+          <a:noFill/>
+        </p:spPr>
+        <p:txBody>
+          <a:bodyPr wrap="square">
+            <a:spAutoFit/>
+          </a:bodyPr>
+          <a:lstStyle/>
+          <a:p>
+            <a:r>
+              <a:rPr sz="3400" b="1">
+                <a:solidFill>
+                  <a:srgbClr val="FFFFFF"/>
+                </a:solidFill>
+                <a:latin typeface="Fira Sans"/>
+              </a:rPr>
+              <a:t>Presentaciones de ideas</a:t>
+            </a:r>
+          </a:p>
+          <a:p>
+            <a:r>
+              <a:rPr sz="1800" b="0">
+                <a:solidFill>
+                  <a:srgbClr val="E0A437"/>
+                </a:solidFill>
+                <a:latin typeface="Fira Sans"/>
+              </a:rPr>
+              <a:t>De 5 a 7 minutos por equipo, y preguntas de todos</a:t>
+            </a:r>
+          </a:p>
+        </p:txBody>
+      </p:sp>
+    </p:spTree>
+  </p:cSld>
+  <p:clrMapOvr>
+    <a:masterClrMapping/>
+  </p:clrMapOvr>
+</p:sld>
+</file>
+
+<file path=ppt/slides/slide32.xml><?xml version="1.0" encoding="utf-8"?>
+<p:sld xmlns:a="http://schemas.openxmlformats.org/drawingml/2006/main" xmlns:p="http://schemas.openxmlformats.org/presentationml/2006/main" xmlns:r="http://schemas.openxmlformats.org/officeDocument/2006/relationships">
+  <p:cSld>
+    <p:spTree>
+      <p:nvGrpSpPr>
+        <p:cNvPr id="1" name=""/>
+        <p:cNvGrpSpPr/>
+        <p:nvPr/>
+      </p:nvGrpSpPr>
+      <p:grpSpPr/>
+      <p:sp>
+        <p:nvSpPr>
+          <p:cNvPr id="2" name="Rectangle 1"/>
+          <p:cNvSpPr/>
+          <p:nvPr/>
+        </p:nvSpPr>
+        <p:spPr>
+          <a:xfrm>
+            <a:off x="0" y="0"/>
+            <a:ext cx="9144000" cy="5138928"/>
+          </a:xfrm>
+          <a:prstGeom prst="rect">
+            <a:avLst/>
+          </a:prstGeom>
+          <a:solidFill>
+            <a:srgbClr val="FAFBFC"/>
+          </a:solidFill>
+          <a:ln>
+            <a:noFill/>
+          </a:ln>
+          <a:effectLst/>
+        </p:spPr>
+        <p:style>
+          <a:lnRef idx="1">
+            <a:schemeClr val="accent1"/>
+          </a:lnRef>
+          <a:fillRef idx="3">
+            <a:schemeClr val="accent1"/>
+          </a:fillRef>
+          <a:effectRef idx="2">
+            <a:schemeClr val="accent1"/>
+          </a:effectRef>
+          <a:fontRef idx="minor">
+            <a:schemeClr val="lt1"/>
+          </a:fontRef>
+        </p:style>
+        <p:txBody>
+          <a:bodyPr rtlCol="0" anchor="ctr"/>
+          <a:lstStyle/>
+          <a:p>
+            <a:pPr algn="ctr"/>
+          </a:p>
+        </p:txBody>
+      </p:sp>
+      <p:sp>
+        <p:nvSpPr>
+          <p:cNvPr id="3" name="TextBox 2"/>
+          <p:cNvSpPr txBox="1"/>
+          <p:nvPr/>
+        </p:nvSpPr>
+        <p:spPr>
+          <a:xfrm>
+            <a:off x="402336" y="301752"/>
+            <a:ext cx="8348472" cy="795528"/>
+          </a:xfrm>
+          <a:prstGeom prst="rect">
+            <a:avLst/>
+          </a:prstGeom>
+          <a:noFill/>
+        </p:spPr>
+        <p:txBody>
+          <a:bodyPr wrap="square">
+            <a:spAutoFit/>
+          </a:bodyPr>
+          <a:lstStyle/>
+          <a:p>
+            <a:r>
+              <a:rPr sz="2800" b="1">
+                <a:solidFill>
+                  <a:srgbClr val="0F0F0F"/>
+                </a:solidFill>
+                <a:latin typeface="Fira Sans"/>
+              </a:rPr>
+              <a:t>El formato</a:t>
+            </a:r>
+          </a:p>
+        </p:txBody>
+      </p:sp>
+      <p:sp>
+        <p:nvSpPr>
+          <p:cNvPr id="4" name="TextBox 3"/>
+          <p:cNvSpPr txBox="1"/>
+          <p:nvPr/>
+        </p:nvSpPr>
+        <p:spPr>
+          <a:xfrm>
+            <a:off x="704088" y="1353312"/>
+            <a:ext cx="7744968" cy="3300984"/>
+          </a:xfrm>
+          <a:prstGeom prst="rect">
+            <a:avLst/>
+          </a:prstGeom>
+          <a:noFill/>
+        </p:spPr>
+        <p:txBody>
+          <a:bodyPr wrap="square">
+            <a:spAutoFit/>
+          </a:bodyPr>
+          <a:lstStyle/>
+          <a:p>
+            <a:pPr>
+              <a:lnSpc>
+                <a:spcPct val="112000"/>
+              </a:lnSpc>
+              <a:spcAft>
+                <a:spcPts val="900"/>
+              </a:spcAft>
+            </a:pPr>
+            <a:r>
+              <a:rPr sz="1800" b="1">
+                <a:solidFill>
+                  <a:srgbClr val="E0A437"/>
+                </a:solidFill>
+                <a:latin typeface="Fira Sans"/>
+              </a:rPr>
+              <a:t>▸ </a:t>
+            </a:r>
+            <a:r>
+              <a:rPr sz="1800" b="1">
+                <a:solidFill>
+                  <a:srgbClr val="1D3557"/>
+                </a:solidFill>
+                <a:latin typeface="Fira Sans"/>
+              </a:rPr>
+              <a:t>Esta instancia no lleva nota: es para recibir retroalimentación temprano, cuando corregir cuesta poco.</a:t>
+            </a:r>
+          </a:p>
+          <a:p>
+            <a:pPr>
+              <a:lnSpc>
+                <a:spcPct val="112000"/>
+              </a:lnSpc>
+              <a:spcAft>
+                <a:spcPts val="900"/>
+              </a:spcAft>
+            </a:pPr>
+            <a:r>
+              <a:rPr sz="1800" b="1">
+                <a:solidFill>
+                  <a:srgbClr val="E0A437"/>
+                </a:solidFill>
+                <a:latin typeface="Fira Sans"/>
+              </a:rPr>
+              <a:t>▸ </a:t>
+            </a:r>
+            <a:r>
+              <a:rPr sz="1800" b="0">
+                <a:solidFill>
+                  <a:srgbClr val="000000"/>
+                </a:solidFill>
+                <a:latin typeface="Fira Sans"/>
+              </a:rPr>
+              <a:t>Después de cada equipo, preguntas y comentarios del curso.</a:t>
+            </a:r>
+          </a:p>
+        </p:txBody>
+      </p:sp>
+    </p:spTree>
+  </p:cSld>
+  <p:clrMapOvr>
+    <a:masterClrMapping/>
+  </p:clrMapOvr>
+</p:sld>
+</file>
+
+<file path=ppt/slides/slide33.xml><?xml version="1.0" encoding="utf-8"?>
+<p:sld xmlns:a="http://schemas.openxmlformats.org/drawingml/2006/main" xmlns:p="http://schemas.openxmlformats.org/presentationml/2006/main" xmlns:r="http://schemas.openxmlformats.org/officeDocument/2006/relationships">
+  <p:cSld>
+    <p:spTree>
+      <p:nvGrpSpPr>
+        <p:cNvPr id="1" name=""/>
+        <p:cNvGrpSpPr/>
+        <p:nvPr/>
+      </p:nvGrpSpPr>
+      <p:grpSpPr/>
+      <p:sp>
+        <p:nvSpPr>
+          <p:cNvPr id="2" name="Rectangle 1"/>
+          <p:cNvSpPr/>
+          <p:nvPr/>
+        </p:nvSpPr>
+        <p:spPr>
+          <a:xfrm>
+            <a:off x="0" y="0"/>
+            <a:ext cx="9144000" cy="5138928"/>
+          </a:xfrm>
+          <a:prstGeom prst="rect">
+            <a:avLst/>
+          </a:prstGeom>
+          <a:solidFill>
+            <a:srgbClr val="FAFBFC"/>
+          </a:solidFill>
+          <a:ln>
+            <a:noFill/>
+          </a:ln>
+          <a:effectLst/>
+        </p:spPr>
+        <p:style>
+          <a:lnRef idx="1">
+            <a:schemeClr val="accent1"/>
+          </a:lnRef>
+          <a:fillRef idx="3">
+            <a:schemeClr val="accent1"/>
+          </a:fillRef>
+          <a:effectRef idx="2">
+            <a:schemeClr val="accent1"/>
+          </a:effectRef>
+          <a:fontRef idx="minor">
+            <a:schemeClr val="lt1"/>
+          </a:fontRef>
+        </p:style>
+        <p:txBody>
+          <a:bodyPr rtlCol="0" anchor="ctr"/>
+          <a:lstStyle/>
+          <a:p>
+            <a:pPr algn="ctr"/>
+          </a:p>
+        </p:txBody>
+      </p:sp>
+      <p:sp>
+        <p:nvSpPr>
+          <p:cNvPr id="3" name="TextBox 2"/>
+          <p:cNvSpPr txBox="1"/>
+          <p:nvPr/>
+        </p:nvSpPr>
+        <p:spPr>
+          <a:xfrm>
+            <a:off x="402336" y="301752"/>
+            <a:ext cx="8348472" cy="795528"/>
+          </a:xfrm>
+          <a:prstGeom prst="rect">
+            <a:avLst/>
+          </a:prstGeom>
+          <a:noFill/>
+        </p:spPr>
+        <p:txBody>
+          <a:bodyPr wrap="square">
+            <a:spAutoFit/>
+          </a:bodyPr>
+          <a:lstStyle/>
+          <a:p>
+            <a:r>
+              <a:rPr sz="2800" b="1">
+                <a:solidFill>
+                  <a:srgbClr val="0F0F0F"/>
+                </a:solidFill>
+                <a:latin typeface="Fira Sans"/>
+              </a:rPr>
+              <a:t>Próxima clase</a:t>
+            </a:r>
+          </a:p>
+        </p:txBody>
+      </p:sp>
+      <p:sp>
+        <p:nvSpPr>
+          <p:cNvPr id="4" name="TextBox 3"/>
+          <p:cNvSpPr txBox="1"/>
+          <p:nvPr/>
+        </p:nvSpPr>
+        <p:spPr>
+          <a:xfrm>
+            <a:off x="704088" y="1353312"/>
+            <a:ext cx="7744968" cy="3300984"/>
+          </a:xfrm>
+          <a:prstGeom prst="rect">
+            <a:avLst/>
+          </a:prstGeom>
+          <a:noFill/>
+        </p:spPr>
+        <p:txBody>
+          <a:bodyPr wrap="square">
+            <a:spAutoFit/>
+          </a:bodyPr>
+          <a:lstStyle/>
+          <a:p>
+            <a:pPr>
+              <a:lnSpc>
+                <a:spcPct val="112000"/>
+              </a:lnSpc>
+              <a:spcAft>
+                <a:spcPts val="900"/>
+              </a:spcAft>
+            </a:pPr>
+            <a:r>
+              <a:rPr sz="1800" b="1">
+                <a:solidFill>
+                  <a:srgbClr val="E0A437"/>
+                </a:solidFill>
+                <a:latin typeface="Fira Sans"/>
+              </a:rPr>
+              <a:t>▸ </a:t>
+            </a:r>
+            <a:r>
+              <a:rPr sz="1800" b="0">
+                <a:solidFill>
+                  <a:srgbClr val="000000"/>
+                </a:solidFill>
+                <a:latin typeface="Fira Sans"/>
+              </a:rPr>
+              <a:t>Martes 8: fundamentos de probabilidad y nociones de inferencia estadística.</a:t>
+            </a:r>
+          </a:p>
+          <a:p>
+            <a:pPr>
+              <a:lnSpc>
+                <a:spcPct val="112000"/>
+              </a:lnSpc>
+              <a:spcAft>
+                <a:spcPts val="900"/>
+              </a:spcAft>
+            </a:pPr>
+            <a:r>
+              <a:rPr sz="1800" b="1">
+                <a:solidFill>
+                  <a:srgbClr val="E0A437"/>
+                </a:solidFill>
+                <a:latin typeface="Fira Sans"/>
+              </a:rPr>
+              <a:t>▸ </a:t>
+            </a:r>
+            <a:r>
+              <a:rPr sz="1800" b="0">
+                <a:solidFill>
+                  <a:srgbClr val="000000"/>
+                </a:solidFill>
+                <a:latin typeface="Fira Sans"/>
+              </a:rPr>
+              <a:t>La pregunta pendiente desde la clase 3: ¿qué significa el valor p que statsmodels ya nos mostró?</a:t>
+            </a:r>
+          </a:p>
+          <a:p>
+            <a:pPr>
+              <a:lnSpc>
+                <a:spcPct val="112000"/>
+              </a:lnSpc>
+              <a:spcAft>
+                <a:spcPts val="900"/>
+              </a:spcAft>
+            </a:pPr>
+            <a:r>
+              <a:rPr sz="1800" b="1">
+                <a:solidFill>
+                  <a:srgbClr val="E0A437"/>
+                </a:solidFill>
+                <a:latin typeface="Fira Sans"/>
+              </a:rPr>
+              <a:t>▸ </a:t>
+            </a:r>
+            <a:r>
+              <a:rPr sz="1800" b="1">
+                <a:solidFill>
+                  <a:srgbClr val="1D3557"/>
+                </a:solidFill>
+                <a:latin typeface="Fira Sans"/>
+              </a:rPr>
+              <a:t>La formulación se entrega el lunes 7; el primer análisis exploratorio, el lunes 15.</a:t>
+            </a:r>
+          </a:p>
+        </p:txBody>
+      </p:sp>
+    </p:spTree>
+  </p:cSld>
+  <p:clrMapOvr>
+    <a:masterClrMapping/>
+  </p:clrMapOvr>
+</p:sld>
+</file>
+
+<file path=ppt/slides/slide34.xml><?xml version="1.0" encoding="utf-8"?>
+<p:sld xmlns:a="http://schemas.openxmlformats.org/drawingml/2006/main" xmlns:p="http://schemas.openxmlformats.org/presentationml/2006/main" xmlns:r="http://schemas.openxmlformats.org/officeDocument/2006/relationships">
+  <p:cSld>
+    <p:spTree>
+      <p:nvGrpSpPr>
+        <p:cNvPr id="1" name=""/>
+        <p:cNvGrpSpPr/>
+        <p:nvPr/>
+      </p:nvGrpSpPr>
+      <p:grpSpPr/>
+      <p:sp>
+        <p:nvSpPr>
+          <p:cNvPr id="2" name="Rectangle 1"/>
+          <p:cNvSpPr/>
+          <p:nvPr/>
+        </p:nvSpPr>
+        <p:spPr>
+          <a:xfrm>
+            <a:off x="0" y="0"/>
+            <a:ext cx="9144000" cy="5138928"/>
+          </a:xfrm>
+          <a:prstGeom prst="rect">
+            <a:avLst/>
+          </a:prstGeom>
+          <a:solidFill>
             <a:srgbClr val="FAFBFC"/>
           </a:solidFill>
           <a:ln>
@@ -7985,7 +8499,7 @@
             <a:avLst/>
           </a:prstGeom>
           <a:solidFill>
-            <a:srgbClr val="FAFBFC"/>
+            <a:srgbClr val="1D3557"/>
           </a:solidFill>
           <a:ln>
             <a:noFill/>
@@ -8022,8 +8536,8 @@
         </p:nvSpPr>
         <p:spPr>
           <a:xfrm>
-            <a:off x="402336" y="301752"/>
-            <a:ext cx="8348472" cy="795528"/>
+            <a:off x="603504" y="1847088"/>
+            <a:ext cx="7946136" cy="1399032"/>
           </a:xfrm>
           <a:prstGeom prst="rect">
             <a:avLst/>
@@ -8037,167 +8551,24 @@
           <a:lstStyle/>
           <a:p>
             <a:r>
-              <a:rPr sz="2800" b="1">
-                <a:solidFill>
-                  <a:srgbClr val="0F0F0F"/>
-                </a:solidFill>
-                <a:latin typeface="Fira Sans"/>
-              </a:rPr>
-              <a:t>Otro modelo: la motorización del hogar</a:t>
-            </a:r>
-          </a:p>
-        </p:txBody>
-      </p:sp>
-      <p:sp>
-        <p:nvSpPr>
-          <p:cNvPr id="4" name="Rectangle 3"/>
-          <p:cNvSpPr/>
-          <p:nvPr/>
-        </p:nvSpPr>
-        <p:spPr>
-          <a:xfrm>
-            <a:off x="704088" y="1280160"/>
-            <a:ext cx="7744968" cy="2880360"/>
-          </a:xfrm>
-          <a:prstGeom prst="rect">
-            <a:avLst/>
-          </a:prstGeom>
-          <a:solidFill>
-            <a:srgbClr val="F0F2F5"/>
-          </a:solidFill>
-          <a:ln>
-            <a:solidFill>
-              <a:srgbClr val="D8DDE3"/>
-            </a:solidFill>
-          </a:ln>
-          <a:effectLst/>
-        </p:spPr>
-        <p:style>
-          <a:lnRef idx="1">
-            <a:schemeClr val="accent1"/>
-          </a:lnRef>
-          <a:fillRef idx="3">
-            <a:schemeClr val="accent1"/>
-          </a:fillRef>
-          <a:effectRef idx="2">
-            <a:schemeClr val="accent1"/>
-          </a:effectRef>
-          <a:fontRef idx="minor">
-            <a:schemeClr val="lt1"/>
-          </a:fontRef>
-        </p:style>
-        <p:txBody>
-          <a:bodyPr rtlCol="0" anchor="ctr" wrap="square" lIns="228600" tIns="137160"/>
-          <a:lstStyle/>
-          <a:p>
-            <a:pPr/>
-            <a:r>
-              <a:rPr sz="1500" b="0">
-                <a:solidFill>
-                  <a:srgbClr val="1D3557"/>
-                </a:solidFill>
-                <a:latin typeface="Menlo"/>
-              </a:rPr>
-              <a:t>x = h["IngresoHogar"] / 1e6</a:t>
-            </a:r>
-          </a:p>
-          <a:p>
-            <a:pPr/>
-            <a:r>
-              <a:rPr sz="1500" b="0">
-                <a:solidFill>
-                  <a:srgbClr val="1D3557"/>
-                </a:solidFill>
-                <a:latin typeface="Menlo"/>
-              </a:rPr>
-              <a:t>y, w = h["NumVeh"], h["Factor"]</a:t>
-            </a:r>
-          </a:p>
-          <a:p>
-            <a:pPr/>
-            <a:r>
-              <a:rPr sz="1500" b="0">
-                <a:solidFill>
-                  <a:srgbClr val="1D3557"/>
-                </a:solidFill>
-                <a:latin typeface="Menlo"/>
-              </a:rPr>
-              <a:t/>
-            </a:r>
-          </a:p>
-          <a:p>
-            <a:pPr/>
-            <a:r>
-              <a:rPr sz="1500" b="0">
-                <a:solidFill>
-                  <a:srgbClr val="1D3557"/>
-                </a:solidFill>
-                <a:latin typeface="Menlo"/>
-              </a:rPr>
-              <a:t># La fórmula de la pendiente ponderada, tal cual</a:t>
-            </a:r>
-          </a:p>
-          <a:p>
-            <a:pPr/>
-            <a:r>
-              <a:rPr sz="1500" b="0">
-                <a:solidFill>
-                  <a:srgbClr val="1D3557"/>
-                </a:solidFill>
-                <a:latin typeface="Menlo"/>
-              </a:rPr>
-              <a:t>b = (w*(x - xw)*(y - yw)).sum() / (w*(x - xw)**2).sum()</a:t>
-            </a:r>
-          </a:p>
-        </p:txBody>
-      </p:sp>
-      <p:sp>
-        <p:nvSpPr>
-          <p:cNvPr id="5" name="TextBox 4"/>
-          <p:cNvSpPr txBox="1"/>
-          <p:nvPr/>
-        </p:nvSpPr>
-        <p:spPr>
-          <a:xfrm>
-            <a:off x="704088" y="4389120"/>
-            <a:ext cx="7744968" cy="1097280"/>
-          </a:xfrm>
-          <a:prstGeom prst="rect">
-            <a:avLst/>
-          </a:prstGeom>
-          <a:noFill/>
-        </p:spPr>
-        <p:txBody>
-          <a:bodyPr wrap="square">
-            <a:spAutoFit/>
-          </a:bodyPr>
-          <a:lstStyle/>
-          <a:p>
-            <a:pPr>
-              <a:lnSpc>
-                <a:spcPct val="112000"/>
-              </a:lnSpc>
-              <a:spcAft>
-                <a:spcPts val="900"/>
-              </a:spcAft>
-            </a:pPr>
-            <a:r>
-              <a:rPr sz="1600" b="1">
+              <a:rPr sz="3400" b="1">
+                <a:solidFill>
+                  <a:srgbClr val="FFFFFF"/>
+                </a:solidFill>
+                <a:latin typeface="Fira Sans"/>
+              </a:rPr>
+              <a:t>¿Cuántos vehículos tiene un hogar según su ingreso?</a:t>
+            </a:r>
+          </a:p>
+          <a:p>
+            <a:r>
+              <a:rPr sz="1800" b="0">
                 <a:solidFill>
                   <a:srgbClr val="E0A437"/>
                 </a:solidFill>
                 <a:latin typeface="Fira Sans"/>
               </a:rPr>
-              <a:t>▸ </a:t>
-            </a:r>
-            <a:r>
-              <a:rPr sz="1600" b="0">
-                <a:solidFill>
-                  <a:srgbClr val="000000"/>
-                </a:solidFill>
-                <a:latin typeface="Fira Sans"/>
-              </a:rPr>
-              <a:t>18.264 hogares reales, ponderados por su factor: vehículos = 0,20 + 0,50 · ingreso. Medio vehículo más por cada millón.</a:t>
+              <a:t>Explicar los vehículos del hogar con el ingreso: 18.264 hogares, ponderados por su factor</a:t>
             </a:r>
           </a:p>
         </p:txBody>
@@ -8293,35 +8664,114 @@
                 </a:solidFill>
                 <a:latin typeface="Fira Sans"/>
               </a:rPr>
-              <a:t>Los atípicos de la variable a predecir</a:t>
-            </a:r>
-          </a:p>
-        </p:txBody>
-      </p:sp>
-      <p:pic>
-        <p:nvPicPr>
-          <p:cNvPr id="4" name="Picture 3" descr="c3_27_boxplot_numveh.png"/>
-          <p:cNvPicPr>
-            <a:picLocks noChangeAspect="1"/>
-          </p:cNvPicPr>
-          <p:nvPr/>
-        </p:nvPicPr>
-        <p:blipFill>
-          <a:blip r:embed="rId2"/>
-          <a:stretch>
-            <a:fillRect/>
-          </a:stretch>
-        </p:blipFill>
-        <p:spPr>
-          <a:xfrm>
-            <a:off x="699515" y="1492260"/>
-            <a:ext cx="7744968" cy="2456159"/>
-          </a:xfrm>
-          <a:prstGeom prst="rect">
-            <a:avLst/>
-          </a:prstGeom>
-        </p:spPr>
-      </p:pic>
+              <a:t>Otro modelo: la motorización del hogar</a:t>
+            </a:r>
+          </a:p>
+        </p:txBody>
+      </p:sp>
+      <p:sp>
+        <p:nvSpPr>
+          <p:cNvPr id="4" name="Rectangle 3"/>
+          <p:cNvSpPr/>
+          <p:nvPr/>
+        </p:nvSpPr>
+        <p:spPr>
+          <a:xfrm>
+            <a:off x="704088" y="1280160"/>
+            <a:ext cx="7744968" cy="2880360"/>
+          </a:xfrm>
+          <a:prstGeom prst="rect">
+            <a:avLst/>
+          </a:prstGeom>
+          <a:solidFill>
+            <a:srgbClr val="F0F2F5"/>
+          </a:solidFill>
+          <a:ln>
+            <a:solidFill>
+              <a:srgbClr val="D8DDE3"/>
+            </a:solidFill>
+          </a:ln>
+          <a:effectLst/>
+        </p:spPr>
+        <p:style>
+          <a:lnRef idx="1">
+            <a:schemeClr val="accent1"/>
+          </a:lnRef>
+          <a:fillRef idx="3">
+            <a:schemeClr val="accent1"/>
+          </a:fillRef>
+          <a:effectRef idx="2">
+            <a:schemeClr val="accent1"/>
+          </a:effectRef>
+          <a:fontRef idx="minor">
+            <a:schemeClr val="lt1"/>
+          </a:fontRef>
+        </p:style>
+        <p:txBody>
+          <a:bodyPr rtlCol="0" anchor="ctr" wrap="square" lIns="228600" tIns="137160"/>
+          <a:lstStyle/>
+          <a:p>
+            <a:pPr/>
+            <a:r>
+              <a:rPr sz="1500" b="0">
+                <a:solidFill>
+                  <a:srgbClr val="1D3557"/>
+                </a:solidFill>
+                <a:latin typeface="Menlo"/>
+              </a:rPr>
+              <a:t>x = h["IngresoHogar"] / 1e6</a:t>
+            </a:r>
+          </a:p>
+          <a:p>
+            <a:pPr/>
+            <a:r>
+              <a:rPr sz="1500" b="0">
+                <a:solidFill>
+                  <a:srgbClr val="1D3557"/>
+                </a:solidFill>
+                <a:latin typeface="Menlo"/>
+              </a:rPr>
+              <a:t>y, w = h["NumVeh"], h["Factor"]</a:t>
+            </a:r>
+          </a:p>
+          <a:p>
+            <a:pPr/>
+            <a:r>
+              <a:rPr sz="1500" b="0">
+                <a:solidFill>
+                  <a:srgbClr val="1D3557"/>
+                </a:solidFill>
+                <a:latin typeface="Menlo"/>
+              </a:rPr>
+              <a:t/>
+            </a:r>
+          </a:p>
+          <a:p>
+            <a:pPr/>
+            <a:r>
+              <a:rPr sz="1500" b="0">
+                <a:solidFill>
+                  <a:srgbClr val="1D3557"/>
+                </a:solidFill>
+                <a:latin typeface="Menlo"/>
+              </a:rPr>
+              <a:t># La fórmula de la pendiente ponderada, tal cual</a:t>
+            </a:r>
+          </a:p>
+          <a:p>
+            <a:pPr/>
+            <a:r>
+              <a:rPr sz="1500" b="0">
+                <a:solidFill>
+                  <a:srgbClr val="1D3557"/>
+                </a:solidFill>
+                <a:latin typeface="Menlo"/>
+              </a:rPr>
+              <a:t>b = (w*(x - xw)*(y - yw)).sum() / (w*(x - xw)**2).sum()</a:t>
+            </a:r>
+          </a:p>
+        </p:txBody>
+      </p:sp>
       <p:sp>
         <p:nvSpPr>
           <p:cNvPr id="5" name="TextBox 4"/>
@@ -8330,8 +8780,8 @@
         </p:nvSpPr>
         <p:spPr>
           <a:xfrm>
-            <a:off x="704088" y="4434840"/>
-            <a:ext cx="7744968" cy="457200"/>
+            <a:off x="704088" y="4389120"/>
+            <a:ext cx="7744968" cy="1097280"/>
           </a:xfrm>
           <a:prstGeom prst="rect">
             <a:avLst/>
@@ -8344,14 +8794,31 @@
           </a:bodyPr>
           <a:lstStyle/>
           <a:p>
-            <a:r>
-              <a:rPr sz="1300" b="0">
-                <a:solidFill>
-                  <a:srgbClr val="333333"/>
-                </a:solidFill>
-                <a:latin typeface="Fira Sans"/>
-              </a:rPr>
-              <a:t>El boxplot de NumVeh (clase 2): la cerca de Tukey queda en 2,5, y los hogares de 3 autos o más son atípicos. La siguiente diapo mide qué pasa al sacarlos.</a:t>
+            <a:pPr>
+              <a:lnSpc>
+                <a:spcPct val="112000"/>
+              </a:lnSpc>
+              <a:spcAft>
+                <a:spcPts val="900"/>
+              </a:spcAft>
+            </a:pPr>
+            <a:r>
+              <a:rPr sz="1600" b="1">
+                <a:solidFill>
+                  <a:srgbClr val="E0A437"/>
+                </a:solidFill>
+                <a:latin typeface="Fira Sans"/>
+              </a:rPr>
+              <a:t>▸ </a:t>
+            </a:r>
+            <a:r>
+              <a:rPr sz="1600" b="0">
+                <a:solidFill>
+                  <a:srgbClr val="000000"/>
+                </a:solidFill>
+                <a:latin typeface="Fira Sans"/>
+              </a:rPr>
+              <a:t>18.264 hogares reales, ponderados por su factor: vehículos = 0,20 + 0,50 · ingreso. Medio vehículo más por cada millón.</a:t>
             </a:r>
           </a:p>
         </p:txBody>
@@ -8447,114 +8914,35 @@
                 </a:solidFill>
                 <a:latin typeface="Fira Sans"/>
               </a:rPr>
-              <a:t>Sacar atípicos de la variable a predecir</a:t>
-            </a:r>
-          </a:p>
-        </p:txBody>
-      </p:sp>
-      <p:sp>
-        <p:nvSpPr>
-          <p:cNvPr id="4" name="Rectangle 3"/>
-          <p:cNvSpPr/>
-          <p:nvPr/>
-        </p:nvSpPr>
-        <p:spPr>
-          <a:xfrm>
-            <a:off x="704088" y="1280160"/>
-            <a:ext cx="7744968" cy="2880360"/>
-          </a:xfrm>
-          <a:prstGeom prst="rect">
-            <a:avLst/>
-          </a:prstGeom>
-          <a:solidFill>
-            <a:srgbClr val="F0F2F5"/>
-          </a:solidFill>
-          <a:ln>
-            <a:solidFill>
-              <a:srgbClr val="D8DDE3"/>
-            </a:solidFill>
-          </a:ln>
-          <a:effectLst/>
-        </p:spPr>
-        <p:style>
-          <a:lnRef idx="1">
-            <a:schemeClr val="accent1"/>
-          </a:lnRef>
-          <a:fillRef idx="3">
-            <a:schemeClr val="accent1"/>
-          </a:fillRef>
-          <a:effectRef idx="2">
-            <a:schemeClr val="accent1"/>
-          </a:effectRef>
-          <a:fontRef idx="minor">
-            <a:schemeClr val="lt1"/>
-          </a:fontRef>
-        </p:style>
-        <p:txBody>
-          <a:bodyPr rtlCol="0" anchor="ctr" wrap="square" lIns="228600" tIns="137160"/>
-          <a:lstStyle/>
-          <a:p>
-            <a:pPr/>
-            <a:r>
-              <a:rPr sz="1500" b="0">
-                <a:solidFill>
-                  <a:srgbClr val="1D3557"/>
-                </a:solidFill>
-                <a:latin typeface="Menlo"/>
-              </a:rPr>
-              <a:t>q1, q3 = h["NumVeh"].quantile([0.25, 0.75])</a:t>
-            </a:r>
-          </a:p>
-          <a:p>
-            <a:pPr/>
-            <a:r>
-              <a:rPr sz="1500" b="0">
-                <a:solidFill>
-                  <a:srgbClr val="1D3557"/>
-                </a:solidFill>
-                <a:latin typeface="Menlo"/>
-              </a:rPr>
-              <a:t>sin_atipicos = h[h["NumVeh"] &lt;= q3 + 1.5 * (q3 - q1)]  # = 2.5</a:t>
-            </a:r>
-          </a:p>
-          <a:p>
-            <a:pPr/>
-            <a:r>
-              <a:rPr sz="1500" b="0">
-                <a:solidFill>
-                  <a:srgbClr val="1D3557"/>
-                </a:solidFill>
-                <a:latin typeface="Menlo"/>
-              </a:rPr>
-              <a:t/>
-            </a:r>
-          </a:p>
-          <a:p>
-            <a:pPr/>
-            <a:r>
-              <a:rPr sz="1500" b="0">
-                <a:solidFill>
-                  <a:srgbClr val="1D3557"/>
-                </a:solidFill>
-                <a:latin typeface="Menlo"/>
-              </a:rPr>
-              <a:t># El mismo modelo, sin los hogares de 3 autos o más</a:t>
-            </a:r>
-          </a:p>
-          <a:p>
-            <a:pPr/>
-            <a:r>
-              <a:rPr sz="1500" b="0">
-                <a:solidFill>
-                  <a:srgbClr val="1D3557"/>
-                </a:solidFill>
-                <a:latin typeface="Menlo"/>
-              </a:rPr>
-              <a:t>np.polyfit(sin_atipicos["IngresoHogar"] / 1e6, sin_atipicos["NumVeh"], 1)</a:t>
-            </a:r>
-          </a:p>
-        </p:txBody>
-      </p:sp>
+              <a:t>Los atípicos de la variable a predecir</a:t>
+            </a:r>
+          </a:p>
+        </p:txBody>
+      </p:sp>
+      <p:pic>
+        <p:nvPicPr>
+          <p:cNvPr id="4" name="Picture 3" descr="c3_27_boxplot_numveh.png"/>
+          <p:cNvPicPr>
+            <a:picLocks noChangeAspect="1"/>
+          </p:cNvPicPr>
+          <p:nvPr/>
+        </p:nvPicPr>
+        <p:blipFill>
+          <a:blip r:embed="rId2"/>
+          <a:stretch>
+            <a:fillRect/>
+          </a:stretch>
+        </p:blipFill>
+        <p:spPr>
+          <a:xfrm>
+            <a:off x="699515" y="1492260"/>
+            <a:ext cx="7744968" cy="2456159"/>
+          </a:xfrm>
+          <a:prstGeom prst="rect">
+            <a:avLst/>
+          </a:prstGeom>
+        </p:spPr>
+      </p:pic>
       <p:sp>
         <p:nvSpPr>
           <p:cNvPr id="5" name="TextBox 4"/>
@@ -8563,8 +8951,8 @@
         </p:nvSpPr>
         <p:spPr>
           <a:xfrm>
-            <a:off x="704088" y="4389120"/>
-            <a:ext cx="7744968" cy="1097280"/>
+            <a:off x="704088" y="4434840"/>
+            <a:ext cx="7744968" cy="457200"/>
           </a:xfrm>
           <a:prstGeom prst="rect">
             <a:avLst/>
@@ -8577,31 +8965,14 @@
           </a:bodyPr>
           <a:lstStyle/>
           <a:p>
-            <a:pPr>
-              <a:lnSpc>
-                <a:spcPct val="112000"/>
-              </a:lnSpc>
-              <a:spcAft>
-                <a:spcPts val="900"/>
-              </a:spcAft>
-            </a:pPr>
-            <a:r>
-              <a:rPr sz="1600" b="1">
-                <a:solidFill>
-                  <a:srgbClr val="E0A437"/>
-                </a:solidFill>
-                <a:latin typeface="Fira Sans"/>
-              </a:rPr>
-              <a:t>▸ </a:t>
-            </a:r>
-            <a:r>
-              <a:rPr sz="1600" b="0">
-                <a:solidFill>
-                  <a:srgbClr val="000000"/>
-                </a:solidFill>
-                <a:latin typeface="Fira Sans"/>
-              </a:rPr>
-              <a:t>Sacar 236 hogares aplana la pendiente ponderada (0,50 a 0,44): no eran errores, eran la señal. Los atípicos de y se investigan; se eliminan solo por dominio.</a:t>
+            <a:r>
+              <a:rPr sz="1300" b="0">
+                <a:solidFill>
+                  <a:srgbClr val="333333"/>
+                </a:solidFill>
+                <a:latin typeface="Fira Sans"/>
+              </a:rPr>
+              <a:t>El boxplot de NumVeh (clase 2): la cerca de Tukey queda en 2,5, y los hogares de 3 autos o más son atípicos. La siguiente diapo mide qué pasa al sacarlos.</a:t>
             </a:r>
           </a:p>
         </p:txBody>

</xml_diff>

<commit_message>
Deck clase 4: avisos en la slide 2 y la pregunta del modelo inicial antes del contenido
Co-Authored-By: Claude Fable 5 <noreply@anthropic.com>
</commit_message>
<xml_diff>
--- a/presentaciones/clase04_regresion_multiple.pptx
+++ b/presentaciones/clase04_regresion_multiple.pptx
@@ -39,6 +39,7 @@
     <p:sldId id="287" r:id="rId38"/>
     <p:sldId id="288" r:id="rId39"/>
     <p:sldId id="289" r:id="rId40"/>
+    <p:sldId id="290" r:id="rId41"/>
   </p:sldIdLst>
   <p:sldSz cx="9144000" cy="5138928" type="screen4x3"/>
   <p:notesSz cx="6858000" cy="9144000"/>
@@ -3456,114 +3457,35 @@
                 </a:solidFill>
                 <a:latin typeface="Fira Sans"/>
               </a:rPr>
-              <a:t>Sacar atípicos de la variable a predecir</a:t>
-            </a:r>
-          </a:p>
-        </p:txBody>
-      </p:sp>
-      <p:sp>
-        <p:nvSpPr>
-          <p:cNvPr id="4" name="Rectangle 3"/>
-          <p:cNvSpPr/>
-          <p:nvPr/>
-        </p:nvSpPr>
-        <p:spPr>
-          <a:xfrm>
-            <a:off x="704088" y="1280160"/>
-            <a:ext cx="7744968" cy="2880360"/>
-          </a:xfrm>
-          <a:prstGeom prst="rect">
-            <a:avLst/>
-          </a:prstGeom>
-          <a:solidFill>
-            <a:srgbClr val="F0F2F5"/>
-          </a:solidFill>
-          <a:ln>
-            <a:solidFill>
-              <a:srgbClr val="D8DDE3"/>
-            </a:solidFill>
-          </a:ln>
-          <a:effectLst/>
-        </p:spPr>
-        <p:style>
-          <a:lnRef idx="1">
-            <a:schemeClr val="accent1"/>
-          </a:lnRef>
-          <a:fillRef idx="3">
-            <a:schemeClr val="accent1"/>
-          </a:fillRef>
-          <a:effectRef idx="2">
-            <a:schemeClr val="accent1"/>
-          </a:effectRef>
-          <a:fontRef idx="minor">
-            <a:schemeClr val="lt1"/>
-          </a:fontRef>
-        </p:style>
-        <p:txBody>
-          <a:bodyPr rtlCol="0" anchor="ctr" wrap="square" lIns="228600" tIns="137160"/>
-          <a:lstStyle/>
-          <a:p>
-            <a:pPr/>
-            <a:r>
-              <a:rPr sz="1500" b="0">
-                <a:solidFill>
-                  <a:srgbClr val="1D3557"/>
-                </a:solidFill>
-                <a:latin typeface="Menlo"/>
-              </a:rPr>
-              <a:t>q1, q3 = h["NumVeh"].quantile([0.25, 0.75])</a:t>
-            </a:r>
-          </a:p>
-          <a:p>
-            <a:pPr/>
-            <a:r>
-              <a:rPr sz="1500" b="0">
-                <a:solidFill>
-                  <a:srgbClr val="1D3557"/>
-                </a:solidFill>
-                <a:latin typeface="Menlo"/>
-              </a:rPr>
-              <a:t>sin_atipicos = h[h["NumVeh"] &lt;= q3 + 1.5 * (q3 - q1)]  # = 2.5</a:t>
-            </a:r>
-          </a:p>
-          <a:p>
-            <a:pPr/>
-            <a:r>
-              <a:rPr sz="1500" b="0">
-                <a:solidFill>
-                  <a:srgbClr val="1D3557"/>
-                </a:solidFill>
-                <a:latin typeface="Menlo"/>
-              </a:rPr>
-              <a:t/>
-            </a:r>
-          </a:p>
-          <a:p>
-            <a:pPr/>
-            <a:r>
-              <a:rPr sz="1500" b="0">
-                <a:solidFill>
-                  <a:srgbClr val="1D3557"/>
-                </a:solidFill>
-                <a:latin typeface="Menlo"/>
-              </a:rPr>
-              <a:t># El mismo modelo, sin los hogares de 3 autos o más</a:t>
-            </a:r>
-          </a:p>
-          <a:p>
-            <a:pPr/>
-            <a:r>
-              <a:rPr sz="1500" b="0">
-                <a:solidFill>
-                  <a:srgbClr val="1D3557"/>
-                </a:solidFill>
-                <a:latin typeface="Menlo"/>
-              </a:rPr>
-              <a:t>np.polyfit(sin_atipicos["IngresoHogar"] / 1e6, sin_atipicos["NumVeh"], 1)</a:t>
-            </a:r>
-          </a:p>
-        </p:txBody>
-      </p:sp>
+              <a:t>Los atípicos de la variable a predecir</a:t>
+            </a:r>
+          </a:p>
+        </p:txBody>
+      </p:sp>
+      <p:pic>
+        <p:nvPicPr>
+          <p:cNvPr id="4" name="Picture 3" descr="c3_27_boxplot_numveh.png"/>
+          <p:cNvPicPr>
+            <a:picLocks noChangeAspect="1"/>
+          </p:cNvPicPr>
+          <p:nvPr/>
+        </p:nvPicPr>
+        <p:blipFill>
+          <a:blip r:embed="rId2"/>
+          <a:stretch>
+            <a:fillRect/>
+          </a:stretch>
+        </p:blipFill>
+        <p:spPr>
+          <a:xfrm>
+            <a:off x="699515" y="1492260"/>
+            <a:ext cx="7744968" cy="2456159"/>
+          </a:xfrm>
+          <a:prstGeom prst="rect">
+            <a:avLst/>
+          </a:prstGeom>
+        </p:spPr>
+      </p:pic>
       <p:sp>
         <p:nvSpPr>
           <p:cNvPr id="5" name="TextBox 4"/>
@@ -3572,8 +3494,8 @@
         </p:nvSpPr>
         <p:spPr>
           <a:xfrm>
-            <a:off x="704088" y="4389120"/>
-            <a:ext cx="7744968" cy="1097280"/>
+            <a:off x="704088" y="4434840"/>
+            <a:ext cx="7744968" cy="457200"/>
           </a:xfrm>
           <a:prstGeom prst="rect">
             <a:avLst/>
@@ -3586,31 +3508,14 @@
           </a:bodyPr>
           <a:lstStyle/>
           <a:p>
-            <a:pPr>
-              <a:lnSpc>
-                <a:spcPct val="112000"/>
-              </a:lnSpc>
-              <a:spcAft>
-                <a:spcPts val="900"/>
-              </a:spcAft>
-            </a:pPr>
-            <a:r>
-              <a:rPr sz="1600" b="1">
-                <a:solidFill>
-                  <a:srgbClr val="E0A437"/>
-                </a:solidFill>
-                <a:latin typeface="Fira Sans"/>
-              </a:rPr>
-              <a:t>▸ </a:t>
-            </a:r>
-            <a:r>
-              <a:rPr sz="1600" b="0">
-                <a:solidFill>
-                  <a:srgbClr val="000000"/>
-                </a:solidFill>
-                <a:latin typeface="Fira Sans"/>
-              </a:rPr>
-              <a:t>Sacar 236 hogares aplana la pendiente ponderada (0,50 a 0,44): no eran errores, eran la señal. Los atípicos de y se investigan; se eliminan solo por dominio.</a:t>
+            <a:r>
+              <a:rPr sz="1300" b="0">
+                <a:solidFill>
+                  <a:srgbClr val="333333"/>
+                </a:solidFill>
+                <a:latin typeface="Fira Sans"/>
+              </a:rPr>
+              <a:t>El boxplot de NumVeh (clase 2): la cerca de Tukey queda en 2,5, y los hogares de 3 autos o más son atípicos. La siguiente diapo mide qué pasa al sacarlos.</a:t>
             </a:r>
           </a:p>
         </p:txBody>
@@ -3648,7 +3553,7 @@
             <a:avLst/>
           </a:prstGeom>
           <a:solidFill>
-            <a:srgbClr val="1D3557"/>
+            <a:srgbClr val="FAFBFC"/>
           </a:solidFill>
           <a:ln>
             <a:noFill/>
@@ -3685,8 +3590,8 @@
         </p:nvSpPr>
         <p:spPr>
           <a:xfrm>
-            <a:off x="603504" y="1847088"/>
-            <a:ext cx="7946136" cy="1399032"/>
+            <a:off x="402336" y="301752"/>
+            <a:ext cx="8348472" cy="795528"/>
           </a:xfrm>
           <a:prstGeom prst="rect">
             <a:avLst/>
@@ -3700,24 +3605,167 @@
           <a:lstStyle/>
           <a:p>
             <a:r>
-              <a:rPr sz="3400" b="1">
-                <a:solidFill>
-                  <a:srgbClr val="FFFFFF"/>
-                </a:solidFill>
-                <a:latin typeface="Fira Sans"/>
-              </a:rPr>
-              <a:t>Visualización</a:t>
-            </a:r>
-          </a:p>
-          <a:p>
-            <a:r>
-              <a:rPr sz="1800" b="0">
+              <a:rPr sz="2800" b="1">
+                <a:solidFill>
+                  <a:srgbClr val="0F0F0F"/>
+                </a:solidFill>
+                <a:latin typeface="Fira Sans"/>
+              </a:rPr>
+              <a:t>Sacar atípicos de la variable a predecir</a:t>
+            </a:r>
+          </a:p>
+        </p:txBody>
+      </p:sp>
+      <p:sp>
+        <p:nvSpPr>
+          <p:cNvPr id="4" name="Rectangle 3"/>
+          <p:cNvSpPr/>
+          <p:nvPr/>
+        </p:nvSpPr>
+        <p:spPr>
+          <a:xfrm>
+            <a:off x="704088" y="1280160"/>
+            <a:ext cx="7744968" cy="2880360"/>
+          </a:xfrm>
+          <a:prstGeom prst="rect">
+            <a:avLst/>
+          </a:prstGeom>
+          <a:solidFill>
+            <a:srgbClr val="F0F2F5"/>
+          </a:solidFill>
+          <a:ln>
+            <a:solidFill>
+              <a:srgbClr val="D8DDE3"/>
+            </a:solidFill>
+          </a:ln>
+          <a:effectLst/>
+        </p:spPr>
+        <p:style>
+          <a:lnRef idx="1">
+            <a:schemeClr val="accent1"/>
+          </a:lnRef>
+          <a:fillRef idx="3">
+            <a:schemeClr val="accent1"/>
+          </a:fillRef>
+          <a:effectRef idx="2">
+            <a:schemeClr val="accent1"/>
+          </a:effectRef>
+          <a:fontRef idx="minor">
+            <a:schemeClr val="lt1"/>
+          </a:fontRef>
+        </p:style>
+        <p:txBody>
+          <a:bodyPr rtlCol="0" anchor="ctr" wrap="square" lIns="228600" tIns="137160"/>
+          <a:lstStyle/>
+          <a:p>
+            <a:pPr/>
+            <a:r>
+              <a:rPr sz="1500" b="0">
+                <a:solidFill>
+                  <a:srgbClr val="1D3557"/>
+                </a:solidFill>
+                <a:latin typeface="Menlo"/>
+              </a:rPr>
+              <a:t>q1, q3 = h["NumVeh"].quantile([0.25, 0.75])</a:t>
+            </a:r>
+          </a:p>
+          <a:p>
+            <a:pPr/>
+            <a:r>
+              <a:rPr sz="1500" b="0">
+                <a:solidFill>
+                  <a:srgbClr val="1D3557"/>
+                </a:solidFill>
+                <a:latin typeface="Menlo"/>
+              </a:rPr>
+              <a:t>sin_atipicos = h[h["NumVeh"] &lt;= q3 + 1.5 * (q3 - q1)]  # = 2.5</a:t>
+            </a:r>
+          </a:p>
+          <a:p>
+            <a:pPr/>
+            <a:r>
+              <a:rPr sz="1500" b="0">
+                <a:solidFill>
+                  <a:srgbClr val="1D3557"/>
+                </a:solidFill>
+                <a:latin typeface="Menlo"/>
+              </a:rPr>
+              <a:t/>
+            </a:r>
+          </a:p>
+          <a:p>
+            <a:pPr/>
+            <a:r>
+              <a:rPr sz="1500" b="0">
+                <a:solidFill>
+                  <a:srgbClr val="1D3557"/>
+                </a:solidFill>
+                <a:latin typeface="Menlo"/>
+              </a:rPr>
+              <a:t># El mismo modelo, sin los hogares de 3 autos o más</a:t>
+            </a:r>
+          </a:p>
+          <a:p>
+            <a:pPr/>
+            <a:r>
+              <a:rPr sz="1500" b="0">
+                <a:solidFill>
+                  <a:srgbClr val="1D3557"/>
+                </a:solidFill>
+                <a:latin typeface="Menlo"/>
+              </a:rPr>
+              <a:t>np.polyfit(sin_atipicos["IngresoHogar"] / 1e6, sin_atipicos["NumVeh"], 1)</a:t>
+            </a:r>
+          </a:p>
+        </p:txBody>
+      </p:sp>
+      <p:sp>
+        <p:nvSpPr>
+          <p:cNvPr id="5" name="TextBox 4"/>
+          <p:cNvSpPr txBox="1"/>
+          <p:nvPr/>
+        </p:nvSpPr>
+        <p:spPr>
+          <a:xfrm>
+            <a:off x="704088" y="4389120"/>
+            <a:ext cx="7744968" cy="1097280"/>
+          </a:xfrm>
+          <a:prstGeom prst="rect">
+            <a:avLst/>
+          </a:prstGeom>
+          <a:noFill/>
+        </p:spPr>
+        <p:txBody>
+          <a:bodyPr wrap="square">
+            <a:spAutoFit/>
+          </a:bodyPr>
+          <a:lstStyle/>
+          <a:p>
+            <a:pPr>
+              <a:lnSpc>
+                <a:spcPct val="112000"/>
+              </a:lnSpc>
+              <a:spcAft>
+                <a:spcPts val="900"/>
+              </a:spcAft>
+            </a:pPr>
+            <a:r>
+              <a:rPr sz="1600" b="1">
                 <a:solidFill>
                   <a:srgbClr val="E0A437"/>
                 </a:solidFill>
                 <a:latin typeface="Fira Sans"/>
               </a:rPr>
-              <a:t>Muchos puntos y colas largas</a:t>
+              <a:t>▸ </a:t>
+            </a:r>
+            <a:r>
+              <a:rPr sz="1600" b="0">
+                <a:solidFill>
+                  <a:srgbClr val="000000"/>
+                </a:solidFill>
+                <a:latin typeface="Fira Sans"/>
+              </a:rPr>
+              <a:t>Sacar 236 hogares aplana la pendiente ponderada (0,50 a 0,44): no eran errores, eran la señal. Los atípicos de y se investigan; se eliminan solo por dominio.</a:t>
             </a:r>
           </a:p>
         </p:txBody>
@@ -3755,7 +3803,7 @@
             <a:avLst/>
           </a:prstGeom>
           <a:solidFill>
-            <a:srgbClr val="FAFBFC"/>
+            <a:srgbClr val="1D3557"/>
           </a:solidFill>
           <a:ln>
             <a:noFill/>
@@ -3792,8 +3840,8 @@
         </p:nvSpPr>
         <p:spPr>
           <a:xfrm>
-            <a:off x="402336" y="301752"/>
-            <a:ext cx="8348472" cy="795528"/>
+            <a:off x="603504" y="1847088"/>
+            <a:ext cx="7946136" cy="1399032"/>
           </a:xfrm>
           <a:prstGeom prst="rect">
             <a:avLst/>
@@ -3807,71 +3855,24 @@
           <a:lstStyle/>
           <a:p>
             <a:r>
-              <a:rPr sz="2800" b="1">
-                <a:solidFill>
-                  <a:srgbClr val="0F0F0F"/>
-                </a:solidFill>
-                <a:latin typeface="Fira Sans"/>
-              </a:rPr>
-              <a:t>Graficar 90 mil puntos: overplotting</a:t>
-            </a:r>
-          </a:p>
-        </p:txBody>
-      </p:sp>
-      <p:pic>
-        <p:nvPicPr>
-          <p:cNvPr id="4" name="Picture 3" descr="c3_08_overplotting.png"/>
-          <p:cNvPicPr>
-            <a:picLocks noChangeAspect="1"/>
-          </p:cNvPicPr>
-          <p:nvPr/>
-        </p:nvPicPr>
-        <p:blipFill>
-          <a:blip r:embed="rId2"/>
-          <a:stretch>
-            <a:fillRect/>
-          </a:stretch>
-        </p:blipFill>
-        <p:spPr>
-          <a:xfrm>
-            <a:off x="699515" y="1545618"/>
-            <a:ext cx="7744968" cy="2349444"/>
-          </a:xfrm>
-          <a:prstGeom prst="rect">
-            <a:avLst/>
-          </a:prstGeom>
-        </p:spPr>
-      </p:pic>
-      <p:sp>
-        <p:nvSpPr>
-          <p:cNvPr id="5" name="TextBox 4"/>
-          <p:cNvSpPr txBox="1"/>
-          <p:nvPr/>
-        </p:nvSpPr>
-        <p:spPr>
-          <a:xfrm>
-            <a:off x="704088" y="4434840"/>
-            <a:ext cx="7744968" cy="457200"/>
-          </a:xfrm>
-          <a:prstGeom prst="rect">
-            <a:avLst/>
-          </a:prstGeom>
-          <a:noFill/>
-        </p:spPr>
-        <p:txBody>
-          <a:bodyPr wrap="square">
-            <a:spAutoFit/>
-          </a:bodyPr>
-          <a:lstStyle/>
-          <a:p>
-            <a:r>
-              <a:rPr sz="1300" b="0">
-                <a:solidFill>
-                  <a:srgbClr val="333333"/>
-                </a:solidFill>
-                <a:latin typeface="Fira Sans"/>
-              </a:rPr>
-              <a:t>Con todos los puntos sólidos, el scatter se satura y miente. Los remedios: transparencia (alpha), muestreo, o hexbin, donde el color cuenta los viajes (la distancia viene en la tabla DistanciaViaje.csv; sus −1 son faltantes disfrazados).</a:t>
+              <a:rPr sz="3400" b="1">
+                <a:solidFill>
+                  <a:srgbClr val="FFFFFF"/>
+                </a:solidFill>
+                <a:latin typeface="Fira Sans"/>
+              </a:rPr>
+              <a:t>Visualización</a:t>
+            </a:r>
+          </a:p>
+          <a:p>
+            <a:r>
+              <a:rPr sz="1800" b="0">
+                <a:solidFill>
+                  <a:srgbClr val="E0A437"/>
+                </a:solidFill>
+                <a:latin typeface="Fira Sans"/>
+              </a:rPr>
+              <a:t>Muchos puntos y colas largas</a:t>
             </a:r>
           </a:p>
         </p:txBody>
@@ -3967,14 +3968,14 @@
                 </a:solidFill>
                 <a:latin typeface="Fira Sans"/>
               </a:rPr>
-              <a:t>Cuándo usar escala logarítmica</a:t>
+              <a:t>Graficar 90 mil puntos: overplotting</a:t>
             </a:r>
           </a:p>
         </p:txBody>
       </p:sp>
       <p:pic>
         <p:nvPicPr>
-          <p:cNvPr id="4" name="Picture 3" descr="c3_10_escala_log.png"/>
+          <p:cNvPr id="4" name="Picture 3" descr="c3_08_overplotting.png"/>
           <p:cNvPicPr>
             <a:picLocks noChangeAspect="1"/>
           </p:cNvPicPr>
@@ -3988,8 +3989,8 @@
         </p:blipFill>
         <p:spPr>
           <a:xfrm>
-            <a:off x="699515" y="1227136"/>
-            <a:ext cx="7744968" cy="2986407"/>
+            <a:off x="699515" y="1545618"/>
+            <a:ext cx="7744968" cy="2349444"/>
           </a:xfrm>
           <a:prstGeom prst="rect">
             <a:avLst/>
@@ -4025,7 +4026,7 @@
                 </a:solidFill>
                 <a:latin typeface="Fira Sans"/>
               </a:rPr>
-              <a:t>La misma distancia tiene cola larga: en lineal se aplasta; en log, la forma aparece. Y transformar con log es feature engineering clásico: vuelve lineales las relaciones multiplicativas.</a:t>
+              <a:t>Con todos los puntos sólidos, el scatter se satura y miente. Los remedios: transparencia (alpha), muestreo, o hexbin, donde el color cuenta los viajes (la distancia viene en la tabla DistanciaViaje.csv; sus −1 son faltantes disfrazados).</a:t>
             </a:r>
           </a:p>
         </p:txBody>
@@ -4121,14 +4122,14 @@
                 </a:solidFill>
                 <a:latin typeface="Fira Sans"/>
               </a:rPr>
-              <a:t>La misma regresión, tres veces</a:t>
+              <a:t>Cuándo usar escala logarítmica</a:t>
             </a:r>
           </a:p>
         </p:txBody>
       </p:sp>
       <p:pic>
         <p:nvPicPr>
-          <p:cNvPr id="4" name="Picture 3" descr="c4_02_tres_modelos.png"/>
+          <p:cNvPr id="4" name="Picture 3" descr="c3_10_escala_log.png"/>
           <p:cNvPicPr>
             <a:picLocks noChangeAspect="1"/>
           </p:cNvPicPr>
@@ -4142,8 +4143,8 @@
         </p:blipFill>
         <p:spPr>
           <a:xfrm>
-            <a:off x="699515" y="1660639"/>
-            <a:ext cx="7744968" cy="2119400"/>
+            <a:off x="699515" y="1227136"/>
+            <a:ext cx="7744968" cy="2986407"/>
           </a:xfrm>
           <a:prstGeom prst="rect">
             <a:avLst/>
@@ -4179,7 +4180,7 @@
                 </a:solidFill>
                 <a:latin typeface="Fira Sans"/>
               </a:rPr>
-              <a:t>La transformación aplicada a duración ~ distancia: el log en ambos lados endereza la nube y el R² sube de 0,32 a 0,53. Y el modelo todavía pide más variables.</a:t>
+              <a:t>La misma distancia tiene cola larga: en lineal se aplasta; en log, la forma aparece. Y transformar con log es feature engineering clásico: vuelve lineales las relaciones multiplicativas.</a:t>
             </a:r>
           </a:p>
         </p:txBody>
@@ -4275,14 +4276,14 @@
                 </a:solidFill>
                 <a:latin typeface="Fira Sans"/>
               </a:rPr>
-              <a:t>El mismo gráfico, dos veces</a:t>
+              <a:t>La misma regresión, tres veces</a:t>
             </a:r>
           </a:p>
         </p:txBody>
       </p:sp>
       <p:pic>
         <p:nvPicPr>
-          <p:cNvPr id="4" name="Picture 3" descr="c3_16_mal_buen_grafico.png"/>
+          <p:cNvPr id="4" name="Picture 3" descr="c4_02_tres_modelos.png"/>
           <p:cNvPicPr>
             <a:picLocks noChangeAspect="1"/>
           </p:cNvPicPr>
@@ -4296,8 +4297,8 @@
         </p:blipFill>
         <p:spPr>
           <a:xfrm>
-            <a:off x="699515" y="1217944"/>
-            <a:ext cx="7744968" cy="3004790"/>
+            <a:off x="699515" y="1660639"/>
+            <a:ext cx="7744968" cy="2119400"/>
           </a:xfrm>
           <a:prstGeom prst="rect">
             <a:avLst/>
@@ -4333,7 +4334,7 @@
                 </a:solidFill>
                 <a:latin typeface="Fira Sans"/>
               </a:rPr>
-              <a:t>Los mismos 30 mil viajes: sin rotular y saturado, contra rotulado, con transparencia y con el hallazgo en el título.</a:t>
+              <a:t>La transformación aplicada a duración ~ distancia: el log en ambos lados endereza la nube y el R² sube de 0,32 a 0,53. Y el modelo todavía pide más variables.</a:t>
             </a:r>
           </a:p>
         </p:txBody>
@@ -4429,21 +4430,45 @@
                 </a:solidFill>
                 <a:latin typeface="Fira Sans"/>
               </a:rPr>
-              <a:t>Checklist del buen gráfico</a:t>
-            </a:r>
-          </a:p>
-        </p:txBody>
-      </p:sp>
-      <p:sp>
-        <p:nvSpPr>
-          <p:cNvPr id="4" name="TextBox 3"/>
+              <a:t>El mismo gráfico, dos veces</a:t>
+            </a:r>
+          </a:p>
+        </p:txBody>
+      </p:sp>
+      <p:pic>
+        <p:nvPicPr>
+          <p:cNvPr id="4" name="Picture 3" descr="c3_16_mal_buen_grafico.png"/>
+          <p:cNvPicPr>
+            <a:picLocks noChangeAspect="1"/>
+          </p:cNvPicPr>
+          <p:nvPr/>
+        </p:nvPicPr>
+        <p:blipFill>
+          <a:blip r:embed="rId2"/>
+          <a:stretch>
+            <a:fillRect/>
+          </a:stretch>
+        </p:blipFill>
+        <p:spPr>
+          <a:xfrm>
+            <a:off x="699515" y="1217944"/>
+            <a:ext cx="7744968" cy="3004790"/>
+          </a:xfrm>
+          <a:prstGeom prst="rect">
+            <a:avLst/>
+          </a:prstGeom>
+        </p:spPr>
+      </p:pic>
+      <p:sp>
+        <p:nvSpPr>
+          <p:cNvPr id="5" name="TextBox 4"/>
           <p:cNvSpPr txBox="1"/>
           <p:nvPr/>
         </p:nvSpPr>
         <p:spPr>
           <a:xfrm>
-            <a:off x="704088" y="1353312"/>
-            <a:ext cx="7744968" cy="3300984"/>
+            <a:off x="704088" y="4434840"/>
+            <a:ext cx="7744968" cy="457200"/>
           </a:xfrm>
           <a:prstGeom prst="rect">
             <a:avLst/>
@@ -4456,143 +4481,14 @@
           </a:bodyPr>
           <a:lstStyle/>
           <a:p>
-            <a:pPr>
-              <a:lnSpc>
-                <a:spcPct val="112000"/>
-              </a:lnSpc>
-              <a:spcAft>
-                <a:spcPts val="900"/>
-              </a:spcAft>
-            </a:pPr>
-            <a:r>
-              <a:rPr sz="1800" b="1">
-                <a:solidFill>
-                  <a:srgbClr val="E0A437"/>
-                </a:solidFill>
-                <a:latin typeface="Fira Sans"/>
-              </a:rPr>
-              <a:t>▸ </a:t>
-            </a:r>
-            <a:r>
-              <a:rPr sz="1800" b="0">
-                <a:solidFill>
-                  <a:srgbClr val="000000"/>
-                </a:solidFill>
-                <a:latin typeface="Fira Sans"/>
-              </a:rPr>
-              <a:t>Título que diga el hallazgo, no solo las variables.</a:t>
-            </a:r>
-          </a:p>
-          <a:p>
-            <a:pPr>
-              <a:lnSpc>
-                <a:spcPct val="112000"/>
-              </a:lnSpc>
-              <a:spcAft>
-                <a:spcPts val="900"/>
-              </a:spcAft>
-            </a:pPr>
-            <a:r>
-              <a:rPr sz="1800" b="1">
-                <a:solidFill>
-                  <a:srgbClr val="E0A437"/>
-                </a:solidFill>
-                <a:latin typeface="Fira Sans"/>
-              </a:rPr>
-              <a:t>▸ </a:t>
-            </a:r>
-            <a:r>
-              <a:rPr sz="1800" b="0">
-                <a:solidFill>
-                  <a:srgbClr val="000000"/>
-                </a:solidFill>
-                <a:latin typeface="Fira Sans"/>
-              </a:rPr>
-              <a:t>Ejes con nombre y unidad; ejes que parten de cero en gráficos de barras.</a:t>
-            </a:r>
-          </a:p>
-          <a:p>
-            <a:pPr>
-              <a:lnSpc>
-                <a:spcPct val="112000"/>
-              </a:lnSpc>
-              <a:spcAft>
-                <a:spcPts val="900"/>
-              </a:spcAft>
-            </a:pPr>
-            <a:r>
-              <a:rPr sz="1800" b="1">
-                <a:solidFill>
-                  <a:srgbClr val="E0A437"/>
-                </a:solidFill>
-                <a:latin typeface="Fira Sans"/>
-              </a:rPr>
-              <a:t>▸ </a:t>
-            </a:r>
-            <a:r>
-              <a:rPr sz="1800" b="0">
-                <a:solidFill>
-                  <a:srgbClr val="000000"/>
-                </a:solidFill>
-                <a:latin typeface="Fira Sans"/>
-              </a:rPr>
-              <a:t>Muchos puntos: alpha, muestreo o hexbin.</a:t>
-            </a:r>
-          </a:p>
-          <a:p>
-            <a:pPr>
-              <a:lnSpc>
-                <a:spcPct val="112000"/>
-              </a:lnSpc>
-              <a:spcAft>
-                <a:spcPts val="900"/>
-              </a:spcAft>
-            </a:pPr>
-            <a:r>
-              <a:rPr sz="1800" b="1">
-                <a:solidFill>
-                  <a:srgbClr val="E0A437"/>
-                </a:solidFill>
-                <a:latin typeface="Fira Sans"/>
-              </a:rPr>
-              <a:t>▸ </a:t>
-            </a:r>
-            <a:r>
-              <a:rPr sz="1800" b="0">
-                <a:solidFill>
-                  <a:srgbClr val="000000"/>
-                </a:solidFill>
-                <a:latin typeface="Fira Sans"/>
-              </a:rPr>
-              <a:t>Colas largas: escala logarítmica o eje recortado, declarándolo.</a:t>
-            </a:r>
-          </a:p>
-          <a:p>
-            <a:pPr>
-              <a:lnSpc>
-                <a:spcPct val="112000"/>
-              </a:lnSpc>
-              <a:spcAft>
-                <a:spcPts val="900"/>
-              </a:spcAft>
-            </a:pPr>
-            <a:r>
-              <a:rPr sz="1800" b="1">
-                <a:solidFill>
-                  <a:srgbClr val="E0A437"/>
-                </a:solidFill>
-                <a:latin typeface="Fira Sans"/>
-              </a:rPr>
-              <a:t>▸ </a:t>
-            </a:r>
-            <a:r>
-              <a:rPr sz="1800" b="1">
-                <a:solidFill>
-                  <a:srgbClr val="1D3557"/>
-                </a:solidFill>
-                <a:latin typeface="Fira Sans"/>
-              </a:rPr>
-              <a:t>El gráfico se corrige igual que el código: se itera hasta que un tercero lo entienda sin explicación oral.</a:t>
+            <a:r>
+              <a:rPr sz="1300" b="0">
+                <a:solidFill>
+                  <a:srgbClr val="333333"/>
+                </a:solidFill>
+                <a:latin typeface="Fira Sans"/>
+              </a:rPr>
+              <a:t>Los mismos 30 mil viajes: sin rotular y saturado, contra rotulado, con transparencia y con el hallazgo en el título.</a:t>
             </a:r>
           </a:p>
         </p:txBody>
@@ -4630,7 +4526,7 @@
             <a:avLst/>
           </a:prstGeom>
           <a:solidFill>
-            <a:srgbClr val="1D3557"/>
+            <a:srgbClr val="FAFBFC"/>
           </a:solidFill>
           <a:ln>
             <a:noFill/>
@@ -4667,8 +4563,8 @@
         </p:nvSpPr>
         <p:spPr>
           <a:xfrm>
-            <a:off x="603504" y="1847088"/>
-            <a:ext cx="7946136" cy="1399032"/>
+            <a:off x="402336" y="301752"/>
+            <a:ext cx="8348472" cy="795528"/>
           </a:xfrm>
           <a:prstGeom prst="rect">
             <a:avLst/>
@@ -4682,24 +4578,176 @@
           <a:lstStyle/>
           <a:p>
             <a:r>
-              <a:rPr sz="3400" b="1">
-                <a:solidFill>
-                  <a:srgbClr val="FFFFFF"/>
-                </a:solidFill>
-                <a:latin typeface="Fira Sans"/>
-              </a:rPr>
-              <a:t>Regresión múltiple</a:t>
-            </a:r>
-          </a:p>
-          <a:p>
+              <a:rPr sz="2800" b="1">
+                <a:solidFill>
+                  <a:srgbClr val="0F0F0F"/>
+                </a:solidFill>
+                <a:latin typeface="Fira Sans"/>
+              </a:rPr>
+              <a:t>Checklist del buen gráfico</a:t>
+            </a:r>
+          </a:p>
+        </p:txBody>
+      </p:sp>
+      <p:sp>
+        <p:nvSpPr>
+          <p:cNvPr id="4" name="TextBox 3"/>
+          <p:cNvSpPr txBox="1"/>
+          <p:nvPr/>
+        </p:nvSpPr>
+        <p:spPr>
+          <a:xfrm>
+            <a:off x="704088" y="1353312"/>
+            <a:ext cx="7744968" cy="3300984"/>
+          </a:xfrm>
+          <a:prstGeom prst="rect">
+            <a:avLst/>
+          </a:prstGeom>
+          <a:noFill/>
+        </p:spPr>
+        <p:txBody>
+          <a:bodyPr wrap="square">
+            <a:spAutoFit/>
+          </a:bodyPr>
+          <a:lstStyle/>
+          <a:p>
+            <a:pPr>
+              <a:lnSpc>
+                <a:spcPct val="112000"/>
+              </a:lnSpc>
+              <a:spcAft>
+                <a:spcPts val="900"/>
+              </a:spcAft>
+            </a:pPr>
+            <a:r>
+              <a:rPr sz="1800" b="1">
+                <a:solidFill>
+                  <a:srgbClr val="E0A437"/>
+                </a:solidFill>
+                <a:latin typeface="Fira Sans"/>
+              </a:rPr>
+              <a:t>▸ </a:t>
+            </a:r>
             <a:r>
               <a:rPr sz="1800" b="0">
                 <a:solidFill>
+                  <a:srgbClr val="000000"/>
+                </a:solidFill>
+                <a:latin typeface="Fira Sans"/>
+              </a:rPr>
+              <a:t>Título que diga el hallazgo, no solo las variables.</a:t>
+            </a:r>
+          </a:p>
+          <a:p>
+            <a:pPr>
+              <a:lnSpc>
+                <a:spcPct val="112000"/>
+              </a:lnSpc>
+              <a:spcAft>
+                <a:spcPts val="900"/>
+              </a:spcAft>
+            </a:pPr>
+            <a:r>
+              <a:rPr sz="1800" b="1">
+                <a:solidFill>
                   <a:srgbClr val="E0A437"/>
                 </a:solidFill>
                 <a:latin typeface="Fira Sans"/>
               </a:rPr>
-              <a:t>El primer modelo con varias variables</a:t>
+              <a:t>▸ </a:t>
+            </a:r>
+            <a:r>
+              <a:rPr sz="1800" b="0">
+                <a:solidFill>
+                  <a:srgbClr val="000000"/>
+                </a:solidFill>
+                <a:latin typeface="Fira Sans"/>
+              </a:rPr>
+              <a:t>Ejes con nombre y unidad; ejes que parten de cero en gráficos de barras.</a:t>
+            </a:r>
+          </a:p>
+          <a:p>
+            <a:pPr>
+              <a:lnSpc>
+                <a:spcPct val="112000"/>
+              </a:lnSpc>
+              <a:spcAft>
+                <a:spcPts val="900"/>
+              </a:spcAft>
+            </a:pPr>
+            <a:r>
+              <a:rPr sz="1800" b="1">
+                <a:solidFill>
+                  <a:srgbClr val="E0A437"/>
+                </a:solidFill>
+                <a:latin typeface="Fira Sans"/>
+              </a:rPr>
+              <a:t>▸ </a:t>
+            </a:r>
+            <a:r>
+              <a:rPr sz="1800" b="0">
+                <a:solidFill>
+                  <a:srgbClr val="000000"/>
+                </a:solidFill>
+                <a:latin typeface="Fira Sans"/>
+              </a:rPr>
+              <a:t>Muchos puntos: alpha, muestreo o hexbin.</a:t>
+            </a:r>
+          </a:p>
+          <a:p>
+            <a:pPr>
+              <a:lnSpc>
+                <a:spcPct val="112000"/>
+              </a:lnSpc>
+              <a:spcAft>
+                <a:spcPts val="900"/>
+              </a:spcAft>
+            </a:pPr>
+            <a:r>
+              <a:rPr sz="1800" b="1">
+                <a:solidFill>
+                  <a:srgbClr val="E0A437"/>
+                </a:solidFill>
+                <a:latin typeface="Fira Sans"/>
+              </a:rPr>
+              <a:t>▸ </a:t>
+            </a:r>
+            <a:r>
+              <a:rPr sz="1800" b="0">
+                <a:solidFill>
+                  <a:srgbClr val="000000"/>
+                </a:solidFill>
+                <a:latin typeface="Fira Sans"/>
+              </a:rPr>
+              <a:t>Colas largas: escala logarítmica o eje recortado, declarándolo.</a:t>
+            </a:r>
+          </a:p>
+          <a:p>
+            <a:pPr>
+              <a:lnSpc>
+                <a:spcPct val="112000"/>
+              </a:lnSpc>
+              <a:spcAft>
+                <a:spcPts val="900"/>
+              </a:spcAft>
+            </a:pPr>
+            <a:r>
+              <a:rPr sz="1800" b="1">
+                <a:solidFill>
+                  <a:srgbClr val="E0A437"/>
+                </a:solidFill>
+                <a:latin typeface="Fira Sans"/>
+              </a:rPr>
+              <a:t>▸ </a:t>
+            </a:r>
+            <a:r>
+              <a:rPr sz="1800" b="1">
+                <a:solidFill>
+                  <a:srgbClr val="1D3557"/>
+                </a:solidFill>
+                <a:latin typeface="Fira Sans"/>
+              </a:rPr>
+              <a:t>El gráfico se corrige igual que el código: se itera hasta que un tercero lo entienda sin explicación oral.</a:t>
             </a:r>
           </a:p>
         </p:txBody>
@@ -4737,7 +4785,7 @@
             <a:avLst/>
           </a:prstGeom>
           <a:solidFill>
-            <a:srgbClr val="FAFBFC"/>
+            <a:srgbClr val="1D3557"/>
           </a:solidFill>
           <a:ln>
             <a:noFill/>
@@ -4774,8 +4822,8 @@
         </p:nvSpPr>
         <p:spPr>
           <a:xfrm>
-            <a:off x="402336" y="301752"/>
-            <a:ext cx="8348472" cy="795528"/>
+            <a:off x="603504" y="1847088"/>
+            <a:ext cx="7946136" cy="1399032"/>
           </a:xfrm>
           <a:prstGeom prst="rect">
             <a:avLst/>
@@ -4789,71 +4837,24 @@
           <a:lstStyle/>
           <a:p>
             <a:r>
-              <a:rPr sz="2800" b="1">
-                <a:solidFill>
-                  <a:srgbClr val="0F0F0F"/>
-                </a:solidFill>
-                <a:latin typeface="Fira Sans"/>
-              </a:rPr>
-              <a:t>La fórmula de la regresión múltiple</a:t>
-            </a:r>
-          </a:p>
-        </p:txBody>
-      </p:sp>
-      <p:pic>
-        <p:nvPicPr>
-          <p:cNvPr id="4" name="Picture 3" descr="c4_01_formula_multiple.png"/>
-          <p:cNvPicPr>
-            <a:picLocks noChangeAspect="1"/>
-          </p:cNvPicPr>
-          <p:nvPr/>
-        </p:nvPicPr>
-        <p:blipFill>
-          <a:blip r:embed="rId2"/>
-          <a:stretch>
-            <a:fillRect/>
-          </a:stretch>
-        </p:blipFill>
-        <p:spPr>
-          <a:xfrm>
-            <a:off x="699515" y="1500263"/>
-            <a:ext cx="7744968" cy="2440154"/>
-          </a:xfrm>
-          <a:prstGeom prst="rect">
-            <a:avLst/>
-          </a:prstGeom>
-        </p:spPr>
-      </p:pic>
-      <p:sp>
-        <p:nvSpPr>
-          <p:cNvPr id="5" name="TextBox 4"/>
-          <p:cNvSpPr txBox="1"/>
-          <p:nvPr/>
-        </p:nvSpPr>
-        <p:spPr>
-          <a:xfrm>
-            <a:off x="704088" y="4434840"/>
-            <a:ext cx="7744968" cy="457200"/>
-          </a:xfrm>
-          <a:prstGeom prst="rect">
-            <a:avLst/>
-          </a:prstGeom>
-          <a:noFill/>
-        </p:spPr>
-        <p:txBody>
-          <a:bodyPr wrap="square">
-            <a:spAutoFit/>
-          </a:bodyPr>
-          <a:lstStyle/>
-          <a:p>
-            <a:r>
-              <a:rPr sz="1300" b="0">
-                <a:solidFill>
-                  <a:srgbClr val="333333"/>
-                </a:solidFill>
-                <a:latin typeface="Fira Sans"/>
-              </a:rPr>
-              <a:t>Cada coeficiente aísla el efecto de su variable: cuánto cambia la predicción por una unidad de esa x, manteniendo las demás constantes.</a:t>
+              <a:rPr sz="3400" b="1">
+                <a:solidFill>
+                  <a:srgbClr val="FFFFFF"/>
+                </a:solidFill>
+                <a:latin typeface="Fira Sans"/>
+              </a:rPr>
+              <a:t>Regresión múltiple</a:t>
+            </a:r>
+          </a:p>
+          <a:p>
+            <a:r>
+              <a:rPr sz="1800" b="0">
+                <a:solidFill>
+                  <a:srgbClr val="E0A437"/>
+                </a:solidFill>
+                <a:latin typeface="Fira Sans"/>
+              </a:rPr>
+              <a:t>El primer modelo con varias variables</a:t>
             </a:r>
           </a:p>
         </p:txBody>
@@ -4891,7 +4892,7 @@
             <a:avLst/>
           </a:prstGeom>
           <a:solidFill>
-            <a:srgbClr val="1D3557"/>
+            <a:srgbClr val="FAFBFC"/>
           </a:solidFill>
           <a:ln>
             <a:noFill/>
@@ -4928,8 +4929,8 @@
         </p:nvSpPr>
         <p:spPr>
           <a:xfrm>
-            <a:off x="603504" y="1847088"/>
-            <a:ext cx="7946136" cy="1399032"/>
+            <a:off x="402336" y="301752"/>
+            <a:ext cx="8348472" cy="795528"/>
           </a:xfrm>
           <a:prstGeom prst="rect">
             <a:avLst/>
@@ -4943,24 +4944,71 @@
           <a:lstStyle/>
           <a:p>
             <a:r>
-              <a:rPr sz="3400" b="1">
-                <a:solidFill>
-                  <a:srgbClr val="FFFFFF"/>
-                </a:solidFill>
-                <a:latin typeface="Fira Sans"/>
-              </a:rPr>
-              <a:t>¿Mejora el modelo si agregamos el tamaño del hogar?</a:t>
-            </a:r>
-          </a:p>
-          <a:p>
-            <a:r>
-              <a:rPr sz="1800" b="0">
-                <a:solidFill>
-                  <a:srgbClr val="E0A437"/>
-                </a:solidFill>
-                <a:latin typeface="Fira Sans"/>
-              </a:rPr>
-              <a:t>Explicar los vehículos con el ingreso y las personas: la primera regresión múltiple</a:t>
+              <a:rPr sz="2800" b="1">
+                <a:solidFill>
+                  <a:srgbClr val="0F0F0F"/>
+                </a:solidFill>
+                <a:latin typeface="Fira Sans"/>
+              </a:rPr>
+              <a:t>La fórmula de la regresión múltiple</a:t>
+            </a:r>
+          </a:p>
+        </p:txBody>
+      </p:sp>
+      <p:pic>
+        <p:nvPicPr>
+          <p:cNvPr id="4" name="Picture 3" descr="c4_01_formula_multiple.png"/>
+          <p:cNvPicPr>
+            <a:picLocks noChangeAspect="1"/>
+          </p:cNvPicPr>
+          <p:nvPr/>
+        </p:nvPicPr>
+        <p:blipFill>
+          <a:blip r:embed="rId2"/>
+          <a:stretch>
+            <a:fillRect/>
+          </a:stretch>
+        </p:blipFill>
+        <p:spPr>
+          <a:xfrm>
+            <a:off x="699515" y="1500263"/>
+            <a:ext cx="7744968" cy="2440154"/>
+          </a:xfrm>
+          <a:prstGeom prst="rect">
+            <a:avLst/>
+          </a:prstGeom>
+        </p:spPr>
+      </p:pic>
+      <p:sp>
+        <p:nvSpPr>
+          <p:cNvPr id="5" name="TextBox 4"/>
+          <p:cNvSpPr txBox="1"/>
+          <p:nvPr/>
+        </p:nvSpPr>
+        <p:spPr>
+          <a:xfrm>
+            <a:off x="704088" y="4434840"/>
+            <a:ext cx="7744968" cy="457200"/>
+          </a:xfrm>
+          <a:prstGeom prst="rect">
+            <a:avLst/>
+          </a:prstGeom>
+          <a:noFill/>
+        </p:spPr>
+        <p:txBody>
+          <a:bodyPr wrap="square">
+            <a:spAutoFit/>
+          </a:bodyPr>
+          <a:lstStyle/>
+          <a:p>
+            <a:r>
+              <a:rPr sz="1300" b="0">
+                <a:solidFill>
+                  <a:srgbClr val="333333"/>
+                </a:solidFill>
+                <a:latin typeface="Fira Sans"/>
+              </a:rPr>
+              <a:t>Cada coeficiente aísla el efecto de su variable: cuánto cambia la predicción por una unidad de esa x, manteniendo las demás constantes.</a:t>
             </a:r>
           </a:p>
         </p:txBody>
@@ -5056,7 +5104,7 @@
                 </a:solidFill>
                 <a:latin typeface="Fira Sans"/>
               </a:rPr>
-              <a:t>Contenidos de la clase</a:t>
+              <a:t>Avisos del proyecto Capstone</a:t>
             </a:r>
           </a:p>
         </p:txBody>
@@ -5101,13 +5149,13 @@
               <a:t>▸ </a:t>
             </a:r>
             <a:r>
-              <a:rPr sz="1800" b="0">
-                <a:solidFill>
-                  <a:srgbClr val="000000"/>
-                </a:solidFill>
-                <a:latin typeface="Fira Sans"/>
-              </a:rPr>
-              <a:t>1. El impacto de sacar filas y atípicos.</a:t>
+              <a:rPr sz="1800" b="1">
+                <a:solidFill>
+                  <a:srgbClr val="1D3557"/>
+                </a:solidFill>
+                <a:latin typeface="Fira Sans"/>
+              </a:rPr>
+              <a:t>Hoy, en el segundo bloque: presentación de la idea de cada equipo, de 5 a 7 minutos, sin nota.</a:t>
             </a:r>
           </a:p>
           <a:p>
@@ -5135,7 +5183,7 @@
                 </a:solidFill>
                 <a:latin typeface="Fira Sans"/>
               </a:rPr>
-              <a:t>2. La regresión ponderada (WLS).</a:t>
+              <a:t>La formulación se entrega el lunes 7; el primer análisis exploratorio, el lunes 15.</a:t>
             </a:r>
           </a:p>
           <a:p>
@@ -5163,63 +5211,7 @@
                 </a:solidFill>
                 <a:latin typeface="Fira Sans"/>
               </a:rPr>
-              <a:t>3. Visualización: muchos puntos y colas largas.</a:t>
-            </a:r>
-          </a:p>
-          <a:p>
-            <a:pPr>
-              <a:lnSpc>
-                <a:spcPct val="112000"/>
-              </a:lnSpc>
-              <a:spcAft>
-                <a:spcPts val="900"/>
-              </a:spcAft>
-            </a:pPr>
-            <a:r>
-              <a:rPr sz="1800" b="1">
-                <a:solidFill>
-                  <a:srgbClr val="E0A437"/>
-                </a:solidFill>
-                <a:latin typeface="Fira Sans"/>
-              </a:rPr>
-              <a:t>▸ </a:t>
-            </a:r>
-            <a:r>
-              <a:rPr sz="1800" b="0">
-                <a:solidFill>
-                  <a:srgbClr val="000000"/>
-                </a:solidFill>
-                <a:latin typeface="Fira Sans"/>
-              </a:rPr>
-              <a:t>4. Regresión múltiple: varias variables a la vez.</a:t>
-            </a:r>
-          </a:p>
-          <a:p>
-            <a:pPr>
-              <a:lnSpc>
-                <a:spcPct val="112000"/>
-              </a:lnSpc>
-              <a:spcAft>
-                <a:spcPts val="900"/>
-              </a:spcAft>
-            </a:pPr>
-            <a:r>
-              <a:rPr sz="1800" b="1">
-                <a:solidFill>
-                  <a:srgbClr val="E0A437"/>
-                </a:solidFill>
-                <a:latin typeface="Fira Sans"/>
-              </a:rPr>
-              <a:t>▸ </a:t>
-            </a:r>
-            <a:r>
-              <a:rPr sz="1800" b="0">
-                <a:solidFill>
-                  <a:srgbClr val="000000"/>
-                </a:solidFill>
-                <a:latin typeface="Fira Sans"/>
-              </a:rPr>
-              <a:t>5. Presentaciones de las ideas de proyecto Capstone (segundo bloque).</a:t>
+              <a:t>El enunciado y la rúbrica del primer análisis exploratorio ya están publicados en el repositorio.</a:t>
             </a:r>
           </a:p>
         </p:txBody>
@@ -5257,7 +5249,7 @@
             <a:avLst/>
           </a:prstGeom>
           <a:solidFill>
-            <a:srgbClr val="FAFBFC"/>
+            <a:srgbClr val="1D3557"/>
           </a:solidFill>
           <a:ln>
             <a:noFill/>
@@ -5294,8 +5286,8 @@
         </p:nvSpPr>
         <p:spPr>
           <a:xfrm>
-            <a:off x="402336" y="301752"/>
-            <a:ext cx="8348472" cy="795528"/>
+            <a:off x="603504" y="1847088"/>
+            <a:ext cx="7946136" cy="1399032"/>
           </a:xfrm>
           <a:prstGeom prst="rect">
             <a:avLst/>
@@ -5309,167 +5301,24 @@
           <a:lstStyle/>
           <a:p>
             <a:r>
-              <a:rPr sz="2800" b="1">
-                <a:solidFill>
-                  <a:srgbClr val="0F0F0F"/>
-                </a:solidFill>
-                <a:latin typeface="Fira Sans"/>
-              </a:rPr>
-              <a:t>La motorización, con dos variables</a:t>
-            </a:r>
-          </a:p>
-        </p:txBody>
-      </p:sp>
-      <p:sp>
-        <p:nvSpPr>
-          <p:cNvPr id="4" name="Rectangle 3"/>
-          <p:cNvSpPr/>
-          <p:nvPr/>
-        </p:nvSpPr>
-        <p:spPr>
-          <a:xfrm>
-            <a:off x="704088" y="1280160"/>
-            <a:ext cx="7744968" cy="2880360"/>
-          </a:xfrm>
-          <a:prstGeom prst="rect">
-            <a:avLst/>
-          </a:prstGeom>
-          <a:solidFill>
-            <a:srgbClr val="F0F2F5"/>
-          </a:solidFill>
-          <a:ln>
-            <a:solidFill>
-              <a:srgbClr val="D8DDE3"/>
-            </a:solidFill>
-          </a:ln>
-          <a:effectLst/>
-        </p:spPr>
-        <p:style>
-          <a:lnRef idx="1">
-            <a:schemeClr val="accent1"/>
-          </a:lnRef>
-          <a:fillRef idx="3">
-            <a:schemeClr val="accent1"/>
-          </a:fillRef>
-          <a:effectRef idx="2">
-            <a:schemeClr val="accent1"/>
-          </a:effectRef>
-          <a:fontRef idx="minor">
-            <a:schemeClr val="lt1"/>
-          </a:fontRef>
-        </p:style>
-        <p:txBody>
-          <a:bodyPr rtlCol="0" anchor="ctr" wrap="square" lIns="228600" tIns="137160"/>
-          <a:lstStyle/>
-          <a:p>
-            <a:pPr/>
-            <a:r>
-              <a:rPr sz="1500" b="0">
-                <a:solidFill>
-                  <a:srgbClr val="1D3557"/>
-                </a:solidFill>
-                <a:latin typeface="Menlo"/>
-              </a:rPr>
-              <a:t># Explicar los vehículos del hogar con el ingreso y las personas</a:t>
-            </a:r>
-          </a:p>
-          <a:p>
-            <a:pPr/>
-            <a:r>
-              <a:rPr sz="1500" b="0">
-                <a:solidFill>
-                  <a:srgbClr val="1D3557"/>
-                </a:solidFill>
-                <a:latin typeface="Menlo"/>
-              </a:rPr>
-              <a:t>X = sm.add_constant(pd.DataFrame({</a:t>
-            </a:r>
-          </a:p>
-          <a:p>
-            <a:pPr/>
-            <a:r>
-              <a:rPr sz="1500" b="0">
-                <a:solidFill>
-                  <a:srgbClr val="1D3557"/>
-                </a:solidFill>
-                <a:latin typeface="Menlo"/>
-              </a:rPr>
-              <a:t>    "ingreso": h["IngresoHogar"] / 1e6,</a:t>
-            </a:r>
-          </a:p>
-          <a:p>
-            <a:pPr/>
-            <a:r>
-              <a:rPr sz="1500" b="0">
-                <a:solidFill>
-                  <a:srgbClr val="1D3557"/>
-                </a:solidFill>
-                <a:latin typeface="Menlo"/>
-              </a:rPr>
-              <a:t>    "personas": h["NumPer"]}))</a:t>
-            </a:r>
-          </a:p>
-          <a:p>
-            <a:pPr/>
-            <a:r>
-              <a:rPr sz="1500" b="0">
-                <a:solidFill>
-                  <a:srgbClr val="1D3557"/>
-                </a:solidFill>
-                <a:latin typeface="Menlo"/>
-              </a:rPr>
-              <a:t>modelo = sm.WLS(h["NumVeh"], X, weights=h["Factor"]).fit()</a:t>
-            </a:r>
-          </a:p>
-        </p:txBody>
-      </p:sp>
-      <p:sp>
-        <p:nvSpPr>
-          <p:cNvPr id="5" name="TextBox 4"/>
-          <p:cNvSpPr txBox="1"/>
-          <p:nvPr/>
-        </p:nvSpPr>
-        <p:spPr>
-          <a:xfrm>
-            <a:off x="704088" y="4389120"/>
-            <a:ext cx="7744968" cy="1097280"/>
-          </a:xfrm>
-          <a:prstGeom prst="rect">
-            <a:avLst/>
-          </a:prstGeom>
-          <a:noFill/>
-        </p:spPr>
-        <p:txBody>
-          <a:bodyPr wrap="square">
-            <a:spAutoFit/>
-          </a:bodyPr>
-          <a:lstStyle/>
-          <a:p>
-            <a:pPr>
-              <a:lnSpc>
-                <a:spcPct val="112000"/>
-              </a:lnSpc>
-              <a:spcAft>
-                <a:spcPts val="900"/>
-              </a:spcAft>
-            </a:pPr>
-            <a:r>
-              <a:rPr sz="1600" b="1">
+              <a:rPr sz="3400" b="1">
+                <a:solidFill>
+                  <a:srgbClr val="FFFFFF"/>
+                </a:solidFill>
+                <a:latin typeface="Fira Sans"/>
+              </a:rPr>
+              <a:t>¿Mejora el modelo si agregamos el tamaño del hogar?</a:t>
+            </a:r>
+          </a:p>
+          <a:p>
+            <a:r>
+              <a:rPr sz="1800" b="0">
                 <a:solidFill>
                   <a:srgbClr val="E0A437"/>
                 </a:solidFill>
                 <a:latin typeface="Fira Sans"/>
               </a:rPr>
-              <a:t>▸ </a:t>
-            </a:r>
-            <a:r>
-              <a:rPr sz="1600" b="0">
-                <a:solidFill>
-                  <a:srgbClr val="000000"/>
-                </a:solidFill>
-                <a:latin typeface="Fira Sans"/>
-              </a:rPr>
-              <a:t>Ponderado: 0,48 vehículos por millón (era 0,50 a solas) y 0,03 por persona extra. El R² sube apenas, de 0,261 a 0,266: agregar variables no siempre aporta.</a:t>
+              <a:t>Explicar los vehículos con el ingreso y las personas: la primera regresión múltiple</a:t>
             </a:r>
           </a:p>
         </p:txBody>
@@ -5565,35 +5414,114 @@
                 </a:solidFill>
                 <a:latin typeface="Fira Sans"/>
               </a:rPr>
-              <a:t>La ecuación ajustada y su lectura</a:t>
-            </a:r>
-          </a:p>
-        </p:txBody>
-      </p:sp>
-      <p:pic>
-        <p:nvPicPr>
-          <p:cNvPr id="4" name="Picture 3" descr="c4_08_ecuacion_motorizacion.png"/>
-          <p:cNvPicPr>
-            <a:picLocks noChangeAspect="1"/>
-          </p:cNvPicPr>
-          <p:nvPr/>
-        </p:nvPicPr>
-        <p:blipFill>
-          <a:blip r:embed="rId2"/>
-          <a:stretch>
-            <a:fillRect/>
-          </a:stretch>
-        </p:blipFill>
-        <p:spPr>
-          <a:xfrm>
-            <a:off x="699515" y="1292657"/>
-            <a:ext cx="7744968" cy="2855366"/>
-          </a:xfrm>
-          <a:prstGeom prst="rect">
-            <a:avLst/>
-          </a:prstGeom>
-        </p:spPr>
-      </p:pic>
+              <a:t>La motorización, con dos variables</a:t>
+            </a:r>
+          </a:p>
+        </p:txBody>
+      </p:sp>
+      <p:sp>
+        <p:nvSpPr>
+          <p:cNvPr id="4" name="Rectangle 3"/>
+          <p:cNvSpPr/>
+          <p:nvPr/>
+        </p:nvSpPr>
+        <p:spPr>
+          <a:xfrm>
+            <a:off x="704088" y="1280160"/>
+            <a:ext cx="7744968" cy="2880360"/>
+          </a:xfrm>
+          <a:prstGeom prst="rect">
+            <a:avLst/>
+          </a:prstGeom>
+          <a:solidFill>
+            <a:srgbClr val="F0F2F5"/>
+          </a:solidFill>
+          <a:ln>
+            <a:solidFill>
+              <a:srgbClr val="D8DDE3"/>
+            </a:solidFill>
+          </a:ln>
+          <a:effectLst/>
+        </p:spPr>
+        <p:style>
+          <a:lnRef idx="1">
+            <a:schemeClr val="accent1"/>
+          </a:lnRef>
+          <a:fillRef idx="3">
+            <a:schemeClr val="accent1"/>
+          </a:fillRef>
+          <a:effectRef idx="2">
+            <a:schemeClr val="accent1"/>
+          </a:effectRef>
+          <a:fontRef idx="minor">
+            <a:schemeClr val="lt1"/>
+          </a:fontRef>
+        </p:style>
+        <p:txBody>
+          <a:bodyPr rtlCol="0" anchor="ctr" wrap="square" lIns="228600" tIns="137160"/>
+          <a:lstStyle/>
+          <a:p>
+            <a:pPr/>
+            <a:r>
+              <a:rPr sz="1500" b="0">
+                <a:solidFill>
+                  <a:srgbClr val="1D3557"/>
+                </a:solidFill>
+                <a:latin typeface="Menlo"/>
+              </a:rPr>
+              <a:t># Explicar los vehículos del hogar con el ingreso y las personas</a:t>
+            </a:r>
+          </a:p>
+          <a:p>
+            <a:pPr/>
+            <a:r>
+              <a:rPr sz="1500" b="0">
+                <a:solidFill>
+                  <a:srgbClr val="1D3557"/>
+                </a:solidFill>
+                <a:latin typeface="Menlo"/>
+              </a:rPr>
+              <a:t>X = sm.add_constant(pd.DataFrame({</a:t>
+            </a:r>
+          </a:p>
+          <a:p>
+            <a:pPr/>
+            <a:r>
+              <a:rPr sz="1500" b="0">
+                <a:solidFill>
+                  <a:srgbClr val="1D3557"/>
+                </a:solidFill>
+                <a:latin typeface="Menlo"/>
+              </a:rPr>
+              <a:t>    "ingreso": h["IngresoHogar"] / 1e6,</a:t>
+            </a:r>
+          </a:p>
+          <a:p>
+            <a:pPr/>
+            <a:r>
+              <a:rPr sz="1500" b="0">
+                <a:solidFill>
+                  <a:srgbClr val="1D3557"/>
+                </a:solidFill>
+                <a:latin typeface="Menlo"/>
+              </a:rPr>
+              <a:t>    "personas": h["NumPer"]}))</a:t>
+            </a:r>
+          </a:p>
+          <a:p>
+            <a:pPr/>
+            <a:r>
+              <a:rPr sz="1500" b="0">
+                <a:solidFill>
+                  <a:srgbClr val="1D3557"/>
+                </a:solidFill>
+                <a:latin typeface="Menlo"/>
+              </a:rPr>
+              <a:t>modelo = sm.WLS(h["NumVeh"], X, weights=h["Factor"]).fit()</a:t>
+            </a:r>
+          </a:p>
+        </p:txBody>
+      </p:sp>
       <p:sp>
         <p:nvSpPr>
           <p:cNvPr id="5" name="TextBox 4"/>
@@ -5602,8 +5530,8 @@
         </p:nvSpPr>
         <p:spPr>
           <a:xfrm>
-            <a:off x="704088" y="4434840"/>
-            <a:ext cx="7744968" cy="457200"/>
+            <a:off x="704088" y="4389120"/>
+            <a:ext cx="7744968" cy="1097280"/>
           </a:xfrm>
           <a:prstGeom prst="rect">
             <a:avLst/>
@@ -5616,14 +5544,31 @@
           </a:bodyPr>
           <a:lstStyle/>
           <a:p>
-            <a:r>
-              <a:rPr sz="1300" b="0">
-                <a:solidFill>
-                  <a:srgbClr val="333333"/>
-                </a:solidFill>
-                <a:latin typeface="Fira Sans"/>
-              </a:rPr>
-              <a:t>La fórmula de la múltiple con nuestros números: cada coeficiente se lee con las demás variables fijas.</a:t>
+            <a:pPr>
+              <a:lnSpc>
+                <a:spcPct val="112000"/>
+              </a:lnSpc>
+              <a:spcAft>
+                <a:spcPts val="900"/>
+              </a:spcAft>
+            </a:pPr>
+            <a:r>
+              <a:rPr sz="1600" b="1">
+                <a:solidFill>
+                  <a:srgbClr val="E0A437"/>
+                </a:solidFill>
+                <a:latin typeface="Fira Sans"/>
+              </a:rPr>
+              <a:t>▸ </a:t>
+            </a:r>
+            <a:r>
+              <a:rPr sz="1600" b="0">
+                <a:solidFill>
+                  <a:srgbClr val="000000"/>
+                </a:solidFill>
+                <a:latin typeface="Fira Sans"/>
+              </a:rPr>
+              <a:t>Ponderado: 0,48 vehículos por millón (era 0,50 a solas) y 0,03 por persona extra. El R² sube apenas, de 0,261 a 0,266: agregar variables no siempre aporta.</a:t>
             </a:r>
           </a:p>
         </p:txBody>
@@ -5719,14 +5664,14 @@
                 </a:solidFill>
                 <a:latin typeface="Fira Sans"/>
               </a:rPr>
-              <a:t>Leer el modelo: R²</a:t>
+              <a:t>La ecuación ajustada y su lectura</a:t>
             </a:r>
           </a:p>
         </p:txBody>
       </p:sp>
       <p:pic>
         <p:nvPicPr>
-          <p:cNvPr id="4" name="Picture 3" descr="c4_04_formula_r2.png"/>
+          <p:cNvPr id="4" name="Picture 3" descr="c4_08_ecuacion_motorizacion.png"/>
           <p:cNvPicPr>
             <a:picLocks noChangeAspect="1"/>
           </p:cNvPicPr>
@@ -5740,8 +5685,8 @@
         </p:blipFill>
         <p:spPr>
           <a:xfrm>
-            <a:off x="699515" y="1297266"/>
-            <a:ext cx="7744968" cy="2846146"/>
+            <a:off x="699515" y="1292657"/>
+            <a:ext cx="7744968" cy="2855366"/>
           </a:xfrm>
           <a:prstGeom prst="rect">
             <a:avLst/>
@@ -5777,7 +5722,7 @@
                 </a:solidFill>
                 <a:latin typeface="Fira Sans"/>
               </a:rPr>
-              <a:t>Nuestro 0,266: ingreso y personas explican un cuarto de la variabilidad de los vehículos entre hogares. Agregar variables nunca baja el R²; por eso no basta con mirarlo.</a:t>
+              <a:t>La fórmula de la múltiple con nuestros números: cada coeficiente se lee con las demás variables fijas.</a:t>
             </a:r>
           </a:p>
         </p:txBody>
@@ -5873,14 +5818,14 @@
                 </a:solidFill>
                 <a:latin typeface="Fira Sans"/>
               </a:rPr>
-              <a:t>El valor p: dónde vive</a:t>
+              <a:t>Leer el modelo: R²</a:t>
             </a:r>
           </a:p>
         </p:txBody>
       </p:sp>
       <p:pic>
         <p:nvPicPr>
-          <p:cNvPr id="4" name="Picture 3" descr="c4_07_pvalue_summary.png"/>
+          <p:cNvPr id="4" name="Picture 3" descr="c4_04_formula_r2.png"/>
           <p:cNvPicPr>
             <a:picLocks noChangeAspect="1"/>
           </p:cNvPicPr>
@@ -5894,8 +5839,8 @@
         </p:blipFill>
         <p:spPr>
           <a:xfrm>
-            <a:off x="699515" y="1504912"/>
-            <a:ext cx="7744968" cy="2430856"/>
+            <a:off x="699515" y="1297266"/>
+            <a:ext cx="7744968" cy="2846146"/>
           </a:xfrm>
           <a:prstGeom prst="rect">
             <a:avLst/>
@@ -5931,7 +5876,7 @@
                 </a:solidFill>
                 <a:latin typeface="Fira Sans"/>
               </a:rPr>
-              <a:t>Para cada variable, P&gt;|t| responde: si en la ciudad el ingreso (o las personas) no tuviera efecto alguno sobre los vehículos, ¿qué tan raro sería este coeficiente solo por azar de la muestra? Ambos dan 0,000; la clase 5 lo formaliza.</a:t>
+              <a:t>Nuestro 0,266: ingreso y personas explican un cuarto de la variabilidad de los vehículos entre hogares. Agregar variables nunca baja el R²; por eso no basta con mirarlo.</a:t>
             </a:r>
           </a:p>
         </p:txBody>
@@ -6027,14 +5972,14 @@
                 </a:solidFill>
                 <a:latin typeface="Fira Sans"/>
               </a:rPr>
-              <a:t>El mapa para elegir variables</a:t>
+              <a:t>El valor p: dónde vive</a:t>
             </a:r>
           </a:p>
         </p:txBody>
       </p:sp>
       <p:pic>
         <p:nvPicPr>
-          <p:cNvPr id="4" name="Picture 3" descr="c4_05_mapa_candidatas.png"/>
+          <p:cNvPr id="4" name="Picture 3" descr="c4_07_pvalue_summary.png"/>
           <p:cNvPicPr>
             <a:picLocks noChangeAspect="1"/>
           </p:cNvPicPr>
@@ -6048,8 +5993,8 @@
         </p:blipFill>
         <p:spPr>
           <a:xfrm>
-            <a:off x="2530736" y="1143000"/>
-            <a:ext cx="4082527" cy="3154680"/>
+            <a:off x="699515" y="1504912"/>
+            <a:ext cx="7744968" cy="2430856"/>
           </a:xfrm>
           <a:prstGeom prst="rect">
             <a:avLst/>
@@ -6085,7 +6030,7 @@
                 </a:solidFill>
                 <a:latin typeface="Fira Sans"/>
               </a:rPr>
-              <a:t>La fila de NumVeh es el mapa: ingreso 0,47 es el motor; las bicicletas casi no correlacionan con los vehículos (0,06) y son redundantes entre sí (0,83). Probarlas confirma: R² 0,266 a 0,267.</a:t>
+              <a:t>Para cada variable, P&gt;|t| responde: si en la ciudad el ingreso (o las personas) no tuviera efecto alguno sobre los vehículos, ¿qué tan raro sería este coeficiente solo por azar de la muestra? Ambos dan 0,000; la clase 5 lo formaliza.</a:t>
             </a:r>
           </a:p>
         </p:txBody>
@@ -6181,14 +6126,14 @@
                 </a:solidFill>
                 <a:latin typeface="Fira Sans"/>
               </a:rPr>
-              <a:t>Los coeficientes al agregar variables</a:t>
+              <a:t>El mapa para elegir variables</a:t>
             </a:r>
           </a:p>
         </p:txBody>
       </p:sp>
       <p:pic>
         <p:nvPicPr>
-          <p:cNvPr id="4" name="Picture 3" descr="c4_10_cambio_coeficientes.png"/>
+          <p:cNvPr id="4" name="Picture 3" descr="c4_05_mapa_candidatas.png"/>
           <p:cNvPicPr>
             <a:picLocks noChangeAspect="1"/>
           </p:cNvPicPr>
@@ -6202,8 +6147,8 @@
         </p:blipFill>
         <p:spPr>
           <a:xfrm>
-            <a:off x="1051559" y="1143000"/>
-            <a:ext cx="7040880" cy="3154680"/>
+            <a:off x="2530736" y="1143000"/>
+            <a:ext cx="4082527" cy="3154680"/>
           </a:xfrm>
           <a:prstGeom prst="rect">
             <a:avLst/>
@@ -6239,7 +6184,7 @@
                 </a:solidFill>
                 <a:latin typeface="Fira Sans"/>
               </a:rPr>
-              <a:t>El ingreso apenas se mueve (0,50 a 0,48) al agregar personas y bicicletas: es un efecto robusto. Las variables nuevas entran con coeficientes minúsculos y el R² casi no cambia.</a:t>
+              <a:t>La fila de NumVeh es el mapa: ingreso 0,47 es el motor; las bicicletas casi no correlacionan con los vehículos (0,06) y son redundantes entre sí (0,83). Probarlas confirma: R² 0,266 a 0,267.</a:t>
             </a:r>
           </a:p>
         </p:txBody>
@@ -6335,114 +6280,35 @@
                 </a:solidFill>
                 <a:latin typeface="Fira Sans"/>
               </a:rPr>
-              <a:t>Una categórica entra como dummies</a:t>
-            </a:r>
-          </a:p>
-        </p:txBody>
-      </p:sp>
-      <p:sp>
-        <p:nvSpPr>
-          <p:cNvPr id="4" name="Rectangle 3"/>
-          <p:cNvSpPr/>
-          <p:nvPr/>
-        </p:nvSpPr>
-        <p:spPr>
-          <a:xfrm>
-            <a:off x="704088" y="1280160"/>
-            <a:ext cx="7744968" cy="2880360"/>
-          </a:xfrm>
-          <a:prstGeom prst="rect">
-            <a:avLst/>
-          </a:prstGeom>
-          <a:solidFill>
-            <a:srgbClr val="F0F2F5"/>
-          </a:solidFill>
-          <a:ln>
-            <a:solidFill>
-              <a:srgbClr val="D8DDE3"/>
-            </a:solidFill>
-          </a:ln>
-          <a:effectLst/>
-        </p:spPr>
-        <p:style>
-          <a:lnRef idx="1">
-            <a:schemeClr val="accent1"/>
-          </a:lnRef>
-          <a:fillRef idx="3">
-            <a:schemeClr val="accent1"/>
-          </a:fillRef>
-          <a:effectRef idx="2">
-            <a:schemeClr val="accent1"/>
-          </a:effectRef>
-          <a:fontRef idx="minor">
-            <a:schemeClr val="lt1"/>
-          </a:fontRef>
-        </p:style>
-        <p:txBody>
-          <a:bodyPr rtlCol="0" anchor="ctr" wrap="square" lIns="228600" tIns="137160"/>
-          <a:lstStyle/>
-          <a:p>
-            <a:pPr/>
-            <a:r>
-              <a:rPr sz="1500" b="0">
-                <a:solidFill>
-                  <a:srgbClr val="1D3557"/>
-                </a:solidFill>
-                <a:latin typeface="Menlo"/>
-              </a:rPr>
-              <a:t># Una columna 0/1 por modo; el auto queda de referencia</a:t>
-            </a:r>
-          </a:p>
-          <a:p>
-            <a:pPr/>
-            <a:r>
-              <a:rPr sz="1500" b="0">
-                <a:solidFill>
-                  <a:srgbClr val="1D3557"/>
-                </a:solidFill>
-                <a:latin typeface="Menlo"/>
-              </a:rPr>
-              <a:t>dummies = pd.get_dummies(viajes["ModoAgrupado"])</a:t>
-            </a:r>
-          </a:p>
-          <a:p>
-            <a:pPr/>
-            <a:r>
-              <a:rPr sz="1500" b="0">
-                <a:solidFill>
-                  <a:srgbClr val="1D3557"/>
-                </a:solidFill>
-                <a:latin typeface="Menlo"/>
-              </a:rPr>
-              <a:t>dummies = dummies.drop(columns=["Auto"])</a:t>
-            </a:r>
-          </a:p>
-          <a:p>
-            <a:pPr/>
-            <a:r>
-              <a:rPr sz="1500" b="0">
-                <a:solidFill>
-                  <a:srgbClr val="1D3557"/>
-                </a:solidFill>
-                <a:latin typeface="Menlo"/>
-              </a:rPr>
-              <a:t/>
-            </a:r>
-          </a:p>
-          <a:p>
-            <a:pPr/>
-            <a:r>
-              <a:rPr sz="1500" b="0">
-                <a:solidFill>
-                  <a:srgbClr val="1D3557"/>
-                </a:solidFill>
-                <a:latin typeface="Menlo"/>
-              </a:rPr>
-              <a:t># Explicar la duración (log) con la distancia (log) y el modo</a:t>
-            </a:r>
-          </a:p>
-        </p:txBody>
-      </p:sp>
+              <a:t>Los coeficientes al agregar variables</a:t>
+            </a:r>
+          </a:p>
+        </p:txBody>
+      </p:sp>
+      <p:pic>
+        <p:nvPicPr>
+          <p:cNvPr id="4" name="Picture 3" descr="c4_10_cambio_coeficientes.png"/>
+          <p:cNvPicPr>
+            <a:picLocks noChangeAspect="1"/>
+          </p:cNvPicPr>
+          <p:nvPr/>
+        </p:nvPicPr>
+        <p:blipFill>
+          <a:blip r:embed="rId2"/>
+          <a:stretch>
+            <a:fillRect/>
+          </a:stretch>
+        </p:blipFill>
+        <p:spPr>
+          <a:xfrm>
+            <a:off x="1051559" y="1143000"/>
+            <a:ext cx="7040880" cy="3154680"/>
+          </a:xfrm>
+          <a:prstGeom prst="rect">
+            <a:avLst/>
+          </a:prstGeom>
+        </p:spPr>
+      </p:pic>
       <p:sp>
         <p:nvSpPr>
           <p:cNvPr id="5" name="TextBox 4"/>
@@ -6451,8 +6317,8 @@
         </p:nvSpPr>
         <p:spPr>
           <a:xfrm>
-            <a:off x="704088" y="4389120"/>
-            <a:ext cx="7744968" cy="1097280"/>
+            <a:off x="704088" y="4434840"/>
+            <a:ext cx="7744968" cy="457200"/>
           </a:xfrm>
           <a:prstGeom prst="rect">
             <a:avLst/>
@@ -6465,31 +6331,14 @@
           </a:bodyPr>
           <a:lstStyle/>
           <a:p>
-            <a:pPr>
-              <a:lnSpc>
-                <a:spcPct val="112000"/>
-              </a:lnSpc>
-              <a:spcAft>
-                <a:spcPts val="900"/>
-              </a:spcAft>
-            </a:pPr>
-            <a:r>
-              <a:rPr sz="1600" b="1">
-                <a:solidFill>
-                  <a:srgbClr val="E0A437"/>
-                </a:solidFill>
-                <a:latin typeface="Fira Sans"/>
-              </a:rPr>
-              <a:t>▸ </a:t>
-            </a:r>
-            <a:r>
-              <a:rPr sz="1600" b="0">
-                <a:solidFill>
-                  <a:srgbClr val="000000"/>
-                </a:solidFill>
-                <a:latin typeface="Fira Sans"/>
-              </a:rPr>
-              <a:t>Cada coeficiente se lee comparado con la referencia: qué le pasa al tiempo de un viaje por ser en ese modo y no en auto, a igual distancia.</a:t>
+            <a:r>
+              <a:rPr sz="1300" b="0">
+                <a:solidFill>
+                  <a:srgbClr val="333333"/>
+                </a:solidFill>
+                <a:latin typeface="Fira Sans"/>
+              </a:rPr>
+              <a:t>El ingreso apenas se mueve (0,50 a 0,48) al agregar personas y bicicletas: es un efecto robusto. Las variables nuevas entran con coeficientes minúsculos y el R² casi no cambia.</a:t>
             </a:r>
           </a:p>
         </p:txBody>
@@ -6585,35 +6434,114 @@
                 </a:solidFill>
                 <a:latin typeface="Fira Sans"/>
               </a:rPr>
-              <a:t>El resultado: distancia y modo</a:t>
-            </a:r>
-          </a:p>
-        </p:txBody>
-      </p:sp>
-      <p:pic>
-        <p:nvPicPr>
-          <p:cNvPr id="4" name="Picture 3" descr="c4_03_coef_modo.png"/>
-          <p:cNvPicPr>
-            <a:picLocks noChangeAspect="1"/>
-          </p:cNvPicPr>
-          <p:nvPr/>
-        </p:nvPicPr>
-        <p:blipFill>
-          <a:blip r:embed="rId2"/>
-          <a:stretch>
-            <a:fillRect/>
-          </a:stretch>
-        </p:blipFill>
-        <p:spPr>
-          <a:xfrm>
-            <a:off x="804842" y="1143000"/>
-            <a:ext cx="7534315" cy="3154680"/>
-          </a:xfrm>
-          <a:prstGeom prst="rect">
-            <a:avLst/>
-          </a:prstGeom>
-        </p:spPr>
-      </p:pic>
+              <a:t>Una categórica entra como dummies</a:t>
+            </a:r>
+          </a:p>
+        </p:txBody>
+      </p:sp>
+      <p:sp>
+        <p:nvSpPr>
+          <p:cNvPr id="4" name="Rectangle 3"/>
+          <p:cNvSpPr/>
+          <p:nvPr/>
+        </p:nvSpPr>
+        <p:spPr>
+          <a:xfrm>
+            <a:off x="704088" y="1280160"/>
+            <a:ext cx="7744968" cy="2880360"/>
+          </a:xfrm>
+          <a:prstGeom prst="rect">
+            <a:avLst/>
+          </a:prstGeom>
+          <a:solidFill>
+            <a:srgbClr val="F0F2F5"/>
+          </a:solidFill>
+          <a:ln>
+            <a:solidFill>
+              <a:srgbClr val="D8DDE3"/>
+            </a:solidFill>
+          </a:ln>
+          <a:effectLst/>
+        </p:spPr>
+        <p:style>
+          <a:lnRef idx="1">
+            <a:schemeClr val="accent1"/>
+          </a:lnRef>
+          <a:fillRef idx="3">
+            <a:schemeClr val="accent1"/>
+          </a:fillRef>
+          <a:effectRef idx="2">
+            <a:schemeClr val="accent1"/>
+          </a:effectRef>
+          <a:fontRef idx="minor">
+            <a:schemeClr val="lt1"/>
+          </a:fontRef>
+        </p:style>
+        <p:txBody>
+          <a:bodyPr rtlCol="0" anchor="ctr" wrap="square" lIns="228600" tIns="137160"/>
+          <a:lstStyle/>
+          <a:p>
+            <a:pPr/>
+            <a:r>
+              <a:rPr sz="1500" b="0">
+                <a:solidFill>
+                  <a:srgbClr val="1D3557"/>
+                </a:solidFill>
+                <a:latin typeface="Menlo"/>
+              </a:rPr>
+              <a:t># Una columna 0/1 por modo; el auto queda de referencia</a:t>
+            </a:r>
+          </a:p>
+          <a:p>
+            <a:pPr/>
+            <a:r>
+              <a:rPr sz="1500" b="0">
+                <a:solidFill>
+                  <a:srgbClr val="1D3557"/>
+                </a:solidFill>
+                <a:latin typeface="Menlo"/>
+              </a:rPr>
+              <a:t>dummies = pd.get_dummies(viajes["ModoAgrupado"])</a:t>
+            </a:r>
+          </a:p>
+          <a:p>
+            <a:pPr/>
+            <a:r>
+              <a:rPr sz="1500" b="0">
+                <a:solidFill>
+                  <a:srgbClr val="1D3557"/>
+                </a:solidFill>
+                <a:latin typeface="Menlo"/>
+              </a:rPr>
+              <a:t>dummies = dummies.drop(columns=["Auto"])</a:t>
+            </a:r>
+          </a:p>
+          <a:p>
+            <a:pPr/>
+            <a:r>
+              <a:rPr sz="1500" b="0">
+                <a:solidFill>
+                  <a:srgbClr val="1D3557"/>
+                </a:solidFill>
+                <a:latin typeface="Menlo"/>
+              </a:rPr>
+              <a:t/>
+            </a:r>
+          </a:p>
+          <a:p>
+            <a:pPr/>
+            <a:r>
+              <a:rPr sz="1500" b="0">
+                <a:solidFill>
+                  <a:srgbClr val="1D3557"/>
+                </a:solidFill>
+                <a:latin typeface="Menlo"/>
+              </a:rPr>
+              <a:t># Explicar la duración (log) con la distancia (log) y el modo</a:t>
+            </a:r>
+          </a:p>
+        </p:txBody>
+      </p:sp>
       <p:sp>
         <p:nvSpPr>
           <p:cNvPr id="5" name="TextBox 4"/>
@@ -6622,8 +6550,8 @@
         </p:nvSpPr>
         <p:spPr>
           <a:xfrm>
-            <a:off x="704088" y="4434840"/>
-            <a:ext cx="7744968" cy="457200"/>
+            <a:off x="704088" y="4389120"/>
+            <a:ext cx="7744968" cy="1097280"/>
           </a:xfrm>
           <a:prstGeom prst="rect">
             <a:avLst/>
@@ -6636,14 +6564,31 @@
           </a:bodyPr>
           <a:lstStyle/>
           <a:p>
-            <a:r>
-              <a:rPr sz="1300" b="0">
-                <a:solidFill>
-                  <a:srgbClr val="333333"/>
-                </a:solidFill>
-                <a:latin typeface="Fira Sans"/>
-              </a:rPr>
-              <a:t>A igual distancia, un viaje en Bip! tarda 1,87 veces lo que uno en auto; taxi y caminata quedan casi iguales al auto. El R² sube de 0,53 a 0,60.</a:t>
+            <a:pPr>
+              <a:lnSpc>
+                <a:spcPct val="112000"/>
+              </a:lnSpc>
+              <a:spcAft>
+                <a:spcPts val="900"/>
+              </a:spcAft>
+            </a:pPr>
+            <a:r>
+              <a:rPr sz="1600" b="1">
+                <a:solidFill>
+                  <a:srgbClr val="E0A437"/>
+                </a:solidFill>
+                <a:latin typeface="Fira Sans"/>
+              </a:rPr>
+              <a:t>▸ </a:t>
+            </a:r>
+            <a:r>
+              <a:rPr sz="1600" b="0">
+                <a:solidFill>
+                  <a:srgbClr val="000000"/>
+                </a:solidFill>
+                <a:latin typeface="Fira Sans"/>
+              </a:rPr>
+              <a:t>Cada coeficiente se lee comparado con la referencia: qué le pasa al tiempo de un viaje por ser en ese modo y no en auto, a igual distancia.</a:t>
             </a:r>
           </a:p>
         </p:txBody>
@@ -6739,14 +6684,14 @@
                 </a:solidFill>
                 <a:latin typeface="Fira Sans"/>
               </a:rPr>
-              <a:t>La ecuación de la duración, leída</a:t>
+              <a:t>El resultado: distancia y modo</a:t>
             </a:r>
           </a:p>
         </p:txBody>
       </p:sp>
       <p:pic>
         <p:nvPicPr>
-          <p:cNvPr id="4" name="Picture 3" descr="c4_09_ecuacion_duracion.png"/>
+          <p:cNvPr id="4" name="Picture 3" descr="c4_03_coef_modo.png"/>
           <p:cNvPicPr>
             <a:picLocks noChangeAspect="1"/>
           </p:cNvPicPr>
@@ -6760,8 +6705,8 @@
         </p:blipFill>
         <p:spPr>
           <a:xfrm>
-            <a:off x="699515" y="1320746"/>
-            <a:ext cx="7744968" cy="2799186"/>
+            <a:off x="804842" y="1143000"/>
+            <a:ext cx="7534315" cy="3154680"/>
           </a:xfrm>
           <a:prstGeom prst="rect">
             <a:avLst/>
@@ -6797,7 +6742,7 @@
                 </a:solidFill>
                 <a:latin typeface="Fira Sans"/>
               </a:rPr>
-              <a:t>La misma tabla de coeficientes, escrita como ecuación: en escala log los efectos multiplican en vez de sumar.</a:t>
+              <a:t>A igual distancia, un viaje en Bip! tarda 1,87 veces lo que uno en auto; taxi y caminata quedan casi iguales al auto. El R² sube de 0,53 a 0,60.</a:t>
             </a:r>
           </a:p>
         </p:txBody>
@@ -6893,21 +6838,45 @@
                 </a:solidFill>
                 <a:latin typeface="Fira Sans"/>
               </a:rPr>
-              <a:t>Síntesis</a:t>
-            </a:r>
-          </a:p>
-        </p:txBody>
-      </p:sp>
-      <p:sp>
-        <p:nvSpPr>
-          <p:cNvPr id="4" name="TextBox 3"/>
+              <a:t>La ecuación de la duración, leída</a:t>
+            </a:r>
+          </a:p>
+        </p:txBody>
+      </p:sp>
+      <p:pic>
+        <p:nvPicPr>
+          <p:cNvPr id="4" name="Picture 3" descr="c4_09_ecuacion_duracion.png"/>
+          <p:cNvPicPr>
+            <a:picLocks noChangeAspect="1"/>
+          </p:cNvPicPr>
+          <p:nvPr/>
+        </p:nvPicPr>
+        <p:blipFill>
+          <a:blip r:embed="rId2"/>
+          <a:stretch>
+            <a:fillRect/>
+          </a:stretch>
+        </p:blipFill>
+        <p:spPr>
+          <a:xfrm>
+            <a:off x="699515" y="1320746"/>
+            <a:ext cx="7744968" cy="2799186"/>
+          </a:xfrm>
+          <a:prstGeom prst="rect">
+            <a:avLst/>
+          </a:prstGeom>
+        </p:spPr>
+      </p:pic>
+      <p:sp>
+        <p:nvSpPr>
+          <p:cNvPr id="5" name="TextBox 4"/>
           <p:cNvSpPr txBox="1"/>
           <p:nvPr/>
         </p:nvSpPr>
         <p:spPr>
           <a:xfrm>
-            <a:off x="704088" y="1353312"/>
-            <a:ext cx="7744968" cy="3300984"/>
+            <a:off x="704088" y="4434840"/>
+            <a:ext cx="7744968" cy="457200"/>
           </a:xfrm>
           <a:prstGeom prst="rect">
             <a:avLst/>
@@ -6920,143 +6889,14 @@
           </a:bodyPr>
           <a:lstStyle/>
           <a:p>
-            <a:pPr>
-              <a:lnSpc>
-                <a:spcPct val="112000"/>
-              </a:lnSpc>
-              <a:spcAft>
-                <a:spcPts val="900"/>
-              </a:spcAft>
-            </a:pPr>
-            <a:r>
-              <a:rPr sz="1800" b="1">
-                <a:solidFill>
-                  <a:srgbClr val="E0A437"/>
-                </a:solidFill>
-                <a:latin typeface="Fira Sans"/>
-              </a:rPr>
-              <a:t>▸ </a:t>
-            </a:r>
-            <a:r>
-              <a:rPr sz="1800" b="0">
-                <a:solidFill>
-                  <a:srgbClr val="000000"/>
-                </a:solidFill>
-                <a:latin typeface="Fira Sans"/>
-              </a:rPr>
-              <a:t>El impacto de filas y atípicos se mide con y sin, sobre todos los resúmenes en uso.</a:t>
-            </a:r>
-          </a:p>
-          <a:p>
-            <a:pPr>
-              <a:lnSpc>
-                <a:spcPct val="112000"/>
-              </a:lnSpc>
-              <a:spcAft>
-                <a:spcPts val="900"/>
-              </a:spcAft>
-            </a:pPr>
-            <a:r>
-              <a:rPr sz="1800" b="1">
-                <a:solidFill>
-                  <a:srgbClr val="E0A437"/>
-                </a:solidFill>
-                <a:latin typeface="Fira Sans"/>
-              </a:rPr>
-              <a:t>▸ </a:t>
-            </a:r>
-            <a:r>
-              <a:rPr sz="1800" b="0">
-                <a:solidFill>
-                  <a:srgbClr val="000000"/>
-                </a:solidFill>
-                <a:latin typeface="Fira Sans"/>
-              </a:rPr>
-              <a:t>Cuando la conclusión es sobre la ciudad, se pondera: WLS.</a:t>
-            </a:r>
-          </a:p>
-          <a:p>
-            <a:pPr>
-              <a:lnSpc>
-                <a:spcPct val="112000"/>
-              </a:lnSpc>
-              <a:spcAft>
-                <a:spcPts val="900"/>
-              </a:spcAft>
-            </a:pPr>
-            <a:r>
-              <a:rPr sz="1800" b="1">
-                <a:solidFill>
-                  <a:srgbClr val="E0A437"/>
-                </a:solidFill>
-                <a:latin typeface="Fira Sans"/>
-              </a:rPr>
-              <a:t>▸ </a:t>
-            </a:r>
-            <a:r>
-              <a:rPr sz="1800" b="0">
-                <a:solidFill>
-                  <a:srgbClr val="000000"/>
-                </a:solidFill>
-                <a:latin typeface="Fira Sans"/>
-              </a:rPr>
-              <a:t>Muchos puntos: alpha o hexbin. Colas largas: log.</a:t>
-            </a:r>
-          </a:p>
-          <a:p>
-            <a:pPr>
-              <a:lnSpc>
-                <a:spcPct val="112000"/>
-              </a:lnSpc>
-              <a:spcAft>
-                <a:spcPts val="900"/>
-              </a:spcAft>
-            </a:pPr>
-            <a:r>
-              <a:rPr sz="1800" b="1">
-                <a:solidFill>
-                  <a:srgbClr val="E0A437"/>
-                </a:solidFill>
-                <a:latin typeface="Fira Sans"/>
-              </a:rPr>
-              <a:t>▸ </a:t>
-            </a:r>
-            <a:r>
-              <a:rPr sz="1800" b="0">
-                <a:solidFill>
-                  <a:srgbClr val="000000"/>
-                </a:solidFill>
-                <a:latin typeface="Fira Sans"/>
-              </a:rPr>
-              <a:t>La múltiple aísla el efecto de cada variable (categóricas como dummies); R² dice cuánto explica y el valor p si un coeficiente se distingue del azar.</a:t>
-            </a:r>
-          </a:p>
-          <a:p>
-            <a:pPr>
-              <a:lnSpc>
-                <a:spcPct val="112000"/>
-              </a:lnSpc>
-              <a:spcAft>
-                <a:spcPts val="900"/>
-              </a:spcAft>
-            </a:pPr>
-            <a:r>
-              <a:rPr sz="1800" b="1">
-                <a:solidFill>
-                  <a:srgbClr val="E0A437"/>
-                </a:solidFill>
-                <a:latin typeface="Fira Sans"/>
-              </a:rPr>
-              <a:t>▸ </a:t>
-            </a:r>
-            <a:r>
-              <a:rPr sz="1800" b="1">
-                <a:solidFill>
-                  <a:srgbClr val="1D3557"/>
-                </a:solidFill>
-                <a:latin typeface="Fira Sans"/>
-              </a:rPr>
-              <a:t>El primer EDA del proyecto usa exactamente estas herramientas (entrega: lunes 15).</a:t>
+            <a:r>
+              <a:rPr sz="1300" b="0">
+                <a:solidFill>
+                  <a:srgbClr val="333333"/>
+                </a:solidFill>
+                <a:latin typeface="Fira Sans"/>
+              </a:rPr>
+              <a:t>La misma tabla de coeficientes, escrita como ecuación: en escala log los efectos multiplican en vez de sumar.</a:t>
             </a:r>
           </a:p>
         </p:txBody>
@@ -7152,7 +6992,7 @@
                 </a:solidFill>
                 <a:latin typeface="Fira Sans"/>
               </a:rPr>
-              <a:t>Avisos del proyecto Capstone</a:t>
+              <a:t>Contenidos de la clase</a:t>
             </a:r>
           </a:p>
         </p:txBody>
@@ -7197,13 +7037,13 @@
               <a:t>▸ </a:t>
             </a:r>
             <a:r>
-              <a:rPr sz="1800" b="1">
-                <a:solidFill>
-                  <a:srgbClr val="1D3557"/>
-                </a:solidFill>
-                <a:latin typeface="Fira Sans"/>
-              </a:rPr>
-              <a:t>Hoy, en el segundo bloque: presentación de la idea de cada equipo, de 5 a 7 minutos, sin nota.</a:t>
+              <a:rPr sz="1800" b="0">
+                <a:solidFill>
+                  <a:srgbClr val="000000"/>
+                </a:solidFill>
+                <a:latin typeface="Fira Sans"/>
+              </a:rPr>
+              <a:t>1. El impacto de sacar filas y atípicos.</a:t>
             </a:r>
           </a:p>
           <a:p>
@@ -7231,7 +7071,7 @@
                 </a:solidFill>
                 <a:latin typeface="Fira Sans"/>
               </a:rPr>
-              <a:t>La formulación se entrega el lunes 7; el primer análisis exploratorio, el lunes 15.</a:t>
+              <a:t>2. La regresión ponderada (WLS).</a:t>
             </a:r>
           </a:p>
           <a:p>
@@ -7259,7 +7099,63 @@
                 </a:solidFill>
                 <a:latin typeface="Fira Sans"/>
               </a:rPr>
-              <a:t>El enunciado y la rúbrica del primer análisis exploratorio ya están publicados en el repositorio.</a:t>
+              <a:t>3. Visualización: muchos puntos y colas largas.</a:t>
+            </a:r>
+          </a:p>
+          <a:p>
+            <a:pPr>
+              <a:lnSpc>
+                <a:spcPct val="112000"/>
+              </a:lnSpc>
+              <a:spcAft>
+                <a:spcPts val="900"/>
+              </a:spcAft>
+            </a:pPr>
+            <a:r>
+              <a:rPr sz="1800" b="1">
+                <a:solidFill>
+                  <a:srgbClr val="E0A437"/>
+                </a:solidFill>
+                <a:latin typeface="Fira Sans"/>
+              </a:rPr>
+              <a:t>▸ </a:t>
+            </a:r>
+            <a:r>
+              <a:rPr sz="1800" b="0">
+                <a:solidFill>
+                  <a:srgbClr val="000000"/>
+                </a:solidFill>
+                <a:latin typeface="Fira Sans"/>
+              </a:rPr>
+              <a:t>4. Regresión múltiple: varias variables a la vez.</a:t>
+            </a:r>
+          </a:p>
+          <a:p>
+            <a:pPr>
+              <a:lnSpc>
+                <a:spcPct val="112000"/>
+              </a:lnSpc>
+              <a:spcAft>
+                <a:spcPts val="900"/>
+              </a:spcAft>
+            </a:pPr>
+            <a:r>
+              <a:rPr sz="1800" b="1">
+                <a:solidFill>
+                  <a:srgbClr val="E0A437"/>
+                </a:solidFill>
+                <a:latin typeface="Fira Sans"/>
+              </a:rPr>
+              <a:t>▸ </a:t>
+            </a:r>
+            <a:r>
+              <a:rPr sz="1800" b="0">
+                <a:solidFill>
+                  <a:srgbClr val="000000"/>
+                </a:solidFill>
+                <a:latin typeface="Fira Sans"/>
+              </a:rPr>
+              <a:t>5. Presentaciones de las ideas de proyecto Capstone (segundo bloque).</a:t>
             </a:r>
           </a:p>
         </p:txBody>
@@ -7297,7 +7193,7 @@
             <a:avLst/>
           </a:prstGeom>
           <a:solidFill>
-            <a:srgbClr val="1D3557"/>
+            <a:srgbClr val="FAFBFC"/>
           </a:solidFill>
           <a:ln>
             <a:noFill/>
@@ -7334,8 +7230,8 @@
         </p:nvSpPr>
         <p:spPr>
           <a:xfrm>
-            <a:off x="603504" y="1847088"/>
-            <a:ext cx="7946136" cy="1399032"/>
+            <a:off x="402336" y="301752"/>
+            <a:ext cx="8348472" cy="795528"/>
           </a:xfrm>
           <a:prstGeom prst="rect">
             <a:avLst/>
@@ -7349,24 +7245,176 @@
           <a:lstStyle/>
           <a:p>
             <a:r>
-              <a:rPr sz="3400" b="1">
-                <a:solidFill>
-                  <a:srgbClr val="FFFFFF"/>
-                </a:solidFill>
-                <a:latin typeface="Fira Sans"/>
-              </a:rPr>
-              <a:t>Recreo</a:t>
-            </a:r>
-          </a:p>
-          <a:p>
+              <a:rPr sz="2800" b="1">
+                <a:solidFill>
+                  <a:srgbClr val="0F0F0F"/>
+                </a:solidFill>
+                <a:latin typeface="Fira Sans"/>
+              </a:rPr>
+              <a:t>Síntesis</a:t>
+            </a:r>
+          </a:p>
+        </p:txBody>
+      </p:sp>
+      <p:sp>
+        <p:nvSpPr>
+          <p:cNvPr id="4" name="TextBox 3"/>
+          <p:cNvSpPr txBox="1"/>
+          <p:nvPr/>
+        </p:nvSpPr>
+        <p:spPr>
+          <a:xfrm>
+            <a:off x="704088" y="1353312"/>
+            <a:ext cx="7744968" cy="3300984"/>
+          </a:xfrm>
+          <a:prstGeom prst="rect">
+            <a:avLst/>
+          </a:prstGeom>
+          <a:noFill/>
+        </p:spPr>
+        <p:txBody>
+          <a:bodyPr wrap="square">
+            <a:spAutoFit/>
+          </a:bodyPr>
+          <a:lstStyle/>
+          <a:p>
+            <a:pPr>
+              <a:lnSpc>
+                <a:spcPct val="112000"/>
+              </a:lnSpc>
+              <a:spcAft>
+                <a:spcPts val="900"/>
+              </a:spcAft>
+            </a:pPr>
+            <a:r>
+              <a:rPr sz="1800" b="1">
+                <a:solidFill>
+                  <a:srgbClr val="E0A437"/>
+                </a:solidFill>
+                <a:latin typeface="Fira Sans"/>
+              </a:rPr>
+              <a:t>▸ </a:t>
+            </a:r>
             <a:r>
               <a:rPr sz="1800" b="0">
                 <a:solidFill>
+                  <a:srgbClr val="000000"/>
+                </a:solidFill>
+                <a:latin typeface="Fira Sans"/>
+              </a:rPr>
+              <a:t>El impacto de filas y atípicos se mide con y sin, sobre todos los resúmenes en uso.</a:t>
+            </a:r>
+          </a:p>
+          <a:p>
+            <a:pPr>
+              <a:lnSpc>
+                <a:spcPct val="112000"/>
+              </a:lnSpc>
+              <a:spcAft>
+                <a:spcPts val="900"/>
+              </a:spcAft>
+            </a:pPr>
+            <a:r>
+              <a:rPr sz="1800" b="1">
+                <a:solidFill>
                   <a:srgbClr val="E0A437"/>
                 </a:solidFill>
                 <a:latin typeface="Fira Sans"/>
               </a:rPr>
-              <a:t>10 minutos · al volver: las presentaciones de ideas</a:t>
+              <a:t>▸ </a:t>
+            </a:r>
+            <a:r>
+              <a:rPr sz="1800" b="0">
+                <a:solidFill>
+                  <a:srgbClr val="000000"/>
+                </a:solidFill>
+                <a:latin typeface="Fira Sans"/>
+              </a:rPr>
+              <a:t>Cuando la conclusión es sobre la ciudad, se pondera: WLS.</a:t>
+            </a:r>
+          </a:p>
+          <a:p>
+            <a:pPr>
+              <a:lnSpc>
+                <a:spcPct val="112000"/>
+              </a:lnSpc>
+              <a:spcAft>
+                <a:spcPts val="900"/>
+              </a:spcAft>
+            </a:pPr>
+            <a:r>
+              <a:rPr sz="1800" b="1">
+                <a:solidFill>
+                  <a:srgbClr val="E0A437"/>
+                </a:solidFill>
+                <a:latin typeface="Fira Sans"/>
+              </a:rPr>
+              <a:t>▸ </a:t>
+            </a:r>
+            <a:r>
+              <a:rPr sz="1800" b="0">
+                <a:solidFill>
+                  <a:srgbClr val="000000"/>
+                </a:solidFill>
+                <a:latin typeface="Fira Sans"/>
+              </a:rPr>
+              <a:t>Muchos puntos: alpha o hexbin. Colas largas: log.</a:t>
+            </a:r>
+          </a:p>
+          <a:p>
+            <a:pPr>
+              <a:lnSpc>
+                <a:spcPct val="112000"/>
+              </a:lnSpc>
+              <a:spcAft>
+                <a:spcPts val="900"/>
+              </a:spcAft>
+            </a:pPr>
+            <a:r>
+              <a:rPr sz="1800" b="1">
+                <a:solidFill>
+                  <a:srgbClr val="E0A437"/>
+                </a:solidFill>
+                <a:latin typeface="Fira Sans"/>
+              </a:rPr>
+              <a:t>▸ </a:t>
+            </a:r>
+            <a:r>
+              <a:rPr sz="1800" b="0">
+                <a:solidFill>
+                  <a:srgbClr val="000000"/>
+                </a:solidFill>
+                <a:latin typeface="Fira Sans"/>
+              </a:rPr>
+              <a:t>La múltiple aísla el efecto de cada variable (categóricas como dummies); R² dice cuánto explica y el valor p si un coeficiente se distingue del azar.</a:t>
+            </a:r>
+          </a:p>
+          <a:p>
+            <a:pPr>
+              <a:lnSpc>
+                <a:spcPct val="112000"/>
+              </a:lnSpc>
+              <a:spcAft>
+                <a:spcPts val="900"/>
+              </a:spcAft>
+            </a:pPr>
+            <a:r>
+              <a:rPr sz="1800" b="1">
+                <a:solidFill>
+                  <a:srgbClr val="E0A437"/>
+                </a:solidFill>
+                <a:latin typeface="Fira Sans"/>
+              </a:rPr>
+              <a:t>▸ </a:t>
+            </a:r>
+            <a:r>
+              <a:rPr sz="1800" b="1">
+                <a:solidFill>
+                  <a:srgbClr val="1D3557"/>
+                </a:solidFill>
+                <a:latin typeface="Fira Sans"/>
+              </a:rPr>
+              <a:t>El primer EDA del proyecto usa exactamente estas herramientas (entrega: lunes 15).</a:t>
             </a:r>
           </a:p>
         </p:txBody>
@@ -7462,7 +7510,7 @@
                 </a:solidFill>
                 <a:latin typeface="Fira Sans"/>
               </a:rPr>
-              <a:t>Presentaciones de ideas</a:t>
+              <a:t>Recreo</a:t>
             </a:r>
           </a:p>
           <a:p>
@@ -7473,7 +7521,7 @@
                 </a:solidFill>
                 <a:latin typeface="Fira Sans"/>
               </a:rPr>
-              <a:t>De 5 a 7 minutos por equipo, y preguntas de todos</a:t>
+              <a:t>10 minutos · al volver: las presentaciones de ideas</a:t>
             </a:r>
           </a:p>
         </p:txBody>
@@ -7511,7 +7559,7 @@
             <a:avLst/>
           </a:prstGeom>
           <a:solidFill>
-            <a:srgbClr val="FAFBFC"/>
+            <a:srgbClr val="1D3557"/>
           </a:solidFill>
           <a:ln>
             <a:noFill/>
@@ -7548,8 +7596,8 @@
         </p:nvSpPr>
         <p:spPr>
           <a:xfrm>
-            <a:off x="402336" y="301752"/>
-            <a:ext cx="8348472" cy="795528"/>
+            <a:off x="603504" y="1847088"/>
+            <a:ext cx="7946136" cy="1399032"/>
           </a:xfrm>
           <a:prstGeom prst="rect">
             <a:avLst/>
@@ -7563,92 +7611,24 @@
           <a:lstStyle/>
           <a:p>
             <a:r>
-              <a:rPr sz="2800" b="1">
-                <a:solidFill>
-                  <a:srgbClr val="0F0F0F"/>
-                </a:solidFill>
-                <a:latin typeface="Fira Sans"/>
-              </a:rPr>
-              <a:t>El formato</a:t>
-            </a:r>
-          </a:p>
-        </p:txBody>
-      </p:sp>
-      <p:sp>
-        <p:nvSpPr>
-          <p:cNvPr id="4" name="TextBox 3"/>
-          <p:cNvSpPr txBox="1"/>
-          <p:nvPr/>
-        </p:nvSpPr>
-        <p:spPr>
-          <a:xfrm>
-            <a:off x="704088" y="1353312"/>
-            <a:ext cx="7744968" cy="3300984"/>
-          </a:xfrm>
-          <a:prstGeom prst="rect">
-            <a:avLst/>
-          </a:prstGeom>
-          <a:noFill/>
-        </p:spPr>
-        <p:txBody>
-          <a:bodyPr wrap="square">
-            <a:spAutoFit/>
-          </a:bodyPr>
-          <a:lstStyle/>
-          <a:p>
-            <a:pPr>
-              <a:lnSpc>
-                <a:spcPct val="112000"/>
-              </a:lnSpc>
-              <a:spcAft>
-                <a:spcPts val="900"/>
-              </a:spcAft>
-            </a:pPr>
-            <a:r>
-              <a:rPr sz="1800" b="1">
+              <a:rPr sz="3400" b="1">
+                <a:solidFill>
+                  <a:srgbClr val="FFFFFF"/>
+                </a:solidFill>
+                <a:latin typeface="Fira Sans"/>
+              </a:rPr>
+              <a:t>Presentaciones de ideas</a:t>
+            </a:r>
+          </a:p>
+          <a:p>
+            <a:r>
+              <a:rPr sz="1800" b="0">
                 <a:solidFill>
                   <a:srgbClr val="E0A437"/>
                 </a:solidFill>
                 <a:latin typeface="Fira Sans"/>
               </a:rPr>
-              <a:t>▸ </a:t>
-            </a:r>
-            <a:r>
-              <a:rPr sz="1800" b="1">
-                <a:solidFill>
-                  <a:srgbClr val="1D3557"/>
-                </a:solidFill>
-                <a:latin typeface="Fira Sans"/>
-              </a:rPr>
-              <a:t>Esta instancia no lleva nota: es para recibir retroalimentación temprano, cuando corregir cuesta poco.</a:t>
-            </a:r>
-          </a:p>
-          <a:p>
-            <a:pPr>
-              <a:lnSpc>
-                <a:spcPct val="112000"/>
-              </a:lnSpc>
-              <a:spcAft>
-                <a:spcPts val="900"/>
-              </a:spcAft>
-            </a:pPr>
-            <a:r>
-              <a:rPr sz="1800" b="1">
-                <a:solidFill>
-                  <a:srgbClr val="E0A437"/>
-                </a:solidFill>
-                <a:latin typeface="Fira Sans"/>
-              </a:rPr>
-              <a:t>▸ </a:t>
-            </a:r>
-            <a:r>
-              <a:rPr sz="1800" b="0">
-                <a:solidFill>
-                  <a:srgbClr val="000000"/>
-                </a:solidFill>
-                <a:latin typeface="Fira Sans"/>
-              </a:rPr>
-              <a:t>Después de cada equipo, preguntas y comentarios del curso.</a:t>
+              <a:t>De 5 a 7 minutos por equipo, y preguntas de todos</a:t>
             </a:r>
           </a:p>
         </p:txBody>
@@ -7744,7 +7724,7 @@
                 </a:solidFill>
                 <a:latin typeface="Fira Sans"/>
               </a:rPr>
-              <a:t>Próxima clase</a:t>
+              <a:t>El formato</a:t>
             </a:r>
           </a:p>
         </p:txBody>
@@ -7789,13 +7769,13 @@
               <a:t>▸ </a:t>
             </a:r>
             <a:r>
-              <a:rPr sz="1800" b="0">
-                <a:solidFill>
-                  <a:srgbClr val="000000"/>
-                </a:solidFill>
-                <a:latin typeface="Fira Sans"/>
-              </a:rPr>
-              <a:t>Martes 8: fundamentos de probabilidad y nociones de inferencia estadística.</a:t>
+              <a:rPr sz="1800" b="1">
+                <a:solidFill>
+                  <a:srgbClr val="1D3557"/>
+                </a:solidFill>
+                <a:latin typeface="Fira Sans"/>
+              </a:rPr>
+              <a:t>Esta instancia no lleva nota: es para recibir retroalimentación temprano, cuando corregir cuesta poco.</a:t>
             </a:r>
           </a:p>
           <a:p>
@@ -7823,35 +7803,7 @@
                 </a:solidFill>
                 <a:latin typeface="Fira Sans"/>
               </a:rPr>
-              <a:t>La pregunta pendiente desde la clase 3: ¿qué significa el valor p que statsmodels ya nos mostró?</a:t>
-            </a:r>
-          </a:p>
-          <a:p>
-            <a:pPr>
-              <a:lnSpc>
-                <a:spcPct val="112000"/>
-              </a:lnSpc>
-              <a:spcAft>
-                <a:spcPts val="900"/>
-              </a:spcAft>
-            </a:pPr>
-            <a:r>
-              <a:rPr sz="1800" b="1">
-                <a:solidFill>
-                  <a:srgbClr val="E0A437"/>
-                </a:solidFill>
-                <a:latin typeface="Fira Sans"/>
-              </a:rPr>
-              <a:t>▸ </a:t>
-            </a:r>
-            <a:r>
-              <a:rPr sz="1800" b="1">
-                <a:solidFill>
-                  <a:srgbClr val="1D3557"/>
-                </a:solidFill>
-                <a:latin typeface="Fira Sans"/>
-              </a:rPr>
-              <a:t>La formulación se entrega el lunes 7; el primer análisis exploratorio, el lunes 15.</a:t>
+              <a:t>Después de cada equipo, preguntas y comentarios del curso.</a:t>
             </a:r>
           </a:p>
         </p:txBody>
@@ -7947,6 +7899,209 @@
                 </a:solidFill>
                 <a:latin typeface="Fira Sans"/>
               </a:rPr>
+              <a:t>Próxima clase</a:t>
+            </a:r>
+          </a:p>
+        </p:txBody>
+      </p:sp>
+      <p:sp>
+        <p:nvSpPr>
+          <p:cNvPr id="4" name="TextBox 3"/>
+          <p:cNvSpPr txBox="1"/>
+          <p:nvPr/>
+        </p:nvSpPr>
+        <p:spPr>
+          <a:xfrm>
+            <a:off x="704088" y="1353312"/>
+            <a:ext cx="7744968" cy="3300984"/>
+          </a:xfrm>
+          <a:prstGeom prst="rect">
+            <a:avLst/>
+          </a:prstGeom>
+          <a:noFill/>
+        </p:spPr>
+        <p:txBody>
+          <a:bodyPr wrap="square">
+            <a:spAutoFit/>
+          </a:bodyPr>
+          <a:lstStyle/>
+          <a:p>
+            <a:pPr>
+              <a:lnSpc>
+                <a:spcPct val="112000"/>
+              </a:lnSpc>
+              <a:spcAft>
+                <a:spcPts val="900"/>
+              </a:spcAft>
+            </a:pPr>
+            <a:r>
+              <a:rPr sz="1800" b="1">
+                <a:solidFill>
+                  <a:srgbClr val="E0A437"/>
+                </a:solidFill>
+                <a:latin typeface="Fira Sans"/>
+              </a:rPr>
+              <a:t>▸ </a:t>
+            </a:r>
+            <a:r>
+              <a:rPr sz="1800" b="0">
+                <a:solidFill>
+                  <a:srgbClr val="000000"/>
+                </a:solidFill>
+                <a:latin typeface="Fira Sans"/>
+              </a:rPr>
+              <a:t>Martes 8: fundamentos de probabilidad y nociones de inferencia estadística.</a:t>
+            </a:r>
+          </a:p>
+          <a:p>
+            <a:pPr>
+              <a:lnSpc>
+                <a:spcPct val="112000"/>
+              </a:lnSpc>
+              <a:spcAft>
+                <a:spcPts val="900"/>
+              </a:spcAft>
+            </a:pPr>
+            <a:r>
+              <a:rPr sz="1800" b="1">
+                <a:solidFill>
+                  <a:srgbClr val="E0A437"/>
+                </a:solidFill>
+                <a:latin typeface="Fira Sans"/>
+              </a:rPr>
+              <a:t>▸ </a:t>
+            </a:r>
+            <a:r>
+              <a:rPr sz="1800" b="0">
+                <a:solidFill>
+                  <a:srgbClr val="000000"/>
+                </a:solidFill>
+                <a:latin typeface="Fira Sans"/>
+              </a:rPr>
+              <a:t>La pregunta pendiente desde la clase 3: ¿qué significa el valor p que statsmodels ya nos mostró?</a:t>
+            </a:r>
+          </a:p>
+          <a:p>
+            <a:pPr>
+              <a:lnSpc>
+                <a:spcPct val="112000"/>
+              </a:lnSpc>
+              <a:spcAft>
+                <a:spcPts val="900"/>
+              </a:spcAft>
+            </a:pPr>
+            <a:r>
+              <a:rPr sz="1800" b="1">
+                <a:solidFill>
+                  <a:srgbClr val="E0A437"/>
+                </a:solidFill>
+                <a:latin typeface="Fira Sans"/>
+              </a:rPr>
+              <a:t>▸ </a:t>
+            </a:r>
+            <a:r>
+              <a:rPr sz="1800" b="1">
+                <a:solidFill>
+                  <a:srgbClr val="1D3557"/>
+                </a:solidFill>
+                <a:latin typeface="Fira Sans"/>
+              </a:rPr>
+              <a:t>La formulación se entrega el lunes 7; el primer análisis exploratorio, el lunes 15.</a:t>
+            </a:r>
+          </a:p>
+        </p:txBody>
+      </p:sp>
+    </p:spTree>
+  </p:cSld>
+  <p:clrMapOvr>
+    <a:masterClrMapping/>
+  </p:clrMapOvr>
+</p:sld>
+</file>
+
+<file path=ppt/slides/slide35.xml><?xml version="1.0" encoding="utf-8"?>
+<p:sld xmlns:a="http://schemas.openxmlformats.org/drawingml/2006/main" xmlns:p="http://schemas.openxmlformats.org/presentationml/2006/main" xmlns:r="http://schemas.openxmlformats.org/officeDocument/2006/relationships">
+  <p:cSld>
+    <p:spTree>
+      <p:nvGrpSpPr>
+        <p:cNvPr id="1" name=""/>
+        <p:cNvGrpSpPr/>
+        <p:nvPr/>
+      </p:nvGrpSpPr>
+      <p:grpSpPr/>
+      <p:sp>
+        <p:nvSpPr>
+          <p:cNvPr id="2" name="Rectangle 1"/>
+          <p:cNvSpPr/>
+          <p:nvPr/>
+        </p:nvSpPr>
+        <p:spPr>
+          <a:xfrm>
+            <a:off x="0" y="0"/>
+            <a:ext cx="9144000" cy="5138928"/>
+          </a:xfrm>
+          <a:prstGeom prst="rect">
+            <a:avLst/>
+          </a:prstGeom>
+          <a:solidFill>
+            <a:srgbClr val="FAFBFC"/>
+          </a:solidFill>
+          <a:ln>
+            <a:noFill/>
+          </a:ln>
+          <a:effectLst/>
+        </p:spPr>
+        <p:style>
+          <a:lnRef idx="1">
+            <a:schemeClr val="accent1"/>
+          </a:lnRef>
+          <a:fillRef idx="3">
+            <a:schemeClr val="accent1"/>
+          </a:fillRef>
+          <a:effectRef idx="2">
+            <a:schemeClr val="accent1"/>
+          </a:effectRef>
+          <a:fontRef idx="minor">
+            <a:schemeClr val="lt1"/>
+          </a:fontRef>
+        </p:style>
+        <p:txBody>
+          <a:bodyPr rtlCol="0" anchor="ctr"/>
+          <a:lstStyle/>
+          <a:p>
+            <a:pPr algn="ctr"/>
+          </a:p>
+        </p:txBody>
+      </p:sp>
+      <p:sp>
+        <p:nvSpPr>
+          <p:cNvPr id="3" name="TextBox 2"/>
+          <p:cNvSpPr txBox="1"/>
+          <p:nvPr/>
+        </p:nvSpPr>
+        <p:spPr>
+          <a:xfrm>
+            <a:off x="402336" y="301752"/>
+            <a:ext cx="8348472" cy="795528"/>
+          </a:xfrm>
+          <a:prstGeom prst="rect">
+            <a:avLst/>
+          </a:prstGeom>
+          <a:noFill/>
+        </p:spPr>
+        <p:txBody>
+          <a:bodyPr wrap="square">
+            <a:spAutoFit/>
+          </a:bodyPr>
+          <a:lstStyle/>
+          <a:p>
+            <a:r>
+              <a:rPr sz="2800" b="1">
+                <a:solidFill>
+                  <a:srgbClr val="0F0F0F"/>
+                </a:solidFill>
+                <a:latin typeface="Fira Sans"/>
+              </a:rPr>
               <a:t>Referencias</a:t>
             </a:r>
           </a:p>
@@ -8142,7 +8297,7 @@
                 </a:solidFill>
                 <a:latin typeface="Fira Sans"/>
               </a:rPr>
-              <a:t>Lo pendiente de la clase 3</a:t>
+              <a:t>¿Las comunas de mayor ingreso viajan menos tiempo?</a:t>
             </a:r>
           </a:p>
           <a:p>
@@ -8153,7 +8308,7 @@
                 </a:solidFill>
                 <a:latin typeface="Fira Sans"/>
               </a:rPr>
-              <a:t>Del impacto de una fila a la regresión ponderada</a:t>
+              <a:t>El modelo inicial (clase 3): explicar la duración media del viaje por comuna con el ingreso medio del hogar, 45 comunas ponderadas. Recta: 38,3 − 4,8 · ingreso</a:t>
             </a:r>
           </a:p>
         </p:txBody>
@@ -8191,7 +8346,7 @@
             <a:avLst/>
           </a:prstGeom>
           <a:solidFill>
-            <a:srgbClr val="FAFBFC"/>
+            <a:srgbClr val="1D3557"/>
           </a:solidFill>
           <a:ln>
             <a:noFill/>
@@ -8228,8 +8383,8 @@
         </p:nvSpPr>
         <p:spPr>
           <a:xfrm>
-            <a:off x="402336" y="301752"/>
-            <a:ext cx="8348472" cy="795528"/>
+            <a:off x="603504" y="1847088"/>
+            <a:ext cx="7946136" cy="1399032"/>
           </a:xfrm>
           <a:prstGeom prst="rect">
             <a:avLst/>
@@ -8243,71 +8398,24 @@
           <a:lstStyle/>
           <a:p>
             <a:r>
-              <a:rPr sz="2800" b="1">
-                <a:solidFill>
-                  <a:srgbClr val="0F0F0F"/>
-                </a:solidFill>
-                <a:latin typeface="Fira Sans"/>
-              </a:rPr>
-              <a:t>El impacto de sacar una fila</a:t>
-            </a:r>
-          </a:p>
-        </p:txBody>
-      </p:sp>
-      <p:pic>
-        <p:nvPicPr>
-          <p:cNvPr id="4" name="Picture 3" descr="c4_06_impacto_fila.png"/>
-          <p:cNvPicPr>
-            <a:picLocks noChangeAspect="1"/>
-          </p:cNvPicPr>
-          <p:nvPr/>
-        </p:nvPicPr>
-        <p:blipFill>
-          <a:blip r:embed="rId2"/>
-          <a:stretch>
-            <a:fillRect/>
-          </a:stretch>
-        </p:blipFill>
-        <p:spPr>
-          <a:xfrm>
-            <a:off x="1353768" y="1143000"/>
-            <a:ext cx="6436462" cy="3154680"/>
-          </a:xfrm>
-          <a:prstGeom prst="rect">
-            <a:avLst/>
-          </a:prstGeom>
-        </p:spPr>
-      </p:pic>
-      <p:sp>
-        <p:nvSpPr>
-          <p:cNvPr id="5" name="TextBox 4"/>
-          <p:cNvSpPr txBox="1"/>
-          <p:nvPr/>
-        </p:nvSpPr>
-        <p:spPr>
-          <a:xfrm>
-            <a:off x="704088" y="4434840"/>
-            <a:ext cx="7744968" cy="457200"/>
-          </a:xfrm>
-          <a:prstGeom prst="rect">
-            <a:avLst/>
-          </a:prstGeom>
-          <a:noFill/>
-        </p:spPr>
-        <p:txBody>
-          <a:bodyPr wrap="square">
-            <a:spAutoFit/>
-          </a:bodyPr>
-          <a:lstStyle/>
-          <a:p>
-            <a:r>
-              <a:rPr sz="1300" b="0">
-                <a:solidFill>
-                  <a:srgbClr val="333333"/>
-                </a:solidFill>
-                <a:latin typeface="Fira Sans"/>
-              </a:rPr>
-              <a:t>Medirlo es recalcular con y sin: r casi no se mueve (−0,34), pero la pendiente cambia en un quinto, de −4,8 a −5,8 minutos por millón. Cada resumen tiene su propia sensibilidad.</a:t>
+              <a:rPr sz="3400" b="1">
+                <a:solidFill>
+                  <a:srgbClr val="FFFFFF"/>
+                </a:solidFill>
+                <a:latin typeface="Fira Sans"/>
+              </a:rPr>
+              <a:t>Lo pendiente de la clase 3</a:t>
+            </a:r>
+          </a:p>
+          <a:p>
+            <a:r>
+              <a:rPr sz="1800" b="0">
+                <a:solidFill>
+                  <a:srgbClr val="E0A437"/>
+                </a:solidFill>
+                <a:latin typeface="Fira Sans"/>
+              </a:rPr>
+              <a:t>Del impacto de una fila a la regresión ponderada</a:t>
             </a:r>
           </a:p>
         </p:txBody>
@@ -8403,14 +8511,14 @@
                 </a:solidFill>
                 <a:latin typeface="Fira Sans"/>
               </a:rPr>
-              <a:t>Las fórmulas, con factor de expansión</a:t>
+              <a:t>El impacto de sacar una fila</a:t>
             </a:r>
           </a:p>
         </p:txBody>
       </p:sp>
       <p:pic>
         <p:nvPicPr>
-          <p:cNvPr id="4" name="Picture 3" descr="c3_22_formulas_ponderada.png"/>
+          <p:cNvPr id="4" name="Picture 3" descr="c4_06_impacto_fila.png"/>
           <p:cNvPicPr>
             <a:picLocks noChangeAspect="1"/>
           </p:cNvPicPr>
@@ -8424,8 +8532,8 @@
         </p:blipFill>
         <p:spPr>
           <a:xfrm>
-            <a:off x="699515" y="1342115"/>
-            <a:ext cx="7744968" cy="2756450"/>
+            <a:off x="1353768" y="1143000"/>
+            <a:ext cx="6436462" cy="3154680"/>
           </a:xfrm>
           <a:prstGeom prst="rect">
             <a:avLst/>
@@ -8461,7 +8569,7 @@
                 </a:solidFill>
                 <a:latin typeface="Fira Sans"/>
               </a:rPr>
-              <a:t>La misma recta de mínimos cuadrados, con cada término pesado por su factor: es la que usa el modelo que sigue, y en statsmodels se llama WLS (weighted least squares).</a:t>
+              <a:t>Medirlo es recalcular con y sin: r casi no se mueve (−0,34), pero la pendiente cambia en un quinto, de −4,8 a −5,8 minutos por millón. Cada resumen tiene su propia sensibilidad.</a:t>
             </a:r>
           </a:p>
         </p:txBody>
@@ -8499,7 +8607,7 @@
             <a:avLst/>
           </a:prstGeom>
           <a:solidFill>
-            <a:srgbClr val="1D3557"/>
+            <a:srgbClr val="FAFBFC"/>
           </a:solidFill>
           <a:ln>
             <a:noFill/>
@@ -8536,8 +8644,8 @@
         </p:nvSpPr>
         <p:spPr>
           <a:xfrm>
-            <a:off x="603504" y="1847088"/>
-            <a:ext cx="7946136" cy="1399032"/>
+            <a:off x="402336" y="301752"/>
+            <a:ext cx="8348472" cy="795528"/>
           </a:xfrm>
           <a:prstGeom prst="rect">
             <a:avLst/>
@@ -8551,24 +8659,71 @@
           <a:lstStyle/>
           <a:p>
             <a:r>
-              <a:rPr sz="3400" b="1">
-                <a:solidFill>
-                  <a:srgbClr val="FFFFFF"/>
-                </a:solidFill>
-                <a:latin typeface="Fira Sans"/>
-              </a:rPr>
-              <a:t>¿Cuántos vehículos tiene un hogar según su ingreso?</a:t>
-            </a:r>
-          </a:p>
-          <a:p>
-            <a:r>
-              <a:rPr sz="1800" b="0">
-                <a:solidFill>
-                  <a:srgbClr val="E0A437"/>
-                </a:solidFill>
-                <a:latin typeface="Fira Sans"/>
-              </a:rPr>
-              <a:t>Explicar los vehículos del hogar con el ingreso: 18.264 hogares, ponderados por su factor</a:t>
+              <a:rPr sz="2800" b="1">
+                <a:solidFill>
+                  <a:srgbClr val="0F0F0F"/>
+                </a:solidFill>
+                <a:latin typeface="Fira Sans"/>
+              </a:rPr>
+              <a:t>Las fórmulas, con factor de expansión</a:t>
+            </a:r>
+          </a:p>
+        </p:txBody>
+      </p:sp>
+      <p:pic>
+        <p:nvPicPr>
+          <p:cNvPr id="4" name="Picture 3" descr="c3_22_formulas_ponderada.png"/>
+          <p:cNvPicPr>
+            <a:picLocks noChangeAspect="1"/>
+          </p:cNvPicPr>
+          <p:nvPr/>
+        </p:nvPicPr>
+        <p:blipFill>
+          <a:blip r:embed="rId2"/>
+          <a:stretch>
+            <a:fillRect/>
+          </a:stretch>
+        </p:blipFill>
+        <p:spPr>
+          <a:xfrm>
+            <a:off x="699515" y="1342115"/>
+            <a:ext cx="7744968" cy="2756450"/>
+          </a:xfrm>
+          <a:prstGeom prst="rect">
+            <a:avLst/>
+          </a:prstGeom>
+        </p:spPr>
+      </p:pic>
+      <p:sp>
+        <p:nvSpPr>
+          <p:cNvPr id="5" name="TextBox 4"/>
+          <p:cNvSpPr txBox="1"/>
+          <p:nvPr/>
+        </p:nvSpPr>
+        <p:spPr>
+          <a:xfrm>
+            <a:off x="704088" y="4434840"/>
+            <a:ext cx="7744968" cy="457200"/>
+          </a:xfrm>
+          <a:prstGeom prst="rect">
+            <a:avLst/>
+          </a:prstGeom>
+          <a:noFill/>
+        </p:spPr>
+        <p:txBody>
+          <a:bodyPr wrap="square">
+            <a:spAutoFit/>
+          </a:bodyPr>
+          <a:lstStyle/>
+          <a:p>
+            <a:r>
+              <a:rPr sz="1300" b="0">
+                <a:solidFill>
+                  <a:srgbClr val="333333"/>
+                </a:solidFill>
+                <a:latin typeface="Fira Sans"/>
+              </a:rPr>
+              <a:t>La misma recta de mínimos cuadrados, con cada término pesado por su factor: es la que usa el modelo que sigue, y en statsmodels se llama WLS (weighted least squares).</a:t>
             </a:r>
           </a:p>
         </p:txBody>
@@ -8606,7 +8761,7 @@
             <a:avLst/>
           </a:prstGeom>
           <a:solidFill>
-            <a:srgbClr val="FAFBFC"/>
+            <a:srgbClr val="1D3557"/>
           </a:solidFill>
           <a:ln>
             <a:noFill/>
@@ -8643,8 +8798,8 @@
         </p:nvSpPr>
         <p:spPr>
           <a:xfrm>
-            <a:off x="402336" y="301752"/>
-            <a:ext cx="8348472" cy="795528"/>
+            <a:off x="603504" y="1847088"/>
+            <a:ext cx="7946136" cy="1399032"/>
           </a:xfrm>
           <a:prstGeom prst="rect">
             <a:avLst/>
@@ -8658,167 +8813,24 @@
           <a:lstStyle/>
           <a:p>
             <a:r>
-              <a:rPr sz="2800" b="1">
-                <a:solidFill>
-                  <a:srgbClr val="0F0F0F"/>
-                </a:solidFill>
-                <a:latin typeface="Fira Sans"/>
-              </a:rPr>
-              <a:t>Otro modelo: la motorización del hogar</a:t>
-            </a:r>
-          </a:p>
-        </p:txBody>
-      </p:sp>
-      <p:sp>
-        <p:nvSpPr>
-          <p:cNvPr id="4" name="Rectangle 3"/>
-          <p:cNvSpPr/>
-          <p:nvPr/>
-        </p:nvSpPr>
-        <p:spPr>
-          <a:xfrm>
-            <a:off x="704088" y="1280160"/>
-            <a:ext cx="7744968" cy="2880360"/>
-          </a:xfrm>
-          <a:prstGeom prst="rect">
-            <a:avLst/>
-          </a:prstGeom>
-          <a:solidFill>
-            <a:srgbClr val="F0F2F5"/>
-          </a:solidFill>
-          <a:ln>
-            <a:solidFill>
-              <a:srgbClr val="D8DDE3"/>
-            </a:solidFill>
-          </a:ln>
-          <a:effectLst/>
-        </p:spPr>
-        <p:style>
-          <a:lnRef idx="1">
-            <a:schemeClr val="accent1"/>
-          </a:lnRef>
-          <a:fillRef idx="3">
-            <a:schemeClr val="accent1"/>
-          </a:fillRef>
-          <a:effectRef idx="2">
-            <a:schemeClr val="accent1"/>
-          </a:effectRef>
-          <a:fontRef idx="minor">
-            <a:schemeClr val="lt1"/>
-          </a:fontRef>
-        </p:style>
-        <p:txBody>
-          <a:bodyPr rtlCol="0" anchor="ctr" wrap="square" lIns="228600" tIns="137160"/>
-          <a:lstStyle/>
-          <a:p>
-            <a:pPr/>
-            <a:r>
-              <a:rPr sz="1500" b="0">
-                <a:solidFill>
-                  <a:srgbClr val="1D3557"/>
-                </a:solidFill>
-                <a:latin typeface="Menlo"/>
-              </a:rPr>
-              <a:t>x = h["IngresoHogar"] / 1e6</a:t>
-            </a:r>
-          </a:p>
-          <a:p>
-            <a:pPr/>
-            <a:r>
-              <a:rPr sz="1500" b="0">
-                <a:solidFill>
-                  <a:srgbClr val="1D3557"/>
-                </a:solidFill>
-                <a:latin typeface="Menlo"/>
-              </a:rPr>
-              <a:t>y, w = h["NumVeh"], h["Factor"]</a:t>
-            </a:r>
-          </a:p>
-          <a:p>
-            <a:pPr/>
-            <a:r>
-              <a:rPr sz="1500" b="0">
-                <a:solidFill>
-                  <a:srgbClr val="1D3557"/>
-                </a:solidFill>
-                <a:latin typeface="Menlo"/>
-              </a:rPr>
-              <a:t/>
-            </a:r>
-          </a:p>
-          <a:p>
-            <a:pPr/>
-            <a:r>
-              <a:rPr sz="1500" b="0">
-                <a:solidFill>
-                  <a:srgbClr val="1D3557"/>
-                </a:solidFill>
-                <a:latin typeface="Menlo"/>
-              </a:rPr>
-              <a:t># La fórmula de la pendiente ponderada, tal cual</a:t>
-            </a:r>
-          </a:p>
-          <a:p>
-            <a:pPr/>
-            <a:r>
-              <a:rPr sz="1500" b="0">
-                <a:solidFill>
-                  <a:srgbClr val="1D3557"/>
-                </a:solidFill>
-                <a:latin typeface="Menlo"/>
-              </a:rPr>
-              <a:t>b = (w*(x - xw)*(y - yw)).sum() / (w*(x - xw)**2).sum()</a:t>
-            </a:r>
-          </a:p>
-        </p:txBody>
-      </p:sp>
-      <p:sp>
-        <p:nvSpPr>
-          <p:cNvPr id="5" name="TextBox 4"/>
-          <p:cNvSpPr txBox="1"/>
-          <p:nvPr/>
-        </p:nvSpPr>
-        <p:spPr>
-          <a:xfrm>
-            <a:off x="704088" y="4389120"/>
-            <a:ext cx="7744968" cy="1097280"/>
-          </a:xfrm>
-          <a:prstGeom prst="rect">
-            <a:avLst/>
-          </a:prstGeom>
-          <a:noFill/>
-        </p:spPr>
-        <p:txBody>
-          <a:bodyPr wrap="square">
-            <a:spAutoFit/>
-          </a:bodyPr>
-          <a:lstStyle/>
-          <a:p>
-            <a:pPr>
-              <a:lnSpc>
-                <a:spcPct val="112000"/>
-              </a:lnSpc>
-              <a:spcAft>
-                <a:spcPts val="900"/>
-              </a:spcAft>
-            </a:pPr>
-            <a:r>
-              <a:rPr sz="1600" b="1">
+              <a:rPr sz="3400" b="1">
+                <a:solidFill>
+                  <a:srgbClr val="FFFFFF"/>
+                </a:solidFill>
+                <a:latin typeface="Fira Sans"/>
+              </a:rPr>
+              <a:t>¿Cuántos vehículos tiene un hogar según su ingreso?</a:t>
+            </a:r>
+          </a:p>
+          <a:p>
+            <a:r>
+              <a:rPr sz="1800" b="0">
                 <a:solidFill>
                   <a:srgbClr val="E0A437"/>
                 </a:solidFill>
                 <a:latin typeface="Fira Sans"/>
               </a:rPr>
-              <a:t>▸ </a:t>
-            </a:r>
-            <a:r>
-              <a:rPr sz="1600" b="0">
-                <a:solidFill>
-                  <a:srgbClr val="000000"/>
-                </a:solidFill>
-                <a:latin typeface="Fira Sans"/>
-              </a:rPr>
-              <a:t>18.264 hogares reales, ponderados por su factor: vehículos = 0,20 + 0,50 · ingreso. Medio vehículo más por cada millón.</a:t>
+              <a:t>Explicar los vehículos del hogar con el ingreso: 18.264 hogares, ponderados por su factor</a:t>
             </a:r>
           </a:p>
         </p:txBody>
@@ -8914,35 +8926,114 @@
                 </a:solidFill>
                 <a:latin typeface="Fira Sans"/>
               </a:rPr>
-              <a:t>Los atípicos de la variable a predecir</a:t>
-            </a:r>
-          </a:p>
-        </p:txBody>
-      </p:sp>
-      <p:pic>
-        <p:nvPicPr>
-          <p:cNvPr id="4" name="Picture 3" descr="c3_27_boxplot_numveh.png"/>
-          <p:cNvPicPr>
-            <a:picLocks noChangeAspect="1"/>
-          </p:cNvPicPr>
-          <p:nvPr/>
-        </p:nvPicPr>
-        <p:blipFill>
-          <a:blip r:embed="rId2"/>
-          <a:stretch>
-            <a:fillRect/>
-          </a:stretch>
-        </p:blipFill>
-        <p:spPr>
-          <a:xfrm>
-            <a:off x="699515" y="1492260"/>
-            <a:ext cx="7744968" cy="2456159"/>
-          </a:xfrm>
-          <a:prstGeom prst="rect">
-            <a:avLst/>
-          </a:prstGeom>
-        </p:spPr>
-      </p:pic>
+              <a:t>Otro modelo: la motorización del hogar</a:t>
+            </a:r>
+          </a:p>
+        </p:txBody>
+      </p:sp>
+      <p:sp>
+        <p:nvSpPr>
+          <p:cNvPr id="4" name="Rectangle 3"/>
+          <p:cNvSpPr/>
+          <p:nvPr/>
+        </p:nvSpPr>
+        <p:spPr>
+          <a:xfrm>
+            <a:off x="704088" y="1280160"/>
+            <a:ext cx="7744968" cy="2880360"/>
+          </a:xfrm>
+          <a:prstGeom prst="rect">
+            <a:avLst/>
+          </a:prstGeom>
+          <a:solidFill>
+            <a:srgbClr val="F0F2F5"/>
+          </a:solidFill>
+          <a:ln>
+            <a:solidFill>
+              <a:srgbClr val="D8DDE3"/>
+            </a:solidFill>
+          </a:ln>
+          <a:effectLst/>
+        </p:spPr>
+        <p:style>
+          <a:lnRef idx="1">
+            <a:schemeClr val="accent1"/>
+          </a:lnRef>
+          <a:fillRef idx="3">
+            <a:schemeClr val="accent1"/>
+          </a:fillRef>
+          <a:effectRef idx="2">
+            <a:schemeClr val="accent1"/>
+          </a:effectRef>
+          <a:fontRef idx="minor">
+            <a:schemeClr val="lt1"/>
+          </a:fontRef>
+        </p:style>
+        <p:txBody>
+          <a:bodyPr rtlCol="0" anchor="ctr" wrap="square" lIns="228600" tIns="137160"/>
+          <a:lstStyle/>
+          <a:p>
+            <a:pPr/>
+            <a:r>
+              <a:rPr sz="1500" b="0">
+                <a:solidFill>
+                  <a:srgbClr val="1D3557"/>
+                </a:solidFill>
+                <a:latin typeface="Menlo"/>
+              </a:rPr>
+              <a:t>x = h["IngresoHogar"] / 1e6</a:t>
+            </a:r>
+          </a:p>
+          <a:p>
+            <a:pPr/>
+            <a:r>
+              <a:rPr sz="1500" b="0">
+                <a:solidFill>
+                  <a:srgbClr val="1D3557"/>
+                </a:solidFill>
+                <a:latin typeface="Menlo"/>
+              </a:rPr>
+              <a:t>y, w = h["NumVeh"], h["Factor"]</a:t>
+            </a:r>
+          </a:p>
+          <a:p>
+            <a:pPr/>
+            <a:r>
+              <a:rPr sz="1500" b="0">
+                <a:solidFill>
+                  <a:srgbClr val="1D3557"/>
+                </a:solidFill>
+                <a:latin typeface="Menlo"/>
+              </a:rPr>
+              <a:t/>
+            </a:r>
+          </a:p>
+          <a:p>
+            <a:pPr/>
+            <a:r>
+              <a:rPr sz="1500" b="0">
+                <a:solidFill>
+                  <a:srgbClr val="1D3557"/>
+                </a:solidFill>
+                <a:latin typeface="Menlo"/>
+              </a:rPr>
+              <a:t># La fórmula de la pendiente ponderada, tal cual</a:t>
+            </a:r>
+          </a:p>
+          <a:p>
+            <a:pPr/>
+            <a:r>
+              <a:rPr sz="1500" b="0">
+                <a:solidFill>
+                  <a:srgbClr val="1D3557"/>
+                </a:solidFill>
+                <a:latin typeface="Menlo"/>
+              </a:rPr>
+              <a:t>b = (w*(x - xw)*(y - yw)).sum() / (w*(x - xw)**2).sum()</a:t>
+            </a:r>
+          </a:p>
+        </p:txBody>
+      </p:sp>
       <p:sp>
         <p:nvSpPr>
           <p:cNvPr id="5" name="TextBox 4"/>
@@ -8951,8 +9042,8 @@
         </p:nvSpPr>
         <p:spPr>
           <a:xfrm>
-            <a:off x="704088" y="4434840"/>
-            <a:ext cx="7744968" cy="457200"/>
+            <a:off x="704088" y="4389120"/>
+            <a:ext cx="7744968" cy="1097280"/>
           </a:xfrm>
           <a:prstGeom prst="rect">
             <a:avLst/>
@@ -8965,14 +9056,31 @@
           </a:bodyPr>
           <a:lstStyle/>
           <a:p>
-            <a:r>
-              <a:rPr sz="1300" b="0">
-                <a:solidFill>
-                  <a:srgbClr val="333333"/>
-                </a:solidFill>
-                <a:latin typeface="Fira Sans"/>
-              </a:rPr>
-              <a:t>El boxplot de NumVeh (clase 2): la cerca de Tukey queda en 2,5, y los hogares de 3 autos o más son atípicos. La siguiente diapo mide qué pasa al sacarlos.</a:t>
+            <a:pPr>
+              <a:lnSpc>
+                <a:spcPct val="112000"/>
+              </a:lnSpc>
+              <a:spcAft>
+                <a:spcPts val="900"/>
+              </a:spcAft>
+            </a:pPr>
+            <a:r>
+              <a:rPr sz="1600" b="1">
+                <a:solidFill>
+                  <a:srgbClr val="E0A437"/>
+                </a:solidFill>
+                <a:latin typeface="Fira Sans"/>
+              </a:rPr>
+              <a:t>▸ </a:t>
+            </a:r>
+            <a:r>
+              <a:rPr sz="1600" b="0">
+                <a:solidFill>
+                  <a:srgbClr val="000000"/>
+                </a:solidFill>
+                <a:latin typeface="Fira Sans"/>
+              </a:rPr>
+              <a:t>18.264 hogares reales, ponderados por su factor: vehículos = 0,20 + 0,50 · ingreso. Medio vehículo más por cada millón.</a:t>
             </a:r>
           </a:p>
         </p:txBody>

</xml_diff>

<commit_message>
Deck clase 4: checklist del grafico sin la frase final
Co-Authored-By: Claude Fable 5 <noreply@anthropic.com>
</commit_message>
<xml_diff>
--- a/presentaciones/clase04_regresion_multiple.pptx
+++ b/presentaciones/clase04_regresion_multiple.pptx
@@ -4720,34 +4720,6 @@
                 <a:latin typeface="Fira Sans"/>
               </a:rPr>
               <a:t>Colas largas: escala logarítmica o eje recortado, declarándolo.</a:t>
-            </a:r>
-          </a:p>
-          <a:p>
-            <a:pPr>
-              <a:lnSpc>
-                <a:spcPct val="112000"/>
-              </a:lnSpc>
-              <a:spcAft>
-                <a:spcPts val="900"/>
-              </a:spcAft>
-            </a:pPr>
-            <a:r>
-              <a:rPr sz="1800" b="1">
-                <a:solidFill>
-                  <a:srgbClr val="E0A437"/>
-                </a:solidFill>
-                <a:latin typeface="Fira Sans"/>
-              </a:rPr>
-              <a:t>▸ </a:t>
-            </a:r>
-            <a:r>
-              <a:rPr sz="1800" b="1">
-                <a:solidFill>
-                  <a:srgbClr val="1D3557"/>
-                </a:solidFill>
-                <a:latin typeface="Fira Sans"/>
-              </a:rPr>
-              <a:t>El gráfico se corrige igual que el código: se itera hasta que un tercero lo entienda sin explicación oral.</a:t>
             </a:r>
           </a:p>
         </p:txBody>

</xml_diff>

<commit_message>
Deck clase 4: la pregunta que introduce el modelo de duracion con distancia y modo
Co-Authored-By: Claude Fable 5 <noreply@anthropic.com>
</commit_message>
<xml_diff>
--- a/presentaciones/clase04_regresion_multiple.pptx
+++ b/presentaciones/clase04_regresion_multiple.pptx
@@ -40,6 +40,7 @@
     <p:sldId id="288" r:id="rId39"/>
     <p:sldId id="289" r:id="rId40"/>
     <p:sldId id="290" r:id="rId41"/>
+    <p:sldId id="291" r:id="rId42"/>
   </p:sldIdLst>
   <p:sldSz cx="9144000" cy="5138928" type="screen4x3"/>
   <p:notesSz cx="6858000" cy="9144000"/>
@@ -6348,7 +6349,7 @@
             <a:avLst/>
           </a:prstGeom>
           <a:solidFill>
-            <a:srgbClr val="FAFBFC"/>
+            <a:srgbClr val="1D3557"/>
           </a:solidFill>
           <a:ln>
             <a:noFill/>
@@ -6385,8 +6386,8 @@
         </p:nvSpPr>
         <p:spPr>
           <a:xfrm>
-            <a:off x="402336" y="301752"/>
-            <a:ext cx="8348472" cy="795528"/>
+            <a:off x="603504" y="1847088"/>
+            <a:ext cx="7946136" cy="1399032"/>
           </a:xfrm>
           <a:prstGeom prst="rect">
             <a:avLst/>
@@ -6400,167 +6401,24 @@
           <a:lstStyle/>
           <a:p>
             <a:r>
-              <a:rPr sz="2800" b="1">
-                <a:solidFill>
-                  <a:srgbClr val="0F0F0F"/>
-                </a:solidFill>
-                <a:latin typeface="Fira Sans"/>
-              </a:rPr>
-              <a:t>Una categórica entra como dummies</a:t>
-            </a:r>
-          </a:p>
-        </p:txBody>
-      </p:sp>
-      <p:sp>
-        <p:nvSpPr>
-          <p:cNvPr id="4" name="Rectangle 3"/>
-          <p:cNvSpPr/>
-          <p:nvPr/>
-        </p:nvSpPr>
-        <p:spPr>
-          <a:xfrm>
-            <a:off x="704088" y="1280160"/>
-            <a:ext cx="7744968" cy="2880360"/>
-          </a:xfrm>
-          <a:prstGeom prst="rect">
-            <a:avLst/>
-          </a:prstGeom>
-          <a:solidFill>
-            <a:srgbClr val="F0F2F5"/>
-          </a:solidFill>
-          <a:ln>
-            <a:solidFill>
-              <a:srgbClr val="D8DDE3"/>
-            </a:solidFill>
-          </a:ln>
-          <a:effectLst/>
-        </p:spPr>
-        <p:style>
-          <a:lnRef idx="1">
-            <a:schemeClr val="accent1"/>
-          </a:lnRef>
-          <a:fillRef idx="3">
-            <a:schemeClr val="accent1"/>
-          </a:fillRef>
-          <a:effectRef idx="2">
-            <a:schemeClr val="accent1"/>
-          </a:effectRef>
-          <a:fontRef idx="minor">
-            <a:schemeClr val="lt1"/>
-          </a:fontRef>
-        </p:style>
-        <p:txBody>
-          <a:bodyPr rtlCol="0" anchor="ctr" wrap="square" lIns="228600" tIns="137160"/>
-          <a:lstStyle/>
-          <a:p>
-            <a:pPr/>
-            <a:r>
-              <a:rPr sz="1500" b="0">
-                <a:solidFill>
-                  <a:srgbClr val="1D3557"/>
-                </a:solidFill>
-                <a:latin typeface="Menlo"/>
-              </a:rPr>
-              <a:t># Una columna 0/1 por modo; el auto queda de referencia</a:t>
-            </a:r>
-          </a:p>
-          <a:p>
-            <a:pPr/>
-            <a:r>
-              <a:rPr sz="1500" b="0">
-                <a:solidFill>
-                  <a:srgbClr val="1D3557"/>
-                </a:solidFill>
-                <a:latin typeface="Menlo"/>
-              </a:rPr>
-              <a:t>dummies = pd.get_dummies(viajes["ModoAgrupado"])</a:t>
-            </a:r>
-          </a:p>
-          <a:p>
-            <a:pPr/>
-            <a:r>
-              <a:rPr sz="1500" b="0">
-                <a:solidFill>
-                  <a:srgbClr val="1D3557"/>
-                </a:solidFill>
-                <a:latin typeface="Menlo"/>
-              </a:rPr>
-              <a:t>dummies = dummies.drop(columns=["Auto"])</a:t>
-            </a:r>
-          </a:p>
-          <a:p>
-            <a:pPr/>
-            <a:r>
-              <a:rPr sz="1500" b="0">
-                <a:solidFill>
-                  <a:srgbClr val="1D3557"/>
-                </a:solidFill>
-                <a:latin typeface="Menlo"/>
-              </a:rPr>
-              <a:t/>
-            </a:r>
-          </a:p>
-          <a:p>
-            <a:pPr/>
-            <a:r>
-              <a:rPr sz="1500" b="0">
-                <a:solidFill>
-                  <a:srgbClr val="1D3557"/>
-                </a:solidFill>
-                <a:latin typeface="Menlo"/>
-              </a:rPr>
-              <a:t># Explicar la duración (log) con la distancia (log) y el modo</a:t>
-            </a:r>
-          </a:p>
-        </p:txBody>
-      </p:sp>
-      <p:sp>
-        <p:nvSpPr>
-          <p:cNvPr id="5" name="TextBox 4"/>
-          <p:cNvSpPr txBox="1"/>
-          <p:nvPr/>
-        </p:nvSpPr>
-        <p:spPr>
-          <a:xfrm>
-            <a:off x="704088" y="4389120"/>
-            <a:ext cx="7744968" cy="1097280"/>
-          </a:xfrm>
-          <a:prstGeom prst="rect">
-            <a:avLst/>
-          </a:prstGeom>
-          <a:noFill/>
-        </p:spPr>
-        <p:txBody>
-          <a:bodyPr wrap="square">
-            <a:spAutoFit/>
-          </a:bodyPr>
-          <a:lstStyle/>
-          <a:p>
-            <a:pPr>
-              <a:lnSpc>
-                <a:spcPct val="112000"/>
-              </a:lnSpc>
-              <a:spcAft>
-                <a:spcPts val="900"/>
-              </a:spcAft>
-            </a:pPr>
-            <a:r>
-              <a:rPr sz="1600" b="1">
+              <a:rPr sz="3400" b="1">
+                <a:solidFill>
+                  <a:srgbClr val="FFFFFF"/>
+                </a:solidFill>
+                <a:latin typeface="Fira Sans"/>
+              </a:rPr>
+              <a:t>¿Cuánto más tarda un viaje según el modo, a igual distancia?</a:t>
+            </a:r>
+          </a:p>
+          <a:p>
+            <a:r>
+              <a:rPr sz="1800" b="0">
                 <a:solidFill>
                   <a:srgbClr val="E0A437"/>
                 </a:solidFill>
                 <a:latin typeface="Fira Sans"/>
               </a:rPr>
-              <a:t>▸ </a:t>
-            </a:r>
-            <a:r>
-              <a:rPr sz="1600" b="0">
-                <a:solidFill>
-                  <a:srgbClr val="000000"/>
-                </a:solidFill>
-                <a:latin typeface="Fira Sans"/>
-              </a:rPr>
-              <a:t>Cada coeficiente se lee comparado con la referencia: qué le pasa al tiempo de un viaje por ser en ese modo y no en auto, a igual distancia.</a:t>
+              <a:t>Explicar la duración del viaje (en log) con la distancia (en log) y el modo de transporte: 102 mil viajes de la EOD</a:t>
             </a:r>
           </a:p>
         </p:txBody>
@@ -6656,35 +6514,114 @@
                 </a:solidFill>
                 <a:latin typeface="Fira Sans"/>
               </a:rPr>
-              <a:t>El resultado: distancia y modo</a:t>
-            </a:r>
-          </a:p>
-        </p:txBody>
-      </p:sp>
-      <p:pic>
-        <p:nvPicPr>
-          <p:cNvPr id="4" name="Picture 3" descr="c4_03_coef_modo.png"/>
-          <p:cNvPicPr>
-            <a:picLocks noChangeAspect="1"/>
-          </p:cNvPicPr>
-          <p:nvPr/>
-        </p:nvPicPr>
-        <p:blipFill>
-          <a:blip r:embed="rId2"/>
-          <a:stretch>
-            <a:fillRect/>
-          </a:stretch>
-        </p:blipFill>
-        <p:spPr>
-          <a:xfrm>
-            <a:off x="804842" y="1143000"/>
-            <a:ext cx="7534315" cy="3154680"/>
-          </a:xfrm>
-          <a:prstGeom prst="rect">
-            <a:avLst/>
-          </a:prstGeom>
-        </p:spPr>
-      </p:pic>
+              <a:t>Una categórica entra como dummies</a:t>
+            </a:r>
+          </a:p>
+        </p:txBody>
+      </p:sp>
+      <p:sp>
+        <p:nvSpPr>
+          <p:cNvPr id="4" name="Rectangle 3"/>
+          <p:cNvSpPr/>
+          <p:nvPr/>
+        </p:nvSpPr>
+        <p:spPr>
+          <a:xfrm>
+            <a:off x="704088" y="1280160"/>
+            <a:ext cx="7744968" cy="2880360"/>
+          </a:xfrm>
+          <a:prstGeom prst="rect">
+            <a:avLst/>
+          </a:prstGeom>
+          <a:solidFill>
+            <a:srgbClr val="F0F2F5"/>
+          </a:solidFill>
+          <a:ln>
+            <a:solidFill>
+              <a:srgbClr val="D8DDE3"/>
+            </a:solidFill>
+          </a:ln>
+          <a:effectLst/>
+        </p:spPr>
+        <p:style>
+          <a:lnRef idx="1">
+            <a:schemeClr val="accent1"/>
+          </a:lnRef>
+          <a:fillRef idx="3">
+            <a:schemeClr val="accent1"/>
+          </a:fillRef>
+          <a:effectRef idx="2">
+            <a:schemeClr val="accent1"/>
+          </a:effectRef>
+          <a:fontRef idx="minor">
+            <a:schemeClr val="lt1"/>
+          </a:fontRef>
+        </p:style>
+        <p:txBody>
+          <a:bodyPr rtlCol="0" anchor="ctr" wrap="square" lIns="228600" tIns="137160"/>
+          <a:lstStyle/>
+          <a:p>
+            <a:pPr/>
+            <a:r>
+              <a:rPr sz="1500" b="0">
+                <a:solidFill>
+                  <a:srgbClr val="1D3557"/>
+                </a:solidFill>
+                <a:latin typeface="Menlo"/>
+              </a:rPr>
+              <a:t># Una columna 0/1 por modo; el auto queda de referencia</a:t>
+            </a:r>
+          </a:p>
+          <a:p>
+            <a:pPr/>
+            <a:r>
+              <a:rPr sz="1500" b="0">
+                <a:solidFill>
+                  <a:srgbClr val="1D3557"/>
+                </a:solidFill>
+                <a:latin typeface="Menlo"/>
+              </a:rPr>
+              <a:t>dummies = pd.get_dummies(viajes["ModoAgrupado"])</a:t>
+            </a:r>
+          </a:p>
+          <a:p>
+            <a:pPr/>
+            <a:r>
+              <a:rPr sz="1500" b="0">
+                <a:solidFill>
+                  <a:srgbClr val="1D3557"/>
+                </a:solidFill>
+                <a:latin typeface="Menlo"/>
+              </a:rPr>
+              <a:t>dummies = dummies.drop(columns=["Auto"])</a:t>
+            </a:r>
+          </a:p>
+          <a:p>
+            <a:pPr/>
+            <a:r>
+              <a:rPr sz="1500" b="0">
+                <a:solidFill>
+                  <a:srgbClr val="1D3557"/>
+                </a:solidFill>
+                <a:latin typeface="Menlo"/>
+              </a:rPr>
+              <a:t/>
+            </a:r>
+          </a:p>
+          <a:p>
+            <a:pPr/>
+            <a:r>
+              <a:rPr sz="1500" b="0">
+                <a:solidFill>
+                  <a:srgbClr val="1D3557"/>
+                </a:solidFill>
+                <a:latin typeface="Menlo"/>
+              </a:rPr>
+              <a:t># Explicar la duración (log) con la distancia (log) y el modo</a:t>
+            </a:r>
+          </a:p>
+        </p:txBody>
+      </p:sp>
       <p:sp>
         <p:nvSpPr>
           <p:cNvPr id="5" name="TextBox 4"/>
@@ -6693,8 +6630,8 @@
         </p:nvSpPr>
         <p:spPr>
           <a:xfrm>
-            <a:off x="704088" y="4434840"/>
-            <a:ext cx="7744968" cy="457200"/>
+            <a:off x="704088" y="4389120"/>
+            <a:ext cx="7744968" cy="1097280"/>
           </a:xfrm>
           <a:prstGeom prst="rect">
             <a:avLst/>
@@ -6707,14 +6644,31 @@
           </a:bodyPr>
           <a:lstStyle/>
           <a:p>
-            <a:r>
-              <a:rPr sz="1300" b="0">
-                <a:solidFill>
-                  <a:srgbClr val="333333"/>
-                </a:solidFill>
-                <a:latin typeface="Fira Sans"/>
-              </a:rPr>
-              <a:t>A igual distancia, un viaje en Bip! tarda 1,87 veces lo que uno en auto; taxi y caminata quedan casi iguales al auto. El R² sube de 0,53 a 0,60.</a:t>
+            <a:pPr>
+              <a:lnSpc>
+                <a:spcPct val="112000"/>
+              </a:lnSpc>
+              <a:spcAft>
+                <a:spcPts val="900"/>
+              </a:spcAft>
+            </a:pPr>
+            <a:r>
+              <a:rPr sz="1600" b="1">
+                <a:solidFill>
+                  <a:srgbClr val="E0A437"/>
+                </a:solidFill>
+                <a:latin typeface="Fira Sans"/>
+              </a:rPr>
+              <a:t>▸ </a:t>
+            </a:r>
+            <a:r>
+              <a:rPr sz="1600" b="0">
+                <a:solidFill>
+                  <a:srgbClr val="000000"/>
+                </a:solidFill>
+                <a:latin typeface="Fira Sans"/>
+              </a:rPr>
+              <a:t>Cada coeficiente se lee comparado con la referencia: qué le pasa al tiempo de un viaje por ser en ese modo y no en auto, a igual distancia.</a:t>
             </a:r>
           </a:p>
         </p:txBody>
@@ -6810,14 +6764,14 @@
                 </a:solidFill>
                 <a:latin typeface="Fira Sans"/>
               </a:rPr>
-              <a:t>La ecuación de la duración, leída</a:t>
+              <a:t>El resultado: distancia y modo</a:t>
             </a:r>
           </a:p>
         </p:txBody>
       </p:sp>
       <p:pic>
         <p:nvPicPr>
-          <p:cNvPr id="4" name="Picture 3" descr="c4_09_ecuacion_duracion.png"/>
+          <p:cNvPr id="4" name="Picture 3" descr="c4_03_coef_modo.png"/>
           <p:cNvPicPr>
             <a:picLocks noChangeAspect="1"/>
           </p:cNvPicPr>
@@ -6831,8 +6785,8 @@
         </p:blipFill>
         <p:spPr>
           <a:xfrm>
-            <a:off x="699515" y="1320746"/>
-            <a:ext cx="7744968" cy="2799186"/>
+            <a:off x="804842" y="1143000"/>
+            <a:ext cx="7534315" cy="3154680"/>
           </a:xfrm>
           <a:prstGeom prst="rect">
             <a:avLst/>
@@ -6868,7 +6822,7 @@
                 </a:solidFill>
                 <a:latin typeface="Fira Sans"/>
               </a:rPr>
-              <a:t>La misma tabla de coeficientes, escrita como ecuación: en escala log los efectos multiplican en vez de sumar.</a:t>
+              <a:t>A igual distancia, un viaje en Bip! tarda 1,87 veces lo que uno en auto; taxi y caminata quedan casi iguales al auto. El R² sube de 0,53 a 0,60.</a:t>
             </a:r>
           </a:p>
         </p:txBody>
@@ -7223,21 +7177,45 @@
                 </a:solidFill>
                 <a:latin typeface="Fira Sans"/>
               </a:rPr>
-              <a:t>Síntesis</a:t>
-            </a:r>
-          </a:p>
-        </p:txBody>
-      </p:sp>
-      <p:sp>
-        <p:nvSpPr>
-          <p:cNvPr id="4" name="TextBox 3"/>
+              <a:t>La ecuación de la duración, leída</a:t>
+            </a:r>
+          </a:p>
+        </p:txBody>
+      </p:sp>
+      <p:pic>
+        <p:nvPicPr>
+          <p:cNvPr id="4" name="Picture 3" descr="c4_09_ecuacion_duracion.png"/>
+          <p:cNvPicPr>
+            <a:picLocks noChangeAspect="1"/>
+          </p:cNvPicPr>
+          <p:nvPr/>
+        </p:nvPicPr>
+        <p:blipFill>
+          <a:blip r:embed="rId2"/>
+          <a:stretch>
+            <a:fillRect/>
+          </a:stretch>
+        </p:blipFill>
+        <p:spPr>
+          <a:xfrm>
+            <a:off x="699515" y="1320746"/>
+            <a:ext cx="7744968" cy="2799186"/>
+          </a:xfrm>
+          <a:prstGeom prst="rect">
+            <a:avLst/>
+          </a:prstGeom>
+        </p:spPr>
+      </p:pic>
+      <p:sp>
+        <p:nvSpPr>
+          <p:cNvPr id="5" name="TextBox 4"/>
           <p:cNvSpPr txBox="1"/>
           <p:nvPr/>
         </p:nvSpPr>
         <p:spPr>
           <a:xfrm>
-            <a:off x="704088" y="1353312"/>
-            <a:ext cx="7744968" cy="3300984"/>
+            <a:off x="704088" y="4434840"/>
+            <a:ext cx="7744968" cy="457200"/>
           </a:xfrm>
           <a:prstGeom prst="rect">
             <a:avLst/>
@@ -7250,143 +7228,14 @@
           </a:bodyPr>
           <a:lstStyle/>
           <a:p>
-            <a:pPr>
-              <a:lnSpc>
-                <a:spcPct val="112000"/>
-              </a:lnSpc>
-              <a:spcAft>
-                <a:spcPts val="900"/>
-              </a:spcAft>
-            </a:pPr>
-            <a:r>
-              <a:rPr sz="1800" b="1">
-                <a:solidFill>
-                  <a:srgbClr val="E0A437"/>
-                </a:solidFill>
-                <a:latin typeface="Fira Sans"/>
-              </a:rPr>
-              <a:t>▸ </a:t>
-            </a:r>
-            <a:r>
-              <a:rPr sz="1800" b="0">
-                <a:solidFill>
-                  <a:srgbClr val="000000"/>
-                </a:solidFill>
-                <a:latin typeface="Fira Sans"/>
-              </a:rPr>
-              <a:t>El impacto de filas y atípicos se mide con y sin, sobre todos los resúmenes en uso.</a:t>
-            </a:r>
-          </a:p>
-          <a:p>
-            <a:pPr>
-              <a:lnSpc>
-                <a:spcPct val="112000"/>
-              </a:lnSpc>
-              <a:spcAft>
-                <a:spcPts val="900"/>
-              </a:spcAft>
-            </a:pPr>
-            <a:r>
-              <a:rPr sz="1800" b="1">
-                <a:solidFill>
-                  <a:srgbClr val="E0A437"/>
-                </a:solidFill>
-                <a:latin typeface="Fira Sans"/>
-              </a:rPr>
-              <a:t>▸ </a:t>
-            </a:r>
-            <a:r>
-              <a:rPr sz="1800" b="0">
-                <a:solidFill>
-                  <a:srgbClr val="000000"/>
-                </a:solidFill>
-                <a:latin typeface="Fira Sans"/>
-              </a:rPr>
-              <a:t>Cuando la conclusión es sobre la ciudad, se pondera: WLS.</a:t>
-            </a:r>
-          </a:p>
-          <a:p>
-            <a:pPr>
-              <a:lnSpc>
-                <a:spcPct val="112000"/>
-              </a:lnSpc>
-              <a:spcAft>
-                <a:spcPts val="900"/>
-              </a:spcAft>
-            </a:pPr>
-            <a:r>
-              <a:rPr sz="1800" b="1">
-                <a:solidFill>
-                  <a:srgbClr val="E0A437"/>
-                </a:solidFill>
-                <a:latin typeface="Fira Sans"/>
-              </a:rPr>
-              <a:t>▸ </a:t>
-            </a:r>
-            <a:r>
-              <a:rPr sz="1800" b="0">
-                <a:solidFill>
-                  <a:srgbClr val="000000"/>
-                </a:solidFill>
-                <a:latin typeface="Fira Sans"/>
-              </a:rPr>
-              <a:t>Muchos puntos: alpha o hexbin. Colas largas: log.</a:t>
-            </a:r>
-          </a:p>
-          <a:p>
-            <a:pPr>
-              <a:lnSpc>
-                <a:spcPct val="112000"/>
-              </a:lnSpc>
-              <a:spcAft>
-                <a:spcPts val="900"/>
-              </a:spcAft>
-            </a:pPr>
-            <a:r>
-              <a:rPr sz="1800" b="1">
-                <a:solidFill>
-                  <a:srgbClr val="E0A437"/>
-                </a:solidFill>
-                <a:latin typeface="Fira Sans"/>
-              </a:rPr>
-              <a:t>▸ </a:t>
-            </a:r>
-            <a:r>
-              <a:rPr sz="1800" b="0">
-                <a:solidFill>
-                  <a:srgbClr val="000000"/>
-                </a:solidFill>
-                <a:latin typeface="Fira Sans"/>
-              </a:rPr>
-              <a:t>La múltiple aísla el efecto de cada variable (categóricas como dummies); R² dice cuánto explica y el valor p si un coeficiente se distingue del azar.</a:t>
-            </a:r>
-          </a:p>
-          <a:p>
-            <a:pPr>
-              <a:lnSpc>
-                <a:spcPct val="112000"/>
-              </a:lnSpc>
-              <a:spcAft>
-                <a:spcPts val="900"/>
-              </a:spcAft>
-            </a:pPr>
-            <a:r>
-              <a:rPr sz="1800" b="1">
-                <a:solidFill>
-                  <a:srgbClr val="E0A437"/>
-                </a:solidFill>
-                <a:latin typeface="Fira Sans"/>
-              </a:rPr>
-              <a:t>▸ </a:t>
-            </a:r>
-            <a:r>
-              <a:rPr sz="1800" b="1">
-                <a:solidFill>
-                  <a:srgbClr val="1D3557"/>
-                </a:solidFill>
-                <a:latin typeface="Fira Sans"/>
-              </a:rPr>
-              <a:t>El primer EDA del proyecto usa exactamente estas herramientas (entrega: lunes 15).</a:t>
+            <a:r>
+              <a:rPr sz="1300" b="0">
+                <a:solidFill>
+                  <a:srgbClr val="333333"/>
+                </a:solidFill>
+                <a:latin typeface="Fira Sans"/>
+              </a:rPr>
+              <a:t>La misma tabla de coeficientes, escrita como ecuación: en escala log los efectos multiplican en vez de sumar.</a:t>
             </a:r>
           </a:p>
         </p:txBody>
@@ -7424,7 +7273,7 @@
             <a:avLst/>
           </a:prstGeom>
           <a:solidFill>
-            <a:srgbClr val="1D3557"/>
+            <a:srgbClr val="FAFBFC"/>
           </a:solidFill>
           <a:ln>
             <a:noFill/>
@@ -7461,8 +7310,8 @@
         </p:nvSpPr>
         <p:spPr>
           <a:xfrm>
-            <a:off x="603504" y="1847088"/>
-            <a:ext cx="7946136" cy="1399032"/>
+            <a:off x="402336" y="301752"/>
+            <a:ext cx="8348472" cy="795528"/>
           </a:xfrm>
           <a:prstGeom prst="rect">
             <a:avLst/>
@@ -7476,24 +7325,176 @@
           <a:lstStyle/>
           <a:p>
             <a:r>
-              <a:rPr sz="3400" b="1">
-                <a:solidFill>
-                  <a:srgbClr val="FFFFFF"/>
-                </a:solidFill>
-                <a:latin typeface="Fira Sans"/>
-              </a:rPr>
-              <a:t>Recreo</a:t>
-            </a:r>
-          </a:p>
-          <a:p>
+              <a:rPr sz="2800" b="1">
+                <a:solidFill>
+                  <a:srgbClr val="0F0F0F"/>
+                </a:solidFill>
+                <a:latin typeface="Fira Sans"/>
+              </a:rPr>
+              <a:t>Síntesis</a:t>
+            </a:r>
+          </a:p>
+        </p:txBody>
+      </p:sp>
+      <p:sp>
+        <p:nvSpPr>
+          <p:cNvPr id="4" name="TextBox 3"/>
+          <p:cNvSpPr txBox="1"/>
+          <p:nvPr/>
+        </p:nvSpPr>
+        <p:spPr>
+          <a:xfrm>
+            <a:off x="704088" y="1353312"/>
+            <a:ext cx="7744968" cy="3300984"/>
+          </a:xfrm>
+          <a:prstGeom prst="rect">
+            <a:avLst/>
+          </a:prstGeom>
+          <a:noFill/>
+        </p:spPr>
+        <p:txBody>
+          <a:bodyPr wrap="square">
+            <a:spAutoFit/>
+          </a:bodyPr>
+          <a:lstStyle/>
+          <a:p>
+            <a:pPr>
+              <a:lnSpc>
+                <a:spcPct val="112000"/>
+              </a:lnSpc>
+              <a:spcAft>
+                <a:spcPts val="900"/>
+              </a:spcAft>
+            </a:pPr>
+            <a:r>
+              <a:rPr sz="1800" b="1">
+                <a:solidFill>
+                  <a:srgbClr val="E0A437"/>
+                </a:solidFill>
+                <a:latin typeface="Fira Sans"/>
+              </a:rPr>
+              <a:t>▸ </a:t>
+            </a:r>
             <a:r>
               <a:rPr sz="1800" b="0">
                 <a:solidFill>
+                  <a:srgbClr val="000000"/>
+                </a:solidFill>
+                <a:latin typeface="Fira Sans"/>
+              </a:rPr>
+              <a:t>El impacto de filas y atípicos se mide con y sin, sobre todos los resúmenes en uso.</a:t>
+            </a:r>
+          </a:p>
+          <a:p>
+            <a:pPr>
+              <a:lnSpc>
+                <a:spcPct val="112000"/>
+              </a:lnSpc>
+              <a:spcAft>
+                <a:spcPts val="900"/>
+              </a:spcAft>
+            </a:pPr>
+            <a:r>
+              <a:rPr sz="1800" b="1">
+                <a:solidFill>
                   <a:srgbClr val="E0A437"/>
                 </a:solidFill>
                 <a:latin typeface="Fira Sans"/>
               </a:rPr>
-              <a:t>10 minutos · al volver: las presentaciones de ideas</a:t>
+              <a:t>▸ </a:t>
+            </a:r>
+            <a:r>
+              <a:rPr sz="1800" b="0">
+                <a:solidFill>
+                  <a:srgbClr val="000000"/>
+                </a:solidFill>
+                <a:latin typeface="Fira Sans"/>
+              </a:rPr>
+              <a:t>Cuando la conclusión es sobre la ciudad, se pondera: WLS.</a:t>
+            </a:r>
+          </a:p>
+          <a:p>
+            <a:pPr>
+              <a:lnSpc>
+                <a:spcPct val="112000"/>
+              </a:lnSpc>
+              <a:spcAft>
+                <a:spcPts val="900"/>
+              </a:spcAft>
+            </a:pPr>
+            <a:r>
+              <a:rPr sz="1800" b="1">
+                <a:solidFill>
+                  <a:srgbClr val="E0A437"/>
+                </a:solidFill>
+                <a:latin typeface="Fira Sans"/>
+              </a:rPr>
+              <a:t>▸ </a:t>
+            </a:r>
+            <a:r>
+              <a:rPr sz="1800" b="0">
+                <a:solidFill>
+                  <a:srgbClr val="000000"/>
+                </a:solidFill>
+                <a:latin typeface="Fira Sans"/>
+              </a:rPr>
+              <a:t>Muchos puntos: alpha o hexbin. Colas largas: log.</a:t>
+            </a:r>
+          </a:p>
+          <a:p>
+            <a:pPr>
+              <a:lnSpc>
+                <a:spcPct val="112000"/>
+              </a:lnSpc>
+              <a:spcAft>
+                <a:spcPts val="900"/>
+              </a:spcAft>
+            </a:pPr>
+            <a:r>
+              <a:rPr sz="1800" b="1">
+                <a:solidFill>
+                  <a:srgbClr val="E0A437"/>
+                </a:solidFill>
+                <a:latin typeface="Fira Sans"/>
+              </a:rPr>
+              <a:t>▸ </a:t>
+            </a:r>
+            <a:r>
+              <a:rPr sz="1800" b="0">
+                <a:solidFill>
+                  <a:srgbClr val="000000"/>
+                </a:solidFill>
+                <a:latin typeface="Fira Sans"/>
+              </a:rPr>
+              <a:t>La múltiple aísla el efecto de cada variable (categóricas como dummies); R² dice cuánto explica y el valor p si un coeficiente se distingue del azar.</a:t>
+            </a:r>
+          </a:p>
+          <a:p>
+            <a:pPr>
+              <a:lnSpc>
+                <a:spcPct val="112000"/>
+              </a:lnSpc>
+              <a:spcAft>
+                <a:spcPts val="900"/>
+              </a:spcAft>
+            </a:pPr>
+            <a:r>
+              <a:rPr sz="1800" b="1">
+                <a:solidFill>
+                  <a:srgbClr val="E0A437"/>
+                </a:solidFill>
+                <a:latin typeface="Fira Sans"/>
+              </a:rPr>
+              <a:t>▸ </a:t>
+            </a:r>
+            <a:r>
+              <a:rPr sz="1800" b="1">
+                <a:solidFill>
+                  <a:srgbClr val="1D3557"/>
+                </a:solidFill>
+                <a:latin typeface="Fira Sans"/>
+              </a:rPr>
+              <a:t>El primer EDA del proyecto usa exactamente estas herramientas (entrega: lunes 15).</a:t>
             </a:r>
           </a:p>
         </p:txBody>
@@ -7589,7 +7590,7 @@
                 </a:solidFill>
                 <a:latin typeface="Fira Sans"/>
               </a:rPr>
-              <a:t>Presentaciones de ideas</a:t>
+              <a:t>Recreo</a:t>
             </a:r>
           </a:p>
           <a:p>
@@ -7600,7 +7601,7 @@
                 </a:solidFill>
                 <a:latin typeface="Fira Sans"/>
               </a:rPr>
-              <a:t>De 5 a 7 minutos por equipo, y preguntas de todos</a:t>
+              <a:t>10 minutos · al volver: las presentaciones de ideas</a:t>
             </a:r>
           </a:p>
         </p:txBody>
@@ -7638,7 +7639,7 @@
             <a:avLst/>
           </a:prstGeom>
           <a:solidFill>
-            <a:srgbClr val="FAFBFC"/>
+            <a:srgbClr val="1D3557"/>
           </a:solidFill>
           <a:ln>
             <a:noFill/>
@@ -7675,8 +7676,8 @@
         </p:nvSpPr>
         <p:spPr>
           <a:xfrm>
-            <a:off x="402336" y="301752"/>
-            <a:ext cx="8348472" cy="795528"/>
+            <a:off x="603504" y="1847088"/>
+            <a:ext cx="7946136" cy="1399032"/>
           </a:xfrm>
           <a:prstGeom prst="rect">
             <a:avLst/>
@@ -7690,92 +7691,24 @@
           <a:lstStyle/>
           <a:p>
             <a:r>
-              <a:rPr sz="2800" b="1">
-                <a:solidFill>
-                  <a:srgbClr val="0F0F0F"/>
-                </a:solidFill>
-                <a:latin typeface="Fira Sans"/>
-              </a:rPr>
-              <a:t>El formato</a:t>
-            </a:r>
-          </a:p>
-        </p:txBody>
-      </p:sp>
-      <p:sp>
-        <p:nvSpPr>
-          <p:cNvPr id="4" name="TextBox 3"/>
-          <p:cNvSpPr txBox="1"/>
-          <p:nvPr/>
-        </p:nvSpPr>
-        <p:spPr>
-          <a:xfrm>
-            <a:off x="704088" y="1353312"/>
-            <a:ext cx="7744968" cy="3300984"/>
-          </a:xfrm>
-          <a:prstGeom prst="rect">
-            <a:avLst/>
-          </a:prstGeom>
-          <a:noFill/>
-        </p:spPr>
-        <p:txBody>
-          <a:bodyPr wrap="square">
-            <a:spAutoFit/>
-          </a:bodyPr>
-          <a:lstStyle/>
-          <a:p>
-            <a:pPr>
-              <a:lnSpc>
-                <a:spcPct val="112000"/>
-              </a:lnSpc>
-              <a:spcAft>
-                <a:spcPts val="900"/>
-              </a:spcAft>
-            </a:pPr>
-            <a:r>
-              <a:rPr sz="1800" b="1">
+              <a:rPr sz="3400" b="1">
+                <a:solidFill>
+                  <a:srgbClr val="FFFFFF"/>
+                </a:solidFill>
+                <a:latin typeface="Fira Sans"/>
+              </a:rPr>
+              <a:t>Presentaciones de ideas</a:t>
+            </a:r>
+          </a:p>
+          <a:p>
+            <a:r>
+              <a:rPr sz="1800" b="0">
                 <a:solidFill>
                   <a:srgbClr val="E0A437"/>
                 </a:solidFill>
                 <a:latin typeface="Fira Sans"/>
               </a:rPr>
-              <a:t>▸ </a:t>
-            </a:r>
-            <a:r>
-              <a:rPr sz="1800" b="1">
-                <a:solidFill>
-                  <a:srgbClr val="1D3557"/>
-                </a:solidFill>
-                <a:latin typeface="Fira Sans"/>
-              </a:rPr>
-              <a:t>Esta instancia no lleva nota: es para recibir retroalimentación temprano, cuando corregir cuesta poco.</a:t>
-            </a:r>
-          </a:p>
-          <a:p>
-            <a:pPr>
-              <a:lnSpc>
-                <a:spcPct val="112000"/>
-              </a:lnSpc>
-              <a:spcAft>
-                <a:spcPts val="900"/>
-              </a:spcAft>
-            </a:pPr>
-            <a:r>
-              <a:rPr sz="1800" b="1">
-                <a:solidFill>
-                  <a:srgbClr val="E0A437"/>
-                </a:solidFill>
-                <a:latin typeface="Fira Sans"/>
-              </a:rPr>
-              <a:t>▸ </a:t>
-            </a:r>
-            <a:r>
-              <a:rPr sz="1800" b="0">
-                <a:solidFill>
-                  <a:srgbClr val="000000"/>
-                </a:solidFill>
-                <a:latin typeface="Fira Sans"/>
-              </a:rPr>
-              <a:t>Después de cada equipo, preguntas y comentarios del curso.</a:t>
+              <a:t>De 5 a 7 minutos por equipo, y preguntas de todos</a:t>
             </a:r>
           </a:p>
         </p:txBody>
@@ -7871,7 +7804,7 @@
                 </a:solidFill>
                 <a:latin typeface="Fira Sans"/>
               </a:rPr>
-              <a:t>Próxima clase</a:t>
+              <a:t>El formato</a:t>
             </a:r>
           </a:p>
         </p:txBody>
@@ -7916,13 +7849,13 @@
               <a:t>▸ </a:t>
             </a:r>
             <a:r>
-              <a:rPr sz="1800" b="0">
-                <a:solidFill>
-                  <a:srgbClr val="000000"/>
-                </a:solidFill>
-                <a:latin typeface="Fira Sans"/>
-              </a:rPr>
-              <a:t>Martes 8: fundamentos de probabilidad y nociones de inferencia estadística.</a:t>
+              <a:rPr sz="1800" b="1">
+                <a:solidFill>
+                  <a:srgbClr val="1D3557"/>
+                </a:solidFill>
+                <a:latin typeface="Fira Sans"/>
+              </a:rPr>
+              <a:t>Esta instancia no lleva nota: es para recibir retroalimentación temprano, cuando corregir cuesta poco.</a:t>
             </a:r>
           </a:p>
           <a:p>
@@ -7950,35 +7883,7 @@
                 </a:solidFill>
                 <a:latin typeface="Fira Sans"/>
               </a:rPr>
-              <a:t>La pregunta pendiente desde la clase 3: ¿qué significa el valor p que statsmodels ya nos mostró?</a:t>
-            </a:r>
-          </a:p>
-          <a:p>
-            <a:pPr>
-              <a:lnSpc>
-                <a:spcPct val="112000"/>
-              </a:lnSpc>
-              <a:spcAft>
-                <a:spcPts val="900"/>
-              </a:spcAft>
-            </a:pPr>
-            <a:r>
-              <a:rPr sz="1800" b="1">
-                <a:solidFill>
-                  <a:srgbClr val="E0A437"/>
-                </a:solidFill>
-                <a:latin typeface="Fira Sans"/>
-              </a:rPr>
-              <a:t>▸ </a:t>
-            </a:r>
-            <a:r>
-              <a:rPr sz="1800" b="1">
-                <a:solidFill>
-                  <a:srgbClr val="1D3557"/>
-                </a:solidFill>
-                <a:latin typeface="Fira Sans"/>
-              </a:rPr>
-              <a:t>La formulación se entrega el lunes 7; el primer análisis exploratorio, el lunes 15.</a:t>
+              <a:t>Después de cada equipo, preguntas y comentarios del curso.</a:t>
             </a:r>
           </a:p>
         </p:txBody>
@@ -7992,6 +7897,209 @@
 </file>
 
 <file path=ppt/slides/slide35.xml><?xml version="1.0" encoding="utf-8"?>
+<p:sld xmlns:a="http://schemas.openxmlformats.org/drawingml/2006/main" xmlns:p="http://schemas.openxmlformats.org/presentationml/2006/main" xmlns:r="http://schemas.openxmlformats.org/officeDocument/2006/relationships">
+  <p:cSld>
+    <p:spTree>
+      <p:nvGrpSpPr>
+        <p:cNvPr id="1" name=""/>
+        <p:cNvGrpSpPr/>
+        <p:nvPr/>
+      </p:nvGrpSpPr>
+      <p:grpSpPr/>
+      <p:sp>
+        <p:nvSpPr>
+          <p:cNvPr id="2" name="Rectangle 1"/>
+          <p:cNvSpPr/>
+          <p:nvPr/>
+        </p:nvSpPr>
+        <p:spPr>
+          <a:xfrm>
+            <a:off x="0" y="0"/>
+            <a:ext cx="9144000" cy="5138928"/>
+          </a:xfrm>
+          <a:prstGeom prst="rect">
+            <a:avLst/>
+          </a:prstGeom>
+          <a:solidFill>
+            <a:srgbClr val="FAFBFC"/>
+          </a:solidFill>
+          <a:ln>
+            <a:noFill/>
+          </a:ln>
+          <a:effectLst/>
+        </p:spPr>
+        <p:style>
+          <a:lnRef idx="1">
+            <a:schemeClr val="accent1"/>
+          </a:lnRef>
+          <a:fillRef idx="3">
+            <a:schemeClr val="accent1"/>
+          </a:fillRef>
+          <a:effectRef idx="2">
+            <a:schemeClr val="accent1"/>
+          </a:effectRef>
+          <a:fontRef idx="minor">
+            <a:schemeClr val="lt1"/>
+          </a:fontRef>
+        </p:style>
+        <p:txBody>
+          <a:bodyPr rtlCol="0" anchor="ctr"/>
+          <a:lstStyle/>
+          <a:p>
+            <a:pPr algn="ctr"/>
+          </a:p>
+        </p:txBody>
+      </p:sp>
+      <p:sp>
+        <p:nvSpPr>
+          <p:cNvPr id="3" name="TextBox 2"/>
+          <p:cNvSpPr txBox="1"/>
+          <p:nvPr/>
+        </p:nvSpPr>
+        <p:spPr>
+          <a:xfrm>
+            <a:off x="402336" y="301752"/>
+            <a:ext cx="8348472" cy="795528"/>
+          </a:xfrm>
+          <a:prstGeom prst="rect">
+            <a:avLst/>
+          </a:prstGeom>
+          <a:noFill/>
+        </p:spPr>
+        <p:txBody>
+          <a:bodyPr wrap="square">
+            <a:spAutoFit/>
+          </a:bodyPr>
+          <a:lstStyle/>
+          <a:p>
+            <a:r>
+              <a:rPr sz="2800" b="1">
+                <a:solidFill>
+                  <a:srgbClr val="0F0F0F"/>
+                </a:solidFill>
+                <a:latin typeface="Fira Sans"/>
+              </a:rPr>
+              <a:t>Próxima clase</a:t>
+            </a:r>
+          </a:p>
+        </p:txBody>
+      </p:sp>
+      <p:sp>
+        <p:nvSpPr>
+          <p:cNvPr id="4" name="TextBox 3"/>
+          <p:cNvSpPr txBox="1"/>
+          <p:nvPr/>
+        </p:nvSpPr>
+        <p:spPr>
+          <a:xfrm>
+            <a:off x="704088" y="1353312"/>
+            <a:ext cx="7744968" cy="3300984"/>
+          </a:xfrm>
+          <a:prstGeom prst="rect">
+            <a:avLst/>
+          </a:prstGeom>
+          <a:noFill/>
+        </p:spPr>
+        <p:txBody>
+          <a:bodyPr wrap="square">
+            <a:spAutoFit/>
+          </a:bodyPr>
+          <a:lstStyle/>
+          <a:p>
+            <a:pPr>
+              <a:lnSpc>
+                <a:spcPct val="112000"/>
+              </a:lnSpc>
+              <a:spcAft>
+                <a:spcPts val="900"/>
+              </a:spcAft>
+            </a:pPr>
+            <a:r>
+              <a:rPr sz="1800" b="1">
+                <a:solidFill>
+                  <a:srgbClr val="E0A437"/>
+                </a:solidFill>
+                <a:latin typeface="Fira Sans"/>
+              </a:rPr>
+              <a:t>▸ </a:t>
+            </a:r>
+            <a:r>
+              <a:rPr sz="1800" b="0">
+                <a:solidFill>
+                  <a:srgbClr val="000000"/>
+                </a:solidFill>
+                <a:latin typeface="Fira Sans"/>
+              </a:rPr>
+              <a:t>Martes 8: fundamentos de probabilidad y nociones de inferencia estadística.</a:t>
+            </a:r>
+          </a:p>
+          <a:p>
+            <a:pPr>
+              <a:lnSpc>
+                <a:spcPct val="112000"/>
+              </a:lnSpc>
+              <a:spcAft>
+                <a:spcPts val="900"/>
+              </a:spcAft>
+            </a:pPr>
+            <a:r>
+              <a:rPr sz="1800" b="1">
+                <a:solidFill>
+                  <a:srgbClr val="E0A437"/>
+                </a:solidFill>
+                <a:latin typeface="Fira Sans"/>
+              </a:rPr>
+              <a:t>▸ </a:t>
+            </a:r>
+            <a:r>
+              <a:rPr sz="1800" b="0">
+                <a:solidFill>
+                  <a:srgbClr val="000000"/>
+                </a:solidFill>
+                <a:latin typeface="Fira Sans"/>
+              </a:rPr>
+              <a:t>La pregunta pendiente desde la clase 3: ¿qué significa el valor p que statsmodels ya nos mostró?</a:t>
+            </a:r>
+          </a:p>
+          <a:p>
+            <a:pPr>
+              <a:lnSpc>
+                <a:spcPct val="112000"/>
+              </a:lnSpc>
+              <a:spcAft>
+                <a:spcPts val="900"/>
+              </a:spcAft>
+            </a:pPr>
+            <a:r>
+              <a:rPr sz="1800" b="1">
+                <a:solidFill>
+                  <a:srgbClr val="E0A437"/>
+                </a:solidFill>
+                <a:latin typeface="Fira Sans"/>
+              </a:rPr>
+              <a:t>▸ </a:t>
+            </a:r>
+            <a:r>
+              <a:rPr sz="1800" b="1">
+                <a:solidFill>
+                  <a:srgbClr val="1D3557"/>
+                </a:solidFill>
+                <a:latin typeface="Fira Sans"/>
+              </a:rPr>
+              <a:t>La formulación se entrega el lunes 7; el primer análisis exploratorio, el lunes 15.</a:t>
+            </a:r>
+          </a:p>
+        </p:txBody>
+      </p:sp>
+    </p:spTree>
+  </p:cSld>
+  <p:clrMapOvr>
+    <a:masterClrMapping/>
+  </p:clrMapOvr>
+</p:sld>
+</file>
+
+<file path=ppt/slides/slide36.xml><?xml version="1.0" encoding="utf-8"?>
 <p:sld xmlns:a="http://schemas.openxmlformats.org/drawingml/2006/main" xmlns:p="http://schemas.openxmlformats.org/presentationml/2006/main" xmlns:r="http://schemas.openxmlformats.org/officeDocument/2006/relationships">
   <p:cSld>
     <p:spTree>

</xml_diff>

<commit_message>
Clase 4: las decisiones del modelo de duracion explicadas, y las dummies con figuras
El hilo de duracion abre con la pregunta general y el r de la clase 3
(0,57), declara la decision de transformar con log, pregunta que mas
podria explicar la duracion (las numericas del hogar no: r cercano a 0;
el modo si: Bip! 62 min contra 15 de caminata, pero tambien va mas lejos)
y justifica agregar el modo. Las dummies se explican con una tabla de
colores (texto a columnas 0/1, el auto de referencia) y con las rectas
paralelas que muestran que hace una dummy en el modelo. El notebook suma
las correlaciones con el hogar, el groupby por modo, la tabla texto/0-1
lado a lado y las rectas; el ejercicio propone agregar el periodo del
dia. Deck en 41 slides.

Co-Authored-By: Claude Fable 5 <noreply@anthropic.com>
</commit_message>
<xml_diff>
--- a/presentaciones/clase04_regresion_multiple.pptx
+++ b/presentaciones/clase04_regresion_multiple.pptx
@@ -41,6 +41,11 @@
     <p:sldId id="289" r:id="rId40"/>
     <p:sldId id="290" r:id="rId41"/>
     <p:sldId id="291" r:id="rId42"/>
+    <p:sldId id="292" r:id="rId43"/>
+    <p:sldId id="293" r:id="rId44"/>
+    <p:sldId id="294" r:id="rId45"/>
+    <p:sldId id="295" r:id="rId46"/>
+    <p:sldId id="296" r:id="rId47"/>
   </p:sldIdLst>
   <p:sldSz cx="9144000" cy="5138928" type="screen4x3"/>
   <p:notesSz cx="6858000" cy="9144000"/>
@@ -4219,7 +4224,7 @@
             <a:avLst/>
           </a:prstGeom>
           <a:solidFill>
-            <a:srgbClr val="FAFBFC"/>
+            <a:srgbClr val="1D3557"/>
           </a:solidFill>
           <a:ln>
             <a:noFill/>
@@ -4256,8 +4261,8 @@
         </p:nvSpPr>
         <p:spPr>
           <a:xfrm>
-            <a:off x="402336" y="301752"/>
-            <a:ext cx="8348472" cy="795528"/>
+            <a:off x="603504" y="1847088"/>
+            <a:ext cx="7946136" cy="1399032"/>
           </a:xfrm>
           <a:prstGeom prst="rect">
             <a:avLst/>
@@ -4271,71 +4276,24 @@
           <a:lstStyle/>
           <a:p>
             <a:r>
-              <a:rPr sz="2800" b="1">
-                <a:solidFill>
-                  <a:srgbClr val="0F0F0F"/>
-                </a:solidFill>
-                <a:latin typeface="Fira Sans"/>
-              </a:rPr>
-              <a:t>La misma regresión, tres veces</a:t>
-            </a:r>
-          </a:p>
-        </p:txBody>
-      </p:sp>
-      <p:pic>
-        <p:nvPicPr>
-          <p:cNvPr id="4" name="Picture 3" descr="c4_02_tres_modelos.png"/>
-          <p:cNvPicPr>
-            <a:picLocks noChangeAspect="1"/>
-          </p:cNvPicPr>
-          <p:nvPr/>
-        </p:nvPicPr>
-        <p:blipFill>
-          <a:blip r:embed="rId2"/>
-          <a:stretch>
-            <a:fillRect/>
-          </a:stretch>
-        </p:blipFill>
-        <p:spPr>
-          <a:xfrm>
-            <a:off x="699515" y="1660639"/>
-            <a:ext cx="7744968" cy="2119400"/>
-          </a:xfrm>
-          <a:prstGeom prst="rect">
-            <a:avLst/>
-          </a:prstGeom>
-        </p:spPr>
-      </p:pic>
-      <p:sp>
-        <p:nvSpPr>
-          <p:cNvPr id="5" name="TextBox 4"/>
-          <p:cNvSpPr txBox="1"/>
-          <p:nvPr/>
-        </p:nvSpPr>
-        <p:spPr>
-          <a:xfrm>
-            <a:off x="704088" y="4434840"/>
-            <a:ext cx="7744968" cy="457200"/>
-          </a:xfrm>
-          <a:prstGeom prst="rect">
-            <a:avLst/>
-          </a:prstGeom>
-          <a:noFill/>
-        </p:spPr>
-        <p:txBody>
-          <a:bodyPr wrap="square">
-            <a:spAutoFit/>
-          </a:bodyPr>
-          <a:lstStyle/>
-          <a:p>
-            <a:r>
-              <a:rPr sz="1300" b="0">
-                <a:solidFill>
-                  <a:srgbClr val="333333"/>
-                </a:solidFill>
-                <a:latin typeface="Fira Sans"/>
-              </a:rPr>
-              <a:t>La transformación aplicada a duración ~ distancia: el log en ambos lados endereza la nube y el R² sube de 0,32 a 0,53. Y el modelo todavía pide más variables.</a:t>
+              <a:rPr sz="3400" b="1">
+                <a:solidFill>
+                  <a:srgbClr val="FFFFFF"/>
+                </a:solidFill>
+                <a:latin typeface="Fira Sans"/>
+              </a:rPr>
+              <a:t>¿De qué depende la duración de un viaje?</a:t>
+            </a:r>
+          </a:p>
+          <a:p>
+            <a:r>
+              <a:rPr sz="1800" b="0">
+                <a:solidFill>
+                  <a:srgbClr val="E0A437"/>
+                </a:solidFill>
+                <a:latin typeface="Fira Sans"/>
+              </a:rPr>
+              <a:t>Lo que ya sabemos (clase 3): correlaciona con la distancia, r = 0,57 y Spearman 0,76. Primera decisión: partir por la distancia, 102 mil viajes de la EOD</a:t>
             </a:r>
           </a:p>
         </p:txBody>
@@ -4431,14 +4389,14 @@
                 </a:solidFill>
                 <a:latin typeface="Fira Sans"/>
               </a:rPr>
-              <a:t>El mismo gráfico, dos veces</a:t>
+              <a:t>La misma regresión, tres veces</a:t>
             </a:r>
           </a:p>
         </p:txBody>
       </p:sp>
       <p:pic>
         <p:nvPicPr>
-          <p:cNvPr id="4" name="Picture 3" descr="c3_16_mal_buen_grafico.png"/>
+          <p:cNvPr id="4" name="Picture 3" descr="c4_02_tres_modelos.png"/>
           <p:cNvPicPr>
             <a:picLocks noChangeAspect="1"/>
           </p:cNvPicPr>
@@ -4452,8 +4410,8 @@
         </p:blipFill>
         <p:spPr>
           <a:xfrm>
-            <a:off x="699515" y="1217944"/>
-            <a:ext cx="7744968" cy="3004790"/>
+            <a:off x="699515" y="1660639"/>
+            <a:ext cx="7744968" cy="2119400"/>
           </a:xfrm>
           <a:prstGeom prst="rect">
             <a:avLst/>
@@ -4489,7 +4447,7 @@
                 </a:solidFill>
                 <a:latin typeface="Fira Sans"/>
               </a:rPr>
-              <a:t>Los mismos 30 mil viajes: sin rotular y saturado, contra rotulado, con transparencia y con el hallazgo en el título.</a:t>
+              <a:t>Decisión 1: transformar con log, porque las dos variables tienen cola larga y en log la nube se endereza: R² de 0,32 a 0,53. Y queda claro que la distancia sola no basta.</a:t>
             </a:r>
           </a:p>
         </p:txBody>
@@ -4585,21 +4543,45 @@
                 </a:solidFill>
                 <a:latin typeface="Fira Sans"/>
               </a:rPr>
-              <a:t>Checklist del buen gráfico</a:t>
-            </a:r>
-          </a:p>
-        </p:txBody>
-      </p:sp>
-      <p:sp>
-        <p:nvSpPr>
-          <p:cNvPr id="4" name="TextBox 3"/>
+              <a:t>El mismo gráfico, dos veces</a:t>
+            </a:r>
+          </a:p>
+        </p:txBody>
+      </p:sp>
+      <p:pic>
+        <p:nvPicPr>
+          <p:cNvPr id="4" name="Picture 3" descr="c3_16_mal_buen_grafico.png"/>
+          <p:cNvPicPr>
+            <a:picLocks noChangeAspect="1"/>
+          </p:cNvPicPr>
+          <p:nvPr/>
+        </p:nvPicPr>
+        <p:blipFill>
+          <a:blip r:embed="rId2"/>
+          <a:stretch>
+            <a:fillRect/>
+          </a:stretch>
+        </p:blipFill>
+        <p:spPr>
+          <a:xfrm>
+            <a:off x="699515" y="1217944"/>
+            <a:ext cx="7744968" cy="3004790"/>
+          </a:xfrm>
+          <a:prstGeom prst="rect">
+            <a:avLst/>
+          </a:prstGeom>
+        </p:spPr>
+      </p:pic>
+      <p:sp>
+        <p:nvSpPr>
+          <p:cNvPr id="5" name="TextBox 4"/>
           <p:cNvSpPr txBox="1"/>
           <p:nvPr/>
         </p:nvSpPr>
         <p:spPr>
           <a:xfrm>
-            <a:off x="704088" y="1353312"/>
-            <a:ext cx="7744968" cy="3300984"/>
+            <a:off x="704088" y="4434840"/>
+            <a:ext cx="7744968" cy="457200"/>
           </a:xfrm>
           <a:prstGeom prst="rect">
             <a:avLst/>
@@ -4612,115 +4594,14 @@
           </a:bodyPr>
           <a:lstStyle/>
           <a:p>
-            <a:pPr>
-              <a:lnSpc>
-                <a:spcPct val="112000"/>
-              </a:lnSpc>
-              <a:spcAft>
-                <a:spcPts val="900"/>
-              </a:spcAft>
-            </a:pPr>
-            <a:r>
-              <a:rPr sz="1800" b="1">
-                <a:solidFill>
-                  <a:srgbClr val="E0A437"/>
-                </a:solidFill>
-                <a:latin typeface="Fira Sans"/>
-              </a:rPr>
-              <a:t>▸ </a:t>
-            </a:r>
-            <a:r>
-              <a:rPr sz="1800" b="0">
-                <a:solidFill>
-                  <a:srgbClr val="000000"/>
-                </a:solidFill>
-                <a:latin typeface="Fira Sans"/>
-              </a:rPr>
-              <a:t>Título que diga el hallazgo, no solo las variables.</a:t>
-            </a:r>
-          </a:p>
-          <a:p>
-            <a:pPr>
-              <a:lnSpc>
-                <a:spcPct val="112000"/>
-              </a:lnSpc>
-              <a:spcAft>
-                <a:spcPts val="900"/>
-              </a:spcAft>
-            </a:pPr>
-            <a:r>
-              <a:rPr sz="1800" b="1">
-                <a:solidFill>
-                  <a:srgbClr val="E0A437"/>
-                </a:solidFill>
-                <a:latin typeface="Fira Sans"/>
-              </a:rPr>
-              <a:t>▸ </a:t>
-            </a:r>
-            <a:r>
-              <a:rPr sz="1800" b="0">
-                <a:solidFill>
-                  <a:srgbClr val="000000"/>
-                </a:solidFill>
-                <a:latin typeface="Fira Sans"/>
-              </a:rPr>
-              <a:t>Ejes con nombre y unidad; ejes que parten de cero en gráficos de barras.</a:t>
-            </a:r>
-          </a:p>
-          <a:p>
-            <a:pPr>
-              <a:lnSpc>
-                <a:spcPct val="112000"/>
-              </a:lnSpc>
-              <a:spcAft>
-                <a:spcPts val="900"/>
-              </a:spcAft>
-            </a:pPr>
-            <a:r>
-              <a:rPr sz="1800" b="1">
-                <a:solidFill>
-                  <a:srgbClr val="E0A437"/>
-                </a:solidFill>
-                <a:latin typeface="Fira Sans"/>
-              </a:rPr>
-              <a:t>▸ </a:t>
-            </a:r>
-            <a:r>
-              <a:rPr sz="1800" b="0">
-                <a:solidFill>
-                  <a:srgbClr val="000000"/>
-                </a:solidFill>
-                <a:latin typeface="Fira Sans"/>
-              </a:rPr>
-              <a:t>Muchos puntos: alpha, muestreo o hexbin.</a:t>
-            </a:r>
-          </a:p>
-          <a:p>
-            <a:pPr>
-              <a:lnSpc>
-                <a:spcPct val="112000"/>
-              </a:lnSpc>
-              <a:spcAft>
-                <a:spcPts val="900"/>
-              </a:spcAft>
-            </a:pPr>
-            <a:r>
-              <a:rPr sz="1800" b="1">
-                <a:solidFill>
-                  <a:srgbClr val="E0A437"/>
-                </a:solidFill>
-                <a:latin typeface="Fira Sans"/>
-              </a:rPr>
-              <a:t>▸ </a:t>
-            </a:r>
-            <a:r>
-              <a:rPr sz="1800" b="0">
-                <a:solidFill>
-                  <a:srgbClr val="000000"/>
-                </a:solidFill>
-                <a:latin typeface="Fira Sans"/>
-              </a:rPr>
-              <a:t>Colas largas: escala logarítmica o eje recortado, declarándolo.</a:t>
+            <a:r>
+              <a:rPr sz="1300" b="0">
+                <a:solidFill>
+                  <a:srgbClr val="333333"/>
+                </a:solidFill>
+                <a:latin typeface="Fira Sans"/>
+              </a:rPr>
+              <a:t>Los mismos 30 mil viajes: sin rotular y saturado, contra rotulado, con transparencia y con el hallazgo en el título.</a:t>
             </a:r>
           </a:p>
         </p:txBody>
@@ -4758,7 +4639,7 @@
             <a:avLst/>
           </a:prstGeom>
           <a:solidFill>
-            <a:srgbClr val="1D3557"/>
+            <a:srgbClr val="FAFBFC"/>
           </a:solidFill>
           <a:ln>
             <a:noFill/>
@@ -4795,8 +4676,8 @@
         </p:nvSpPr>
         <p:spPr>
           <a:xfrm>
-            <a:off x="603504" y="1847088"/>
-            <a:ext cx="7946136" cy="1399032"/>
+            <a:off x="402336" y="301752"/>
+            <a:ext cx="8348472" cy="795528"/>
           </a:xfrm>
           <a:prstGeom prst="rect">
             <a:avLst/>
@@ -4810,24 +4691,148 @@
           <a:lstStyle/>
           <a:p>
             <a:r>
-              <a:rPr sz="3400" b="1">
-                <a:solidFill>
-                  <a:srgbClr val="FFFFFF"/>
-                </a:solidFill>
-                <a:latin typeface="Fira Sans"/>
-              </a:rPr>
-              <a:t>Regresión múltiple</a:t>
-            </a:r>
-          </a:p>
-          <a:p>
+              <a:rPr sz="2800" b="1">
+                <a:solidFill>
+                  <a:srgbClr val="0F0F0F"/>
+                </a:solidFill>
+                <a:latin typeface="Fira Sans"/>
+              </a:rPr>
+              <a:t>Checklist del buen gráfico</a:t>
+            </a:r>
+          </a:p>
+        </p:txBody>
+      </p:sp>
+      <p:sp>
+        <p:nvSpPr>
+          <p:cNvPr id="4" name="TextBox 3"/>
+          <p:cNvSpPr txBox="1"/>
+          <p:nvPr/>
+        </p:nvSpPr>
+        <p:spPr>
+          <a:xfrm>
+            <a:off x="704088" y="1353312"/>
+            <a:ext cx="7744968" cy="3300984"/>
+          </a:xfrm>
+          <a:prstGeom prst="rect">
+            <a:avLst/>
+          </a:prstGeom>
+          <a:noFill/>
+        </p:spPr>
+        <p:txBody>
+          <a:bodyPr wrap="square">
+            <a:spAutoFit/>
+          </a:bodyPr>
+          <a:lstStyle/>
+          <a:p>
+            <a:pPr>
+              <a:lnSpc>
+                <a:spcPct val="112000"/>
+              </a:lnSpc>
+              <a:spcAft>
+                <a:spcPts val="900"/>
+              </a:spcAft>
+            </a:pPr>
+            <a:r>
+              <a:rPr sz="1800" b="1">
+                <a:solidFill>
+                  <a:srgbClr val="E0A437"/>
+                </a:solidFill>
+                <a:latin typeface="Fira Sans"/>
+              </a:rPr>
+              <a:t>▸ </a:t>
+            </a:r>
             <a:r>
               <a:rPr sz="1800" b="0">
                 <a:solidFill>
+                  <a:srgbClr val="000000"/>
+                </a:solidFill>
+                <a:latin typeface="Fira Sans"/>
+              </a:rPr>
+              <a:t>Título que diga el hallazgo, no solo las variables.</a:t>
+            </a:r>
+          </a:p>
+          <a:p>
+            <a:pPr>
+              <a:lnSpc>
+                <a:spcPct val="112000"/>
+              </a:lnSpc>
+              <a:spcAft>
+                <a:spcPts val="900"/>
+              </a:spcAft>
+            </a:pPr>
+            <a:r>
+              <a:rPr sz="1800" b="1">
+                <a:solidFill>
                   <a:srgbClr val="E0A437"/>
                 </a:solidFill>
                 <a:latin typeface="Fira Sans"/>
               </a:rPr>
-              <a:t>El primer modelo con varias variables</a:t>
+              <a:t>▸ </a:t>
+            </a:r>
+            <a:r>
+              <a:rPr sz="1800" b="0">
+                <a:solidFill>
+                  <a:srgbClr val="000000"/>
+                </a:solidFill>
+                <a:latin typeface="Fira Sans"/>
+              </a:rPr>
+              <a:t>Ejes con nombre y unidad; ejes que parten de cero en gráficos de barras.</a:t>
+            </a:r>
+          </a:p>
+          <a:p>
+            <a:pPr>
+              <a:lnSpc>
+                <a:spcPct val="112000"/>
+              </a:lnSpc>
+              <a:spcAft>
+                <a:spcPts val="900"/>
+              </a:spcAft>
+            </a:pPr>
+            <a:r>
+              <a:rPr sz="1800" b="1">
+                <a:solidFill>
+                  <a:srgbClr val="E0A437"/>
+                </a:solidFill>
+                <a:latin typeface="Fira Sans"/>
+              </a:rPr>
+              <a:t>▸ </a:t>
+            </a:r>
+            <a:r>
+              <a:rPr sz="1800" b="0">
+                <a:solidFill>
+                  <a:srgbClr val="000000"/>
+                </a:solidFill>
+                <a:latin typeface="Fira Sans"/>
+              </a:rPr>
+              <a:t>Muchos puntos: alpha, muestreo o hexbin.</a:t>
+            </a:r>
+          </a:p>
+          <a:p>
+            <a:pPr>
+              <a:lnSpc>
+                <a:spcPct val="112000"/>
+              </a:lnSpc>
+              <a:spcAft>
+                <a:spcPts val="900"/>
+              </a:spcAft>
+            </a:pPr>
+            <a:r>
+              <a:rPr sz="1800" b="1">
+                <a:solidFill>
+                  <a:srgbClr val="E0A437"/>
+                </a:solidFill>
+                <a:latin typeface="Fira Sans"/>
+              </a:rPr>
+              <a:t>▸ </a:t>
+            </a:r>
+            <a:r>
+              <a:rPr sz="1800" b="0">
+                <a:solidFill>
+                  <a:srgbClr val="000000"/>
+                </a:solidFill>
+                <a:latin typeface="Fira Sans"/>
+              </a:rPr>
+              <a:t>Colas largas: escala logarítmica o eje recortado, declarándolo.</a:t>
             </a:r>
           </a:p>
         </p:txBody>
@@ -4865,7 +4870,7 @@
             <a:avLst/>
           </a:prstGeom>
           <a:solidFill>
-            <a:srgbClr val="FAFBFC"/>
+            <a:srgbClr val="1D3557"/>
           </a:solidFill>
           <a:ln>
             <a:noFill/>
@@ -4902,8 +4907,8 @@
         </p:nvSpPr>
         <p:spPr>
           <a:xfrm>
-            <a:off x="402336" y="301752"/>
-            <a:ext cx="8348472" cy="795528"/>
+            <a:off x="603504" y="1847088"/>
+            <a:ext cx="7946136" cy="1399032"/>
           </a:xfrm>
           <a:prstGeom prst="rect">
             <a:avLst/>
@@ -4917,71 +4922,24 @@
           <a:lstStyle/>
           <a:p>
             <a:r>
-              <a:rPr sz="2800" b="1">
-                <a:solidFill>
-                  <a:srgbClr val="0F0F0F"/>
-                </a:solidFill>
-                <a:latin typeface="Fira Sans"/>
-              </a:rPr>
-              <a:t>La fórmula de la regresión múltiple</a:t>
-            </a:r>
-          </a:p>
-        </p:txBody>
-      </p:sp>
-      <p:pic>
-        <p:nvPicPr>
-          <p:cNvPr id="4" name="Picture 3" descr="c4_01_formula_multiple.png"/>
-          <p:cNvPicPr>
-            <a:picLocks noChangeAspect="1"/>
-          </p:cNvPicPr>
-          <p:nvPr/>
-        </p:nvPicPr>
-        <p:blipFill>
-          <a:blip r:embed="rId2"/>
-          <a:stretch>
-            <a:fillRect/>
-          </a:stretch>
-        </p:blipFill>
-        <p:spPr>
-          <a:xfrm>
-            <a:off x="699515" y="1500263"/>
-            <a:ext cx="7744968" cy="2440154"/>
-          </a:xfrm>
-          <a:prstGeom prst="rect">
-            <a:avLst/>
-          </a:prstGeom>
-        </p:spPr>
-      </p:pic>
-      <p:sp>
-        <p:nvSpPr>
-          <p:cNvPr id="5" name="TextBox 4"/>
-          <p:cNvSpPr txBox="1"/>
-          <p:nvPr/>
-        </p:nvSpPr>
-        <p:spPr>
-          <a:xfrm>
-            <a:off x="704088" y="4434840"/>
-            <a:ext cx="7744968" cy="457200"/>
-          </a:xfrm>
-          <a:prstGeom prst="rect">
-            <a:avLst/>
-          </a:prstGeom>
-          <a:noFill/>
-        </p:spPr>
-        <p:txBody>
-          <a:bodyPr wrap="square">
-            <a:spAutoFit/>
-          </a:bodyPr>
-          <a:lstStyle/>
-          <a:p>
-            <a:r>
-              <a:rPr sz="1300" b="0">
-                <a:solidFill>
-                  <a:srgbClr val="333333"/>
-                </a:solidFill>
-                <a:latin typeface="Fira Sans"/>
-              </a:rPr>
-              <a:t>Cada coeficiente aísla el efecto de su variable: cuánto cambia la predicción por una unidad de esa x, manteniendo las demás constantes.</a:t>
+              <a:rPr sz="3400" b="1">
+                <a:solidFill>
+                  <a:srgbClr val="FFFFFF"/>
+                </a:solidFill>
+                <a:latin typeface="Fira Sans"/>
+              </a:rPr>
+              <a:t>Regresión múltiple</a:t>
+            </a:r>
+          </a:p>
+          <a:p>
+            <a:r>
+              <a:rPr sz="1800" b="0">
+                <a:solidFill>
+                  <a:srgbClr val="E0A437"/>
+                </a:solidFill>
+                <a:latin typeface="Fira Sans"/>
+              </a:rPr>
+              <a:t>El primer modelo con varias variables</a:t>
             </a:r>
           </a:p>
         </p:txBody>
@@ -5222,7 +5180,7 @@
             <a:avLst/>
           </a:prstGeom>
           <a:solidFill>
-            <a:srgbClr val="1D3557"/>
+            <a:srgbClr val="FAFBFC"/>
           </a:solidFill>
           <a:ln>
             <a:noFill/>
@@ -5259,8 +5217,8 @@
         </p:nvSpPr>
         <p:spPr>
           <a:xfrm>
-            <a:off x="603504" y="1847088"/>
-            <a:ext cx="7946136" cy="1399032"/>
+            <a:off x="402336" y="301752"/>
+            <a:ext cx="8348472" cy="795528"/>
           </a:xfrm>
           <a:prstGeom prst="rect">
             <a:avLst/>
@@ -5274,24 +5232,71 @@
           <a:lstStyle/>
           <a:p>
             <a:r>
-              <a:rPr sz="3400" b="1">
-                <a:solidFill>
-                  <a:srgbClr val="FFFFFF"/>
-                </a:solidFill>
-                <a:latin typeface="Fira Sans"/>
-              </a:rPr>
-              <a:t>¿Mejora el modelo si agregamos el tamaño del hogar?</a:t>
-            </a:r>
-          </a:p>
-          <a:p>
-            <a:r>
-              <a:rPr sz="1800" b="0">
-                <a:solidFill>
-                  <a:srgbClr val="E0A437"/>
-                </a:solidFill>
-                <a:latin typeface="Fira Sans"/>
-              </a:rPr>
-              <a:t>Explicar los vehículos con el ingreso y las personas: la primera regresión múltiple</a:t>
+              <a:rPr sz="2800" b="1">
+                <a:solidFill>
+                  <a:srgbClr val="0F0F0F"/>
+                </a:solidFill>
+                <a:latin typeface="Fira Sans"/>
+              </a:rPr>
+              <a:t>La fórmula de la regresión múltiple</a:t>
+            </a:r>
+          </a:p>
+        </p:txBody>
+      </p:sp>
+      <p:pic>
+        <p:nvPicPr>
+          <p:cNvPr id="4" name="Picture 3" descr="c4_01_formula_multiple.png"/>
+          <p:cNvPicPr>
+            <a:picLocks noChangeAspect="1"/>
+          </p:cNvPicPr>
+          <p:nvPr/>
+        </p:nvPicPr>
+        <p:blipFill>
+          <a:blip r:embed="rId2"/>
+          <a:stretch>
+            <a:fillRect/>
+          </a:stretch>
+        </p:blipFill>
+        <p:spPr>
+          <a:xfrm>
+            <a:off x="699515" y="1500263"/>
+            <a:ext cx="7744968" cy="2440154"/>
+          </a:xfrm>
+          <a:prstGeom prst="rect">
+            <a:avLst/>
+          </a:prstGeom>
+        </p:spPr>
+      </p:pic>
+      <p:sp>
+        <p:nvSpPr>
+          <p:cNvPr id="5" name="TextBox 4"/>
+          <p:cNvSpPr txBox="1"/>
+          <p:nvPr/>
+        </p:nvSpPr>
+        <p:spPr>
+          <a:xfrm>
+            <a:off x="704088" y="4434840"/>
+            <a:ext cx="7744968" cy="457200"/>
+          </a:xfrm>
+          <a:prstGeom prst="rect">
+            <a:avLst/>
+          </a:prstGeom>
+          <a:noFill/>
+        </p:spPr>
+        <p:txBody>
+          <a:bodyPr wrap="square">
+            <a:spAutoFit/>
+          </a:bodyPr>
+          <a:lstStyle/>
+          <a:p>
+            <a:r>
+              <a:rPr sz="1300" b="0">
+                <a:solidFill>
+                  <a:srgbClr val="333333"/>
+                </a:solidFill>
+                <a:latin typeface="Fira Sans"/>
+              </a:rPr>
+              <a:t>Cada coeficiente aísla el efecto de su variable: cuánto cambia la predicción por una unidad de esa x, manteniendo las demás constantes.</a:t>
             </a:r>
           </a:p>
         </p:txBody>
@@ -5329,7 +5334,7 @@
             <a:avLst/>
           </a:prstGeom>
           <a:solidFill>
-            <a:srgbClr val="FAFBFC"/>
+            <a:srgbClr val="1D3557"/>
           </a:solidFill>
           <a:ln>
             <a:noFill/>
@@ -5366,8 +5371,8 @@
         </p:nvSpPr>
         <p:spPr>
           <a:xfrm>
-            <a:off x="402336" y="301752"/>
-            <a:ext cx="8348472" cy="795528"/>
+            <a:off x="603504" y="1847088"/>
+            <a:ext cx="7946136" cy="1399032"/>
           </a:xfrm>
           <a:prstGeom prst="rect">
             <a:avLst/>
@@ -5381,167 +5386,24 @@
           <a:lstStyle/>
           <a:p>
             <a:r>
-              <a:rPr sz="2800" b="1">
-                <a:solidFill>
-                  <a:srgbClr val="0F0F0F"/>
-                </a:solidFill>
-                <a:latin typeface="Fira Sans"/>
-              </a:rPr>
-              <a:t>La motorización, con dos variables</a:t>
-            </a:r>
-          </a:p>
-        </p:txBody>
-      </p:sp>
-      <p:sp>
-        <p:nvSpPr>
-          <p:cNvPr id="4" name="Rectangle 3"/>
-          <p:cNvSpPr/>
-          <p:nvPr/>
-        </p:nvSpPr>
-        <p:spPr>
-          <a:xfrm>
-            <a:off x="704088" y="1280160"/>
-            <a:ext cx="7744968" cy="2880360"/>
-          </a:xfrm>
-          <a:prstGeom prst="rect">
-            <a:avLst/>
-          </a:prstGeom>
-          <a:solidFill>
-            <a:srgbClr val="F0F2F5"/>
-          </a:solidFill>
-          <a:ln>
-            <a:solidFill>
-              <a:srgbClr val="D8DDE3"/>
-            </a:solidFill>
-          </a:ln>
-          <a:effectLst/>
-        </p:spPr>
-        <p:style>
-          <a:lnRef idx="1">
-            <a:schemeClr val="accent1"/>
-          </a:lnRef>
-          <a:fillRef idx="3">
-            <a:schemeClr val="accent1"/>
-          </a:fillRef>
-          <a:effectRef idx="2">
-            <a:schemeClr val="accent1"/>
-          </a:effectRef>
-          <a:fontRef idx="minor">
-            <a:schemeClr val="lt1"/>
-          </a:fontRef>
-        </p:style>
-        <p:txBody>
-          <a:bodyPr rtlCol="0" anchor="ctr" wrap="square" lIns="228600" tIns="137160"/>
-          <a:lstStyle/>
-          <a:p>
-            <a:pPr/>
-            <a:r>
-              <a:rPr sz="1500" b="0">
-                <a:solidFill>
-                  <a:srgbClr val="1D3557"/>
-                </a:solidFill>
-                <a:latin typeface="Menlo"/>
-              </a:rPr>
-              <a:t># Explicar los vehículos del hogar con el ingreso y las personas</a:t>
-            </a:r>
-          </a:p>
-          <a:p>
-            <a:pPr/>
-            <a:r>
-              <a:rPr sz="1500" b="0">
-                <a:solidFill>
-                  <a:srgbClr val="1D3557"/>
-                </a:solidFill>
-                <a:latin typeface="Menlo"/>
-              </a:rPr>
-              <a:t>X = sm.add_constant(pd.DataFrame({</a:t>
-            </a:r>
-          </a:p>
-          <a:p>
-            <a:pPr/>
-            <a:r>
-              <a:rPr sz="1500" b="0">
-                <a:solidFill>
-                  <a:srgbClr val="1D3557"/>
-                </a:solidFill>
-                <a:latin typeface="Menlo"/>
-              </a:rPr>
-              <a:t>    "ingreso": h["IngresoHogar"] / 1e6,</a:t>
-            </a:r>
-          </a:p>
-          <a:p>
-            <a:pPr/>
-            <a:r>
-              <a:rPr sz="1500" b="0">
-                <a:solidFill>
-                  <a:srgbClr val="1D3557"/>
-                </a:solidFill>
-                <a:latin typeface="Menlo"/>
-              </a:rPr>
-              <a:t>    "personas": h["NumPer"]}))</a:t>
-            </a:r>
-          </a:p>
-          <a:p>
-            <a:pPr/>
-            <a:r>
-              <a:rPr sz="1500" b="0">
-                <a:solidFill>
-                  <a:srgbClr val="1D3557"/>
-                </a:solidFill>
-                <a:latin typeface="Menlo"/>
-              </a:rPr>
-              <a:t>modelo = sm.WLS(h["NumVeh"], X, weights=h["Factor"]).fit()</a:t>
-            </a:r>
-          </a:p>
-        </p:txBody>
-      </p:sp>
-      <p:sp>
-        <p:nvSpPr>
-          <p:cNvPr id="5" name="TextBox 4"/>
-          <p:cNvSpPr txBox="1"/>
-          <p:nvPr/>
-        </p:nvSpPr>
-        <p:spPr>
-          <a:xfrm>
-            <a:off x="704088" y="4389120"/>
-            <a:ext cx="7744968" cy="1097280"/>
-          </a:xfrm>
-          <a:prstGeom prst="rect">
-            <a:avLst/>
-          </a:prstGeom>
-          <a:noFill/>
-        </p:spPr>
-        <p:txBody>
-          <a:bodyPr wrap="square">
-            <a:spAutoFit/>
-          </a:bodyPr>
-          <a:lstStyle/>
-          <a:p>
-            <a:pPr>
-              <a:lnSpc>
-                <a:spcPct val="112000"/>
-              </a:lnSpc>
-              <a:spcAft>
-                <a:spcPts val="900"/>
-              </a:spcAft>
-            </a:pPr>
-            <a:r>
-              <a:rPr sz="1600" b="1">
+              <a:rPr sz="3400" b="1">
+                <a:solidFill>
+                  <a:srgbClr val="FFFFFF"/>
+                </a:solidFill>
+                <a:latin typeface="Fira Sans"/>
+              </a:rPr>
+              <a:t>¿Mejora el modelo si agregamos el tamaño del hogar?</a:t>
+            </a:r>
+          </a:p>
+          <a:p>
+            <a:r>
+              <a:rPr sz="1800" b="0">
                 <a:solidFill>
                   <a:srgbClr val="E0A437"/>
                 </a:solidFill>
                 <a:latin typeface="Fira Sans"/>
               </a:rPr>
-              <a:t>▸ </a:t>
-            </a:r>
-            <a:r>
-              <a:rPr sz="1600" b="0">
-                <a:solidFill>
-                  <a:srgbClr val="000000"/>
-                </a:solidFill>
-                <a:latin typeface="Fira Sans"/>
-              </a:rPr>
-              <a:t>Ponderado: 0,48 vehículos por millón (era 0,50 a solas) y 0,03 por persona extra. El R² sube apenas, de 0,261 a 0,266: agregar variables no siempre aporta.</a:t>
+              <a:t>Explicar los vehículos con el ingreso y las personas: la primera regresión múltiple</a:t>
             </a:r>
           </a:p>
         </p:txBody>
@@ -5637,35 +5499,114 @@
                 </a:solidFill>
                 <a:latin typeface="Fira Sans"/>
               </a:rPr>
-              <a:t>La ecuación ajustada y su lectura</a:t>
-            </a:r>
-          </a:p>
-        </p:txBody>
-      </p:sp>
-      <p:pic>
-        <p:nvPicPr>
-          <p:cNvPr id="4" name="Picture 3" descr="c4_08_ecuacion_motorizacion.png"/>
-          <p:cNvPicPr>
-            <a:picLocks noChangeAspect="1"/>
-          </p:cNvPicPr>
-          <p:nvPr/>
-        </p:nvPicPr>
-        <p:blipFill>
-          <a:blip r:embed="rId2"/>
-          <a:stretch>
-            <a:fillRect/>
-          </a:stretch>
-        </p:blipFill>
-        <p:spPr>
-          <a:xfrm>
-            <a:off x="699515" y="1292657"/>
-            <a:ext cx="7744968" cy="2855366"/>
-          </a:xfrm>
-          <a:prstGeom prst="rect">
-            <a:avLst/>
-          </a:prstGeom>
-        </p:spPr>
-      </p:pic>
+              <a:t>La motorización, con dos variables</a:t>
+            </a:r>
+          </a:p>
+        </p:txBody>
+      </p:sp>
+      <p:sp>
+        <p:nvSpPr>
+          <p:cNvPr id="4" name="Rectangle 3"/>
+          <p:cNvSpPr/>
+          <p:nvPr/>
+        </p:nvSpPr>
+        <p:spPr>
+          <a:xfrm>
+            <a:off x="704088" y="1280160"/>
+            <a:ext cx="7744968" cy="2880360"/>
+          </a:xfrm>
+          <a:prstGeom prst="rect">
+            <a:avLst/>
+          </a:prstGeom>
+          <a:solidFill>
+            <a:srgbClr val="F0F2F5"/>
+          </a:solidFill>
+          <a:ln>
+            <a:solidFill>
+              <a:srgbClr val="D8DDE3"/>
+            </a:solidFill>
+          </a:ln>
+          <a:effectLst/>
+        </p:spPr>
+        <p:style>
+          <a:lnRef idx="1">
+            <a:schemeClr val="accent1"/>
+          </a:lnRef>
+          <a:fillRef idx="3">
+            <a:schemeClr val="accent1"/>
+          </a:fillRef>
+          <a:effectRef idx="2">
+            <a:schemeClr val="accent1"/>
+          </a:effectRef>
+          <a:fontRef idx="minor">
+            <a:schemeClr val="lt1"/>
+          </a:fontRef>
+        </p:style>
+        <p:txBody>
+          <a:bodyPr rtlCol="0" anchor="ctr" wrap="square" lIns="228600" tIns="137160"/>
+          <a:lstStyle/>
+          <a:p>
+            <a:pPr/>
+            <a:r>
+              <a:rPr sz="1500" b="0">
+                <a:solidFill>
+                  <a:srgbClr val="1D3557"/>
+                </a:solidFill>
+                <a:latin typeface="Menlo"/>
+              </a:rPr>
+              <a:t># Explicar los vehículos del hogar con el ingreso y las personas</a:t>
+            </a:r>
+          </a:p>
+          <a:p>
+            <a:pPr/>
+            <a:r>
+              <a:rPr sz="1500" b="0">
+                <a:solidFill>
+                  <a:srgbClr val="1D3557"/>
+                </a:solidFill>
+                <a:latin typeface="Menlo"/>
+              </a:rPr>
+              <a:t>X = sm.add_constant(pd.DataFrame({</a:t>
+            </a:r>
+          </a:p>
+          <a:p>
+            <a:pPr/>
+            <a:r>
+              <a:rPr sz="1500" b="0">
+                <a:solidFill>
+                  <a:srgbClr val="1D3557"/>
+                </a:solidFill>
+                <a:latin typeface="Menlo"/>
+              </a:rPr>
+              <a:t>    "ingreso": h["IngresoHogar"] / 1e6,</a:t>
+            </a:r>
+          </a:p>
+          <a:p>
+            <a:pPr/>
+            <a:r>
+              <a:rPr sz="1500" b="0">
+                <a:solidFill>
+                  <a:srgbClr val="1D3557"/>
+                </a:solidFill>
+                <a:latin typeface="Menlo"/>
+              </a:rPr>
+              <a:t>    "personas": h["NumPer"]}))</a:t>
+            </a:r>
+          </a:p>
+          <a:p>
+            <a:pPr/>
+            <a:r>
+              <a:rPr sz="1500" b="0">
+                <a:solidFill>
+                  <a:srgbClr val="1D3557"/>
+                </a:solidFill>
+                <a:latin typeface="Menlo"/>
+              </a:rPr>
+              <a:t>modelo = sm.WLS(h["NumVeh"], X, weights=h["Factor"]).fit()</a:t>
+            </a:r>
+          </a:p>
+        </p:txBody>
+      </p:sp>
       <p:sp>
         <p:nvSpPr>
           <p:cNvPr id="5" name="TextBox 4"/>
@@ -5674,8 +5615,8 @@
         </p:nvSpPr>
         <p:spPr>
           <a:xfrm>
-            <a:off x="704088" y="4434840"/>
-            <a:ext cx="7744968" cy="457200"/>
+            <a:off x="704088" y="4389120"/>
+            <a:ext cx="7744968" cy="1097280"/>
           </a:xfrm>
           <a:prstGeom prst="rect">
             <a:avLst/>
@@ -5688,14 +5629,31 @@
           </a:bodyPr>
           <a:lstStyle/>
           <a:p>
-            <a:r>
-              <a:rPr sz="1300" b="0">
-                <a:solidFill>
-                  <a:srgbClr val="333333"/>
-                </a:solidFill>
-                <a:latin typeface="Fira Sans"/>
-              </a:rPr>
-              <a:t>La fórmula de la múltiple con nuestros números: cada coeficiente se lee con las demás variables fijas.</a:t>
+            <a:pPr>
+              <a:lnSpc>
+                <a:spcPct val="112000"/>
+              </a:lnSpc>
+              <a:spcAft>
+                <a:spcPts val="900"/>
+              </a:spcAft>
+            </a:pPr>
+            <a:r>
+              <a:rPr sz="1600" b="1">
+                <a:solidFill>
+                  <a:srgbClr val="E0A437"/>
+                </a:solidFill>
+                <a:latin typeface="Fira Sans"/>
+              </a:rPr>
+              <a:t>▸ </a:t>
+            </a:r>
+            <a:r>
+              <a:rPr sz="1600" b="0">
+                <a:solidFill>
+                  <a:srgbClr val="000000"/>
+                </a:solidFill>
+                <a:latin typeface="Fira Sans"/>
+              </a:rPr>
+              <a:t>Ponderado: 0,48 vehículos por millón (era 0,50 a solas) y 0,03 por persona extra. El R² sube apenas, de 0,261 a 0,266: agregar variables no siempre aporta.</a:t>
             </a:r>
           </a:p>
         </p:txBody>
@@ -5791,14 +5749,14 @@
                 </a:solidFill>
                 <a:latin typeface="Fira Sans"/>
               </a:rPr>
-              <a:t>Leer el modelo: R²</a:t>
+              <a:t>La ecuación ajustada y su lectura</a:t>
             </a:r>
           </a:p>
         </p:txBody>
       </p:sp>
       <p:pic>
         <p:nvPicPr>
-          <p:cNvPr id="4" name="Picture 3" descr="c4_04_formula_r2.png"/>
+          <p:cNvPr id="4" name="Picture 3" descr="c4_08_ecuacion_motorizacion.png"/>
           <p:cNvPicPr>
             <a:picLocks noChangeAspect="1"/>
           </p:cNvPicPr>
@@ -5812,8 +5770,8 @@
         </p:blipFill>
         <p:spPr>
           <a:xfrm>
-            <a:off x="699515" y="1297266"/>
-            <a:ext cx="7744968" cy="2846146"/>
+            <a:off x="699515" y="1292657"/>
+            <a:ext cx="7744968" cy="2855366"/>
           </a:xfrm>
           <a:prstGeom prst="rect">
             <a:avLst/>
@@ -5849,7 +5807,7 @@
                 </a:solidFill>
                 <a:latin typeface="Fira Sans"/>
               </a:rPr>
-              <a:t>Nuestro 0,266: ingreso y personas explican un cuarto de la variabilidad de los vehículos entre hogares. Agregar variables nunca baja el R²; por eso no basta con mirarlo.</a:t>
+              <a:t>La fórmula de la múltiple con nuestros números: cada coeficiente se lee con las demás variables fijas.</a:t>
             </a:r>
           </a:p>
         </p:txBody>
@@ -5945,14 +5903,14 @@
                 </a:solidFill>
                 <a:latin typeface="Fira Sans"/>
               </a:rPr>
-              <a:t>El valor p: dónde vive</a:t>
+              <a:t>Leer el modelo: R²</a:t>
             </a:r>
           </a:p>
         </p:txBody>
       </p:sp>
       <p:pic>
         <p:nvPicPr>
-          <p:cNvPr id="4" name="Picture 3" descr="c4_07_pvalue_summary.png"/>
+          <p:cNvPr id="4" name="Picture 3" descr="c4_04_formula_r2.png"/>
           <p:cNvPicPr>
             <a:picLocks noChangeAspect="1"/>
           </p:cNvPicPr>
@@ -5966,8 +5924,8 @@
         </p:blipFill>
         <p:spPr>
           <a:xfrm>
-            <a:off x="699515" y="1504912"/>
-            <a:ext cx="7744968" cy="2430856"/>
+            <a:off x="699515" y="1297266"/>
+            <a:ext cx="7744968" cy="2846146"/>
           </a:xfrm>
           <a:prstGeom prst="rect">
             <a:avLst/>
@@ -6003,7 +5961,7 @@
                 </a:solidFill>
                 <a:latin typeface="Fira Sans"/>
               </a:rPr>
-              <a:t>Para cada variable, P&gt;|t| responde: si en la ciudad el ingreso (o las personas) no tuviera efecto alguno sobre los vehículos, ¿qué tan raro sería este coeficiente solo por azar de la muestra? Ambos dan 0,000; la clase 5 lo formaliza.</a:t>
+              <a:t>Nuestro 0,266: ingreso y personas explican un cuarto de la variabilidad de los vehículos entre hogares. Agregar variables nunca baja el R²; por eso no basta con mirarlo.</a:t>
             </a:r>
           </a:p>
         </p:txBody>
@@ -6099,14 +6057,14 @@
                 </a:solidFill>
                 <a:latin typeface="Fira Sans"/>
               </a:rPr>
-              <a:t>El mapa para elegir variables</a:t>
+              <a:t>El valor p: dónde vive</a:t>
             </a:r>
           </a:p>
         </p:txBody>
       </p:sp>
       <p:pic>
         <p:nvPicPr>
-          <p:cNvPr id="4" name="Picture 3" descr="c4_05_mapa_candidatas.png"/>
+          <p:cNvPr id="4" name="Picture 3" descr="c4_07_pvalue_summary.png"/>
           <p:cNvPicPr>
             <a:picLocks noChangeAspect="1"/>
           </p:cNvPicPr>
@@ -6120,8 +6078,8 @@
         </p:blipFill>
         <p:spPr>
           <a:xfrm>
-            <a:off x="2530736" y="1143000"/>
-            <a:ext cx="4082527" cy="3154680"/>
+            <a:off x="699515" y="1504912"/>
+            <a:ext cx="7744968" cy="2430856"/>
           </a:xfrm>
           <a:prstGeom prst="rect">
             <a:avLst/>
@@ -6157,7 +6115,7 @@
                 </a:solidFill>
                 <a:latin typeface="Fira Sans"/>
               </a:rPr>
-              <a:t>La fila de NumVeh es el mapa: ingreso 0,47 es el motor; las bicicletas casi no correlacionan con los vehículos (0,06) y son redundantes entre sí (0,83). Probarlas confirma: R² 0,266 a 0,267.</a:t>
+              <a:t>Para cada variable, P&gt;|t| responde: si en la ciudad el ingreso (o las personas) no tuviera efecto alguno sobre los vehículos, ¿qué tan raro sería este coeficiente solo por azar de la muestra? Ambos dan 0,000; la clase 5 lo formaliza.</a:t>
             </a:r>
           </a:p>
         </p:txBody>
@@ -6253,14 +6211,14 @@
                 </a:solidFill>
                 <a:latin typeface="Fira Sans"/>
               </a:rPr>
-              <a:t>Los coeficientes al agregar variables</a:t>
+              <a:t>El mapa para elegir variables</a:t>
             </a:r>
           </a:p>
         </p:txBody>
       </p:sp>
       <p:pic>
         <p:nvPicPr>
-          <p:cNvPr id="4" name="Picture 3" descr="c4_10_cambio_coeficientes.png"/>
+          <p:cNvPr id="4" name="Picture 3" descr="c4_05_mapa_candidatas.png"/>
           <p:cNvPicPr>
             <a:picLocks noChangeAspect="1"/>
           </p:cNvPicPr>
@@ -6274,8 +6232,8 @@
         </p:blipFill>
         <p:spPr>
           <a:xfrm>
-            <a:off x="1051559" y="1143000"/>
-            <a:ext cx="7040880" cy="3154680"/>
+            <a:off x="2530736" y="1143000"/>
+            <a:ext cx="4082527" cy="3154680"/>
           </a:xfrm>
           <a:prstGeom prst="rect">
             <a:avLst/>
@@ -6311,7 +6269,7 @@
                 </a:solidFill>
                 <a:latin typeface="Fira Sans"/>
               </a:rPr>
-              <a:t>El ingreso apenas se mueve (0,50 a 0,48) al agregar personas y bicicletas: es un efecto robusto. Las variables nuevas entran con coeficientes minúsculos y el R² casi no cambia.</a:t>
+              <a:t>La fila de NumVeh es el mapa: ingreso 0,47 es el motor; las bicicletas casi no correlacionan con los vehículos (0,06) y son redundantes entre sí (0,83). Probarlas confirma: R² 0,266 a 0,267.</a:t>
             </a:r>
           </a:p>
         </p:txBody>
@@ -6349,7 +6307,7 @@
             <a:avLst/>
           </a:prstGeom>
           <a:solidFill>
-            <a:srgbClr val="1D3557"/>
+            <a:srgbClr val="FAFBFC"/>
           </a:solidFill>
           <a:ln>
             <a:noFill/>
@@ -6386,8 +6344,8 @@
         </p:nvSpPr>
         <p:spPr>
           <a:xfrm>
-            <a:off x="603504" y="1847088"/>
-            <a:ext cx="7946136" cy="1399032"/>
+            <a:off x="402336" y="301752"/>
+            <a:ext cx="8348472" cy="795528"/>
           </a:xfrm>
           <a:prstGeom prst="rect">
             <a:avLst/>
@@ -6401,24 +6359,71 @@
           <a:lstStyle/>
           <a:p>
             <a:r>
-              <a:rPr sz="3400" b="1">
-                <a:solidFill>
-                  <a:srgbClr val="FFFFFF"/>
-                </a:solidFill>
-                <a:latin typeface="Fira Sans"/>
-              </a:rPr>
-              <a:t>¿Cuánto más tarda un viaje según el modo, a igual distancia?</a:t>
-            </a:r>
-          </a:p>
-          <a:p>
-            <a:r>
-              <a:rPr sz="1800" b="0">
-                <a:solidFill>
-                  <a:srgbClr val="E0A437"/>
-                </a:solidFill>
-                <a:latin typeface="Fira Sans"/>
-              </a:rPr>
-              <a:t>Explicar la duración del viaje (en log) con la distancia (en log) y el modo de transporte: 102 mil viajes de la EOD</a:t>
+              <a:rPr sz="2800" b="1">
+                <a:solidFill>
+                  <a:srgbClr val="0F0F0F"/>
+                </a:solidFill>
+                <a:latin typeface="Fira Sans"/>
+              </a:rPr>
+              <a:t>Los coeficientes al agregar variables</a:t>
+            </a:r>
+          </a:p>
+        </p:txBody>
+      </p:sp>
+      <p:pic>
+        <p:nvPicPr>
+          <p:cNvPr id="4" name="Picture 3" descr="c4_10_cambio_coeficientes.png"/>
+          <p:cNvPicPr>
+            <a:picLocks noChangeAspect="1"/>
+          </p:cNvPicPr>
+          <p:nvPr/>
+        </p:nvPicPr>
+        <p:blipFill>
+          <a:blip r:embed="rId2"/>
+          <a:stretch>
+            <a:fillRect/>
+          </a:stretch>
+        </p:blipFill>
+        <p:spPr>
+          <a:xfrm>
+            <a:off x="1051559" y="1143000"/>
+            <a:ext cx="7040880" cy="3154680"/>
+          </a:xfrm>
+          <a:prstGeom prst="rect">
+            <a:avLst/>
+          </a:prstGeom>
+        </p:spPr>
+      </p:pic>
+      <p:sp>
+        <p:nvSpPr>
+          <p:cNvPr id="5" name="TextBox 4"/>
+          <p:cNvSpPr txBox="1"/>
+          <p:nvPr/>
+        </p:nvSpPr>
+        <p:spPr>
+          <a:xfrm>
+            <a:off x="704088" y="4434840"/>
+            <a:ext cx="7744968" cy="457200"/>
+          </a:xfrm>
+          <a:prstGeom prst="rect">
+            <a:avLst/>
+          </a:prstGeom>
+          <a:noFill/>
+        </p:spPr>
+        <p:txBody>
+          <a:bodyPr wrap="square">
+            <a:spAutoFit/>
+          </a:bodyPr>
+          <a:lstStyle/>
+          <a:p>
+            <a:r>
+              <a:rPr sz="1300" b="0">
+                <a:solidFill>
+                  <a:srgbClr val="333333"/>
+                </a:solidFill>
+                <a:latin typeface="Fira Sans"/>
+              </a:rPr>
+              <a:t>El ingreso apenas se mueve (0,50 a 0,48) al agregar personas y bicicletas: es un efecto robusto. Las variables nuevas entran con coeficientes minúsculos y el R² casi no cambia.</a:t>
             </a:r>
           </a:p>
         </p:txBody>
@@ -6456,7 +6461,7 @@
             <a:avLst/>
           </a:prstGeom>
           <a:solidFill>
-            <a:srgbClr val="FAFBFC"/>
+            <a:srgbClr val="1D3557"/>
           </a:solidFill>
           <a:ln>
             <a:noFill/>
@@ -6493,8 +6498,8 @@
         </p:nvSpPr>
         <p:spPr>
           <a:xfrm>
-            <a:off x="402336" y="301752"/>
-            <a:ext cx="8348472" cy="795528"/>
+            <a:off x="603504" y="1847088"/>
+            <a:ext cx="7946136" cy="1399032"/>
           </a:xfrm>
           <a:prstGeom prst="rect">
             <a:avLst/>
@@ -6508,167 +6513,24 @@
           <a:lstStyle/>
           <a:p>
             <a:r>
-              <a:rPr sz="2800" b="1">
-                <a:solidFill>
-                  <a:srgbClr val="0F0F0F"/>
-                </a:solidFill>
-                <a:latin typeface="Fira Sans"/>
-              </a:rPr>
-              <a:t>Una categórica entra como dummies</a:t>
-            </a:r>
-          </a:p>
-        </p:txBody>
-      </p:sp>
-      <p:sp>
-        <p:nvSpPr>
-          <p:cNvPr id="4" name="Rectangle 3"/>
-          <p:cNvSpPr/>
-          <p:nvPr/>
-        </p:nvSpPr>
-        <p:spPr>
-          <a:xfrm>
-            <a:off x="704088" y="1280160"/>
-            <a:ext cx="7744968" cy="2880360"/>
-          </a:xfrm>
-          <a:prstGeom prst="rect">
-            <a:avLst/>
-          </a:prstGeom>
-          <a:solidFill>
-            <a:srgbClr val="F0F2F5"/>
-          </a:solidFill>
-          <a:ln>
-            <a:solidFill>
-              <a:srgbClr val="D8DDE3"/>
-            </a:solidFill>
-          </a:ln>
-          <a:effectLst/>
-        </p:spPr>
-        <p:style>
-          <a:lnRef idx="1">
-            <a:schemeClr val="accent1"/>
-          </a:lnRef>
-          <a:fillRef idx="3">
-            <a:schemeClr val="accent1"/>
-          </a:fillRef>
-          <a:effectRef idx="2">
-            <a:schemeClr val="accent1"/>
-          </a:effectRef>
-          <a:fontRef idx="minor">
-            <a:schemeClr val="lt1"/>
-          </a:fontRef>
-        </p:style>
-        <p:txBody>
-          <a:bodyPr rtlCol="0" anchor="ctr" wrap="square" lIns="228600" tIns="137160"/>
-          <a:lstStyle/>
-          <a:p>
-            <a:pPr/>
-            <a:r>
-              <a:rPr sz="1500" b="0">
-                <a:solidFill>
-                  <a:srgbClr val="1D3557"/>
-                </a:solidFill>
-                <a:latin typeface="Menlo"/>
-              </a:rPr>
-              <a:t># Una columna 0/1 por modo; el auto queda de referencia</a:t>
-            </a:r>
-          </a:p>
-          <a:p>
-            <a:pPr/>
-            <a:r>
-              <a:rPr sz="1500" b="0">
-                <a:solidFill>
-                  <a:srgbClr val="1D3557"/>
-                </a:solidFill>
-                <a:latin typeface="Menlo"/>
-              </a:rPr>
-              <a:t>dummies = pd.get_dummies(viajes["ModoAgrupado"])</a:t>
-            </a:r>
-          </a:p>
-          <a:p>
-            <a:pPr/>
-            <a:r>
-              <a:rPr sz="1500" b="0">
-                <a:solidFill>
-                  <a:srgbClr val="1D3557"/>
-                </a:solidFill>
-                <a:latin typeface="Menlo"/>
-              </a:rPr>
-              <a:t>dummies = dummies.drop(columns=["Auto"])</a:t>
-            </a:r>
-          </a:p>
-          <a:p>
-            <a:pPr/>
-            <a:r>
-              <a:rPr sz="1500" b="0">
-                <a:solidFill>
-                  <a:srgbClr val="1D3557"/>
-                </a:solidFill>
-                <a:latin typeface="Menlo"/>
-              </a:rPr>
-              <a:t/>
-            </a:r>
-          </a:p>
-          <a:p>
-            <a:pPr/>
-            <a:r>
-              <a:rPr sz="1500" b="0">
-                <a:solidFill>
-                  <a:srgbClr val="1D3557"/>
-                </a:solidFill>
-                <a:latin typeface="Menlo"/>
-              </a:rPr>
-              <a:t># Explicar la duración (log) con la distancia (log) y el modo</a:t>
-            </a:r>
-          </a:p>
-        </p:txBody>
-      </p:sp>
-      <p:sp>
-        <p:nvSpPr>
-          <p:cNvPr id="5" name="TextBox 4"/>
-          <p:cNvSpPr txBox="1"/>
-          <p:nvPr/>
-        </p:nvSpPr>
-        <p:spPr>
-          <a:xfrm>
-            <a:off x="704088" y="4389120"/>
-            <a:ext cx="7744968" cy="1097280"/>
-          </a:xfrm>
-          <a:prstGeom prst="rect">
-            <a:avLst/>
-          </a:prstGeom>
-          <a:noFill/>
-        </p:spPr>
-        <p:txBody>
-          <a:bodyPr wrap="square">
-            <a:spAutoFit/>
-          </a:bodyPr>
-          <a:lstStyle/>
-          <a:p>
-            <a:pPr>
-              <a:lnSpc>
-                <a:spcPct val="112000"/>
-              </a:lnSpc>
-              <a:spcAft>
-                <a:spcPts val="900"/>
-              </a:spcAft>
-            </a:pPr>
-            <a:r>
-              <a:rPr sz="1600" b="1">
+              <a:rPr sz="3400" b="1">
+                <a:solidFill>
+                  <a:srgbClr val="FFFFFF"/>
+                </a:solidFill>
+                <a:latin typeface="Fira Sans"/>
+              </a:rPr>
+              <a:t>¿Y si agregamos más variables?</a:t>
+            </a:r>
+          </a:p>
+          <a:p>
+            <a:r>
+              <a:rPr sz="1800" b="0">
                 <a:solidFill>
                   <a:srgbClr val="E0A437"/>
                 </a:solidFill>
                 <a:latin typeface="Fira Sans"/>
               </a:rPr>
-              <a:t>▸ </a:t>
-            </a:r>
-            <a:r>
-              <a:rPr sz="1600" b="0">
-                <a:solidFill>
-                  <a:srgbClr val="000000"/>
-                </a:solidFill>
-                <a:latin typeface="Fira Sans"/>
-              </a:rPr>
-              <a:t>Cada coeficiente se lee comparado con la referencia: qué le pasa al tiempo de un viaje por ser en ese modo y no en auto, a igual distancia.</a:t>
+              <a:t>Volvemos a la duración: la distancia explica el 53%. ¿Qué más podría explicarla, y cómo se decide?</a:t>
             </a:r>
           </a:p>
         </p:txBody>
@@ -6764,14 +6626,14 @@
                 </a:solidFill>
                 <a:latin typeface="Fira Sans"/>
               </a:rPr>
-              <a:t>El resultado: distancia y modo</a:t>
+              <a:t>¿Qué más podría explicar la duración?</a:t>
             </a:r>
           </a:p>
         </p:txBody>
       </p:sp>
       <p:pic>
         <p:nvPicPr>
-          <p:cNvPr id="4" name="Picture 3" descr="c4_03_coef_modo.png"/>
+          <p:cNvPr id="4" name="Picture 3" descr="c4_13_por_modo.png"/>
           <p:cNvPicPr>
             <a:picLocks noChangeAspect="1"/>
           </p:cNvPicPr>
@@ -6785,8 +6647,8 @@
         </p:blipFill>
         <p:spPr>
           <a:xfrm>
-            <a:off x="804842" y="1143000"/>
-            <a:ext cx="7534315" cy="3154680"/>
+            <a:off x="699515" y="1409022"/>
+            <a:ext cx="7744968" cy="2622635"/>
           </a:xfrm>
           <a:prstGeom prst="rect">
             <a:avLst/>
@@ -6822,7 +6684,7 @@
                 </a:solidFill>
                 <a:latin typeface="Fira Sans"/>
               </a:rPr>
-              <a:t>A igual distancia, un viaje en Bip! tarda 1,87 veces lo que uno en auto; taxi y caminata quedan casi iguales al auto. El R² sube de 0,53 a 0,60.</a:t>
+              <a:t>Las numéricas del hogar no ayudan (ingreso r = −0,03, vehículos −0,09). El modo, que la matriz no ve, sí: Bip! 62 min contra 15 de caminata. Pero Bip! también va más lejos: hay que comparar a igual distancia.</a:t>
             </a:r>
           </a:p>
         </p:txBody>
@@ -7177,45 +7039,21 @@
                 </a:solidFill>
                 <a:latin typeface="Fira Sans"/>
               </a:rPr>
-              <a:t>La ecuación de la duración, leída</a:t>
-            </a:r>
-          </a:p>
-        </p:txBody>
-      </p:sp>
-      <p:pic>
-        <p:nvPicPr>
-          <p:cNvPr id="4" name="Picture 3" descr="c4_09_ecuacion_duracion.png"/>
-          <p:cNvPicPr>
-            <a:picLocks noChangeAspect="1"/>
-          </p:cNvPicPr>
-          <p:nvPr/>
-        </p:nvPicPr>
-        <p:blipFill>
-          <a:blip r:embed="rId2"/>
-          <a:stretch>
-            <a:fillRect/>
-          </a:stretch>
-        </p:blipFill>
-        <p:spPr>
-          <a:xfrm>
-            <a:off x="699515" y="1320746"/>
-            <a:ext cx="7744968" cy="2799186"/>
-          </a:xfrm>
-          <a:prstGeom prst="rect">
-            <a:avLst/>
-          </a:prstGeom>
-        </p:spPr>
-      </p:pic>
-      <p:sp>
-        <p:nvSpPr>
-          <p:cNvPr id="5" name="TextBox 4"/>
+              <a:t>Decisión 2: agregar el modo</a:t>
+            </a:r>
+          </a:p>
+        </p:txBody>
+      </p:sp>
+      <p:sp>
+        <p:nvSpPr>
+          <p:cNvPr id="4" name="TextBox 3"/>
           <p:cNvSpPr txBox="1"/>
           <p:nvPr/>
         </p:nvSpPr>
         <p:spPr>
           <a:xfrm>
-            <a:off x="704088" y="4434840"/>
-            <a:ext cx="7744968" cy="457200"/>
+            <a:off x="704088" y="1353312"/>
+            <a:ext cx="7744968" cy="3300984"/>
           </a:xfrm>
           <a:prstGeom prst="rect">
             <a:avLst/>
@@ -7228,14 +7066,115 @@
           </a:bodyPr>
           <a:lstStyle/>
           <a:p>
-            <a:r>
-              <a:rPr sz="1300" b="0">
-                <a:solidFill>
-                  <a:srgbClr val="333333"/>
-                </a:solidFill>
-                <a:latin typeface="Fira Sans"/>
-              </a:rPr>
-              <a:t>La misma tabla de coeficientes, escrita como ecuación: en escala log los efectos multiplican en vez de sumar.</a:t>
+            <a:pPr>
+              <a:lnSpc>
+                <a:spcPct val="112000"/>
+              </a:lnSpc>
+              <a:spcAft>
+                <a:spcPts val="900"/>
+              </a:spcAft>
+            </a:pPr>
+            <a:r>
+              <a:rPr sz="1800" b="1">
+                <a:solidFill>
+                  <a:srgbClr val="E0A437"/>
+                </a:solidFill>
+                <a:latin typeface="Fira Sans"/>
+              </a:rPr>
+              <a:t>▸ </a:t>
+            </a:r>
+            <a:r>
+              <a:rPr sz="1800" b="1">
+                <a:solidFill>
+                  <a:srgbClr val="1D3557"/>
+                </a:solidFill>
+                <a:latin typeface="Fira Sans"/>
+              </a:rPr>
+              <a:t>El modo es la candidata de mayor contraste y responde una pregunta de equidad: ¿cuánto más tarda un viaje según el modo, a igual distancia?</a:t>
+            </a:r>
+          </a:p>
+          <a:p>
+            <a:pPr>
+              <a:lnSpc>
+                <a:spcPct val="112000"/>
+              </a:lnSpc>
+              <a:spcAft>
+                <a:spcPts val="900"/>
+              </a:spcAft>
+            </a:pPr>
+            <a:r>
+              <a:rPr sz="1800" b="1">
+                <a:solidFill>
+                  <a:srgbClr val="E0A437"/>
+                </a:solidFill>
+                <a:latin typeface="Fira Sans"/>
+              </a:rPr>
+              <a:t>▸ </a:t>
+            </a:r>
+            <a:r>
+              <a:rPr sz="1800" b="0">
+                <a:solidFill>
+                  <a:srgbClr val="000000"/>
+                </a:solidFill>
+                <a:latin typeface="Fira Sans"/>
+              </a:rPr>
+              <a:t>Comparar duraciones a secas mezcla el modo con la distancia; la regresión múltiple controla la distancia y aísla el modo.</a:t>
+            </a:r>
+          </a:p>
+          <a:p>
+            <a:pPr>
+              <a:lnSpc>
+                <a:spcPct val="112000"/>
+              </a:lnSpc>
+              <a:spcAft>
+                <a:spcPts val="900"/>
+              </a:spcAft>
+            </a:pPr>
+            <a:r>
+              <a:rPr sz="1800" b="1">
+                <a:solidFill>
+                  <a:srgbClr val="E0A437"/>
+                </a:solidFill>
+                <a:latin typeface="Fira Sans"/>
+              </a:rPr>
+              <a:t>▸ </a:t>
+            </a:r>
+            <a:r>
+              <a:rPr sz="1800" b="0">
+                <a:solidFill>
+                  <a:srgbClr val="000000"/>
+                </a:solidFill>
+                <a:latin typeface="Fira Sans"/>
+              </a:rPr>
+              <a:t>Como el modo es texto, no puede entrar tal cual a la fórmula: primero hay que convertirlo en números.</a:t>
+            </a:r>
+          </a:p>
+          <a:p>
+            <a:pPr>
+              <a:lnSpc>
+                <a:spcPct val="112000"/>
+              </a:lnSpc>
+              <a:spcAft>
+                <a:spcPts val="900"/>
+              </a:spcAft>
+            </a:pPr>
+            <a:r>
+              <a:rPr sz="1800" b="1">
+                <a:solidFill>
+                  <a:srgbClr val="E0A437"/>
+                </a:solidFill>
+                <a:latin typeface="Fira Sans"/>
+              </a:rPr>
+              <a:t>▸ </a:t>
+            </a:r>
+            <a:r>
+              <a:rPr sz="1800" b="0">
+                <a:solidFill>
+                  <a:srgbClr val="000000"/>
+                </a:solidFill>
+                <a:latin typeface="Fira Sans"/>
+              </a:rPr>
+              <a:t>El período del día es la otra candidata fuerte (punta mañana 60 min, fuera de punta 32): queda para el ejercicio.</a:t>
             </a:r>
           </a:p>
         </p:txBody>
@@ -7331,21 +7270,45 @@
                 </a:solidFill>
                 <a:latin typeface="Fira Sans"/>
               </a:rPr>
-              <a:t>Síntesis</a:t>
-            </a:r>
-          </a:p>
-        </p:txBody>
-      </p:sp>
-      <p:sp>
-        <p:nvSpPr>
-          <p:cNvPr id="4" name="TextBox 3"/>
+              <a:t>Una categórica, convertida en columnas 0/1</a:t>
+            </a:r>
+          </a:p>
+        </p:txBody>
+      </p:sp>
+      <p:pic>
+        <p:nvPicPr>
+          <p:cNvPr id="4" name="Picture 3" descr="c4_11_dummies_tabla.png"/>
+          <p:cNvPicPr>
+            <a:picLocks noChangeAspect="1"/>
+          </p:cNvPicPr>
+          <p:nvPr/>
+        </p:nvPicPr>
+        <p:blipFill>
+          <a:blip r:embed="rId2"/>
+          <a:stretch>
+            <a:fillRect/>
+          </a:stretch>
+        </p:blipFill>
+        <p:spPr>
+          <a:xfrm>
+            <a:off x="755966" y="1143000"/>
+            <a:ext cx="7632067" cy="3154680"/>
+          </a:xfrm>
+          <a:prstGeom prst="rect">
+            <a:avLst/>
+          </a:prstGeom>
+        </p:spPr>
+      </p:pic>
+      <p:sp>
+        <p:nvSpPr>
+          <p:cNvPr id="5" name="TextBox 4"/>
           <p:cNvSpPr txBox="1"/>
           <p:nvPr/>
         </p:nvSpPr>
         <p:spPr>
           <a:xfrm>
-            <a:off x="704088" y="1353312"/>
-            <a:ext cx="7744968" cy="3300984"/>
+            <a:off x="704088" y="4434840"/>
+            <a:ext cx="7744968" cy="457200"/>
           </a:xfrm>
           <a:prstGeom prst="rect">
             <a:avLst/>
@@ -7358,143 +7321,14 @@
           </a:bodyPr>
           <a:lstStyle/>
           <a:p>
-            <a:pPr>
-              <a:lnSpc>
-                <a:spcPct val="112000"/>
-              </a:lnSpc>
-              <a:spcAft>
-                <a:spcPts val="900"/>
-              </a:spcAft>
-            </a:pPr>
-            <a:r>
-              <a:rPr sz="1800" b="1">
-                <a:solidFill>
-                  <a:srgbClr val="E0A437"/>
-                </a:solidFill>
-                <a:latin typeface="Fira Sans"/>
-              </a:rPr>
-              <a:t>▸ </a:t>
-            </a:r>
-            <a:r>
-              <a:rPr sz="1800" b="0">
-                <a:solidFill>
-                  <a:srgbClr val="000000"/>
-                </a:solidFill>
-                <a:latin typeface="Fira Sans"/>
-              </a:rPr>
-              <a:t>El impacto de filas y atípicos se mide con y sin, sobre todos los resúmenes en uso.</a:t>
-            </a:r>
-          </a:p>
-          <a:p>
-            <a:pPr>
-              <a:lnSpc>
-                <a:spcPct val="112000"/>
-              </a:lnSpc>
-              <a:spcAft>
-                <a:spcPts val="900"/>
-              </a:spcAft>
-            </a:pPr>
-            <a:r>
-              <a:rPr sz="1800" b="1">
-                <a:solidFill>
-                  <a:srgbClr val="E0A437"/>
-                </a:solidFill>
-                <a:latin typeface="Fira Sans"/>
-              </a:rPr>
-              <a:t>▸ </a:t>
-            </a:r>
-            <a:r>
-              <a:rPr sz="1800" b="0">
-                <a:solidFill>
-                  <a:srgbClr val="000000"/>
-                </a:solidFill>
-                <a:latin typeface="Fira Sans"/>
-              </a:rPr>
-              <a:t>Cuando la conclusión es sobre la ciudad, se pondera: WLS.</a:t>
-            </a:r>
-          </a:p>
-          <a:p>
-            <a:pPr>
-              <a:lnSpc>
-                <a:spcPct val="112000"/>
-              </a:lnSpc>
-              <a:spcAft>
-                <a:spcPts val="900"/>
-              </a:spcAft>
-            </a:pPr>
-            <a:r>
-              <a:rPr sz="1800" b="1">
-                <a:solidFill>
-                  <a:srgbClr val="E0A437"/>
-                </a:solidFill>
-                <a:latin typeface="Fira Sans"/>
-              </a:rPr>
-              <a:t>▸ </a:t>
-            </a:r>
-            <a:r>
-              <a:rPr sz="1800" b="0">
-                <a:solidFill>
-                  <a:srgbClr val="000000"/>
-                </a:solidFill>
-                <a:latin typeface="Fira Sans"/>
-              </a:rPr>
-              <a:t>Muchos puntos: alpha o hexbin. Colas largas: log.</a:t>
-            </a:r>
-          </a:p>
-          <a:p>
-            <a:pPr>
-              <a:lnSpc>
-                <a:spcPct val="112000"/>
-              </a:lnSpc>
-              <a:spcAft>
-                <a:spcPts val="900"/>
-              </a:spcAft>
-            </a:pPr>
-            <a:r>
-              <a:rPr sz="1800" b="1">
-                <a:solidFill>
-                  <a:srgbClr val="E0A437"/>
-                </a:solidFill>
-                <a:latin typeface="Fira Sans"/>
-              </a:rPr>
-              <a:t>▸ </a:t>
-            </a:r>
-            <a:r>
-              <a:rPr sz="1800" b="0">
-                <a:solidFill>
-                  <a:srgbClr val="000000"/>
-                </a:solidFill>
-                <a:latin typeface="Fira Sans"/>
-              </a:rPr>
-              <a:t>La múltiple aísla el efecto de cada variable (categóricas como dummies); R² dice cuánto explica y el valor p si un coeficiente se distingue del azar.</a:t>
-            </a:r>
-          </a:p>
-          <a:p>
-            <a:pPr>
-              <a:lnSpc>
-                <a:spcPct val="112000"/>
-              </a:lnSpc>
-              <a:spcAft>
-                <a:spcPts val="900"/>
-              </a:spcAft>
-            </a:pPr>
-            <a:r>
-              <a:rPr sz="1800" b="1">
-                <a:solidFill>
-                  <a:srgbClr val="E0A437"/>
-                </a:solidFill>
-                <a:latin typeface="Fira Sans"/>
-              </a:rPr>
-              <a:t>▸ </a:t>
-            </a:r>
-            <a:r>
-              <a:rPr sz="1800" b="1">
-                <a:solidFill>
-                  <a:srgbClr val="1D3557"/>
-                </a:solidFill>
-                <a:latin typeface="Fira Sans"/>
-              </a:rPr>
-              <a:t>El primer EDA del proyecto usa exactamente estas herramientas (entrega: lunes 15).</a:t>
+            <a:r>
+              <a:rPr sz="1300" b="0">
+                <a:solidFill>
+                  <a:srgbClr val="333333"/>
+                </a:solidFill>
+                <a:latin typeface="Fira Sans"/>
+              </a:rPr>
+              <a:t>El modo es texto y la fórmula solo suma números: pd.get_dummies crea una columna por categoría. Cada viaje tiene un solo 1, en la de su modo; el auto se saca y queda de referencia.</a:t>
             </a:r>
           </a:p>
         </p:txBody>
@@ -7532,7 +7366,7 @@
             <a:avLst/>
           </a:prstGeom>
           <a:solidFill>
-            <a:srgbClr val="1D3557"/>
+            <a:srgbClr val="FAFBFC"/>
           </a:solidFill>
           <a:ln>
             <a:noFill/>
@@ -7569,8 +7403,8 @@
         </p:nvSpPr>
         <p:spPr>
           <a:xfrm>
-            <a:off x="603504" y="1847088"/>
-            <a:ext cx="7946136" cy="1399032"/>
+            <a:off x="402336" y="301752"/>
+            <a:ext cx="8348472" cy="795528"/>
           </a:xfrm>
           <a:prstGeom prst="rect">
             <a:avLst/>
@@ -7584,24 +7418,167 @@
           <a:lstStyle/>
           <a:p>
             <a:r>
-              <a:rPr sz="3400" b="1">
-                <a:solidFill>
-                  <a:srgbClr val="FFFFFF"/>
-                </a:solidFill>
-                <a:latin typeface="Fira Sans"/>
-              </a:rPr>
-              <a:t>Recreo</a:t>
-            </a:r>
-          </a:p>
-          <a:p>
-            <a:r>
-              <a:rPr sz="1800" b="0">
+              <a:rPr sz="2800" b="1">
+                <a:solidFill>
+                  <a:srgbClr val="0F0F0F"/>
+                </a:solidFill>
+                <a:latin typeface="Fira Sans"/>
+              </a:rPr>
+              <a:t>Las dummies, en código</a:t>
+            </a:r>
+          </a:p>
+        </p:txBody>
+      </p:sp>
+      <p:sp>
+        <p:nvSpPr>
+          <p:cNvPr id="4" name="Rectangle 3"/>
+          <p:cNvSpPr/>
+          <p:nvPr/>
+        </p:nvSpPr>
+        <p:spPr>
+          <a:xfrm>
+            <a:off x="704088" y="1280160"/>
+            <a:ext cx="7744968" cy="2880360"/>
+          </a:xfrm>
+          <a:prstGeom prst="rect">
+            <a:avLst/>
+          </a:prstGeom>
+          <a:solidFill>
+            <a:srgbClr val="F0F2F5"/>
+          </a:solidFill>
+          <a:ln>
+            <a:solidFill>
+              <a:srgbClr val="D8DDE3"/>
+            </a:solidFill>
+          </a:ln>
+          <a:effectLst/>
+        </p:spPr>
+        <p:style>
+          <a:lnRef idx="1">
+            <a:schemeClr val="accent1"/>
+          </a:lnRef>
+          <a:fillRef idx="3">
+            <a:schemeClr val="accent1"/>
+          </a:fillRef>
+          <a:effectRef idx="2">
+            <a:schemeClr val="accent1"/>
+          </a:effectRef>
+          <a:fontRef idx="minor">
+            <a:schemeClr val="lt1"/>
+          </a:fontRef>
+        </p:style>
+        <p:txBody>
+          <a:bodyPr rtlCol="0" anchor="ctr" wrap="square" lIns="228600" tIns="137160"/>
+          <a:lstStyle/>
+          <a:p>
+            <a:pPr/>
+            <a:r>
+              <a:rPr sz="1500" b="0">
+                <a:solidFill>
+                  <a:srgbClr val="1D3557"/>
+                </a:solidFill>
+                <a:latin typeface="Menlo"/>
+              </a:rPr>
+              <a:t># Una columna 0/1 por modo; el auto queda de referencia</a:t>
+            </a:r>
+          </a:p>
+          <a:p>
+            <a:pPr/>
+            <a:r>
+              <a:rPr sz="1500" b="0">
+                <a:solidFill>
+                  <a:srgbClr val="1D3557"/>
+                </a:solidFill>
+                <a:latin typeface="Menlo"/>
+              </a:rPr>
+              <a:t>dummies = pd.get_dummies(viajes["ModoAgrupado"])</a:t>
+            </a:r>
+          </a:p>
+          <a:p>
+            <a:pPr/>
+            <a:r>
+              <a:rPr sz="1500" b="0">
+                <a:solidFill>
+                  <a:srgbClr val="1D3557"/>
+                </a:solidFill>
+                <a:latin typeface="Menlo"/>
+              </a:rPr>
+              <a:t>dummies = dummies.drop(columns=["Auto"])</a:t>
+            </a:r>
+          </a:p>
+          <a:p>
+            <a:pPr/>
+            <a:r>
+              <a:rPr sz="1500" b="0">
+                <a:solidFill>
+                  <a:srgbClr val="1D3557"/>
+                </a:solidFill>
+                <a:latin typeface="Menlo"/>
+              </a:rPr>
+              <a:t/>
+            </a:r>
+          </a:p>
+          <a:p>
+            <a:pPr/>
+            <a:r>
+              <a:rPr sz="1500" b="0">
+                <a:solidFill>
+                  <a:srgbClr val="1D3557"/>
+                </a:solidFill>
+                <a:latin typeface="Menlo"/>
+              </a:rPr>
+              <a:t># Explicar la duración (log) con la distancia (log) y el modo</a:t>
+            </a:r>
+          </a:p>
+        </p:txBody>
+      </p:sp>
+      <p:sp>
+        <p:nvSpPr>
+          <p:cNvPr id="5" name="TextBox 4"/>
+          <p:cNvSpPr txBox="1"/>
+          <p:nvPr/>
+        </p:nvSpPr>
+        <p:spPr>
+          <a:xfrm>
+            <a:off x="704088" y="4389120"/>
+            <a:ext cx="7744968" cy="1097280"/>
+          </a:xfrm>
+          <a:prstGeom prst="rect">
+            <a:avLst/>
+          </a:prstGeom>
+          <a:noFill/>
+        </p:spPr>
+        <p:txBody>
+          <a:bodyPr wrap="square">
+            <a:spAutoFit/>
+          </a:bodyPr>
+          <a:lstStyle/>
+          <a:p>
+            <a:pPr>
+              <a:lnSpc>
+                <a:spcPct val="112000"/>
+              </a:lnSpc>
+              <a:spcAft>
+                <a:spcPts val="900"/>
+              </a:spcAft>
+            </a:pPr>
+            <a:r>
+              <a:rPr sz="1600" b="1">
                 <a:solidFill>
                   <a:srgbClr val="E0A437"/>
                 </a:solidFill>
                 <a:latin typeface="Fira Sans"/>
               </a:rPr>
-              <a:t>10 minutos · al volver: las presentaciones de ideas</a:t>
+              <a:t>▸ </a:t>
+            </a:r>
+            <a:r>
+              <a:rPr sz="1600" b="0">
+                <a:solidFill>
+                  <a:srgbClr val="000000"/>
+                </a:solidFill>
+                <a:latin typeface="Fira Sans"/>
+              </a:rPr>
+              <a:t>Las dummies se agregan a la X junto al log de la distancia. Cada coeficiente se lee comparado con la referencia: ese modo frente al auto, a igual distancia.</a:t>
             </a:r>
           </a:p>
         </p:txBody>
@@ -7639,7 +7616,7 @@
             <a:avLst/>
           </a:prstGeom>
           <a:solidFill>
-            <a:srgbClr val="1D3557"/>
+            <a:srgbClr val="FAFBFC"/>
           </a:solidFill>
           <a:ln>
             <a:noFill/>
@@ -7676,8 +7653,8 @@
         </p:nvSpPr>
         <p:spPr>
           <a:xfrm>
-            <a:off x="603504" y="1847088"/>
-            <a:ext cx="7946136" cy="1399032"/>
+            <a:off x="402336" y="301752"/>
+            <a:ext cx="8348472" cy="795528"/>
           </a:xfrm>
           <a:prstGeom prst="rect">
             <a:avLst/>
@@ -7691,24 +7668,71 @@
           <a:lstStyle/>
           <a:p>
             <a:r>
-              <a:rPr sz="3400" b="1">
-                <a:solidFill>
-                  <a:srgbClr val="FFFFFF"/>
-                </a:solidFill>
-                <a:latin typeface="Fira Sans"/>
-              </a:rPr>
-              <a:t>Presentaciones de ideas</a:t>
-            </a:r>
-          </a:p>
-          <a:p>
-            <a:r>
-              <a:rPr sz="1800" b="0">
-                <a:solidFill>
-                  <a:srgbClr val="E0A437"/>
-                </a:solidFill>
-                <a:latin typeface="Fira Sans"/>
-              </a:rPr>
-              <a:t>De 5 a 7 minutos por equipo, y preguntas de todos</a:t>
+              <a:rPr sz="2800" b="1">
+                <a:solidFill>
+                  <a:srgbClr val="0F0F0F"/>
+                </a:solidFill>
+                <a:latin typeface="Fira Sans"/>
+              </a:rPr>
+              <a:t>Qué hace una dummy dentro del modelo</a:t>
+            </a:r>
+          </a:p>
+        </p:txBody>
+      </p:sp>
+      <p:pic>
+        <p:nvPicPr>
+          <p:cNvPr id="4" name="Picture 3" descr="c4_12_dummies_rectas.png"/>
+          <p:cNvPicPr>
+            <a:picLocks noChangeAspect="1"/>
+          </p:cNvPicPr>
+          <p:nvPr/>
+        </p:nvPicPr>
+        <p:blipFill>
+          <a:blip r:embed="rId2"/>
+          <a:stretch>
+            <a:fillRect/>
+          </a:stretch>
+        </p:blipFill>
+        <p:spPr>
+          <a:xfrm>
+            <a:off x="1280160" y="1143000"/>
+            <a:ext cx="6583680" cy="3154680"/>
+          </a:xfrm>
+          <a:prstGeom prst="rect">
+            <a:avLst/>
+          </a:prstGeom>
+        </p:spPr>
+      </p:pic>
+      <p:sp>
+        <p:nvSpPr>
+          <p:cNvPr id="5" name="TextBox 4"/>
+          <p:cNvSpPr txBox="1"/>
+          <p:nvPr/>
+        </p:nvSpPr>
+        <p:spPr>
+          <a:xfrm>
+            <a:off x="704088" y="4434840"/>
+            <a:ext cx="7744968" cy="457200"/>
+          </a:xfrm>
+          <a:prstGeom prst="rect">
+            <a:avLst/>
+          </a:prstGeom>
+          <a:noFill/>
+        </p:spPr>
+        <p:txBody>
+          <a:bodyPr wrap="square">
+            <a:spAutoFit/>
+          </a:bodyPr>
+          <a:lstStyle/>
+          <a:p>
+            <a:r>
+              <a:rPr sz="1300" b="0">
+                <a:solidFill>
+                  <a:srgbClr val="333333"/>
+                </a:solidFill>
+                <a:latin typeface="Fira Sans"/>
+              </a:rPr>
+              <a:t>La dummy suma su coeficiente al intercepto de su modo: rectas paralelas, con la misma pendiente en la distancia. En log, sumar 0,27 es multiplicar el tiempo por 1,87.</a:t>
             </a:r>
           </a:p>
         </p:txBody>
@@ -7804,21 +7828,45 @@
                 </a:solidFill>
                 <a:latin typeface="Fira Sans"/>
               </a:rPr>
-              <a:t>El formato</a:t>
-            </a:r>
-          </a:p>
-        </p:txBody>
-      </p:sp>
-      <p:sp>
-        <p:nvSpPr>
-          <p:cNvPr id="4" name="TextBox 3"/>
+              <a:t>El resultado: distancia y modo</a:t>
+            </a:r>
+          </a:p>
+        </p:txBody>
+      </p:sp>
+      <p:pic>
+        <p:nvPicPr>
+          <p:cNvPr id="4" name="Picture 3" descr="c4_03_coef_modo.png"/>
+          <p:cNvPicPr>
+            <a:picLocks noChangeAspect="1"/>
+          </p:cNvPicPr>
+          <p:nvPr/>
+        </p:nvPicPr>
+        <p:blipFill>
+          <a:blip r:embed="rId2"/>
+          <a:stretch>
+            <a:fillRect/>
+          </a:stretch>
+        </p:blipFill>
+        <p:spPr>
+          <a:xfrm>
+            <a:off x="804842" y="1143000"/>
+            <a:ext cx="7534315" cy="3154680"/>
+          </a:xfrm>
+          <a:prstGeom prst="rect">
+            <a:avLst/>
+          </a:prstGeom>
+        </p:spPr>
+      </p:pic>
+      <p:sp>
+        <p:nvSpPr>
+          <p:cNvPr id="5" name="TextBox 4"/>
           <p:cNvSpPr txBox="1"/>
           <p:nvPr/>
         </p:nvSpPr>
         <p:spPr>
           <a:xfrm>
-            <a:off x="704088" y="1353312"/>
-            <a:ext cx="7744968" cy="3300984"/>
+            <a:off x="704088" y="4434840"/>
+            <a:ext cx="7744968" cy="457200"/>
           </a:xfrm>
           <a:prstGeom prst="rect">
             <a:avLst/>
@@ -7831,59 +7879,14 @@
           </a:bodyPr>
           <a:lstStyle/>
           <a:p>
-            <a:pPr>
-              <a:lnSpc>
-                <a:spcPct val="112000"/>
-              </a:lnSpc>
-              <a:spcAft>
-                <a:spcPts val="900"/>
-              </a:spcAft>
-            </a:pPr>
-            <a:r>
-              <a:rPr sz="1800" b="1">
-                <a:solidFill>
-                  <a:srgbClr val="E0A437"/>
-                </a:solidFill>
-                <a:latin typeface="Fira Sans"/>
-              </a:rPr>
-              <a:t>▸ </a:t>
-            </a:r>
-            <a:r>
-              <a:rPr sz="1800" b="1">
-                <a:solidFill>
-                  <a:srgbClr val="1D3557"/>
-                </a:solidFill>
-                <a:latin typeface="Fira Sans"/>
-              </a:rPr>
-              <a:t>Esta instancia no lleva nota: es para recibir retroalimentación temprano, cuando corregir cuesta poco.</a:t>
-            </a:r>
-          </a:p>
-          <a:p>
-            <a:pPr>
-              <a:lnSpc>
-                <a:spcPct val="112000"/>
-              </a:lnSpc>
-              <a:spcAft>
-                <a:spcPts val="900"/>
-              </a:spcAft>
-            </a:pPr>
-            <a:r>
-              <a:rPr sz="1800" b="1">
-                <a:solidFill>
-                  <a:srgbClr val="E0A437"/>
-                </a:solidFill>
-                <a:latin typeface="Fira Sans"/>
-              </a:rPr>
-              <a:t>▸ </a:t>
-            </a:r>
-            <a:r>
-              <a:rPr sz="1800" b="0">
-                <a:solidFill>
-                  <a:srgbClr val="000000"/>
-                </a:solidFill>
-                <a:latin typeface="Fira Sans"/>
-              </a:rPr>
-              <a:t>Después de cada equipo, preguntas y comentarios del curso.</a:t>
+            <a:r>
+              <a:rPr sz="1300" b="0">
+                <a:solidFill>
+                  <a:srgbClr val="333333"/>
+                </a:solidFill>
+                <a:latin typeface="Fira Sans"/>
+              </a:rPr>
+              <a:t>A igual distancia, un viaje en Bip! tarda 1,87 veces lo que uno en auto; taxi y caminata quedan casi iguales al auto. El R² sube de 0,53 a 0,60.</a:t>
             </a:r>
           </a:p>
         </p:txBody>
@@ -7979,21 +7982,45 @@
                 </a:solidFill>
                 <a:latin typeface="Fira Sans"/>
               </a:rPr>
-              <a:t>Próxima clase</a:t>
-            </a:r>
-          </a:p>
-        </p:txBody>
-      </p:sp>
-      <p:sp>
-        <p:nvSpPr>
-          <p:cNvPr id="4" name="TextBox 3"/>
+              <a:t>La ecuación de la duración, leída</a:t>
+            </a:r>
+          </a:p>
+        </p:txBody>
+      </p:sp>
+      <p:pic>
+        <p:nvPicPr>
+          <p:cNvPr id="4" name="Picture 3" descr="c4_09_ecuacion_duracion.png"/>
+          <p:cNvPicPr>
+            <a:picLocks noChangeAspect="1"/>
+          </p:cNvPicPr>
+          <p:nvPr/>
+        </p:nvPicPr>
+        <p:blipFill>
+          <a:blip r:embed="rId2"/>
+          <a:stretch>
+            <a:fillRect/>
+          </a:stretch>
+        </p:blipFill>
+        <p:spPr>
+          <a:xfrm>
+            <a:off x="699515" y="1320746"/>
+            <a:ext cx="7744968" cy="2799186"/>
+          </a:xfrm>
+          <a:prstGeom prst="rect">
+            <a:avLst/>
+          </a:prstGeom>
+        </p:spPr>
+      </p:pic>
+      <p:sp>
+        <p:nvSpPr>
+          <p:cNvPr id="5" name="TextBox 4"/>
           <p:cNvSpPr txBox="1"/>
           <p:nvPr/>
         </p:nvSpPr>
         <p:spPr>
           <a:xfrm>
-            <a:off x="704088" y="1353312"/>
-            <a:ext cx="7744968" cy="3300984"/>
+            <a:off x="704088" y="4434840"/>
+            <a:ext cx="7744968" cy="457200"/>
           </a:xfrm>
           <a:prstGeom prst="rect">
             <a:avLst/>
@@ -8006,87 +8033,14 @@
           </a:bodyPr>
           <a:lstStyle/>
           <a:p>
-            <a:pPr>
-              <a:lnSpc>
-                <a:spcPct val="112000"/>
-              </a:lnSpc>
-              <a:spcAft>
-                <a:spcPts val="900"/>
-              </a:spcAft>
-            </a:pPr>
-            <a:r>
-              <a:rPr sz="1800" b="1">
-                <a:solidFill>
-                  <a:srgbClr val="E0A437"/>
-                </a:solidFill>
-                <a:latin typeface="Fira Sans"/>
-              </a:rPr>
-              <a:t>▸ </a:t>
-            </a:r>
-            <a:r>
-              <a:rPr sz="1800" b="0">
-                <a:solidFill>
-                  <a:srgbClr val="000000"/>
-                </a:solidFill>
-                <a:latin typeface="Fira Sans"/>
-              </a:rPr>
-              <a:t>Martes 8: fundamentos de probabilidad y nociones de inferencia estadística.</a:t>
-            </a:r>
-          </a:p>
-          <a:p>
-            <a:pPr>
-              <a:lnSpc>
-                <a:spcPct val="112000"/>
-              </a:lnSpc>
-              <a:spcAft>
-                <a:spcPts val="900"/>
-              </a:spcAft>
-            </a:pPr>
-            <a:r>
-              <a:rPr sz="1800" b="1">
-                <a:solidFill>
-                  <a:srgbClr val="E0A437"/>
-                </a:solidFill>
-                <a:latin typeface="Fira Sans"/>
-              </a:rPr>
-              <a:t>▸ </a:t>
-            </a:r>
-            <a:r>
-              <a:rPr sz="1800" b="0">
-                <a:solidFill>
-                  <a:srgbClr val="000000"/>
-                </a:solidFill>
-                <a:latin typeface="Fira Sans"/>
-              </a:rPr>
-              <a:t>La pregunta pendiente desde la clase 3: ¿qué significa el valor p que statsmodels ya nos mostró?</a:t>
-            </a:r>
-          </a:p>
-          <a:p>
-            <a:pPr>
-              <a:lnSpc>
-                <a:spcPct val="112000"/>
-              </a:lnSpc>
-              <a:spcAft>
-                <a:spcPts val="900"/>
-              </a:spcAft>
-            </a:pPr>
-            <a:r>
-              <a:rPr sz="1800" b="1">
-                <a:solidFill>
-                  <a:srgbClr val="E0A437"/>
-                </a:solidFill>
-                <a:latin typeface="Fira Sans"/>
-              </a:rPr>
-              <a:t>▸ </a:t>
-            </a:r>
-            <a:r>
-              <a:rPr sz="1800" b="1">
-                <a:solidFill>
-                  <a:srgbClr val="1D3557"/>
-                </a:solidFill>
-                <a:latin typeface="Fira Sans"/>
-              </a:rPr>
-              <a:t>La formulación se entrega el lunes 7; el primer análisis exploratorio, el lunes 15.</a:t>
+            <a:r>
+              <a:rPr sz="1300" b="0">
+                <a:solidFill>
+                  <a:srgbClr val="333333"/>
+                </a:solidFill>
+                <a:latin typeface="Fira Sans"/>
+              </a:rPr>
+              <a:t>La misma tabla de coeficientes, escrita como ecuación: en escala log los efectos multiplican en vez de sumar.</a:t>
             </a:r>
           </a:p>
         </p:txBody>
@@ -8182,7 +8136,7 @@
                 </a:solidFill>
                 <a:latin typeface="Fira Sans"/>
               </a:rPr>
-              <a:t>Referencias</a:t>
+              <a:t>Síntesis</a:t>
             </a:r>
           </a:p>
         </p:txBody>
@@ -8195,8 +8149,8 @@
         </p:nvSpPr>
         <p:spPr>
           <a:xfrm>
-            <a:off x="704088" y="1234440"/>
-            <a:ext cx="7744968" cy="3566160"/>
+            <a:off x="704088" y="1353312"/>
+            <a:ext cx="7744968" cy="3300984"/>
           </a:xfrm>
           <a:prstGeom prst="rect">
             <a:avLst/>
@@ -8211,77 +8165,530 @@
           <a:p>
             <a:pPr>
               <a:lnSpc>
-                <a:spcPct val="115000"/>
+                <a:spcPct val="112000"/>
               </a:lnSpc>
               <a:spcAft>
-                <a:spcPts val="700"/>
+                <a:spcPts val="900"/>
               </a:spcAft>
             </a:pPr>
             <a:r>
-              <a:rPr sz="1300" b="0">
-                <a:solidFill>
-                  <a:srgbClr val="333333"/>
-                </a:solidFill>
-                <a:latin typeface="Fira Sans"/>
-              </a:rPr>
-              <a:t>Tukey, J. W. (1977). Exploratory Data Analysis. Addison-Wesley.</a:t>
+              <a:rPr sz="1800" b="1">
+                <a:solidFill>
+                  <a:srgbClr val="E0A437"/>
+                </a:solidFill>
+                <a:latin typeface="Fira Sans"/>
+              </a:rPr>
+              <a:t>▸ </a:t>
+            </a:r>
+            <a:r>
+              <a:rPr sz="1800" b="0">
+                <a:solidFill>
+                  <a:srgbClr val="000000"/>
+                </a:solidFill>
+                <a:latin typeface="Fira Sans"/>
+              </a:rPr>
+              <a:t>El impacto de filas y atípicos se mide con y sin, sobre todos los resúmenes en uso.</a:t>
             </a:r>
           </a:p>
           <a:p>
             <a:pPr>
               <a:lnSpc>
-                <a:spcPct val="115000"/>
+                <a:spcPct val="112000"/>
               </a:lnSpc>
               <a:spcAft>
-                <a:spcPts val="700"/>
+                <a:spcPts val="900"/>
               </a:spcAft>
             </a:pPr>
             <a:r>
-              <a:rPr sz="1300" b="0">
-                <a:solidFill>
-                  <a:srgbClr val="333333"/>
-                </a:solidFill>
-                <a:latin typeface="Fira Sans"/>
-              </a:rPr>
-              <a:t>Seabold, S. y Perktold, J. (2010). statsmodels: Econometric and statistical modeling with Python. Proceedings of the 9th Python in Science Conference.</a:t>
+              <a:rPr sz="1800" b="1">
+                <a:solidFill>
+                  <a:srgbClr val="E0A437"/>
+                </a:solidFill>
+                <a:latin typeface="Fira Sans"/>
+              </a:rPr>
+              <a:t>▸ </a:t>
+            </a:r>
+            <a:r>
+              <a:rPr sz="1800" b="0">
+                <a:solidFill>
+                  <a:srgbClr val="000000"/>
+                </a:solidFill>
+                <a:latin typeface="Fira Sans"/>
+              </a:rPr>
+              <a:t>Cuando la conclusión es sobre la ciudad, se pondera: WLS.</a:t>
             </a:r>
           </a:p>
           <a:p>
             <a:pPr>
               <a:lnSpc>
-                <a:spcPct val="115000"/>
+                <a:spcPct val="112000"/>
               </a:lnSpc>
               <a:spcAft>
-                <a:spcPts val="700"/>
+                <a:spcPts val="900"/>
               </a:spcAft>
             </a:pPr>
             <a:r>
-              <a:rPr sz="1300" b="0">
-                <a:solidFill>
-                  <a:srgbClr val="333333"/>
-                </a:solidFill>
-                <a:latin typeface="Fira Sans"/>
-              </a:rPr>
-              <a:t>VanderPlas, J. (2016). Python Data Science Handbook. O'Reilly. Capítulo 5 (regresión lineal).</a:t>
+              <a:rPr sz="1800" b="1">
+                <a:solidFill>
+                  <a:srgbClr val="E0A437"/>
+                </a:solidFill>
+                <a:latin typeface="Fira Sans"/>
+              </a:rPr>
+              <a:t>▸ </a:t>
+            </a:r>
+            <a:r>
+              <a:rPr sz="1800" b="0">
+                <a:solidFill>
+                  <a:srgbClr val="000000"/>
+                </a:solidFill>
+                <a:latin typeface="Fira Sans"/>
+              </a:rPr>
+              <a:t>Muchos puntos: alpha o hexbin. Colas largas: log.</a:t>
             </a:r>
           </a:p>
           <a:p>
             <a:pPr>
               <a:lnSpc>
-                <a:spcPct val="115000"/>
+                <a:spcPct val="112000"/>
               </a:lnSpc>
               <a:spcAft>
-                <a:spcPts val="700"/>
+                <a:spcPts val="900"/>
               </a:spcAft>
             </a:pPr>
             <a:r>
-              <a:rPr sz="1300" b="0">
-                <a:solidFill>
-                  <a:srgbClr val="333333"/>
-                </a:solidFill>
-                <a:latin typeface="Fira Sans"/>
-              </a:rPr>
-              <a:t>Datos: Encuesta Origen Destino Santiago 2012 (Sectra).</a:t>
+              <a:rPr sz="1800" b="1">
+                <a:solidFill>
+                  <a:srgbClr val="E0A437"/>
+                </a:solidFill>
+                <a:latin typeface="Fira Sans"/>
+              </a:rPr>
+              <a:t>▸ </a:t>
+            </a:r>
+            <a:r>
+              <a:rPr sz="1800" b="0">
+                <a:solidFill>
+                  <a:srgbClr val="000000"/>
+                </a:solidFill>
+                <a:latin typeface="Fira Sans"/>
+              </a:rPr>
+              <a:t>La múltiple aísla el efecto de cada variable (categóricas como dummies); R² dice cuánto explica y el valor p si un coeficiente se distingue del azar.</a:t>
+            </a:r>
+          </a:p>
+          <a:p>
+            <a:pPr>
+              <a:lnSpc>
+                <a:spcPct val="112000"/>
+              </a:lnSpc>
+              <a:spcAft>
+                <a:spcPts val="900"/>
+              </a:spcAft>
+            </a:pPr>
+            <a:r>
+              <a:rPr sz="1800" b="1">
+                <a:solidFill>
+                  <a:srgbClr val="E0A437"/>
+                </a:solidFill>
+                <a:latin typeface="Fira Sans"/>
+              </a:rPr>
+              <a:t>▸ </a:t>
+            </a:r>
+            <a:r>
+              <a:rPr sz="1800" b="1">
+                <a:solidFill>
+                  <a:srgbClr val="1D3557"/>
+                </a:solidFill>
+                <a:latin typeface="Fira Sans"/>
+              </a:rPr>
+              <a:t>El primer EDA del proyecto usa exactamente estas herramientas (entrega: lunes 15).</a:t>
+            </a:r>
+          </a:p>
+        </p:txBody>
+      </p:sp>
+    </p:spTree>
+  </p:cSld>
+  <p:clrMapOvr>
+    <a:masterClrMapping/>
+  </p:clrMapOvr>
+</p:sld>
+</file>
+
+<file path=ppt/slides/slide37.xml><?xml version="1.0" encoding="utf-8"?>
+<p:sld xmlns:a="http://schemas.openxmlformats.org/drawingml/2006/main" xmlns:p="http://schemas.openxmlformats.org/presentationml/2006/main" xmlns:r="http://schemas.openxmlformats.org/officeDocument/2006/relationships">
+  <p:cSld>
+    <p:spTree>
+      <p:nvGrpSpPr>
+        <p:cNvPr id="1" name=""/>
+        <p:cNvGrpSpPr/>
+        <p:nvPr/>
+      </p:nvGrpSpPr>
+      <p:grpSpPr/>
+      <p:sp>
+        <p:nvSpPr>
+          <p:cNvPr id="2" name="Rectangle 1"/>
+          <p:cNvSpPr/>
+          <p:nvPr/>
+        </p:nvSpPr>
+        <p:spPr>
+          <a:xfrm>
+            <a:off x="0" y="0"/>
+            <a:ext cx="9144000" cy="5138928"/>
+          </a:xfrm>
+          <a:prstGeom prst="rect">
+            <a:avLst/>
+          </a:prstGeom>
+          <a:solidFill>
+            <a:srgbClr val="1D3557"/>
+          </a:solidFill>
+          <a:ln>
+            <a:noFill/>
+          </a:ln>
+          <a:effectLst/>
+        </p:spPr>
+        <p:style>
+          <a:lnRef idx="1">
+            <a:schemeClr val="accent1"/>
+          </a:lnRef>
+          <a:fillRef idx="3">
+            <a:schemeClr val="accent1"/>
+          </a:fillRef>
+          <a:effectRef idx="2">
+            <a:schemeClr val="accent1"/>
+          </a:effectRef>
+          <a:fontRef idx="minor">
+            <a:schemeClr val="lt1"/>
+          </a:fontRef>
+        </p:style>
+        <p:txBody>
+          <a:bodyPr rtlCol="0" anchor="ctr"/>
+          <a:lstStyle/>
+          <a:p>
+            <a:pPr algn="ctr"/>
+          </a:p>
+        </p:txBody>
+      </p:sp>
+      <p:sp>
+        <p:nvSpPr>
+          <p:cNvPr id="3" name="TextBox 2"/>
+          <p:cNvSpPr txBox="1"/>
+          <p:nvPr/>
+        </p:nvSpPr>
+        <p:spPr>
+          <a:xfrm>
+            <a:off x="603504" y="1847088"/>
+            <a:ext cx="7946136" cy="1399032"/>
+          </a:xfrm>
+          <a:prstGeom prst="rect">
+            <a:avLst/>
+          </a:prstGeom>
+          <a:noFill/>
+        </p:spPr>
+        <p:txBody>
+          <a:bodyPr wrap="square">
+            <a:spAutoFit/>
+          </a:bodyPr>
+          <a:lstStyle/>
+          <a:p>
+            <a:r>
+              <a:rPr sz="3400" b="1">
+                <a:solidFill>
+                  <a:srgbClr val="FFFFFF"/>
+                </a:solidFill>
+                <a:latin typeface="Fira Sans"/>
+              </a:rPr>
+              <a:t>Recreo</a:t>
+            </a:r>
+          </a:p>
+          <a:p>
+            <a:r>
+              <a:rPr sz="1800" b="0">
+                <a:solidFill>
+                  <a:srgbClr val="E0A437"/>
+                </a:solidFill>
+                <a:latin typeface="Fira Sans"/>
+              </a:rPr>
+              <a:t>10 minutos · al volver: las presentaciones de ideas</a:t>
+            </a:r>
+          </a:p>
+        </p:txBody>
+      </p:sp>
+    </p:spTree>
+  </p:cSld>
+  <p:clrMapOvr>
+    <a:masterClrMapping/>
+  </p:clrMapOvr>
+</p:sld>
+</file>
+
+<file path=ppt/slides/slide38.xml><?xml version="1.0" encoding="utf-8"?>
+<p:sld xmlns:a="http://schemas.openxmlformats.org/drawingml/2006/main" xmlns:p="http://schemas.openxmlformats.org/presentationml/2006/main" xmlns:r="http://schemas.openxmlformats.org/officeDocument/2006/relationships">
+  <p:cSld>
+    <p:spTree>
+      <p:nvGrpSpPr>
+        <p:cNvPr id="1" name=""/>
+        <p:cNvGrpSpPr/>
+        <p:nvPr/>
+      </p:nvGrpSpPr>
+      <p:grpSpPr/>
+      <p:sp>
+        <p:nvSpPr>
+          <p:cNvPr id="2" name="Rectangle 1"/>
+          <p:cNvSpPr/>
+          <p:nvPr/>
+        </p:nvSpPr>
+        <p:spPr>
+          <a:xfrm>
+            <a:off x="0" y="0"/>
+            <a:ext cx="9144000" cy="5138928"/>
+          </a:xfrm>
+          <a:prstGeom prst="rect">
+            <a:avLst/>
+          </a:prstGeom>
+          <a:solidFill>
+            <a:srgbClr val="1D3557"/>
+          </a:solidFill>
+          <a:ln>
+            <a:noFill/>
+          </a:ln>
+          <a:effectLst/>
+        </p:spPr>
+        <p:style>
+          <a:lnRef idx="1">
+            <a:schemeClr val="accent1"/>
+          </a:lnRef>
+          <a:fillRef idx="3">
+            <a:schemeClr val="accent1"/>
+          </a:fillRef>
+          <a:effectRef idx="2">
+            <a:schemeClr val="accent1"/>
+          </a:effectRef>
+          <a:fontRef idx="minor">
+            <a:schemeClr val="lt1"/>
+          </a:fontRef>
+        </p:style>
+        <p:txBody>
+          <a:bodyPr rtlCol="0" anchor="ctr"/>
+          <a:lstStyle/>
+          <a:p>
+            <a:pPr algn="ctr"/>
+          </a:p>
+        </p:txBody>
+      </p:sp>
+      <p:sp>
+        <p:nvSpPr>
+          <p:cNvPr id="3" name="TextBox 2"/>
+          <p:cNvSpPr txBox="1"/>
+          <p:nvPr/>
+        </p:nvSpPr>
+        <p:spPr>
+          <a:xfrm>
+            <a:off x="603504" y="1847088"/>
+            <a:ext cx="7946136" cy="1399032"/>
+          </a:xfrm>
+          <a:prstGeom prst="rect">
+            <a:avLst/>
+          </a:prstGeom>
+          <a:noFill/>
+        </p:spPr>
+        <p:txBody>
+          <a:bodyPr wrap="square">
+            <a:spAutoFit/>
+          </a:bodyPr>
+          <a:lstStyle/>
+          <a:p>
+            <a:r>
+              <a:rPr sz="3400" b="1">
+                <a:solidFill>
+                  <a:srgbClr val="FFFFFF"/>
+                </a:solidFill>
+                <a:latin typeface="Fira Sans"/>
+              </a:rPr>
+              <a:t>Presentaciones de ideas</a:t>
+            </a:r>
+          </a:p>
+          <a:p>
+            <a:r>
+              <a:rPr sz="1800" b="0">
+                <a:solidFill>
+                  <a:srgbClr val="E0A437"/>
+                </a:solidFill>
+                <a:latin typeface="Fira Sans"/>
+              </a:rPr>
+              <a:t>De 5 a 7 minutos por equipo, y preguntas de todos</a:t>
+            </a:r>
+          </a:p>
+        </p:txBody>
+      </p:sp>
+    </p:spTree>
+  </p:cSld>
+  <p:clrMapOvr>
+    <a:masterClrMapping/>
+  </p:clrMapOvr>
+</p:sld>
+</file>
+
+<file path=ppt/slides/slide39.xml><?xml version="1.0" encoding="utf-8"?>
+<p:sld xmlns:a="http://schemas.openxmlformats.org/drawingml/2006/main" xmlns:p="http://schemas.openxmlformats.org/presentationml/2006/main" xmlns:r="http://schemas.openxmlformats.org/officeDocument/2006/relationships">
+  <p:cSld>
+    <p:spTree>
+      <p:nvGrpSpPr>
+        <p:cNvPr id="1" name=""/>
+        <p:cNvGrpSpPr/>
+        <p:nvPr/>
+      </p:nvGrpSpPr>
+      <p:grpSpPr/>
+      <p:sp>
+        <p:nvSpPr>
+          <p:cNvPr id="2" name="Rectangle 1"/>
+          <p:cNvSpPr/>
+          <p:nvPr/>
+        </p:nvSpPr>
+        <p:spPr>
+          <a:xfrm>
+            <a:off x="0" y="0"/>
+            <a:ext cx="9144000" cy="5138928"/>
+          </a:xfrm>
+          <a:prstGeom prst="rect">
+            <a:avLst/>
+          </a:prstGeom>
+          <a:solidFill>
+            <a:srgbClr val="FAFBFC"/>
+          </a:solidFill>
+          <a:ln>
+            <a:noFill/>
+          </a:ln>
+          <a:effectLst/>
+        </p:spPr>
+        <p:style>
+          <a:lnRef idx="1">
+            <a:schemeClr val="accent1"/>
+          </a:lnRef>
+          <a:fillRef idx="3">
+            <a:schemeClr val="accent1"/>
+          </a:fillRef>
+          <a:effectRef idx="2">
+            <a:schemeClr val="accent1"/>
+          </a:effectRef>
+          <a:fontRef idx="minor">
+            <a:schemeClr val="lt1"/>
+          </a:fontRef>
+        </p:style>
+        <p:txBody>
+          <a:bodyPr rtlCol="0" anchor="ctr"/>
+          <a:lstStyle/>
+          <a:p>
+            <a:pPr algn="ctr"/>
+          </a:p>
+        </p:txBody>
+      </p:sp>
+      <p:sp>
+        <p:nvSpPr>
+          <p:cNvPr id="3" name="TextBox 2"/>
+          <p:cNvSpPr txBox="1"/>
+          <p:nvPr/>
+        </p:nvSpPr>
+        <p:spPr>
+          <a:xfrm>
+            <a:off x="402336" y="301752"/>
+            <a:ext cx="8348472" cy="795528"/>
+          </a:xfrm>
+          <a:prstGeom prst="rect">
+            <a:avLst/>
+          </a:prstGeom>
+          <a:noFill/>
+        </p:spPr>
+        <p:txBody>
+          <a:bodyPr wrap="square">
+            <a:spAutoFit/>
+          </a:bodyPr>
+          <a:lstStyle/>
+          <a:p>
+            <a:r>
+              <a:rPr sz="2800" b="1">
+                <a:solidFill>
+                  <a:srgbClr val="0F0F0F"/>
+                </a:solidFill>
+                <a:latin typeface="Fira Sans"/>
+              </a:rPr>
+              <a:t>El formato</a:t>
+            </a:r>
+          </a:p>
+        </p:txBody>
+      </p:sp>
+      <p:sp>
+        <p:nvSpPr>
+          <p:cNvPr id="4" name="TextBox 3"/>
+          <p:cNvSpPr txBox="1"/>
+          <p:nvPr/>
+        </p:nvSpPr>
+        <p:spPr>
+          <a:xfrm>
+            <a:off x="704088" y="1353312"/>
+            <a:ext cx="7744968" cy="3300984"/>
+          </a:xfrm>
+          <a:prstGeom prst="rect">
+            <a:avLst/>
+          </a:prstGeom>
+          <a:noFill/>
+        </p:spPr>
+        <p:txBody>
+          <a:bodyPr wrap="square">
+            <a:spAutoFit/>
+          </a:bodyPr>
+          <a:lstStyle/>
+          <a:p>
+            <a:pPr>
+              <a:lnSpc>
+                <a:spcPct val="112000"/>
+              </a:lnSpc>
+              <a:spcAft>
+                <a:spcPts val="900"/>
+              </a:spcAft>
+            </a:pPr>
+            <a:r>
+              <a:rPr sz="1800" b="1">
+                <a:solidFill>
+                  <a:srgbClr val="E0A437"/>
+                </a:solidFill>
+                <a:latin typeface="Fira Sans"/>
+              </a:rPr>
+              <a:t>▸ </a:t>
+            </a:r>
+            <a:r>
+              <a:rPr sz="1800" b="1">
+                <a:solidFill>
+                  <a:srgbClr val="1D3557"/>
+                </a:solidFill>
+                <a:latin typeface="Fira Sans"/>
+              </a:rPr>
+              <a:t>Esta instancia no lleva nota: es para recibir retroalimentación temprano, cuando corregir cuesta poco.</a:t>
+            </a:r>
+          </a:p>
+          <a:p>
+            <a:pPr>
+              <a:lnSpc>
+                <a:spcPct val="112000"/>
+              </a:lnSpc>
+              <a:spcAft>
+                <a:spcPts val="900"/>
+              </a:spcAft>
+            </a:pPr>
+            <a:r>
+              <a:rPr sz="1800" b="1">
+                <a:solidFill>
+                  <a:srgbClr val="E0A437"/>
+                </a:solidFill>
+                <a:latin typeface="Fira Sans"/>
+              </a:rPr>
+              <a:t>▸ </a:t>
+            </a:r>
+            <a:r>
+              <a:rPr sz="1800" b="0">
+                <a:solidFill>
+                  <a:srgbClr val="000000"/>
+                </a:solidFill>
+                <a:latin typeface="Fira Sans"/>
+              </a:rPr>
+              <a:t>Después de cada equipo, preguntas y comentarios del curso.</a:t>
             </a:r>
           </a:p>
         </p:txBody>
@@ -8389,6 +8796,404 @@
                 <a:latin typeface="Fira Sans"/>
               </a:rPr>
               <a:t>El modelo inicial (clase 3): explicar la duración media del viaje por comuna con el ingreso medio del hogar, 45 comunas ponderadas. Recta: 38,3 − 4,8 · ingreso</a:t>
+            </a:r>
+          </a:p>
+        </p:txBody>
+      </p:sp>
+    </p:spTree>
+  </p:cSld>
+  <p:clrMapOvr>
+    <a:masterClrMapping/>
+  </p:clrMapOvr>
+</p:sld>
+</file>
+
+<file path=ppt/slides/slide40.xml><?xml version="1.0" encoding="utf-8"?>
+<p:sld xmlns:a="http://schemas.openxmlformats.org/drawingml/2006/main" xmlns:p="http://schemas.openxmlformats.org/presentationml/2006/main" xmlns:r="http://schemas.openxmlformats.org/officeDocument/2006/relationships">
+  <p:cSld>
+    <p:spTree>
+      <p:nvGrpSpPr>
+        <p:cNvPr id="1" name=""/>
+        <p:cNvGrpSpPr/>
+        <p:nvPr/>
+      </p:nvGrpSpPr>
+      <p:grpSpPr/>
+      <p:sp>
+        <p:nvSpPr>
+          <p:cNvPr id="2" name="Rectangle 1"/>
+          <p:cNvSpPr/>
+          <p:nvPr/>
+        </p:nvSpPr>
+        <p:spPr>
+          <a:xfrm>
+            <a:off x="0" y="0"/>
+            <a:ext cx="9144000" cy="5138928"/>
+          </a:xfrm>
+          <a:prstGeom prst="rect">
+            <a:avLst/>
+          </a:prstGeom>
+          <a:solidFill>
+            <a:srgbClr val="FAFBFC"/>
+          </a:solidFill>
+          <a:ln>
+            <a:noFill/>
+          </a:ln>
+          <a:effectLst/>
+        </p:spPr>
+        <p:style>
+          <a:lnRef idx="1">
+            <a:schemeClr val="accent1"/>
+          </a:lnRef>
+          <a:fillRef idx="3">
+            <a:schemeClr val="accent1"/>
+          </a:fillRef>
+          <a:effectRef idx="2">
+            <a:schemeClr val="accent1"/>
+          </a:effectRef>
+          <a:fontRef idx="minor">
+            <a:schemeClr val="lt1"/>
+          </a:fontRef>
+        </p:style>
+        <p:txBody>
+          <a:bodyPr rtlCol="0" anchor="ctr"/>
+          <a:lstStyle/>
+          <a:p>
+            <a:pPr algn="ctr"/>
+          </a:p>
+        </p:txBody>
+      </p:sp>
+      <p:sp>
+        <p:nvSpPr>
+          <p:cNvPr id="3" name="TextBox 2"/>
+          <p:cNvSpPr txBox="1"/>
+          <p:nvPr/>
+        </p:nvSpPr>
+        <p:spPr>
+          <a:xfrm>
+            <a:off x="402336" y="301752"/>
+            <a:ext cx="8348472" cy="795528"/>
+          </a:xfrm>
+          <a:prstGeom prst="rect">
+            <a:avLst/>
+          </a:prstGeom>
+          <a:noFill/>
+        </p:spPr>
+        <p:txBody>
+          <a:bodyPr wrap="square">
+            <a:spAutoFit/>
+          </a:bodyPr>
+          <a:lstStyle/>
+          <a:p>
+            <a:r>
+              <a:rPr sz="2800" b="1">
+                <a:solidFill>
+                  <a:srgbClr val="0F0F0F"/>
+                </a:solidFill>
+                <a:latin typeface="Fira Sans"/>
+              </a:rPr>
+              <a:t>Próxima clase</a:t>
+            </a:r>
+          </a:p>
+        </p:txBody>
+      </p:sp>
+      <p:sp>
+        <p:nvSpPr>
+          <p:cNvPr id="4" name="TextBox 3"/>
+          <p:cNvSpPr txBox="1"/>
+          <p:nvPr/>
+        </p:nvSpPr>
+        <p:spPr>
+          <a:xfrm>
+            <a:off x="704088" y="1353312"/>
+            <a:ext cx="7744968" cy="3300984"/>
+          </a:xfrm>
+          <a:prstGeom prst="rect">
+            <a:avLst/>
+          </a:prstGeom>
+          <a:noFill/>
+        </p:spPr>
+        <p:txBody>
+          <a:bodyPr wrap="square">
+            <a:spAutoFit/>
+          </a:bodyPr>
+          <a:lstStyle/>
+          <a:p>
+            <a:pPr>
+              <a:lnSpc>
+                <a:spcPct val="112000"/>
+              </a:lnSpc>
+              <a:spcAft>
+                <a:spcPts val="900"/>
+              </a:spcAft>
+            </a:pPr>
+            <a:r>
+              <a:rPr sz="1800" b="1">
+                <a:solidFill>
+                  <a:srgbClr val="E0A437"/>
+                </a:solidFill>
+                <a:latin typeface="Fira Sans"/>
+              </a:rPr>
+              <a:t>▸ </a:t>
+            </a:r>
+            <a:r>
+              <a:rPr sz="1800" b="0">
+                <a:solidFill>
+                  <a:srgbClr val="000000"/>
+                </a:solidFill>
+                <a:latin typeface="Fira Sans"/>
+              </a:rPr>
+              <a:t>Martes 8: fundamentos de probabilidad y nociones de inferencia estadística.</a:t>
+            </a:r>
+          </a:p>
+          <a:p>
+            <a:pPr>
+              <a:lnSpc>
+                <a:spcPct val="112000"/>
+              </a:lnSpc>
+              <a:spcAft>
+                <a:spcPts val="900"/>
+              </a:spcAft>
+            </a:pPr>
+            <a:r>
+              <a:rPr sz="1800" b="1">
+                <a:solidFill>
+                  <a:srgbClr val="E0A437"/>
+                </a:solidFill>
+                <a:latin typeface="Fira Sans"/>
+              </a:rPr>
+              <a:t>▸ </a:t>
+            </a:r>
+            <a:r>
+              <a:rPr sz="1800" b="0">
+                <a:solidFill>
+                  <a:srgbClr val="000000"/>
+                </a:solidFill>
+                <a:latin typeface="Fira Sans"/>
+              </a:rPr>
+              <a:t>La pregunta pendiente desde la clase 3: ¿qué significa el valor p que statsmodels ya nos mostró?</a:t>
+            </a:r>
+          </a:p>
+          <a:p>
+            <a:pPr>
+              <a:lnSpc>
+                <a:spcPct val="112000"/>
+              </a:lnSpc>
+              <a:spcAft>
+                <a:spcPts val="900"/>
+              </a:spcAft>
+            </a:pPr>
+            <a:r>
+              <a:rPr sz="1800" b="1">
+                <a:solidFill>
+                  <a:srgbClr val="E0A437"/>
+                </a:solidFill>
+                <a:latin typeface="Fira Sans"/>
+              </a:rPr>
+              <a:t>▸ </a:t>
+            </a:r>
+            <a:r>
+              <a:rPr sz="1800" b="1">
+                <a:solidFill>
+                  <a:srgbClr val="1D3557"/>
+                </a:solidFill>
+                <a:latin typeface="Fira Sans"/>
+              </a:rPr>
+              <a:t>La formulación se entrega el lunes 7; el primer análisis exploratorio, el lunes 15.</a:t>
+            </a:r>
+          </a:p>
+        </p:txBody>
+      </p:sp>
+    </p:spTree>
+  </p:cSld>
+  <p:clrMapOvr>
+    <a:masterClrMapping/>
+  </p:clrMapOvr>
+</p:sld>
+</file>
+
+<file path=ppt/slides/slide41.xml><?xml version="1.0" encoding="utf-8"?>
+<p:sld xmlns:a="http://schemas.openxmlformats.org/drawingml/2006/main" xmlns:p="http://schemas.openxmlformats.org/presentationml/2006/main" xmlns:r="http://schemas.openxmlformats.org/officeDocument/2006/relationships">
+  <p:cSld>
+    <p:spTree>
+      <p:nvGrpSpPr>
+        <p:cNvPr id="1" name=""/>
+        <p:cNvGrpSpPr/>
+        <p:nvPr/>
+      </p:nvGrpSpPr>
+      <p:grpSpPr/>
+      <p:sp>
+        <p:nvSpPr>
+          <p:cNvPr id="2" name="Rectangle 1"/>
+          <p:cNvSpPr/>
+          <p:nvPr/>
+        </p:nvSpPr>
+        <p:spPr>
+          <a:xfrm>
+            <a:off x="0" y="0"/>
+            <a:ext cx="9144000" cy="5138928"/>
+          </a:xfrm>
+          <a:prstGeom prst="rect">
+            <a:avLst/>
+          </a:prstGeom>
+          <a:solidFill>
+            <a:srgbClr val="FAFBFC"/>
+          </a:solidFill>
+          <a:ln>
+            <a:noFill/>
+          </a:ln>
+          <a:effectLst/>
+        </p:spPr>
+        <p:style>
+          <a:lnRef idx="1">
+            <a:schemeClr val="accent1"/>
+          </a:lnRef>
+          <a:fillRef idx="3">
+            <a:schemeClr val="accent1"/>
+          </a:fillRef>
+          <a:effectRef idx="2">
+            <a:schemeClr val="accent1"/>
+          </a:effectRef>
+          <a:fontRef idx="minor">
+            <a:schemeClr val="lt1"/>
+          </a:fontRef>
+        </p:style>
+        <p:txBody>
+          <a:bodyPr rtlCol="0" anchor="ctr"/>
+          <a:lstStyle/>
+          <a:p>
+            <a:pPr algn="ctr"/>
+          </a:p>
+        </p:txBody>
+      </p:sp>
+      <p:sp>
+        <p:nvSpPr>
+          <p:cNvPr id="3" name="TextBox 2"/>
+          <p:cNvSpPr txBox="1"/>
+          <p:nvPr/>
+        </p:nvSpPr>
+        <p:spPr>
+          <a:xfrm>
+            <a:off x="402336" y="301752"/>
+            <a:ext cx="8348472" cy="795528"/>
+          </a:xfrm>
+          <a:prstGeom prst="rect">
+            <a:avLst/>
+          </a:prstGeom>
+          <a:noFill/>
+        </p:spPr>
+        <p:txBody>
+          <a:bodyPr wrap="square">
+            <a:spAutoFit/>
+          </a:bodyPr>
+          <a:lstStyle/>
+          <a:p>
+            <a:r>
+              <a:rPr sz="2800" b="1">
+                <a:solidFill>
+                  <a:srgbClr val="0F0F0F"/>
+                </a:solidFill>
+                <a:latin typeface="Fira Sans"/>
+              </a:rPr>
+              <a:t>Referencias</a:t>
+            </a:r>
+          </a:p>
+        </p:txBody>
+      </p:sp>
+      <p:sp>
+        <p:nvSpPr>
+          <p:cNvPr id="4" name="TextBox 3"/>
+          <p:cNvSpPr txBox="1"/>
+          <p:nvPr/>
+        </p:nvSpPr>
+        <p:spPr>
+          <a:xfrm>
+            <a:off x="704088" y="1234440"/>
+            <a:ext cx="7744968" cy="3566160"/>
+          </a:xfrm>
+          <a:prstGeom prst="rect">
+            <a:avLst/>
+          </a:prstGeom>
+          <a:noFill/>
+        </p:spPr>
+        <p:txBody>
+          <a:bodyPr wrap="square">
+            <a:spAutoFit/>
+          </a:bodyPr>
+          <a:lstStyle/>
+          <a:p>
+            <a:pPr>
+              <a:lnSpc>
+                <a:spcPct val="115000"/>
+              </a:lnSpc>
+              <a:spcAft>
+                <a:spcPts val="700"/>
+              </a:spcAft>
+            </a:pPr>
+            <a:r>
+              <a:rPr sz="1300" b="0">
+                <a:solidFill>
+                  <a:srgbClr val="333333"/>
+                </a:solidFill>
+                <a:latin typeface="Fira Sans"/>
+              </a:rPr>
+              <a:t>Tukey, J. W. (1977). Exploratory Data Analysis. Addison-Wesley.</a:t>
+            </a:r>
+          </a:p>
+          <a:p>
+            <a:pPr>
+              <a:lnSpc>
+                <a:spcPct val="115000"/>
+              </a:lnSpc>
+              <a:spcAft>
+                <a:spcPts val="700"/>
+              </a:spcAft>
+            </a:pPr>
+            <a:r>
+              <a:rPr sz="1300" b="0">
+                <a:solidFill>
+                  <a:srgbClr val="333333"/>
+                </a:solidFill>
+                <a:latin typeface="Fira Sans"/>
+              </a:rPr>
+              <a:t>Seabold, S. y Perktold, J. (2010). statsmodels: Econometric and statistical modeling with Python. Proceedings of the 9th Python in Science Conference.</a:t>
+            </a:r>
+          </a:p>
+          <a:p>
+            <a:pPr>
+              <a:lnSpc>
+                <a:spcPct val="115000"/>
+              </a:lnSpc>
+              <a:spcAft>
+                <a:spcPts val="700"/>
+              </a:spcAft>
+            </a:pPr>
+            <a:r>
+              <a:rPr sz="1300" b="0">
+                <a:solidFill>
+                  <a:srgbClr val="333333"/>
+                </a:solidFill>
+                <a:latin typeface="Fira Sans"/>
+              </a:rPr>
+              <a:t>VanderPlas, J. (2016). Python Data Science Handbook. O'Reilly. Capítulo 5 (regresión lineal).</a:t>
+            </a:r>
+          </a:p>
+          <a:p>
+            <a:pPr>
+              <a:lnSpc>
+                <a:spcPct val="115000"/>
+              </a:lnSpc>
+              <a:spcAft>
+                <a:spcPts val="700"/>
+              </a:spcAft>
+            </a:pPr>
+            <a:r>
+              <a:rPr sz="1300" b="0">
+                <a:solidFill>
+                  <a:srgbClr val="333333"/>
+                </a:solidFill>
+                <a:latin typeface="Fira Sans"/>
+              </a:rPr>
+              <a:t>Datos: Encuesta Origen Destino Santiago 2012 (Sectra).</a:t>
             </a:r>
           </a:p>
         </p:txBody>

</xml_diff>

<commit_message>
Deck clase 4: visualizacion al principio y despues solo modelos, con la duracion contigua
Co-Authored-By: Claude Fable 5 <noreply@anthropic.com>
</commit_message>
<xml_diff>
--- a/presentaciones/clase04_regresion_multiple.pptx
+++ b/presentaciones/clase04_regresion_multiple.pptx
@@ -3405,7 +3405,7 @@
             <a:avLst/>
           </a:prstGeom>
           <a:solidFill>
-            <a:srgbClr val="FAFBFC"/>
+            <a:srgbClr val="1D3557"/>
           </a:solidFill>
           <a:ln>
             <a:noFill/>
@@ -3442,8 +3442,8 @@
         </p:nvSpPr>
         <p:spPr>
           <a:xfrm>
-            <a:off x="402336" y="301752"/>
-            <a:ext cx="8348472" cy="795528"/>
+            <a:off x="603504" y="1847088"/>
+            <a:ext cx="7946136" cy="1399032"/>
           </a:xfrm>
           <a:prstGeom prst="rect">
             <a:avLst/>
@@ -3457,71 +3457,24 @@
           <a:lstStyle/>
           <a:p>
             <a:r>
-              <a:rPr sz="2800" b="1">
-                <a:solidFill>
-                  <a:srgbClr val="0F0F0F"/>
-                </a:solidFill>
-                <a:latin typeface="Fira Sans"/>
-              </a:rPr>
-              <a:t>Los atípicos de la variable a predecir</a:t>
-            </a:r>
-          </a:p>
-        </p:txBody>
-      </p:sp>
-      <p:pic>
-        <p:nvPicPr>
-          <p:cNvPr id="4" name="Picture 3" descr="c3_27_boxplot_numveh.png"/>
-          <p:cNvPicPr>
-            <a:picLocks noChangeAspect="1"/>
-          </p:cNvPicPr>
-          <p:nvPr/>
-        </p:nvPicPr>
-        <p:blipFill>
-          <a:blip r:embed="rId2"/>
-          <a:stretch>
-            <a:fillRect/>
-          </a:stretch>
-        </p:blipFill>
-        <p:spPr>
-          <a:xfrm>
-            <a:off x="699515" y="1492260"/>
-            <a:ext cx="7744968" cy="2456159"/>
-          </a:xfrm>
-          <a:prstGeom prst="rect">
-            <a:avLst/>
-          </a:prstGeom>
-        </p:spPr>
-      </p:pic>
-      <p:sp>
-        <p:nvSpPr>
-          <p:cNvPr id="5" name="TextBox 4"/>
-          <p:cNvSpPr txBox="1"/>
-          <p:nvPr/>
-        </p:nvSpPr>
-        <p:spPr>
-          <a:xfrm>
-            <a:off x="704088" y="4434840"/>
-            <a:ext cx="7744968" cy="457200"/>
-          </a:xfrm>
-          <a:prstGeom prst="rect">
-            <a:avLst/>
-          </a:prstGeom>
-          <a:noFill/>
-        </p:spPr>
-        <p:txBody>
-          <a:bodyPr wrap="square">
-            <a:spAutoFit/>
-          </a:bodyPr>
-          <a:lstStyle/>
-          <a:p>
-            <a:r>
-              <a:rPr sz="1300" b="0">
-                <a:solidFill>
-                  <a:srgbClr val="333333"/>
-                </a:solidFill>
-                <a:latin typeface="Fira Sans"/>
-              </a:rPr>
-              <a:t>El boxplot de NumVeh (clase 2): la cerca de Tukey queda en 2,5, y los hogares de 3 autos o más son atípicos. La siguiente diapo mide qué pasa al sacarlos.</a:t>
+              <a:rPr sz="3400" b="1">
+                <a:solidFill>
+                  <a:srgbClr val="FFFFFF"/>
+                </a:solidFill>
+                <a:latin typeface="Fira Sans"/>
+              </a:rPr>
+              <a:t>¿Las comunas de mayor ingreso viajan menos tiempo?</a:t>
+            </a:r>
+          </a:p>
+          <a:p>
+            <a:r>
+              <a:rPr sz="1800" b="0">
+                <a:solidFill>
+                  <a:srgbClr val="E0A437"/>
+                </a:solidFill>
+                <a:latin typeface="Fira Sans"/>
+              </a:rPr>
+              <a:t>El modelo inicial (clase 3): explicar la duración media del viaje por comuna con el ingreso medio del hogar, 45 comunas ponderadas. Recta: 38,3 − 4,8 · ingreso</a:t>
             </a:r>
           </a:p>
         </p:txBody>
@@ -3617,114 +3570,35 @@
                 </a:solidFill>
                 <a:latin typeface="Fira Sans"/>
               </a:rPr>
-              <a:t>Sacar atípicos de la variable a predecir</a:t>
-            </a:r>
-          </a:p>
-        </p:txBody>
-      </p:sp>
-      <p:sp>
-        <p:nvSpPr>
-          <p:cNvPr id="4" name="Rectangle 3"/>
-          <p:cNvSpPr/>
-          <p:nvPr/>
-        </p:nvSpPr>
-        <p:spPr>
-          <a:xfrm>
-            <a:off x="704088" y="1280160"/>
-            <a:ext cx="7744968" cy="2880360"/>
-          </a:xfrm>
-          <a:prstGeom prst="rect">
-            <a:avLst/>
-          </a:prstGeom>
-          <a:solidFill>
-            <a:srgbClr val="F0F2F5"/>
-          </a:solidFill>
-          <a:ln>
-            <a:solidFill>
-              <a:srgbClr val="D8DDE3"/>
-            </a:solidFill>
-          </a:ln>
-          <a:effectLst/>
-        </p:spPr>
-        <p:style>
-          <a:lnRef idx="1">
-            <a:schemeClr val="accent1"/>
-          </a:lnRef>
-          <a:fillRef idx="3">
-            <a:schemeClr val="accent1"/>
-          </a:fillRef>
-          <a:effectRef idx="2">
-            <a:schemeClr val="accent1"/>
-          </a:effectRef>
-          <a:fontRef idx="minor">
-            <a:schemeClr val="lt1"/>
-          </a:fontRef>
-        </p:style>
-        <p:txBody>
-          <a:bodyPr rtlCol="0" anchor="ctr" wrap="square" lIns="228600" tIns="137160"/>
-          <a:lstStyle/>
-          <a:p>
-            <a:pPr/>
-            <a:r>
-              <a:rPr sz="1500" b="0">
-                <a:solidFill>
-                  <a:srgbClr val="1D3557"/>
-                </a:solidFill>
-                <a:latin typeface="Menlo"/>
-              </a:rPr>
-              <a:t>q1, q3 = h["NumVeh"].quantile([0.25, 0.75])</a:t>
-            </a:r>
-          </a:p>
-          <a:p>
-            <a:pPr/>
-            <a:r>
-              <a:rPr sz="1500" b="0">
-                <a:solidFill>
-                  <a:srgbClr val="1D3557"/>
-                </a:solidFill>
-                <a:latin typeface="Menlo"/>
-              </a:rPr>
-              <a:t>sin_atipicos = h[h["NumVeh"] &lt;= q3 + 1.5 * (q3 - q1)]  # = 2.5</a:t>
-            </a:r>
-          </a:p>
-          <a:p>
-            <a:pPr/>
-            <a:r>
-              <a:rPr sz="1500" b="0">
-                <a:solidFill>
-                  <a:srgbClr val="1D3557"/>
-                </a:solidFill>
-                <a:latin typeface="Menlo"/>
-              </a:rPr>
-              <a:t/>
-            </a:r>
-          </a:p>
-          <a:p>
-            <a:pPr/>
-            <a:r>
-              <a:rPr sz="1500" b="0">
-                <a:solidFill>
-                  <a:srgbClr val="1D3557"/>
-                </a:solidFill>
-                <a:latin typeface="Menlo"/>
-              </a:rPr>
-              <a:t># El mismo modelo, sin los hogares de 3 autos o más</a:t>
-            </a:r>
-          </a:p>
-          <a:p>
-            <a:pPr/>
-            <a:r>
-              <a:rPr sz="1500" b="0">
-                <a:solidFill>
-                  <a:srgbClr val="1D3557"/>
-                </a:solidFill>
-                <a:latin typeface="Menlo"/>
-              </a:rPr>
-              <a:t>np.polyfit(sin_atipicos["IngresoHogar"] / 1e6, sin_atipicos["NumVeh"], 1)</a:t>
-            </a:r>
-          </a:p>
-        </p:txBody>
-      </p:sp>
+              <a:t>El impacto de sacar una fila</a:t>
+            </a:r>
+          </a:p>
+        </p:txBody>
+      </p:sp>
+      <p:pic>
+        <p:nvPicPr>
+          <p:cNvPr id="4" name="Picture 3" descr="c4_06_impacto_fila.png"/>
+          <p:cNvPicPr>
+            <a:picLocks noChangeAspect="1"/>
+          </p:cNvPicPr>
+          <p:nvPr/>
+        </p:nvPicPr>
+        <p:blipFill>
+          <a:blip r:embed="rId2"/>
+          <a:stretch>
+            <a:fillRect/>
+          </a:stretch>
+        </p:blipFill>
+        <p:spPr>
+          <a:xfrm>
+            <a:off x="1353768" y="1143000"/>
+            <a:ext cx="6436462" cy="3154680"/>
+          </a:xfrm>
+          <a:prstGeom prst="rect">
+            <a:avLst/>
+          </a:prstGeom>
+        </p:spPr>
+      </p:pic>
       <p:sp>
         <p:nvSpPr>
           <p:cNvPr id="5" name="TextBox 4"/>
@@ -3733,8 +3607,8 @@
         </p:nvSpPr>
         <p:spPr>
           <a:xfrm>
-            <a:off x="704088" y="4389120"/>
-            <a:ext cx="7744968" cy="1097280"/>
+            <a:off x="704088" y="4434840"/>
+            <a:ext cx="7744968" cy="457200"/>
           </a:xfrm>
           <a:prstGeom prst="rect">
             <a:avLst/>
@@ -3747,31 +3621,14 @@
           </a:bodyPr>
           <a:lstStyle/>
           <a:p>
-            <a:pPr>
-              <a:lnSpc>
-                <a:spcPct val="112000"/>
-              </a:lnSpc>
-              <a:spcAft>
-                <a:spcPts val="900"/>
-              </a:spcAft>
-            </a:pPr>
-            <a:r>
-              <a:rPr sz="1600" b="1">
-                <a:solidFill>
-                  <a:srgbClr val="E0A437"/>
-                </a:solidFill>
-                <a:latin typeface="Fira Sans"/>
-              </a:rPr>
-              <a:t>▸ </a:t>
-            </a:r>
-            <a:r>
-              <a:rPr sz="1600" b="0">
-                <a:solidFill>
-                  <a:srgbClr val="000000"/>
-                </a:solidFill>
-                <a:latin typeface="Fira Sans"/>
-              </a:rPr>
-              <a:t>Sin esos 236 hogares la pendiente baja de 0,50 a 0,44: eran la señal, no errores. Los atípicos se investigan y solo se eliminan por una razón del dominio.</a:t>
+            <a:r>
+              <a:rPr sz="1300" b="0">
+                <a:solidFill>
+                  <a:srgbClr val="333333"/>
+                </a:solidFill>
+                <a:latin typeface="Fira Sans"/>
+              </a:rPr>
+              <a:t>Medirlo es recalcular con y sin: r casi no se mueve (−0,34), pero la pendiente cambia en un quinto, de −4,8 a −5,8 minutos por millón. Cada resumen tiene su propia sensibilidad.</a:t>
             </a:r>
           </a:p>
         </p:txBody>
@@ -3809,7 +3666,7 @@
             <a:avLst/>
           </a:prstGeom>
           <a:solidFill>
-            <a:srgbClr val="1D3557"/>
+            <a:srgbClr val="FAFBFC"/>
           </a:solidFill>
           <a:ln>
             <a:noFill/>
@@ -3846,8 +3703,8 @@
         </p:nvSpPr>
         <p:spPr>
           <a:xfrm>
-            <a:off x="603504" y="1847088"/>
-            <a:ext cx="7946136" cy="1399032"/>
+            <a:off x="402336" y="301752"/>
+            <a:ext cx="8348472" cy="795528"/>
           </a:xfrm>
           <a:prstGeom prst="rect">
             <a:avLst/>
@@ -3861,24 +3718,71 @@
           <a:lstStyle/>
           <a:p>
             <a:r>
-              <a:rPr sz="3400" b="1">
-                <a:solidFill>
-                  <a:srgbClr val="FFFFFF"/>
-                </a:solidFill>
-                <a:latin typeface="Fira Sans"/>
-              </a:rPr>
-              <a:t>Visualización</a:t>
-            </a:r>
-          </a:p>
-          <a:p>
-            <a:r>
-              <a:rPr sz="1800" b="0">
-                <a:solidFill>
-                  <a:srgbClr val="E0A437"/>
-                </a:solidFill>
-                <a:latin typeface="Fira Sans"/>
-              </a:rPr>
-              <a:t>Muchos puntos y colas largas</a:t>
+              <a:rPr sz="2800" b="1">
+                <a:solidFill>
+                  <a:srgbClr val="0F0F0F"/>
+                </a:solidFill>
+                <a:latin typeface="Fira Sans"/>
+              </a:rPr>
+              <a:t>Las fórmulas, con factor de expansión</a:t>
+            </a:r>
+          </a:p>
+        </p:txBody>
+      </p:sp>
+      <p:pic>
+        <p:nvPicPr>
+          <p:cNvPr id="4" name="Picture 3" descr="c3_22_formulas_ponderada.png"/>
+          <p:cNvPicPr>
+            <a:picLocks noChangeAspect="1"/>
+          </p:cNvPicPr>
+          <p:nvPr/>
+        </p:nvPicPr>
+        <p:blipFill>
+          <a:blip r:embed="rId2"/>
+          <a:stretch>
+            <a:fillRect/>
+          </a:stretch>
+        </p:blipFill>
+        <p:spPr>
+          <a:xfrm>
+            <a:off x="699515" y="1342115"/>
+            <a:ext cx="7744968" cy="2756450"/>
+          </a:xfrm>
+          <a:prstGeom prst="rect">
+            <a:avLst/>
+          </a:prstGeom>
+        </p:spPr>
+      </p:pic>
+      <p:sp>
+        <p:nvSpPr>
+          <p:cNvPr id="5" name="TextBox 4"/>
+          <p:cNvSpPr txBox="1"/>
+          <p:nvPr/>
+        </p:nvSpPr>
+        <p:spPr>
+          <a:xfrm>
+            <a:off x="704088" y="4434840"/>
+            <a:ext cx="7744968" cy="457200"/>
+          </a:xfrm>
+          <a:prstGeom prst="rect">
+            <a:avLst/>
+          </a:prstGeom>
+          <a:noFill/>
+        </p:spPr>
+        <p:txBody>
+          <a:bodyPr wrap="square">
+            <a:spAutoFit/>
+          </a:bodyPr>
+          <a:lstStyle/>
+          <a:p>
+            <a:r>
+              <a:rPr sz="1300" b="0">
+                <a:solidFill>
+                  <a:srgbClr val="333333"/>
+                </a:solidFill>
+                <a:latin typeface="Fira Sans"/>
+              </a:rPr>
+              <a:t>La misma recta de mínimos cuadrados, con cada término pesado por su factor: es la que usa el modelo que sigue, y en statsmodels se llama WLS (weighted least squares).</a:t>
             </a:r>
           </a:p>
         </p:txBody>
@@ -3916,7 +3820,7 @@
             <a:avLst/>
           </a:prstGeom>
           <a:solidFill>
-            <a:srgbClr val="FAFBFC"/>
+            <a:srgbClr val="1D3557"/>
           </a:solidFill>
           <a:ln>
             <a:noFill/>
@@ -3953,8 +3857,8 @@
         </p:nvSpPr>
         <p:spPr>
           <a:xfrm>
-            <a:off x="402336" y="301752"/>
-            <a:ext cx="8348472" cy="795528"/>
+            <a:off x="603504" y="1847088"/>
+            <a:ext cx="7946136" cy="1399032"/>
           </a:xfrm>
           <a:prstGeom prst="rect">
             <a:avLst/>
@@ -3968,71 +3872,24 @@
           <a:lstStyle/>
           <a:p>
             <a:r>
-              <a:rPr sz="2800" b="1">
-                <a:solidFill>
-                  <a:srgbClr val="0F0F0F"/>
-                </a:solidFill>
-                <a:latin typeface="Fira Sans"/>
-              </a:rPr>
-              <a:t>Graficar 90 mil puntos: overplotting</a:t>
-            </a:r>
-          </a:p>
-        </p:txBody>
-      </p:sp>
-      <p:pic>
-        <p:nvPicPr>
-          <p:cNvPr id="4" name="Picture 3" descr="c3_08_overplotting.png"/>
-          <p:cNvPicPr>
-            <a:picLocks noChangeAspect="1"/>
-          </p:cNvPicPr>
-          <p:nvPr/>
-        </p:nvPicPr>
-        <p:blipFill>
-          <a:blip r:embed="rId2"/>
-          <a:stretch>
-            <a:fillRect/>
-          </a:stretch>
-        </p:blipFill>
-        <p:spPr>
-          <a:xfrm>
-            <a:off x="699515" y="1545618"/>
-            <a:ext cx="7744968" cy="2349444"/>
-          </a:xfrm>
-          <a:prstGeom prst="rect">
-            <a:avLst/>
-          </a:prstGeom>
-        </p:spPr>
-      </p:pic>
-      <p:sp>
-        <p:nvSpPr>
-          <p:cNvPr id="5" name="TextBox 4"/>
-          <p:cNvSpPr txBox="1"/>
-          <p:nvPr/>
-        </p:nvSpPr>
-        <p:spPr>
-          <a:xfrm>
-            <a:off x="704088" y="4434840"/>
-            <a:ext cx="7744968" cy="457200"/>
-          </a:xfrm>
-          <a:prstGeom prst="rect">
-            <a:avLst/>
-          </a:prstGeom>
-          <a:noFill/>
-        </p:spPr>
-        <p:txBody>
-          <a:bodyPr wrap="square">
-            <a:spAutoFit/>
-          </a:bodyPr>
-          <a:lstStyle/>
-          <a:p>
-            <a:r>
-              <a:rPr sz="1300" b="0">
-                <a:solidFill>
-                  <a:srgbClr val="333333"/>
-                </a:solidFill>
-                <a:latin typeface="Fira Sans"/>
-              </a:rPr>
-              <a:t>Con todos los puntos sólidos, el scatter se satura y miente. Los remedios: transparencia (alpha), muestreo, o hexbin, donde el color cuenta los viajes (la distancia viene en la tabla DistanciaViaje.csv; sus −1 son faltantes disfrazados).</a:t>
+              <a:rPr sz="3400" b="1">
+                <a:solidFill>
+                  <a:srgbClr val="FFFFFF"/>
+                </a:solidFill>
+                <a:latin typeface="Fira Sans"/>
+              </a:rPr>
+              <a:t>¿Cuántos vehículos tiene un hogar según su ingreso?</a:t>
+            </a:r>
+          </a:p>
+          <a:p>
+            <a:r>
+              <a:rPr sz="1800" b="0">
+                <a:solidFill>
+                  <a:srgbClr val="E0A437"/>
+                </a:solidFill>
+                <a:latin typeface="Fira Sans"/>
+              </a:rPr>
+              <a:t>Explicar los vehículos del hogar con el ingreso: 18.264 hogares, ponderados por su factor</a:t>
             </a:r>
           </a:p>
         </p:txBody>
@@ -4128,35 +3985,114 @@
                 </a:solidFill>
                 <a:latin typeface="Fira Sans"/>
               </a:rPr>
-              <a:t>Cuándo usar escala logarítmica</a:t>
-            </a:r>
-          </a:p>
-        </p:txBody>
-      </p:sp>
-      <p:pic>
-        <p:nvPicPr>
-          <p:cNvPr id="4" name="Picture 3" descr="c3_10_escala_log.png"/>
-          <p:cNvPicPr>
-            <a:picLocks noChangeAspect="1"/>
-          </p:cNvPicPr>
-          <p:nvPr/>
-        </p:nvPicPr>
-        <p:blipFill>
-          <a:blip r:embed="rId2"/>
-          <a:stretch>
-            <a:fillRect/>
-          </a:stretch>
-        </p:blipFill>
-        <p:spPr>
-          <a:xfrm>
-            <a:off x="699515" y="1227136"/>
-            <a:ext cx="7744968" cy="2986407"/>
-          </a:xfrm>
-          <a:prstGeom prst="rect">
-            <a:avLst/>
-          </a:prstGeom>
-        </p:spPr>
-      </p:pic>
+              <a:t>Otro modelo: la motorización del hogar</a:t>
+            </a:r>
+          </a:p>
+        </p:txBody>
+      </p:sp>
+      <p:sp>
+        <p:nvSpPr>
+          <p:cNvPr id="4" name="Rectangle 3"/>
+          <p:cNvSpPr/>
+          <p:nvPr/>
+        </p:nvSpPr>
+        <p:spPr>
+          <a:xfrm>
+            <a:off x="704088" y="1280160"/>
+            <a:ext cx="7744968" cy="2880360"/>
+          </a:xfrm>
+          <a:prstGeom prst="rect">
+            <a:avLst/>
+          </a:prstGeom>
+          <a:solidFill>
+            <a:srgbClr val="F0F2F5"/>
+          </a:solidFill>
+          <a:ln>
+            <a:solidFill>
+              <a:srgbClr val="D8DDE3"/>
+            </a:solidFill>
+          </a:ln>
+          <a:effectLst/>
+        </p:spPr>
+        <p:style>
+          <a:lnRef idx="1">
+            <a:schemeClr val="accent1"/>
+          </a:lnRef>
+          <a:fillRef idx="3">
+            <a:schemeClr val="accent1"/>
+          </a:fillRef>
+          <a:effectRef idx="2">
+            <a:schemeClr val="accent1"/>
+          </a:effectRef>
+          <a:fontRef idx="minor">
+            <a:schemeClr val="lt1"/>
+          </a:fontRef>
+        </p:style>
+        <p:txBody>
+          <a:bodyPr rtlCol="0" anchor="ctr" wrap="square" lIns="228600" tIns="137160"/>
+          <a:lstStyle/>
+          <a:p>
+            <a:pPr/>
+            <a:r>
+              <a:rPr sz="1500" b="0">
+                <a:solidFill>
+                  <a:srgbClr val="1D3557"/>
+                </a:solidFill>
+                <a:latin typeface="Menlo"/>
+              </a:rPr>
+              <a:t>x = h["IngresoHogar"] / 1e6</a:t>
+            </a:r>
+          </a:p>
+          <a:p>
+            <a:pPr/>
+            <a:r>
+              <a:rPr sz="1500" b="0">
+                <a:solidFill>
+                  <a:srgbClr val="1D3557"/>
+                </a:solidFill>
+                <a:latin typeface="Menlo"/>
+              </a:rPr>
+              <a:t>y, w = h["NumVeh"], h["Factor"]</a:t>
+            </a:r>
+          </a:p>
+          <a:p>
+            <a:pPr/>
+            <a:r>
+              <a:rPr sz="1500" b="0">
+                <a:solidFill>
+                  <a:srgbClr val="1D3557"/>
+                </a:solidFill>
+                <a:latin typeface="Menlo"/>
+              </a:rPr>
+              <a:t/>
+            </a:r>
+          </a:p>
+          <a:p>
+            <a:pPr/>
+            <a:r>
+              <a:rPr sz="1500" b="0">
+                <a:solidFill>
+                  <a:srgbClr val="1D3557"/>
+                </a:solidFill>
+                <a:latin typeface="Menlo"/>
+              </a:rPr>
+              <a:t># La fórmula de la pendiente ponderada, tal cual</a:t>
+            </a:r>
+          </a:p>
+          <a:p>
+            <a:pPr/>
+            <a:r>
+              <a:rPr sz="1500" b="0">
+                <a:solidFill>
+                  <a:srgbClr val="1D3557"/>
+                </a:solidFill>
+                <a:latin typeface="Menlo"/>
+              </a:rPr>
+              <a:t>b = (w*(x - xw)*(y - yw)).sum() / (w*(x - xw)**2).sum()</a:t>
+            </a:r>
+          </a:p>
+        </p:txBody>
+      </p:sp>
       <p:sp>
         <p:nvSpPr>
           <p:cNvPr id="5" name="TextBox 4"/>
@@ -4165,8 +4101,8 @@
         </p:nvSpPr>
         <p:spPr>
           <a:xfrm>
-            <a:off x="704088" y="4434840"/>
-            <a:ext cx="7744968" cy="457200"/>
+            <a:off x="704088" y="4389120"/>
+            <a:ext cx="7744968" cy="1097280"/>
           </a:xfrm>
           <a:prstGeom prst="rect">
             <a:avLst/>
@@ -4179,14 +4115,31 @@
           </a:bodyPr>
           <a:lstStyle/>
           <a:p>
-            <a:r>
-              <a:rPr sz="1300" b="0">
-                <a:solidFill>
-                  <a:srgbClr val="333333"/>
-                </a:solidFill>
-                <a:latin typeface="Fira Sans"/>
-              </a:rPr>
-              <a:t>La misma distancia tiene cola larga: en lineal se aplasta; en log, la forma aparece. Y transformar con log es feature engineering clásico: vuelve lineales las relaciones multiplicativas.</a:t>
+            <a:pPr>
+              <a:lnSpc>
+                <a:spcPct val="112000"/>
+              </a:lnSpc>
+              <a:spcAft>
+                <a:spcPts val="900"/>
+              </a:spcAft>
+            </a:pPr>
+            <a:r>
+              <a:rPr sz="1600" b="1">
+                <a:solidFill>
+                  <a:srgbClr val="E0A437"/>
+                </a:solidFill>
+                <a:latin typeface="Fira Sans"/>
+              </a:rPr>
+              <a:t>▸ </a:t>
+            </a:r>
+            <a:r>
+              <a:rPr sz="1600" b="0">
+                <a:solidFill>
+                  <a:srgbClr val="000000"/>
+                </a:solidFill>
+                <a:latin typeface="Fira Sans"/>
+              </a:rPr>
+              <a:t>18.264 hogares reales, ponderados por su factor: vehículos = 0,20 + 0,50 · ingreso. Medio vehículo más por cada millón.</a:t>
             </a:r>
           </a:p>
         </p:txBody>
@@ -4224,7 +4177,7 @@
             <a:avLst/>
           </a:prstGeom>
           <a:solidFill>
-            <a:srgbClr val="1D3557"/>
+            <a:srgbClr val="FAFBFC"/>
           </a:solidFill>
           <a:ln>
             <a:noFill/>
@@ -4261,8 +4214,8 @@
         </p:nvSpPr>
         <p:spPr>
           <a:xfrm>
-            <a:off x="603504" y="1847088"/>
-            <a:ext cx="7946136" cy="1399032"/>
+            <a:off x="402336" y="301752"/>
+            <a:ext cx="8348472" cy="795528"/>
           </a:xfrm>
           <a:prstGeom prst="rect">
             <a:avLst/>
@@ -4276,24 +4229,71 @@
           <a:lstStyle/>
           <a:p>
             <a:r>
-              <a:rPr sz="3400" b="1">
-                <a:solidFill>
-                  <a:srgbClr val="FFFFFF"/>
-                </a:solidFill>
-                <a:latin typeface="Fira Sans"/>
-              </a:rPr>
-              <a:t>¿De qué depende la duración de un viaje?</a:t>
-            </a:r>
-          </a:p>
-          <a:p>
-            <a:r>
-              <a:rPr sz="1800" b="0">
-                <a:solidFill>
-                  <a:srgbClr val="E0A437"/>
-                </a:solidFill>
-                <a:latin typeface="Fira Sans"/>
-              </a:rPr>
-              <a:t>Lo que ya sabemos (clase 3): correlaciona con la distancia, r = 0,57 y Spearman 0,76. Primera decisión: partir por la distancia, 102 mil viajes de la EOD</a:t>
+              <a:rPr sz="2800" b="1">
+                <a:solidFill>
+                  <a:srgbClr val="0F0F0F"/>
+                </a:solidFill>
+                <a:latin typeface="Fira Sans"/>
+              </a:rPr>
+              <a:t>Los atípicos de la variable a predecir</a:t>
+            </a:r>
+          </a:p>
+        </p:txBody>
+      </p:sp>
+      <p:pic>
+        <p:nvPicPr>
+          <p:cNvPr id="4" name="Picture 3" descr="c3_27_boxplot_numveh.png"/>
+          <p:cNvPicPr>
+            <a:picLocks noChangeAspect="1"/>
+          </p:cNvPicPr>
+          <p:nvPr/>
+        </p:nvPicPr>
+        <p:blipFill>
+          <a:blip r:embed="rId2"/>
+          <a:stretch>
+            <a:fillRect/>
+          </a:stretch>
+        </p:blipFill>
+        <p:spPr>
+          <a:xfrm>
+            <a:off x="699515" y="1492260"/>
+            <a:ext cx="7744968" cy="2456159"/>
+          </a:xfrm>
+          <a:prstGeom prst="rect">
+            <a:avLst/>
+          </a:prstGeom>
+        </p:spPr>
+      </p:pic>
+      <p:sp>
+        <p:nvSpPr>
+          <p:cNvPr id="5" name="TextBox 4"/>
+          <p:cNvSpPr txBox="1"/>
+          <p:nvPr/>
+        </p:nvSpPr>
+        <p:spPr>
+          <a:xfrm>
+            <a:off x="704088" y="4434840"/>
+            <a:ext cx="7744968" cy="457200"/>
+          </a:xfrm>
+          <a:prstGeom prst="rect">
+            <a:avLst/>
+          </a:prstGeom>
+          <a:noFill/>
+        </p:spPr>
+        <p:txBody>
+          <a:bodyPr wrap="square">
+            <a:spAutoFit/>
+          </a:bodyPr>
+          <a:lstStyle/>
+          <a:p>
+            <a:r>
+              <a:rPr sz="1300" b="0">
+                <a:solidFill>
+                  <a:srgbClr val="333333"/>
+                </a:solidFill>
+                <a:latin typeface="Fira Sans"/>
+              </a:rPr>
+              <a:t>El boxplot de NumVeh (clase 2): la cerca de Tukey queda en 2,5, y los hogares de 3 autos o más son atípicos. La siguiente diapo mide qué pasa al sacarlos.</a:t>
             </a:r>
           </a:p>
         </p:txBody>
@@ -4389,35 +4389,114 @@
                 </a:solidFill>
                 <a:latin typeface="Fira Sans"/>
               </a:rPr>
-              <a:t>La misma regresión, tres veces</a:t>
-            </a:r>
-          </a:p>
-        </p:txBody>
-      </p:sp>
-      <p:pic>
-        <p:nvPicPr>
-          <p:cNvPr id="4" name="Picture 3" descr="c4_02_tres_modelos.png"/>
-          <p:cNvPicPr>
-            <a:picLocks noChangeAspect="1"/>
-          </p:cNvPicPr>
-          <p:nvPr/>
-        </p:nvPicPr>
-        <p:blipFill>
-          <a:blip r:embed="rId2"/>
-          <a:stretch>
-            <a:fillRect/>
-          </a:stretch>
-        </p:blipFill>
-        <p:spPr>
-          <a:xfrm>
-            <a:off x="699515" y="1660639"/>
-            <a:ext cx="7744968" cy="2119400"/>
-          </a:xfrm>
-          <a:prstGeom prst="rect">
-            <a:avLst/>
-          </a:prstGeom>
-        </p:spPr>
-      </p:pic>
+              <a:t>Sacar atípicos de la variable a predecir</a:t>
+            </a:r>
+          </a:p>
+        </p:txBody>
+      </p:sp>
+      <p:sp>
+        <p:nvSpPr>
+          <p:cNvPr id="4" name="Rectangle 3"/>
+          <p:cNvSpPr/>
+          <p:nvPr/>
+        </p:nvSpPr>
+        <p:spPr>
+          <a:xfrm>
+            <a:off x="704088" y="1280160"/>
+            <a:ext cx="7744968" cy="2880360"/>
+          </a:xfrm>
+          <a:prstGeom prst="rect">
+            <a:avLst/>
+          </a:prstGeom>
+          <a:solidFill>
+            <a:srgbClr val="F0F2F5"/>
+          </a:solidFill>
+          <a:ln>
+            <a:solidFill>
+              <a:srgbClr val="D8DDE3"/>
+            </a:solidFill>
+          </a:ln>
+          <a:effectLst/>
+        </p:spPr>
+        <p:style>
+          <a:lnRef idx="1">
+            <a:schemeClr val="accent1"/>
+          </a:lnRef>
+          <a:fillRef idx="3">
+            <a:schemeClr val="accent1"/>
+          </a:fillRef>
+          <a:effectRef idx="2">
+            <a:schemeClr val="accent1"/>
+          </a:effectRef>
+          <a:fontRef idx="minor">
+            <a:schemeClr val="lt1"/>
+          </a:fontRef>
+        </p:style>
+        <p:txBody>
+          <a:bodyPr rtlCol="0" anchor="ctr" wrap="square" lIns="228600" tIns="137160"/>
+          <a:lstStyle/>
+          <a:p>
+            <a:pPr/>
+            <a:r>
+              <a:rPr sz="1500" b="0">
+                <a:solidFill>
+                  <a:srgbClr val="1D3557"/>
+                </a:solidFill>
+                <a:latin typeface="Menlo"/>
+              </a:rPr>
+              <a:t>q1, q3 = h["NumVeh"].quantile([0.25, 0.75])</a:t>
+            </a:r>
+          </a:p>
+          <a:p>
+            <a:pPr/>
+            <a:r>
+              <a:rPr sz="1500" b="0">
+                <a:solidFill>
+                  <a:srgbClr val="1D3557"/>
+                </a:solidFill>
+                <a:latin typeface="Menlo"/>
+              </a:rPr>
+              <a:t>sin_atipicos = h[h["NumVeh"] &lt;= q3 + 1.5 * (q3 - q1)]  # = 2.5</a:t>
+            </a:r>
+          </a:p>
+          <a:p>
+            <a:pPr/>
+            <a:r>
+              <a:rPr sz="1500" b="0">
+                <a:solidFill>
+                  <a:srgbClr val="1D3557"/>
+                </a:solidFill>
+                <a:latin typeface="Menlo"/>
+              </a:rPr>
+              <a:t/>
+            </a:r>
+          </a:p>
+          <a:p>
+            <a:pPr/>
+            <a:r>
+              <a:rPr sz="1500" b="0">
+                <a:solidFill>
+                  <a:srgbClr val="1D3557"/>
+                </a:solidFill>
+                <a:latin typeface="Menlo"/>
+              </a:rPr>
+              <a:t># El mismo modelo, sin los hogares de 3 autos o más</a:t>
+            </a:r>
+          </a:p>
+          <a:p>
+            <a:pPr/>
+            <a:r>
+              <a:rPr sz="1500" b="0">
+                <a:solidFill>
+                  <a:srgbClr val="1D3557"/>
+                </a:solidFill>
+                <a:latin typeface="Menlo"/>
+              </a:rPr>
+              <a:t>np.polyfit(sin_atipicos["IngresoHogar"] / 1e6, sin_atipicos["NumVeh"], 1)</a:t>
+            </a:r>
+          </a:p>
+        </p:txBody>
+      </p:sp>
       <p:sp>
         <p:nvSpPr>
           <p:cNvPr id="5" name="TextBox 4"/>
@@ -4426,8 +4505,8 @@
         </p:nvSpPr>
         <p:spPr>
           <a:xfrm>
-            <a:off x="704088" y="4434840"/>
-            <a:ext cx="7744968" cy="457200"/>
+            <a:off x="704088" y="4389120"/>
+            <a:ext cx="7744968" cy="1097280"/>
           </a:xfrm>
           <a:prstGeom prst="rect">
             <a:avLst/>
@@ -4440,14 +4519,31 @@
           </a:bodyPr>
           <a:lstStyle/>
           <a:p>
-            <a:r>
-              <a:rPr sz="1300" b="0">
-                <a:solidFill>
-                  <a:srgbClr val="333333"/>
-                </a:solidFill>
-                <a:latin typeface="Fira Sans"/>
-              </a:rPr>
-              <a:t>Decisión 1: transformar con log, porque las dos variables tienen cola larga y en log la nube se endereza: R² de 0,32 a 0,53. Y queda claro que la distancia sola no basta.</a:t>
+            <a:pPr>
+              <a:lnSpc>
+                <a:spcPct val="112000"/>
+              </a:lnSpc>
+              <a:spcAft>
+                <a:spcPts val="900"/>
+              </a:spcAft>
+            </a:pPr>
+            <a:r>
+              <a:rPr sz="1600" b="1">
+                <a:solidFill>
+                  <a:srgbClr val="E0A437"/>
+                </a:solidFill>
+                <a:latin typeface="Fira Sans"/>
+              </a:rPr>
+              <a:t>▸ </a:t>
+            </a:r>
+            <a:r>
+              <a:rPr sz="1600" b="0">
+                <a:solidFill>
+                  <a:srgbClr val="000000"/>
+                </a:solidFill>
+                <a:latin typeface="Fira Sans"/>
+              </a:rPr>
+              <a:t>Sin esos 236 hogares la pendiente baja de 0,50 a 0,44: eran la señal, no errores. Los atípicos se investigan y solo se eliminan por una razón del dominio.</a:t>
             </a:r>
           </a:p>
         </p:txBody>
@@ -4485,7 +4581,7 @@
             <a:avLst/>
           </a:prstGeom>
           <a:solidFill>
-            <a:srgbClr val="FAFBFC"/>
+            <a:srgbClr val="1D3557"/>
           </a:solidFill>
           <a:ln>
             <a:noFill/>
@@ -4522,8 +4618,8 @@
         </p:nvSpPr>
         <p:spPr>
           <a:xfrm>
-            <a:off x="402336" y="301752"/>
-            <a:ext cx="8348472" cy="795528"/>
+            <a:off x="603504" y="1847088"/>
+            <a:ext cx="7946136" cy="1399032"/>
           </a:xfrm>
           <a:prstGeom prst="rect">
             <a:avLst/>
@@ -4537,71 +4633,24 @@
           <a:lstStyle/>
           <a:p>
             <a:r>
-              <a:rPr sz="2800" b="1">
-                <a:solidFill>
-                  <a:srgbClr val="0F0F0F"/>
-                </a:solidFill>
-                <a:latin typeface="Fira Sans"/>
-              </a:rPr>
-              <a:t>El mismo gráfico, dos veces</a:t>
-            </a:r>
-          </a:p>
-        </p:txBody>
-      </p:sp>
-      <p:pic>
-        <p:nvPicPr>
-          <p:cNvPr id="4" name="Picture 3" descr="c3_16_mal_buen_grafico.png"/>
-          <p:cNvPicPr>
-            <a:picLocks noChangeAspect="1"/>
-          </p:cNvPicPr>
-          <p:nvPr/>
-        </p:nvPicPr>
-        <p:blipFill>
-          <a:blip r:embed="rId2"/>
-          <a:stretch>
-            <a:fillRect/>
-          </a:stretch>
-        </p:blipFill>
-        <p:spPr>
-          <a:xfrm>
-            <a:off x="699515" y="1217944"/>
-            <a:ext cx="7744968" cy="3004790"/>
-          </a:xfrm>
-          <a:prstGeom prst="rect">
-            <a:avLst/>
-          </a:prstGeom>
-        </p:spPr>
-      </p:pic>
-      <p:sp>
-        <p:nvSpPr>
-          <p:cNvPr id="5" name="TextBox 4"/>
-          <p:cNvSpPr txBox="1"/>
-          <p:nvPr/>
-        </p:nvSpPr>
-        <p:spPr>
-          <a:xfrm>
-            <a:off x="704088" y="4434840"/>
-            <a:ext cx="7744968" cy="457200"/>
-          </a:xfrm>
-          <a:prstGeom prst="rect">
-            <a:avLst/>
-          </a:prstGeom>
-          <a:noFill/>
-        </p:spPr>
-        <p:txBody>
-          <a:bodyPr wrap="square">
-            <a:spAutoFit/>
-          </a:bodyPr>
-          <a:lstStyle/>
-          <a:p>
-            <a:r>
-              <a:rPr sz="1300" b="0">
-                <a:solidFill>
-                  <a:srgbClr val="333333"/>
-                </a:solidFill>
-                <a:latin typeface="Fira Sans"/>
-              </a:rPr>
-              <a:t>Los mismos 30 mil viajes: sin rotular y saturado, contra rotulado, con transparencia y con el hallazgo en el título.</a:t>
+              <a:rPr sz="3400" b="1">
+                <a:solidFill>
+                  <a:srgbClr val="FFFFFF"/>
+                </a:solidFill>
+                <a:latin typeface="Fira Sans"/>
+              </a:rPr>
+              <a:t>Regresión múltiple</a:t>
+            </a:r>
+          </a:p>
+          <a:p>
+            <a:r>
+              <a:rPr sz="1800" b="0">
+                <a:solidFill>
+                  <a:srgbClr val="E0A437"/>
+                </a:solidFill>
+                <a:latin typeface="Fira Sans"/>
+              </a:rPr>
+              <a:t>El primer modelo con varias variables</a:t>
             </a:r>
           </a:p>
         </p:txBody>
@@ -4697,21 +4746,45 @@
                 </a:solidFill>
                 <a:latin typeface="Fira Sans"/>
               </a:rPr>
-              <a:t>Checklist del buen gráfico</a:t>
-            </a:r>
-          </a:p>
-        </p:txBody>
-      </p:sp>
-      <p:sp>
-        <p:nvSpPr>
-          <p:cNvPr id="4" name="TextBox 3"/>
+              <a:t>La fórmula de la regresión múltiple</a:t>
+            </a:r>
+          </a:p>
+        </p:txBody>
+      </p:sp>
+      <p:pic>
+        <p:nvPicPr>
+          <p:cNvPr id="4" name="Picture 3" descr="c4_01_formula_multiple.png"/>
+          <p:cNvPicPr>
+            <a:picLocks noChangeAspect="1"/>
+          </p:cNvPicPr>
+          <p:nvPr/>
+        </p:nvPicPr>
+        <p:blipFill>
+          <a:blip r:embed="rId2"/>
+          <a:stretch>
+            <a:fillRect/>
+          </a:stretch>
+        </p:blipFill>
+        <p:spPr>
+          <a:xfrm>
+            <a:off x="699515" y="1500263"/>
+            <a:ext cx="7744968" cy="2440154"/>
+          </a:xfrm>
+          <a:prstGeom prst="rect">
+            <a:avLst/>
+          </a:prstGeom>
+        </p:spPr>
+      </p:pic>
+      <p:sp>
+        <p:nvSpPr>
+          <p:cNvPr id="5" name="TextBox 4"/>
           <p:cNvSpPr txBox="1"/>
           <p:nvPr/>
         </p:nvSpPr>
         <p:spPr>
           <a:xfrm>
-            <a:off x="704088" y="1353312"/>
-            <a:ext cx="7744968" cy="3300984"/>
+            <a:off x="704088" y="4434840"/>
+            <a:ext cx="7744968" cy="457200"/>
           </a:xfrm>
           <a:prstGeom prst="rect">
             <a:avLst/>
@@ -4724,115 +4797,14 @@
           </a:bodyPr>
           <a:lstStyle/>
           <a:p>
-            <a:pPr>
-              <a:lnSpc>
-                <a:spcPct val="112000"/>
-              </a:lnSpc>
-              <a:spcAft>
-                <a:spcPts val="900"/>
-              </a:spcAft>
-            </a:pPr>
-            <a:r>
-              <a:rPr sz="1800" b="1">
-                <a:solidFill>
-                  <a:srgbClr val="E0A437"/>
-                </a:solidFill>
-                <a:latin typeface="Fira Sans"/>
-              </a:rPr>
-              <a:t>▸ </a:t>
-            </a:r>
-            <a:r>
-              <a:rPr sz="1800" b="0">
-                <a:solidFill>
-                  <a:srgbClr val="000000"/>
-                </a:solidFill>
-                <a:latin typeface="Fira Sans"/>
-              </a:rPr>
-              <a:t>Título adecuado: dice qué muestra el gráfico.</a:t>
-            </a:r>
-          </a:p>
-          <a:p>
-            <a:pPr>
-              <a:lnSpc>
-                <a:spcPct val="112000"/>
-              </a:lnSpc>
-              <a:spcAft>
-                <a:spcPts val="900"/>
-              </a:spcAft>
-            </a:pPr>
-            <a:r>
-              <a:rPr sz="1800" b="1">
-                <a:solidFill>
-                  <a:srgbClr val="E0A437"/>
-                </a:solidFill>
-                <a:latin typeface="Fira Sans"/>
-              </a:rPr>
-              <a:t>▸ </a:t>
-            </a:r>
-            <a:r>
-              <a:rPr sz="1800" b="0">
-                <a:solidFill>
-                  <a:srgbClr val="000000"/>
-                </a:solidFill>
-                <a:latin typeface="Fira Sans"/>
-              </a:rPr>
-              <a:t>Ejes con nombre y unidad; ejes que parten de cero en gráficos de barras.</a:t>
-            </a:r>
-          </a:p>
-          <a:p>
-            <a:pPr>
-              <a:lnSpc>
-                <a:spcPct val="112000"/>
-              </a:lnSpc>
-              <a:spcAft>
-                <a:spcPts val="900"/>
-              </a:spcAft>
-            </a:pPr>
-            <a:r>
-              <a:rPr sz="1800" b="1">
-                <a:solidFill>
-                  <a:srgbClr val="E0A437"/>
-                </a:solidFill>
-                <a:latin typeface="Fira Sans"/>
-              </a:rPr>
-              <a:t>▸ </a:t>
-            </a:r>
-            <a:r>
-              <a:rPr sz="1800" b="0">
-                <a:solidFill>
-                  <a:srgbClr val="000000"/>
-                </a:solidFill>
-                <a:latin typeface="Fira Sans"/>
-              </a:rPr>
-              <a:t>Muchos puntos: alpha, muestreo o hexbin.</a:t>
-            </a:r>
-          </a:p>
-          <a:p>
-            <a:pPr>
-              <a:lnSpc>
-                <a:spcPct val="112000"/>
-              </a:lnSpc>
-              <a:spcAft>
-                <a:spcPts val="900"/>
-              </a:spcAft>
-            </a:pPr>
-            <a:r>
-              <a:rPr sz="1800" b="1">
-                <a:solidFill>
-                  <a:srgbClr val="E0A437"/>
-                </a:solidFill>
-                <a:latin typeface="Fira Sans"/>
-              </a:rPr>
-              <a:t>▸ </a:t>
-            </a:r>
-            <a:r>
-              <a:rPr sz="1800" b="0">
-                <a:solidFill>
-                  <a:srgbClr val="000000"/>
-                </a:solidFill>
-                <a:latin typeface="Fira Sans"/>
-              </a:rPr>
-              <a:t>Colas largas: escala logarítmica o eje recortado, declarándolo.</a:t>
+            <a:r>
+              <a:rPr sz="1300" b="0">
+                <a:solidFill>
+                  <a:srgbClr val="333333"/>
+                </a:solidFill>
+                <a:latin typeface="Fira Sans"/>
+              </a:rPr>
+              <a:t>Cada coeficiente aísla el efecto de su variable: cuánto cambia la predicción por una unidad de esa x, manteniendo las demás constantes.</a:t>
             </a:r>
           </a:p>
         </p:txBody>
@@ -4928,7 +4900,7 @@
                 </a:solidFill>
                 <a:latin typeface="Fira Sans"/>
               </a:rPr>
-              <a:t>Regresión múltiple</a:t>
+              <a:t>¿Mejora el modelo si agregamos el tamaño del hogar?</a:t>
             </a:r>
           </a:p>
           <a:p>
@@ -4939,7 +4911,7 @@
                 </a:solidFill>
                 <a:latin typeface="Fira Sans"/>
               </a:rPr>
-              <a:t>El primer modelo con varias variables</a:t>
+              <a:t>Explicar los vehículos con el ingreso y las personas: la primera regresión múltiple</a:t>
             </a:r>
           </a:p>
         </p:txBody>
@@ -5238,35 +5210,114 @@
                 </a:solidFill>
                 <a:latin typeface="Fira Sans"/>
               </a:rPr>
-              <a:t>La fórmula de la regresión múltiple</a:t>
-            </a:r>
-          </a:p>
-        </p:txBody>
-      </p:sp>
-      <p:pic>
-        <p:nvPicPr>
-          <p:cNvPr id="4" name="Picture 3" descr="c4_01_formula_multiple.png"/>
-          <p:cNvPicPr>
-            <a:picLocks noChangeAspect="1"/>
-          </p:cNvPicPr>
-          <p:nvPr/>
-        </p:nvPicPr>
-        <p:blipFill>
-          <a:blip r:embed="rId2"/>
-          <a:stretch>
-            <a:fillRect/>
-          </a:stretch>
-        </p:blipFill>
-        <p:spPr>
-          <a:xfrm>
-            <a:off x="699515" y="1500263"/>
-            <a:ext cx="7744968" cy="2440154"/>
-          </a:xfrm>
-          <a:prstGeom prst="rect">
-            <a:avLst/>
-          </a:prstGeom>
-        </p:spPr>
-      </p:pic>
+              <a:t>La motorización, con dos variables</a:t>
+            </a:r>
+          </a:p>
+        </p:txBody>
+      </p:sp>
+      <p:sp>
+        <p:nvSpPr>
+          <p:cNvPr id="4" name="Rectangle 3"/>
+          <p:cNvSpPr/>
+          <p:nvPr/>
+        </p:nvSpPr>
+        <p:spPr>
+          <a:xfrm>
+            <a:off x="704088" y="1280160"/>
+            <a:ext cx="7744968" cy="2880360"/>
+          </a:xfrm>
+          <a:prstGeom prst="rect">
+            <a:avLst/>
+          </a:prstGeom>
+          <a:solidFill>
+            <a:srgbClr val="F0F2F5"/>
+          </a:solidFill>
+          <a:ln>
+            <a:solidFill>
+              <a:srgbClr val="D8DDE3"/>
+            </a:solidFill>
+          </a:ln>
+          <a:effectLst/>
+        </p:spPr>
+        <p:style>
+          <a:lnRef idx="1">
+            <a:schemeClr val="accent1"/>
+          </a:lnRef>
+          <a:fillRef idx="3">
+            <a:schemeClr val="accent1"/>
+          </a:fillRef>
+          <a:effectRef idx="2">
+            <a:schemeClr val="accent1"/>
+          </a:effectRef>
+          <a:fontRef idx="minor">
+            <a:schemeClr val="lt1"/>
+          </a:fontRef>
+        </p:style>
+        <p:txBody>
+          <a:bodyPr rtlCol="0" anchor="ctr" wrap="square" lIns="228600" tIns="137160"/>
+          <a:lstStyle/>
+          <a:p>
+            <a:pPr/>
+            <a:r>
+              <a:rPr sz="1500" b="0">
+                <a:solidFill>
+                  <a:srgbClr val="1D3557"/>
+                </a:solidFill>
+                <a:latin typeface="Menlo"/>
+              </a:rPr>
+              <a:t># Explicar los vehículos del hogar con el ingreso y las personas</a:t>
+            </a:r>
+          </a:p>
+          <a:p>
+            <a:pPr/>
+            <a:r>
+              <a:rPr sz="1500" b="0">
+                <a:solidFill>
+                  <a:srgbClr val="1D3557"/>
+                </a:solidFill>
+                <a:latin typeface="Menlo"/>
+              </a:rPr>
+              <a:t>X = sm.add_constant(pd.DataFrame({</a:t>
+            </a:r>
+          </a:p>
+          <a:p>
+            <a:pPr/>
+            <a:r>
+              <a:rPr sz="1500" b="0">
+                <a:solidFill>
+                  <a:srgbClr val="1D3557"/>
+                </a:solidFill>
+                <a:latin typeface="Menlo"/>
+              </a:rPr>
+              <a:t>    "ingreso": h["IngresoHogar"] / 1e6,</a:t>
+            </a:r>
+          </a:p>
+          <a:p>
+            <a:pPr/>
+            <a:r>
+              <a:rPr sz="1500" b="0">
+                <a:solidFill>
+                  <a:srgbClr val="1D3557"/>
+                </a:solidFill>
+                <a:latin typeface="Menlo"/>
+              </a:rPr>
+              <a:t>    "personas": h["NumPer"]}))</a:t>
+            </a:r>
+          </a:p>
+          <a:p>
+            <a:pPr/>
+            <a:r>
+              <a:rPr sz="1500" b="0">
+                <a:solidFill>
+                  <a:srgbClr val="1D3557"/>
+                </a:solidFill>
+                <a:latin typeface="Menlo"/>
+              </a:rPr>
+              <a:t>modelo = sm.WLS(h["NumVeh"], X, weights=h["Factor"]).fit()</a:t>
+            </a:r>
+          </a:p>
+        </p:txBody>
+      </p:sp>
       <p:sp>
         <p:nvSpPr>
           <p:cNvPr id="5" name="TextBox 4"/>
@@ -5275,8 +5326,8 @@
         </p:nvSpPr>
         <p:spPr>
           <a:xfrm>
-            <a:off x="704088" y="4434840"/>
-            <a:ext cx="7744968" cy="457200"/>
+            <a:off x="704088" y="4389120"/>
+            <a:ext cx="7744968" cy="1097280"/>
           </a:xfrm>
           <a:prstGeom prst="rect">
             <a:avLst/>
@@ -5289,14 +5340,31 @@
           </a:bodyPr>
           <a:lstStyle/>
           <a:p>
-            <a:r>
-              <a:rPr sz="1300" b="0">
-                <a:solidFill>
-                  <a:srgbClr val="333333"/>
-                </a:solidFill>
-                <a:latin typeface="Fira Sans"/>
-              </a:rPr>
-              <a:t>Cada coeficiente aísla el efecto de su variable: cuánto cambia la predicción por una unidad de esa x, manteniendo las demás constantes.</a:t>
+            <a:pPr>
+              <a:lnSpc>
+                <a:spcPct val="112000"/>
+              </a:lnSpc>
+              <a:spcAft>
+                <a:spcPts val="900"/>
+              </a:spcAft>
+            </a:pPr>
+            <a:r>
+              <a:rPr sz="1600" b="1">
+                <a:solidFill>
+                  <a:srgbClr val="E0A437"/>
+                </a:solidFill>
+                <a:latin typeface="Fira Sans"/>
+              </a:rPr>
+              <a:t>▸ </a:t>
+            </a:r>
+            <a:r>
+              <a:rPr sz="1600" b="0">
+                <a:solidFill>
+                  <a:srgbClr val="000000"/>
+                </a:solidFill>
+                <a:latin typeface="Fira Sans"/>
+              </a:rPr>
+              <a:t>Ponderado: 0,48 vehículos por millón (era 0,50 a solas) y 0,03 por persona extra. El R² sube apenas, de 0,261 a 0,266: agregar variables no siempre aporta.</a:t>
             </a:r>
           </a:p>
         </p:txBody>
@@ -5334,7 +5402,7 @@
             <a:avLst/>
           </a:prstGeom>
           <a:solidFill>
-            <a:srgbClr val="1D3557"/>
+            <a:srgbClr val="FAFBFC"/>
           </a:solidFill>
           <a:ln>
             <a:noFill/>
@@ -5371,8 +5439,8 @@
         </p:nvSpPr>
         <p:spPr>
           <a:xfrm>
-            <a:off x="603504" y="1847088"/>
-            <a:ext cx="7946136" cy="1399032"/>
+            <a:off x="402336" y="301752"/>
+            <a:ext cx="8348472" cy="795528"/>
           </a:xfrm>
           <a:prstGeom prst="rect">
             <a:avLst/>
@@ -5386,24 +5454,71 @@
           <a:lstStyle/>
           <a:p>
             <a:r>
-              <a:rPr sz="3400" b="1">
-                <a:solidFill>
-                  <a:srgbClr val="FFFFFF"/>
-                </a:solidFill>
-                <a:latin typeface="Fira Sans"/>
-              </a:rPr>
-              <a:t>¿Mejora el modelo si agregamos el tamaño del hogar?</a:t>
-            </a:r>
-          </a:p>
-          <a:p>
-            <a:r>
-              <a:rPr sz="1800" b="0">
-                <a:solidFill>
-                  <a:srgbClr val="E0A437"/>
-                </a:solidFill>
-                <a:latin typeface="Fira Sans"/>
-              </a:rPr>
-              <a:t>Explicar los vehículos con el ingreso y las personas: la primera regresión múltiple</a:t>
+              <a:rPr sz="2800" b="1">
+                <a:solidFill>
+                  <a:srgbClr val="0F0F0F"/>
+                </a:solidFill>
+                <a:latin typeface="Fira Sans"/>
+              </a:rPr>
+              <a:t>La ecuación ajustada y su lectura</a:t>
+            </a:r>
+          </a:p>
+        </p:txBody>
+      </p:sp>
+      <p:pic>
+        <p:nvPicPr>
+          <p:cNvPr id="4" name="Picture 3" descr="c4_08_ecuacion_motorizacion.png"/>
+          <p:cNvPicPr>
+            <a:picLocks noChangeAspect="1"/>
+          </p:cNvPicPr>
+          <p:nvPr/>
+        </p:nvPicPr>
+        <p:blipFill>
+          <a:blip r:embed="rId2"/>
+          <a:stretch>
+            <a:fillRect/>
+          </a:stretch>
+        </p:blipFill>
+        <p:spPr>
+          <a:xfrm>
+            <a:off x="699515" y="1292657"/>
+            <a:ext cx="7744968" cy="2855366"/>
+          </a:xfrm>
+          <a:prstGeom prst="rect">
+            <a:avLst/>
+          </a:prstGeom>
+        </p:spPr>
+      </p:pic>
+      <p:sp>
+        <p:nvSpPr>
+          <p:cNvPr id="5" name="TextBox 4"/>
+          <p:cNvSpPr txBox="1"/>
+          <p:nvPr/>
+        </p:nvSpPr>
+        <p:spPr>
+          <a:xfrm>
+            <a:off x="704088" y="4434840"/>
+            <a:ext cx="7744968" cy="457200"/>
+          </a:xfrm>
+          <a:prstGeom prst="rect">
+            <a:avLst/>
+          </a:prstGeom>
+          <a:noFill/>
+        </p:spPr>
+        <p:txBody>
+          <a:bodyPr wrap="square">
+            <a:spAutoFit/>
+          </a:bodyPr>
+          <a:lstStyle/>
+          <a:p>
+            <a:r>
+              <a:rPr sz="1300" b="0">
+                <a:solidFill>
+                  <a:srgbClr val="333333"/>
+                </a:solidFill>
+                <a:latin typeface="Fira Sans"/>
+              </a:rPr>
+              <a:t>La fórmula de la múltiple con nuestros números: cada coeficiente se lee con las demás variables fijas.</a:t>
             </a:r>
           </a:p>
         </p:txBody>
@@ -5499,114 +5614,35 @@
                 </a:solidFill>
                 <a:latin typeface="Fira Sans"/>
               </a:rPr>
-              <a:t>La motorización, con dos variables</a:t>
-            </a:r>
-          </a:p>
-        </p:txBody>
-      </p:sp>
-      <p:sp>
-        <p:nvSpPr>
-          <p:cNvPr id="4" name="Rectangle 3"/>
-          <p:cNvSpPr/>
-          <p:nvPr/>
-        </p:nvSpPr>
-        <p:spPr>
-          <a:xfrm>
-            <a:off x="704088" y="1280160"/>
-            <a:ext cx="7744968" cy="2880360"/>
-          </a:xfrm>
-          <a:prstGeom prst="rect">
-            <a:avLst/>
-          </a:prstGeom>
-          <a:solidFill>
-            <a:srgbClr val="F0F2F5"/>
-          </a:solidFill>
-          <a:ln>
-            <a:solidFill>
-              <a:srgbClr val="D8DDE3"/>
-            </a:solidFill>
-          </a:ln>
-          <a:effectLst/>
-        </p:spPr>
-        <p:style>
-          <a:lnRef idx="1">
-            <a:schemeClr val="accent1"/>
-          </a:lnRef>
-          <a:fillRef idx="3">
-            <a:schemeClr val="accent1"/>
-          </a:fillRef>
-          <a:effectRef idx="2">
-            <a:schemeClr val="accent1"/>
-          </a:effectRef>
-          <a:fontRef idx="minor">
-            <a:schemeClr val="lt1"/>
-          </a:fontRef>
-        </p:style>
-        <p:txBody>
-          <a:bodyPr rtlCol="0" anchor="ctr" wrap="square" lIns="228600" tIns="137160"/>
-          <a:lstStyle/>
-          <a:p>
-            <a:pPr/>
-            <a:r>
-              <a:rPr sz="1500" b="0">
-                <a:solidFill>
-                  <a:srgbClr val="1D3557"/>
-                </a:solidFill>
-                <a:latin typeface="Menlo"/>
-              </a:rPr>
-              <a:t># Explicar los vehículos del hogar con el ingreso y las personas</a:t>
-            </a:r>
-          </a:p>
-          <a:p>
-            <a:pPr/>
-            <a:r>
-              <a:rPr sz="1500" b="0">
-                <a:solidFill>
-                  <a:srgbClr val="1D3557"/>
-                </a:solidFill>
-                <a:latin typeface="Menlo"/>
-              </a:rPr>
-              <a:t>X = sm.add_constant(pd.DataFrame({</a:t>
-            </a:r>
-          </a:p>
-          <a:p>
-            <a:pPr/>
-            <a:r>
-              <a:rPr sz="1500" b="0">
-                <a:solidFill>
-                  <a:srgbClr val="1D3557"/>
-                </a:solidFill>
-                <a:latin typeface="Menlo"/>
-              </a:rPr>
-              <a:t>    "ingreso": h["IngresoHogar"] / 1e6,</a:t>
-            </a:r>
-          </a:p>
-          <a:p>
-            <a:pPr/>
-            <a:r>
-              <a:rPr sz="1500" b="0">
-                <a:solidFill>
-                  <a:srgbClr val="1D3557"/>
-                </a:solidFill>
-                <a:latin typeface="Menlo"/>
-              </a:rPr>
-              <a:t>    "personas": h["NumPer"]}))</a:t>
-            </a:r>
-          </a:p>
-          <a:p>
-            <a:pPr/>
-            <a:r>
-              <a:rPr sz="1500" b="0">
-                <a:solidFill>
-                  <a:srgbClr val="1D3557"/>
-                </a:solidFill>
-                <a:latin typeface="Menlo"/>
-              </a:rPr>
-              <a:t>modelo = sm.WLS(h["NumVeh"], X, weights=h["Factor"]).fit()</a:t>
-            </a:r>
-          </a:p>
-        </p:txBody>
-      </p:sp>
+              <a:t>Leer el modelo: R²</a:t>
+            </a:r>
+          </a:p>
+        </p:txBody>
+      </p:sp>
+      <p:pic>
+        <p:nvPicPr>
+          <p:cNvPr id="4" name="Picture 3" descr="c4_04_formula_r2.png"/>
+          <p:cNvPicPr>
+            <a:picLocks noChangeAspect="1"/>
+          </p:cNvPicPr>
+          <p:nvPr/>
+        </p:nvPicPr>
+        <p:blipFill>
+          <a:blip r:embed="rId2"/>
+          <a:stretch>
+            <a:fillRect/>
+          </a:stretch>
+        </p:blipFill>
+        <p:spPr>
+          <a:xfrm>
+            <a:off x="699515" y="1297266"/>
+            <a:ext cx="7744968" cy="2846146"/>
+          </a:xfrm>
+          <a:prstGeom prst="rect">
+            <a:avLst/>
+          </a:prstGeom>
+        </p:spPr>
+      </p:pic>
       <p:sp>
         <p:nvSpPr>
           <p:cNvPr id="5" name="TextBox 4"/>
@@ -5615,8 +5651,8 @@
         </p:nvSpPr>
         <p:spPr>
           <a:xfrm>
-            <a:off x="704088" y="4389120"/>
-            <a:ext cx="7744968" cy="1097280"/>
+            <a:off x="704088" y="4434840"/>
+            <a:ext cx="7744968" cy="457200"/>
           </a:xfrm>
           <a:prstGeom prst="rect">
             <a:avLst/>
@@ -5629,31 +5665,14 @@
           </a:bodyPr>
           <a:lstStyle/>
           <a:p>
-            <a:pPr>
-              <a:lnSpc>
-                <a:spcPct val="112000"/>
-              </a:lnSpc>
-              <a:spcAft>
-                <a:spcPts val="900"/>
-              </a:spcAft>
-            </a:pPr>
-            <a:r>
-              <a:rPr sz="1600" b="1">
-                <a:solidFill>
-                  <a:srgbClr val="E0A437"/>
-                </a:solidFill>
-                <a:latin typeface="Fira Sans"/>
-              </a:rPr>
-              <a:t>▸ </a:t>
-            </a:r>
-            <a:r>
-              <a:rPr sz="1600" b="0">
-                <a:solidFill>
-                  <a:srgbClr val="000000"/>
-                </a:solidFill>
-                <a:latin typeface="Fira Sans"/>
-              </a:rPr>
-              <a:t>Ponderado: 0,48 vehículos por millón (era 0,50 a solas) y 0,03 por persona extra. El R² sube apenas, de 0,261 a 0,266: agregar variables no siempre aporta.</a:t>
+            <a:r>
+              <a:rPr sz="1300" b="0">
+                <a:solidFill>
+                  <a:srgbClr val="333333"/>
+                </a:solidFill>
+                <a:latin typeface="Fira Sans"/>
+              </a:rPr>
+              <a:t>Nuestro 0,266: ingreso y personas explican un cuarto de la variabilidad de los vehículos entre hogares. Agregar variables nunca baja el R²; por eso no basta con mirarlo.</a:t>
             </a:r>
           </a:p>
         </p:txBody>
@@ -5749,14 +5768,14 @@
                 </a:solidFill>
                 <a:latin typeface="Fira Sans"/>
               </a:rPr>
-              <a:t>La ecuación ajustada y su lectura</a:t>
+              <a:t>El valor p: dónde vive</a:t>
             </a:r>
           </a:p>
         </p:txBody>
       </p:sp>
       <p:pic>
         <p:nvPicPr>
-          <p:cNvPr id="4" name="Picture 3" descr="c4_08_ecuacion_motorizacion.png"/>
+          <p:cNvPr id="4" name="Picture 3" descr="c4_07_pvalue_summary.png"/>
           <p:cNvPicPr>
             <a:picLocks noChangeAspect="1"/>
           </p:cNvPicPr>
@@ -5770,8 +5789,8 @@
         </p:blipFill>
         <p:spPr>
           <a:xfrm>
-            <a:off x="699515" y="1292657"/>
-            <a:ext cx="7744968" cy="2855366"/>
+            <a:off x="699515" y="1504912"/>
+            <a:ext cx="7744968" cy="2430856"/>
           </a:xfrm>
           <a:prstGeom prst="rect">
             <a:avLst/>
@@ -5807,7 +5826,7 @@
                 </a:solidFill>
                 <a:latin typeface="Fira Sans"/>
               </a:rPr>
-              <a:t>La fórmula de la múltiple con nuestros números: cada coeficiente se lee con las demás variables fijas.</a:t>
+              <a:t>Para cada variable, P&gt;|t| responde: si en la ciudad el ingreso (o las personas) no tuviera efecto alguno sobre los vehículos, ¿qué tan raro sería este coeficiente solo por azar de la muestra? Ambos dan 0,000; la clase 5 lo formaliza.</a:t>
             </a:r>
           </a:p>
         </p:txBody>
@@ -5903,14 +5922,14 @@
                 </a:solidFill>
                 <a:latin typeface="Fira Sans"/>
               </a:rPr>
-              <a:t>Leer el modelo: R²</a:t>
+              <a:t>El mapa para elegir variables</a:t>
             </a:r>
           </a:p>
         </p:txBody>
       </p:sp>
       <p:pic>
         <p:nvPicPr>
-          <p:cNvPr id="4" name="Picture 3" descr="c4_04_formula_r2.png"/>
+          <p:cNvPr id="4" name="Picture 3" descr="c4_05_mapa_candidatas.png"/>
           <p:cNvPicPr>
             <a:picLocks noChangeAspect="1"/>
           </p:cNvPicPr>
@@ -5924,8 +5943,8 @@
         </p:blipFill>
         <p:spPr>
           <a:xfrm>
-            <a:off x="699515" y="1297266"/>
-            <a:ext cx="7744968" cy="2846146"/>
+            <a:off x="2530736" y="1143000"/>
+            <a:ext cx="4082527" cy="3154680"/>
           </a:xfrm>
           <a:prstGeom prst="rect">
             <a:avLst/>
@@ -5961,7 +5980,7 @@
                 </a:solidFill>
                 <a:latin typeface="Fira Sans"/>
               </a:rPr>
-              <a:t>Nuestro 0,266: ingreso y personas explican un cuarto de la variabilidad de los vehículos entre hogares. Agregar variables nunca baja el R²; por eso no basta con mirarlo.</a:t>
+              <a:t>La fila de NumVeh es el mapa: ingreso 0,47 es el motor; las bicicletas casi no correlacionan con los vehículos (0,06) y son redundantes entre sí (0,83). Probarlas confirma: R² 0,266 a 0,267.</a:t>
             </a:r>
           </a:p>
         </p:txBody>
@@ -6057,14 +6076,14 @@
                 </a:solidFill>
                 <a:latin typeface="Fira Sans"/>
               </a:rPr>
-              <a:t>El valor p: dónde vive</a:t>
+              <a:t>Los coeficientes al agregar variables</a:t>
             </a:r>
           </a:p>
         </p:txBody>
       </p:sp>
       <p:pic>
         <p:nvPicPr>
-          <p:cNvPr id="4" name="Picture 3" descr="c4_07_pvalue_summary.png"/>
+          <p:cNvPr id="4" name="Picture 3" descr="c4_10_cambio_coeficientes.png"/>
           <p:cNvPicPr>
             <a:picLocks noChangeAspect="1"/>
           </p:cNvPicPr>
@@ -6078,8 +6097,8 @@
         </p:blipFill>
         <p:spPr>
           <a:xfrm>
-            <a:off x="699515" y="1504912"/>
-            <a:ext cx="7744968" cy="2430856"/>
+            <a:off x="1051559" y="1143000"/>
+            <a:ext cx="7040880" cy="3154680"/>
           </a:xfrm>
           <a:prstGeom prst="rect">
             <a:avLst/>
@@ -6115,7 +6134,7 @@
                 </a:solidFill>
                 <a:latin typeface="Fira Sans"/>
               </a:rPr>
-              <a:t>Para cada variable, P&gt;|t| responde: si en la ciudad el ingreso (o las personas) no tuviera efecto alguno sobre los vehículos, ¿qué tan raro sería este coeficiente solo por azar de la muestra? Ambos dan 0,000; la clase 5 lo formaliza.</a:t>
+              <a:t>El ingreso apenas se mueve (0,50 a 0,48) al agregar personas y bicicletas: es un efecto robusto. Las variables nuevas entran con coeficientes minúsculos y el R² casi no cambia.</a:t>
             </a:r>
           </a:p>
         </p:txBody>
@@ -6153,7 +6172,7 @@
             <a:avLst/>
           </a:prstGeom>
           <a:solidFill>
-            <a:srgbClr val="FAFBFC"/>
+            <a:srgbClr val="1D3557"/>
           </a:solidFill>
           <a:ln>
             <a:noFill/>
@@ -6190,8 +6209,8 @@
         </p:nvSpPr>
         <p:spPr>
           <a:xfrm>
-            <a:off x="402336" y="301752"/>
-            <a:ext cx="8348472" cy="795528"/>
+            <a:off x="603504" y="1847088"/>
+            <a:ext cx="7946136" cy="1399032"/>
           </a:xfrm>
           <a:prstGeom prst="rect">
             <a:avLst/>
@@ -6205,71 +6224,24 @@
           <a:lstStyle/>
           <a:p>
             <a:r>
-              <a:rPr sz="2800" b="1">
-                <a:solidFill>
-                  <a:srgbClr val="0F0F0F"/>
-                </a:solidFill>
-                <a:latin typeface="Fira Sans"/>
-              </a:rPr>
-              <a:t>El mapa para elegir variables</a:t>
-            </a:r>
-          </a:p>
-        </p:txBody>
-      </p:sp>
-      <p:pic>
-        <p:nvPicPr>
-          <p:cNvPr id="4" name="Picture 3" descr="c4_05_mapa_candidatas.png"/>
-          <p:cNvPicPr>
-            <a:picLocks noChangeAspect="1"/>
-          </p:cNvPicPr>
-          <p:nvPr/>
-        </p:nvPicPr>
-        <p:blipFill>
-          <a:blip r:embed="rId2"/>
-          <a:stretch>
-            <a:fillRect/>
-          </a:stretch>
-        </p:blipFill>
-        <p:spPr>
-          <a:xfrm>
-            <a:off x="2530736" y="1143000"/>
-            <a:ext cx="4082527" cy="3154680"/>
-          </a:xfrm>
-          <a:prstGeom prst="rect">
-            <a:avLst/>
-          </a:prstGeom>
-        </p:spPr>
-      </p:pic>
-      <p:sp>
-        <p:nvSpPr>
-          <p:cNvPr id="5" name="TextBox 4"/>
-          <p:cNvSpPr txBox="1"/>
-          <p:nvPr/>
-        </p:nvSpPr>
-        <p:spPr>
-          <a:xfrm>
-            <a:off x="704088" y="4434840"/>
-            <a:ext cx="7744968" cy="457200"/>
-          </a:xfrm>
-          <a:prstGeom prst="rect">
-            <a:avLst/>
-          </a:prstGeom>
-          <a:noFill/>
-        </p:spPr>
-        <p:txBody>
-          <a:bodyPr wrap="square">
-            <a:spAutoFit/>
-          </a:bodyPr>
-          <a:lstStyle/>
-          <a:p>
-            <a:r>
-              <a:rPr sz="1300" b="0">
-                <a:solidFill>
-                  <a:srgbClr val="333333"/>
-                </a:solidFill>
-                <a:latin typeface="Fira Sans"/>
-              </a:rPr>
-              <a:t>La fila de NumVeh es el mapa: ingreso 0,47 es el motor; las bicicletas casi no correlacionan con los vehículos (0,06) y son redundantes entre sí (0,83). Probarlas confirma: R² 0,266 a 0,267.</a:t>
+              <a:rPr sz="3400" b="1">
+                <a:solidFill>
+                  <a:srgbClr val="FFFFFF"/>
+                </a:solidFill>
+                <a:latin typeface="Fira Sans"/>
+              </a:rPr>
+              <a:t>¿De qué depende la duración de un viaje?</a:t>
+            </a:r>
+          </a:p>
+          <a:p>
+            <a:r>
+              <a:rPr sz="1800" b="0">
+                <a:solidFill>
+                  <a:srgbClr val="E0A437"/>
+                </a:solidFill>
+                <a:latin typeface="Fira Sans"/>
+              </a:rPr>
+              <a:t>Lo que ya sabemos (clase 3): correlaciona con la distancia, r = 0,57 y Spearman 0,76. Primera decisión: partir por la distancia, 102 mil viajes de la EOD</a:t>
             </a:r>
           </a:p>
         </p:txBody>
@@ -6365,14 +6337,14 @@
                 </a:solidFill>
                 <a:latin typeface="Fira Sans"/>
               </a:rPr>
-              <a:t>Los coeficientes al agregar variables</a:t>
+              <a:t>La misma regresión, tres veces</a:t>
             </a:r>
           </a:p>
         </p:txBody>
       </p:sp>
       <p:pic>
         <p:nvPicPr>
-          <p:cNvPr id="4" name="Picture 3" descr="c4_10_cambio_coeficientes.png"/>
+          <p:cNvPr id="4" name="Picture 3" descr="c4_02_tres_modelos.png"/>
           <p:cNvPicPr>
             <a:picLocks noChangeAspect="1"/>
           </p:cNvPicPr>
@@ -6386,8 +6358,8 @@
         </p:blipFill>
         <p:spPr>
           <a:xfrm>
-            <a:off x="1051559" y="1143000"/>
-            <a:ext cx="7040880" cy="3154680"/>
+            <a:off x="699515" y="1660639"/>
+            <a:ext cx="7744968" cy="2119400"/>
           </a:xfrm>
           <a:prstGeom prst="rect">
             <a:avLst/>
@@ -6423,7 +6395,7 @@
                 </a:solidFill>
                 <a:latin typeface="Fira Sans"/>
               </a:rPr>
-              <a:t>El ingreso apenas se mueve (0,50 a 0,48) al agregar personas y bicicletas: es un efecto robusto. Las variables nuevas entran con coeficientes minúsculos y el R² casi no cambia.</a:t>
+              <a:t>Decisión 1: transformar con log, porque las dos variables tienen cola larga y en log la nube se endereza: R² de 0,32 a 0,53. Y queda claro que la distancia sola no basta.</a:t>
             </a:r>
           </a:p>
         </p:txBody>
@@ -6831,7 +6803,7 @@
                 </a:solidFill>
                 <a:latin typeface="Fira Sans"/>
               </a:rPr>
-              <a:t>1. El impacto de sacar filas y atípicos.</a:t>
+              <a:t>1. Visualización: muchos puntos y colas largas.</a:t>
             </a:r>
           </a:p>
           <a:p>
@@ -6859,7 +6831,7 @@
                 </a:solidFill>
                 <a:latin typeface="Fira Sans"/>
               </a:rPr>
-              <a:t>2. La regresión ponderada (WLS).</a:t>
+              <a:t>2. El impacto de sacar filas y atípicos.</a:t>
             </a:r>
           </a:p>
           <a:p>
@@ -6887,7 +6859,7 @@
                 </a:solidFill>
                 <a:latin typeface="Fira Sans"/>
               </a:rPr>
-              <a:t>3. Visualización: muchos puntos y colas largas.</a:t>
+              <a:t>3. La regresión ponderada (WLS).</a:t>
             </a:r>
           </a:p>
           <a:p>
@@ -8187,7 +8159,7 @@
                 </a:solidFill>
                 <a:latin typeface="Fira Sans"/>
               </a:rPr>
-              <a:t>El impacto de filas y atípicos se mide con y sin, sobre todos los resúmenes en uso.</a:t>
+              <a:t>Muchos puntos: alpha o hexbin. Colas largas: log.</a:t>
             </a:r>
           </a:p>
           <a:p>
@@ -8215,7 +8187,7 @@
                 </a:solidFill>
                 <a:latin typeface="Fira Sans"/>
               </a:rPr>
-              <a:t>Cuando la conclusión es sobre la ciudad, se pondera: WLS.</a:t>
+              <a:t>El impacto de filas y atípicos se mide con y sin, sobre todos los resúmenes en uso.</a:t>
             </a:r>
           </a:p>
           <a:p>
@@ -8243,7 +8215,7 @@
                 </a:solidFill>
                 <a:latin typeface="Fira Sans"/>
               </a:rPr>
-              <a:t>Muchos puntos: alpha o hexbin. Colas largas: log.</a:t>
+              <a:t>Cuando la conclusión es sobre la ciudad, se pondera: WLS.</a:t>
             </a:r>
           </a:p>
           <a:p>
@@ -8784,7 +8756,7 @@
                 </a:solidFill>
                 <a:latin typeface="Fira Sans"/>
               </a:rPr>
-              <a:t>¿Las comunas de mayor ingreso viajan menos tiempo?</a:t>
+              <a:t>Visualización</a:t>
             </a:r>
           </a:p>
           <a:p>
@@ -8795,7 +8767,7 @@
                 </a:solidFill>
                 <a:latin typeface="Fira Sans"/>
               </a:rPr>
-              <a:t>El modelo inicial (clase 3): explicar la duración media del viaje por comuna con el ingreso medio del hogar, 45 comunas ponderadas. Recta: 38,3 − 4,8 · ingreso</a:t>
+              <a:t>Muchos puntos y colas largas</a:t>
             </a:r>
           </a:p>
         </p:txBody>
@@ -9231,7 +9203,7 @@
             <a:avLst/>
           </a:prstGeom>
           <a:solidFill>
-            <a:srgbClr val="1D3557"/>
+            <a:srgbClr val="FAFBFC"/>
           </a:solidFill>
           <a:ln>
             <a:noFill/>
@@ -9268,8 +9240,8 @@
         </p:nvSpPr>
         <p:spPr>
           <a:xfrm>
-            <a:off x="603504" y="1847088"/>
-            <a:ext cx="7946136" cy="1399032"/>
+            <a:off x="402336" y="301752"/>
+            <a:ext cx="8348472" cy="795528"/>
           </a:xfrm>
           <a:prstGeom prst="rect">
             <a:avLst/>
@@ -9283,24 +9255,71 @@
           <a:lstStyle/>
           <a:p>
             <a:r>
-              <a:rPr sz="3400" b="1">
-                <a:solidFill>
-                  <a:srgbClr val="FFFFFF"/>
-                </a:solidFill>
-                <a:latin typeface="Fira Sans"/>
-              </a:rPr>
-              <a:t>Lo pendiente de la clase 3</a:t>
-            </a:r>
-          </a:p>
-          <a:p>
-            <a:r>
-              <a:rPr sz="1800" b="0">
-                <a:solidFill>
-                  <a:srgbClr val="E0A437"/>
-                </a:solidFill>
-                <a:latin typeface="Fira Sans"/>
-              </a:rPr>
-              <a:t>Del impacto de una fila a la regresión ponderada</a:t>
+              <a:rPr sz="2800" b="1">
+                <a:solidFill>
+                  <a:srgbClr val="0F0F0F"/>
+                </a:solidFill>
+                <a:latin typeface="Fira Sans"/>
+              </a:rPr>
+              <a:t>Graficar 90 mil puntos: overplotting</a:t>
+            </a:r>
+          </a:p>
+        </p:txBody>
+      </p:sp>
+      <p:pic>
+        <p:nvPicPr>
+          <p:cNvPr id="4" name="Picture 3" descr="c3_08_overplotting.png"/>
+          <p:cNvPicPr>
+            <a:picLocks noChangeAspect="1"/>
+          </p:cNvPicPr>
+          <p:nvPr/>
+        </p:nvPicPr>
+        <p:blipFill>
+          <a:blip r:embed="rId2"/>
+          <a:stretch>
+            <a:fillRect/>
+          </a:stretch>
+        </p:blipFill>
+        <p:spPr>
+          <a:xfrm>
+            <a:off x="699515" y="1545618"/>
+            <a:ext cx="7744968" cy="2349444"/>
+          </a:xfrm>
+          <a:prstGeom prst="rect">
+            <a:avLst/>
+          </a:prstGeom>
+        </p:spPr>
+      </p:pic>
+      <p:sp>
+        <p:nvSpPr>
+          <p:cNvPr id="5" name="TextBox 4"/>
+          <p:cNvSpPr txBox="1"/>
+          <p:nvPr/>
+        </p:nvSpPr>
+        <p:spPr>
+          <a:xfrm>
+            <a:off x="704088" y="4434840"/>
+            <a:ext cx="7744968" cy="457200"/>
+          </a:xfrm>
+          <a:prstGeom prst="rect">
+            <a:avLst/>
+          </a:prstGeom>
+          <a:noFill/>
+        </p:spPr>
+        <p:txBody>
+          <a:bodyPr wrap="square">
+            <a:spAutoFit/>
+          </a:bodyPr>
+          <a:lstStyle/>
+          <a:p>
+            <a:r>
+              <a:rPr sz="1300" b="0">
+                <a:solidFill>
+                  <a:srgbClr val="333333"/>
+                </a:solidFill>
+                <a:latin typeface="Fira Sans"/>
+              </a:rPr>
+              <a:t>Con todos los puntos sólidos, el scatter se satura y miente. Los remedios: transparencia (alpha), muestreo, o hexbin, donde el color cuenta los viajes (la distancia viene en la tabla DistanciaViaje.csv; sus −1 son faltantes disfrazados).</a:t>
             </a:r>
           </a:p>
         </p:txBody>
@@ -9396,14 +9415,14 @@
                 </a:solidFill>
                 <a:latin typeface="Fira Sans"/>
               </a:rPr>
-              <a:t>El impacto de sacar una fila</a:t>
+              <a:t>Cuándo usar escala logarítmica</a:t>
             </a:r>
           </a:p>
         </p:txBody>
       </p:sp>
       <p:pic>
         <p:nvPicPr>
-          <p:cNvPr id="4" name="Picture 3" descr="c4_06_impacto_fila.png"/>
+          <p:cNvPr id="4" name="Picture 3" descr="c3_10_escala_log.png"/>
           <p:cNvPicPr>
             <a:picLocks noChangeAspect="1"/>
           </p:cNvPicPr>
@@ -9417,8 +9436,8 @@
         </p:blipFill>
         <p:spPr>
           <a:xfrm>
-            <a:off x="1353768" y="1143000"/>
-            <a:ext cx="6436462" cy="3154680"/>
+            <a:off x="699515" y="1227136"/>
+            <a:ext cx="7744968" cy="2986407"/>
           </a:xfrm>
           <a:prstGeom prst="rect">
             <a:avLst/>
@@ -9454,7 +9473,7 @@
                 </a:solidFill>
                 <a:latin typeface="Fira Sans"/>
               </a:rPr>
-              <a:t>Medirlo es recalcular con y sin: r casi no se mueve (−0,34), pero la pendiente cambia en un quinto, de −4,8 a −5,8 minutos por millón. Cada resumen tiene su propia sensibilidad.</a:t>
+              <a:t>La misma distancia tiene cola larga: en lineal se aplasta; en log, la forma aparece. Y transformar con log es feature engineering clásico: vuelve lineales las relaciones multiplicativas.</a:t>
             </a:r>
           </a:p>
         </p:txBody>
@@ -9550,14 +9569,14 @@
                 </a:solidFill>
                 <a:latin typeface="Fira Sans"/>
               </a:rPr>
-              <a:t>Las fórmulas, con factor de expansión</a:t>
+              <a:t>El mismo gráfico, dos veces</a:t>
             </a:r>
           </a:p>
         </p:txBody>
       </p:sp>
       <p:pic>
         <p:nvPicPr>
-          <p:cNvPr id="4" name="Picture 3" descr="c3_22_formulas_ponderada.png"/>
+          <p:cNvPr id="4" name="Picture 3" descr="c3_16_mal_buen_grafico.png"/>
           <p:cNvPicPr>
             <a:picLocks noChangeAspect="1"/>
           </p:cNvPicPr>
@@ -9571,8 +9590,8 @@
         </p:blipFill>
         <p:spPr>
           <a:xfrm>
-            <a:off x="699515" y="1342115"/>
-            <a:ext cx="7744968" cy="2756450"/>
+            <a:off x="699515" y="1217944"/>
+            <a:ext cx="7744968" cy="3004790"/>
           </a:xfrm>
           <a:prstGeom prst="rect">
             <a:avLst/>
@@ -9608,7 +9627,7 @@
                 </a:solidFill>
                 <a:latin typeface="Fira Sans"/>
               </a:rPr>
-              <a:t>La misma recta de mínimos cuadrados, con cada término pesado por su factor: es la que usa el modelo que sigue, y en statsmodels se llama WLS (weighted least squares).</a:t>
+              <a:t>Los mismos 30 mil viajes: sin rotular y saturado, contra rotulado, con transparencia y con el hallazgo en el título.</a:t>
             </a:r>
           </a:p>
         </p:txBody>
@@ -9646,7 +9665,7 @@
             <a:avLst/>
           </a:prstGeom>
           <a:solidFill>
-            <a:srgbClr val="1D3557"/>
+            <a:srgbClr val="FAFBFC"/>
           </a:solidFill>
           <a:ln>
             <a:noFill/>
@@ -9683,8 +9702,8 @@
         </p:nvSpPr>
         <p:spPr>
           <a:xfrm>
-            <a:off x="603504" y="1847088"/>
-            <a:ext cx="7946136" cy="1399032"/>
+            <a:off x="402336" y="301752"/>
+            <a:ext cx="8348472" cy="795528"/>
           </a:xfrm>
           <a:prstGeom prst="rect">
             <a:avLst/>
@@ -9698,24 +9717,148 @@
           <a:lstStyle/>
           <a:p>
             <a:r>
-              <a:rPr sz="3400" b="1">
-                <a:solidFill>
-                  <a:srgbClr val="FFFFFF"/>
-                </a:solidFill>
-                <a:latin typeface="Fira Sans"/>
-              </a:rPr>
-              <a:t>¿Cuántos vehículos tiene un hogar según su ingreso?</a:t>
-            </a:r>
-          </a:p>
-          <a:p>
+              <a:rPr sz="2800" b="1">
+                <a:solidFill>
+                  <a:srgbClr val="0F0F0F"/>
+                </a:solidFill>
+                <a:latin typeface="Fira Sans"/>
+              </a:rPr>
+              <a:t>Checklist del buen gráfico</a:t>
+            </a:r>
+          </a:p>
+        </p:txBody>
+      </p:sp>
+      <p:sp>
+        <p:nvSpPr>
+          <p:cNvPr id="4" name="TextBox 3"/>
+          <p:cNvSpPr txBox="1"/>
+          <p:nvPr/>
+        </p:nvSpPr>
+        <p:spPr>
+          <a:xfrm>
+            <a:off x="704088" y="1353312"/>
+            <a:ext cx="7744968" cy="3300984"/>
+          </a:xfrm>
+          <a:prstGeom prst="rect">
+            <a:avLst/>
+          </a:prstGeom>
+          <a:noFill/>
+        </p:spPr>
+        <p:txBody>
+          <a:bodyPr wrap="square">
+            <a:spAutoFit/>
+          </a:bodyPr>
+          <a:lstStyle/>
+          <a:p>
+            <a:pPr>
+              <a:lnSpc>
+                <a:spcPct val="112000"/>
+              </a:lnSpc>
+              <a:spcAft>
+                <a:spcPts val="900"/>
+              </a:spcAft>
+            </a:pPr>
+            <a:r>
+              <a:rPr sz="1800" b="1">
+                <a:solidFill>
+                  <a:srgbClr val="E0A437"/>
+                </a:solidFill>
+                <a:latin typeface="Fira Sans"/>
+              </a:rPr>
+              <a:t>▸ </a:t>
+            </a:r>
             <a:r>
               <a:rPr sz="1800" b="0">
                 <a:solidFill>
+                  <a:srgbClr val="000000"/>
+                </a:solidFill>
+                <a:latin typeface="Fira Sans"/>
+              </a:rPr>
+              <a:t>Título adecuado: dice qué muestra el gráfico.</a:t>
+            </a:r>
+          </a:p>
+          <a:p>
+            <a:pPr>
+              <a:lnSpc>
+                <a:spcPct val="112000"/>
+              </a:lnSpc>
+              <a:spcAft>
+                <a:spcPts val="900"/>
+              </a:spcAft>
+            </a:pPr>
+            <a:r>
+              <a:rPr sz="1800" b="1">
+                <a:solidFill>
                   <a:srgbClr val="E0A437"/>
                 </a:solidFill>
                 <a:latin typeface="Fira Sans"/>
               </a:rPr>
-              <a:t>Explicar los vehículos del hogar con el ingreso: 18.264 hogares, ponderados por su factor</a:t>
+              <a:t>▸ </a:t>
+            </a:r>
+            <a:r>
+              <a:rPr sz="1800" b="0">
+                <a:solidFill>
+                  <a:srgbClr val="000000"/>
+                </a:solidFill>
+                <a:latin typeface="Fira Sans"/>
+              </a:rPr>
+              <a:t>Ejes con nombre y unidad; ejes que parten de cero en gráficos de barras.</a:t>
+            </a:r>
+          </a:p>
+          <a:p>
+            <a:pPr>
+              <a:lnSpc>
+                <a:spcPct val="112000"/>
+              </a:lnSpc>
+              <a:spcAft>
+                <a:spcPts val="900"/>
+              </a:spcAft>
+            </a:pPr>
+            <a:r>
+              <a:rPr sz="1800" b="1">
+                <a:solidFill>
+                  <a:srgbClr val="E0A437"/>
+                </a:solidFill>
+                <a:latin typeface="Fira Sans"/>
+              </a:rPr>
+              <a:t>▸ </a:t>
+            </a:r>
+            <a:r>
+              <a:rPr sz="1800" b="0">
+                <a:solidFill>
+                  <a:srgbClr val="000000"/>
+                </a:solidFill>
+                <a:latin typeface="Fira Sans"/>
+              </a:rPr>
+              <a:t>Muchos puntos: alpha, muestreo o hexbin.</a:t>
+            </a:r>
+          </a:p>
+          <a:p>
+            <a:pPr>
+              <a:lnSpc>
+                <a:spcPct val="112000"/>
+              </a:lnSpc>
+              <a:spcAft>
+                <a:spcPts val="900"/>
+              </a:spcAft>
+            </a:pPr>
+            <a:r>
+              <a:rPr sz="1800" b="1">
+                <a:solidFill>
+                  <a:srgbClr val="E0A437"/>
+                </a:solidFill>
+                <a:latin typeface="Fira Sans"/>
+              </a:rPr>
+              <a:t>▸ </a:t>
+            </a:r>
+            <a:r>
+              <a:rPr sz="1800" b="0">
+                <a:solidFill>
+                  <a:srgbClr val="000000"/>
+                </a:solidFill>
+                <a:latin typeface="Fira Sans"/>
+              </a:rPr>
+              <a:t>Colas largas: escala logarítmica o eje recortado, declarándolo.</a:t>
             </a:r>
           </a:p>
         </p:txBody>
@@ -9753,7 +9896,7 @@
             <a:avLst/>
           </a:prstGeom>
           <a:solidFill>
-            <a:srgbClr val="FAFBFC"/>
+            <a:srgbClr val="1D3557"/>
           </a:solidFill>
           <a:ln>
             <a:noFill/>
@@ -9790,8 +9933,8 @@
         </p:nvSpPr>
         <p:spPr>
           <a:xfrm>
-            <a:off x="402336" y="301752"/>
-            <a:ext cx="8348472" cy="795528"/>
+            <a:off x="603504" y="1847088"/>
+            <a:ext cx="7946136" cy="1399032"/>
           </a:xfrm>
           <a:prstGeom prst="rect">
             <a:avLst/>
@@ -9805,167 +9948,24 @@
           <a:lstStyle/>
           <a:p>
             <a:r>
-              <a:rPr sz="2800" b="1">
-                <a:solidFill>
-                  <a:srgbClr val="0F0F0F"/>
-                </a:solidFill>
-                <a:latin typeface="Fira Sans"/>
-              </a:rPr>
-              <a:t>Otro modelo: la motorización del hogar</a:t>
-            </a:r>
-          </a:p>
-        </p:txBody>
-      </p:sp>
-      <p:sp>
-        <p:nvSpPr>
-          <p:cNvPr id="4" name="Rectangle 3"/>
-          <p:cNvSpPr/>
-          <p:nvPr/>
-        </p:nvSpPr>
-        <p:spPr>
-          <a:xfrm>
-            <a:off x="704088" y="1280160"/>
-            <a:ext cx="7744968" cy="2880360"/>
-          </a:xfrm>
-          <a:prstGeom prst="rect">
-            <a:avLst/>
-          </a:prstGeom>
-          <a:solidFill>
-            <a:srgbClr val="F0F2F5"/>
-          </a:solidFill>
-          <a:ln>
-            <a:solidFill>
-              <a:srgbClr val="D8DDE3"/>
-            </a:solidFill>
-          </a:ln>
-          <a:effectLst/>
-        </p:spPr>
-        <p:style>
-          <a:lnRef idx="1">
-            <a:schemeClr val="accent1"/>
-          </a:lnRef>
-          <a:fillRef idx="3">
-            <a:schemeClr val="accent1"/>
-          </a:fillRef>
-          <a:effectRef idx="2">
-            <a:schemeClr val="accent1"/>
-          </a:effectRef>
-          <a:fontRef idx="minor">
-            <a:schemeClr val="lt1"/>
-          </a:fontRef>
-        </p:style>
-        <p:txBody>
-          <a:bodyPr rtlCol="0" anchor="ctr" wrap="square" lIns="228600" tIns="137160"/>
-          <a:lstStyle/>
-          <a:p>
-            <a:pPr/>
-            <a:r>
-              <a:rPr sz="1500" b="0">
-                <a:solidFill>
-                  <a:srgbClr val="1D3557"/>
-                </a:solidFill>
-                <a:latin typeface="Menlo"/>
-              </a:rPr>
-              <a:t>x = h["IngresoHogar"] / 1e6</a:t>
-            </a:r>
-          </a:p>
-          <a:p>
-            <a:pPr/>
-            <a:r>
-              <a:rPr sz="1500" b="0">
-                <a:solidFill>
-                  <a:srgbClr val="1D3557"/>
-                </a:solidFill>
-                <a:latin typeface="Menlo"/>
-              </a:rPr>
-              <a:t>y, w = h["NumVeh"], h["Factor"]</a:t>
-            </a:r>
-          </a:p>
-          <a:p>
-            <a:pPr/>
-            <a:r>
-              <a:rPr sz="1500" b="0">
-                <a:solidFill>
-                  <a:srgbClr val="1D3557"/>
-                </a:solidFill>
-                <a:latin typeface="Menlo"/>
-              </a:rPr>
-              <a:t/>
-            </a:r>
-          </a:p>
-          <a:p>
-            <a:pPr/>
-            <a:r>
-              <a:rPr sz="1500" b="0">
-                <a:solidFill>
-                  <a:srgbClr val="1D3557"/>
-                </a:solidFill>
-                <a:latin typeface="Menlo"/>
-              </a:rPr>
-              <a:t># La fórmula de la pendiente ponderada, tal cual</a:t>
-            </a:r>
-          </a:p>
-          <a:p>
-            <a:pPr/>
-            <a:r>
-              <a:rPr sz="1500" b="0">
-                <a:solidFill>
-                  <a:srgbClr val="1D3557"/>
-                </a:solidFill>
-                <a:latin typeface="Menlo"/>
-              </a:rPr>
-              <a:t>b = (w*(x - xw)*(y - yw)).sum() / (w*(x - xw)**2).sum()</a:t>
-            </a:r>
-          </a:p>
-        </p:txBody>
-      </p:sp>
-      <p:sp>
-        <p:nvSpPr>
-          <p:cNvPr id="5" name="TextBox 4"/>
-          <p:cNvSpPr txBox="1"/>
-          <p:nvPr/>
-        </p:nvSpPr>
-        <p:spPr>
-          <a:xfrm>
-            <a:off x="704088" y="4389120"/>
-            <a:ext cx="7744968" cy="1097280"/>
-          </a:xfrm>
-          <a:prstGeom prst="rect">
-            <a:avLst/>
-          </a:prstGeom>
-          <a:noFill/>
-        </p:spPr>
-        <p:txBody>
-          <a:bodyPr wrap="square">
-            <a:spAutoFit/>
-          </a:bodyPr>
-          <a:lstStyle/>
-          <a:p>
-            <a:pPr>
-              <a:lnSpc>
-                <a:spcPct val="112000"/>
-              </a:lnSpc>
-              <a:spcAft>
-                <a:spcPts val="900"/>
-              </a:spcAft>
-            </a:pPr>
-            <a:r>
-              <a:rPr sz="1600" b="1">
+              <a:rPr sz="3400" b="1">
+                <a:solidFill>
+                  <a:srgbClr val="FFFFFF"/>
+                </a:solidFill>
+                <a:latin typeface="Fira Sans"/>
+              </a:rPr>
+              <a:t>Lo pendiente de la clase 3</a:t>
+            </a:r>
+          </a:p>
+          <a:p>
+            <a:r>
+              <a:rPr sz="1800" b="0">
                 <a:solidFill>
                   <a:srgbClr val="E0A437"/>
                 </a:solidFill>
                 <a:latin typeface="Fira Sans"/>
               </a:rPr>
-              <a:t>▸ </a:t>
-            </a:r>
-            <a:r>
-              <a:rPr sz="1600" b="0">
-                <a:solidFill>
-                  <a:srgbClr val="000000"/>
-                </a:solidFill>
-                <a:latin typeface="Fira Sans"/>
-              </a:rPr>
-              <a:t>18.264 hogares reales, ponderados por su factor: vehículos = 0,20 + 0,50 · ingreso. Medio vehículo más por cada millón.</a:t>
+              <a:t>Del impacto de una fila a la regresión ponderada</a:t>
             </a:r>
           </a:p>
         </p:txBody>

</xml_diff>

<commit_message>
Deck clase 4: scatter de hogares con las dos rectas para el impacto de los atipicos de y
Co-Authored-By: Claude Fable 5 <noreply@anthropic.com>
</commit_message>
<xml_diff>
--- a/presentaciones/clase04_regresion_multiple.pptx
+++ b/presentaciones/clase04_regresion_multiple.pptx
@@ -46,6 +46,7 @@
     <p:sldId id="294" r:id="rId45"/>
     <p:sldId id="295" r:id="rId46"/>
     <p:sldId id="296" r:id="rId47"/>
+    <p:sldId id="297" r:id="rId48"/>
   </p:sldIdLst>
   <p:sldSz cx="9144000" cy="5138928" type="screen4x3"/>
   <p:notesSz cx="6858000" cy="9144000"/>
@@ -4581,7 +4582,7 @@
             <a:avLst/>
           </a:prstGeom>
           <a:solidFill>
-            <a:srgbClr val="1D3557"/>
+            <a:srgbClr val="FAFBFC"/>
           </a:solidFill>
           <a:ln>
             <a:noFill/>
@@ -4618,8 +4619,8 @@
         </p:nvSpPr>
         <p:spPr>
           <a:xfrm>
-            <a:off x="603504" y="1847088"/>
-            <a:ext cx="7946136" cy="1399032"/>
+            <a:off x="402336" y="301752"/>
+            <a:ext cx="8348472" cy="795528"/>
           </a:xfrm>
           <a:prstGeom prst="rect">
             <a:avLst/>
@@ -4633,24 +4634,71 @@
           <a:lstStyle/>
           <a:p>
             <a:r>
-              <a:rPr sz="3400" b="1">
-                <a:solidFill>
-                  <a:srgbClr val="FFFFFF"/>
-                </a:solidFill>
-                <a:latin typeface="Fira Sans"/>
-              </a:rPr>
-              <a:t>Regresión múltiple</a:t>
-            </a:r>
-          </a:p>
-          <a:p>
-            <a:r>
-              <a:rPr sz="1800" b="0">
-                <a:solidFill>
-                  <a:srgbClr val="E0A437"/>
-                </a:solidFill>
-                <a:latin typeface="Fira Sans"/>
-              </a:rPr>
-              <a:t>El primer modelo con varias variables</a:t>
+              <a:rPr sz="2800" b="1">
+                <a:solidFill>
+                  <a:srgbClr val="0F0F0F"/>
+                </a:solidFill>
+                <a:latin typeface="Fira Sans"/>
+              </a:rPr>
+              <a:t>El impacto, dibujado: las dos rectas</a:t>
+            </a:r>
+          </a:p>
+        </p:txBody>
+      </p:sp>
+      <p:pic>
+        <p:nvPicPr>
+          <p:cNvPr id="4" name="Picture 3" descr="c4_14_impacto_atipicos.png"/>
+          <p:cNvPicPr>
+            <a:picLocks noChangeAspect="1"/>
+          </p:cNvPicPr>
+          <p:nvPr/>
+        </p:nvPicPr>
+        <p:blipFill>
+          <a:blip r:embed="rId2"/>
+          <a:stretch>
+            <a:fillRect/>
+          </a:stretch>
+        </p:blipFill>
+        <p:spPr>
+          <a:xfrm>
+            <a:off x="1355268" y="1143000"/>
+            <a:ext cx="6433462" cy="3154680"/>
+          </a:xfrm>
+          <a:prstGeom prst="rect">
+            <a:avLst/>
+          </a:prstGeom>
+        </p:spPr>
+      </p:pic>
+      <p:sp>
+        <p:nvSpPr>
+          <p:cNvPr id="5" name="TextBox 4"/>
+          <p:cNvSpPr txBox="1"/>
+          <p:nvPr/>
+        </p:nvSpPr>
+        <p:spPr>
+          <a:xfrm>
+            <a:off x="704088" y="4434840"/>
+            <a:ext cx="7744968" cy="457200"/>
+          </a:xfrm>
+          <a:prstGeom prst="rect">
+            <a:avLst/>
+          </a:prstGeom>
+          <a:noFill/>
+        </p:spPr>
+        <p:txBody>
+          <a:bodyPr wrap="square">
+            <a:spAutoFit/>
+          </a:bodyPr>
+          <a:lstStyle/>
+          <a:p>
+            <a:r>
+              <a:rPr sz="1300" b="0">
+                <a:solidFill>
+                  <a:srgbClr val="333333"/>
+                </a:solidFill>
+                <a:latin typeface="Fira Sans"/>
+              </a:rPr>
+              <a:t>Al perder los puntos dorados de arriba, la recta punteada gira hacia abajo: de 0,50 a 0,44 vehículos por millón. El modelo queda ciego justo a los hogares más motorizados, el fenómeno que quería capturar.</a:t>
             </a:r>
           </a:p>
         </p:txBody>
@@ -4688,7 +4736,7 @@
             <a:avLst/>
           </a:prstGeom>
           <a:solidFill>
-            <a:srgbClr val="FAFBFC"/>
+            <a:srgbClr val="1D3557"/>
           </a:solidFill>
           <a:ln>
             <a:noFill/>
@@ -4725,8 +4773,8 @@
         </p:nvSpPr>
         <p:spPr>
           <a:xfrm>
-            <a:off x="402336" y="301752"/>
-            <a:ext cx="8348472" cy="795528"/>
+            <a:off x="603504" y="1847088"/>
+            <a:ext cx="7946136" cy="1399032"/>
           </a:xfrm>
           <a:prstGeom prst="rect">
             <a:avLst/>
@@ -4740,71 +4788,24 @@
           <a:lstStyle/>
           <a:p>
             <a:r>
-              <a:rPr sz="2800" b="1">
-                <a:solidFill>
-                  <a:srgbClr val="0F0F0F"/>
-                </a:solidFill>
-                <a:latin typeface="Fira Sans"/>
-              </a:rPr>
-              <a:t>La fórmula de la regresión múltiple</a:t>
-            </a:r>
-          </a:p>
-        </p:txBody>
-      </p:sp>
-      <p:pic>
-        <p:nvPicPr>
-          <p:cNvPr id="4" name="Picture 3" descr="c4_01_formula_multiple.png"/>
-          <p:cNvPicPr>
-            <a:picLocks noChangeAspect="1"/>
-          </p:cNvPicPr>
-          <p:nvPr/>
-        </p:nvPicPr>
-        <p:blipFill>
-          <a:blip r:embed="rId2"/>
-          <a:stretch>
-            <a:fillRect/>
-          </a:stretch>
-        </p:blipFill>
-        <p:spPr>
-          <a:xfrm>
-            <a:off x="699515" y="1500263"/>
-            <a:ext cx="7744968" cy="2440154"/>
-          </a:xfrm>
-          <a:prstGeom prst="rect">
-            <a:avLst/>
-          </a:prstGeom>
-        </p:spPr>
-      </p:pic>
-      <p:sp>
-        <p:nvSpPr>
-          <p:cNvPr id="5" name="TextBox 4"/>
-          <p:cNvSpPr txBox="1"/>
-          <p:nvPr/>
-        </p:nvSpPr>
-        <p:spPr>
-          <a:xfrm>
-            <a:off x="704088" y="4434840"/>
-            <a:ext cx="7744968" cy="457200"/>
-          </a:xfrm>
-          <a:prstGeom prst="rect">
-            <a:avLst/>
-          </a:prstGeom>
-          <a:noFill/>
-        </p:spPr>
-        <p:txBody>
-          <a:bodyPr wrap="square">
-            <a:spAutoFit/>
-          </a:bodyPr>
-          <a:lstStyle/>
-          <a:p>
-            <a:r>
-              <a:rPr sz="1300" b="0">
-                <a:solidFill>
-                  <a:srgbClr val="333333"/>
-                </a:solidFill>
-                <a:latin typeface="Fira Sans"/>
-              </a:rPr>
-              <a:t>Cada coeficiente aísla el efecto de su variable: cuánto cambia la predicción por una unidad de esa x, manteniendo las demás constantes.</a:t>
+              <a:rPr sz="3400" b="1">
+                <a:solidFill>
+                  <a:srgbClr val="FFFFFF"/>
+                </a:solidFill>
+                <a:latin typeface="Fira Sans"/>
+              </a:rPr>
+              <a:t>Regresión múltiple</a:t>
+            </a:r>
+          </a:p>
+          <a:p>
+            <a:r>
+              <a:rPr sz="1800" b="0">
+                <a:solidFill>
+                  <a:srgbClr val="E0A437"/>
+                </a:solidFill>
+                <a:latin typeface="Fira Sans"/>
+              </a:rPr>
+              <a:t>El primer modelo con varias variables</a:t>
             </a:r>
           </a:p>
         </p:txBody>
@@ -4842,7 +4843,7 @@
             <a:avLst/>
           </a:prstGeom>
           <a:solidFill>
-            <a:srgbClr val="1D3557"/>
+            <a:srgbClr val="FAFBFC"/>
           </a:solidFill>
           <a:ln>
             <a:noFill/>
@@ -4879,8 +4880,8 @@
         </p:nvSpPr>
         <p:spPr>
           <a:xfrm>
-            <a:off x="603504" y="1847088"/>
-            <a:ext cx="7946136" cy="1399032"/>
+            <a:off x="402336" y="301752"/>
+            <a:ext cx="8348472" cy="795528"/>
           </a:xfrm>
           <a:prstGeom prst="rect">
             <a:avLst/>
@@ -4894,24 +4895,71 @@
           <a:lstStyle/>
           <a:p>
             <a:r>
-              <a:rPr sz="3400" b="1">
-                <a:solidFill>
-                  <a:srgbClr val="FFFFFF"/>
-                </a:solidFill>
-                <a:latin typeface="Fira Sans"/>
-              </a:rPr>
-              <a:t>¿Mejora el modelo si agregamos el tamaño del hogar?</a:t>
-            </a:r>
-          </a:p>
-          <a:p>
-            <a:r>
-              <a:rPr sz="1800" b="0">
-                <a:solidFill>
-                  <a:srgbClr val="E0A437"/>
-                </a:solidFill>
-                <a:latin typeface="Fira Sans"/>
-              </a:rPr>
-              <a:t>Explicar los vehículos con el ingreso y las personas: la primera regresión múltiple</a:t>
+              <a:rPr sz="2800" b="1">
+                <a:solidFill>
+                  <a:srgbClr val="0F0F0F"/>
+                </a:solidFill>
+                <a:latin typeface="Fira Sans"/>
+              </a:rPr>
+              <a:t>La fórmula de la regresión múltiple</a:t>
+            </a:r>
+          </a:p>
+        </p:txBody>
+      </p:sp>
+      <p:pic>
+        <p:nvPicPr>
+          <p:cNvPr id="4" name="Picture 3" descr="c4_01_formula_multiple.png"/>
+          <p:cNvPicPr>
+            <a:picLocks noChangeAspect="1"/>
+          </p:cNvPicPr>
+          <p:nvPr/>
+        </p:nvPicPr>
+        <p:blipFill>
+          <a:blip r:embed="rId2"/>
+          <a:stretch>
+            <a:fillRect/>
+          </a:stretch>
+        </p:blipFill>
+        <p:spPr>
+          <a:xfrm>
+            <a:off x="699515" y="1500263"/>
+            <a:ext cx="7744968" cy="2440154"/>
+          </a:xfrm>
+          <a:prstGeom prst="rect">
+            <a:avLst/>
+          </a:prstGeom>
+        </p:spPr>
+      </p:pic>
+      <p:sp>
+        <p:nvSpPr>
+          <p:cNvPr id="5" name="TextBox 4"/>
+          <p:cNvSpPr txBox="1"/>
+          <p:nvPr/>
+        </p:nvSpPr>
+        <p:spPr>
+          <a:xfrm>
+            <a:off x="704088" y="4434840"/>
+            <a:ext cx="7744968" cy="457200"/>
+          </a:xfrm>
+          <a:prstGeom prst="rect">
+            <a:avLst/>
+          </a:prstGeom>
+          <a:noFill/>
+        </p:spPr>
+        <p:txBody>
+          <a:bodyPr wrap="square">
+            <a:spAutoFit/>
+          </a:bodyPr>
+          <a:lstStyle/>
+          <a:p>
+            <a:r>
+              <a:rPr sz="1300" b="0">
+                <a:solidFill>
+                  <a:srgbClr val="333333"/>
+                </a:solidFill>
+                <a:latin typeface="Fira Sans"/>
+              </a:rPr>
+              <a:t>Cada coeficiente aísla el efecto de su variable: cuánto cambia la predicción por una unidad de esa x, manteniendo las demás constantes.</a:t>
             </a:r>
           </a:p>
         </p:txBody>
@@ -5152,7 +5200,7 @@
             <a:avLst/>
           </a:prstGeom>
           <a:solidFill>
-            <a:srgbClr val="FAFBFC"/>
+            <a:srgbClr val="1D3557"/>
           </a:solidFill>
           <a:ln>
             <a:noFill/>
@@ -5189,8 +5237,8 @@
         </p:nvSpPr>
         <p:spPr>
           <a:xfrm>
-            <a:off x="402336" y="301752"/>
-            <a:ext cx="8348472" cy="795528"/>
+            <a:off x="603504" y="1847088"/>
+            <a:ext cx="7946136" cy="1399032"/>
           </a:xfrm>
           <a:prstGeom prst="rect">
             <a:avLst/>
@@ -5204,167 +5252,24 @@
           <a:lstStyle/>
           <a:p>
             <a:r>
-              <a:rPr sz="2800" b="1">
-                <a:solidFill>
-                  <a:srgbClr val="0F0F0F"/>
-                </a:solidFill>
-                <a:latin typeface="Fira Sans"/>
-              </a:rPr>
-              <a:t>La motorización, con dos variables</a:t>
-            </a:r>
-          </a:p>
-        </p:txBody>
-      </p:sp>
-      <p:sp>
-        <p:nvSpPr>
-          <p:cNvPr id="4" name="Rectangle 3"/>
-          <p:cNvSpPr/>
-          <p:nvPr/>
-        </p:nvSpPr>
-        <p:spPr>
-          <a:xfrm>
-            <a:off x="704088" y="1280160"/>
-            <a:ext cx="7744968" cy="2880360"/>
-          </a:xfrm>
-          <a:prstGeom prst="rect">
-            <a:avLst/>
-          </a:prstGeom>
-          <a:solidFill>
-            <a:srgbClr val="F0F2F5"/>
-          </a:solidFill>
-          <a:ln>
-            <a:solidFill>
-              <a:srgbClr val="D8DDE3"/>
-            </a:solidFill>
-          </a:ln>
-          <a:effectLst/>
-        </p:spPr>
-        <p:style>
-          <a:lnRef idx="1">
-            <a:schemeClr val="accent1"/>
-          </a:lnRef>
-          <a:fillRef idx="3">
-            <a:schemeClr val="accent1"/>
-          </a:fillRef>
-          <a:effectRef idx="2">
-            <a:schemeClr val="accent1"/>
-          </a:effectRef>
-          <a:fontRef idx="minor">
-            <a:schemeClr val="lt1"/>
-          </a:fontRef>
-        </p:style>
-        <p:txBody>
-          <a:bodyPr rtlCol="0" anchor="ctr" wrap="square" lIns="228600" tIns="137160"/>
-          <a:lstStyle/>
-          <a:p>
-            <a:pPr/>
-            <a:r>
-              <a:rPr sz="1500" b="0">
-                <a:solidFill>
-                  <a:srgbClr val="1D3557"/>
-                </a:solidFill>
-                <a:latin typeface="Menlo"/>
-              </a:rPr>
-              <a:t># Explicar los vehículos del hogar con el ingreso y las personas</a:t>
-            </a:r>
-          </a:p>
-          <a:p>
-            <a:pPr/>
-            <a:r>
-              <a:rPr sz="1500" b="0">
-                <a:solidFill>
-                  <a:srgbClr val="1D3557"/>
-                </a:solidFill>
-                <a:latin typeface="Menlo"/>
-              </a:rPr>
-              <a:t>X = sm.add_constant(pd.DataFrame({</a:t>
-            </a:r>
-          </a:p>
-          <a:p>
-            <a:pPr/>
-            <a:r>
-              <a:rPr sz="1500" b="0">
-                <a:solidFill>
-                  <a:srgbClr val="1D3557"/>
-                </a:solidFill>
-                <a:latin typeface="Menlo"/>
-              </a:rPr>
-              <a:t>    "ingreso": h["IngresoHogar"] / 1e6,</a:t>
-            </a:r>
-          </a:p>
-          <a:p>
-            <a:pPr/>
-            <a:r>
-              <a:rPr sz="1500" b="0">
-                <a:solidFill>
-                  <a:srgbClr val="1D3557"/>
-                </a:solidFill>
-                <a:latin typeface="Menlo"/>
-              </a:rPr>
-              <a:t>    "personas": h["NumPer"]}))</a:t>
-            </a:r>
-          </a:p>
-          <a:p>
-            <a:pPr/>
-            <a:r>
-              <a:rPr sz="1500" b="0">
-                <a:solidFill>
-                  <a:srgbClr val="1D3557"/>
-                </a:solidFill>
-                <a:latin typeface="Menlo"/>
-              </a:rPr>
-              <a:t>modelo = sm.WLS(h["NumVeh"], X, weights=h["Factor"]).fit()</a:t>
-            </a:r>
-          </a:p>
-        </p:txBody>
-      </p:sp>
-      <p:sp>
-        <p:nvSpPr>
-          <p:cNvPr id="5" name="TextBox 4"/>
-          <p:cNvSpPr txBox="1"/>
-          <p:nvPr/>
-        </p:nvSpPr>
-        <p:spPr>
-          <a:xfrm>
-            <a:off x="704088" y="4389120"/>
-            <a:ext cx="7744968" cy="1097280"/>
-          </a:xfrm>
-          <a:prstGeom prst="rect">
-            <a:avLst/>
-          </a:prstGeom>
-          <a:noFill/>
-        </p:spPr>
-        <p:txBody>
-          <a:bodyPr wrap="square">
-            <a:spAutoFit/>
-          </a:bodyPr>
-          <a:lstStyle/>
-          <a:p>
-            <a:pPr>
-              <a:lnSpc>
-                <a:spcPct val="112000"/>
-              </a:lnSpc>
-              <a:spcAft>
-                <a:spcPts val="900"/>
-              </a:spcAft>
-            </a:pPr>
-            <a:r>
-              <a:rPr sz="1600" b="1">
+              <a:rPr sz="3400" b="1">
+                <a:solidFill>
+                  <a:srgbClr val="FFFFFF"/>
+                </a:solidFill>
+                <a:latin typeface="Fira Sans"/>
+              </a:rPr>
+              <a:t>¿Mejora el modelo si agregamos el tamaño del hogar?</a:t>
+            </a:r>
+          </a:p>
+          <a:p>
+            <a:r>
+              <a:rPr sz="1800" b="0">
                 <a:solidFill>
                   <a:srgbClr val="E0A437"/>
                 </a:solidFill>
                 <a:latin typeface="Fira Sans"/>
               </a:rPr>
-              <a:t>▸ </a:t>
-            </a:r>
-            <a:r>
-              <a:rPr sz="1600" b="0">
-                <a:solidFill>
-                  <a:srgbClr val="000000"/>
-                </a:solidFill>
-                <a:latin typeface="Fira Sans"/>
-              </a:rPr>
-              <a:t>Ponderado: 0,48 vehículos por millón (era 0,50 a solas) y 0,03 por persona extra. El R² sube apenas, de 0,261 a 0,266: agregar variables no siempre aporta.</a:t>
+              <a:t>Explicar los vehículos con el ingreso y las personas: la primera regresión múltiple</a:t>
             </a:r>
           </a:p>
         </p:txBody>
@@ -5460,35 +5365,114 @@
                 </a:solidFill>
                 <a:latin typeface="Fira Sans"/>
               </a:rPr>
-              <a:t>La ecuación ajustada y su lectura</a:t>
-            </a:r>
-          </a:p>
-        </p:txBody>
-      </p:sp>
-      <p:pic>
-        <p:nvPicPr>
-          <p:cNvPr id="4" name="Picture 3" descr="c4_08_ecuacion_motorizacion.png"/>
-          <p:cNvPicPr>
-            <a:picLocks noChangeAspect="1"/>
-          </p:cNvPicPr>
-          <p:nvPr/>
-        </p:nvPicPr>
-        <p:blipFill>
-          <a:blip r:embed="rId2"/>
-          <a:stretch>
-            <a:fillRect/>
-          </a:stretch>
-        </p:blipFill>
-        <p:spPr>
-          <a:xfrm>
-            <a:off x="699515" y="1292657"/>
-            <a:ext cx="7744968" cy="2855366"/>
-          </a:xfrm>
-          <a:prstGeom prst="rect">
-            <a:avLst/>
-          </a:prstGeom>
-        </p:spPr>
-      </p:pic>
+              <a:t>La motorización, con dos variables</a:t>
+            </a:r>
+          </a:p>
+        </p:txBody>
+      </p:sp>
+      <p:sp>
+        <p:nvSpPr>
+          <p:cNvPr id="4" name="Rectangle 3"/>
+          <p:cNvSpPr/>
+          <p:nvPr/>
+        </p:nvSpPr>
+        <p:spPr>
+          <a:xfrm>
+            <a:off x="704088" y="1280160"/>
+            <a:ext cx="7744968" cy="2880360"/>
+          </a:xfrm>
+          <a:prstGeom prst="rect">
+            <a:avLst/>
+          </a:prstGeom>
+          <a:solidFill>
+            <a:srgbClr val="F0F2F5"/>
+          </a:solidFill>
+          <a:ln>
+            <a:solidFill>
+              <a:srgbClr val="D8DDE3"/>
+            </a:solidFill>
+          </a:ln>
+          <a:effectLst/>
+        </p:spPr>
+        <p:style>
+          <a:lnRef idx="1">
+            <a:schemeClr val="accent1"/>
+          </a:lnRef>
+          <a:fillRef idx="3">
+            <a:schemeClr val="accent1"/>
+          </a:fillRef>
+          <a:effectRef idx="2">
+            <a:schemeClr val="accent1"/>
+          </a:effectRef>
+          <a:fontRef idx="minor">
+            <a:schemeClr val="lt1"/>
+          </a:fontRef>
+        </p:style>
+        <p:txBody>
+          <a:bodyPr rtlCol="0" anchor="ctr" wrap="square" lIns="228600" tIns="137160"/>
+          <a:lstStyle/>
+          <a:p>
+            <a:pPr/>
+            <a:r>
+              <a:rPr sz="1500" b="0">
+                <a:solidFill>
+                  <a:srgbClr val="1D3557"/>
+                </a:solidFill>
+                <a:latin typeface="Menlo"/>
+              </a:rPr>
+              <a:t># Explicar los vehículos del hogar con el ingreso y las personas</a:t>
+            </a:r>
+          </a:p>
+          <a:p>
+            <a:pPr/>
+            <a:r>
+              <a:rPr sz="1500" b="0">
+                <a:solidFill>
+                  <a:srgbClr val="1D3557"/>
+                </a:solidFill>
+                <a:latin typeface="Menlo"/>
+              </a:rPr>
+              <a:t>X = sm.add_constant(pd.DataFrame({</a:t>
+            </a:r>
+          </a:p>
+          <a:p>
+            <a:pPr/>
+            <a:r>
+              <a:rPr sz="1500" b="0">
+                <a:solidFill>
+                  <a:srgbClr val="1D3557"/>
+                </a:solidFill>
+                <a:latin typeface="Menlo"/>
+              </a:rPr>
+              <a:t>    "ingreso": h["IngresoHogar"] / 1e6,</a:t>
+            </a:r>
+          </a:p>
+          <a:p>
+            <a:pPr/>
+            <a:r>
+              <a:rPr sz="1500" b="0">
+                <a:solidFill>
+                  <a:srgbClr val="1D3557"/>
+                </a:solidFill>
+                <a:latin typeface="Menlo"/>
+              </a:rPr>
+              <a:t>    "personas": h["NumPer"]}))</a:t>
+            </a:r>
+          </a:p>
+          <a:p>
+            <a:pPr/>
+            <a:r>
+              <a:rPr sz="1500" b="0">
+                <a:solidFill>
+                  <a:srgbClr val="1D3557"/>
+                </a:solidFill>
+                <a:latin typeface="Menlo"/>
+              </a:rPr>
+              <a:t>modelo = sm.WLS(h["NumVeh"], X, weights=h["Factor"]).fit()</a:t>
+            </a:r>
+          </a:p>
+        </p:txBody>
+      </p:sp>
       <p:sp>
         <p:nvSpPr>
           <p:cNvPr id="5" name="TextBox 4"/>
@@ -5497,8 +5481,8 @@
         </p:nvSpPr>
         <p:spPr>
           <a:xfrm>
-            <a:off x="704088" y="4434840"/>
-            <a:ext cx="7744968" cy="457200"/>
+            <a:off x="704088" y="4389120"/>
+            <a:ext cx="7744968" cy="1097280"/>
           </a:xfrm>
           <a:prstGeom prst="rect">
             <a:avLst/>
@@ -5511,14 +5495,31 @@
           </a:bodyPr>
           <a:lstStyle/>
           <a:p>
-            <a:r>
-              <a:rPr sz="1300" b="0">
-                <a:solidFill>
-                  <a:srgbClr val="333333"/>
-                </a:solidFill>
-                <a:latin typeface="Fira Sans"/>
-              </a:rPr>
-              <a:t>La fórmula de la múltiple con nuestros números: cada coeficiente se lee con las demás variables fijas.</a:t>
+            <a:pPr>
+              <a:lnSpc>
+                <a:spcPct val="112000"/>
+              </a:lnSpc>
+              <a:spcAft>
+                <a:spcPts val="900"/>
+              </a:spcAft>
+            </a:pPr>
+            <a:r>
+              <a:rPr sz="1600" b="1">
+                <a:solidFill>
+                  <a:srgbClr val="E0A437"/>
+                </a:solidFill>
+                <a:latin typeface="Fira Sans"/>
+              </a:rPr>
+              <a:t>▸ </a:t>
+            </a:r>
+            <a:r>
+              <a:rPr sz="1600" b="0">
+                <a:solidFill>
+                  <a:srgbClr val="000000"/>
+                </a:solidFill>
+                <a:latin typeface="Fira Sans"/>
+              </a:rPr>
+              <a:t>Ponderado: 0,48 vehículos por millón (era 0,50 a solas) y 0,03 por persona extra. El R² sube apenas, de 0,261 a 0,266: agregar variables no siempre aporta.</a:t>
             </a:r>
           </a:p>
         </p:txBody>
@@ -5614,14 +5615,14 @@
                 </a:solidFill>
                 <a:latin typeface="Fira Sans"/>
               </a:rPr>
-              <a:t>Leer el modelo: R²</a:t>
+              <a:t>La ecuación ajustada y su lectura</a:t>
             </a:r>
           </a:p>
         </p:txBody>
       </p:sp>
       <p:pic>
         <p:nvPicPr>
-          <p:cNvPr id="4" name="Picture 3" descr="c4_04_formula_r2.png"/>
+          <p:cNvPr id="4" name="Picture 3" descr="c4_08_ecuacion_motorizacion.png"/>
           <p:cNvPicPr>
             <a:picLocks noChangeAspect="1"/>
           </p:cNvPicPr>
@@ -5635,8 +5636,8 @@
         </p:blipFill>
         <p:spPr>
           <a:xfrm>
-            <a:off x="699515" y="1297266"/>
-            <a:ext cx="7744968" cy="2846146"/>
+            <a:off x="699515" y="1292657"/>
+            <a:ext cx="7744968" cy="2855366"/>
           </a:xfrm>
           <a:prstGeom prst="rect">
             <a:avLst/>
@@ -5672,7 +5673,7 @@
                 </a:solidFill>
                 <a:latin typeface="Fira Sans"/>
               </a:rPr>
-              <a:t>Nuestro 0,266: ingreso y personas explican un cuarto de la variabilidad de los vehículos entre hogares. Agregar variables nunca baja el R²; por eso no basta con mirarlo.</a:t>
+              <a:t>La fórmula de la múltiple con nuestros números: cada coeficiente se lee con las demás variables fijas.</a:t>
             </a:r>
           </a:p>
         </p:txBody>
@@ -5768,14 +5769,14 @@
                 </a:solidFill>
                 <a:latin typeface="Fira Sans"/>
               </a:rPr>
-              <a:t>El valor p: dónde vive</a:t>
+              <a:t>Leer el modelo: R²</a:t>
             </a:r>
           </a:p>
         </p:txBody>
       </p:sp>
       <p:pic>
         <p:nvPicPr>
-          <p:cNvPr id="4" name="Picture 3" descr="c4_07_pvalue_summary.png"/>
+          <p:cNvPr id="4" name="Picture 3" descr="c4_04_formula_r2.png"/>
           <p:cNvPicPr>
             <a:picLocks noChangeAspect="1"/>
           </p:cNvPicPr>
@@ -5789,8 +5790,8 @@
         </p:blipFill>
         <p:spPr>
           <a:xfrm>
-            <a:off x="699515" y="1504912"/>
-            <a:ext cx="7744968" cy="2430856"/>
+            <a:off x="699515" y="1297266"/>
+            <a:ext cx="7744968" cy="2846146"/>
           </a:xfrm>
           <a:prstGeom prst="rect">
             <a:avLst/>
@@ -5826,7 +5827,7 @@
                 </a:solidFill>
                 <a:latin typeface="Fira Sans"/>
               </a:rPr>
-              <a:t>Para cada variable, P&gt;|t| responde: si en la ciudad el ingreso (o las personas) no tuviera efecto alguno sobre los vehículos, ¿qué tan raro sería este coeficiente solo por azar de la muestra? Ambos dan 0,000; la clase 5 lo formaliza.</a:t>
+              <a:t>Nuestro 0,266: ingreso y personas explican un cuarto de la variabilidad de los vehículos entre hogares. Agregar variables nunca baja el R²; por eso no basta con mirarlo.</a:t>
             </a:r>
           </a:p>
         </p:txBody>
@@ -5922,14 +5923,14 @@
                 </a:solidFill>
                 <a:latin typeface="Fira Sans"/>
               </a:rPr>
-              <a:t>El mapa para elegir variables</a:t>
+              <a:t>El valor p: dónde vive</a:t>
             </a:r>
           </a:p>
         </p:txBody>
       </p:sp>
       <p:pic>
         <p:nvPicPr>
-          <p:cNvPr id="4" name="Picture 3" descr="c4_05_mapa_candidatas.png"/>
+          <p:cNvPr id="4" name="Picture 3" descr="c4_07_pvalue_summary.png"/>
           <p:cNvPicPr>
             <a:picLocks noChangeAspect="1"/>
           </p:cNvPicPr>
@@ -5943,8 +5944,8 @@
         </p:blipFill>
         <p:spPr>
           <a:xfrm>
-            <a:off x="2530736" y="1143000"/>
-            <a:ext cx="4082527" cy="3154680"/>
+            <a:off x="699515" y="1504912"/>
+            <a:ext cx="7744968" cy="2430856"/>
           </a:xfrm>
           <a:prstGeom prst="rect">
             <a:avLst/>
@@ -5980,7 +5981,7 @@
                 </a:solidFill>
                 <a:latin typeface="Fira Sans"/>
               </a:rPr>
-              <a:t>La fila de NumVeh es el mapa: ingreso 0,47 es el motor; las bicicletas casi no correlacionan con los vehículos (0,06) y son redundantes entre sí (0,83). Probarlas confirma: R² 0,266 a 0,267.</a:t>
+              <a:t>Para cada variable, P&gt;|t| responde: si en la ciudad el ingreso (o las personas) no tuviera efecto alguno sobre los vehículos, ¿qué tan raro sería este coeficiente solo por azar de la muestra? Ambos dan 0,000; la clase 5 lo formaliza.</a:t>
             </a:r>
           </a:p>
         </p:txBody>
@@ -6076,14 +6077,14 @@
                 </a:solidFill>
                 <a:latin typeface="Fira Sans"/>
               </a:rPr>
-              <a:t>Los coeficientes al agregar variables</a:t>
+              <a:t>El mapa para elegir variables</a:t>
             </a:r>
           </a:p>
         </p:txBody>
       </p:sp>
       <p:pic>
         <p:nvPicPr>
-          <p:cNvPr id="4" name="Picture 3" descr="c4_10_cambio_coeficientes.png"/>
+          <p:cNvPr id="4" name="Picture 3" descr="c4_05_mapa_candidatas.png"/>
           <p:cNvPicPr>
             <a:picLocks noChangeAspect="1"/>
           </p:cNvPicPr>
@@ -6097,8 +6098,8 @@
         </p:blipFill>
         <p:spPr>
           <a:xfrm>
-            <a:off x="1051559" y="1143000"/>
-            <a:ext cx="7040880" cy="3154680"/>
+            <a:off x="2530736" y="1143000"/>
+            <a:ext cx="4082527" cy="3154680"/>
           </a:xfrm>
           <a:prstGeom prst="rect">
             <a:avLst/>
@@ -6134,7 +6135,7 @@
                 </a:solidFill>
                 <a:latin typeface="Fira Sans"/>
               </a:rPr>
-              <a:t>El ingreso apenas se mueve (0,50 a 0,48) al agregar personas y bicicletas: es un efecto robusto. Las variables nuevas entran con coeficientes minúsculos y el R² casi no cambia.</a:t>
+              <a:t>La fila de NumVeh es el mapa: ingreso 0,47 es el motor; las bicicletas casi no correlacionan con los vehículos (0,06) y son redundantes entre sí (0,83). Probarlas confirma: R² 0,266 a 0,267.</a:t>
             </a:r>
           </a:p>
         </p:txBody>
@@ -6172,7 +6173,7 @@
             <a:avLst/>
           </a:prstGeom>
           <a:solidFill>
-            <a:srgbClr val="1D3557"/>
+            <a:srgbClr val="FAFBFC"/>
           </a:solidFill>
           <a:ln>
             <a:noFill/>
@@ -6209,8 +6210,8 @@
         </p:nvSpPr>
         <p:spPr>
           <a:xfrm>
-            <a:off x="603504" y="1847088"/>
-            <a:ext cx="7946136" cy="1399032"/>
+            <a:off x="402336" y="301752"/>
+            <a:ext cx="8348472" cy="795528"/>
           </a:xfrm>
           <a:prstGeom prst="rect">
             <a:avLst/>
@@ -6224,24 +6225,71 @@
           <a:lstStyle/>
           <a:p>
             <a:r>
-              <a:rPr sz="3400" b="1">
-                <a:solidFill>
-                  <a:srgbClr val="FFFFFF"/>
-                </a:solidFill>
-                <a:latin typeface="Fira Sans"/>
-              </a:rPr>
-              <a:t>¿De qué depende la duración de un viaje?</a:t>
-            </a:r>
-          </a:p>
-          <a:p>
-            <a:r>
-              <a:rPr sz="1800" b="0">
-                <a:solidFill>
-                  <a:srgbClr val="E0A437"/>
-                </a:solidFill>
-                <a:latin typeface="Fira Sans"/>
-              </a:rPr>
-              <a:t>Lo que ya sabemos (clase 3): correlaciona con la distancia, r = 0,57 y Spearman 0,76. Primera decisión: partir por la distancia, 102 mil viajes de la EOD</a:t>
+              <a:rPr sz="2800" b="1">
+                <a:solidFill>
+                  <a:srgbClr val="0F0F0F"/>
+                </a:solidFill>
+                <a:latin typeface="Fira Sans"/>
+              </a:rPr>
+              <a:t>Los coeficientes al agregar variables</a:t>
+            </a:r>
+          </a:p>
+        </p:txBody>
+      </p:sp>
+      <p:pic>
+        <p:nvPicPr>
+          <p:cNvPr id="4" name="Picture 3" descr="c4_10_cambio_coeficientes.png"/>
+          <p:cNvPicPr>
+            <a:picLocks noChangeAspect="1"/>
+          </p:cNvPicPr>
+          <p:nvPr/>
+        </p:nvPicPr>
+        <p:blipFill>
+          <a:blip r:embed="rId2"/>
+          <a:stretch>
+            <a:fillRect/>
+          </a:stretch>
+        </p:blipFill>
+        <p:spPr>
+          <a:xfrm>
+            <a:off x="1051559" y="1143000"/>
+            <a:ext cx="7040880" cy="3154680"/>
+          </a:xfrm>
+          <a:prstGeom prst="rect">
+            <a:avLst/>
+          </a:prstGeom>
+        </p:spPr>
+      </p:pic>
+      <p:sp>
+        <p:nvSpPr>
+          <p:cNvPr id="5" name="TextBox 4"/>
+          <p:cNvSpPr txBox="1"/>
+          <p:nvPr/>
+        </p:nvSpPr>
+        <p:spPr>
+          <a:xfrm>
+            <a:off x="704088" y="4434840"/>
+            <a:ext cx="7744968" cy="457200"/>
+          </a:xfrm>
+          <a:prstGeom prst="rect">
+            <a:avLst/>
+          </a:prstGeom>
+          <a:noFill/>
+        </p:spPr>
+        <p:txBody>
+          <a:bodyPr wrap="square">
+            <a:spAutoFit/>
+          </a:bodyPr>
+          <a:lstStyle/>
+          <a:p>
+            <a:r>
+              <a:rPr sz="1300" b="0">
+                <a:solidFill>
+                  <a:srgbClr val="333333"/>
+                </a:solidFill>
+                <a:latin typeface="Fira Sans"/>
+              </a:rPr>
+              <a:t>El ingreso apenas se mueve (0,50 a 0,48) al agregar personas y bicicletas: es un efecto robusto. Las variables nuevas entran con coeficientes minúsculos y el R² casi no cambia.</a:t>
             </a:r>
           </a:p>
         </p:txBody>
@@ -6279,7 +6327,7 @@
             <a:avLst/>
           </a:prstGeom>
           <a:solidFill>
-            <a:srgbClr val="FAFBFC"/>
+            <a:srgbClr val="1D3557"/>
           </a:solidFill>
           <a:ln>
             <a:noFill/>
@@ -6316,8 +6364,8 @@
         </p:nvSpPr>
         <p:spPr>
           <a:xfrm>
-            <a:off x="402336" y="301752"/>
-            <a:ext cx="8348472" cy="795528"/>
+            <a:off x="603504" y="1847088"/>
+            <a:ext cx="7946136" cy="1399032"/>
           </a:xfrm>
           <a:prstGeom prst="rect">
             <a:avLst/>
@@ -6331,71 +6379,24 @@
           <a:lstStyle/>
           <a:p>
             <a:r>
-              <a:rPr sz="2800" b="1">
-                <a:solidFill>
-                  <a:srgbClr val="0F0F0F"/>
-                </a:solidFill>
-                <a:latin typeface="Fira Sans"/>
-              </a:rPr>
-              <a:t>La misma regresión, tres veces</a:t>
-            </a:r>
-          </a:p>
-        </p:txBody>
-      </p:sp>
-      <p:pic>
-        <p:nvPicPr>
-          <p:cNvPr id="4" name="Picture 3" descr="c4_02_tres_modelos.png"/>
-          <p:cNvPicPr>
-            <a:picLocks noChangeAspect="1"/>
-          </p:cNvPicPr>
-          <p:nvPr/>
-        </p:nvPicPr>
-        <p:blipFill>
-          <a:blip r:embed="rId2"/>
-          <a:stretch>
-            <a:fillRect/>
-          </a:stretch>
-        </p:blipFill>
-        <p:spPr>
-          <a:xfrm>
-            <a:off x="699515" y="1660639"/>
-            <a:ext cx="7744968" cy="2119400"/>
-          </a:xfrm>
-          <a:prstGeom prst="rect">
-            <a:avLst/>
-          </a:prstGeom>
-        </p:spPr>
-      </p:pic>
-      <p:sp>
-        <p:nvSpPr>
-          <p:cNvPr id="5" name="TextBox 4"/>
-          <p:cNvSpPr txBox="1"/>
-          <p:nvPr/>
-        </p:nvSpPr>
-        <p:spPr>
-          <a:xfrm>
-            <a:off x="704088" y="4434840"/>
-            <a:ext cx="7744968" cy="457200"/>
-          </a:xfrm>
-          <a:prstGeom prst="rect">
-            <a:avLst/>
-          </a:prstGeom>
-          <a:noFill/>
-        </p:spPr>
-        <p:txBody>
-          <a:bodyPr wrap="square">
-            <a:spAutoFit/>
-          </a:bodyPr>
-          <a:lstStyle/>
-          <a:p>
-            <a:r>
-              <a:rPr sz="1300" b="0">
-                <a:solidFill>
-                  <a:srgbClr val="333333"/>
-                </a:solidFill>
-                <a:latin typeface="Fira Sans"/>
-              </a:rPr>
-              <a:t>Decisión 1: transformar con log, porque las dos variables tienen cola larga y en log la nube se endereza: R² de 0,32 a 0,53. Y queda claro que la distancia sola no basta.</a:t>
+              <a:rPr sz="3400" b="1">
+                <a:solidFill>
+                  <a:srgbClr val="FFFFFF"/>
+                </a:solidFill>
+                <a:latin typeface="Fira Sans"/>
+              </a:rPr>
+              <a:t>¿De qué depende la duración de un viaje?</a:t>
+            </a:r>
+          </a:p>
+          <a:p>
+            <a:r>
+              <a:rPr sz="1800" b="0">
+                <a:solidFill>
+                  <a:srgbClr val="E0A437"/>
+                </a:solidFill>
+                <a:latin typeface="Fira Sans"/>
+              </a:rPr>
+              <a:t>Lo que ya sabemos (clase 3): correlaciona con la distancia, r = 0,57 y Spearman 0,76. Primera decisión: partir por la distancia, 102 mil viajes de la EOD</a:t>
             </a:r>
           </a:p>
         </p:txBody>
@@ -6433,7 +6434,7 @@
             <a:avLst/>
           </a:prstGeom>
           <a:solidFill>
-            <a:srgbClr val="1D3557"/>
+            <a:srgbClr val="FAFBFC"/>
           </a:solidFill>
           <a:ln>
             <a:noFill/>
@@ -6470,8 +6471,8 @@
         </p:nvSpPr>
         <p:spPr>
           <a:xfrm>
-            <a:off x="603504" y="1847088"/>
-            <a:ext cx="7946136" cy="1399032"/>
+            <a:off x="402336" y="301752"/>
+            <a:ext cx="8348472" cy="795528"/>
           </a:xfrm>
           <a:prstGeom prst="rect">
             <a:avLst/>
@@ -6485,24 +6486,71 @@
           <a:lstStyle/>
           <a:p>
             <a:r>
-              <a:rPr sz="3400" b="1">
-                <a:solidFill>
-                  <a:srgbClr val="FFFFFF"/>
-                </a:solidFill>
-                <a:latin typeface="Fira Sans"/>
-              </a:rPr>
-              <a:t>¿Y si agregamos más variables?</a:t>
-            </a:r>
-          </a:p>
-          <a:p>
-            <a:r>
-              <a:rPr sz="1800" b="0">
-                <a:solidFill>
-                  <a:srgbClr val="E0A437"/>
-                </a:solidFill>
-                <a:latin typeface="Fira Sans"/>
-              </a:rPr>
-              <a:t>Volvemos a la duración: la distancia explica el 53%. ¿Qué más podría explicarla, y cómo se decide?</a:t>
+              <a:rPr sz="2800" b="1">
+                <a:solidFill>
+                  <a:srgbClr val="0F0F0F"/>
+                </a:solidFill>
+                <a:latin typeface="Fira Sans"/>
+              </a:rPr>
+              <a:t>La misma regresión, tres veces</a:t>
+            </a:r>
+          </a:p>
+        </p:txBody>
+      </p:sp>
+      <p:pic>
+        <p:nvPicPr>
+          <p:cNvPr id="4" name="Picture 3" descr="c4_02_tres_modelos.png"/>
+          <p:cNvPicPr>
+            <a:picLocks noChangeAspect="1"/>
+          </p:cNvPicPr>
+          <p:nvPr/>
+        </p:nvPicPr>
+        <p:blipFill>
+          <a:blip r:embed="rId2"/>
+          <a:stretch>
+            <a:fillRect/>
+          </a:stretch>
+        </p:blipFill>
+        <p:spPr>
+          <a:xfrm>
+            <a:off x="699515" y="1660639"/>
+            <a:ext cx="7744968" cy="2119400"/>
+          </a:xfrm>
+          <a:prstGeom prst="rect">
+            <a:avLst/>
+          </a:prstGeom>
+        </p:spPr>
+      </p:pic>
+      <p:sp>
+        <p:nvSpPr>
+          <p:cNvPr id="5" name="TextBox 4"/>
+          <p:cNvSpPr txBox="1"/>
+          <p:nvPr/>
+        </p:nvSpPr>
+        <p:spPr>
+          <a:xfrm>
+            <a:off x="704088" y="4434840"/>
+            <a:ext cx="7744968" cy="457200"/>
+          </a:xfrm>
+          <a:prstGeom prst="rect">
+            <a:avLst/>
+          </a:prstGeom>
+          <a:noFill/>
+        </p:spPr>
+        <p:txBody>
+          <a:bodyPr wrap="square">
+            <a:spAutoFit/>
+          </a:bodyPr>
+          <a:lstStyle/>
+          <a:p>
+            <a:r>
+              <a:rPr sz="1300" b="0">
+                <a:solidFill>
+                  <a:srgbClr val="333333"/>
+                </a:solidFill>
+                <a:latin typeface="Fira Sans"/>
+              </a:rPr>
+              <a:t>Decisión 1: transformar con log, porque las dos variables tienen cola larga y en log la nube se endereza: R² de 0,32 a 0,53. Y queda claro que la distancia sola no basta.</a:t>
             </a:r>
           </a:p>
         </p:txBody>
@@ -6540,7 +6588,7 @@
             <a:avLst/>
           </a:prstGeom>
           <a:solidFill>
-            <a:srgbClr val="FAFBFC"/>
+            <a:srgbClr val="1D3557"/>
           </a:solidFill>
           <a:ln>
             <a:noFill/>
@@ -6577,8 +6625,8 @@
         </p:nvSpPr>
         <p:spPr>
           <a:xfrm>
-            <a:off x="402336" y="301752"/>
-            <a:ext cx="8348472" cy="795528"/>
+            <a:off x="603504" y="1847088"/>
+            <a:ext cx="7946136" cy="1399032"/>
           </a:xfrm>
           <a:prstGeom prst="rect">
             <a:avLst/>
@@ -6592,71 +6640,24 @@
           <a:lstStyle/>
           <a:p>
             <a:r>
-              <a:rPr sz="2800" b="1">
-                <a:solidFill>
-                  <a:srgbClr val="0F0F0F"/>
-                </a:solidFill>
-                <a:latin typeface="Fira Sans"/>
-              </a:rPr>
-              <a:t>¿Qué más podría explicar la duración?</a:t>
-            </a:r>
-          </a:p>
-        </p:txBody>
-      </p:sp>
-      <p:pic>
-        <p:nvPicPr>
-          <p:cNvPr id="4" name="Picture 3" descr="c4_13_por_modo.png"/>
-          <p:cNvPicPr>
-            <a:picLocks noChangeAspect="1"/>
-          </p:cNvPicPr>
-          <p:nvPr/>
-        </p:nvPicPr>
-        <p:blipFill>
-          <a:blip r:embed="rId2"/>
-          <a:stretch>
-            <a:fillRect/>
-          </a:stretch>
-        </p:blipFill>
-        <p:spPr>
-          <a:xfrm>
-            <a:off x="699515" y="1409022"/>
-            <a:ext cx="7744968" cy="2622635"/>
-          </a:xfrm>
-          <a:prstGeom prst="rect">
-            <a:avLst/>
-          </a:prstGeom>
-        </p:spPr>
-      </p:pic>
-      <p:sp>
-        <p:nvSpPr>
-          <p:cNvPr id="5" name="TextBox 4"/>
-          <p:cNvSpPr txBox="1"/>
-          <p:nvPr/>
-        </p:nvSpPr>
-        <p:spPr>
-          <a:xfrm>
-            <a:off x="704088" y="4434840"/>
-            <a:ext cx="7744968" cy="457200"/>
-          </a:xfrm>
-          <a:prstGeom prst="rect">
-            <a:avLst/>
-          </a:prstGeom>
-          <a:noFill/>
-        </p:spPr>
-        <p:txBody>
-          <a:bodyPr wrap="square">
-            <a:spAutoFit/>
-          </a:bodyPr>
-          <a:lstStyle/>
-          <a:p>
-            <a:r>
-              <a:rPr sz="1300" b="0">
-                <a:solidFill>
-                  <a:srgbClr val="333333"/>
-                </a:solidFill>
-                <a:latin typeface="Fira Sans"/>
-              </a:rPr>
-              <a:t>Las numéricas del hogar no ayudan (ingreso r = −0,03, vehículos −0,09). El modo, que la matriz no ve, sí: Bip! 62 min contra 15 de caminata. Pero Bip! también va más lejos: hay que comparar a igual distancia.</a:t>
+              <a:rPr sz="3400" b="1">
+                <a:solidFill>
+                  <a:srgbClr val="FFFFFF"/>
+                </a:solidFill>
+                <a:latin typeface="Fira Sans"/>
+              </a:rPr>
+              <a:t>¿Y si agregamos más variables?</a:t>
+            </a:r>
+          </a:p>
+          <a:p>
+            <a:r>
+              <a:rPr sz="1800" b="0">
+                <a:solidFill>
+                  <a:srgbClr val="E0A437"/>
+                </a:solidFill>
+                <a:latin typeface="Fira Sans"/>
+              </a:rPr>
+              <a:t>Volvemos a la duración: la distancia explica el 53%. ¿Qué más podría explicarla, y cómo se decide?</a:t>
             </a:r>
           </a:p>
         </p:txBody>
@@ -7011,21 +7012,45 @@
                 </a:solidFill>
                 <a:latin typeface="Fira Sans"/>
               </a:rPr>
-              <a:t>Decisión 2: agregar el modo</a:t>
-            </a:r>
-          </a:p>
-        </p:txBody>
-      </p:sp>
-      <p:sp>
-        <p:nvSpPr>
-          <p:cNvPr id="4" name="TextBox 3"/>
+              <a:t>¿Qué más podría explicar la duración?</a:t>
+            </a:r>
+          </a:p>
+        </p:txBody>
+      </p:sp>
+      <p:pic>
+        <p:nvPicPr>
+          <p:cNvPr id="4" name="Picture 3" descr="c4_13_por_modo.png"/>
+          <p:cNvPicPr>
+            <a:picLocks noChangeAspect="1"/>
+          </p:cNvPicPr>
+          <p:nvPr/>
+        </p:nvPicPr>
+        <p:blipFill>
+          <a:blip r:embed="rId2"/>
+          <a:stretch>
+            <a:fillRect/>
+          </a:stretch>
+        </p:blipFill>
+        <p:spPr>
+          <a:xfrm>
+            <a:off x="699515" y="1409022"/>
+            <a:ext cx="7744968" cy="2622635"/>
+          </a:xfrm>
+          <a:prstGeom prst="rect">
+            <a:avLst/>
+          </a:prstGeom>
+        </p:spPr>
+      </p:pic>
+      <p:sp>
+        <p:nvSpPr>
+          <p:cNvPr id="5" name="TextBox 4"/>
           <p:cNvSpPr txBox="1"/>
           <p:nvPr/>
         </p:nvSpPr>
         <p:spPr>
           <a:xfrm>
-            <a:off x="704088" y="1353312"/>
-            <a:ext cx="7744968" cy="3300984"/>
+            <a:off x="704088" y="4434840"/>
+            <a:ext cx="7744968" cy="457200"/>
           </a:xfrm>
           <a:prstGeom prst="rect">
             <a:avLst/>
@@ -7038,115 +7063,14 @@
           </a:bodyPr>
           <a:lstStyle/>
           <a:p>
-            <a:pPr>
-              <a:lnSpc>
-                <a:spcPct val="112000"/>
-              </a:lnSpc>
-              <a:spcAft>
-                <a:spcPts val="900"/>
-              </a:spcAft>
-            </a:pPr>
-            <a:r>
-              <a:rPr sz="1800" b="1">
-                <a:solidFill>
-                  <a:srgbClr val="E0A437"/>
-                </a:solidFill>
-                <a:latin typeface="Fira Sans"/>
-              </a:rPr>
-              <a:t>▸ </a:t>
-            </a:r>
-            <a:r>
-              <a:rPr sz="1800" b="1">
-                <a:solidFill>
-                  <a:srgbClr val="1D3557"/>
-                </a:solidFill>
-                <a:latin typeface="Fira Sans"/>
-              </a:rPr>
-              <a:t>El modo es la candidata de mayor contraste y responde una pregunta de equidad: ¿cuánto más tarda un viaje según el modo, a igual distancia?</a:t>
-            </a:r>
-          </a:p>
-          <a:p>
-            <a:pPr>
-              <a:lnSpc>
-                <a:spcPct val="112000"/>
-              </a:lnSpc>
-              <a:spcAft>
-                <a:spcPts val="900"/>
-              </a:spcAft>
-            </a:pPr>
-            <a:r>
-              <a:rPr sz="1800" b="1">
-                <a:solidFill>
-                  <a:srgbClr val="E0A437"/>
-                </a:solidFill>
-                <a:latin typeface="Fira Sans"/>
-              </a:rPr>
-              <a:t>▸ </a:t>
-            </a:r>
-            <a:r>
-              <a:rPr sz="1800" b="0">
-                <a:solidFill>
-                  <a:srgbClr val="000000"/>
-                </a:solidFill>
-                <a:latin typeface="Fira Sans"/>
-              </a:rPr>
-              <a:t>Comparar duraciones a secas mezcla el modo con la distancia; la regresión múltiple controla la distancia y aísla el modo.</a:t>
-            </a:r>
-          </a:p>
-          <a:p>
-            <a:pPr>
-              <a:lnSpc>
-                <a:spcPct val="112000"/>
-              </a:lnSpc>
-              <a:spcAft>
-                <a:spcPts val="900"/>
-              </a:spcAft>
-            </a:pPr>
-            <a:r>
-              <a:rPr sz="1800" b="1">
-                <a:solidFill>
-                  <a:srgbClr val="E0A437"/>
-                </a:solidFill>
-                <a:latin typeface="Fira Sans"/>
-              </a:rPr>
-              <a:t>▸ </a:t>
-            </a:r>
-            <a:r>
-              <a:rPr sz="1800" b="0">
-                <a:solidFill>
-                  <a:srgbClr val="000000"/>
-                </a:solidFill>
-                <a:latin typeface="Fira Sans"/>
-              </a:rPr>
-              <a:t>Como el modo es texto, no puede entrar tal cual a la fórmula: primero hay que convertirlo en números.</a:t>
-            </a:r>
-          </a:p>
-          <a:p>
-            <a:pPr>
-              <a:lnSpc>
-                <a:spcPct val="112000"/>
-              </a:lnSpc>
-              <a:spcAft>
-                <a:spcPts val="900"/>
-              </a:spcAft>
-            </a:pPr>
-            <a:r>
-              <a:rPr sz="1800" b="1">
-                <a:solidFill>
-                  <a:srgbClr val="E0A437"/>
-                </a:solidFill>
-                <a:latin typeface="Fira Sans"/>
-              </a:rPr>
-              <a:t>▸ </a:t>
-            </a:r>
-            <a:r>
-              <a:rPr sz="1800" b="0">
-                <a:solidFill>
-                  <a:srgbClr val="000000"/>
-                </a:solidFill>
-                <a:latin typeface="Fira Sans"/>
-              </a:rPr>
-              <a:t>El período del día es la otra candidata fuerte (punta mañana 60 min, fuera de punta 32): queda para el ejercicio.</a:t>
+            <a:r>
+              <a:rPr sz="1300" b="0">
+                <a:solidFill>
+                  <a:srgbClr val="333333"/>
+                </a:solidFill>
+                <a:latin typeface="Fira Sans"/>
+              </a:rPr>
+              <a:t>Las numéricas del hogar no ayudan (ingreso r = −0,03, vehículos −0,09). El modo, que la matriz no ve, sí: Bip! 62 min contra 15 de caminata. Pero Bip! también va más lejos: hay que comparar a igual distancia.</a:t>
             </a:r>
           </a:p>
         </p:txBody>
@@ -7242,45 +7166,21 @@
                 </a:solidFill>
                 <a:latin typeface="Fira Sans"/>
               </a:rPr>
-              <a:t>Una categórica, convertida en columnas 0/1</a:t>
-            </a:r>
-          </a:p>
-        </p:txBody>
-      </p:sp>
-      <p:pic>
-        <p:nvPicPr>
-          <p:cNvPr id="4" name="Picture 3" descr="c4_11_dummies_tabla.png"/>
-          <p:cNvPicPr>
-            <a:picLocks noChangeAspect="1"/>
-          </p:cNvPicPr>
-          <p:nvPr/>
-        </p:nvPicPr>
-        <p:blipFill>
-          <a:blip r:embed="rId2"/>
-          <a:stretch>
-            <a:fillRect/>
-          </a:stretch>
-        </p:blipFill>
-        <p:spPr>
-          <a:xfrm>
-            <a:off x="755966" y="1143000"/>
-            <a:ext cx="7632067" cy="3154680"/>
-          </a:xfrm>
-          <a:prstGeom prst="rect">
-            <a:avLst/>
-          </a:prstGeom>
-        </p:spPr>
-      </p:pic>
-      <p:sp>
-        <p:nvSpPr>
-          <p:cNvPr id="5" name="TextBox 4"/>
+              <a:t>Decisión 2: agregar el modo</a:t>
+            </a:r>
+          </a:p>
+        </p:txBody>
+      </p:sp>
+      <p:sp>
+        <p:nvSpPr>
+          <p:cNvPr id="4" name="TextBox 3"/>
           <p:cNvSpPr txBox="1"/>
           <p:nvPr/>
         </p:nvSpPr>
         <p:spPr>
           <a:xfrm>
-            <a:off x="704088" y="4434840"/>
-            <a:ext cx="7744968" cy="457200"/>
+            <a:off x="704088" y="1353312"/>
+            <a:ext cx="7744968" cy="3300984"/>
           </a:xfrm>
           <a:prstGeom prst="rect">
             <a:avLst/>
@@ -7293,14 +7193,115 @@
           </a:bodyPr>
           <a:lstStyle/>
           <a:p>
-            <a:r>
-              <a:rPr sz="1300" b="0">
-                <a:solidFill>
-                  <a:srgbClr val="333333"/>
-                </a:solidFill>
-                <a:latin typeface="Fira Sans"/>
-              </a:rPr>
-              <a:t>El modo es texto y la fórmula solo suma números: pd.get_dummies crea una columna por categoría. Cada viaje tiene un solo 1, en la de su modo; el auto se saca y queda de referencia.</a:t>
+            <a:pPr>
+              <a:lnSpc>
+                <a:spcPct val="112000"/>
+              </a:lnSpc>
+              <a:spcAft>
+                <a:spcPts val="900"/>
+              </a:spcAft>
+            </a:pPr>
+            <a:r>
+              <a:rPr sz="1800" b="1">
+                <a:solidFill>
+                  <a:srgbClr val="E0A437"/>
+                </a:solidFill>
+                <a:latin typeface="Fira Sans"/>
+              </a:rPr>
+              <a:t>▸ </a:t>
+            </a:r>
+            <a:r>
+              <a:rPr sz="1800" b="1">
+                <a:solidFill>
+                  <a:srgbClr val="1D3557"/>
+                </a:solidFill>
+                <a:latin typeface="Fira Sans"/>
+              </a:rPr>
+              <a:t>El modo es la candidata de mayor contraste y responde una pregunta de equidad: ¿cuánto más tarda un viaje según el modo, a igual distancia?</a:t>
+            </a:r>
+          </a:p>
+          <a:p>
+            <a:pPr>
+              <a:lnSpc>
+                <a:spcPct val="112000"/>
+              </a:lnSpc>
+              <a:spcAft>
+                <a:spcPts val="900"/>
+              </a:spcAft>
+            </a:pPr>
+            <a:r>
+              <a:rPr sz="1800" b="1">
+                <a:solidFill>
+                  <a:srgbClr val="E0A437"/>
+                </a:solidFill>
+                <a:latin typeface="Fira Sans"/>
+              </a:rPr>
+              <a:t>▸ </a:t>
+            </a:r>
+            <a:r>
+              <a:rPr sz="1800" b="0">
+                <a:solidFill>
+                  <a:srgbClr val="000000"/>
+                </a:solidFill>
+                <a:latin typeface="Fira Sans"/>
+              </a:rPr>
+              <a:t>Comparar duraciones a secas mezcla el modo con la distancia; la regresión múltiple controla la distancia y aísla el modo.</a:t>
+            </a:r>
+          </a:p>
+          <a:p>
+            <a:pPr>
+              <a:lnSpc>
+                <a:spcPct val="112000"/>
+              </a:lnSpc>
+              <a:spcAft>
+                <a:spcPts val="900"/>
+              </a:spcAft>
+            </a:pPr>
+            <a:r>
+              <a:rPr sz="1800" b="1">
+                <a:solidFill>
+                  <a:srgbClr val="E0A437"/>
+                </a:solidFill>
+                <a:latin typeface="Fira Sans"/>
+              </a:rPr>
+              <a:t>▸ </a:t>
+            </a:r>
+            <a:r>
+              <a:rPr sz="1800" b="0">
+                <a:solidFill>
+                  <a:srgbClr val="000000"/>
+                </a:solidFill>
+                <a:latin typeface="Fira Sans"/>
+              </a:rPr>
+              <a:t>Como el modo es texto, no puede entrar tal cual a la fórmula: primero hay que convertirlo en números.</a:t>
+            </a:r>
+          </a:p>
+          <a:p>
+            <a:pPr>
+              <a:lnSpc>
+                <a:spcPct val="112000"/>
+              </a:lnSpc>
+              <a:spcAft>
+                <a:spcPts val="900"/>
+              </a:spcAft>
+            </a:pPr>
+            <a:r>
+              <a:rPr sz="1800" b="1">
+                <a:solidFill>
+                  <a:srgbClr val="E0A437"/>
+                </a:solidFill>
+                <a:latin typeface="Fira Sans"/>
+              </a:rPr>
+              <a:t>▸ </a:t>
+            </a:r>
+            <a:r>
+              <a:rPr sz="1800" b="0">
+                <a:solidFill>
+                  <a:srgbClr val="000000"/>
+                </a:solidFill>
+                <a:latin typeface="Fira Sans"/>
+              </a:rPr>
+              <a:t>El período del día es la otra candidata fuerte (punta mañana 60 min, fuera de punta 32): queda para el ejercicio.</a:t>
             </a:r>
           </a:p>
         </p:txBody>
@@ -7396,114 +7397,35 @@
                 </a:solidFill>
                 <a:latin typeface="Fira Sans"/>
               </a:rPr>
-              <a:t>Las dummies, en código</a:t>
-            </a:r>
-          </a:p>
-        </p:txBody>
-      </p:sp>
-      <p:sp>
-        <p:nvSpPr>
-          <p:cNvPr id="4" name="Rectangle 3"/>
-          <p:cNvSpPr/>
-          <p:nvPr/>
-        </p:nvSpPr>
-        <p:spPr>
-          <a:xfrm>
-            <a:off x="704088" y="1280160"/>
-            <a:ext cx="7744968" cy="2880360"/>
-          </a:xfrm>
-          <a:prstGeom prst="rect">
-            <a:avLst/>
-          </a:prstGeom>
-          <a:solidFill>
-            <a:srgbClr val="F0F2F5"/>
-          </a:solidFill>
-          <a:ln>
-            <a:solidFill>
-              <a:srgbClr val="D8DDE3"/>
-            </a:solidFill>
-          </a:ln>
-          <a:effectLst/>
-        </p:spPr>
-        <p:style>
-          <a:lnRef idx="1">
-            <a:schemeClr val="accent1"/>
-          </a:lnRef>
-          <a:fillRef idx="3">
-            <a:schemeClr val="accent1"/>
-          </a:fillRef>
-          <a:effectRef idx="2">
-            <a:schemeClr val="accent1"/>
-          </a:effectRef>
-          <a:fontRef idx="minor">
-            <a:schemeClr val="lt1"/>
-          </a:fontRef>
-        </p:style>
-        <p:txBody>
-          <a:bodyPr rtlCol="0" anchor="ctr" wrap="square" lIns="228600" tIns="137160"/>
-          <a:lstStyle/>
-          <a:p>
-            <a:pPr/>
-            <a:r>
-              <a:rPr sz="1500" b="0">
-                <a:solidFill>
-                  <a:srgbClr val="1D3557"/>
-                </a:solidFill>
-                <a:latin typeface="Menlo"/>
-              </a:rPr>
-              <a:t># Una columna 0/1 por modo; el auto queda de referencia</a:t>
-            </a:r>
-          </a:p>
-          <a:p>
-            <a:pPr/>
-            <a:r>
-              <a:rPr sz="1500" b="0">
-                <a:solidFill>
-                  <a:srgbClr val="1D3557"/>
-                </a:solidFill>
-                <a:latin typeface="Menlo"/>
-              </a:rPr>
-              <a:t>dummies = pd.get_dummies(viajes["ModoAgrupado"])</a:t>
-            </a:r>
-          </a:p>
-          <a:p>
-            <a:pPr/>
-            <a:r>
-              <a:rPr sz="1500" b="0">
-                <a:solidFill>
-                  <a:srgbClr val="1D3557"/>
-                </a:solidFill>
-                <a:latin typeface="Menlo"/>
-              </a:rPr>
-              <a:t>dummies = dummies.drop(columns=["Auto"])</a:t>
-            </a:r>
-          </a:p>
-          <a:p>
-            <a:pPr/>
-            <a:r>
-              <a:rPr sz="1500" b="0">
-                <a:solidFill>
-                  <a:srgbClr val="1D3557"/>
-                </a:solidFill>
-                <a:latin typeface="Menlo"/>
-              </a:rPr>
-              <a:t/>
-            </a:r>
-          </a:p>
-          <a:p>
-            <a:pPr/>
-            <a:r>
-              <a:rPr sz="1500" b="0">
-                <a:solidFill>
-                  <a:srgbClr val="1D3557"/>
-                </a:solidFill>
-                <a:latin typeface="Menlo"/>
-              </a:rPr>
-              <a:t># Explicar la duración (log) con la distancia (log) y el modo</a:t>
-            </a:r>
-          </a:p>
-        </p:txBody>
-      </p:sp>
+              <a:t>Una categórica, convertida en columnas 0/1</a:t>
+            </a:r>
+          </a:p>
+        </p:txBody>
+      </p:sp>
+      <p:pic>
+        <p:nvPicPr>
+          <p:cNvPr id="4" name="Picture 3" descr="c4_11_dummies_tabla.png"/>
+          <p:cNvPicPr>
+            <a:picLocks noChangeAspect="1"/>
+          </p:cNvPicPr>
+          <p:nvPr/>
+        </p:nvPicPr>
+        <p:blipFill>
+          <a:blip r:embed="rId2"/>
+          <a:stretch>
+            <a:fillRect/>
+          </a:stretch>
+        </p:blipFill>
+        <p:spPr>
+          <a:xfrm>
+            <a:off x="755966" y="1143000"/>
+            <a:ext cx="7632067" cy="3154680"/>
+          </a:xfrm>
+          <a:prstGeom prst="rect">
+            <a:avLst/>
+          </a:prstGeom>
+        </p:spPr>
+      </p:pic>
       <p:sp>
         <p:nvSpPr>
           <p:cNvPr id="5" name="TextBox 4"/>
@@ -7512,8 +7434,8 @@
         </p:nvSpPr>
         <p:spPr>
           <a:xfrm>
-            <a:off x="704088" y="4389120"/>
-            <a:ext cx="7744968" cy="1097280"/>
+            <a:off x="704088" y="4434840"/>
+            <a:ext cx="7744968" cy="457200"/>
           </a:xfrm>
           <a:prstGeom prst="rect">
             <a:avLst/>
@@ -7526,31 +7448,14 @@
           </a:bodyPr>
           <a:lstStyle/>
           <a:p>
-            <a:pPr>
-              <a:lnSpc>
-                <a:spcPct val="112000"/>
-              </a:lnSpc>
-              <a:spcAft>
-                <a:spcPts val="900"/>
-              </a:spcAft>
-            </a:pPr>
-            <a:r>
-              <a:rPr sz="1600" b="1">
-                <a:solidFill>
-                  <a:srgbClr val="E0A437"/>
-                </a:solidFill>
-                <a:latin typeface="Fira Sans"/>
-              </a:rPr>
-              <a:t>▸ </a:t>
-            </a:r>
-            <a:r>
-              <a:rPr sz="1600" b="0">
-                <a:solidFill>
-                  <a:srgbClr val="000000"/>
-                </a:solidFill>
-                <a:latin typeface="Fira Sans"/>
-              </a:rPr>
-              <a:t>Las dummies se agregan a la X junto al log de la distancia. Cada coeficiente se lee comparado con la referencia: ese modo frente al auto, a igual distancia.</a:t>
+            <a:r>
+              <a:rPr sz="1300" b="0">
+                <a:solidFill>
+                  <a:srgbClr val="333333"/>
+                </a:solidFill>
+                <a:latin typeface="Fira Sans"/>
+              </a:rPr>
+              <a:t>El modo es texto y la fórmula solo suma números: pd.get_dummies crea una columna por categoría. Cada viaje tiene un solo 1, en la de su modo; el auto se saca y queda de referencia.</a:t>
             </a:r>
           </a:p>
         </p:txBody>
@@ -7646,35 +7551,114 @@
                 </a:solidFill>
                 <a:latin typeface="Fira Sans"/>
               </a:rPr>
-              <a:t>Qué hace una dummy dentro del modelo</a:t>
-            </a:r>
-          </a:p>
-        </p:txBody>
-      </p:sp>
-      <p:pic>
-        <p:nvPicPr>
-          <p:cNvPr id="4" name="Picture 3" descr="c4_12_dummies_rectas.png"/>
-          <p:cNvPicPr>
-            <a:picLocks noChangeAspect="1"/>
-          </p:cNvPicPr>
-          <p:nvPr/>
-        </p:nvPicPr>
-        <p:blipFill>
-          <a:blip r:embed="rId2"/>
-          <a:stretch>
-            <a:fillRect/>
-          </a:stretch>
-        </p:blipFill>
-        <p:spPr>
-          <a:xfrm>
-            <a:off x="1280160" y="1143000"/>
-            <a:ext cx="6583680" cy="3154680"/>
-          </a:xfrm>
-          <a:prstGeom prst="rect">
-            <a:avLst/>
-          </a:prstGeom>
-        </p:spPr>
-      </p:pic>
+              <a:t>Las dummies, en código</a:t>
+            </a:r>
+          </a:p>
+        </p:txBody>
+      </p:sp>
+      <p:sp>
+        <p:nvSpPr>
+          <p:cNvPr id="4" name="Rectangle 3"/>
+          <p:cNvSpPr/>
+          <p:nvPr/>
+        </p:nvSpPr>
+        <p:spPr>
+          <a:xfrm>
+            <a:off x="704088" y="1280160"/>
+            <a:ext cx="7744968" cy="2880360"/>
+          </a:xfrm>
+          <a:prstGeom prst="rect">
+            <a:avLst/>
+          </a:prstGeom>
+          <a:solidFill>
+            <a:srgbClr val="F0F2F5"/>
+          </a:solidFill>
+          <a:ln>
+            <a:solidFill>
+              <a:srgbClr val="D8DDE3"/>
+            </a:solidFill>
+          </a:ln>
+          <a:effectLst/>
+        </p:spPr>
+        <p:style>
+          <a:lnRef idx="1">
+            <a:schemeClr val="accent1"/>
+          </a:lnRef>
+          <a:fillRef idx="3">
+            <a:schemeClr val="accent1"/>
+          </a:fillRef>
+          <a:effectRef idx="2">
+            <a:schemeClr val="accent1"/>
+          </a:effectRef>
+          <a:fontRef idx="minor">
+            <a:schemeClr val="lt1"/>
+          </a:fontRef>
+        </p:style>
+        <p:txBody>
+          <a:bodyPr rtlCol="0" anchor="ctr" wrap="square" lIns="228600" tIns="137160"/>
+          <a:lstStyle/>
+          <a:p>
+            <a:pPr/>
+            <a:r>
+              <a:rPr sz="1500" b="0">
+                <a:solidFill>
+                  <a:srgbClr val="1D3557"/>
+                </a:solidFill>
+                <a:latin typeface="Menlo"/>
+              </a:rPr>
+              <a:t># Una columna 0/1 por modo; el auto queda de referencia</a:t>
+            </a:r>
+          </a:p>
+          <a:p>
+            <a:pPr/>
+            <a:r>
+              <a:rPr sz="1500" b="0">
+                <a:solidFill>
+                  <a:srgbClr val="1D3557"/>
+                </a:solidFill>
+                <a:latin typeface="Menlo"/>
+              </a:rPr>
+              <a:t>dummies = pd.get_dummies(viajes["ModoAgrupado"])</a:t>
+            </a:r>
+          </a:p>
+          <a:p>
+            <a:pPr/>
+            <a:r>
+              <a:rPr sz="1500" b="0">
+                <a:solidFill>
+                  <a:srgbClr val="1D3557"/>
+                </a:solidFill>
+                <a:latin typeface="Menlo"/>
+              </a:rPr>
+              <a:t>dummies = dummies.drop(columns=["Auto"])</a:t>
+            </a:r>
+          </a:p>
+          <a:p>
+            <a:pPr/>
+            <a:r>
+              <a:rPr sz="1500" b="0">
+                <a:solidFill>
+                  <a:srgbClr val="1D3557"/>
+                </a:solidFill>
+                <a:latin typeface="Menlo"/>
+              </a:rPr>
+              <a:t/>
+            </a:r>
+          </a:p>
+          <a:p>
+            <a:pPr/>
+            <a:r>
+              <a:rPr sz="1500" b="0">
+                <a:solidFill>
+                  <a:srgbClr val="1D3557"/>
+                </a:solidFill>
+                <a:latin typeface="Menlo"/>
+              </a:rPr>
+              <a:t># Explicar la duración (log) con la distancia (log) y el modo</a:t>
+            </a:r>
+          </a:p>
+        </p:txBody>
+      </p:sp>
       <p:sp>
         <p:nvSpPr>
           <p:cNvPr id="5" name="TextBox 4"/>
@@ -7683,8 +7667,8 @@
         </p:nvSpPr>
         <p:spPr>
           <a:xfrm>
-            <a:off x="704088" y="4434840"/>
-            <a:ext cx="7744968" cy="457200"/>
+            <a:off x="704088" y="4389120"/>
+            <a:ext cx="7744968" cy="1097280"/>
           </a:xfrm>
           <a:prstGeom prst="rect">
             <a:avLst/>
@@ -7697,14 +7681,31 @@
           </a:bodyPr>
           <a:lstStyle/>
           <a:p>
-            <a:r>
-              <a:rPr sz="1300" b="0">
-                <a:solidFill>
-                  <a:srgbClr val="333333"/>
-                </a:solidFill>
-                <a:latin typeface="Fira Sans"/>
-              </a:rPr>
-              <a:t>La dummy suma su coeficiente al intercepto de su modo: rectas paralelas, con la misma pendiente en la distancia. En log, sumar 0,27 es multiplicar el tiempo por 1,87.</a:t>
+            <a:pPr>
+              <a:lnSpc>
+                <a:spcPct val="112000"/>
+              </a:lnSpc>
+              <a:spcAft>
+                <a:spcPts val="900"/>
+              </a:spcAft>
+            </a:pPr>
+            <a:r>
+              <a:rPr sz="1600" b="1">
+                <a:solidFill>
+                  <a:srgbClr val="E0A437"/>
+                </a:solidFill>
+                <a:latin typeface="Fira Sans"/>
+              </a:rPr>
+              <a:t>▸ </a:t>
+            </a:r>
+            <a:r>
+              <a:rPr sz="1600" b="0">
+                <a:solidFill>
+                  <a:srgbClr val="000000"/>
+                </a:solidFill>
+                <a:latin typeface="Fira Sans"/>
+              </a:rPr>
+              <a:t>Las dummies se agregan a la X junto al log de la distancia. Cada coeficiente se lee comparado con la referencia: ese modo frente al auto, a igual distancia.</a:t>
             </a:r>
           </a:p>
         </p:txBody>
@@ -7800,14 +7801,14 @@
                 </a:solidFill>
                 <a:latin typeface="Fira Sans"/>
               </a:rPr>
-              <a:t>El resultado: distancia y modo</a:t>
+              <a:t>Qué hace una dummy dentro del modelo</a:t>
             </a:r>
           </a:p>
         </p:txBody>
       </p:sp>
       <p:pic>
         <p:nvPicPr>
-          <p:cNvPr id="4" name="Picture 3" descr="c4_03_coef_modo.png"/>
+          <p:cNvPr id="4" name="Picture 3" descr="c4_12_dummies_rectas.png"/>
           <p:cNvPicPr>
             <a:picLocks noChangeAspect="1"/>
           </p:cNvPicPr>
@@ -7821,8 +7822,8 @@
         </p:blipFill>
         <p:spPr>
           <a:xfrm>
-            <a:off x="804842" y="1143000"/>
-            <a:ext cx="7534315" cy="3154680"/>
+            <a:off x="1280160" y="1143000"/>
+            <a:ext cx="6583680" cy="3154680"/>
           </a:xfrm>
           <a:prstGeom prst="rect">
             <a:avLst/>
@@ -7858,7 +7859,7 @@
                 </a:solidFill>
                 <a:latin typeface="Fira Sans"/>
               </a:rPr>
-              <a:t>A igual distancia, un viaje en Bip! tarda 1,87 veces lo que uno en auto; taxi y caminata quedan casi iguales al auto. El R² sube de 0,53 a 0,60.</a:t>
+              <a:t>La dummy suma su coeficiente al intercepto de su modo: rectas paralelas, con la misma pendiente en la distancia. En log, sumar 0,27 es multiplicar el tiempo por 1,87.</a:t>
             </a:r>
           </a:p>
         </p:txBody>
@@ -7954,14 +7955,14 @@
                 </a:solidFill>
                 <a:latin typeface="Fira Sans"/>
               </a:rPr>
-              <a:t>La ecuación de la duración, leída</a:t>
+              <a:t>El resultado: distancia y modo</a:t>
             </a:r>
           </a:p>
         </p:txBody>
       </p:sp>
       <p:pic>
         <p:nvPicPr>
-          <p:cNvPr id="4" name="Picture 3" descr="c4_09_ecuacion_duracion.png"/>
+          <p:cNvPr id="4" name="Picture 3" descr="c4_03_coef_modo.png"/>
           <p:cNvPicPr>
             <a:picLocks noChangeAspect="1"/>
           </p:cNvPicPr>
@@ -7975,8 +7976,8 @@
         </p:blipFill>
         <p:spPr>
           <a:xfrm>
-            <a:off x="699515" y="1320746"/>
-            <a:ext cx="7744968" cy="2799186"/>
+            <a:off x="804842" y="1143000"/>
+            <a:ext cx="7534315" cy="3154680"/>
           </a:xfrm>
           <a:prstGeom prst="rect">
             <a:avLst/>
@@ -8012,7 +8013,7 @@
                 </a:solidFill>
                 <a:latin typeface="Fira Sans"/>
               </a:rPr>
-              <a:t>La misma tabla de coeficientes, escrita como ecuación: en escala log los efectos multiplican en vez de sumar.</a:t>
+              <a:t>A igual distancia, un viaje en Bip! tarda 1,87 veces lo que uno en auto; taxi y caminata quedan casi iguales al auto. El R² sube de 0,53 a 0,60.</a:t>
             </a:r>
           </a:p>
         </p:txBody>
@@ -8108,21 +8109,45 @@
                 </a:solidFill>
                 <a:latin typeface="Fira Sans"/>
               </a:rPr>
-              <a:t>Síntesis</a:t>
-            </a:r>
-          </a:p>
-        </p:txBody>
-      </p:sp>
-      <p:sp>
-        <p:nvSpPr>
-          <p:cNvPr id="4" name="TextBox 3"/>
+              <a:t>La ecuación de la duración, leída</a:t>
+            </a:r>
+          </a:p>
+        </p:txBody>
+      </p:sp>
+      <p:pic>
+        <p:nvPicPr>
+          <p:cNvPr id="4" name="Picture 3" descr="c4_09_ecuacion_duracion.png"/>
+          <p:cNvPicPr>
+            <a:picLocks noChangeAspect="1"/>
+          </p:cNvPicPr>
+          <p:nvPr/>
+        </p:nvPicPr>
+        <p:blipFill>
+          <a:blip r:embed="rId2"/>
+          <a:stretch>
+            <a:fillRect/>
+          </a:stretch>
+        </p:blipFill>
+        <p:spPr>
+          <a:xfrm>
+            <a:off x="699515" y="1320746"/>
+            <a:ext cx="7744968" cy="2799186"/>
+          </a:xfrm>
+          <a:prstGeom prst="rect">
+            <a:avLst/>
+          </a:prstGeom>
+        </p:spPr>
+      </p:pic>
+      <p:sp>
+        <p:nvSpPr>
+          <p:cNvPr id="5" name="TextBox 4"/>
           <p:cNvSpPr txBox="1"/>
           <p:nvPr/>
         </p:nvSpPr>
         <p:spPr>
           <a:xfrm>
-            <a:off x="704088" y="1353312"/>
-            <a:ext cx="7744968" cy="3300984"/>
+            <a:off x="704088" y="4434840"/>
+            <a:ext cx="7744968" cy="457200"/>
           </a:xfrm>
           <a:prstGeom prst="rect">
             <a:avLst/>
@@ -8135,143 +8160,14 @@
           </a:bodyPr>
           <a:lstStyle/>
           <a:p>
-            <a:pPr>
-              <a:lnSpc>
-                <a:spcPct val="112000"/>
-              </a:lnSpc>
-              <a:spcAft>
-                <a:spcPts val="900"/>
-              </a:spcAft>
-            </a:pPr>
-            <a:r>
-              <a:rPr sz="1800" b="1">
-                <a:solidFill>
-                  <a:srgbClr val="E0A437"/>
-                </a:solidFill>
-                <a:latin typeface="Fira Sans"/>
-              </a:rPr>
-              <a:t>▸ </a:t>
-            </a:r>
-            <a:r>
-              <a:rPr sz="1800" b="0">
-                <a:solidFill>
-                  <a:srgbClr val="000000"/>
-                </a:solidFill>
-                <a:latin typeface="Fira Sans"/>
-              </a:rPr>
-              <a:t>Muchos puntos: alpha o hexbin. Colas largas: log.</a:t>
-            </a:r>
-          </a:p>
-          <a:p>
-            <a:pPr>
-              <a:lnSpc>
-                <a:spcPct val="112000"/>
-              </a:lnSpc>
-              <a:spcAft>
-                <a:spcPts val="900"/>
-              </a:spcAft>
-            </a:pPr>
-            <a:r>
-              <a:rPr sz="1800" b="1">
-                <a:solidFill>
-                  <a:srgbClr val="E0A437"/>
-                </a:solidFill>
-                <a:latin typeface="Fira Sans"/>
-              </a:rPr>
-              <a:t>▸ </a:t>
-            </a:r>
-            <a:r>
-              <a:rPr sz="1800" b="0">
-                <a:solidFill>
-                  <a:srgbClr val="000000"/>
-                </a:solidFill>
-                <a:latin typeface="Fira Sans"/>
-              </a:rPr>
-              <a:t>El impacto de filas y atípicos se mide con y sin, sobre todos los resúmenes en uso.</a:t>
-            </a:r>
-          </a:p>
-          <a:p>
-            <a:pPr>
-              <a:lnSpc>
-                <a:spcPct val="112000"/>
-              </a:lnSpc>
-              <a:spcAft>
-                <a:spcPts val="900"/>
-              </a:spcAft>
-            </a:pPr>
-            <a:r>
-              <a:rPr sz="1800" b="1">
-                <a:solidFill>
-                  <a:srgbClr val="E0A437"/>
-                </a:solidFill>
-                <a:latin typeface="Fira Sans"/>
-              </a:rPr>
-              <a:t>▸ </a:t>
-            </a:r>
-            <a:r>
-              <a:rPr sz="1800" b="0">
-                <a:solidFill>
-                  <a:srgbClr val="000000"/>
-                </a:solidFill>
-                <a:latin typeface="Fira Sans"/>
-              </a:rPr>
-              <a:t>Cuando la conclusión es sobre la ciudad, se pondera: WLS.</a:t>
-            </a:r>
-          </a:p>
-          <a:p>
-            <a:pPr>
-              <a:lnSpc>
-                <a:spcPct val="112000"/>
-              </a:lnSpc>
-              <a:spcAft>
-                <a:spcPts val="900"/>
-              </a:spcAft>
-            </a:pPr>
-            <a:r>
-              <a:rPr sz="1800" b="1">
-                <a:solidFill>
-                  <a:srgbClr val="E0A437"/>
-                </a:solidFill>
-                <a:latin typeface="Fira Sans"/>
-              </a:rPr>
-              <a:t>▸ </a:t>
-            </a:r>
-            <a:r>
-              <a:rPr sz="1800" b="0">
-                <a:solidFill>
-                  <a:srgbClr val="000000"/>
-                </a:solidFill>
-                <a:latin typeface="Fira Sans"/>
-              </a:rPr>
-              <a:t>La múltiple aísla el efecto de cada variable (categóricas como dummies); R² dice cuánto explica y el valor p si un coeficiente se distingue del azar.</a:t>
-            </a:r>
-          </a:p>
-          <a:p>
-            <a:pPr>
-              <a:lnSpc>
-                <a:spcPct val="112000"/>
-              </a:lnSpc>
-              <a:spcAft>
-                <a:spcPts val="900"/>
-              </a:spcAft>
-            </a:pPr>
-            <a:r>
-              <a:rPr sz="1800" b="1">
-                <a:solidFill>
-                  <a:srgbClr val="E0A437"/>
-                </a:solidFill>
-                <a:latin typeface="Fira Sans"/>
-              </a:rPr>
-              <a:t>▸ </a:t>
-            </a:r>
-            <a:r>
-              <a:rPr sz="1800" b="1">
-                <a:solidFill>
-                  <a:srgbClr val="1D3557"/>
-                </a:solidFill>
-                <a:latin typeface="Fira Sans"/>
-              </a:rPr>
-              <a:t>El primer EDA del proyecto usa exactamente estas herramientas (entrega: lunes 15).</a:t>
+            <a:r>
+              <a:rPr sz="1300" b="0">
+                <a:solidFill>
+                  <a:srgbClr val="333333"/>
+                </a:solidFill>
+                <a:latin typeface="Fira Sans"/>
+              </a:rPr>
+              <a:t>La misma tabla de coeficientes, escrita como ecuación: en escala log los efectos multiplican en vez de sumar.</a:t>
             </a:r>
           </a:p>
         </p:txBody>
@@ -8309,7 +8205,7 @@
             <a:avLst/>
           </a:prstGeom>
           <a:solidFill>
-            <a:srgbClr val="1D3557"/>
+            <a:srgbClr val="FAFBFC"/>
           </a:solidFill>
           <a:ln>
             <a:noFill/>
@@ -8346,8 +8242,8 @@
         </p:nvSpPr>
         <p:spPr>
           <a:xfrm>
-            <a:off x="603504" y="1847088"/>
-            <a:ext cx="7946136" cy="1399032"/>
+            <a:off x="402336" y="301752"/>
+            <a:ext cx="8348472" cy="795528"/>
           </a:xfrm>
           <a:prstGeom prst="rect">
             <a:avLst/>
@@ -8361,24 +8257,176 @@
           <a:lstStyle/>
           <a:p>
             <a:r>
-              <a:rPr sz="3400" b="1">
-                <a:solidFill>
-                  <a:srgbClr val="FFFFFF"/>
-                </a:solidFill>
-                <a:latin typeface="Fira Sans"/>
-              </a:rPr>
-              <a:t>Recreo</a:t>
-            </a:r>
-          </a:p>
-          <a:p>
+              <a:rPr sz="2800" b="1">
+                <a:solidFill>
+                  <a:srgbClr val="0F0F0F"/>
+                </a:solidFill>
+                <a:latin typeface="Fira Sans"/>
+              </a:rPr>
+              <a:t>Síntesis</a:t>
+            </a:r>
+          </a:p>
+        </p:txBody>
+      </p:sp>
+      <p:sp>
+        <p:nvSpPr>
+          <p:cNvPr id="4" name="TextBox 3"/>
+          <p:cNvSpPr txBox="1"/>
+          <p:nvPr/>
+        </p:nvSpPr>
+        <p:spPr>
+          <a:xfrm>
+            <a:off x="704088" y="1353312"/>
+            <a:ext cx="7744968" cy="3300984"/>
+          </a:xfrm>
+          <a:prstGeom prst="rect">
+            <a:avLst/>
+          </a:prstGeom>
+          <a:noFill/>
+        </p:spPr>
+        <p:txBody>
+          <a:bodyPr wrap="square">
+            <a:spAutoFit/>
+          </a:bodyPr>
+          <a:lstStyle/>
+          <a:p>
+            <a:pPr>
+              <a:lnSpc>
+                <a:spcPct val="112000"/>
+              </a:lnSpc>
+              <a:spcAft>
+                <a:spcPts val="900"/>
+              </a:spcAft>
+            </a:pPr>
+            <a:r>
+              <a:rPr sz="1800" b="1">
+                <a:solidFill>
+                  <a:srgbClr val="E0A437"/>
+                </a:solidFill>
+                <a:latin typeface="Fira Sans"/>
+              </a:rPr>
+              <a:t>▸ </a:t>
+            </a:r>
             <a:r>
               <a:rPr sz="1800" b="0">
                 <a:solidFill>
+                  <a:srgbClr val="000000"/>
+                </a:solidFill>
+                <a:latin typeface="Fira Sans"/>
+              </a:rPr>
+              <a:t>Muchos puntos: alpha o hexbin. Colas largas: log.</a:t>
+            </a:r>
+          </a:p>
+          <a:p>
+            <a:pPr>
+              <a:lnSpc>
+                <a:spcPct val="112000"/>
+              </a:lnSpc>
+              <a:spcAft>
+                <a:spcPts val="900"/>
+              </a:spcAft>
+            </a:pPr>
+            <a:r>
+              <a:rPr sz="1800" b="1">
+                <a:solidFill>
                   <a:srgbClr val="E0A437"/>
                 </a:solidFill>
                 <a:latin typeface="Fira Sans"/>
               </a:rPr>
-              <a:t>10 minutos · al volver: las presentaciones de ideas</a:t>
+              <a:t>▸ </a:t>
+            </a:r>
+            <a:r>
+              <a:rPr sz="1800" b="0">
+                <a:solidFill>
+                  <a:srgbClr val="000000"/>
+                </a:solidFill>
+                <a:latin typeface="Fira Sans"/>
+              </a:rPr>
+              <a:t>El impacto de filas y atípicos se mide con y sin, sobre todos los resúmenes en uso.</a:t>
+            </a:r>
+          </a:p>
+          <a:p>
+            <a:pPr>
+              <a:lnSpc>
+                <a:spcPct val="112000"/>
+              </a:lnSpc>
+              <a:spcAft>
+                <a:spcPts val="900"/>
+              </a:spcAft>
+            </a:pPr>
+            <a:r>
+              <a:rPr sz="1800" b="1">
+                <a:solidFill>
+                  <a:srgbClr val="E0A437"/>
+                </a:solidFill>
+                <a:latin typeface="Fira Sans"/>
+              </a:rPr>
+              <a:t>▸ </a:t>
+            </a:r>
+            <a:r>
+              <a:rPr sz="1800" b="0">
+                <a:solidFill>
+                  <a:srgbClr val="000000"/>
+                </a:solidFill>
+                <a:latin typeface="Fira Sans"/>
+              </a:rPr>
+              <a:t>Cuando la conclusión es sobre la ciudad, se pondera: WLS.</a:t>
+            </a:r>
+          </a:p>
+          <a:p>
+            <a:pPr>
+              <a:lnSpc>
+                <a:spcPct val="112000"/>
+              </a:lnSpc>
+              <a:spcAft>
+                <a:spcPts val="900"/>
+              </a:spcAft>
+            </a:pPr>
+            <a:r>
+              <a:rPr sz="1800" b="1">
+                <a:solidFill>
+                  <a:srgbClr val="E0A437"/>
+                </a:solidFill>
+                <a:latin typeface="Fira Sans"/>
+              </a:rPr>
+              <a:t>▸ </a:t>
+            </a:r>
+            <a:r>
+              <a:rPr sz="1800" b="0">
+                <a:solidFill>
+                  <a:srgbClr val="000000"/>
+                </a:solidFill>
+                <a:latin typeface="Fira Sans"/>
+              </a:rPr>
+              <a:t>La múltiple aísla el efecto de cada variable (categóricas como dummies); R² dice cuánto explica y el valor p si un coeficiente se distingue del azar.</a:t>
+            </a:r>
+          </a:p>
+          <a:p>
+            <a:pPr>
+              <a:lnSpc>
+                <a:spcPct val="112000"/>
+              </a:lnSpc>
+              <a:spcAft>
+                <a:spcPts val="900"/>
+              </a:spcAft>
+            </a:pPr>
+            <a:r>
+              <a:rPr sz="1800" b="1">
+                <a:solidFill>
+                  <a:srgbClr val="E0A437"/>
+                </a:solidFill>
+                <a:latin typeface="Fira Sans"/>
+              </a:rPr>
+              <a:t>▸ </a:t>
+            </a:r>
+            <a:r>
+              <a:rPr sz="1800" b="1">
+                <a:solidFill>
+                  <a:srgbClr val="1D3557"/>
+                </a:solidFill>
+                <a:latin typeface="Fira Sans"/>
+              </a:rPr>
+              <a:t>El primer EDA del proyecto usa exactamente estas herramientas (entrega: lunes 15).</a:t>
             </a:r>
           </a:p>
         </p:txBody>
@@ -8474,7 +8522,7 @@
                 </a:solidFill>
                 <a:latin typeface="Fira Sans"/>
               </a:rPr>
-              <a:t>Presentaciones de ideas</a:t>
+              <a:t>Recreo</a:t>
             </a:r>
           </a:p>
           <a:p>
@@ -8485,7 +8533,7 @@
                 </a:solidFill>
                 <a:latin typeface="Fira Sans"/>
               </a:rPr>
-              <a:t>De 5 a 7 minutos por equipo, y preguntas de todos</a:t>
+              <a:t>10 minutos · al volver: las presentaciones de ideas</a:t>
             </a:r>
           </a:p>
         </p:txBody>
@@ -8523,7 +8571,7 @@
             <a:avLst/>
           </a:prstGeom>
           <a:solidFill>
-            <a:srgbClr val="FAFBFC"/>
+            <a:srgbClr val="1D3557"/>
           </a:solidFill>
           <a:ln>
             <a:noFill/>
@@ -8560,8 +8608,8 @@
         </p:nvSpPr>
         <p:spPr>
           <a:xfrm>
-            <a:off x="402336" y="301752"/>
-            <a:ext cx="8348472" cy="795528"/>
+            <a:off x="603504" y="1847088"/>
+            <a:ext cx="7946136" cy="1399032"/>
           </a:xfrm>
           <a:prstGeom prst="rect">
             <a:avLst/>
@@ -8575,92 +8623,24 @@
           <a:lstStyle/>
           <a:p>
             <a:r>
-              <a:rPr sz="2800" b="1">
-                <a:solidFill>
-                  <a:srgbClr val="0F0F0F"/>
-                </a:solidFill>
-                <a:latin typeface="Fira Sans"/>
-              </a:rPr>
-              <a:t>El formato</a:t>
-            </a:r>
-          </a:p>
-        </p:txBody>
-      </p:sp>
-      <p:sp>
-        <p:nvSpPr>
-          <p:cNvPr id="4" name="TextBox 3"/>
-          <p:cNvSpPr txBox="1"/>
-          <p:nvPr/>
-        </p:nvSpPr>
-        <p:spPr>
-          <a:xfrm>
-            <a:off x="704088" y="1353312"/>
-            <a:ext cx="7744968" cy="3300984"/>
-          </a:xfrm>
-          <a:prstGeom prst="rect">
-            <a:avLst/>
-          </a:prstGeom>
-          <a:noFill/>
-        </p:spPr>
-        <p:txBody>
-          <a:bodyPr wrap="square">
-            <a:spAutoFit/>
-          </a:bodyPr>
-          <a:lstStyle/>
-          <a:p>
-            <a:pPr>
-              <a:lnSpc>
-                <a:spcPct val="112000"/>
-              </a:lnSpc>
-              <a:spcAft>
-                <a:spcPts val="900"/>
-              </a:spcAft>
-            </a:pPr>
-            <a:r>
-              <a:rPr sz="1800" b="1">
+              <a:rPr sz="3400" b="1">
+                <a:solidFill>
+                  <a:srgbClr val="FFFFFF"/>
+                </a:solidFill>
+                <a:latin typeface="Fira Sans"/>
+              </a:rPr>
+              <a:t>Presentaciones de ideas</a:t>
+            </a:r>
+          </a:p>
+          <a:p>
+            <a:r>
+              <a:rPr sz="1800" b="0">
                 <a:solidFill>
                   <a:srgbClr val="E0A437"/>
                 </a:solidFill>
                 <a:latin typeface="Fira Sans"/>
               </a:rPr>
-              <a:t>▸ </a:t>
-            </a:r>
-            <a:r>
-              <a:rPr sz="1800" b="1">
-                <a:solidFill>
-                  <a:srgbClr val="1D3557"/>
-                </a:solidFill>
-                <a:latin typeface="Fira Sans"/>
-              </a:rPr>
-              <a:t>Esta instancia no lleva nota: es para recibir retroalimentación temprano, cuando corregir cuesta poco.</a:t>
-            </a:r>
-          </a:p>
-          <a:p>
-            <a:pPr>
-              <a:lnSpc>
-                <a:spcPct val="112000"/>
-              </a:lnSpc>
-              <a:spcAft>
-                <a:spcPts val="900"/>
-              </a:spcAft>
-            </a:pPr>
-            <a:r>
-              <a:rPr sz="1800" b="1">
-                <a:solidFill>
-                  <a:srgbClr val="E0A437"/>
-                </a:solidFill>
-                <a:latin typeface="Fira Sans"/>
-              </a:rPr>
-              <a:t>▸ </a:t>
-            </a:r>
-            <a:r>
-              <a:rPr sz="1800" b="0">
-                <a:solidFill>
-                  <a:srgbClr val="000000"/>
-                </a:solidFill>
-                <a:latin typeface="Fira Sans"/>
-              </a:rPr>
-              <a:t>Después de cada equipo, preguntas y comentarios del curso.</a:t>
+              <a:t>De 5 a 7 minutos por equipo, y preguntas de todos</a:t>
             </a:r>
           </a:p>
         </p:txBody>
@@ -8863,7 +8843,7 @@
                 </a:solidFill>
                 <a:latin typeface="Fira Sans"/>
               </a:rPr>
-              <a:t>Próxima clase</a:t>
+              <a:t>El formato</a:t>
             </a:r>
           </a:p>
         </p:txBody>
@@ -8908,13 +8888,13 @@
               <a:t>▸ </a:t>
             </a:r>
             <a:r>
-              <a:rPr sz="1800" b="0">
-                <a:solidFill>
-                  <a:srgbClr val="000000"/>
-                </a:solidFill>
-                <a:latin typeface="Fira Sans"/>
-              </a:rPr>
-              <a:t>Martes 8: fundamentos de probabilidad y nociones de inferencia estadística.</a:t>
+              <a:rPr sz="1800" b="1">
+                <a:solidFill>
+                  <a:srgbClr val="1D3557"/>
+                </a:solidFill>
+                <a:latin typeface="Fira Sans"/>
+              </a:rPr>
+              <a:t>Esta instancia no lleva nota: es para recibir retroalimentación temprano, cuando corregir cuesta poco.</a:t>
             </a:r>
           </a:p>
           <a:p>
@@ -8942,35 +8922,7 @@
                 </a:solidFill>
                 <a:latin typeface="Fira Sans"/>
               </a:rPr>
-              <a:t>La pregunta pendiente desde la clase 3: ¿qué significa el valor p que statsmodels ya nos mostró?</a:t>
-            </a:r>
-          </a:p>
-          <a:p>
-            <a:pPr>
-              <a:lnSpc>
-                <a:spcPct val="112000"/>
-              </a:lnSpc>
-              <a:spcAft>
-                <a:spcPts val="900"/>
-              </a:spcAft>
-            </a:pPr>
-            <a:r>
-              <a:rPr sz="1800" b="1">
-                <a:solidFill>
-                  <a:srgbClr val="E0A437"/>
-                </a:solidFill>
-                <a:latin typeface="Fira Sans"/>
-              </a:rPr>
-              <a:t>▸ </a:t>
-            </a:r>
-            <a:r>
-              <a:rPr sz="1800" b="1">
-                <a:solidFill>
-                  <a:srgbClr val="1D3557"/>
-                </a:solidFill>
-                <a:latin typeface="Fira Sans"/>
-              </a:rPr>
-              <a:t>La formulación se entrega el lunes 7; el primer análisis exploratorio, el lunes 15.</a:t>
+              <a:t>Después de cada equipo, preguntas y comentarios del curso.</a:t>
             </a:r>
           </a:p>
         </p:txBody>
@@ -8984,6 +8936,209 @@
 </file>
 
 <file path=ppt/slides/slide41.xml><?xml version="1.0" encoding="utf-8"?>
+<p:sld xmlns:a="http://schemas.openxmlformats.org/drawingml/2006/main" xmlns:p="http://schemas.openxmlformats.org/presentationml/2006/main" xmlns:r="http://schemas.openxmlformats.org/officeDocument/2006/relationships">
+  <p:cSld>
+    <p:spTree>
+      <p:nvGrpSpPr>
+        <p:cNvPr id="1" name=""/>
+        <p:cNvGrpSpPr/>
+        <p:nvPr/>
+      </p:nvGrpSpPr>
+      <p:grpSpPr/>
+      <p:sp>
+        <p:nvSpPr>
+          <p:cNvPr id="2" name="Rectangle 1"/>
+          <p:cNvSpPr/>
+          <p:nvPr/>
+        </p:nvSpPr>
+        <p:spPr>
+          <a:xfrm>
+            <a:off x="0" y="0"/>
+            <a:ext cx="9144000" cy="5138928"/>
+          </a:xfrm>
+          <a:prstGeom prst="rect">
+            <a:avLst/>
+          </a:prstGeom>
+          <a:solidFill>
+            <a:srgbClr val="FAFBFC"/>
+          </a:solidFill>
+          <a:ln>
+            <a:noFill/>
+          </a:ln>
+          <a:effectLst/>
+        </p:spPr>
+        <p:style>
+          <a:lnRef idx="1">
+            <a:schemeClr val="accent1"/>
+          </a:lnRef>
+          <a:fillRef idx="3">
+            <a:schemeClr val="accent1"/>
+          </a:fillRef>
+          <a:effectRef idx="2">
+            <a:schemeClr val="accent1"/>
+          </a:effectRef>
+          <a:fontRef idx="minor">
+            <a:schemeClr val="lt1"/>
+          </a:fontRef>
+        </p:style>
+        <p:txBody>
+          <a:bodyPr rtlCol="0" anchor="ctr"/>
+          <a:lstStyle/>
+          <a:p>
+            <a:pPr algn="ctr"/>
+          </a:p>
+        </p:txBody>
+      </p:sp>
+      <p:sp>
+        <p:nvSpPr>
+          <p:cNvPr id="3" name="TextBox 2"/>
+          <p:cNvSpPr txBox="1"/>
+          <p:nvPr/>
+        </p:nvSpPr>
+        <p:spPr>
+          <a:xfrm>
+            <a:off x="402336" y="301752"/>
+            <a:ext cx="8348472" cy="795528"/>
+          </a:xfrm>
+          <a:prstGeom prst="rect">
+            <a:avLst/>
+          </a:prstGeom>
+          <a:noFill/>
+        </p:spPr>
+        <p:txBody>
+          <a:bodyPr wrap="square">
+            <a:spAutoFit/>
+          </a:bodyPr>
+          <a:lstStyle/>
+          <a:p>
+            <a:r>
+              <a:rPr sz="2800" b="1">
+                <a:solidFill>
+                  <a:srgbClr val="0F0F0F"/>
+                </a:solidFill>
+                <a:latin typeface="Fira Sans"/>
+              </a:rPr>
+              <a:t>Próxima clase</a:t>
+            </a:r>
+          </a:p>
+        </p:txBody>
+      </p:sp>
+      <p:sp>
+        <p:nvSpPr>
+          <p:cNvPr id="4" name="TextBox 3"/>
+          <p:cNvSpPr txBox="1"/>
+          <p:nvPr/>
+        </p:nvSpPr>
+        <p:spPr>
+          <a:xfrm>
+            <a:off x="704088" y="1353312"/>
+            <a:ext cx="7744968" cy="3300984"/>
+          </a:xfrm>
+          <a:prstGeom prst="rect">
+            <a:avLst/>
+          </a:prstGeom>
+          <a:noFill/>
+        </p:spPr>
+        <p:txBody>
+          <a:bodyPr wrap="square">
+            <a:spAutoFit/>
+          </a:bodyPr>
+          <a:lstStyle/>
+          <a:p>
+            <a:pPr>
+              <a:lnSpc>
+                <a:spcPct val="112000"/>
+              </a:lnSpc>
+              <a:spcAft>
+                <a:spcPts val="900"/>
+              </a:spcAft>
+            </a:pPr>
+            <a:r>
+              <a:rPr sz="1800" b="1">
+                <a:solidFill>
+                  <a:srgbClr val="E0A437"/>
+                </a:solidFill>
+                <a:latin typeface="Fira Sans"/>
+              </a:rPr>
+              <a:t>▸ </a:t>
+            </a:r>
+            <a:r>
+              <a:rPr sz="1800" b="0">
+                <a:solidFill>
+                  <a:srgbClr val="000000"/>
+                </a:solidFill>
+                <a:latin typeface="Fira Sans"/>
+              </a:rPr>
+              <a:t>Martes 8: fundamentos de probabilidad y nociones de inferencia estadística.</a:t>
+            </a:r>
+          </a:p>
+          <a:p>
+            <a:pPr>
+              <a:lnSpc>
+                <a:spcPct val="112000"/>
+              </a:lnSpc>
+              <a:spcAft>
+                <a:spcPts val="900"/>
+              </a:spcAft>
+            </a:pPr>
+            <a:r>
+              <a:rPr sz="1800" b="1">
+                <a:solidFill>
+                  <a:srgbClr val="E0A437"/>
+                </a:solidFill>
+                <a:latin typeface="Fira Sans"/>
+              </a:rPr>
+              <a:t>▸ </a:t>
+            </a:r>
+            <a:r>
+              <a:rPr sz="1800" b="0">
+                <a:solidFill>
+                  <a:srgbClr val="000000"/>
+                </a:solidFill>
+                <a:latin typeface="Fira Sans"/>
+              </a:rPr>
+              <a:t>La pregunta pendiente desde la clase 3: ¿qué significa el valor p que statsmodels ya nos mostró?</a:t>
+            </a:r>
+          </a:p>
+          <a:p>
+            <a:pPr>
+              <a:lnSpc>
+                <a:spcPct val="112000"/>
+              </a:lnSpc>
+              <a:spcAft>
+                <a:spcPts val="900"/>
+              </a:spcAft>
+            </a:pPr>
+            <a:r>
+              <a:rPr sz="1800" b="1">
+                <a:solidFill>
+                  <a:srgbClr val="E0A437"/>
+                </a:solidFill>
+                <a:latin typeface="Fira Sans"/>
+              </a:rPr>
+              <a:t>▸ </a:t>
+            </a:r>
+            <a:r>
+              <a:rPr sz="1800" b="1">
+                <a:solidFill>
+                  <a:srgbClr val="1D3557"/>
+                </a:solidFill>
+                <a:latin typeface="Fira Sans"/>
+              </a:rPr>
+              <a:t>La formulación se entrega el lunes 7; el primer análisis exploratorio, el lunes 15.</a:t>
+            </a:r>
+          </a:p>
+        </p:txBody>
+      </p:sp>
+    </p:spTree>
+  </p:cSld>
+  <p:clrMapOvr>
+    <a:masterClrMapping/>
+  </p:clrMapOvr>
+</p:sld>
+</file>
+
+<file path=ppt/slides/slide42.xml><?xml version="1.0" encoding="utf-8"?>
 <p:sld xmlns:a="http://schemas.openxmlformats.org/drawingml/2006/main" xmlns:p="http://schemas.openxmlformats.org/presentationml/2006/main" xmlns:r="http://schemas.openxmlformats.org/officeDocument/2006/relationships">
   <p:cSld>
     <p:spTree>

</xml_diff>

<commit_message>
Deck clase 4: el mapa de correlaciones antes del modelo de vehiculos con dos variables
La pregunta pasa a ser si agregamos mas variables al modelo de vehiculos;
el mapa decide (las personas, la unica candidata con algo) y recien
despues viene el modelo con ingreso y personas.

Co-Authored-By: Claude Fable 5 <noreply@anthropic.com>
</commit_message>
<xml_diff>
--- a/presentaciones/clase04_regresion_multiple.pptx
+++ b/presentaciones/clase04_regresion_multiple.pptx
@@ -5258,7 +5258,7 @@
                 </a:solidFill>
                 <a:latin typeface="Fira Sans"/>
               </a:rPr>
-              <a:t>¿Mejora el modelo si agregamos el tamaño del hogar?</a:t>
+              <a:t>¿Y si agregamos más variables al modelo de vehículos?</a:t>
             </a:r>
           </a:p>
           <a:p>
@@ -5269,7 +5269,7 @@
                 </a:solidFill>
                 <a:latin typeface="Fira Sans"/>
               </a:rPr>
-              <a:t>Explicar los vehículos con el ingreso y las personas: la primera regresión múltiple</a:t>
+              <a:t>Explicar los vehículos con el ingreso y algo más: ¿qué candidatas trae la tabla de hogares, y cómo se elige? La primera regresión múltiple</a:t>
             </a:r>
           </a:p>
         </p:txBody>
@@ -5365,114 +5365,35 @@
                 </a:solidFill>
                 <a:latin typeface="Fira Sans"/>
               </a:rPr>
-              <a:t>La motorización, con dos variables</a:t>
-            </a:r>
-          </a:p>
-        </p:txBody>
-      </p:sp>
-      <p:sp>
-        <p:nvSpPr>
-          <p:cNvPr id="4" name="Rectangle 3"/>
-          <p:cNvSpPr/>
-          <p:nvPr/>
-        </p:nvSpPr>
-        <p:spPr>
-          <a:xfrm>
-            <a:off x="704088" y="1280160"/>
-            <a:ext cx="7744968" cy="2880360"/>
-          </a:xfrm>
-          <a:prstGeom prst="rect">
-            <a:avLst/>
-          </a:prstGeom>
-          <a:solidFill>
-            <a:srgbClr val="F0F2F5"/>
-          </a:solidFill>
-          <a:ln>
-            <a:solidFill>
-              <a:srgbClr val="D8DDE3"/>
-            </a:solidFill>
-          </a:ln>
-          <a:effectLst/>
-        </p:spPr>
-        <p:style>
-          <a:lnRef idx="1">
-            <a:schemeClr val="accent1"/>
-          </a:lnRef>
-          <a:fillRef idx="3">
-            <a:schemeClr val="accent1"/>
-          </a:fillRef>
-          <a:effectRef idx="2">
-            <a:schemeClr val="accent1"/>
-          </a:effectRef>
-          <a:fontRef idx="minor">
-            <a:schemeClr val="lt1"/>
-          </a:fontRef>
-        </p:style>
-        <p:txBody>
-          <a:bodyPr rtlCol="0" anchor="ctr" wrap="square" lIns="228600" tIns="137160"/>
-          <a:lstStyle/>
-          <a:p>
-            <a:pPr/>
-            <a:r>
-              <a:rPr sz="1500" b="0">
-                <a:solidFill>
-                  <a:srgbClr val="1D3557"/>
-                </a:solidFill>
-                <a:latin typeface="Menlo"/>
-              </a:rPr>
-              <a:t># Explicar los vehículos del hogar con el ingreso y las personas</a:t>
-            </a:r>
-          </a:p>
-          <a:p>
-            <a:pPr/>
-            <a:r>
-              <a:rPr sz="1500" b="0">
-                <a:solidFill>
-                  <a:srgbClr val="1D3557"/>
-                </a:solidFill>
-                <a:latin typeface="Menlo"/>
-              </a:rPr>
-              <a:t>X = sm.add_constant(pd.DataFrame({</a:t>
-            </a:r>
-          </a:p>
-          <a:p>
-            <a:pPr/>
-            <a:r>
-              <a:rPr sz="1500" b="0">
-                <a:solidFill>
-                  <a:srgbClr val="1D3557"/>
-                </a:solidFill>
-                <a:latin typeface="Menlo"/>
-              </a:rPr>
-              <a:t>    "ingreso": h["IngresoHogar"] / 1e6,</a:t>
-            </a:r>
-          </a:p>
-          <a:p>
-            <a:pPr/>
-            <a:r>
-              <a:rPr sz="1500" b="0">
-                <a:solidFill>
-                  <a:srgbClr val="1D3557"/>
-                </a:solidFill>
-                <a:latin typeface="Menlo"/>
-              </a:rPr>
-              <a:t>    "personas": h["NumPer"]}))</a:t>
-            </a:r>
-          </a:p>
-          <a:p>
-            <a:pPr/>
-            <a:r>
-              <a:rPr sz="1500" b="0">
-                <a:solidFill>
-                  <a:srgbClr val="1D3557"/>
-                </a:solidFill>
-                <a:latin typeface="Menlo"/>
-              </a:rPr>
-              <a:t>modelo = sm.WLS(h["NumVeh"], X, weights=h["Factor"]).fit()</a:t>
-            </a:r>
-          </a:p>
-        </p:txBody>
-      </p:sp>
+              <a:t>El mapa para elegir variables</a:t>
+            </a:r>
+          </a:p>
+        </p:txBody>
+      </p:sp>
+      <p:pic>
+        <p:nvPicPr>
+          <p:cNvPr id="4" name="Picture 3" descr="c4_05_mapa_candidatas.png"/>
+          <p:cNvPicPr>
+            <a:picLocks noChangeAspect="1"/>
+          </p:cNvPicPr>
+          <p:nvPr/>
+        </p:nvPicPr>
+        <p:blipFill>
+          <a:blip r:embed="rId2"/>
+          <a:stretch>
+            <a:fillRect/>
+          </a:stretch>
+        </p:blipFill>
+        <p:spPr>
+          <a:xfrm>
+            <a:off x="2530736" y="1143000"/>
+            <a:ext cx="4082527" cy="3154680"/>
+          </a:xfrm>
+          <a:prstGeom prst="rect">
+            <a:avLst/>
+          </a:prstGeom>
+        </p:spPr>
+      </p:pic>
       <p:sp>
         <p:nvSpPr>
           <p:cNvPr id="5" name="TextBox 4"/>
@@ -5481,8 +5402,8 @@
         </p:nvSpPr>
         <p:spPr>
           <a:xfrm>
-            <a:off x="704088" y="4389120"/>
-            <a:ext cx="7744968" cy="1097280"/>
+            <a:off x="704088" y="4434840"/>
+            <a:ext cx="7744968" cy="457200"/>
           </a:xfrm>
           <a:prstGeom prst="rect">
             <a:avLst/>
@@ -5495,31 +5416,14 @@
           </a:bodyPr>
           <a:lstStyle/>
           <a:p>
-            <a:pPr>
-              <a:lnSpc>
-                <a:spcPct val="112000"/>
-              </a:lnSpc>
-              <a:spcAft>
-                <a:spcPts val="900"/>
-              </a:spcAft>
-            </a:pPr>
-            <a:r>
-              <a:rPr sz="1600" b="1">
-                <a:solidFill>
-                  <a:srgbClr val="E0A437"/>
-                </a:solidFill>
-                <a:latin typeface="Fira Sans"/>
-              </a:rPr>
-              <a:t>▸ </a:t>
-            </a:r>
-            <a:r>
-              <a:rPr sz="1600" b="0">
-                <a:solidFill>
-                  <a:srgbClr val="000000"/>
-                </a:solidFill>
-                <a:latin typeface="Fira Sans"/>
-              </a:rPr>
-              <a:t>Ponderado: 0,48 vehículos por millón (era 0,50 a solas) y 0,03 por persona extra. El R² sube apenas, de 0,261 a 0,266: agregar variables no siempre aporta.</a:t>
+            <a:r>
+              <a:rPr sz="1300" b="0">
+                <a:solidFill>
+                  <a:srgbClr val="333333"/>
+                </a:solidFill>
+                <a:latin typeface="Fira Sans"/>
+              </a:rPr>
+              <a:t>La fila de NumVeh es el mapa: ingreso 0,47 es el motor; las personas (0,13) son la única candidata con algo; las bicicletas casi nada (0,06) y redundantes entre sí (0,83). Decisión: agregar las personas.</a:t>
             </a:r>
           </a:p>
         </p:txBody>
@@ -5615,35 +5519,114 @@
                 </a:solidFill>
                 <a:latin typeface="Fira Sans"/>
               </a:rPr>
-              <a:t>La ecuación ajustada y su lectura</a:t>
-            </a:r>
-          </a:p>
-        </p:txBody>
-      </p:sp>
-      <p:pic>
-        <p:nvPicPr>
-          <p:cNvPr id="4" name="Picture 3" descr="c4_08_ecuacion_motorizacion.png"/>
-          <p:cNvPicPr>
-            <a:picLocks noChangeAspect="1"/>
-          </p:cNvPicPr>
-          <p:nvPr/>
-        </p:nvPicPr>
-        <p:blipFill>
-          <a:blip r:embed="rId2"/>
-          <a:stretch>
-            <a:fillRect/>
-          </a:stretch>
-        </p:blipFill>
-        <p:spPr>
-          <a:xfrm>
-            <a:off x="699515" y="1292657"/>
-            <a:ext cx="7744968" cy="2855366"/>
-          </a:xfrm>
-          <a:prstGeom prst="rect">
-            <a:avLst/>
-          </a:prstGeom>
-        </p:spPr>
-      </p:pic>
+              <a:t>La motorización, con dos variables</a:t>
+            </a:r>
+          </a:p>
+        </p:txBody>
+      </p:sp>
+      <p:sp>
+        <p:nvSpPr>
+          <p:cNvPr id="4" name="Rectangle 3"/>
+          <p:cNvSpPr/>
+          <p:nvPr/>
+        </p:nvSpPr>
+        <p:spPr>
+          <a:xfrm>
+            <a:off x="704088" y="1280160"/>
+            <a:ext cx="7744968" cy="2880360"/>
+          </a:xfrm>
+          <a:prstGeom prst="rect">
+            <a:avLst/>
+          </a:prstGeom>
+          <a:solidFill>
+            <a:srgbClr val="F0F2F5"/>
+          </a:solidFill>
+          <a:ln>
+            <a:solidFill>
+              <a:srgbClr val="D8DDE3"/>
+            </a:solidFill>
+          </a:ln>
+          <a:effectLst/>
+        </p:spPr>
+        <p:style>
+          <a:lnRef idx="1">
+            <a:schemeClr val="accent1"/>
+          </a:lnRef>
+          <a:fillRef idx="3">
+            <a:schemeClr val="accent1"/>
+          </a:fillRef>
+          <a:effectRef idx="2">
+            <a:schemeClr val="accent1"/>
+          </a:effectRef>
+          <a:fontRef idx="minor">
+            <a:schemeClr val="lt1"/>
+          </a:fontRef>
+        </p:style>
+        <p:txBody>
+          <a:bodyPr rtlCol="0" anchor="ctr" wrap="square" lIns="228600" tIns="137160"/>
+          <a:lstStyle/>
+          <a:p>
+            <a:pPr/>
+            <a:r>
+              <a:rPr sz="1500" b="0">
+                <a:solidFill>
+                  <a:srgbClr val="1D3557"/>
+                </a:solidFill>
+                <a:latin typeface="Menlo"/>
+              </a:rPr>
+              <a:t># Explicar los vehículos del hogar con el ingreso y las personas</a:t>
+            </a:r>
+          </a:p>
+          <a:p>
+            <a:pPr/>
+            <a:r>
+              <a:rPr sz="1500" b="0">
+                <a:solidFill>
+                  <a:srgbClr val="1D3557"/>
+                </a:solidFill>
+                <a:latin typeface="Menlo"/>
+              </a:rPr>
+              <a:t>X = sm.add_constant(pd.DataFrame({</a:t>
+            </a:r>
+          </a:p>
+          <a:p>
+            <a:pPr/>
+            <a:r>
+              <a:rPr sz="1500" b="0">
+                <a:solidFill>
+                  <a:srgbClr val="1D3557"/>
+                </a:solidFill>
+                <a:latin typeface="Menlo"/>
+              </a:rPr>
+              <a:t>    "ingreso": h["IngresoHogar"] / 1e6,</a:t>
+            </a:r>
+          </a:p>
+          <a:p>
+            <a:pPr/>
+            <a:r>
+              <a:rPr sz="1500" b="0">
+                <a:solidFill>
+                  <a:srgbClr val="1D3557"/>
+                </a:solidFill>
+                <a:latin typeface="Menlo"/>
+              </a:rPr>
+              <a:t>    "personas": h["NumPer"]}))</a:t>
+            </a:r>
+          </a:p>
+          <a:p>
+            <a:pPr/>
+            <a:r>
+              <a:rPr sz="1500" b="0">
+                <a:solidFill>
+                  <a:srgbClr val="1D3557"/>
+                </a:solidFill>
+                <a:latin typeface="Menlo"/>
+              </a:rPr>
+              <a:t>modelo = sm.WLS(h["NumVeh"], X, weights=h["Factor"]).fit()</a:t>
+            </a:r>
+          </a:p>
+        </p:txBody>
+      </p:sp>
       <p:sp>
         <p:nvSpPr>
           <p:cNvPr id="5" name="TextBox 4"/>
@@ -5652,8 +5635,8 @@
         </p:nvSpPr>
         <p:spPr>
           <a:xfrm>
-            <a:off x="704088" y="4434840"/>
-            <a:ext cx="7744968" cy="457200"/>
+            <a:off x="704088" y="4389120"/>
+            <a:ext cx="7744968" cy="1097280"/>
           </a:xfrm>
           <a:prstGeom prst="rect">
             <a:avLst/>
@@ -5666,14 +5649,31 @@
           </a:bodyPr>
           <a:lstStyle/>
           <a:p>
-            <a:r>
-              <a:rPr sz="1300" b="0">
-                <a:solidFill>
-                  <a:srgbClr val="333333"/>
-                </a:solidFill>
-                <a:latin typeface="Fira Sans"/>
-              </a:rPr>
-              <a:t>La fórmula de la múltiple con nuestros números: cada coeficiente se lee con las demás variables fijas.</a:t>
+            <a:pPr>
+              <a:lnSpc>
+                <a:spcPct val="112000"/>
+              </a:lnSpc>
+              <a:spcAft>
+                <a:spcPts val="900"/>
+              </a:spcAft>
+            </a:pPr>
+            <a:r>
+              <a:rPr sz="1600" b="1">
+                <a:solidFill>
+                  <a:srgbClr val="E0A437"/>
+                </a:solidFill>
+                <a:latin typeface="Fira Sans"/>
+              </a:rPr>
+              <a:t>▸ </a:t>
+            </a:r>
+            <a:r>
+              <a:rPr sz="1600" b="0">
+                <a:solidFill>
+                  <a:srgbClr val="000000"/>
+                </a:solidFill>
+                <a:latin typeface="Fira Sans"/>
+              </a:rPr>
+              <a:t>Ponderado: 0,48 vehículos por millón (era 0,50 a solas) y 0,03 por persona extra. El R² sube apenas, de 0,261 a 0,266: agregar variables no siempre aporta.</a:t>
             </a:r>
           </a:p>
         </p:txBody>
@@ -5769,14 +5769,14 @@
                 </a:solidFill>
                 <a:latin typeface="Fira Sans"/>
               </a:rPr>
-              <a:t>Leer el modelo: R²</a:t>
+              <a:t>La ecuación ajustada y su lectura</a:t>
             </a:r>
           </a:p>
         </p:txBody>
       </p:sp>
       <p:pic>
         <p:nvPicPr>
-          <p:cNvPr id="4" name="Picture 3" descr="c4_04_formula_r2.png"/>
+          <p:cNvPr id="4" name="Picture 3" descr="c4_08_ecuacion_motorizacion.png"/>
           <p:cNvPicPr>
             <a:picLocks noChangeAspect="1"/>
           </p:cNvPicPr>
@@ -5790,8 +5790,8 @@
         </p:blipFill>
         <p:spPr>
           <a:xfrm>
-            <a:off x="699515" y="1297266"/>
-            <a:ext cx="7744968" cy="2846146"/>
+            <a:off x="699515" y="1292657"/>
+            <a:ext cx="7744968" cy="2855366"/>
           </a:xfrm>
           <a:prstGeom prst="rect">
             <a:avLst/>
@@ -5827,7 +5827,7 @@
                 </a:solidFill>
                 <a:latin typeface="Fira Sans"/>
               </a:rPr>
-              <a:t>Nuestro 0,266: ingreso y personas explican un cuarto de la variabilidad de los vehículos entre hogares. Agregar variables nunca baja el R²; por eso no basta con mirarlo.</a:t>
+              <a:t>La fórmula de la múltiple con nuestros números: cada coeficiente se lee con las demás variables fijas.</a:t>
             </a:r>
           </a:p>
         </p:txBody>
@@ -5923,14 +5923,14 @@
                 </a:solidFill>
                 <a:latin typeface="Fira Sans"/>
               </a:rPr>
-              <a:t>El valor p: dónde vive</a:t>
+              <a:t>Leer el modelo: R²</a:t>
             </a:r>
           </a:p>
         </p:txBody>
       </p:sp>
       <p:pic>
         <p:nvPicPr>
-          <p:cNvPr id="4" name="Picture 3" descr="c4_07_pvalue_summary.png"/>
+          <p:cNvPr id="4" name="Picture 3" descr="c4_04_formula_r2.png"/>
           <p:cNvPicPr>
             <a:picLocks noChangeAspect="1"/>
           </p:cNvPicPr>
@@ -5944,8 +5944,8 @@
         </p:blipFill>
         <p:spPr>
           <a:xfrm>
-            <a:off x="699515" y="1504912"/>
-            <a:ext cx="7744968" cy="2430856"/>
+            <a:off x="699515" y="1297266"/>
+            <a:ext cx="7744968" cy="2846146"/>
           </a:xfrm>
           <a:prstGeom prst="rect">
             <a:avLst/>
@@ -5981,7 +5981,7 @@
                 </a:solidFill>
                 <a:latin typeface="Fira Sans"/>
               </a:rPr>
-              <a:t>Para cada variable, P&gt;|t| responde: si en la ciudad el ingreso (o las personas) no tuviera efecto alguno sobre los vehículos, ¿qué tan raro sería este coeficiente solo por azar de la muestra? Ambos dan 0,000; la clase 5 lo formaliza.</a:t>
+              <a:t>Nuestro 0,266: ingreso y personas explican un cuarto de la variabilidad de los vehículos entre hogares. Agregar variables nunca baja el R²; por eso no basta con mirarlo.</a:t>
             </a:r>
           </a:p>
         </p:txBody>
@@ -6077,14 +6077,14 @@
                 </a:solidFill>
                 <a:latin typeface="Fira Sans"/>
               </a:rPr>
-              <a:t>El mapa para elegir variables</a:t>
+              <a:t>El valor p: dónde vive</a:t>
             </a:r>
           </a:p>
         </p:txBody>
       </p:sp>
       <p:pic>
         <p:nvPicPr>
-          <p:cNvPr id="4" name="Picture 3" descr="c4_05_mapa_candidatas.png"/>
+          <p:cNvPr id="4" name="Picture 3" descr="c4_07_pvalue_summary.png"/>
           <p:cNvPicPr>
             <a:picLocks noChangeAspect="1"/>
           </p:cNvPicPr>
@@ -6098,8 +6098,8 @@
         </p:blipFill>
         <p:spPr>
           <a:xfrm>
-            <a:off x="2530736" y="1143000"/>
-            <a:ext cx="4082527" cy="3154680"/>
+            <a:off x="699515" y="1504912"/>
+            <a:ext cx="7744968" cy="2430856"/>
           </a:xfrm>
           <a:prstGeom prst="rect">
             <a:avLst/>
@@ -6135,7 +6135,7 @@
                 </a:solidFill>
                 <a:latin typeface="Fira Sans"/>
               </a:rPr>
-              <a:t>La fila de NumVeh es el mapa: ingreso 0,47 es el motor; las bicicletas casi no correlacionan con los vehículos (0,06) y son redundantes entre sí (0,83). Probarlas confirma: R² 0,266 a 0,267.</a:t>
+              <a:t>Para cada variable, P&gt;|t| responde: si en la ciudad el ingreso (o las personas) no tuviera efecto alguno sobre los vehículos, ¿qué tan raro sería este coeficiente solo por azar de la muestra? Ambos dan 0,000; la clase 5 lo formaliza.</a:t>
             </a:r>
           </a:p>
         </p:txBody>

</xml_diff>

<commit_message>
Deck clase 4: el summary antes de la ecuacion ajustada, con los coeficientes y el valor p marcados
Co-Authored-By: Claude Fable 5 <noreply@anthropic.com>
</commit_message>
<xml_diff>
--- a/presentaciones/clase04_regresion_multiple.pptx
+++ b/presentaciones/clase04_regresion_multiple.pptx
@@ -5769,14 +5769,14 @@
                 </a:solidFill>
                 <a:latin typeface="Fira Sans"/>
               </a:rPr>
-              <a:t>La ecuación ajustada y su lectura</a:t>
+              <a:t>El summary: los coeficientes y el valor p</a:t>
             </a:r>
           </a:p>
         </p:txBody>
       </p:sp>
       <p:pic>
         <p:nvPicPr>
-          <p:cNvPr id="4" name="Picture 3" descr="c4_08_ecuacion_motorizacion.png"/>
+          <p:cNvPr id="4" name="Picture 3" descr="c4_07_pvalue_summary.png"/>
           <p:cNvPicPr>
             <a:picLocks noChangeAspect="1"/>
           </p:cNvPicPr>
@@ -5790,8 +5790,8 @@
         </p:blipFill>
         <p:spPr>
           <a:xfrm>
-            <a:off x="699515" y="1292657"/>
-            <a:ext cx="7744968" cy="2855366"/>
+            <a:off x="699515" y="1504912"/>
+            <a:ext cx="7744968" cy="2430856"/>
           </a:xfrm>
           <a:prstGeom prst="rect">
             <a:avLst/>
@@ -5827,7 +5827,7 @@
                 </a:solidFill>
                 <a:latin typeface="Fira Sans"/>
               </a:rPr>
-              <a:t>La fórmula de la múltiple con nuestros números: cada coeficiente se lee con las demás variables fijas.</a:t>
+              <a:t>coef es el modelo ajustado: de ahí sale la ecuación que sigue. P&gt;|t| responde, por variable: si en la ciudad el ingreso (o las personas) no tuviera efecto sobre los vehículos, ¿qué tan raro sería este coeficiente por azar de la muestra? Ambos dan 0,000.</a:t>
             </a:r>
           </a:p>
         </p:txBody>
@@ -5923,14 +5923,14 @@
                 </a:solidFill>
                 <a:latin typeface="Fira Sans"/>
               </a:rPr>
-              <a:t>Leer el modelo: R²</a:t>
+              <a:t>La ecuación ajustada y su lectura</a:t>
             </a:r>
           </a:p>
         </p:txBody>
       </p:sp>
       <p:pic>
         <p:nvPicPr>
-          <p:cNvPr id="4" name="Picture 3" descr="c4_04_formula_r2.png"/>
+          <p:cNvPr id="4" name="Picture 3" descr="c4_08_ecuacion_motorizacion.png"/>
           <p:cNvPicPr>
             <a:picLocks noChangeAspect="1"/>
           </p:cNvPicPr>
@@ -5944,8 +5944,8 @@
         </p:blipFill>
         <p:spPr>
           <a:xfrm>
-            <a:off x="699515" y="1297266"/>
-            <a:ext cx="7744968" cy="2846146"/>
+            <a:off x="699515" y="1292657"/>
+            <a:ext cx="7744968" cy="2855366"/>
           </a:xfrm>
           <a:prstGeom prst="rect">
             <a:avLst/>
@@ -5981,7 +5981,7 @@
                 </a:solidFill>
                 <a:latin typeface="Fira Sans"/>
               </a:rPr>
-              <a:t>Nuestro 0,266: ingreso y personas explican un cuarto de la variabilidad de los vehículos entre hogares. Agregar variables nunca baja el R²; por eso no basta con mirarlo.</a:t>
+              <a:t>La fórmula de la múltiple con nuestros números: cada coeficiente se lee con las demás variables fijas.</a:t>
             </a:r>
           </a:p>
         </p:txBody>
@@ -6077,14 +6077,14 @@
                 </a:solidFill>
                 <a:latin typeface="Fira Sans"/>
               </a:rPr>
-              <a:t>El valor p: dónde vive</a:t>
+              <a:t>Leer el modelo: R²</a:t>
             </a:r>
           </a:p>
         </p:txBody>
       </p:sp>
       <p:pic>
         <p:nvPicPr>
-          <p:cNvPr id="4" name="Picture 3" descr="c4_07_pvalue_summary.png"/>
+          <p:cNvPr id="4" name="Picture 3" descr="c4_04_formula_r2.png"/>
           <p:cNvPicPr>
             <a:picLocks noChangeAspect="1"/>
           </p:cNvPicPr>
@@ -6098,8 +6098,8 @@
         </p:blipFill>
         <p:spPr>
           <a:xfrm>
-            <a:off x="699515" y="1504912"/>
-            <a:ext cx="7744968" cy="2430856"/>
+            <a:off x="699515" y="1297266"/>
+            <a:ext cx="7744968" cy="2846146"/>
           </a:xfrm>
           <a:prstGeom prst="rect">
             <a:avLst/>
@@ -6135,7 +6135,7 @@
                 </a:solidFill>
                 <a:latin typeface="Fira Sans"/>
               </a:rPr>
-              <a:t>Para cada variable, P&gt;|t| responde: si en la ciudad el ingreso (o las personas) no tuviera efecto alguno sobre los vehículos, ¿qué tan raro sería este coeficiente solo por azar de la muestra? Ambos dan 0,000; la clase 5 lo formaliza.</a:t>
+              <a:t>Nuestro 0,266: ingreso y personas explican un cuarto de la variabilidad de los vehículos entre hogares. Agregar variables nunca baja el R²; por eso no basta con mirarlo.</a:t>
             </a:r>
           </a:p>
         </p:txBody>

</xml_diff>

<commit_message>
Clase 4: mapa de correlaciones tambien para el modelo de duracion; el ingreso queda como ejercicio
Consistente con vehiculos: antes de decidir que agregar, el mapa (con
duracion y distancia en log). La distancia da 0,73 y el ingreso 0,00 por
viaje: el -0,34 de la clase 3 era entre comunas, y la escala cambia la
respuesta. Probar el ingreso en el modelo pasa al ejercicio 5 del
notebook. Deck en 43 slides.

Co-Authored-By: Claude Fable 5 <noreply@anthropic.com>
</commit_message>
<xml_diff>
--- a/presentaciones/clase04_regresion_multiple.pptx
+++ b/presentaciones/clase04_regresion_multiple.pptx
@@ -47,6 +47,7 @@
     <p:sldId id="295" r:id="rId46"/>
     <p:sldId id="296" r:id="rId47"/>
     <p:sldId id="297" r:id="rId48"/>
+    <p:sldId id="298" r:id="rId49"/>
   </p:sldIdLst>
   <p:sldSz cx="9144000" cy="5138928" type="screen4x3"/>
   <p:notesSz cx="6858000" cy="9144000"/>
@@ -7012,14 +7013,14 @@
                 </a:solidFill>
                 <a:latin typeface="Fira Sans"/>
               </a:rPr>
-              <a:t>¿Qué más podría explicar la duración?</a:t>
+              <a:t>El mapa, también para la duración</a:t>
             </a:r>
           </a:p>
         </p:txBody>
       </p:sp>
       <p:pic>
         <p:nvPicPr>
-          <p:cNvPr id="4" name="Picture 3" descr="c4_13_por_modo.png"/>
+          <p:cNvPr id="4" name="Picture 3" descr="c4_15_mapa_duracion.png"/>
           <p:cNvPicPr>
             <a:picLocks noChangeAspect="1"/>
           </p:cNvPicPr>
@@ -7033,8 +7034,8 @@
         </p:blipFill>
         <p:spPr>
           <a:xfrm>
-            <a:off x="699515" y="1409022"/>
-            <a:ext cx="7744968" cy="2622635"/>
+            <a:off x="2529769" y="1143000"/>
+            <a:ext cx="4084460" cy="3154680"/>
           </a:xfrm>
           <a:prstGeom prst="rect">
             <a:avLst/>
@@ -7070,7 +7071,7 @@
                 </a:solidFill>
                 <a:latin typeface="Fira Sans"/>
               </a:rPr>
-              <a:t>Las numéricas del hogar no ayudan (ingreso r = −0,03, vehículos −0,09). El modo, que la matriz no ve, sí: Bip! 62 min contra 15 de caminata. Pero Bip! también va más lejos: hay que comparar a igual distancia.</a:t>
+              <a:t>Igual que en vehículos, primero el mapa. La distancia (en log) es el motor: 0,73. El ingreso da 0,00 por viaje: el −0,34 de la clase 3 era entre comunas, y un promedio esconde a los individuos. Al modo, que es texto, el mapa no lo ve.</a:t>
             </a:r>
           </a:p>
         </p:txBody>
@@ -7166,21 +7167,45 @@
                 </a:solidFill>
                 <a:latin typeface="Fira Sans"/>
               </a:rPr>
-              <a:t>Decisión 2: agregar el modo</a:t>
-            </a:r>
-          </a:p>
-        </p:txBody>
-      </p:sp>
-      <p:sp>
-        <p:nvSpPr>
-          <p:cNvPr id="4" name="TextBox 3"/>
+              <a:t>¿Qué más podría explicar la duración?</a:t>
+            </a:r>
+          </a:p>
+        </p:txBody>
+      </p:sp>
+      <p:pic>
+        <p:nvPicPr>
+          <p:cNvPr id="4" name="Picture 3" descr="c4_13_por_modo.png"/>
+          <p:cNvPicPr>
+            <a:picLocks noChangeAspect="1"/>
+          </p:cNvPicPr>
+          <p:nvPr/>
+        </p:nvPicPr>
+        <p:blipFill>
+          <a:blip r:embed="rId2"/>
+          <a:stretch>
+            <a:fillRect/>
+          </a:stretch>
+        </p:blipFill>
+        <p:spPr>
+          <a:xfrm>
+            <a:off x="699515" y="1409022"/>
+            <a:ext cx="7744968" cy="2622635"/>
+          </a:xfrm>
+          <a:prstGeom prst="rect">
+            <a:avLst/>
+          </a:prstGeom>
+        </p:spPr>
+      </p:pic>
+      <p:sp>
+        <p:nvSpPr>
+          <p:cNvPr id="5" name="TextBox 4"/>
           <p:cNvSpPr txBox="1"/>
           <p:nvPr/>
         </p:nvSpPr>
         <p:spPr>
           <a:xfrm>
-            <a:off x="704088" y="1353312"/>
-            <a:ext cx="7744968" cy="3300984"/>
+            <a:off x="704088" y="4434840"/>
+            <a:ext cx="7744968" cy="457200"/>
           </a:xfrm>
           <a:prstGeom prst="rect">
             <a:avLst/>
@@ -7193,115 +7218,14 @@
           </a:bodyPr>
           <a:lstStyle/>
           <a:p>
-            <a:pPr>
-              <a:lnSpc>
-                <a:spcPct val="112000"/>
-              </a:lnSpc>
-              <a:spcAft>
-                <a:spcPts val="900"/>
-              </a:spcAft>
-            </a:pPr>
-            <a:r>
-              <a:rPr sz="1800" b="1">
-                <a:solidFill>
-                  <a:srgbClr val="E0A437"/>
-                </a:solidFill>
-                <a:latin typeface="Fira Sans"/>
-              </a:rPr>
-              <a:t>▸ </a:t>
-            </a:r>
-            <a:r>
-              <a:rPr sz="1800" b="1">
-                <a:solidFill>
-                  <a:srgbClr val="1D3557"/>
-                </a:solidFill>
-                <a:latin typeface="Fira Sans"/>
-              </a:rPr>
-              <a:t>El modo es la candidata de mayor contraste y responde una pregunta de equidad: ¿cuánto más tarda un viaje según el modo, a igual distancia?</a:t>
-            </a:r>
-          </a:p>
-          <a:p>
-            <a:pPr>
-              <a:lnSpc>
-                <a:spcPct val="112000"/>
-              </a:lnSpc>
-              <a:spcAft>
-                <a:spcPts val="900"/>
-              </a:spcAft>
-            </a:pPr>
-            <a:r>
-              <a:rPr sz="1800" b="1">
-                <a:solidFill>
-                  <a:srgbClr val="E0A437"/>
-                </a:solidFill>
-                <a:latin typeface="Fira Sans"/>
-              </a:rPr>
-              <a:t>▸ </a:t>
-            </a:r>
-            <a:r>
-              <a:rPr sz="1800" b="0">
-                <a:solidFill>
-                  <a:srgbClr val="000000"/>
-                </a:solidFill>
-                <a:latin typeface="Fira Sans"/>
-              </a:rPr>
-              <a:t>Comparar duraciones a secas mezcla el modo con la distancia; la regresión múltiple controla la distancia y aísla el modo.</a:t>
-            </a:r>
-          </a:p>
-          <a:p>
-            <a:pPr>
-              <a:lnSpc>
-                <a:spcPct val="112000"/>
-              </a:lnSpc>
-              <a:spcAft>
-                <a:spcPts val="900"/>
-              </a:spcAft>
-            </a:pPr>
-            <a:r>
-              <a:rPr sz="1800" b="1">
-                <a:solidFill>
-                  <a:srgbClr val="E0A437"/>
-                </a:solidFill>
-                <a:latin typeface="Fira Sans"/>
-              </a:rPr>
-              <a:t>▸ </a:t>
-            </a:r>
-            <a:r>
-              <a:rPr sz="1800" b="0">
-                <a:solidFill>
-                  <a:srgbClr val="000000"/>
-                </a:solidFill>
-                <a:latin typeface="Fira Sans"/>
-              </a:rPr>
-              <a:t>Como el modo es texto, no puede entrar tal cual a la fórmula: primero hay que convertirlo en números.</a:t>
-            </a:r>
-          </a:p>
-          <a:p>
-            <a:pPr>
-              <a:lnSpc>
-                <a:spcPct val="112000"/>
-              </a:lnSpc>
-              <a:spcAft>
-                <a:spcPts val="900"/>
-              </a:spcAft>
-            </a:pPr>
-            <a:r>
-              <a:rPr sz="1800" b="1">
-                <a:solidFill>
-                  <a:srgbClr val="E0A437"/>
-                </a:solidFill>
-                <a:latin typeface="Fira Sans"/>
-              </a:rPr>
-              <a:t>▸ </a:t>
-            </a:r>
-            <a:r>
-              <a:rPr sz="1800" b="0">
-                <a:solidFill>
-                  <a:srgbClr val="000000"/>
-                </a:solidFill>
-                <a:latin typeface="Fira Sans"/>
-              </a:rPr>
-              <a:t>El período del día es la otra candidata fuerte (punta mañana 60 min, fuera de punta 32): queda para el ejercicio.</a:t>
+            <a:r>
+              <a:rPr sz="1300" b="0">
+                <a:solidFill>
+                  <a:srgbClr val="333333"/>
+                </a:solidFill>
+                <a:latin typeface="Fira Sans"/>
+              </a:rPr>
+              <a:t>Las categóricas se miran con groupby: el modo sí importa, Bip! 62 min contra 15 de caminata. Pero Bip! también va más lejos (7,5 km contra 0,4): hay que comparar a igual distancia.</a:t>
             </a:r>
           </a:p>
         </p:txBody>
@@ -7397,45 +7321,21 @@
                 </a:solidFill>
                 <a:latin typeface="Fira Sans"/>
               </a:rPr>
-              <a:t>Una categórica, convertida en columnas 0/1</a:t>
-            </a:r>
-          </a:p>
-        </p:txBody>
-      </p:sp>
-      <p:pic>
-        <p:nvPicPr>
-          <p:cNvPr id="4" name="Picture 3" descr="c4_11_dummies_tabla.png"/>
-          <p:cNvPicPr>
-            <a:picLocks noChangeAspect="1"/>
-          </p:cNvPicPr>
-          <p:nvPr/>
-        </p:nvPicPr>
-        <p:blipFill>
-          <a:blip r:embed="rId2"/>
-          <a:stretch>
-            <a:fillRect/>
-          </a:stretch>
-        </p:blipFill>
-        <p:spPr>
-          <a:xfrm>
-            <a:off x="755966" y="1143000"/>
-            <a:ext cx="7632067" cy="3154680"/>
-          </a:xfrm>
-          <a:prstGeom prst="rect">
-            <a:avLst/>
-          </a:prstGeom>
-        </p:spPr>
-      </p:pic>
-      <p:sp>
-        <p:nvSpPr>
-          <p:cNvPr id="5" name="TextBox 4"/>
+              <a:t>Decisión 2: agregar el modo</a:t>
+            </a:r>
+          </a:p>
+        </p:txBody>
+      </p:sp>
+      <p:sp>
+        <p:nvSpPr>
+          <p:cNvPr id="4" name="TextBox 3"/>
           <p:cNvSpPr txBox="1"/>
           <p:nvPr/>
         </p:nvSpPr>
         <p:spPr>
           <a:xfrm>
-            <a:off x="704088" y="4434840"/>
-            <a:ext cx="7744968" cy="457200"/>
+            <a:off x="704088" y="1353312"/>
+            <a:ext cx="7744968" cy="3300984"/>
           </a:xfrm>
           <a:prstGeom prst="rect">
             <a:avLst/>
@@ -7448,14 +7348,115 @@
           </a:bodyPr>
           <a:lstStyle/>
           <a:p>
-            <a:r>
-              <a:rPr sz="1300" b="0">
-                <a:solidFill>
-                  <a:srgbClr val="333333"/>
-                </a:solidFill>
-                <a:latin typeface="Fira Sans"/>
-              </a:rPr>
-              <a:t>El modo es texto y la fórmula solo suma números: pd.get_dummies crea una columna por categoría. Cada viaje tiene un solo 1, en la de su modo; el auto se saca y queda de referencia.</a:t>
+            <a:pPr>
+              <a:lnSpc>
+                <a:spcPct val="112000"/>
+              </a:lnSpc>
+              <a:spcAft>
+                <a:spcPts val="900"/>
+              </a:spcAft>
+            </a:pPr>
+            <a:r>
+              <a:rPr sz="1800" b="1">
+                <a:solidFill>
+                  <a:srgbClr val="E0A437"/>
+                </a:solidFill>
+                <a:latin typeface="Fira Sans"/>
+              </a:rPr>
+              <a:t>▸ </a:t>
+            </a:r>
+            <a:r>
+              <a:rPr sz="1800" b="1">
+                <a:solidFill>
+                  <a:srgbClr val="1D3557"/>
+                </a:solidFill>
+                <a:latin typeface="Fira Sans"/>
+              </a:rPr>
+              <a:t>El modo es la candidata de mayor contraste y responde una pregunta de equidad: ¿cuánto más tarda un viaje según el modo, a igual distancia?</a:t>
+            </a:r>
+          </a:p>
+          <a:p>
+            <a:pPr>
+              <a:lnSpc>
+                <a:spcPct val="112000"/>
+              </a:lnSpc>
+              <a:spcAft>
+                <a:spcPts val="900"/>
+              </a:spcAft>
+            </a:pPr>
+            <a:r>
+              <a:rPr sz="1800" b="1">
+                <a:solidFill>
+                  <a:srgbClr val="E0A437"/>
+                </a:solidFill>
+                <a:latin typeface="Fira Sans"/>
+              </a:rPr>
+              <a:t>▸ </a:t>
+            </a:r>
+            <a:r>
+              <a:rPr sz="1800" b="0">
+                <a:solidFill>
+                  <a:srgbClr val="000000"/>
+                </a:solidFill>
+                <a:latin typeface="Fira Sans"/>
+              </a:rPr>
+              <a:t>Comparar duraciones a secas mezcla el modo con la distancia; la regresión múltiple controla la distancia y aísla el modo.</a:t>
+            </a:r>
+          </a:p>
+          <a:p>
+            <a:pPr>
+              <a:lnSpc>
+                <a:spcPct val="112000"/>
+              </a:lnSpc>
+              <a:spcAft>
+                <a:spcPts val="900"/>
+              </a:spcAft>
+            </a:pPr>
+            <a:r>
+              <a:rPr sz="1800" b="1">
+                <a:solidFill>
+                  <a:srgbClr val="E0A437"/>
+                </a:solidFill>
+                <a:latin typeface="Fira Sans"/>
+              </a:rPr>
+              <a:t>▸ </a:t>
+            </a:r>
+            <a:r>
+              <a:rPr sz="1800" b="0">
+                <a:solidFill>
+                  <a:srgbClr val="000000"/>
+                </a:solidFill>
+                <a:latin typeface="Fira Sans"/>
+              </a:rPr>
+              <a:t>Como el modo es texto, no puede entrar tal cual a la fórmula: primero hay que convertirlo en números.</a:t>
+            </a:r>
+          </a:p>
+          <a:p>
+            <a:pPr>
+              <a:lnSpc>
+                <a:spcPct val="112000"/>
+              </a:lnSpc>
+              <a:spcAft>
+                <a:spcPts val="900"/>
+              </a:spcAft>
+            </a:pPr>
+            <a:r>
+              <a:rPr sz="1800" b="1">
+                <a:solidFill>
+                  <a:srgbClr val="E0A437"/>
+                </a:solidFill>
+                <a:latin typeface="Fira Sans"/>
+              </a:rPr>
+              <a:t>▸ </a:t>
+            </a:r>
+            <a:r>
+              <a:rPr sz="1800" b="0">
+                <a:solidFill>
+                  <a:srgbClr val="000000"/>
+                </a:solidFill>
+                <a:latin typeface="Fira Sans"/>
+              </a:rPr>
+              <a:t>El período del día es la otra candidata fuerte (punta mañana 60 min, fuera de punta 32): queda para el ejercicio.</a:t>
             </a:r>
           </a:p>
         </p:txBody>
@@ -7551,114 +7552,35 @@
                 </a:solidFill>
                 <a:latin typeface="Fira Sans"/>
               </a:rPr>
-              <a:t>Las dummies, en código</a:t>
-            </a:r>
-          </a:p>
-        </p:txBody>
-      </p:sp>
-      <p:sp>
-        <p:nvSpPr>
-          <p:cNvPr id="4" name="Rectangle 3"/>
-          <p:cNvSpPr/>
-          <p:nvPr/>
-        </p:nvSpPr>
-        <p:spPr>
-          <a:xfrm>
-            <a:off x="704088" y="1280160"/>
-            <a:ext cx="7744968" cy="2880360"/>
-          </a:xfrm>
-          <a:prstGeom prst="rect">
-            <a:avLst/>
-          </a:prstGeom>
-          <a:solidFill>
-            <a:srgbClr val="F0F2F5"/>
-          </a:solidFill>
-          <a:ln>
-            <a:solidFill>
-              <a:srgbClr val="D8DDE3"/>
-            </a:solidFill>
-          </a:ln>
-          <a:effectLst/>
-        </p:spPr>
-        <p:style>
-          <a:lnRef idx="1">
-            <a:schemeClr val="accent1"/>
-          </a:lnRef>
-          <a:fillRef idx="3">
-            <a:schemeClr val="accent1"/>
-          </a:fillRef>
-          <a:effectRef idx="2">
-            <a:schemeClr val="accent1"/>
-          </a:effectRef>
-          <a:fontRef idx="minor">
-            <a:schemeClr val="lt1"/>
-          </a:fontRef>
-        </p:style>
-        <p:txBody>
-          <a:bodyPr rtlCol="0" anchor="ctr" wrap="square" lIns="228600" tIns="137160"/>
-          <a:lstStyle/>
-          <a:p>
-            <a:pPr/>
-            <a:r>
-              <a:rPr sz="1500" b="0">
-                <a:solidFill>
-                  <a:srgbClr val="1D3557"/>
-                </a:solidFill>
-                <a:latin typeface="Menlo"/>
-              </a:rPr>
-              <a:t># Una columna 0/1 por modo; el auto queda de referencia</a:t>
-            </a:r>
-          </a:p>
-          <a:p>
-            <a:pPr/>
-            <a:r>
-              <a:rPr sz="1500" b="0">
-                <a:solidFill>
-                  <a:srgbClr val="1D3557"/>
-                </a:solidFill>
-                <a:latin typeface="Menlo"/>
-              </a:rPr>
-              <a:t>dummies = pd.get_dummies(viajes["ModoAgrupado"])</a:t>
-            </a:r>
-          </a:p>
-          <a:p>
-            <a:pPr/>
-            <a:r>
-              <a:rPr sz="1500" b="0">
-                <a:solidFill>
-                  <a:srgbClr val="1D3557"/>
-                </a:solidFill>
-                <a:latin typeface="Menlo"/>
-              </a:rPr>
-              <a:t>dummies = dummies.drop(columns=["Auto"])</a:t>
-            </a:r>
-          </a:p>
-          <a:p>
-            <a:pPr/>
-            <a:r>
-              <a:rPr sz="1500" b="0">
-                <a:solidFill>
-                  <a:srgbClr val="1D3557"/>
-                </a:solidFill>
-                <a:latin typeface="Menlo"/>
-              </a:rPr>
-              <a:t/>
-            </a:r>
-          </a:p>
-          <a:p>
-            <a:pPr/>
-            <a:r>
-              <a:rPr sz="1500" b="0">
-                <a:solidFill>
-                  <a:srgbClr val="1D3557"/>
-                </a:solidFill>
-                <a:latin typeface="Menlo"/>
-              </a:rPr>
-              <a:t># Explicar la duración (log) con la distancia (log) y el modo</a:t>
-            </a:r>
-          </a:p>
-        </p:txBody>
-      </p:sp>
+              <a:t>Una categórica, convertida en columnas 0/1</a:t>
+            </a:r>
+          </a:p>
+        </p:txBody>
+      </p:sp>
+      <p:pic>
+        <p:nvPicPr>
+          <p:cNvPr id="4" name="Picture 3" descr="c4_11_dummies_tabla.png"/>
+          <p:cNvPicPr>
+            <a:picLocks noChangeAspect="1"/>
+          </p:cNvPicPr>
+          <p:nvPr/>
+        </p:nvPicPr>
+        <p:blipFill>
+          <a:blip r:embed="rId2"/>
+          <a:stretch>
+            <a:fillRect/>
+          </a:stretch>
+        </p:blipFill>
+        <p:spPr>
+          <a:xfrm>
+            <a:off x="755966" y="1143000"/>
+            <a:ext cx="7632067" cy="3154680"/>
+          </a:xfrm>
+          <a:prstGeom prst="rect">
+            <a:avLst/>
+          </a:prstGeom>
+        </p:spPr>
+      </p:pic>
       <p:sp>
         <p:nvSpPr>
           <p:cNvPr id="5" name="TextBox 4"/>
@@ -7667,8 +7589,8 @@
         </p:nvSpPr>
         <p:spPr>
           <a:xfrm>
-            <a:off x="704088" y="4389120"/>
-            <a:ext cx="7744968" cy="1097280"/>
+            <a:off x="704088" y="4434840"/>
+            <a:ext cx="7744968" cy="457200"/>
           </a:xfrm>
           <a:prstGeom prst="rect">
             <a:avLst/>
@@ -7681,31 +7603,14 @@
           </a:bodyPr>
           <a:lstStyle/>
           <a:p>
-            <a:pPr>
-              <a:lnSpc>
-                <a:spcPct val="112000"/>
-              </a:lnSpc>
-              <a:spcAft>
-                <a:spcPts val="900"/>
-              </a:spcAft>
-            </a:pPr>
-            <a:r>
-              <a:rPr sz="1600" b="1">
-                <a:solidFill>
-                  <a:srgbClr val="E0A437"/>
-                </a:solidFill>
-                <a:latin typeface="Fira Sans"/>
-              </a:rPr>
-              <a:t>▸ </a:t>
-            </a:r>
-            <a:r>
-              <a:rPr sz="1600" b="0">
-                <a:solidFill>
-                  <a:srgbClr val="000000"/>
-                </a:solidFill>
-                <a:latin typeface="Fira Sans"/>
-              </a:rPr>
-              <a:t>Las dummies se agregan a la X junto al log de la distancia. Cada coeficiente se lee comparado con la referencia: ese modo frente al auto, a igual distancia.</a:t>
+            <a:r>
+              <a:rPr sz="1300" b="0">
+                <a:solidFill>
+                  <a:srgbClr val="333333"/>
+                </a:solidFill>
+                <a:latin typeface="Fira Sans"/>
+              </a:rPr>
+              <a:t>El modo es texto y la fórmula solo suma números: pd.get_dummies crea una columna por categoría. Cada viaje tiene un solo 1, en la de su modo; el auto se saca y queda de referencia.</a:t>
             </a:r>
           </a:p>
         </p:txBody>
@@ -7801,35 +7706,114 @@
                 </a:solidFill>
                 <a:latin typeface="Fira Sans"/>
               </a:rPr>
-              <a:t>Qué hace una dummy dentro del modelo</a:t>
-            </a:r>
-          </a:p>
-        </p:txBody>
-      </p:sp>
-      <p:pic>
-        <p:nvPicPr>
-          <p:cNvPr id="4" name="Picture 3" descr="c4_12_dummies_rectas.png"/>
-          <p:cNvPicPr>
-            <a:picLocks noChangeAspect="1"/>
-          </p:cNvPicPr>
-          <p:nvPr/>
-        </p:nvPicPr>
-        <p:blipFill>
-          <a:blip r:embed="rId2"/>
-          <a:stretch>
-            <a:fillRect/>
-          </a:stretch>
-        </p:blipFill>
-        <p:spPr>
-          <a:xfrm>
-            <a:off x="1280160" y="1143000"/>
-            <a:ext cx="6583680" cy="3154680"/>
-          </a:xfrm>
-          <a:prstGeom prst="rect">
-            <a:avLst/>
-          </a:prstGeom>
-        </p:spPr>
-      </p:pic>
+              <a:t>Las dummies, en código</a:t>
+            </a:r>
+          </a:p>
+        </p:txBody>
+      </p:sp>
+      <p:sp>
+        <p:nvSpPr>
+          <p:cNvPr id="4" name="Rectangle 3"/>
+          <p:cNvSpPr/>
+          <p:nvPr/>
+        </p:nvSpPr>
+        <p:spPr>
+          <a:xfrm>
+            <a:off x="704088" y="1280160"/>
+            <a:ext cx="7744968" cy="2880360"/>
+          </a:xfrm>
+          <a:prstGeom prst="rect">
+            <a:avLst/>
+          </a:prstGeom>
+          <a:solidFill>
+            <a:srgbClr val="F0F2F5"/>
+          </a:solidFill>
+          <a:ln>
+            <a:solidFill>
+              <a:srgbClr val="D8DDE3"/>
+            </a:solidFill>
+          </a:ln>
+          <a:effectLst/>
+        </p:spPr>
+        <p:style>
+          <a:lnRef idx="1">
+            <a:schemeClr val="accent1"/>
+          </a:lnRef>
+          <a:fillRef idx="3">
+            <a:schemeClr val="accent1"/>
+          </a:fillRef>
+          <a:effectRef idx="2">
+            <a:schemeClr val="accent1"/>
+          </a:effectRef>
+          <a:fontRef idx="minor">
+            <a:schemeClr val="lt1"/>
+          </a:fontRef>
+        </p:style>
+        <p:txBody>
+          <a:bodyPr rtlCol="0" anchor="ctr" wrap="square" lIns="228600" tIns="137160"/>
+          <a:lstStyle/>
+          <a:p>
+            <a:pPr/>
+            <a:r>
+              <a:rPr sz="1500" b="0">
+                <a:solidFill>
+                  <a:srgbClr val="1D3557"/>
+                </a:solidFill>
+                <a:latin typeface="Menlo"/>
+              </a:rPr>
+              <a:t># Una columna 0/1 por modo; el auto queda de referencia</a:t>
+            </a:r>
+          </a:p>
+          <a:p>
+            <a:pPr/>
+            <a:r>
+              <a:rPr sz="1500" b="0">
+                <a:solidFill>
+                  <a:srgbClr val="1D3557"/>
+                </a:solidFill>
+                <a:latin typeface="Menlo"/>
+              </a:rPr>
+              <a:t>dummies = pd.get_dummies(viajes["ModoAgrupado"])</a:t>
+            </a:r>
+          </a:p>
+          <a:p>
+            <a:pPr/>
+            <a:r>
+              <a:rPr sz="1500" b="0">
+                <a:solidFill>
+                  <a:srgbClr val="1D3557"/>
+                </a:solidFill>
+                <a:latin typeface="Menlo"/>
+              </a:rPr>
+              <a:t>dummies = dummies.drop(columns=["Auto"])</a:t>
+            </a:r>
+          </a:p>
+          <a:p>
+            <a:pPr/>
+            <a:r>
+              <a:rPr sz="1500" b="0">
+                <a:solidFill>
+                  <a:srgbClr val="1D3557"/>
+                </a:solidFill>
+                <a:latin typeface="Menlo"/>
+              </a:rPr>
+              <a:t/>
+            </a:r>
+          </a:p>
+          <a:p>
+            <a:pPr/>
+            <a:r>
+              <a:rPr sz="1500" b="0">
+                <a:solidFill>
+                  <a:srgbClr val="1D3557"/>
+                </a:solidFill>
+                <a:latin typeface="Menlo"/>
+              </a:rPr>
+              <a:t># Explicar la duración (log) con la distancia (log) y el modo</a:t>
+            </a:r>
+          </a:p>
+        </p:txBody>
+      </p:sp>
       <p:sp>
         <p:nvSpPr>
           <p:cNvPr id="5" name="TextBox 4"/>
@@ -7838,8 +7822,8 @@
         </p:nvSpPr>
         <p:spPr>
           <a:xfrm>
-            <a:off x="704088" y="4434840"/>
-            <a:ext cx="7744968" cy="457200"/>
+            <a:off x="704088" y="4389120"/>
+            <a:ext cx="7744968" cy="1097280"/>
           </a:xfrm>
           <a:prstGeom prst="rect">
             <a:avLst/>
@@ -7852,14 +7836,31 @@
           </a:bodyPr>
           <a:lstStyle/>
           <a:p>
-            <a:r>
-              <a:rPr sz="1300" b="0">
-                <a:solidFill>
-                  <a:srgbClr val="333333"/>
-                </a:solidFill>
-                <a:latin typeface="Fira Sans"/>
-              </a:rPr>
-              <a:t>La dummy suma su coeficiente al intercepto de su modo: rectas paralelas, con la misma pendiente en la distancia. En log, sumar 0,27 es multiplicar el tiempo por 1,87.</a:t>
+            <a:pPr>
+              <a:lnSpc>
+                <a:spcPct val="112000"/>
+              </a:lnSpc>
+              <a:spcAft>
+                <a:spcPts val="900"/>
+              </a:spcAft>
+            </a:pPr>
+            <a:r>
+              <a:rPr sz="1600" b="1">
+                <a:solidFill>
+                  <a:srgbClr val="E0A437"/>
+                </a:solidFill>
+                <a:latin typeface="Fira Sans"/>
+              </a:rPr>
+              <a:t>▸ </a:t>
+            </a:r>
+            <a:r>
+              <a:rPr sz="1600" b="0">
+                <a:solidFill>
+                  <a:srgbClr val="000000"/>
+                </a:solidFill>
+                <a:latin typeface="Fira Sans"/>
+              </a:rPr>
+              <a:t>Las dummies se agregan a la X junto al log de la distancia. Cada coeficiente se lee comparado con la referencia: ese modo frente al auto, a igual distancia.</a:t>
             </a:r>
           </a:p>
         </p:txBody>
@@ -7955,14 +7956,14 @@
                 </a:solidFill>
                 <a:latin typeface="Fira Sans"/>
               </a:rPr>
-              <a:t>El resultado: distancia y modo</a:t>
+              <a:t>Qué hace una dummy dentro del modelo</a:t>
             </a:r>
           </a:p>
         </p:txBody>
       </p:sp>
       <p:pic>
         <p:nvPicPr>
-          <p:cNvPr id="4" name="Picture 3" descr="c4_03_coef_modo.png"/>
+          <p:cNvPr id="4" name="Picture 3" descr="c4_12_dummies_rectas.png"/>
           <p:cNvPicPr>
             <a:picLocks noChangeAspect="1"/>
           </p:cNvPicPr>
@@ -7976,8 +7977,8 @@
         </p:blipFill>
         <p:spPr>
           <a:xfrm>
-            <a:off x="804842" y="1143000"/>
-            <a:ext cx="7534315" cy="3154680"/>
+            <a:off x="1280160" y="1143000"/>
+            <a:ext cx="6583680" cy="3154680"/>
           </a:xfrm>
           <a:prstGeom prst="rect">
             <a:avLst/>
@@ -8013,7 +8014,7 @@
                 </a:solidFill>
                 <a:latin typeface="Fira Sans"/>
               </a:rPr>
-              <a:t>A igual distancia, un viaje en Bip! tarda 1,87 veces lo que uno en auto; taxi y caminata quedan casi iguales al auto. El R² sube de 0,53 a 0,60.</a:t>
+              <a:t>La dummy suma su coeficiente al intercepto de su modo: rectas paralelas, con la misma pendiente en la distancia. En log, sumar 0,27 es multiplicar el tiempo por 1,87.</a:t>
             </a:r>
           </a:p>
         </p:txBody>
@@ -8109,14 +8110,14 @@
                 </a:solidFill>
                 <a:latin typeface="Fira Sans"/>
               </a:rPr>
-              <a:t>La ecuación de la duración, leída</a:t>
+              <a:t>El resultado: distancia y modo</a:t>
             </a:r>
           </a:p>
         </p:txBody>
       </p:sp>
       <p:pic>
         <p:nvPicPr>
-          <p:cNvPr id="4" name="Picture 3" descr="c4_09_ecuacion_duracion.png"/>
+          <p:cNvPr id="4" name="Picture 3" descr="c4_03_coef_modo.png"/>
           <p:cNvPicPr>
             <a:picLocks noChangeAspect="1"/>
           </p:cNvPicPr>
@@ -8130,8 +8131,8 @@
         </p:blipFill>
         <p:spPr>
           <a:xfrm>
-            <a:off x="699515" y="1320746"/>
-            <a:ext cx="7744968" cy="2799186"/>
+            <a:off x="804842" y="1143000"/>
+            <a:ext cx="7534315" cy="3154680"/>
           </a:xfrm>
           <a:prstGeom prst="rect">
             <a:avLst/>
@@ -8167,7 +8168,7 @@
                 </a:solidFill>
                 <a:latin typeface="Fira Sans"/>
               </a:rPr>
-              <a:t>La misma tabla de coeficientes, escrita como ecuación: en escala log los efectos multiplican en vez de sumar.</a:t>
+              <a:t>A igual distancia, un viaje en Bip! tarda 1,87 veces lo que uno en auto; taxi y caminata quedan casi iguales al auto. El R² sube de 0,53 a 0,60.</a:t>
             </a:r>
           </a:p>
         </p:txBody>
@@ -8263,21 +8264,45 @@
                 </a:solidFill>
                 <a:latin typeface="Fira Sans"/>
               </a:rPr>
-              <a:t>Síntesis</a:t>
-            </a:r>
-          </a:p>
-        </p:txBody>
-      </p:sp>
-      <p:sp>
-        <p:nvSpPr>
-          <p:cNvPr id="4" name="TextBox 3"/>
+              <a:t>La ecuación de la duración, leída</a:t>
+            </a:r>
+          </a:p>
+        </p:txBody>
+      </p:sp>
+      <p:pic>
+        <p:nvPicPr>
+          <p:cNvPr id="4" name="Picture 3" descr="c4_09_ecuacion_duracion.png"/>
+          <p:cNvPicPr>
+            <a:picLocks noChangeAspect="1"/>
+          </p:cNvPicPr>
+          <p:nvPr/>
+        </p:nvPicPr>
+        <p:blipFill>
+          <a:blip r:embed="rId2"/>
+          <a:stretch>
+            <a:fillRect/>
+          </a:stretch>
+        </p:blipFill>
+        <p:spPr>
+          <a:xfrm>
+            <a:off x="699515" y="1320746"/>
+            <a:ext cx="7744968" cy="2799186"/>
+          </a:xfrm>
+          <a:prstGeom prst="rect">
+            <a:avLst/>
+          </a:prstGeom>
+        </p:spPr>
+      </p:pic>
+      <p:sp>
+        <p:nvSpPr>
+          <p:cNvPr id="5" name="TextBox 4"/>
           <p:cNvSpPr txBox="1"/>
           <p:nvPr/>
         </p:nvSpPr>
         <p:spPr>
           <a:xfrm>
-            <a:off x="704088" y="1353312"/>
-            <a:ext cx="7744968" cy="3300984"/>
+            <a:off x="704088" y="4434840"/>
+            <a:ext cx="7744968" cy="457200"/>
           </a:xfrm>
           <a:prstGeom prst="rect">
             <a:avLst/>
@@ -8290,143 +8315,14 @@
           </a:bodyPr>
           <a:lstStyle/>
           <a:p>
-            <a:pPr>
-              <a:lnSpc>
-                <a:spcPct val="112000"/>
-              </a:lnSpc>
-              <a:spcAft>
-                <a:spcPts val="900"/>
-              </a:spcAft>
-            </a:pPr>
-            <a:r>
-              <a:rPr sz="1800" b="1">
-                <a:solidFill>
-                  <a:srgbClr val="E0A437"/>
-                </a:solidFill>
-                <a:latin typeface="Fira Sans"/>
-              </a:rPr>
-              <a:t>▸ </a:t>
-            </a:r>
-            <a:r>
-              <a:rPr sz="1800" b="0">
-                <a:solidFill>
-                  <a:srgbClr val="000000"/>
-                </a:solidFill>
-                <a:latin typeface="Fira Sans"/>
-              </a:rPr>
-              <a:t>Muchos puntos: alpha o hexbin. Colas largas: log.</a:t>
-            </a:r>
-          </a:p>
-          <a:p>
-            <a:pPr>
-              <a:lnSpc>
-                <a:spcPct val="112000"/>
-              </a:lnSpc>
-              <a:spcAft>
-                <a:spcPts val="900"/>
-              </a:spcAft>
-            </a:pPr>
-            <a:r>
-              <a:rPr sz="1800" b="1">
-                <a:solidFill>
-                  <a:srgbClr val="E0A437"/>
-                </a:solidFill>
-                <a:latin typeface="Fira Sans"/>
-              </a:rPr>
-              <a:t>▸ </a:t>
-            </a:r>
-            <a:r>
-              <a:rPr sz="1800" b="0">
-                <a:solidFill>
-                  <a:srgbClr val="000000"/>
-                </a:solidFill>
-                <a:latin typeface="Fira Sans"/>
-              </a:rPr>
-              <a:t>El impacto de filas y atípicos se mide con y sin, sobre todos los resúmenes en uso.</a:t>
-            </a:r>
-          </a:p>
-          <a:p>
-            <a:pPr>
-              <a:lnSpc>
-                <a:spcPct val="112000"/>
-              </a:lnSpc>
-              <a:spcAft>
-                <a:spcPts val="900"/>
-              </a:spcAft>
-            </a:pPr>
-            <a:r>
-              <a:rPr sz="1800" b="1">
-                <a:solidFill>
-                  <a:srgbClr val="E0A437"/>
-                </a:solidFill>
-                <a:latin typeface="Fira Sans"/>
-              </a:rPr>
-              <a:t>▸ </a:t>
-            </a:r>
-            <a:r>
-              <a:rPr sz="1800" b="0">
-                <a:solidFill>
-                  <a:srgbClr val="000000"/>
-                </a:solidFill>
-                <a:latin typeface="Fira Sans"/>
-              </a:rPr>
-              <a:t>Cuando la conclusión es sobre la ciudad, se pondera: WLS.</a:t>
-            </a:r>
-          </a:p>
-          <a:p>
-            <a:pPr>
-              <a:lnSpc>
-                <a:spcPct val="112000"/>
-              </a:lnSpc>
-              <a:spcAft>
-                <a:spcPts val="900"/>
-              </a:spcAft>
-            </a:pPr>
-            <a:r>
-              <a:rPr sz="1800" b="1">
-                <a:solidFill>
-                  <a:srgbClr val="E0A437"/>
-                </a:solidFill>
-                <a:latin typeface="Fira Sans"/>
-              </a:rPr>
-              <a:t>▸ </a:t>
-            </a:r>
-            <a:r>
-              <a:rPr sz="1800" b="0">
-                <a:solidFill>
-                  <a:srgbClr val="000000"/>
-                </a:solidFill>
-                <a:latin typeface="Fira Sans"/>
-              </a:rPr>
-              <a:t>La múltiple aísla el efecto de cada variable (categóricas como dummies); R² dice cuánto explica y el valor p si un coeficiente se distingue del azar.</a:t>
-            </a:r>
-          </a:p>
-          <a:p>
-            <a:pPr>
-              <a:lnSpc>
-                <a:spcPct val="112000"/>
-              </a:lnSpc>
-              <a:spcAft>
-                <a:spcPts val="900"/>
-              </a:spcAft>
-            </a:pPr>
-            <a:r>
-              <a:rPr sz="1800" b="1">
-                <a:solidFill>
-                  <a:srgbClr val="E0A437"/>
-                </a:solidFill>
-                <a:latin typeface="Fira Sans"/>
-              </a:rPr>
-              <a:t>▸ </a:t>
-            </a:r>
-            <a:r>
-              <a:rPr sz="1800" b="1">
-                <a:solidFill>
-                  <a:srgbClr val="1D3557"/>
-                </a:solidFill>
-                <a:latin typeface="Fira Sans"/>
-              </a:rPr>
-              <a:t>El primer EDA del proyecto usa exactamente estas herramientas (entrega: lunes 15).</a:t>
+            <a:r>
+              <a:rPr sz="1300" b="0">
+                <a:solidFill>
+                  <a:srgbClr val="333333"/>
+                </a:solidFill>
+                <a:latin typeface="Fira Sans"/>
+              </a:rPr>
+              <a:t>La misma tabla de coeficientes, escrita como ecuación: en escala log los efectos multiplican en vez de sumar.</a:t>
             </a:r>
           </a:p>
         </p:txBody>
@@ -8464,7 +8360,7 @@
             <a:avLst/>
           </a:prstGeom>
           <a:solidFill>
-            <a:srgbClr val="1D3557"/>
+            <a:srgbClr val="FAFBFC"/>
           </a:solidFill>
           <a:ln>
             <a:noFill/>
@@ -8501,8 +8397,8 @@
         </p:nvSpPr>
         <p:spPr>
           <a:xfrm>
-            <a:off x="603504" y="1847088"/>
-            <a:ext cx="7946136" cy="1399032"/>
+            <a:off x="402336" y="301752"/>
+            <a:ext cx="8348472" cy="795528"/>
           </a:xfrm>
           <a:prstGeom prst="rect">
             <a:avLst/>
@@ -8516,24 +8412,176 @@
           <a:lstStyle/>
           <a:p>
             <a:r>
-              <a:rPr sz="3400" b="1">
-                <a:solidFill>
-                  <a:srgbClr val="FFFFFF"/>
-                </a:solidFill>
-                <a:latin typeface="Fira Sans"/>
-              </a:rPr>
-              <a:t>Recreo</a:t>
-            </a:r>
-          </a:p>
-          <a:p>
+              <a:rPr sz="2800" b="1">
+                <a:solidFill>
+                  <a:srgbClr val="0F0F0F"/>
+                </a:solidFill>
+                <a:latin typeface="Fira Sans"/>
+              </a:rPr>
+              <a:t>Síntesis</a:t>
+            </a:r>
+          </a:p>
+        </p:txBody>
+      </p:sp>
+      <p:sp>
+        <p:nvSpPr>
+          <p:cNvPr id="4" name="TextBox 3"/>
+          <p:cNvSpPr txBox="1"/>
+          <p:nvPr/>
+        </p:nvSpPr>
+        <p:spPr>
+          <a:xfrm>
+            <a:off x="704088" y="1353312"/>
+            <a:ext cx="7744968" cy="3300984"/>
+          </a:xfrm>
+          <a:prstGeom prst="rect">
+            <a:avLst/>
+          </a:prstGeom>
+          <a:noFill/>
+        </p:spPr>
+        <p:txBody>
+          <a:bodyPr wrap="square">
+            <a:spAutoFit/>
+          </a:bodyPr>
+          <a:lstStyle/>
+          <a:p>
+            <a:pPr>
+              <a:lnSpc>
+                <a:spcPct val="112000"/>
+              </a:lnSpc>
+              <a:spcAft>
+                <a:spcPts val="900"/>
+              </a:spcAft>
+            </a:pPr>
+            <a:r>
+              <a:rPr sz="1800" b="1">
+                <a:solidFill>
+                  <a:srgbClr val="E0A437"/>
+                </a:solidFill>
+                <a:latin typeface="Fira Sans"/>
+              </a:rPr>
+              <a:t>▸ </a:t>
+            </a:r>
             <a:r>
               <a:rPr sz="1800" b="0">
                 <a:solidFill>
+                  <a:srgbClr val="000000"/>
+                </a:solidFill>
+                <a:latin typeface="Fira Sans"/>
+              </a:rPr>
+              <a:t>Muchos puntos: alpha o hexbin. Colas largas: log.</a:t>
+            </a:r>
+          </a:p>
+          <a:p>
+            <a:pPr>
+              <a:lnSpc>
+                <a:spcPct val="112000"/>
+              </a:lnSpc>
+              <a:spcAft>
+                <a:spcPts val="900"/>
+              </a:spcAft>
+            </a:pPr>
+            <a:r>
+              <a:rPr sz="1800" b="1">
+                <a:solidFill>
                   <a:srgbClr val="E0A437"/>
                 </a:solidFill>
                 <a:latin typeface="Fira Sans"/>
               </a:rPr>
-              <a:t>10 minutos · al volver: las presentaciones de ideas</a:t>
+              <a:t>▸ </a:t>
+            </a:r>
+            <a:r>
+              <a:rPr sz="1800" b="0">
+                <a:solidFill>
+                  <a:srgbClr val="000000"/>
+                </a:solidFill>
+                <a:latin typeface="Fira Sans"/>
+              </a:rPr>
+              <a:t>El impacto de filas y atípicos se mide con y sin, sobre todos los resúmenes en uso.</a:t>
+            </a:r>
+          </a:p>
+          <a:p>
+            <a:pPr>
+              <a:lnSpc>
+                <a:spcPct val="112000"/>
+              </a:lnSpc>
+              <a:spcAft>
+                <a:spcPts val="900"/>
+              </a:spcAft>
+            </a:pPr>
+            <a:r>
+              <a:rPr sz="1800" b="1">
+                <a:solidFill>
+                  <a:srgbClr val="E0A437"/>
+                </a:solidFill>
+                <a:latin typeface="Fira Sans"/>
+              </a:rPr>
+              <a:t>▸ </a:t>
+            </a:r>
+            <a:r>
+              <a:rPr sz="1800" b="0">
+                <a:solidFill>
+                  <a:srgbClr val="000000"/>
+                </a:solidFill>
+                <a:latin typeface="Fira Sans"/>
+              </a:rPr>
+              <a:t>Cuando la conclusión es sobre la ciudad, se pondera: WLS.</a:t>
+            </a:r>
+          </a:p>
+          <a:p>
+            <a:pPr>
+              <a:lnSpc>
+                <a:spcPct val="112000"/>
+              </a:lnSpc>
+              <a:spcAft>
+                <a:spcPts val="900"/>
+              </a:spcAft>
+            </a:pPr>
+            <a:r>
+              <a:rPr sz="1800" b="1">
+                <a:solidFill>
+                  <a:srgbClr val="E0A437"/>
+                </a:solidFill>
+                <a:latin typeface="Fira Sans"/>
+              </a:rPr>
+              <a:t>▸ </a:t>
+            </a:r>
+            <a:r>
+              <a:rPr sz="1800" b="0">
+                <a:solidFill>
+                  <a:srgbClr val="000000"/>
+                </a:solidFill>
+                <a:latin typeface="Fira Sans"/>
+              </a:rPr>
+              <a:t>La múltiple aísla el efecto de cada variable (categóricas como dummies); R² dice cuánto explica y el valor p si un coeficiente se distingue del azar.</a:t>
+            </a:r>
+          </a:p>
+          <a:p>
+            <a:pPr>
+              <a:lnSpc>
+                <a:spcPct val="112000"/>
+              </a:lnSpc>
+              <a:spcAft>
+                <a:spcPts val="900"/>
+              </a:spcAft>
+            </a:pPr>
+            <a:r>
+              <a:rPr sz="1800" b="1">
+                <a:solidFill>
+                  <a:srgbClr val="E0A437"/>
+                </a:solidFill>
+                <a:latin typeface="Fira Sans"/>
+              </a:rPr>
+              <a:t>▸ </a:t>
+            </a:r>
+            <a:r>
+              <a:rPr sz="1800" b="1">
+                <a:solidFill>
+                  <a:srgbClr val="1D3557"/>
+                </a:solidFill>
+                <a:latin typeface="Fira Sans"/>
+              </a:rPr>
+              <a:t>El primer EDA del proyecto usa exactamente estas herramientas (entrega: lunes 15).</a:t>
             </a:r>
           </a:p>
         </p:txBody>
@@ -8629,7 +8677,7 @@
                 </a:solidFill>
                 <a:latin typeface="Fira Sans"/>
               </a:rPr>
-              <a:t>Presentaciones de ideas</a:t>
+              <a:t>Recreo</a:t>
             </a:r>
           </a:p>
           <a:p>
@@ -8640,7 +8688,7 @@
                 </a:solidFill>
                 <a:latin typeface="Fira Sans"/>
               </a:rPr>
-              <a:t>De 5 a 7 minutos por equipo, y preguntas de todos</a:t>
+              <a:t>10 minutos · al volver: las presentaciones de ideas</a:t>
             </a:r>
           </a:p>
         </p:txBody>
@@ -8785,7 +8833,7 @@
             <a:avLst/>
           </a:prstGeom>
           <a:solidFill>
-            <a:srgbClr val="FAFBFC"/>
+            <a:srgbClr val="1D3557"/>
           </a:solidFill>
           <a:ln>
             <a:noFill/>
@@ -8822,8 +8870,8 @@
         </p:nvSpPr>
         <p:spPr>
           <a:xfrm>
-            <a:off x="402336" y="301752"/>
-            <a:ext cx="8348472" cy="795528"/>
+            <a:off x="603504" y="1847088"/>
+            <a:ext cx="7946136" cy="1399032"/>
           </a:xfrm>
           <a:prstGeom prst="rect">
             <a:avLst/>
@@ -8837,92 +8885,24 @@
           <a:lstStyle/>
           <a:p>
             <a:r>
-              <a:rPr sz="2800" b="1">
-                <a:solidFill>
-                  <a:srgbClr val="0F0F0F"/>
-                </a:solidFill>
-                <a:latin typeface="Fira Sans"/>
-              </a:rPr>
-              <a:t>El formato</a:t>
-            </a:r>
-          </a:p>
-        </p:txBody>
-      </p:sp>
-      <p:sp>
-        <p:nvSpPr>
-          <p:cNvPr id="4" name="TextBox 3"/>
-          <p:cNvSpPr txBox="1"/>
-          <p:nvPr/>
-        </p:nvSpPr>
-        <p:spPr>
-          <a:xfrm>
-            <a:off x="704088" y="1353312"/>
-            <a:ext cx="7744968" cy="3300984"/>
-          </a:xfrm>
-          <a:prstGeom prst="rect">
-            <a:avLst/>
-          </a:prstGeom>
-          <a:noFill/>
-        </p:spPr>
-        <p:txBody>
-          <a:bodyPr wrap="square">
-            <a:spAutoFit/>
-          </a:bodyPr>
-          <a:lstStyle/>
-          <a:p>
-            <a:pPr>
-              <a:lnSpc>
-                <a:spcPct val="112000"/>
-              </a:lnSpc>
-              <a:spcAft>
-                <a:spcPts val="900"/>
-              </a:spcAft>
-            </a:pPr>
-            <a:r>
-              <a:rPr sz="1800" b="1">
+              <a:rPr sz="3400" b="1">
+                <a:solidFill>
+                  <a:srgbClr val="FFFFFF"/>
+                </a:solidFill>
+                <a:latin typeface="Fira Sans"/>
+              </a:rPr>
+              <a:t>Presentaciones de ideas</a:t>
+            </a:r>
+          </a:p>
+          <a:p>
+            <a:r>
+              <a:rPr sz="1800" b="0">
                 <a:solidFill>
                   <a:srgbClr val="E0A437"/>
                 </a:solidFill>
                 <a:latin typeface="Fira Sans"/>
               </a:rPr>
-              <a:t>▸ </a:t>
-            </a:r>
-            <a:r>
-              <a:rPr sz="1800" b="1">
-                <a:solidFill>
-                  <a:srgbClr val="1D3557"/>
-                </a:solidFill>
-                <a:latin typeface="Fira Sans"/>
-              </a:rPr>
-              <a:t>Esta instancia no lleva nota: es para recibir retroalimentación temprano, cuando corregir cuesta poco.</a:t>
-            </a:r>
-          </a:p>
-          <a:p>
-            <a:pPr>
-              <a:lnSpc>
-                <a:spcPct val="112000"/>
-              </a:lnSpc>
-              <a:spcAft>
-                <a:spcPts val="900"/>
-              </a:spcAft>
-            </a:pPr>
-            <a:r>
-              <a:rPr sz="1800" b="1">
-                <a:solidFill>
-                  <a:srgbClr val="E0A437"/>
-                </a:solidFill>
-                <a:latin typeface="Fira Sans"/>
-              </a:rPr>
-              <a:t>▸ </a:t>
-            </a:r>
-            <a:r>
-              <a:rPr sz="1800" b="0">
-                <a:solidFill>
-                  <a:srgbClr val="000000"/>
-                </a:solidFill>
-                <a:latin typeface="Fira Sans"/>
-              </a:rPr>
-              <a:t>Después de cada equipo, preguntas y comentarios del curso.</a:t>
+              <a:t>De 5 a 7 minutos por equipo, y preguntas de todos</a:t>
             </a:r>
           </a:p>
         </p:txBody>
@@ -9018,7 +8998,7 @@
                 </a:solidFill>
                 <a:latin typeface="Fira Sans"/>
               </a:rPr>
-              <a:t>Próxima clase</a:t>
+              <a:t>El formato</a:t>
             </a:r>
           </a:p>
         </p:txBody>
@@ -9063,13 +9043,13 @@
               <a:t>▸ </a:t>
             </a:r>
             <a:r>
-              <a:rPr sz="1800" b="0">
-                <a:solidFill>
-                  <a:srgbClr val="000000"/>
-                </a:solidFill>
-                <a:latin typeface="Fira Sans"/>
-              </a:rPr>
-              <a:t>Martes 8: fundamentos de probabilidad y nociones de inferencia estadística.</a:t>
+              <a:rPr sz="1800" b="1">
+                <a:solidFill>
+                  <a:srgbClr val="1D3557"/>
+                </a:solidFill>
+                <a:latin typeface="Fira Sans"/>
+              </a:rPr>
+              <a:t>Esta instancia no lleva nota: es para recibir retroalimentación temprano, cuando corregir cuesta poco.</a:t>
             </a:r>
           </a:p>
           <a:p>
@@ -9097,35 +9077,7 @@
                 </a:solidFill>
                 <a:latin typeface="Fira Sans"/>
               </a:rPr>
-              <a:t>La pregunta pendiente desde la clase 3: ¿qué significa el valor p que statsmodels ya nos mostró?</a:t>
-            </a:r>
-          </a:p>
-          <a:p>
-            <a:pPr>
-              <a:lnSpc>
-                <a:spcPct val="112000"/>
-              </a:lnSpc>
-              <a:spcAft>
-                <a:spcPts val="900"/>
-              </a:spcAft>
-            </a:pPr>
-            <a:r>
-              <a:rPr sz="1800" b="1">
-                <a:solidFill>
-                  <a:srgbClr val="E0A437"/>
-                </a:solidFill>
-                <a:latin typeface="Fira Sans"/>
-              </a:rPr>
-              <a:t>▸ </a:t>
-            </a:r>
-            <a:r>
-              <a:rPr sz="1800" b="1">
-                <a:solidFill>
-                  <a:srgbClr val="1D3557"/>
-                </a:solidFill>
-                <a:latin typeface="Fira Sans"/>
-              </a:rPr>
-              <a:t>La formulación se entrega el lunes 7; el primer análisis exploratorio, el lunes 15.</a:t>
+              <a:t>Después de cada equipo, preguntas y comentarios del curso.</a:t>
             </a:r>
           </a:p>
         </p:txBody>
@@ -9139,6 +9091,209 @@
 </file>
 
 <file path=ppt/slides/slide42.xml><?xml version="1.0" encoding="utf-8"?>
+<p:sld xmlns:a="http://schemas.openxmlformats.org/drawingml/2006/main" xmlns:p="http://schemas.openxmlformats.org/presentationml/2006/main" xmlns:r="http://schemas.openxmlformats.org/officeDocument/2006/relationships">
+  <p:cSld>
+    <p:spTree>
+      <p:nvGrpSpPr>
+        <p:cNvPr id="1" name=""/>
+        <p:cNvGrpSpPr/>
+        <p:nvPr/>
+      </p:nvGrpSpPr>
+      <p:grpSpPr/>
+      <p:sp>
+        <p:nvSpPr>
+          <p:cNvPr id="2" name="Rectangle 1"/>
+          <p:cNvSpPr/>
+          <p:nvPr/>
+        </p:nvSpPr>
+        <p:spPr>
+          <a:xfrm>
+            <a:off x="0" y="0"/>
+            <a:ext cx="9144000" cy="5138928"/>
+          </a:xfrm>
+          <a:prstGeom prst="rect">
+            <a:avLst/>
+          </a:prstGeom>
+          <a:solidFill>
+            <a:srgbClr val="FAFBFC"/>
+          </a:solidFill>
+          <a:ln>
+            <a:noFill/>
+          </a:ln>
+          <a:effectLst/>
+        </p:spPr>
+        <p:style>
+          <a:lnRef idx="1">
+            <a:schemeClr val="accent1"/>
+          </a:lnRef>
+          <a:fillRef idx="3">
+            <a:schemeClr val="accent1"/>
+          </a:fillRef>
+          <a:effectRef idx="2">
+            <a:schemeClr val="accent1"/>
+          </a:effectRef>
+          <a:fontRef idx="minor">
+            <a:schemeClr val="lt1"/>
+          </a:fontRef>
+        </p:style>
+        <p:txBody>
+          <a:bodyPr rtlCol="0" anchor="ctr"/>
+          <a:lstStyle/>
+          <a:p>
+            <a:pPr algn="ctr"/>
+          </a:p>
+        </p:txBody>
+      </p:sp>
+      <p:sp>
+        <p:nvSpPr>
+          <p:cNvPr id="3" name="TextBox 2"/>
+          <p:cNvSpPr txBox="1"/>
+          <p:nvPr/>
+        </p:nvSpPr>
+        <p:spPr>
+          <a:xfrm>
+            <a:off x="402336" y="301752"/>
+            <a:ext cx="8348472" cy="795528"/>
+          </a:xfrm>
+          <a:prstGeom prst="rect">
+            <a:avLst/>
+          </a:prstGeom>
+          <a:noFill/>
+        </p:spPr>
+        <p:txBody>
+          <a:bodyPr wrap="square">
+            <a:spAutoFit/>
+          </a:bodyPr>
+          <a:lstStyle/>
+          <a:p>
+            <a:r>
+              <a:rPr sz="2800" b="1">
+                <a:solidFill>
+                  <a:srgbClr val="0F0F0F"/>
+                </a:solidFill>
+                <a:latin typeface="Fira Sans"/>
+              </a:rPr>
+              <a:t>Próxima clase</a:t>
+            </a:r>
+          </a:p>
+        </p:txBody>
+      </p:sp>
+      <p:sp>
+        <p:nvSpPr>
+          <p:cNvPr id="4" name="TextBox 3"/>
+          <p:cNvSpPr txBox="1"/>
+          <p:nvPr/>
+        </p:nvSpPr>
+        <p:spPr>
+          <a:xfrm>
+            <a:off x="704088" y="1353312"/>
+            <a:ext cx="7744968" cy="3300984"/>
+          </a:xfrm>
+          <a:prstGeom prst="rect">
+            <a:avLst/>
+          </a:prstGeom>
+          <a:noFill/>
+        </p:spPr>
+        <p:txBody>
+          <a:bodyPr wrap="square">
+            <a:spAutoFit/>
+          </a:bodyPr>
+          <a:lstStyle/>
+          <a:p>
+            <a:pPr>
+              <a:lnSpc>
+                <a:spcPct val="112000"/>
+              </a:lnSpc>
+              <a:spcAft>
+                <a:spcPts val="900"/>
+              </a:spcAft>
+            </a:pPr>
+            <a:r>
+              <a:rPr sz="1800" b="1">
+                <a:solidFill>
+                  <a:srgbClr val="E0A437"/>
+                </a:solidFill>
+                <a:latin typeface="Fira Sans"/>
+              </a:rPr>
+              <a:t>▸ </a:t>
+            </a:r>
+            <a:r>
+              <a:rPr sz="1800" b="0">
+                <a:solidFill>
+                  <a:srgbClr val="000000"/>
+                </a:solidFill>
+                <a:latin typeface="Fira Sans"/>
+              </a:rPr>
+              <a:t>Martes 8: fundamentos de probabilidad y nociones de inferencia estadística.</a:t>
+            </a:r>
+          </a:p>
+          <a:p>
+            <a:pPr>
+              <a:lnSpc>
+                <a:spcPct val="112000"/>
+              </a:lnSpc>
+              <a:spcAft>
+                <a:spcPts val="900"/>
+              </a:spcAft>
+            </a:pPr>
+            <a:r>
+              <a:rPr sz="1800" b="1">
+                <a:solidFill>
+                  <a:srgbClr val="E0A437"/>
+                </a:solidFill>
+                <a:latin typeface="Fira Sans"/>
+              </a:rPr>
+              <a:t>▸ </a:t>
+            </a:r>
+            <a:r>
+              <a:rPr sz="1800" b="0">
+                <a:solidFill>
+                  <a:srgbClr val="000000"/>
+                </a:solidFill>
+                <a:latin typeface="Fira Sans"/>
+              </a:rPr>
+              <a:t>La pregunta pendiente desde la clase 3: ¿qué significa el valor p que statsmodels ya nos mostró?</a:t>
+            </a:r>
+          </a:p>
+          <a:p>
+            <a:pPr>
+              <a:lnSpc>
+                <a:spcPct val="112000"/>
+              </a:lnSpc>
+              <a:spcAft>
+                <a:spcPts val="900"/>
+              </a:spcAft>
+            </a:pPr>
+            <a:r>
+              <a:rPr sz="1800" b="1">
+                <a:solidFill>
+                  <a:srgbClr val="E0A437"/>
+                </a:solidFill>
+                <a:latin typeface="Fira Sans"/>
+              </a:rPr>
+              <a:t>▸ </a:t>
+            </a:r>
+            <a:r>
+              <a:rPr sz="1800" b="1">
+                <a:solidFill>
+                  <a:srgbClr val="1D3557"/>
+                </a:solidFill>
+                <a:latin typeface="Fira Sans"/>
+              </a:rPr>
+              <a:t>La formulación se entrega el lunes 7; el primer análisis exploratorio, el lunes 15.</a:t>
+            </a:r>
+          </a:p>
+        </p:txBody>
+      </p:sp>
+    </p:spTree>
+  </p:cSld>
+  <p:clrMapOvr>
+    <a:masterClrMapping/>
+  </p:clrMapOvr>
+</p:sld>
+</file>
+
+<file path=ppt/slides/slide43.xml><?xml version="1.0" encoding="utf-8"?>
 <p:sld xmlns:a="http://schemas.openxmlformats.org/drawingml/2006/main" xmlns:p="http://schemas.openxmlformats.org/presentationml/2006/main" xmlns:r="http://schemas.openxmlformats.org/officeDocument/2006/relationships">
   <p:cSld>
     <p:spTree>

</xml_diff>

<commit_message>
Deck clase 4: la regla para leer una dummy, simplificada en tres puntos
Co-Authored-By: Claude Fable 5 <noreply@anthropic.com>
</commit_message>
<xml_diff>
--- a/presentaciones/clase04_regresion_multiple.pptx
+++ b/presentaciones/clase04_regresion_multiple.pptx
@@ -8436,7 +8436,7 @@
                 </a:solidFill>
                 <a:latin typeface="Fira Sans"/>
               </a:rPr>
-              <a:t>La dummy vale 0 en la referencia (auto) y 1 en su modo: su coeficiente se suma solo cuando vale 1.</a:t>
+              <a:t>El coeficiente de una dummy solo se considera si el viaje es en ese modo de transporte; si no, la dummy vale 0 y el término desaparece.</a:t>
             </a:r>
           </a:p>
           <a:p>
@@ -8464,7 +8464,7 @@
                 </a:solidFill>
                 <a:latin typeface="Fira Sans"/>
               </a:rPr>
-              <a:t>Con el modelo en log, ese coeficiente se suma al log de la duración, y sumar en log es multiplicar en la escala original: 10 elevado a 0,27 = 1,87.</a:t>
+              <a:t>Como el modelo está en log, el coeficiente se suma al log, y sumar en log es multiplicar: 10 elevado a 0,27 = 1,87. Por eso los dos tiempos se dividen y no se restan.</a:t>
             </a:r>
           </a:p>
           <a:p>
@@ -8492,63 +8492,7 @@
                 </a:solidFill>
                 <a:latin typeface="Fira Sans"/>
               </a:rPr>
-              <a:t>Lectura: cuántas veces más (×1,87) frente a la referencia, a igual valor de las demás variables (aquí, la distancia).</a:t>
-            </a:r>
-          </a:p>
-          <a:p>
-            <a:pPr>
-              <a:lnSpc>
-                <a:spcPct val="112000"/>
-              </a:lnSpc>
-              <a:spcAft>
-                <a:spcPts val="900"/>
-              </a:spcAft>
-            </a:pPr>
-            <a:r>
-              <a:rPr sz="1800" b="1">
-                <a:solidFill>
-                  <a:srgbClr val="E0A437"/>
-                </a:solidFill>
-                <a:latin typeface="Fira Sans"/>
-              </a:rPr>
-              <a:t>▸ </a:t>
-            </a:r>
-            <a:r>
-              <a:rPr sz="1800" b="0">
-                <a:solidFill>
-                  <a:srgbClr val="000000"/>
-                </a:solidFill>
-                <a:latin typeface="Fira Sans"/>
-              </a:rPr>
-              <a:t>¿Por qué dividir los dos tiempos y no restarlos? Porque restar en log es dividir en la escala original: log(a) − log(b) = log(a/b). La resta en minutos cambia con la distancia; la razón 1,87, no.</a:t>
-            </a:r>
-          </a:p>
-          <a:p>
-            <a:pPr>
-              <a:lnSpc>
-                <a:spcPct val="112000"/>
-              </a:lnSpc>
-              <a:spcAft>
-                <a:spcPts val="900"/>
-              </a:spcAft>
-            </a:pPr>
-            <a:r>
-              <a:rPr sz="1800" b="1">
-                <a:solidFill>
-                  <a:srgbClr val="E0A437"/>
-                </a:solidFill>
-                <a:latin typeface="Fira Sans"/>
-              </a:rPr>
-              <a:t>▸ </a:t>
-            </a:r>
-            <a:r>
-              <a:rPr sz="1800" b="0">
-                <a:solidFill>
-                  <a:srgbClr val="000000"/>
-                </a:solidFill>
-                <a:latin typeface="Fira Sans"/>
-              </a:rPr>
-              <a:t>Sin log, la lectura sería aditiva: tantos minutos más, a igual distancia.</a:t>
+              <a:t>Lectura: un viaje en Bip! tarda 1,87 veces lo que uno en auto, a igual distancia.</a:t>
             </a:r>
           </a:p>
         </p:txBody>

</xml_diff>